<commit_message>
Add school badge and emblem to the recruitment deck title slide
- 교표 (winged badge) as a crisp brand mark in the top-left corner
- 엠블럼 (circular emblem) as a large watermark on the right at 84%
  transparency, replacing the placeholder decorative circles
- Both extracted from the school website's 교표·엠블럼 page and
  background-removed to transparent PNGs (docs/assets/)
- Use the school's full name, 정석항공과학고등학교, on the title and
  summary slides to match the emblem

Co-Authored-By: Claude Opus 5 <noreply@anthropic.com>
Claude-Session: https://claude.ai/code/session_01GZfitk2JEKppZ4fGSDdghv
</commit_message>
<xml_diff>
--- a/docs/2027년_사무직원_채용계획안.pptx
+++ b/docs/2027년_사무직원_채용계획안.pptx
@@ -1952,49 +1952,59 @@
           <a:chExt cx="0" cy="0"/>
         </a:xfrm>
       </p:grpSpPr>
-      <p:sp>
-        <p:nvSpPr>
-          <p:cNvPr id="2" name="Shape 0"/>
-          <p:cNvSpPr/>
-          <p:nvPr/>
-        </p:nvSpPr>
-        <p:spPr>
-          <a:xfrm>
-            <a:off x="8686800" y="-1463040"/>
-            <a:ext cx="5120640" cy="5120640"/>
-          </a:xfrm>
-          <a:prstGeom prst="ellipse">
-            <a:avLst/>
-          </a:prstGeom>
-          <a:solidFill>
-            <a:srgbClr val="141B44"/>
-          </a:solidFill>
-          <a:ln/>
-        </p:spPr>
-      </p:sp>
-      <p:sp>
-        <p:nvSpPr>
-          <p:cNvPr id="3" name="Shape 1"/>
-          <p:cNvSpPr/>
-          <p:nvPr/>
-        </p:nvSpPr>
-        <p:spPr>
-          <a:xfrm>
-            <a:off x="10149840" y="4114800"/>
-            <a:ext cx="2926080" cy="2926080"/>
-          </a:xfrm>
-          <a:prstGeom prst="ellipse">
-            <a:avLst/>
-          </a:prstGeom>
-          <a:solidFill>
-            <a:srgbClr val="141B44"/>
-          </a:solidFill>
-          <a:ln/>
-        </p:spPr>
-      </p:sp>
-      <p:sp>
-        <p:nvSpPr>
-          <p:cNvPr id="4" name="Text 2"/>
+      <p:pic>
+        <p:nvPicPr>
+          <p:cNvPr id="2" name="Image 0" descr="정석항공과학고등학교 엠블럼">    </p:cNvPr>
+          <p:cNvPicPr>
+            <a:picLocks noChangeAspect="1"/>
+          </p:cNvPicPr>
+          <p:nvPr/>
+        </p:nvPicPr>
+        <p:blipFill>
+          <a:blip r:embed="rId1">
+            <a:alphaModFix amt="16000"/>
+          </a:blip>
+          <a:stretch>
+            <a:fillRect/>
+          </a:stretch>
+        </p:blipFill>
+        <p:spPr>
+          <a:xfrm>
+            <a:off x="7680960" y="1097280"/>
+            <a:ext cx="4023360" cy="4023360"/>
+          </a:xfrm>
+          <a:prstGeom prst="rect">
+            <a:avLst/>
+          </a:prstGeom>
+        </p:spPr>
+      </p:pic>
+      <p:pic>
+        <p:nvPicPr>
+          <p:cNvPr id="3" name="Image 1" descr="정석항공과학고등학교 교표">    </p:cNvPr>
+          <p:cNvPicPr>
+            <a:picLocks noChangeAspect="1"/>
+          </p:cNvPicPr>
+          <p:nvPr/>
+        </p:nvPicPr>
+        <p:blipFill>
+          <a:blip r:embed="rId2"/>
+          <a:stretch>
+            <a:fillRect/>
+          </a:stretch>
+        </p:blipFill>
+        <p:spPr>
+          <a:xfrm>
+            <a:off x="658368" y="457200"/>
+            <a:ext cx="1133856" cy="484632"/>
+          </a:xfrm>
+          <a:prstGeom prst="rect">
+            <a:avLst/>
+          </a:prstGeom>
+        </p:spPr>
+      </p:pic>
+      <p:sp>
+        <p:nvSpPr>
+          <p:cNvPr id="4" name="Text 0"/>
           <p:cNvSpPr txBox="1"/>
           <p:nvPr/>
         </p:nvSpPr>
@@ -2025,7 +2035,7 @@
                 <a:ea typeface="맑은 고딕" pitchFamily="34" charset="-122"/>
                 <a:cs typeface="맑은 고딕" pitchFamily="34" charset="-120"/>
               </a:rPr>
-              <a:t>정석고등학교 (24학급)</a:t>
+              <a:t>정석항공과학고등학교 (24학급)</a:t>
             </a:r>
             <a:endParaRPr lang="en-US" sz="1500" dirty="0"/>
           </a:p>
@@ -2033,7 +2043,7 @@
       </p:sp>
       <p:sp>
         <p:nvSpPr>
-          <p:cNvPr id="5" name="Text 3"/>
+          <p:cNvPr id="5" name="Text 1"/>
           <p:cNvSpPr txBox="1"/>
           <p:nvPr/>
         </p:nvSpPr>
@@ -2095,7 +2105,7 @@
       </p:sp>
       <p:sp>
         <p:nvSpPr>
-          <p:cNvPr id="6" name="Shape 4"/>
+          <p:cNvPr id="6" name="Shape 2"/>
           <p:cNvSpPr/>
           <p:nvPr/>
         </p:nvSpPr>
@@ -2117,7 +2127,7 @@
       </p:sp>
       <p:sp>
         <p:nvSpPr>
-          <p:cNvPr id="7" name="Text 5"/>
+          <p:cNvPr id="7" name="Text 3"/>
           <p:cNvSpPr txBox="1"/>
           <p:nvPr/>
         </p:nvSpPr>
@@ -2156,7 +2166,7 @@
       </p:sp>
       <p:sp>
         <p:nvSpPr>
-          <p:cNvPr id="8" name="Text 6"/>
+          <p:cNvPr id="8" name="Text 4"/>
           <p:cNvSpPr txBox="1"/>
           <p:nvPr/>
         </p:nvSpPr>
@@ -2195,7 +2205,7 @@
       </p:sp>
       <p:sp>
         <p:nvSpPr>
-          <p:cNvPr id="9" name="Text 7"/>
+          <p:cNvPr id="9" name="Text 5"/>
           <p:cNvSpPr txBox="1"/>
           <p:nvPr/>
         </p:nvSpPr>
@@ -2234,7 +2244,7 @@
       </p:sp>
       <p:sp>
         <p:nvSpPr>
-          <p:cNvPr id="10" name="Text 8"/>
+          <p:cNvPr id="10" name="Text 6"/>
           <p:cNvSpPr txBox="1"/>
           <p:nvPr/>
         </p:nvSpPr>
@@ -2273,7 +2283,7 @@
       </p:sp>
       <p:sp>
         <p:nvSpPr>
-          <p:cNvPr id="11" name="Text 9"/>
+          <p:cNvPr id="11" name="Text 7"/>
           <p:cNvSpPr txBox="1"/>
           <p:nvPr/>
         </p:nvSpPr>
@@ -2312,7 +2322,7 @@
       </p:sp>
       <p:sp>
         <p:nvSpPr>
-          <p:cNvPr id="12" name="Text 10"/>
+          <p:cNvPr id="12" name="Text 8"/>
           <p:cNvSpPr txBox="1"/>
           <p:nvPr/>
         </p:nvSpPr>
@@ -2351,7 +2361,7 @@
       </p:sp>
       <p:sp>
         <p:nvSpPr>
-          <p:cNvPr id="13" name="Text 11"/>
+          <p:cNvPr id="13" name="Text 9"/>
           <p:cNvSpPr txBox="1"/>
           <p:nvPr/>
         </p:nvSpPr>
@@ -2390,7 +2400,7 @@
       </p:sp>
       <p:sp>
         <p:nvSpPr>
-          <p:cNvPr id="14" name="Text 12"/>
+          <p:cNvPr id="14" name="Text 10"/>
           <p:cNvSpPr txBox="1"/>
           <p:nvPr/>
         </p:nvSpPr>
@@ -3292,7 +3302,7 @@
                 <a:ea typeface="맑은 고딕" pitchFamily="34" charset="-122"/>
                 <a:cs typeface="맑은 고딕" pitchFamily="34" charset="-120"/>
               </a:rPr>
-              <a:t>정석고등학교 · 기술·관리운영직(9급) 1명 공개채용</a:t>
+              <a:t>정석항공과학고등학교 · 기술·관리운영직(9급) 1명 공개채용</a:t>
             </a:r>
             <a:endParaRPr lang="en-US" sz="1400" dirty="0"/>
           </a:p>

</xml_diff>

<commit_message>
Even out the staffing table and stop words breaking across lines
Page 2 (staffing) table:
- The nine short columns (5급 … 채용(안)) now share one width; only
  구분, 기술·관리운영직 and 비고 are sized to their content
- Cell margins drop to 3pt and the header rows grow to 0.40", so
  "채용(안)" and "(기술직)" no longer wrap mid-header

Every slide:
- postprocess-linebreak.py stamps eaLnBrk="0" latinLnBrk="0" onto every
  paragraph in the slide XML, so Korean text wraps at word boundaries
  instead of mid-word (pptxgenjs exposes neither attribute). Run it
  after the generator:
      node build-recruitment-deck.js
      python3 postprocess-linebreak.py 2027년_사무직원_채용계획안.pptx

Co-Authored-By: Claude Opus 5 <noreply@anthropic.com>
Claude-Session: https://claude.ai/code/session_01GZfitk2JEKppZ4fGSDdghv
</commit_message>
<xml_diff>
--- a/docs/2027년_사무직원_채용계획안.pptx
+++ b/docs/2027년_사무직원_채용계획안.pptx
@@ -2023,7 +2023,7 @@
           <a:bodyPr wrap="square" lIns="0" tIns="0" rIns="0" bIns="0" rtlCol="0" anchor="ctr"/>
           <a:lstStyle/>
           <a:p>
-            <a:pPr indent="0" marL="0">
+            <a:pPr eaLnBrk="0" latinLnBrk="0" indent="0" marL="0">
               <a:buNone/>
             </a:pPr>
             <a:r>
@@ -2062,7 +2062,7 @@
           <a:bodyPr wrap="square" lIns="0" tIns="0" rIns="0" bIns="0" rtlCol="0" anchor="ctr"/>
           <a:lstStyle/>
           <a:p>
-            <a:pPr indent="0" marL="0">
+            <a:pPr eaLnBrk="0" latinLnBrk="0" indent="0" marL="0">
               <a:lnSpc>
                 <a:spcPts val="5400"/>
               </a:lnSpc>
@@ -2082,7 +2082,7 @@
             <a:endParaRPr lang="en-US" sz="4600" dirty="0"/>
           </a:p>
           <a:p>
-            <a:pPr indent="0" marL="0">
+            <a:pPr eaLnBrk="0" latinLnBrk="0" indent="0" marL="0">
               <a:lnSpc>
                 <a:spcPts val="5400"/>
               </a:lnSpc>
@@ -2146,7 +2146,7 @@
           <a:bodyPr wrap="square" lIns="0" tIns="0" rIns="0" bIns="0" rtlCol="0" anchor="ctr"/>
           <a:lstStyle/>
           <a:p>
-            <a:pPr algn="ctr" indent="0" marL="0">
+            <a:pPr eaLnBrk="0" latinLnBrk="0" algn="ctr" indent="0" marL="0">
               <a:buNone/>
             </a:pPr>
             <a:r>
@@ -2185,7 +2185,7 @@
           <a:bodyPr wrap="square" lIns="0" tIns="0" rIns="0" bIns="0" rtlCol="0" anchor="ctr"/>
           <a:lstStyle/>
           <a:p>
-            <a:pPr indent="0" marL="0">
+            <a:pPr eaLnBrk="0" latinLnBrk="0" indent="0" marL="0">
               <a:buNone/>
             </a:pPr>
             <a:r>
@@ -2224,7 +2224,7 @@
           <a:bodyPr wrap="square" lIns="0" tIns="0" rIns="0" bIns="0" rtlCol="0" anchor="ctr"/>
           <a:lstStyle/>
           <a:p>
-            <a:pPr indent="0" marL="0">
+            <a:pPr eaLnBrk="0" latinLnBrk="0" indent="0" marL="0">
               <a:buNone/>
             </a:pPr>
             <a:r>
@@ -2263,7 +2263,7 @@
           <a:bodyPr wrap="square" lIns="0" tIns="0" rIns="0" bIns="0" rtlCol="0" anchor="ctr"/>
           <a:lstStyle/>
           <a:p>
-            <a:pPr indent="0" marL="0">
+            <a:pPr eaLnBrk="0" latinLnBrk="0" indent="0" marL="0">
               <a:buNone/>
             </a:pPr>
             <a:r>
@@ -2302,7 +2302,7 @@
           <a:bodyPr wrap="square" lIns="0" tIns="0" rIns="0" bIns="0" rtlCol="0" anchor="ctr"/>
           <a:lstStyle/>
           <a:p>
-            <a:pPr indent="0" marL="0">
+            <a:pPr eaLnBrk="0" latinLnBrk="0" indent="0" marL="0">
               <a:buNone/>
             </a:pPr>
             <a:r>
@@ -2341,7 +2341,7 @@
           <a:bodyPr wrap="square" lIns="0" tIns="0" rIns="0" bIns="0" rtlCol="0" anchor="ctr"/>
           <a:lstStyle/>
           <a:p>
-            <a:pPr indent="0" marL="0">
+            <a:pPr eaLnBrk="0" latinLnBrk="0" indent="0" marL="0">
               <a:buNone/>
             </a:pPr>
             <a:r>
@@ -2380,7 +2380,7 @@
           <a:bodyPr wrap="square" lIns="0" tIns="0" rIns="0" bIns="0" rtlCol="0" anchor="ctr"/>
           <a:lstStyle/>
           <a:p>
-            <a:pPr indent="0" marL="0">
+            <a:pPr eaLnBrk="0" latinLnBrk="0" indent="0" marL="0">
               <a:buNone/>
             </a:pPr>
             <a:r>
@@ -2419,7 +2419,7 @@
           <a:bodyPr wrap="square" lIns="0" tIns="0" rIns="0" bIns="0" rtlCol="0" anchor="ctr"/>
           <a:lstStyle/>
           <a:p>
-            <a:pPr indent="0" marL="0">
+            <a:pPr eaLnBrk="0" latinLnBrk="0" indent="0" marL="0">
               <a:buNone/>
             </a:pPr>
             <a:r>
@@ -2514,7 +2514,7 @@
           <a:bodyPr wrap="square" lIns="0" tIns="0" rIns="0" bIns="0" rtlCol="0" anchor="ctr"/>
           <a:lstStyle/>
           <a:p>
-            <a:pPr algn="ctr" indent="0" marL="0">
+            <a:pPr eaLnBrk="0" latinLnBrk="0" algn="ctr" indent="0" marL="0">
               <a:buNone/>
             </a:pPr>
             <a:r>
@@ -2553,7 +2553,7 @@
           <a:bodyPr wrap="square" lIns="0" tIns="0" rIns="0" bIns="0" rtlCol="0" anchor="ctr"/>
           <a:lstStyle/>
           <a:p>
-            <a:pPr indent="0" marL="0">
+            <a:pPr eaLnBrk="0" latinLnBrk="0" indent="0" marL="0">
               <a:buNone/>
             </a:pPr>
             <a:r>
@@ -2592,7 +2592,7 @@
           <a:bodyPr wrap="square" lIns="0" tIns="0" rIns="0" bIns="0" rtlCol="0" anchor="ctr"/>
           <a:lstStyle/>
           <a:p>
-            <a:pPr indent="0" marL="0">
+            <a:pPr eaLnBrk="0" latinLnBrk="0" indent="0" marL="0">
               <a:buNone/>
             </a:pPr>
             <a:r>
@@ -2685,7 +2685,7 @@
           <a:bodyPr wrap="square" lIns="0" tIns="0" rIns="0" bIns="0" rtlCol="0" anchor="ctr"/>
           <a:lstStyle/>
           <a:p>
-            <a:pPr algn="ctr" indent="0" marL="0">
+            <a:pPr eaLnBrk="0" latinLnBrk="0" algn="ctr" indent="0" marL="0">
               <a:buNone/>
             </a:pPr>
             <a:r>
@@ -2724,7 +2724,7 @@
           <a:bodyPr wrap="square" lIns="0" tIns="0" rIns="0" bIns="0" rtlCol="0" anchor="ctr"/>
           <a:lstStyle/>
           <a:p>
-            <a:pPr indent="0" marL="0">
+            <a:pPr eaLnBrk="0" latinLnBrk="0" indent="0" marL="0">
               <a:buNone/>
             </a:pPr>
             <a:r>
@@ -2763,7 +2763,7 @@
           <a:bodyPr wrap="square" lIns="0" tIns="0" rIns="0" bIns="0" rtlCol="0" anchor="t"/>
           <a:lstStyle/>
           <a:p>
-            <a:pPr marL="342900" indent="-342900">
+            <a:pPr eaLnBrk="0" latinLnBrk="0" marL="342900" indent="-342900">
               <a:lnSpc>
                 <a:spcPts val="2200"/>
               </a:lnSpc>
@@ -2787,7 +2787,7 @@
             <a:endParaRPr lang="en-US" sz="1300" dirty="0"/>
           </a:p>
           <a:p>
-            <a:pPr marL="342900" indent="-342900">
+            <a:pPr eaLnBrk="0" latinLnBrk="0" marL="342900" indent="-342900">
               <a:lnSpc>
                 <a:spcPts val="2200"/>
               </a:lnSpc>
@@ -2887,7 +2887,7 @@
           <a:bodyPr wrap="square" lIns="0" tIns="0" rIns="0" bIns="0" rtlCol="0" anchor="ctr"/>
           <a:lstStyle/>
           <a:p>
-            <a:pPr algn="ctr" indent="0" marL="0">
+            <a:pPr eaLnBrk="0" latinLnBrk="0" algn="ctr" indent="0" marL="0">
               <a:buNone/>
             </a:pPr>
             <a:r>
@@ -2926,7 +2926,7 @@
           <a:bodyPr wrap="square" lIns="0" tIns="0" rIns="0" bIns="0" rtlCol="0" anchor="ctr"/>
           <a:lstStyle/>
           <a:p>
-            <a:pPr indent="0" marL="0">
+            <a:pPr eaLnBrk="0" latinLnBrk="0" indent="0" marL="0">
               <a:buNone/>
             </a:pPr>
             <a:r>
@@ -2965,7 +2965,7 @@
           <a:bodyPr wrap="square" lIns="0" tIns="0" rIns="0" bIns="0" rtlCol="0" anchor="t"/>
           <a:lstStyle/>
           <a:p>
-            <a:pPr marL="342900" indent="-342900">
+            <a:pPr eaLnBrk="0" latinLnBrk="0" marL="342900" indent="-342900">
               <a:lnSpc>
                 <a:spcPts val="2200"/>
               </a:lnSpc>
@@ -3065,7 +3065,7 @@
           <a:bodyPr wrap="square" lIns="0" tIns="0" rIns="0" bIns="0" rtlCol="0" anchor="ctr"/>
           <a:lstStyle/>
           <a:p>
-            <a:pPr algn="ctr" indent="0" marL="0">
+            <a:pPr eaLnBrk="0" latinLnBrk="0" algn="ctr" indent="0" marL="0">
               <a:buNone/>
             </a:pPr>
             <a:r>
@@ -3104,7 +3104,7 @@
           <a:bodyPr wrap="square" lIns="0" tIns="0" rIns="0" bIns="0" rtlCol="0" anchor="ctr"/>
           <a:lstStyle/>
           <a:p>
-            <a:pPr indent="0" marL="0">
+            <a:pPr eaLnBrk="0" latinLnBrk="0" indent="0" marL="0">
               <a:buNone/>
             </a:pPr>
             <a:r>
@@ -3143,7 +3143,7 @@
           <a:bodyPr wrap="square" lIns="0" tIns="0" rIns="0" bIns="0" rtlCol="0" anchor="t"/>
           <a:lstStyle/>
           <a:p>
-            <a:pPr marL="342900" indent="-342900">
+            <a:pPr eaLnBrk="0" latinLnBrk="0" marL="342900" indent="-342900">
               <a:lnSpc>
                 <a:spcPts val="2200"/>
               </a:lnSpc>
@@ -3223,7 +3223,7 @@
           <a:bodyPr wrap="square" lIns="0" tIns="0" rIns="0" bIns="0" rtlCol="0" anchor="ctr"/>
           <a:lstStyle/>
           <a:p>
-            <a:pPr algn="ctr" indent="0" marL="0">
+            <a:pPr eaLnBrk="0" latinLnBrk="0" algn="ctr" indent="0" marL="0">
               <a:buNone/>
             </a:pPr>
             <a:r>
@@ -3318,7 +3318,7 @@
           <a:bodyPr wrap="square" lIns="0" tIns="0" rIns="0" bIns="0" rtlCol="0" anchor="ctr"/>
           <a:lstStyle/>
           <a:p>
-            <a:pPr algn="ctr" indent="0" marL="0">
+            <a:pPr eaLnBrk="0" latinLnBrk="0" algn="ctr" indent="0" marL="0">
               <a:buNone/>
             </a:pPr>
             <a:r>
@@ -3357,7 +3357,7 @@
           <a:bodyPr wrap="square" lIns="0" tIns="0" rIns="0" bIns="0" rtlCol="0" anchor="ctr"/>
           <a:lstStyle/>
           <a:p>
-            <a:pPr indent="0" marL="0">
+            <a:pPr eaLnBrk="0" latinLnBrk="0" indent="0" marL="0">
               <a:buNone/>
             </a:pPr>
             <a:r>
@@ -3396,7 +3396,7 @@
           <a:bodyPr wrap="square" lIns="0" tIns="0" rIns="0" bIns="0" rtlCol="0" anchor="ctr"/>
           <a:lstStyle/>
           <a:p>
-            <a:pPr indent="0" marL="0">
+            <a:pPr eaLnBrk="0" latinLnBrk="0" indent="0" marL="0">
               <a:buNone/>
             </a:pPr>
             <a:r>
@@ -3462,7 +3462,7 @@
           <a:bodyPr wrap="square" lIns="0" tIns="0" rIns="0" bIns="0" rtlCol="0" anchor="ctr"/>
           <a:lstStyle/>
           <a:p>
-            <a:pPr indent="0" marL="0">
+            <a:pPr eaLnBrk="0" latinLnBrk="0" indent="0" marL="0">
               <a:buNone/>
             </a:pPr>
             <a:r>
@@ -3501,7 +3501,7 @@
           <a:bodyPr wrap="square" lIns="0" tIns="0" rIns="0" bIns="0" rtlCol="0" anchor="ctr"/>
           <a:lstStyle/>
           <a:p>
-            <a:pPr indent="0" marL="0">
+            <a:pPr eaLnBrk="0" latinLnBrk="0" indent="0" marL="0">
               <a:buNone/>
             </a:pPr>
             <a:r>
@@ -3540,7 +3540,7 @@
           <a:bodyPr wrap="square" lIns="0" tIns="0" rIns="0" bIns="0" rtlCol="0" anchor="ctr"/>
           <a:lstStyle/>
           <a:p>
-            <a:pPr indent="0" marL="0">
+            <a:pPr eaLnBrk="0" latinLnBrk="0" indent="0" marL="0">
               <a:lnSpc>
                 <a:spcPts val="1600"/>
               </a:lnSpc>
@@ -3609,7 +3609,7 @@
           <a:bodyPr wrap="square" lIns="0" tIns="0" rIns="0" bIns="0" rtlCol="0" anchor="ctr"/>
           <a:lstStyle/>
           <a:p>
-            <a:pPr indent="0" marL="0">
+            <a:pPr eaLnBrk="0" latinLnBrk="0" indent="0" marL="0">
               <a:buNone/>
             </a:pPr>
             <a:r>
@@ -3648,7 +3648,7 @@
           <a:bodyPr wrap="square" lIns="0" tIns="0" rIns="0" bIns="0" rtlCol="0" anchor="ctr"/>
           <a:lstStyle/>
           <a:p>
-            <a:pPr indent="0" marL="0">
+            <a:pPr eaLnBrk="0" latinLnBrk="0" indent="0" marL="0">
               <a:buNone/>
             </a:pPr>
             <a:r>
@@ -3687,7 +3687,7 @@
           <a:bodyPr wrap="square" lIns="0" tIns="0" rIns="0" bIns="0" rtlCol="0" anchor="ctr"/>
           <a:lstStyle/>
           <a:p>
-            <a:pPr indent="0" marL="0">
+            <a:pPr eaLnBrk="0" latinLnBrk="0" indent="0" marL="0">
               <a:lnSpc>
                 <a:spcPts val="1600"/>
               </a:lnSpc>
@@ -3756,7 +3756,7 @@
           <a:bodyPr wrap="square" lIns="0" tIns="0" rIns="0" bIns="0" rtlCol="0" anchor="ctr"/>
           <a:lstStyle/>
           <a:p>
-            <a:pPr indent="0" marL="0">
+            <a:pPr eaLnBrk="0" latinLnBrk="0" indent="0" marL="0">
               <a:buNone/>
             </a:pPr>
             <a:r>
@@ -3795,7 +3795,7 @@
           <a:bodyPr wrap="square" lIns="0" tIns="0" rIns="0" bIns="0" rtlCol="0" anchor="ctr"/>
           <a:lstStyle/>
           <a:p>
-            <a:pPr indent="0" marL="0">
+            <a:pPr eaLnBrk="0" latinLnBrk="0" indent="0" marL="0">
               <a:buNone/>
             </a:pPr>
             <a:r>
@@ -3834,7 +3834,7 @@
           <a:bodyPr wrap="square" lIns="0" tIns="0" rIns="0" bIns="0" rtlCol="0" anchor="ctr"/>
           <a:lstStyle/>
           <a:p>
-            <a:pPr indent="0" marL="0">
+            <a:pPr eaLnBrk="0" latinLnBrk="0" indent="0" marL="0">
               <a:lnSpc>
                 <a:spcPts val="1600"/>
               </a:lnSpc>
@@ -3903,7 +3903,7 @@
           <a:bodyPr wrap="square" lIns="0" tIns="0" rIns="0" bIns="0" rtlCol="0" anchor="ctr"/>
           <a:lstStyle/>
           <a:p>
-            <a:pPr indent="0" marL="0">
+            <a:pPr eaLnBrk="0" latinLnBrk="0" indent="0" marL="0">
               <a:buNone/>
             </a:pPr>
             <a:r>
@@ -3942,7 +3942,7 @@
           <a:bodyPr wrap="square" lIns="0" tIns="0" rIns="0" bIns="0" rtlCol="0" anchor="ctr"/>
           <a:lstStyle/>
           <a:p>
-            <a:pPr indent="0" marL="0">
+            <a:pPr eaLnBrk="0" latinLnBrk="0" indent="0" marL="0">
               <a:buNone/>
             </a:pPr>
             <a:r>
@@ -3981,7 +3981,7 @@
           <a:bodyPr wrap="square" lIns="0" tIns="0" rIns="0" bIns="0" rtlCol="0" anchor="ctr"/>
           <a:lstStyle/>
           <a:p>
-            <a:pPr indent="0" marL="0">
+            <a:pPr eaLnBrk="0" latinLnBrk="0" indent="0" marL="0">
               <a:lnSpc>
                 <a:spcPts val="1600"/>
               </a:lnSpc>
@@ -4023,7 +4023,7 @@
           <a:bodyPr wrap="square" lIns="0" tIns="0" rIns="0" bIns="0" rtlCol="0" anchor="ctr"/>
           <a:lstStyle/>
           <a:p>
-            <a:pPr indent="0" marL="0">
+            <a:pPr eaLnBrk="0" latinLnBrk="0" indent="0" marL="0">
               <a:buNone/>
             </a:pPr>
             <a:r>
@@ -4082,7 +4082,7 @@
           <a:bodyPr wrap="square" lIns="0" tIns="0" rIns="0" bIns="0" rtlCol="0" anchor="ctr"/>
           <a:lstStyle/>
           <a:p>
-            <a:pPr indent="0" marL="0">
+            <a:pPr eaLnBrk="0" latinLnBrk="0" indent="0" marL="0">
               <a:buNone/>
             </a:pPr>
             <a:r>
@@ -4121,7 +4121,7 @@
           <a:bodyPr wrap="square" lIns="0" tIns="0" rIns="0" bIns="0" rtlCol="0" anchor="ctr"/>
           <a:lstStyle/>
           <a:p>
-            <a:pPr indent="0" marL="0">
+            <a:pPr eaLnBrk="0" latinLnBrk="0" indent="0" marL="0">
               <a:lnSpc>
                 <a:spcPts val="1700"/>
               </a:lnSpc>
@@ -4183,7 +4183,7 @@
           <a:bodyPr wrap="square" lIns="0" tIns="0" rIns="0" bIns="0" rtlCol="0" anchor="ctr"/>
           <a:lstStyle/>
           <a:p>
-            <a:pPr indent="0" marL="0">
+            <a:pPr eaLnBrk="0" latinLnBrk="0" indent="0" marL="0">
               <a:buNone/>
             </a:pPr>
             <a:r>
@@ -4222,7 +4222,7 @@
           <a:bodyPr wrap="square" lIns="0" tIns="0" rIns="0" bIns="0" rtlCol="0" anchor="ctr"/>
           <a:lstStyle/>
           <a:p>
-            <a:pPr indent="0" marL="0">
+            <a:pPr eaLnBrk="0" latinLnBrk="0" indent="0" marL="0">
               <a:lnSpc>
                 <a:spcPts val="1700"/>
               </a:lnSpc>
@@ -4284,7 +4284,7 @@
           <a:bodyPr wrap="square" lIns="0" tIns="0" rIns="0" bIns="0" rtlCol="0" anchor="ctr"/>
           <a:lstStyle/>
           <a:p>
-            <a:pPr indent="0" marL="0">
+            <a:pPr eaLnBrk="0" latinLnBrk="0" indent="0" marL="0">
               <a:buNone/>
             </a:pPr>
             <a:r>
@@ -4323,7 +4323,7 @@
           <a:bodyPr wrap="square" lIns="0" tIns="0" rIns="0" bIns="0" rtlCol="0" anchor="ctr"/>
           <a:lstStyle/>
           <a:p>
-            <a:pPr indent="0" marL="0">
+            <a:pPr eaLnBrk="0" latinLnBrk="0" indent="0" marL="0">
               <a:lnSpc>
                 <a:spcPts val="1700"/>
               </a:lnSpc>
@@ -4385,7 +4385,7 @@
           <a:bodyPr wrap="square" lIns="0" tIns="0" rIns="0" bIns="0" rtlCol="0" anchor="ctr"/>
           <a:lstStyle/>
           <a:p>
-            <a:pPr indent="0" marL="0">
+            <a:pPr eaLnBrk="0" latinLnBrk="0" indent="0" marL="0">
               <a:buNone/>
             </a:pPr>
             <a:r>
@@ -4424,7 +4424,7 @@
           <a:bodyPr wrap="square" lIns="0" tIns="0" rIns="0" bIns="0" rtlCol="0" anchor="ctr"/>
           <a:lstStyle/>
           <a:p>
-            <a:pPr indent="0" marL="0">
+            <a:pPr eaLnBrk="0" latinLnBrk="0" indent="0" marL="0">
               <a:lnSpc>
                 <a:spcPts val="1700"/>
               </a:lnSpc>
@@ -4522,7 +4522,7 @@
           <a:bodyPr wrap="square" lIns="0" tIns="0" rIns="0" bIns="0" rtlCol="0" anchor="ctr"/>
           <a:lstStyle/>
           <a:p>
-            <a:pPr algn="ctr" indent="0" marL="0">
+            <a:pPr eaLnBrk="0" latinLnBrk="0" algn="ctr" indent="0" marL="0">
               <a:buNone/>
             </a:pPr>
             <a:r>
@@ -4561,7 +4561,7 @@
           <a:bodyPr wrap="square" lIns="0" tIns="0" rIns="0" bIns="0" rtlCol="0" anchor="ctr"/>
           <a:lstStyle/>
           <a:p>
-            <a:pPr indent="0" marL="0">
+            <a:pPr eaLnBrk="0" latinLnBrk="0" indent="0" marL="0">
               <a:buNone/>
             </a:pPr>
             <a:r>
@@ -4600,7 +4600,7 @@
           <a:bodyPr wrap="square" lIns="0" tIns="0" rIns="0" bIns="0" rtlCol="0" anchor="ctr"/>
           <a:lstStyle/>
           <a:p>
-            <a:pPr indent="0" marL="0">
+            <a:pPr eaLnBrk="0" latinLnBrk="0" indent="0" marL="0">
               <a:buNone/>
             </a:pPr>
             <a:r>
@@ -4673,7 +4673,7 @@
           <a:bodyPr wrap="square" lIns="0" tIns="0" rIns="0" bIns="0" rtlCol="0" anchor="ctr"/>
           <a:lstStyle/>
           <a:p>
-            <a:pPr algn="ctr" indent="0" marL="0">
+            <a:pPr eaLnBrk="0" latinLnBrk="0" algn="ctr" indent="0" marL="0">
               <a:buNone/>
             </a:pPr>
             <a:r>
@@ -4712,7 +4712,7 @@
           <a:bodyPr wrap="square" lIns="0" tIns="0" rIns="0" bIns="0" rtlCol="0" anchor="ctr"/>
           <a:lstStyle/>
           <a:p>
-            <a:pPr algn="ctr" indent="0" marL="0">
+            <a:pPr eaLnBrk="0" latinLnBrk="0" algn="ctr" indent="0" marL="0">
               <a:buNone/>
             </a:pPr>
             <a:r>
@@ -4785,7 +4785,7 @@
           <a:bodyPr wrap="square" lIns="0" tIns="0" rIns="0" bIns="0" rtlCol="0" anchor="ctr"/>
           <a:lstStyle/>
           <a:p>
-            <a:pPr algn="ctr" indent="0" marL="0">
+            <a:pPr eaLnBrk="0" latinLnBrk="0" algn="ctr" indent="0" marL="0">
               <a:buNone/>
             </a:pPr>
             <a:r>
@@ -4824,7 +4824,7 @@
           <a:bodyPr wrap="square" lIns="0" tIns="0" rIns="0" bIns="0" rtlCol="0" anchor="ctr"/>
           <a:lstStyle/>
           <a:p>
-            <a:pPr algn="ctr" indent="0" marL="0">
+            <a:pPr eaLnBrk="0" latinLnBrk="0" algn="ctr" indent="0" marL="0">
               <a:buNone/>
             </a:pPr>
             <a:r>
@@ -4897,7 +4897,7 @@
           <a:bodyPr wrap="square" lIns="0" tIns="0" rIns="0" bIns="0" rtlCol="0" anchor="ctr"/>
           <a:lstStyle/>
           <a:p>
-            <a:pPr algn="ctr" indent="0" marL="0">
+            <a:pPr eaLnBrk="0" latinLnBrk="0" algn="ctr" indent="0" marL="0">
               <a:buNone/>
             </a:pPr>
             <a:r>
@@ -4936,7 +4936,7 @@
           <a:bodyPr wrap="square" lIns="0" tIns="0" rIns="0" bIns="0" rtlCol="0" anchor="ctr"/>
           <a:lstStyle/>
           <a:p>
-            <a:pPr algn="ctr" indent="0" marL="0">
+            <a:pPr eaLnBrk="0" latinLnBrk="0" algn="ctr" indent="0" marL="0">
               <a:buNone/>
             </a:pPr>
             <a:r>
@@ -5009,7 +5009,7 @@
           <a:bodyPr wrap="square" lIns="0" tIns="0" rIns="0" bIns="0" rtlCol="0" anchor="ctr"/>
           <a:lstStyle/>
           <a:p>
-            <a:pPr indent="0" marL="0">
+            <a:pPr eaLnBrk="0" latinLnBrk="0" indent="0" marL="0">
               <a:buNone/>
             </a:pPr>
             <a:r>
@@ -5048,7 +5048,7 @@
           <a:bodyPr wrap="square" lIns="0" tIns="0" rIns="0" bIns="0" rtlCol="0" anchor="ctr"/>
           <a:lstStyle/>
           <a:p>
-            <a:pPr indent="0" marL="0">
+            <a:pPr eaLnBrk="0" latinLnBrk="0" indent="0" marL="0">
               <a:buNone/>
             </a:pPr>
             <a:r>
@@ -5087,7 +5087,7 @@
           <a:bodyPr wrap="square" lIns="0" tIns="0" rIns="0" bIns="0" rtlCol="0" anchor="ctr"/>
           <a:lstStyle/>
           <a:p>
-            <a:pPr indent="0" marL="0">
+            <a:pPr eaLnBrk="0" latinLnBrk="0" indent="0" marL="0">
               <a:lnSpc>
                 <a:spcPts val="2100"/>
               </a:lnSpc>
@@ -5107,7 +5107,7 @@
             <a:endParaRPr lang="en-US" sz="1300" dirty="0"/>
           </a:p>
           <a:p>
-            <a:pPr indent="0" marL="0">
+            <a:pPr eaLnBrk="0" latinLnBrk="0" indent="0" marL="0">
               <a:lnSpc>
                 <a:spcPts val="2100"/>
               </a:lnSpc>
@@ -5183,7 +5183,7 @@
           <a:bodyPr wrap="square" lIns="0" tIns="0" rIns="0" bIns="0" rtlCol="0" anchor="ctr"/>
           <a:lstStyle/>
           <a:p>
-            <a:pPr indent="0" marL="0">
+            <a:pPr eaLnBrk="0" latinLnBrk="0" indent="0" marL="0">
               <a:buNone/>
             </a:pPr>
             <a:r>
@@ -5222,7 +5222,7 @@
           <a:bodyPr wrap="square" lIns="0" tIns="0" rIns="0" bIns="0" rtlCol="0" anchor="ctr"/>
           <a:lstStyle/>
           <a:p>
-            <a:pPr indent="0" marL="0">
+            <a:pPr eaLnBrk="0" latinLnBrk="0" indent="0" marL="0">
               <a:buNone/>
             </a:pPr>
             <a:r>
@@ -5295,7 +5295,7 @@
           <a:bodyPr wrap="square" lIns="0" tIns="0" rIns="0" bIns="0" rtlCol="0" anchor="ctr"/>
           <a:lstStyle/>
           <a:p>
-            <a:pPr indent="0" marL="0">
+            <a:pPr eaLnBrk="0" latinLnBrk="0" indent="0" marL="0">
               <a:buNone/>
             </a:pPr>
             <a:r>
@@ -5354,7 +5354,7 @@
           <a:bodyPr wrap="square" lIns="0" tIns="0" rIns="0" bIns="0" rtlCol="0" anchor="ctr"/>
           <a:lstStyle/>
           <a:p>
-            <a:pPr algn="ctr" indent="0" marL="0">
+            <a:pPr eaLnBrk="0" latinLnBrk="0" algn="ctr" indent="0" marL="0">
               <a:buNone/>
             </a:pPr>
             <a:r>
@@ -5393,7 +5393,7 @@
           <a:bodyPr wrap="square" lIns="0" tIns="0" rIns="0" bIns="0" rtlCol="0" anchor="ctr"/>
           <a:lstStyle/>
           <a:p>
-            <a:pPr indent="0" marL="0">
+            <a:pPr eaLnBrk="0" latinLnBrk="0" indent="0" marL="0">
               <a:lnSpc>
                 <a:spcPts val="2500"/>
               </a:lnSpc>
@@ -5455,7 +5455,7 @@
           <a:bodyPr wrap="square" lIns="0" tIns="0" rIns="0" bIns="0" rtlCol="0" anchor="ctr"/>
           <a:lstStyle/>
           <a:p>
-            <a:pPr algn="ctr" indent="0" marL="0">
+            <a:pPr eaLnBrk="0" latinLnBrk="0" algn="ctr" indent="0" marL="0">
               <a:buNone/>
             </a:pPr>
             <a:r>
@@ -5494,7 +5494,7 @@
           <a:bodyPr wrap="square" lIns="0" tIns="0" rIns="0" bIns="0" rtlCol="0" anchor="ctr"/>
           <a:lstStyle/>
           <a:p>
-            <a:pPr indent="0" marL="0">
+            <a:pPr eaLnBrk="0" latinLnBrk="0" indent="0" marL="0">
               <a:lnSpc>
                 <a:spcPts val="2500"/>
               </a:lnSpc>
@@ -5536,7 +5536,7 @@
           <a:bodyPr wrap="square" lIns="0" tIns="0" rIns="0" bIns="0" rtlCol="0" anchor="ctr"/>
           <a:lstStyle/>
           <a:p>
-            <a:pPr indent="0" marL="0">
+            <a:pPr eaLnBrk="0" latinLnBrk="0" indent="0" marL="0">
               <a:buNone/>
             </a:pPr>
             <a:r>
@@ -5631,7 +5631,7 @@
           <a:bodyPr wrap="square" lIns="0" tIns="0" rIns="0" bIns="0" rtlCol="0" anchor="ctr"/>
           <a:lstStyle/>
           <a:p>
-            <a:pPr algn="ctr" indent="0" marL="0">
+            <a:pPr eaLnBrk="0" latinLnBrk="0" algn="ctr" indent="0" marL="0">
               <a:buNone/>
             </a:pPr>
             <a:r>
@@ -5670,7 +5670,7 @@
           <a:bodyPr wrap="square" lIns="0" tIns="0" rIns="0" bIns="0" rtlCol="0" anchor="ctr"/>
           <a:lstStyle/>
           <a:p>
-            <a:pPr indent="0" marL="0">
+            <a:pPr eaLnBrk="0" latinLnBrk="0" indent="0" marL="0">
               <a:buNone/>
             </a:pPr>
             <a:r>
@@ -5709,7 +5709,7 @@
           <a:bodyPr wrap="square" lIns="0" tIns="0" rIns="0" bIns="0" rtlCol="0" anchor="ctr"/>
           <a:lstStyle/>
           <a:p>
-            <a:pPr indent="0" marL="0">
+            <a:pPr eaLnBrk="0" latinLnBrk="0" indent="0" marL="0">
               <a:buNone/>
             </a:pPr>
             <a:r>
@@ -5748,7 +5748,7 @@
           <a:bodyPr wrap="square" lIns="0" tIns="0" rIns="0" bIns="0" rtlCol="0" anchor="ctr"/>
           <a:lstStyle/>
           <a:p>
-            <a:pPr indent="0" marL="0">
+            <a:pPr eaLnBrk="0" latinLnBrk="0" indent="0" marL="0">
               <a:buNone/>
             </a:pPr>
             <a:r>
@@ -5789,27 +5789,27 @@
             <a:tbl>
               <a:tblPr/>
               <a:tblGrid>
-                <a:gridCol w="1133856"/>
-                <a:gridCol w="658368"/>
-                <a:gridCol w="548640"/>
-                <a:gridCol w="548640"/>
-                <a:gridCol w="548640"/>
-                <a:gridCol w="548640"/>
-                <a:gridCol w="1060704"/>
-                <a:gridCol w="548640"/>
-                <a:gridCol w="694944"/>
-                <a:gridCol w="603504"/>
-                <a:gridCol w="694944"/>
-                <a:gridCol w="822960"/>
-                <a:gridCol w="2432304"/>
+                <a:gridCol w="1097280"/>
+                <a:gridCol w="676656"/>
+                <a:gridCol w="682782"/>
+                <a:gridCol w="682782"/>
+                <a:gridCol w="682782"/>
+                <a:gridCol w="682782"/>
+                <a:gridCol w="1143000"/>
+                <a:gridCol w="682782"/>
+                <a:gridCol w="682782"/>
+                <a:gridCol w="682782"/>
+                <a:gridCol w="682782"/>
+                <a:gridCol w="682782"/>
+                <a:gridCol w="1783080"/>
               </a:tblGrid>
-              <a:tr h="347472">
+              <a:tr h="365760">
                 <a:tc rowSpan="3" gridSpan="2">
                   <a:txBody>
                     <a:bodyPr/>
                     <a:lstStyle/>
                     <a:p>
-                      <a:pPr algn="ctr" indent="0" marL="0">
+                      <a:pPr eaLnBrk="0" latinLnBrk="0" algn="ctr" indent="0" marL="0">
                         <a:buNone/>
                       </a:pPr>
                       <a:r>
@@ -5830,7 +5830,7 @@
                       </a:endParaRPr>
                     </a:p>
                   </a:txBody>
-                  <a:tcPr marL="91440" marR="91440" marT="45720" marB="45720" anchor="ctr">
+                  <a:tcPr marL="38100" marR="38100" marT="38100" marB="38100" anchor="ctr">
                     <a:lnL w="12700" cap="flat" cmpd="sng" algn="ctr">
                       <a:solidFill>
                         <a:srgbClr val="C6CEE2"/>
@@ -5880,7 +5880,7 @@
                     <a:bodyPr/>
                     <a:lstStyle/>
                     <a:p>
-                      <a:pPr algn="ctr" indent="0" marL="0">
+                      <a:pPr eaLnBrk="0" latinLnBrk="0" algn="ctr" indent="0" marL="0">
                         <a:buNone/>
                       </a:pPr>
                       <a:r>
@@ -5901,7 +5901,7 @@
                       </a:endParaRPr>
                     </a:p>
                   </a:txBody>
-                  <a:tcPr marL="91440" marR="91440" marT="45720" marB="45720" anchor="ctr">
+                  <a:tcPr marL="38100" marR="38100" marT="38100" marB="38100" anchor="ctr">
                     <a:lnL w="12700" cap="flat" cmpd="sng" algn="ctr">
                       <a:solidFill>
                         <a:srgbClr val="C6CEE2"/>
@@ -5960,7 +5960,7 @@
                     <a:bodyPr/>
                     <a:lstStyle/>
                     <a:p>
-                      <a:pPr algn="ctr" indent="0" marL="0">
+                      <a:pPr eaLnBrk="0" latinLnBrk="0" algn="ctr" indent="0" marL="0">
                         <a:buNone/>
                       </a:pPr>
                       <a:r>
@@ -5981,7 +5981,7 @@
                       </a:endParaRPr>
                     </a:p>
                   </a:txBody>
-                  <a:tcPr marL="91440" marR="91440" marT="45720" marB="45720" anchor="ctr">
+                  <a:tcPr marL="38100" marR="38100" marT="38100" marB="38100" anchor="ctr">
                     <a:lnL w="12700" cap="flat" cmpd="sng" algn="ctr">
                       <a:solidFill>
                         <a:srgbClr val="C6CEE2"/>
@@ -6028,7 +6028,7 @@
                     <a:bodyPr/>
                     <a:lstStyle/>
                     <a:p>
-                      <a:pPr algn="ctr" indent="0" marL="0">
+                      <a:pPr eaLnBrk="0" latinLnBrk="0" algn="ctr" indent="0" marL="0">
                         <a:buNone/>
                       </a:pPr>
                       <a:r>
@@ -6049,7 +6049,7 @@
                       </a:endParaRPr>
                     </a:p>
                     <a:p>
-                      <a:pPr algn="ctr" indent="0" marL="0">
+                      <a:pPr eaLnBrk="0" latinLnBrk="0" algn="ctr" indent="0" marL="0">
                         <a:buNone/>
                       </a:pPr>
                       <a:r>
@@ -6070,7 +6070,7 @@
                       </a:endParaRPr>
                     </a:p>
                   </a:txBody>
-                  <a:tcPr marL="91440" marR="91440" marT="45720" marB="45720" anchor="ctr">
+                  <a:tcPr marL="38100" marR="38100" marT="38100" marB="38100" anchor="ctr">
                     <a:lnL w="12700" cap="flat" cmpd="sng" algn="ctr">
                       <a:solidFill>
                         <a:srgbClr val="C6CEE2"/>
@@ -6117,7 +6117,7 @@
                     <a:bodyPr/>
                     <a:lstStyle/>
                     <a:p>
-                      <a:pPr algn="ctr" indent="0" marL="0">
+                      <a:pPr eaLnBrk="0" latinLnBrk="0" algn="ctr" indent="0" marL="0">
                         <a:buNone/>
                       </a:pPr>
                       <a:r>
@@ -6138,7 +6138,7 @@
                       </a:endParaRPr>
                     </a:p>
                   </a:txBody>
-                  <a:tcPr marL="91440" marR="91440" marT="45720" marB="45720" anchor="ctr">
+                  <a:tcPr marL="38100" marR="38100" marT="38100" marB="38100" anchor="ctr">
                     <a:lnL w="12700" cap="flat" cmpd="sng" algn="ctr">
                       <a:solidFill>
                         <a:srgbClr val="C6CEE2"/>
@@ -6185,7 +6185,7 @@
                     <a:bodyPr/>
                     <a:lstStyle/>
                     <a:p>
-                      <a:pPr algn="ctr" indent="0" marL="0">
+                      <a:pPr eaLnBrk="0" latinLnBrk="0" algn="ctr" indent="0" marL="0">
                         <a:buNone/>
                       </a:pPr>
                       <a:r>
@@ -6206,7 +6206,7 @@
                       </a:endParaRPr>
                     </a:p>
                   </a:txBody>
-                  <a:tcPr marL="91440" marR="91440" marT="45720" marB="45720" anchor="ctr">
+                  <a:tcPr marL="38100" marR="38100" marT="38100" marB="38100" anchor="ctr">
                     <a:lnL w="12700" cap="flat" cmpd="sng" algn="ctr">
                       <a:solidFill>
                         <a:srgbClr val="C6CEE2"/>
@@ -6253,7 +6253,7 @@
                     <a:bodyPr/>
                     <a:lstStyle/>
                     <a:p>
-                      <a:pPr algn="ctr" indent="0" marL="0">
+                      <a:pPr eaLnBrk="0" latinLnBrk="0" algn="ctr" indent="0" marL="0">
                         <a:buNone/>
                       </a:pPr>
                       <a:r>
@@ -6274,7 +6274,7 @@
                       </a:endParaRPr>
                     </a:p>
                   </a:txBody>
-                  <a:tcPr marL="91440" marR="91440" marT="45720" marB="45720" anchor="ctr">
+                  <a:tcPr marL="38100" marR="38100" marT="38100" marB="38100" anchor="ctr">
                     <a:lnL w="12700" cap="flat" cmpd="sng" algn="ctr">
                       <a:solidFill>
                         <a:srgbClr val="C6CEE2"/>
@@ -6321,7 +6321,7 @@
                     <a:bodyPr/>
                     <a:lstStyle/>
                     <a:p>
-                      <a:pPr algn="ctr" indent="0" marL="0">
+                      <a:pPr eaLnBrk="0" latinLnBrk="0" algn="ctr" indent="0" marL="0">
                         <a:buNone/>
                       </a:pPr>
                       <a:r>
@@ -6342,7 +6342,7 @@
                       </a:endParaRPr>
                     </a:p>
                   </a:txBody>
-                  <a:tcPr marL="91440" marR="91440" marT="45720" marB="45720" anchor="ctr">
+                  <a:tcPr marL="38100" marR="38100" marT="38100" marB="38100" anchor="ctr">
                     <a:lnL w="12700" cap="flat" cmpd="sng" algn="ctr">
                       <a:solidFill>
                         <a:srgbClr val="C6CEE2"/>
@@ -6385,7 +6385,7 @@
                   </a:tcPr>
                 </a:tc>
               </a:tr>
-              <a:tr h="347472">
+              <a:tr h="365760">
                 <a:tc gridSpan="2" vMerge="1">
                   <a:tcPr/>
                 </a:tc>
@@ -6397,7 +6397,7 @@
                     <a:bodyPr/>
                     <a:lstStyle/>
                     <a:p>
-                      <a:pPr algn="ctr" indent="0" marL="0">
+                      <a:pPr eaLnBrk="0" latinLnBrk="0" algn="ctr" indent="0" marL="0">
                         <a:buNone/>
                       </a:pPr>
                       <a:r>
@@ -6418,7 +6418,7 @@
                       </a:endParaRPr>
                     </a:p>
                   </a:txBody>
-                  <a:tcPr marL="91440" marR="91440" marT="45720" marB="45720" anchor="ctr">
+                  <a:tcPr marL="38100" marR="38100" marT="38100" marB="38100" anchor="ctr">
                     <a:lnL w="12700" cap="flat" cmpd="sng" algn="ctr">
                       <a:solidFill>
                         <a:srgbClr val="C6CEE2"/>
@@ -6474,7 +6474,7 @@
                     <a:bodyPr/>
                     <a:lstStyle/>
                     <a:p>
-                      <a:pPr algn="ctr" indent="0" marL="0">
+                      <a:pPr eaLnBrk="0" latinLnBrk="0" algn="ctr" indent="0" marL="0">
                         <a:buNone/>
                       </a:pPr>
                       <a:r>
@@ -6495,7 +6495,7 @@
                       </a:endParaRPr>
                     </a:p>
                     <a:p>
-                      <a:pPr algn="ctr" indent="0" marL="0">
+                      <a:pPr eaLnBrk="0" latinLnBrk="0" algn="ctr" indent="0" marL="0">
                         <a:buNone/>
                       </a:pPr>
                       <a:r>
@@ -6516,7 +6516,7 @@
                       </a:endParaRPr>
                     </a:p>
                   </a:txBody>
-                  <a:tcPr marL="91440" marR="91440" marT="45720" marB="45720" anchor="ctr">
+                  <a:tcPr marL="38100" marR="38100" marT="38100" marB="38100" anchor="ctr">
                     <a:lnL w="12700" cap="flat" cmpd="sng" algn="ctr">
                       <a:solidFill>
                         <a:srgbClr val="C6CEE2"/>
@@ -6577,7 +6577,7 @@
                   <a:tcPr/>
                 </a:tc>
               </a:tr>
-              <a:tr h="347472">
+              <a:tr h="365760">
                 <a:tc gridSpan="2" vMerge="1">
                   <a:tcPr/>
                 </a:tc>
@@ -6589,7 +6589,7 @@
                     <a:bodyPr/>
                     <a:lstStyle/>
                     <a:p>
-                      <a:pPr algn="ctr" indent="0" marL="0">
+                      <a:pPr eaLnBrk="0" latinLnBrk="0" algn="ctr" indent="0" marL="0">
                         <a:buNone/>
                       </a:pPr>
                       <a:r>
@@ -6610,7 +6610,7 @@
                       </a:endParaRPr>
                     </a:p>
                   </a:txBody>
-                  <a:tcPr marL="91440" marR="91440" marT="45720" marB="45720" anchor="ctr">
+                  <a:tcPr marL="38100" marR="38100" marT="38100" marB="38100" anchor="ctr">
                     <a:lnL w="12700" cap="flat" cmpd="sng" algn="ctr">
                       <a:solidFill>
                         <a:srgbClr val="C6CEE2"/>
@@ -6657,7 +6657,7 @@
                     <a:bodyPr/>
                     <a:lstStyle/>
                     <a:p>
-                      <a:pPr algn="ctr" indent="0" marL="0">
+                      <a:pPr eaLnBrk="0" latinLnBrk="0" algn="ctr" indent="0" marL="0">
                         <a:buNone/>
                       </a:pPr>
                       <a:r>
@@ -6678,7 +6678,7 @@
                       </a:endParaRPr>
                     </a:p>
                   </a:txBody>
-                  <a:tcPr marL="91440" marR="91440" marT="45720" marB="45720" anchor="ctr">
+                  <a:tcPr marL="38100" marR="38100" marT="38100" marB="38100" anchor="ctr">
                     <a:lnL w="12700" cap="flat" cmpd="sng" algn="ctr">
                       <a:solidFill>
                         <a:srgbClr val="C6CEE2"/>
@@ -6725,7 +6725,7 @@
                     <a:bodyPr/>
                     <a:lstStyle/>
                     <a:p>
-                      <a:pPr algn="ctr" indent="0" marL="0">
+                      <a:pPr eaLnBrk="0" latinLnBrk="0" algn="ctr" indent="0" marL="0">
                         <a:buNone/>
                       </a:pPr>
                       <a:r>
@@ -6746,7 +6746,7 @@
                       </a:endParaRPr>
                     </a:p>
                   </a:txBody>
-                  <a:tcPr marL="91440" marR="91440" marT="45720" marB="45720" anchor="ctr">
+                  <a:tcPr marL="38100" marR="38100" marT="38100" marB="38100" anchor="ctr">
                     <a:lnL w="12700" cap="flat" cmpd="sng" algn="ctr">
                       <a:solidFill>
                         <a:srgbClr val="C6CEE2"/>
@@ -6793,7 +6793,7 @@
                     <a:bodyPr/>
                     <a:lstStyle/>
                     <a:p>
-                      <a:pPr algn="ctr" indent="0" marL="0">
+                      <a:pPr eaLnBrk="0" latinLnBrk="0" algn="ctr" indent="0" marL="0">
                         <a:buNone/>
                       </a:pPr>
                       <a:r>
@@ -6814,7 +6814,7 @@
                       </a:endParaRPr>
                     </a:p>
                   </a:txBody>
-                  <a:tcPr marL="91440" marR="91440" marT="45720" marB="45720" anchor="ctr">
+                  <a:tcPr marL="38100" marR="38100" marT="38100" marB="38100" anchor="ctr">
                     <a:lnL w="12700" cap="flat" cmpd="sng" algn="ctr">
                       <a:solidFill>
                         <a:srgbClr val="C6CEE2"/>
@@ -6878,13 +6878,13 @@
                   <a:tcPr/>
                 </a:tc>
               </a:tr>
-              <a:tr h="658368">
+              <a:tr h="676656">
                 <a:tc rowSpan="2">
                   <a:txBody>
                     <a:bodyPr/>
                     <a:lstStyle/>
                     <a:p>
-                      <a:pPr algn="ctr" indent="0" marL="0">
+                      <a:pPr eaLnBrk="0" latinLnBrk="0" algn="ctr" indent="0" marL="0">
                         <a:buNone/>
                       </a:pPr>
                       <a:r>
@@ -6905,7 +6905,7 @@
                       </a:endParaRPr>
                     </a:p>
                     <a:p>
-                      <a:pPr algn="ctr" indent="0" marL="0">
+                      <a:pPr eaLnBrk="0" latinLnBrk="0" algn="ctr" indent="0" marL="0">
                         <a:buNone/>
                       </a:pPr>
                       <a:r>
@@ -6926,7 +6926,7 @@
                       </a:endParaRPr>
                     </a:p>
                   </a:txBody>
-                  <a:tcPr marL="91440" marR="91440" marT="45720" marB="45720" anchor="ctr">
+                  <a:tcPr marL="38100" marR="38100" marT="38100" marB="38100" anchor="ctr">
                     <a:lnL w="12700" cap="flat" cmpd="sng" algn="ctr">
                       <a:solidFill>
                         <a:srgbClr val="C6CEE2"/>
@@ -6973,7 +6973,7 @@
                     <a:bodyPr/>
                     <a:lstStyle/>
                     <a:p>
-                      <a:pPr algn="ctr" indent="0" marL="0">
+                      <a:pPr eaLnBrk="0" latinLnBrk="0" algn="ctr" indent="0" marL="0">
                         <a:buNone/>
                       </a:pPr>
                       <a:r>
@@ -6994,7 +6994,7 @@
                       </a:endParaRPr>
                     </a:p>
                   </a:txBody>
-                  <a:tcPr marL="91440" marR="91440" marT="45720" marB="45720" anchor="ctr">
+                  <a:tcPr marL="38100" marR="38100" marT="38100" marB="38100" anchor="ctr">
                     <a:lnL w="12700" cap="flat" cmpd="sng" algn="ctr">
                       <a:solidFill>
                         <a:srgbClr val="C6CEE2"/>
@@ -7041,7 +7041,7 @@
                     <a:bodyPr/>
                     <a:lstStyle/>
                     <a:p>
-                      <a:pPr algn="ctr" indent="0" marL="0">
+                      <a:pPr eaLnBrk="0" latinLnBrk="0" algn="ctr" indent="0" marL="0">
                         <a:buNone/>
                       </a:pPr>
                       <a:r>
@@ -7062,7 +7062,7 @@
                       </a:endParaRPr>
                     </a:p>
                   </a:txBody>
-                  <a:tcPr marL="91440" marR="91440" marT="45720" marB="45720" anchor="ctr">
+                  <a:tcPr marL="38100" marR="38100" marT="38100" marB="38100" anchor="ctr">
                     <a:lnL w="12700" cap="flat" cmpd="sng" algn="ctr">
                       <a:solidFill>
                         <a:srgbClr val="C6CEE2"/>
@@ -7106,7 +7106,7 @@
                     <a:bodyPr/>
                     <a:lstStyle/>
                     <a:p>
-                      <a:pPr algn="ctr" indent="0" marL="0">
+                      <a:pPr eaLnBrk="0" latinLnBrk="0" algn="ctr" indent="0" marL="0">
                         <a:buNone/>
                       </a:pPr>
                       <a:r>
@@ -7127,7 +7127,7 @@
                       </a:endParaRPr>
                     </a:p>
                   </a:txBody>
-                  <a:tcPr marL="91440" marR="91440" marT="45720" marB="45720" anchor="ctr">
+                  <a:tcPr marL="38100" marR="38100" marT="38100" marB="38100" anchor="ctr">
                     <a:lnL w="12700" cap="flat" cmpd="sng" algn="ctr">
                       <a:solidFill>
                         <a:srgbClr val="C6CEE2"/>
@@ -7171,7 +7171,7 @@
                     <a:bodyPr/>
                     <a:lstStyle/>
                     <a:p>
-                      <a:pPr algn="ctr" indent="0" marL="0">
+                      <a:pPr eaLnBrk="0" latinLnBrk="0" algn="ctr" indent="0" marL="0">
                         <a:buNone/>
                       </a:pPr>
                       <a:r>
@@ -7192,7 +7192,7 @@
                       </a:endParaRPr>
                     </a:p>
                   </a:txBody>
-                  <a:tcPr marL="91440" marR="91440" marT="45720" marB="45720" anchor="ctr">
+                  <a:tcPr marL="38100" marR="38100" marT="38100" marB="38100" anchor="ctr">
                     <a:lnL w="12700" cap="flat" cmpd="sng" algn="ctr">
                       <a:solidFill>
                         <a:srgbClr val="C6CEE2"/>
@@ -7236,7 +7236,7 @@
                     <a:bodyPr/>
                     <a:lstStyle/>
                     <a:p>
-                      <a:pPr algn="ctr" indent="0" marL="0">
+                      <a:pPr eaLnBrk="0" latinLnBrk="0" algn="ctr" indent="0" marL="0">
                         <a:buNone/>
                       </a:pPr>
                       <a:r>
@@ -7257,7 +7257,7 @@
                       </a:endParaRPr>
                     </a:p>
                   </a:txBody>
-                  <a:tcPr marL="91440" marR="91440" marT="45720" marB="45720" anchor="ctr">
+                  <a:tcPr marL="38100" marR="38100" marT="38100" marB="38100" anchor="ctr">
                     <a:lnL w="12700" cap="flat" cmpd="sng" algn="ctr">
                       <a:solidFill>
                         <a:srgbClr val="C6CEE2"/>
@@ -7301,7 +7301,7 @@
                     <a:bodyPr/>
                     <a:lstStyle/>
                     <a:p>
-                      <a:pPr algn="ctr" indent="0" marL="0">
+                      <a:pPr eaLnBrk="0" latinLnBrk="0" algn="ctr" indent="0" marL="0">
                         <a:buNone/>
                       </a:pPr>
                       <a:r>
@@ -7322,7 +7322,7 @@
                       </a:endParaRPr>
                     </a:p>
                   </a:txBody>
-                  <a:tcPr marL="91440" marR="91440" marT="45720" marB="45720" anchor="ctr">
+                  <a:tcPr marL="38100" marR="38100" marT="38100" marB="38100" anchor="ctr">
                     <a:lnL w="12700" cap="flat" cmpd="sng" algn="ctr">
                       <a:solidFill>
                         <a:srgbClr val="C6CEE2"/>
@@ -7366,7 +7366,7 @@
                     <a:bodyPr/>
                     <a:lstStyle/>
                     <a:p>
-                      <a:pPr algn="ctr" indent="0" marL="0">
+                      <a:pPr eaLnBrk="0" latinLnBrk="0" algn="ctr" indent="0" marL="0">
                         <a:buNone/>
                       </a:pPr>
                       <a:r>
@@ -7387,7 +7387,7 @@
                       </a:endParaRPr>
                     </a:p>
                   </a:txBody>
-                  <a:tcPr marL="91440" marR="91440" marT="45720" marB="45720" anchor="ctr">
+                  <a:tcPr marL="38100" marR="38100" marT="38100" marB="38100" anchor="ctr">
                     <a:lnL w="12700" cap="flat" cmpd="sng" algn="ctr">
                       <a:solidFill>
                         <a:srgbClr val="C6CEE2"/>
@@ -7431,7 +7431,7 @@
                     <a:bodyPr/>
                     <a:lstStyle/>
                     <a:p>
-                      <a:pPr algn="ctr" indent="0" marL="0">
+                      <a:pPr eaLnBrk="0" latinLnBrk="0" algn="ctr" indent="0" marL="0">
                         <a:buNone/>
                       </a:pPr>
                       <a:r>
@@ -7452,7 +7452,7 @@
                       </a:endParaRPr>
                     </a:p>
                   </a:txBody>
-                  <a:tcPr marL="91440" marR="91440" marT="45720" marB="45720" anchor="ctr">
+                  <a:tcPr marL="38100" marR="38100" marT="38100" marB="38100" anchor="ctr">
                     <a:lnL w="12700" cap="flat" cmpd="sng" algn="ctr">
                       <a:solidFill>
                         <a:srgbClr val="C6CEE2"/>
@@ -7496,7 +7496,7 @@
                     <a:bodyPr/>
                     <a:lstStyle/>
                     <a:p>
-                      <a:pPr algn="ctr" indent="0" marL="0">
+                      <a:pPr eaLnBrk="0" latinLnBrk="0" algn="ctr" indent="0" marL="0">
                         <a:buNone/>
                       </a:pPr>
                       <a:r>
@@ -7517,7 +7517,7 @@
                       </a:endParaRPr>
                     </a:p>
                   </a:txBody>
-                  <a:tcPr marL="91440" marR="91440" marT="45720" marB="45720" anchor="ctr">
+                  <a:tcPr marL="38100" marR="38100" marT="38100" marB="38100" anchor="ctr">
                     <a:lnL w="12700" cap="flat" cmpd="sng" algn="ctr">
                       <a:solidFill>
                         <a:srgbClr val="C6CEE2"/>
@@ -7561,7 +7561,7 @@
                     <a:bodyPr/>
                     <a:lstStyle/>
                     <a:p>
-                      <a:pPr algn="ctr" indent="0" marL="0">
+                      <a:pPr eaLnBrk="0" latinLnBrk="0" algn="ctr" indent="0" marL="0">
                         <a:buNone/>
                       </a:pPr>
                       <a:r>
@@ -7582,7 +7582,7 @@
                       </a:endParaRPr>
                     </a:p>
                   </a:txBody>
-                  <a:tcPr marL="91440" marR="91440" marT="45720" marB="45720" anchor="ctr">
+                  <a:tcPr marL="38100" marR="38100" marT="38100" marB="38100" anchor="ctr">
                     <a:lnL w="12700" cap="flat" cmpd="sng" algn="ctr">
                       <a:solidFill>
                         <a:srgbClr val="C6CEE2"/>
@@ -7629,7 +7629,7 @@
                     <a:bodyPr/>
                     <a:lstStyle/>
                     <a:p>
-                      <a:pPr algn="ctr" indent="0" marL="0">
+                      <a:pPr eaLnBrk="0" latinLnBrk="0" algn="ctr" indent="0" marL="0">
                         <a:buNone/>
                       </a:pPr>
                       <a:r>
@@ -7650,7 +7650,7 @@
                       </a:endParaRPr>
                     </a:p>
                   </a:txBody>
-                  <a:tcPr marL="91440" marR="91440" marT="45720" marB="45720" anchor="ctr">
+                  <a:tcPr marL="38100" marR="38100" marT="38100" marB="38100" anchor="ctr">
                     <a:lnL w="12700" cap="flat" cmpd="sng" algn="ctr">
                       <a:solidFill>
                         <a:srgbClr val="C6CEE2"/>
@@ -7697,7 +7697,7 @@
                     <a:bodyPr/>
                     <a:lstStyle/>
                     <a:p>
-                      <a:pPr algn="l" indent="0" marL="0">
+                      <a:pPr eaLnBrk="0" latinLnBrk="0" algn="l" indent="0" marL="0">
                         <a:buNone/>
                       </a:pPr>
                       <a:r>
@@ -7718,7 +7718,7 @@
                       </a:endParaRPr>
                     </a:p>
                     <a:p>
-                      <a:pPr algn="l" indent="0" marL="0">
+                      <a:pPr eaLnBrk="0" latinLnBrk="0" algn="l" indent="0" marL="0">
                         <a:buNone/>
                       </a:pPr>
                       <a:r>
@@ -7739,7 +7739,7 @@
                       </a:endParaRPr>
                     </a:p>
                   </a:txBody>
-                  <a:tcPr marL="91440" marR="91440" marT="45720" marB="45720" anchor="ctr">
+                  <a:tcPr marL="38100" marR="38100" marT="38100" marB="38100" anchor="ctr">
                     <a:lnL w="12700" cap="flat" cmpd="sng" algn="ctr">
                       <a:solidFill>
                         <a:srgbClr val="C6CEE2"/>
@@ -7779,7 +7779,7 @@
                   </a:tcPr>
                 </a:tc>
               </a:tr>
-              <a:tr h="658368">
+              <a:tr h="676656">
                 <a:tc vMerge="1">
                   <a:tcPr/>
                 </a:tc>
@@ -7788,7 +7788,7 @@
                     <a:bodyPr/>
                     <a:lstStyle/>
                     <a:p>
-                      <a:pPr algn="ctr" indent="0" marL="0">
+                      <a:pPr eaLnBrk="0" latinLnBrk="0" algn="ctr" indent="0" marL="0">
                         <a:buNone/>
                       </a:pPr>
                       <a:r>
@@ -7809,7 +7809,7 @@
                       </a:endParaRPr>
                     </a:p>
                   </a:txBody>
-                  <a:tcPr marL="91440" marR="91440" marT="45720" marB="45720" anchor="ctr">
+                  <a:tcPr marL="38100" marR="38100" marT="38100" marB="38100" anchor="ctr">
                     <a:lnL w="12700" cap="flat" cmpd="sng" algn="ctr">
                       <a:solidFill>
                         <a:srgbClr val="C6CEE2"/>
@@ -7856,7 +7856,7 @@
                     <a:bodyPr/>
                     <a:lstStyle/>
                     <a:p>
-                      <a:pPr algn="ctr" indent="0" marL="0">
+                      <a:pPr eaLnBrk="0" latinLnBrk="0" algn="ctr" indent="0" marL="0">
                         <a:buNone/>
                       </a:pPr>
                       <a:endParaRPr lang="en-US" sz="1200" dirty="0">
@@ -7866,7 +7866,7 @@
                       </a:endParaRPr>
                     </a:p>
                   </a:txBody>
-                  <a:tcPr marL="91440" marR="91440" marT="45720" marB="45720" anchor="ctr">
+                  <a:tcPr marL="38100" marR="38100" marT="38100" marB="38100" anchor="ctr">
                     <a:lnL w="12700" cap="flat" cmpd="sng" algn="ctr">
                       <a:solidFill>
                         <a:srgbClr val="C6CEE2"/>
@@ -7910,7 +7910,7 @@
                     <a:bodyPr/>
                     <a:lstStyle/>
                     <a:p>
-                      <a:pPr algn="ctr" indent="0" marL="0">
+                      <a:pPr eaLnBrk="0" latinLnBrk="0" algn="ctr" indent="0" marL="0">
                         <a:buNone/>
                       </a:pPr>
                       <a:r>
@@ -7931,7 +7931,7 @@
                       </a:endParaRPr>
                     </a:p>
                   </a:txBody>
-                  <a:tcPr marL="91440" marR="91440" marT="45720" marB="45720" anchor="ctr">
+                  <a:tcPr marL="38100" marR="38100" marT="38100" marB="38100" anchor="ctr">
                     <a:lnL w="12700" cap="flat" cmpd="sng" algn="ctr">
                       <a:solidFill>
                         <a:srgbClr val="C6CEE2"/>
@@ -7975,7 +7975,7 @@
                     <a:bodyPr/>
                     <a:lstStyle/>
                     <a:p>
-                      <a:pPr algn="ctr" indent="0" marL="0">
+                      <a:pPr eaLnBrk="0" latinLnBrk="0" algn="ctr" indent="0" marL="0">
                         <a:buNone/>
                       </a:pPr>
                       <a:r>
@@ -7996,7 +7996,7 @@
                       </a:endParaRPr>
                     </a:p>
                   </a:txBody>
-                  <a:tcPr marL="91440" marR="91440" marT="45720" marB="45720" anchor="ctr">
+                  <a:tcPr marL="38100" marR="38100" marT="38100" marB="38100" anchor="ctr">
                     <a:lnL w="12700" cap="flat" cmpd="sng" algn="ctr">
                       <a:solidFill>
                         <a:srgbClr val="C6CEE2"/>
@@ -8040,7 +8040,7 @@
                     <a:bodyPr/>
                     <a:lstStyle/>
                     <a:p>
-                      <a:pPr algn="ctr" indent="0" marL="0">
+                      <a:pPr eaLnBrk="0" latinLnBrk="0" algn="ctr" indent="0" marL="0">
                         <a:buNone/>
                       </a:pPr>
                       <a:r>
@@ -8061,7 +8061,7 @@
                       </a:endParaRPr>
                     </a:p>
                   </a:txBody>
-                  <a:tcPr marL="91440" marR="91440" marT="45720" marB="45720" anchor="ctr">
+                  <a:tcPr marL="38100" marR="38100" marT="38100" marB="38100" anchor="ctr">
                     <a:lnL w="12700" cap="flat" cmpd="sng" algn="ctr">
                       <a:solidFill>
                         <a:srgbClr val="C6CEE2"/>
@@ -8105,7 +8105,7 @@
                     <a:bodyPr/>
                     <a:lstStyle/>
                     <a:p>
-                      <a:pPr algn="ctr" indent="0" marL="0">
+                      <a:pPr eaLnBrk="0" latinLnBrk="0" algn="ctr" indent="0" marL="0">
                         <a:buNone/>
                       </a:pPr>
                       <a:r>
@@ -8126,7 +8126,7 @@
                       </a:endParaRPr>
                     </a:p>
                   </a:txBody>
-                  <a:tcPr marL="91440" marR="91440" marT="45720" marB="45720" anchor="ctr">
+                  <a:tcPr marL="38100" marR="38100" marT="38100" marB="38100" anchor="ctr">
                     <a:lnL w="12700" cap="flat" cmpd="sng" algn="ctr">
                       <a:solidFill>
                         <a:srgbClr val="C6CEE2"/>
@@ -8170,7 +8170,7 @@
                     <a:bodyPr/>
                     <a:lstStyle/>
                     <a:p>
-                      <a:pPr algn="ctr" indent="0" marL="0">
+                      <a:pPr eaLnBrk="0" latinLnBrk="0" algn="ctr" indent="0" marL="0">
                         <a:buNone/>
                       </a:pPr>
                       <a:r>
@@ -8191,7 +8191,7 @@
                       </a:endParaRPr>
                     </a:p>
                   </a:txBody>
-                  <a:tcPr marL="91440" marR="91440" marT="45720" marB="45720" anchor="ctr">
+                  <a:tcPr marL="38100" marR="38100" marT="38100" marB="38100" anchor="ctr">
                     <a:lnL w="12700" cap="flat" cmpd="sng" algn="ctr">
                       <a:solidFill>
                         <a:srgbClr val="C6CEE2"/>
@@ -8235,7 +8235,7 @@
                     <a:bodyPr/>
                     <a:lstStyle/>
                     <a:p>
-                      <a:pPr algn="ctr" indent="0" marL="0">
+                      <a:pPr eaLnBrk="0" latinLnBrk="0" algn="ctr" indent="0" marL="0">
                         <a:buNone/>
                       </a:pPr>
                       <a:r>
@@ -8256,7 +8256,7 @@
                       </a:endParaRPr>
                     </a:p>
                   </a:txBody>
-                  <a:tcPr marL="91440" marR="91440" marT="45720" marB="45720" anchor="ctr">
+                  <a:tcPr marL="38100" marR="38100" marT="38100" marB="38100" anchor="ctr">
                     <a:lnL w="12700" cap="flat" cmpd="sng" algn="ctr">
                       <a:solidFill>
                         <a:srgbClr val="C6CEE2"/>
@@ -8300,7 +8300,7 @@
                     <a:bodyPr/>
                     <a:lstStyle/>
                     <a:p>
-                      <a:pPr algn="ctr" indent="0" marL="0">
+                      <a:pPr eaLnBrk="0" latinLnBrk="0" algn="ctr" indent="0" marL="0">
                         <a:buNone/>
                       </a:pPr>
                       <a:r>
@@ -8321,7 +8321,7 @@
                       </a:endParaRPr>
                     </a:p>
                   </a:txBody>
-                  <a:tcPr marL="91440" marR="91440" marT="45720" marB="45720" anchor="ctr">
+                  <a:tcPr marL="38100" marR="38100" marT="38100" marB="38100" anchor="ctr">
                     <a:lnL w="12700" cap="flat" cmpd="sng" algn="ctr">
                       <a:solidFill>
                         <a:srgbClr val="C6CEE2"/>
@@ -8382,7 +8382,7 @@
         </p:nvSpPr>
         <p:spPr>
           <a:xfrm>
-            <a:off x="658368" y="4114800"/>
+            <a:off x="658368" y="4224528"/>
             <a:ext cx="11027664" cy="310896"/>
           </a:xfrm>
           <a:prstGeom prst="rect">
@@ -8395,7 +8395,7 @@
           <a:bodyPr wrap="square" lIns="0" tIns="0" rIns="0" bIns="0" rtlCol="0" anchor="ctr"/>
           <a:lstStyle/>
           <a:p>
-            <a:pPr indent="0" marL="0">
+            <a:pPr eaLnBrk="0" latinLnBrk="0" indent="0" marL="0">
               <a:buNone/>
             </a:pPr>
             <a:r>
@@ -8421,7 +8421,7 @@
         </p:nvSpPr>
         <p:spPr>
           <a:xfrm>
-            <a:off x="658368" y="4846320"/>
+            <a:off x="658368" y="4901184"/>
             <a:ext cx="2011680" cy="1042416"/>
           </a:xfrm>
           <a:prstGeom prst="roundRect">
@@ -8455,7 +8455,7 @@
         </p:nvSpPr>
         <p:spPr>
           <a:xfrm>
-            <a:off x="658368" y="4992624"/>
+            <a:off x="658368" y="5047488"/>
             <a:ext cx="2011680" cy="274320"/>
           </a:xfrm>
           <a:prstGeom prst="rect">
@@ -8468,7 +8468,7 @@
           <a:bodyPr wrap="square" lIns="0" tIns="0" rIns="0" bIns="0" rtlCol="0" anchor="ctr"/>
           <a:lstStyle/>
           <a:p>
-            <a:pPr algn="ctr" indent="0" marL="0">
+            <a:pPr eaLnBrk="0" latinLnBrk="0" algn="ctr" indent="0" marL="0">
               <a:buNone/>
             </a:pPr>
             <a:r>
@@ -8494,7 +8494,7 @@
         </p:nvSpPr>
         <p:spPr>
           <a:xfrm>
-            <a:off x="658368" y="5285232"/>
+            <a:off x="658368" y="5340096"/>
             <a:ext cx="2011680" cy="457200"/>
           </a:xfrm>
           <a:prstGeom prst="rect">
@@ -8507,7 +8507,7 @@
           <a:bodyPr wrap="square" lIns="0" tIns="0" rIns="0" bIns="0" rtlCol="0" anchor="ctr"/>
           <a:lstStyle/>
           <a:p>
-            <a:pPr algn="ctr" indent="0" marL="0">
+            <a:pPr eaLnBrk="0" latinLnBrk="0" algn="ctr" indent="0" marL="0">
               <a:buNone/>
             </a:pPr>
             <a:r>
@@ -8533,7 +8533,7 @@
         </p:nvSpPr>
         <p:spPr>
           <a:xfrm>
-            <a:off x="2852928" y="4846320"/>
+            <a:off x="2852928" y="4901184"/>
             <a:ext cx="2011680" cy="1042416"/>
           </a:xfrm>
           <a:prstGeom prst="roundRect">
@@ -8567,7 +8567,7 @@
         </p:nvSpPr>
         <p:spPr>
           <a:xfrm>
-            <a:off x="2852928" y="4992624"/>
+            <a:off x="2852928" y="5047488"/>
             <a:ext cx="2011680" cy="274320"/>
           </a:xfrm>
           <a:prstGeom prst="rect">
@@ -8580,7 +8580,7 @@
           <a:bodyPr wrap="square" lIns="0" tIns="0" rIns="0" bIns="0" rtlCol="0" anchor="ctr"/>
           <a:lstStyle/>
           <a:p>
-            <a:pPr algn="ctr" indent="0" marL="0">
+            <a:pPr eaLnBrk="0" latinLnBrk="0" algn="ctr" indent="0" marL="0">
               <a:buNone/>
             </a:pPr>
             <a:r>
@@ -8606,7 +8606,7 @@
         </p:nvSpPr>
         <p:spPr>
           <a:xfrm>
-            <a:off x="2852928" y="5285232"/>
+            <a:off x="2852928" y="5340096"/>
             <a:ext cx="2011680" cy="457200"/>
           </a:xfrm>
           <a:prstGeom prst="rect">
@@ -8619,7 +8619,7 @@
           <a:bodyPr wrap="square" lIns="0" tIns="0" rIns="0" bIns="0" rtlCol="0" anchor="ctr"/>
           <a:lstStyle/>
           <a:p>
-            <a:pPr algn="ctr" indent="0" marL="0">
+            <a:pPr eaLnBrk="0" latinLnBrk="0" algn="ctr" indent="0" marL="0">
               <a:buNone/>
             </a:pPr>
             <a:r>
@@ -8645,7 +8645,7 @@
         </p:nvSpPr>
         <p:spPr>
           <a:xfrm>
-            <a:off x="5047488" y="4846320"/>
+            <a:off x="5047488" y="4901184"/>
             <a:ext cx="2011680" cy="1042416"/>
           </a:xfrm>
           <a:prstGeom prst="roundRect">
@@ -8679,7 +8679,7 @@
         </p:nvSpPr>
         <p:spPr>
           <a:xfrm>
-            <a:off x="5047488" y="4992624"/>
+            <a:off x="5047488" y="5047488"/>
             <a:ext cx="2011680" cy="274320"/>
           </a:xfrm>
           <a:prstGeom prst="rect">
@@ -8692,7 +8692,7 @@
           <a:bodyPr wrap="square" lIns="0" tIns="0" rIns="0" bIns="0" rtlCol="0" anchor="ctr"/>
           <a:lstStyle/>
           <a:p>
-            <a:pPr algn="ctr" indent="0" marL="0">
+            <a:pPr eaLnBrk="0" latinLnBrk="0" algn="ctr" indent="0" marL="0">
               <a:buNone/>
             </a:pPr>
             <a:r>
@@ -8718,7 +8718,7 @@
         </p:nvSpPr>
         <p:spPr>
           <a:xfrm>
-            <a:off x="5047488" y="5285232"/>
+            <a:off x="5047488" y="5340096"/>
             <a:ext cx="2011680" cy="457200"/>
           </a:xfrm>
           <a:prstGeom prst="rect">
@@ -8731,7 +8731,7 @@
           <a:bodyPr wrap="square" lIns="0" tIns="0" rIns="0" bIns="0" rtlCol="0" anchor="ctr"/>
           <a:lstStyle/>
           <a:p>
-            <a:pPr algn="ctr" indent="0" marL="0">
+            <a:pPr eaLnBrk="0" latinLnBrk="0" algn="ctr" indent="0" marL="0">
               <a:buNone/>
             </a:pPr>
             <a:r>
@@ -8757,7 +8757,7 @@
         </p:nvSpPr>
         <p:spPr>
           <a:xfrm>
-            <a:off x="7242048" y="4846320"/>
+            <a:off x="7242048" y="4901184"/>
             <a:ext cx="2011680" cy="1042416"/>
           </a:xfrm>
           <a:prstGeom prst="roundRect">
@@ -8791,7 +8791,7 @@
         </p:nvSpPr>
         <p:spPr>
           <a:xfrm>
-            <a:off x="7242048" y="4992624"/>
+            <a:off x="7242048" y="5047488"/>
             <a:ext cx="2011680" cy="274320"/>
           </a:xfrm>
           <a:prstGeom prst="rect">
@@ -8804,7 +8804,7 @@
           <a:bodyPr wrap="square" lIns="0" tIns="0" rIns="0" bIns="0" rtlCol="0" anchor="ctr"/>
           <a:lstStyle/>
           <a:p>
-            <a:pPr algn="ctr" indent="0" marL="0">
+            <a:pPr eaLnBrk="0" latinLnBrk="0" algn="ctr" indent="0" marL="0">
               <a:buNone/>
             </a:pPr>
             <a:r>
@@ -8830,7 +8830,7 @@
         </p:nvSpPr>
         <p:spPr>
           <a:xfrm>
-            <a:off x="7242048" y="5285232"/>
+            <a:off x="7242048" y="5340096"/>
             <a:ext cx="2011680" cy="457200"/>
           </a:xfrm>
           <a:prstGeom prst="rect">
@@ -8843,7 +8843,7 @@
           <a:bodyPr wrap="square" lIns="0" tIns="0" rIns="0" bIns="0" rtlCol="0" anchor="ctr"/>
           <a:lstStyle/>
           <a:p>
-            <a:pPr algn="ctr" indent="0" marL="0">
+            <a:pPr eaLnBrk="0" latinLnBrk="0" algn="ctr" indent="0" marL="0">
               <a:buNone/>
             </a:pPr>
             <a:r>
@@ -8869,7 +8869,7 @@
         </p:nvSpPr>
         <p:spPr>
           <a:xfrm>
-            <a:off x="9436608" y="4846320"/>
+            <a:off x="9436608" y="4901184"/>
             <a:ext cx="2011680" cy="1042416"/>
           </a:xfrm>
           <a:prstGeom prst="roundRect">
@@ -8903,7 +8903,7 @@
         </p:nvSpPr>
         <p:spPr>
           <a:xfrm>
-            <a:off x="9436608" y="4992624"/>
+            <a:off x="9436608" y="5047488"/>
             <a:ext cx="2011680" cy="274320"/>
           </a:xfrm>
           <a:prstGeom prst="rect">
@@ -8916,7 +8916,7 @@
           <a:bodyPr wrap="square" lIns="0" tIns="0" rIns="0" bIns="0" rtlCol="0" anchor="ctr"/>
           <a:lstStyle/>
           <a:p>
-            <a:pPr algn="ctr" indent="0" marL="0">
+            <a:pPr eaLnBrk="0" latinLnBrk="0" algn="ctr" indent="0" marL="0">
               <a:buNone/>
             </a:pPr>
             <a:r>
@@ -8942,7 +8942,7 @@
         </p:nvSpPr>
         <p:spPr>
           <a:xfrm>
-            <a:off x="9436608" y="5285232"/>
+            <a:off x="9436608" y="5340096"/>
             <a:ext cx="2011680" cy="457200"/>
           </a:xfrm>
           <a:prstGeom prst="rect">
@@ -8955,7 +8955,7 @@
           <a:bodyPr wrap="square" lIns="0" tIns="0" rIns="0" bIns="0" rtlCol="0" anchor="ctr"/>
           <a:lstStyle/>
           <a:p>
-            <a:pPr algn="ctr" indent="0" marL="0">
+            <a:pPr eaLnBrk="0" latinLnBrk="0" algn="ctr" indent="0" marL="0">
               <a:buNone/>
             </a:pPr>
             <a:r>
@@ -9050,7 +9050,7 @@
           <a:bodyPr wrap="square" lIns="0" tIns="0" rIns="0" bIns="0" rtlCol="0" anchor="ctr"/>
           <a:lstStyle/>
           <a:p>
-            <a:pPr algn="ctr" indent="0" marL="0">
+            <a:pPr eaLnBrk="0" latinLnBrk="0" algn="ctr" indent="0" marL="0">
               <a:buNone/>
             </a:pPr>
             <a:r>
@@ -9089,7 +9089,7 @@
           <a:bodyPr wrap="square" lIns="0" tIns="0" rIns="0" bIns="0" rtlCol="0" anchor="ctr"/>
           <a:lstStyle/>
           <a:p>
-            <a:pPr indent="0" marL="0">
+            <a:pPr eaLnBrk="0" latinLnBrk="0" indent="0" marL="0">
               <a:buNone/>
             </a:pPr>
             <a:r>
@@ -9128,7 +9128,7 @@
           <a:bodyPr wrap="square" lIns="0" tIns="0" rIns="0" bIns="0" rtlCol="0" anchor="ctr"/>
           <a:lstStyle/>
           <a:p>
-            <a:pPr indent="0" marL="0">
+            <a:pPr eaLnBrk="0" latinLnBrk="0" indent="0" marL="0">
               <a:buNone/>
             </a:pPr>
             <a:r>
@@ -9221,7 +9221,7 @@
           <a:bodyPr wrap="square" lIns="0" tIns="0" rIns="0" bIns="0" rtlCol="0" anchor="ctr"/>
           <a:lstStyle/>
           <a:p>
-            <a:pPr algn="ctr" indent="0" marL="0">
+            <a:pPr eaLnBrk="0" latinLnBrk="0" algn="ctr" indent="0" marL="0">
               <a:buNone/>
             </a:pPr>
             <a:r>
@@ -9260,7 +9260,7 @@
           <a:bodyPr wrap="square" lIns="0" tIns="0" rIns="0" bIns="0" rtlCol="0" anchor="ctr"/>
           <a:lstStyle/>
           <a:p>
-            <a:pPr algn="ctr" indent="0" marL="0">
+            <a:pPr eaLnBrk="0" latinLnBrk="0" algn="ctr" indent="0" marL="0">
               <a:lnSpc>
                 <a:spcPts val="2000"/>
               </a:lnSpc>
@@ -9280,7 +9280,7 @@
             <a:endParaRPr lang="en-US" sz="1300" dirty="0"/>
           </a:p>
           <a:p>
-            <a:pPr algn="ctr" indent="0" marL="0">
+            <a:pPr eaLnBrk="0" latinLnBrk="0" algn="ctr" indent="0" marL="0">
               <a:lnSpc>
                 <a:spcPts val="2000"/>
               </a:lnSpc>
@@ -9322,7 +9322,7 @@
           <a:bodyPr wrap="square" lIns="0" tIns="0" rIns="0" bIns="0" rtlCol="0" anchor="ctr"/>
           <a:lstStyle/>
           <a:p>
-            <a:pPr algn="ctr" indent="0" marL="0">
+            <a:pPr eaLnBrk="0" latinLnBrk="0" algn="ctr" indent="0" marL="0">
               <a:buNone/>
             </a:pPr>
             <a:r>
@@ -9435,7 +9435,7 @@
           <a:bodyPr wrap="square" lIns="0" tIns="0" rIns="0" bIns="0" rtlCol="0" anchor="ctr"/>
           <a:lstStyle/>
           <a:p>
-            <a:pPr algn="ctr" indent="0" marL="0">
+            <a:pPr eaLnBrk="0" latinLnBrk="0" algn="ctr" indent="0" marL="0">
               <a:buNone/>
             </a:pPr>
             <a:r>
@@ -9474,7 +9474,7 @@
           <a:bodyPr wrap="square" lIns="0" tIns="0" rIns="0" bIns="0" rtlCol="0" anchor="ctr"/>
           <a:lstStyle/>
           <a:p>
-            <a:pPr algn="ctr" indent="0" marL="0">
+            <a:pPr eaLnBrk="0" latinLnBrk="0" algn="ctr" indent="0" marL="0">
               <a:lnSpc>
                 <a:spcPts val="2000"/>
               </a:lnSpc>
@@ -9494,7 +9494,7 @@
             <a:endParaRPr lang="en-US" sz="1300" dirty="0"/>
           </a:p>
           <a:p>
-            <a:pPr algn="ctr" indent="0" marL="0">
+            <a:pPr eaLnBrk="0" latinLnBrk="0" algn="ctr" indent="0" marL="0">
               <a:lnSpc>
                 <a:spcPts val="2000"/>
               </a:lnSpc>
@@ -9536,7 +9536,7 @@
           <a:bodyPr wrap="square" lIns="0" tIns="0" rIns="0" bIns="0" rtlCol="0" anchor="ctr"/>
           <a:lstStyle/>
           <a:p>
-            <a:pPr algn="ctr" indent="0" marL="0">
+            <a:pPr eaLnBrk="0" latinLnBrk="0" algn="ctr" indent="0" marL="0">
               <a:buNone/>
             </a:pPr>
             <a:r>
@@ -9649,7 +9649,7 @@
           <a:bodyPr wrap="square" lIns="0" tIns="0" rIns="0" bIns="0" rtlCol="0" anchor="ctr"/>
           <a:lstStyle/>
           <a:p>
-            <a:pPr algn="ctr" indent="0" marL="0">
+            <a:pPr eaLnBrk="0" latinLnBrk="0" algn="ctr" indent="0" marL="0">
               <a:buNone/>
             </a:pPr>
             <a:r>
@@ -9688,7 +9688,7 @@
           <a:bodyPr wrap="square" lIns="0" tIns="0" rIns="0" bIns="0" rtlCol="0" anchor="ctr"/>
           <a:lstStyle/>
           <a:p>
-            <a:pPr algn="ctr" indent="0" marL="0">
+            <a:pPr eaLnBrk="0" latinLnBrk="0" algn="ctr" indent="0" marL="0">
               <a:lnSpc>
                 <a:spcPts val="2000"/>
               </a:lnSpc>
@@ -9708,7 +9708,7 @@
             <a:endParaRPr lang="en-US" sz="1300" dirty="0"/>
           </a:p>
           <a:p>
-            <a:pPr algn="ctr" indent="0" marL="0">
+            <a:pPr eaLnBrk="0" latinLnBrk="0" algn="ctr" indent="0" marL="0">
               <a:lnSpc>
                 <a:spcPts val="2000"/>
               </a:lnSpc>
@@ -9728,7 +9728,7 @@
             <a:endParaRPr lang="en-US" sz="1300" dirty="0"/>
           </a:p>
           <a:p>
-            <a:pPr algn="ctr" indent="0" marL="0">
+            <a:pPr eaLnBrk="0" latinLnBrk="0" algn="ctr" indent="0" marL="0">
               <a:lnSpc>
                 <a:spcPts val="2000"/>
               </a:lnSpc>
@@ -9770,7 +9770,7 @@
           <a:bodyPr wrap="square" lIns="0" tIns="0" rIns="0" bIns="0" rtlCol="0" anchor="ctr"/>
           <a:lstStyle/>
           <a:p>
-            <a:pPr algn="ctr" indent="0" marL="0">
+            <a:pPr eaLnBrk="0" latinLnBrk="0" algn="ctr" indent="0" marL="0">
               <a:buNone/>
             </a:pPr>
             <a:r>
@@ -9883,7 +9883,7 @@
           <a:bodyPr wrap="square" lIns="0" tIns="0" rIns="0" bIns="0" rtlCol="0" anchor="ctr"/>
           <a:lstStyle/>
           <a:p>
-            <a:pPr algn="ctr" indent="0" marL="0">
+            <a:pPr eaLnBrk="0" latinLnBrk="0" algn="ctr" indent="0" marL="0">
               <a:buNone/>
             </a:pPr>
             <a:r>
@@ -9922,7 +9922,7 @@
           <a:bodyPr wrap="square" lIns="0" tIns="0" rIns="0" bIns="0" rtlCol="0" anchor="ctr"/>
           <a:lstStyle/>
           <a:p>
-            <a:pPr algn="ctr" indent="0" marL="0">
+            <a:pPr eaLnBrk="0" latinLnBrk="0" algn="ctr" indent="0" marL="0">
               <a:lnSpc>
                 <a:spcPts val="2000"/>
               </a:lnSpc>
@@ -9942,7 +9942,7 @@
             <a:endParaRPr lang="en-US" sz="1300" dirty="0"/>
           </a:p>
           <a:p>
-            <a:pPr algn="ctr" indent="0" marL="0">
+            <a:pPr eaLnBrk="0" latinLnBrk="0" algn="ctr" indent="0" marL="0">
               <a:lnSpc>
                 <a:spcPts val="2000"/>
               </a:lnSpc>
@@ -9984,7 +9984,7 @@
           <a:bodyPr wrap="square" lIns="0" tIns="0" rIns="0" bIns="0" rtlCol="0" anchor="ctr"/>
           <a:lstStyle/>
           <a:p>
-            <a:pPr algn="ctr" indent="0" marL="0">
+            <a:pPr eaLnBrk="0" latinLnBrk="0" algn="ctr" indent="0" marL="0">
               <a:buNone/>
             </a:pPr>
             <a:r>
@@ -10097,7 +10097,7 @@
           <a:bodyPr wrap="square" lIns="0" tIns="0" rIns="0" bIns="0" rtlCol="0" anchor="ctr"/>
           <a:lstStyle/>
           <a:p>
-            <a:pPr algn="ctr" indent="0" marL="0">
+            <a:pPr eaLnBrk="0" latinLnBrk="0" algn="ctr" indent="0" marL="0">
               <a:buNone/>
             </a:pPr>
             <a:r>
@@ -10136,7 +10136,7 @@
           <a:bodyPr wrap="square" lIns="0" tIns="0" rIns="0" bIns="0" rtlCol="0" anchor="ctr"/>
           <a:lstStyle/>
           <a:p>
-            <a:pPr algn="ctr" indent="0" marL="0">
+            <a:pPr eaLnBrk="0" latinLnBrk="0" algn="ctr" indent="0" marL="0">
               <a:lnSpc>
                 <a:spcPts val="2000"/>
               </a:lnSpc>
@@ -10178,7 +10178,7 @@
           <a:bodyPr wrap="square" lIns="0" tIns="0" rIns="0" bIns="0" rtlCol="0" anchor="ctr"/>
           <a:lstStyle/>
           <a:p>
-            <a:pPr algn="ctr" indent="0" marL="0">
+            <a:pPr eaLnBrk="0" latinLnBrk="0" algn="ctr" indent="0" marL="0">
               <a:buNone/>
             </a:pPr>
             <a:r>
@@ -10251,7 +10251,7 @@
           <a:bodyPr wrap="square" lIns="0" tIns="0" rIns="0" bIns="0" rtlCol="0" anchor="ctr"/>
           <a:lstStyle/>
           <a:p>
-            <a:pPr algn="ctr" indent="0" marL="0">
+            <a:pPr eaLnBrk="0" latinLnBrk="0" algn="ctr" indent="0" marL="0">
               <a:buNone/>
             </a:pPr>
             <a:r>
@@ -10346,7 +10346,7 @@
           <a:bodyPr wrap="square" lIns="0" tIns="0" rIns="0" bIns="0" rtlCol="0" anchor="ctr"/>
           <a:lstStyle/>
           <a:p>
-            <a:pPr algn="ctr" indent="0" marL="0">
+            <a:pPr eaLnBrk="0" latinLnBrk="0" algn="ctr" indent="0" marL="0">
               <a:buNone/>
             </a:pPr>
             <a:r>
@@ -10385,7 +10385,7 @@
           <a:bodyPr wrap="square" lIns="0" tIns="0" rIns="0" bIns="0" rtlCol="0" anchor="ctr"/>
           <a:lstStyle/>
           <a:p>
-            <a:pPr indent="0" marL="0">
+            <a:pPr eaLnBrk="0" latinLnBrk="0" indent="0" marL="0">
               <a:buNone/>
             </a:pPr>
             <a:r>
@@ -10424,7 +10424,7 @@
           <a:bodyPr wrap="square" lIns="0" tIns="0" rIns="0" bIns="0" rtlCol="0" anchor="ctr"/>
           <a:lstStyle/>
           <a:p>
-            <a:pPr indent="0" marL="0">
+            <a:pPr eaLnBrk="0" latinLnBrk="0" indent="0" marL="0">
               <a:buNone/>
             </a:pPr>
             <a:r>
@@ -10517,7 +10517,7 @@
           <a:bodyPr wrap="square" lIns="0" tIns="0" rIns="0" bIns="0" rtlCol="0" anchor="ctr"/>
           <a:lstStyle/>
           <a:p>
-            <a:pPr algn="ctr" indent="0" marL="0">
+            <a:pPr eaLnBrk="0" latinLnBrk="0" algn="ctr" indent="0" marL="0">
               <a:buNone/>
             </a:pPr>
             <a:r>
@@ -10556,7 +10556,7 @@
           <a:bodyPr wrap="square" lIns="0" tIns="0" rIns="0" bIns="0" rtlCol="0" anchor="ctr"/>
           <a:lstStyle/>
           <a:p>
-            <a:pPr algn="ctr" indent="0" marL="0">
+            <a:pPr eaLnBrk="0" latinLnBrk="0" algn="ctr" indent="0" marL="0">
               <a:lnSpc>
                 <a:spcPts val="2100"/>
               </a:lnSpc>
@@ -10672,7 +10672,7 @@
           <a:bodyPr wrap="square" lIns="0" tIns="0" rIns="0" bIns="0" rtlCol="0" anchor="ctr"/>
           <a:lstStyle/>
           <a:p>
-            <a:pPr algn="ctr" indent="0" marL="0">
+            <a:pPr eaLnBrk="0" latinLnBrk="0" algn="ctr" indent="0" marL="0">
               <a:buNone/>
             </a:pPr>
             <a:r>
@@ -10711,7 +10711,7 @@
           <a:bodyPr wrap="square" lIns="0" tIns="0" rIns="0" bIns="0" rtlCol="0" anchor="ctr"/>
           <a:lstStyle/>
           <a:p>
-            <a:pPr algn="ctr" indent="0" marL="0">
+            <a:pPr eaLnBrk="0" latinLnBrk="0" algn="ctr" indent="0" marL="0">
               <a:lnSpc>
                 <a:spcPts val="2100"/>
               </a:lnSpc>
@@ -10753,7 +10753,7 @@
           <a:bodyPr wrap="square" lIns="0" tIns="0" rIns="0" bIns="0" rtlCol="0" anchor="ctr"/>
           <a:lstStyle/>
           <a:p>
-            <a:pPr algn="ctr" indent="0" marL="0">
+            <a:pPr eaLnBrk="0" latinLnBrk="0" algn="ctr" indent="0" marL="0">
               <a:lnSpc>
                 <a:spcPts val="1800"/>
               </a:lnSpc>
@@ -10869,7 +10869,7 @@
           <a:bodyPr wrap="square" lIns="0" tIns="0" rIns="0" bIns="0" rtlCol="0" anchor="ctr"/>
           <a:lstStyle/>
           <a:p>
-            <a:pPr algn="ctr" indent="0" marL="0">
+            <a:pPr eaLnBrk="0" latinLnBrk="0" algn="ctr" indent="0" marL="0">
               <a:buNone/>
             </a:pPr>
             <a:r>
@@ -10908,7 +10908,7 @@
           <a:bodyPr wrap="square" lIns="0" tIns="0" rIns="0" bIns="0" rtlCol="0" anchor="ctr"/>
           <a:lstStyle/>
           <a:p>
-            <a:pPr algn="ctr" indent="0" marL="0">
+            <a:pPr eaLnBrk="0" latinLnBrk="0" algn="ctr" indent="0" marL="0">
               <a:lnSpc>
                 <a:spcPts val="2100"/>
               </a:lnSpc>
@@ -10928,7 +10928,7 @@
             <a:endParaRPr lang="en-US" sz="1500" dirty="0"/>
           </a:p>
           <a:p>
-            <a:pPr algn="ctr" indent="0" marL="0">
+            <a:pPr eaLnBrk="0" latinLnBrk="0" algn="ctr" indent="0" marL="0">
               <a:lnSpc>
                 <a:spcPts val="2100"/>
               </a:lnSpc>
@@ -10970,7 +10970,7 @@
           <a:bodyPr wrap="square" lIns="0" tIns="0" rIns="0" bIns="0" rtlCol="0" anchor="ctr"/>
           <a:lstStyle/>
           <a:p>
-            <a:pPr algn="ctr" indent="0" marL="0">
+            <a:pPr eaLnBrk="0" latinLnBrk="0" algn="ctr" indent="0" marL="0">
               <a:lnSpc>
                 <a:spcPts val="1800"/>
               </a:lnSpc>
@@ -10990,7 +10990,7 @@
             <a:endParaRPr lang="en-US" sz="1250" dirty="0"/>
           </a:p>
           <a:p>
-            <a:pPr algn="ctr" indent="0" marL="0">
+            <a:pPr eaLnBrk="0" latinLnBrk="0" algn="ctr" indent="0" marL="0">
               <a:lnSpc>
                 <a:spcPts val="1800"/>
               </a:lnSpc>
@@ -11106,7 +11106,7 @@
           <a:bodyPr wrap="square" lIns="0" tIns="0" rIns="0" bIns="0" rtlCol="0" anchor="ctr"/>
           <a:lstStyle/>
           <a:p>
-            <a:pPr algn="ctr" indent="0" marL="0">
+            <a:pPr eaLnBrk="0" latinLnBrk="0" algn="ctr" indent="0" marL="0">
               <a:buNone/>
             </a:pPr>
             <a:r>
@@ -11145,7 +11145,7 @@
           <a:bodyPr wrap="square" lIns="0" tIns="0" rIns="0" bIns="0" rtlCol="0" anchor="ctr"/>
           <a:lstStyle/>
           <a:p>
-            <a:pPr algn="ctr" indent="0" marL="0">
+            <a:pPr eaLnBrk="0" latinLnBrk="0" algn="ctr" indent="0" marL="0">
               <a:lnSpc>
                 <a:spcPts val="2100"/>
               </a:lnSpc>
@@ -11165,7 +11165,7 @@
             <a:endParaRPr lang="en-US" sz="1500" dirty="0"/>
           </a:p>
           <a:p>
-            <a:pPr algn="ctr" indent="0" marL="0">
+            <a:pPr eaLnBrk="0" latinLnBrk="0" algn="ctr" indent="0" marL="0">
               <a:lnSpc>
                 <a:spcPts val="2100"/>
               </a:lnSpc>
@@ -11207,7 +11207,7 @@
           <a:bodyPr wrap="square" lIns="0" tIns="0" rIns="0" bIns="0" rtlCol="0" anchor="t"/>
           <a:lstStyle/>
           <a:p>
-            <a:pPr marL="342900" indent="-342900">
+            <a:pPr eaLnBrk="0" latinLnBrk="0" marL="342900" indent="-342900">
               <a:spcAft>
                 <a:spcPts val="600"/>
               </a:spcAft>
@@ -11228,7 +11228,7 @@
             <a:endParaRPr lang="en-US" sz="1150" dirty="0"/>
           </a:p>
           <a:p>
-            <a:pPr marL="342900" indent="-342900">
+            <a:pPr eaLnBrk="0" latinLnBrk="0" marL="342900" indent="-342900">
               <a:spcAft>
                 <a:spcPts val="600"/>
               </a:spcAft>
@@ -11249,7 +11249,7 @@
             <a:endParaRPr lang="en-US" sz="1150" dirty="0"/>
           </a:p>
           <a:p>
-            <a:pPr marL="342900" indent="-342900">
+            <a:pPr eaLnBrk="0" latinLnBrk="0" marL="342900" indent="-342900">
               <a:spcAft>
                 <a:spcPts val="600"/>
               </a:spcAft>
@@ -11366,7 +11366,7 @@
           <a:bodyPr wrap="square" lIns="0" tIns="0" rIns="0" bIns="0" rtlCol="0" anchor="ctr"/>
           <a:lstStyle/>
           <a:p>
-            <a:pPr algn="ctr" indent="0" marL="0">
+            <a:pPr eaLnBrk="0" latinLnBrk="0" algn="ctr" indent="0" marL="0">
               <a:buNone/>
             </a:pPr>
             <a:r>
@@ -11405,7 +11405,7 @@
           <a:bodyPr wrap="square" lIns="0" tIns="0" rIns="0" bIns="0" rtlCol="0" anchor="ctr"/>
           <a:lstStyle/>
           <a:p>
-            <a:pPr algn="ctr" indent="0" marL="0">
+            <a:pPr eaLnBrk="0" latinLnBrk="0" algn="ctr" indent="0" marL="0">
               <a:lnSpc>
                 <a:spcPts val="2100"/>
               </a:lnSpc>
@@ -11425,7 +11425,7 @@
             <a:endParaRPr lang="en-US" sz="1500" dirty="0"/>
           </a:p>
           <a:p>
-            <a:pPr algn="ctr" indent="0" marL="0">
+            <a:pPr eaLnBrk="0" latinLnBrk="0" algn="ctr" indent="0" marL="0">
               <a:lnSpc>
                 <a:spcPts val="2100"/>
               </a:lnSpc>
@@ -11467,7 +11467,7 @@
           <a:bodyPr wrap="square" lIns="0" tIns="0" rIns="0" bIns="0" rtlCol="0" anchor="ctr"/>
           <a:lstStyle/>
           <a:p>
-            <a:pPr algn="ctr" indent="0" marL="0">
+            <a:pPr eaLnBrk="0" latinLnBrk="0" algn="ctr" indent="0" marL="0">
               <a:lnSpc>
                 <a:spcPts val="1800"/>
               </a:lnSpc>
@@ -11543,7 +11543,7 @@
           <a:bodyPr wrap="square" lIns="0" tIns="0" rIns="0" bIns="0" rtlCol="0" anchor="ctr"/>
           <a:lstStyle/>
           <a:p>
-            <a:pPr indent="0" marL="0">
+            <a:pPr eaLnBrk="0" latinLnBrk="0" indent="0" marL="0">
               <a:buNone/>
             </a:pPr>
             <a:r>
@@ -11582,7 +11582,7 @@
           <a:bodyPr wrap="square" lIns="0" tIns="0" rIns="0" bIns="0" rtlCol="0" anchor="ctr"/>
           <a:lstStyle/>
           <a:p>
-            <a:pPr indent="0" marL="0">
+            <a:pPr eaLnBrk="0" latinLnBrk="0" indent="0" marL="0">
               <a:lnSpc>
                 <a:spcPts val="1700"/>
               </a:lnSpc>
@@ -11658,7 +11658,7 @@
           <a:bodyPr wrap="square" lIns="0" tIns="0" rIns="0" bIns="0" rtlCol="0" anchor="ctr"/>
           <a:lstStyle/>
           <a:p>
-            <a:pPr indent="0" marL="0">
+            <a:pPr eaLnBrk="0" latinLnBrk="0" indent="0" marL="0">
               <a:buNone/>
             </a:pPr>
             <a:r>
@@ -11697,7 +11697,7 @@
           <a:bodyPr wrap="square" lIns="0" tIns="0" rIns="0" bIns="0" rtlCol="0" anchor="ctr"/>
           <a:lstStyle/>
           <a:p>
-            <a:pPr indent="0" marL="0">
+            <a:pPr eaLnBrk="0" latinLnBrk="0" indent="0" marL="0">
               <a:lnSpc>
                 <a:spcPts val="1700"/>
               </a:lnSpc>
@@ -11795,7 +11795,7 @@
           <a:bodyPr wrap="square" lIns="0" tIns="0" rIns="0" bIns="0" rtlCol="0" anchor="ctr"/>
           <a:lstStyle/>
           <a:p>
-            <a:pPr algn="ctr" indent="0" marL="0">
+            <a:pPr eaLnBrk="0" latinLnBrk="0" algn="ctr" indent="0" marL="0">
               <a:buNone/>
             </a:pPr>
             <a:r>
@@ -11834,7 +11834,7 @@
           <a:bodyPr wrap="square" lIns="0" tIns="0" rIns="0" bIns="0" rtlCol="0" anchor="ctr"/>
           <a:lstStyle/>
           <a:p>
-            <a:pPr indent="0" marL="0">
+            <a:pPr eaLnBrk="0" latinLnBrk="0" indent="0" marL="0">
               <a:buNone/>
             </a:pPr>
             <a:r>
@@ -11873,7 +11873,7 @@
           <a:bodyPr wrap="square" lIns="0" tIns="0" rIns="0" bIns="0" rtlCol="0" anchor="ctr"/>
           <a:lstStyle/>
           <a:p>
-            <a:pPr indent="0" marL="0">
+            <a:pPr eaLnBrk="0" latinLnBrk="0" indent="0" marL="0">
               <a:buNone/>
             </a:pPr>
             <a:r>
@@ -11934,7 +11934,7 @@
           <a:bodyPr wrap="square" lIns="0" tIns="0" rIns="0" bIns="0" rtlCol="0" anchor="ctr"/>
           <a:lstStyle/>
           <a:p>
-            <a:pPr algn="ctr" indent="0" marL="0">
+            <a:pPr eaLnBrk="0" latinLnBrk="0" algn="ctr" indent="0" marL="0">
               <a:buNone/>
             </a:pPr>
             <a:r>
@@ -11995,7 +11995,7 @@
           <a:bodyPr wrap="square" lIns="0" tIns="0" rIns="0" bIns="0" rtlCol="0" anchor="ctr"/>
           <a:lstStyle/>
           <a:p>
-            <a:pPr algn="ctr" indent="0" marL="0">
+            <a:pPr eaLnBrk="0" latinLnBrk="0" algn="ctr" indent="0" marL="0">
               <a:buNone/>
             </a:pPr>
             <a:r>
@@ -12056,7 +12056,7 @@
           <a:bodyPr wrap="square" lIns="0" tIns="0" rIns="0" bIns="0" rtlCol="0" anchor="ctr"/>
           <a:lstStyle/>
           <a:p>
-            <a:pPr algn="ctr" indent="0" marL="0">
+            <a:pPr eaLnBrk="0" latinLnBrk="0" algn="ctr" indent="0" marL="0">
               <a:buNone/>
             </a:pPr>
             <a:r>
@@ -12117,7 +12117,7 @@
           <a:bodyPr wrap="square" lIns="0" tIns="0" rIns="0" bIns="0" rtlCol="0" anchor="ctr"/>
           <a:lstStyle/>
           <a:p>
-            <a:pPr algn="ctr" indent="0" marL="0">
+            <a:pPr eaLnBrk="0" latinLnBrk="0" algn="ctr" indent="0" marL="0">
               <a:buNone/>
             </a:pPr>
             <a:r>
@@ -12190,7 +12190,7 @@
           <a:bodyPr wrap="square" lIns="0" tIns="0" rIns="0" bIns="0" rtlCol="0" anchor="ctr"/>
           <a:lstStyle/>
           <a:p>
-            <a:pPr indent="0" marL="0">
+            <a:pPr eaLnBrk="0" latinLnBrk="0" indent="0" marL="0">
               <a:buNone/>
             </a:pPr>
             <a:r>
@@ -12249,7 +12249,7 @@
           <a:bodyPr wrap="square" lIns="0" tIns="0" rIns="0" bIns="0" rtlCol="0" anchor="ctr"/>
           <a:lstStyle/>
           <a:p>
-            <a:pPr indent="0" marL="0">
+            <a:pPr eaLnBrk="0" latinLnBrk="0" indent="0" marL="0">
               <a:lnSpc>
                 <a:spcPts val="2300"/>
               </a:lnSpc>
@@ -12311,7 +12311,7 @@
           <a:bodyPr wrap="square" lIns="0" tIns="0" rIns="0" bIns="0" rtlCol="0" anchor="ctr"/>
           <a:lstStyle/>
           <a:p>
-            <a:pPr indent="0" marL="0">
+            <a:pPr eaLnBrk="0" latinLnBrk="0" indent="0" marL="0">
               <a:lnSpc>
                 <a:spcPts val="2300"/>
               </a:lnSpc>
@@ -12387,7 +12387,7 @@
           <a:bodyPr wrap="square" lIns="0" tIns="0" rIns="0" bIns="0" rtlCol="0" anchor="ctr"/>
           <a:lstStyle/>
           <a:p>
-            <a:pPr indent="0" marL="0">
+            <a:pPr eaLnBrk="0" latinLnBrk="0" indent="0" marL="0">
               <a:buNone/>
             </a:pPr>
             <a:r>
@@ -12426,7 +12426,7 @@
           <a:bodyPr wrap="square" lIns="0" tIns="0" rIns="0" bIns="0" rtlCol="0" anchor="ctr"/>
           <a:lstStyle/>
           <a:p>
-            <a:pPr indent="0" marL="0">
+            <a:pPr eaLnBrk="0" latinLnBrk="0" indent="0" marL="0">
               <a:buNone/>
             </a:pPr>
             <a:r>
@@ -12465,7 +12465,7 @@
           <a:bodyPr wrap="square" lIns="0" tIns="0" rIns="0" bIns="0" rtlCol="0" anchor="ctr"/>
           <a:lstStyle/>
           <a:p>
-            <a:pPr indent="0" marL="0">
+            <a:pPr eaLnBrk="0" latinLnBrk="0" indent="0" marL="0">
               <a:buNone/>
             </a:pPr>
             <a:r>
@@ -12558,7 +12558,7 @@
           <a:bodyPr wrap="square" lIns="0" tIns="0" rIns="0" bIns="0" rtlCol="0" anchor="ctr"/>
           <a:lstStyle/>
           <a:p>
-            <a:pPr algn="ctr" indent="0" marL="0">
+            <a:pPr eaLnBrk="0" latinLnBrk="0" algn="ctr" indent="0" marL="0">
               <a:buNone/>
             </a:pPr>
             <a:r>
@@ -12597,7 +12597,7 @@
           <a:bodyPr wrap="square" lIns="0" tIns="0" rIns="0" bIns="0" rtlCol="0" anchor="ctr"/>
           <a:lstStyle/>
           <a:p>
-            <a:pPr indent="0" marL="0">
+            <a:pPr eaLnBrk="0" latinLnBrk="0" indent="0" marL="0">
               <a:lnSpc>
                 <a:spcPts val="2000"/>
               </a:lnSpc>
@@ -12693,7 +12693,7 @@
           <a:bodyPr wrap="square" lIns="0" tIns="0" rIns="0" bIns="0" rtlCol="0" anchor="ctr"/>
           <a:lstStyle/>
           <a:p>
-            <a:pPr algn="ctr" indent="0" marL="0">
+            <a:pPr eaLnBrk="0" latinLnBrk="0" algn="ctr" indent="0" marL="0">
               <a:buNone/>
             </a:pPr>
             <a:r>
@@ -12732,7 +12732,7 @@
           <a:bodyPr wrap="square" lIns="0" tIns="0" rIns="0" bIns="0" rtlCol="0" anchor="ctr"/>
           <a:lstStyle/>
           <a:p>
-            <a:pPr indent="0" marL="0">
+            <a:pPr eaLnBrk="0" latinLnBrk="0" indent="0" marL="0">
               <a:lnSpc>
                 <a:spcPts val="2000"/>
               </a:lnSpc>
@@ -12828,7 +12828,7 @@
           <a:bodyPr wrap="square" lIns="0" tIns="0" rIns="0" bIns="0" rtlCol="0" anchor="ctr"/>
           <a:lstStyle/>
           <a:p>
-            <a:pPr algn="ctr" indent="0" marL="0">
+            <a:pPr eaLnBrk="0" latinLnBrk="0" algn="ctr" indent="0" marL="0">
               <a:buNone/>
             </a:pPr>
             <a:r>
@@ -12867,7 +12867,7 @@
           <a:bodyPr wrap="square" lIns="0" tIns="0" rIns="0" bIns="0" rtlCol="0" anchor="ctr"/>
           <a:lstStyle/>
           <a:p>
-            <a:pPr indent="0" marL="0">
+            <a:pPr eaLnBrk="0" latinLnBrk="0" indent="0" marL="0">
               <a:lnSpc>
                 <a:spcPts val="2000"/>
               </a:lnSpc>
@@ -12963,7 +12963,7 @@
           <a:bodyPr wrap="square" lIns="0" tIns="0" rIns="0" bIns="0" rtlCol="0" anchor="ctr"/>
           <a:lstStyle/>
           <a:p>
-            <a:pPr algn="ctr" indent="0" marL="0">
+            <a:pPr eaLnBrk="0" latinLnBrk="0" algn="ctr" indent="0" marL="0">
               <a:buNone/>
             </a:pPr>
             <a:r>
@@ -13002,7 +13002,7 @@
           <a:bodyPr wrap="square" lIns="0" tIns="0" rIns="0" bIns="0" rtlCol="0" anchor="ctr"/>
           <a:lstStyle/>
           <a:p>
-            <a:pPr indent="0" marL="0">
+            <a:pPr eaLnBrk="0" latinLnBrk="0" indent="0" marL="0">
               <a:lnSpc>
                 <a:spcPts val="2000"/>
               </a:lnSpc>
@@ -13100,7 +13100,7 @@
           <a:bodyPr wrap="square" lIns="0" tIns="0" rIns="0" bIns="0" rtlCol="0" anchor="ctr"/>
           <a:lstStyle/>
           <a:p>
-            <a:pPr algn="ctr" indent="0" marL="0">
+            <a:pPr eaLnBrk="0" latinLnBrk="0" algn="ctr" indent="0" marL="0">
               <a:buNone/>
             </a:pPr>
             <a:r>
@@ -13139,7 +13139,7 @@
           <a:bodyPr wrap="square" lIns="0" tIns="0" rIns="0" bIns="0" rtlCol="0" anchor="ctr"/>
           <a:lstStyle/>
           <a:p>
-            <a:pPr indent="0" marL="0">
+            <a:pPr eaLnBrk="0" latinLnBrk="0" indent="0" marL="0">
               <a:buNone/>
             </a:pPr>
             <a:r>
@@ -13178,7 +13178,7 @@
           <a:bodyPr wrap="square" lIns="0" tIns="0" rIns="0" bIns="0" rtlCol="0" anchor="ctr"/>
           <a:lstStyle/>
           <a:p>
-            <a:pPr indent="0" marL="0">
+            <a:pPr eaLnBrk="0" latinLnBrk="0" indent="0" marL="0">
               <a:buNone/>
             </a:pPr>
             <a:r>
@@ -13239,7 +13239,7 @@
           <a:bodyPr wrap="square" lIns="0" tIns="0" rIns="0" bIns="0" rtlCol="0" anchor="ctr"/>
           <a:lstStyle/>
           <a:p>
-            <a:pPr algn="ctr" indent="0" marL="0">
+            <a:pPr eaLnBrk="0" latinLnBrk="0" algn="ctr" indent="0" marL="0">
               <a:buNone/>
             </a:pPr>
             <a:r>
@@ -13300,7 +13300,7 @@
           <a:bodyPr wrap="square" lIns="0" tIns="0" rIns="0" bIns="0" rtlCol="0" anchor="ctr"/>
           <a:lstStyle/>
           <a:p>
-            <a:pPr algn="ctr" indent="0" marL="0">
+            <a:pPr eaLnBrk="0" latinLnBrk="0" algn="ctr" indent="0" marL="0">
               <a:buNone/>
             </a:pPr>
             <a:r>
@@ -13361,7 +13361,7 @@
           <a:bodyPr wrap="square" lIns="0" tIns="0" rIns="0" bIns="0" rtlCol="0" anchor="ctr"/>
           <a:lstStyle/>
           <a:p>
-            <a:pPr algn="ctr" indent="0" marL="0">
+            <a:pPr eaLnBrk="0" latinLnBrk="0" algn="ctr" indent="0" marL="0">
               <a:buNone/>
             </a:pPr>
             <a:r>
@@ -13422,7 +13422,7 @@
           <a:bodyPr wrap="square" lIns="0" tIns="0" rIns="0" bIns="0" rtlCol="0" anchor="ctr"/>
           <a:lstStyle/>
           <a:p>
-            <a:pPr algn="ctr" indent="0" marL="0">
+            <a:pPr eaLnBrk="0" latinLnBrk="0" algn="ctr" indent="0" marL="0">
               <a:buNone/>
             </a:pPr>
             <a:r>
@@ -13461,7 +13461,7 @@
           <a:bodyPr wrap="square" lIns="0" tIns="0" rIns="0" bIns="0" rtlCol="0" anchor="ctr"/>
           <a:lstStyle/>
           <a:p>
-            <a:pPr indent="0" marL="0">
+            <a:pPr eaLnBrk="0" latinLnBrk="0" indent="0" marL="0">
               <a:buNone/>
             </a:pPr>
             <a:r>
@@ -13475,7 +13475,7 @@
               </a:rPr>
               <a:t>평가방법  </a:t>
             </a:r>
-            <a:pPr indent="0" marL="0">
+            <a:pPr eaLnBrk="0" latinLnBrk="0" indent="0" marL="0">
               <a:buNone/>
             </a:pPr>
             <a:r>
@@ -13514,7 +13514,7 @@
           <a:bodyPr wrap="square" lIns="0" tIns="0" rIns="0" bIns="0" rtlCol="0" anchor="ctr"/>
           <a:lstStyle/>
           <a:p>
-            <a:pPr indent="0" marL="0">
+            <a:pPr eaLnBrk="0" latinLnBrk="0" indent="0" marL="0">
               <a:buNone/>
             </a:pPr>
             <a:r>
@@ -13528,7 +13528,7 @@
               </a:rPr>
               <a:t>심사위원  </a:t>
             </a:r>
-            <a:pPr indent="0" marL="0">
+            <a:pPr eaLnBrk="0" latinLnBrk="0" indent="0" marL="0">
               <a:buNone/>
             </a:pPr>
             <a:r>
@@ -13579,7 +13579,7 @@
                     <a:bodyPr/>
                     <a:lstStyle/>
                     <a:p>
-                      <a:pPr algn="ctr" indent="0" marL="0">
+                      <a:pPr eaLnBrk="0" latinLnBrk="0" algn="ctr" indent="0" marL="0">
                         <a:buNone/>
                       </a:pPr>
                       <a:r>
@@ -13647,7 +13647,7 @@
                     <a:bodyPr/>
                     <a:lstStyle/>
                     <a:p>
-                      <a:pPr algn="ctr" indent="0" marL="0">
+                      <a:pPr eaLnBrk="0" latinLnBrk="0" algn="ctr" indent="0" marL="0">
                         <a:buNone/>
                       </a:pPr>
                       <a:r>
@@ -13715,7 +13715,7 @@
                     <a:bodyPr/>
                     <a:lstStyle/>
                     <a:p>
-                      <a:pPr algn="ctr" indent="0" marL="0">
+                      <a:pPr eaLnBrk="0" latinLnBrk="0" algn="ctr" indent="0" marL="0">
                         <a:buNone/>
                       </a:pPr>
                       <a:r>
@@ -13785,7 +13785,7 @@
                     <a:bodyPr/>
                     <a:lstStyle/>
                     <a:p>
-                      <a:pPr algn="l" indent="0" marL="0">
+                      <a:pPr eaLnBrk="0" latinLnBrk="0" algn="l" indent="0" marL="0">
                         <a:buNone/>
                       </a:pPr>
                       <a:r>
@@ -13850,7 +13850,7 @@
                     <a:bodyPr/>
                     <a:lstStyle/>
                     <a:p>
-                      <a:pPr algn="ctr" indent="0" marL="0">
+                      <a:pPr eaLnBrk="0" latinLnBrk="0" algn="ctr" indent="0" marL="0">
                         <a:buNone/>
                       </a:pPr>
                       <a:r>
@@ -13915,7 +13915,7 @@
                     <a:bodyPr/>
                     <a:lstStyle/>
                     <a:p>
-                      <a:pPr algn="ctr" indent="0" marL="0">
+                      <a:pPr eaLnBrk="0" latinLnBrk="0" algn="ctr" indent="0" marL="0">
                         <a:buNone/>
                       </a:pPr>
                       <a:r>
@@ -13936,7 +13936,7 @@
                       </a:endParaRPr>
                     </a:p>
                     <a:p>
-                      <a:pPr algn="ctr" indent="0" marL="0">
+                      <a:pPr eaLnBrk="0" latinLnBrk="0" algn="ctr" indent="0" marL="0">
                         <a:buNone/>
                       </a:pPr>
                       <a:r>
@@ -14006,7 +14006,7 @@
                     <a:bodyPr/>
                     <a:lstStyle/>
                     <a:p>
-                      <a:pPr algn="l" indent="0" marL="0">
+                      <a:pPr eaLnBrk="0" latinLnBrk="0" algn="l" indent="0" marL="0">
                         <a:buNone/>
                       </a:pPr>
                       <a:r>
@@ -14071,7 +14071,7 @@
                     <a:bodyPr/>
                     <a:lstStyle/>
                     <a:p>
-                      <a:pPr algn="ctr" indent="0" marL="0">
+                      <a:pPr eaLnBrk="0" latinLnBrk="0" algn="ctr" indent="0" marL="0">
                         <a:buNone/>
                       </a:pPr>
                       <a:r>
@@ -14141,7 +14141,7 @@
                     <a:bodyPr/>
                     <a:lstStyle/>
                     <a:p>
-                      <a:pPr algn="l" indent="0" marL="0">
+                      <a:pPr eaLnBrk="0" latinLnBrk="0" algn="l" indent="0" marL="0">
                         <a:buNone/>
                       </a:pPr>
                       <a:r>
@@ -14206,7 +14206,7 @@
                     <a:bodyPr/>
                     <a:lstStyle/>
                     <a:p>
-                      <a:pPr algn="ctr" indent="0" marL="0">
+                      <a:pPr eaLnBrk="0" latinLnBrk="0" algn="ctr" indent="0" marL="0">
                         <a:buNone/>
                       </a:pPr>
                       <a:r>
@@ -14276,7 +14276,7 @@
                     <a:bodyPr/>
                     <a:lstStyle/>
                     <a:p>
-                      <a:pPr algn="l" indent="0" marL="0">
+                      <a:pPr eaLnBrk="0" latinLnBrk="0" algn="l" indent="0" marL="0">
                         <a:buNone/>
                       </a:pPr>
                       <a:r>
@@ -14341,7 +14341,7 @@
                     <a:bodyPr/>
                     <a:lstStyle/>
                     <a:p>
-                      <a:pPr algn="ctr" indent="0" marL="0">
+                      <a:pPr eaLnBrk="0" latinLnBrk="0" algn="ctr" indent="0" marL="0">
                         <a:buNone/>
                       </a:pPr>
                       <a:r>
@@ -14411,7 +14411,7 @@
                     <a:bodyPr/>
                     <a:lstStyle/>
                     <a:p>
-                      <a:pPr algn="l" indent="0" marL="0">
+                      <a:pPr eaLnBrk="0" latinLnBrk="0" algn="l" indent="0" marL="0">
                         <a:buNone/>
                       </a:pPr>
                       <a:r>
@@ -14479,7 +14479,7 @@
                     <a:bodyPr/>
                     <a:lstStyle/>
                     <a:p>
-                      <a:pPr algn="ctr" indent="0" marL="0">
+                      <a:pPr eaLnBrk="0" latinLnBrk="0" algn="ctr" indent="0" marL="0">
                         <a:buNone/>
                       </a:pPr>
                       <a:r>
@@ -14605,7 +14605,7 @@
           <a:bodyPr wrap="square" lIns="0" tIns="0" rIns="0" bIns="0" rtlCol="0" anchor="ctr"/>
           <a:lstStyle/>
           <a:p>
-            <a:pPr indent="0" marL="0">
+            <a:pPr eaLnBrk="0" latinLnBrk="0" indent="0" marL="0">
               <a:lnSpc>
                 <a:spcPts val="2600"/>
               </a:lnSpc>
@@ -14625,7 +14625,7 @@
             <a:endParaRPr lang="en-US" sz="1800" dirty="0"/>
           </a:p>
           <a:p>
-            <a:pPr indent="0" marL="0">
+            <a:pPr eaLnBrk="0" latinLnBrk="0" indent="0" marL="0">
               <a:lnSpc>
                 <a:spcPts val="2600"/>
               </a:lnSpc>
@@ -14687,7 +14687,7 @@
           <a:bodyPr wrap="square" lIns="0" tIns="0" rIns="0" bIns="0" rtlCol="0" anchor="ctr"/>
           <a:lstStyle/>
           <a:p>
-            <a:pPr indent="0" marL="0">
+            <a:pPr eaLnBrk="0" latinLnBrk="0" indent="0" marL="0">
               <a:lnSpc>
                 <a:spcPts val="2100"/>
               </a:lnSpc>
@@ -14749,7 +14749,7 @@
           <a:bodyPr wrap="square" lIns="0" tIns="0" rIns="0" bIns="0" rtlCol="0" anchor="ctr"/>
           <a:lstStyle/>
           <a:p>
-            <a:pPr indent="0" marL="0">
+            <a:pPr eaLnBrk="0" latinLnBrk="0" indent="0" marL="0">
               <a:lnSpc>
                 <a:spcPts val="2100"/>
               </a:lnSpc>
@@ -14811,7 +14811,7 @@
           <a:bodyPr wrap="square" lIns="0" tIns="0" rIns="0" bIns="0" rtlCol="0" anchor="ctr"/>
           <a:lstStyle/>
           <a:p>
-            <a:pPr indent="0" marL="0">
+            <a:pPr eaLnBrk="0" latinLnBrk="0" indent="0" marL="0">
               <a:lnSpc>
                 <a:spcPts val="2100"/>
               </a:lnSpc>
@@ -14887,7 +14887,7 @@
           <a:bodyPr wrap="square" lIns="0" tIns="0" rIns="0" bIns="0" rtlCol="0" anchor="ctr"/>
           <a:lstStyle/>
           <a:p>
-            <a:pPr algn="ctr" indent="0" marL="0">
+            <a:pPr eaLnBrk="0" latinLnBrk="0" algn="ctr" indent="0" marL="0">
               <a:buNone/>
             </a:pPr>
             <a:r>
@@ -14982,7 +14982,7 @@
           <a:bodyPr wrap="square" lIns="0" tIns="0" rIns="0" bIns="0" rtlCol="0" anchor="ctr"/>
           <a:lstStyle/>
           <a:p>
-            <a:pPr algn="ctr" indent="0" marL="0">
+            <a:pPr eaLnBrk="0" latinLnBrk="0" algn="ctr" indent="0" marL="0">
               <a:buNone/>
             </a:pPr>
             <a:r>
@@ -15021,7 +15021,7 @@
           <a:bodyPr wrap="square" lIns="0" tIns="0" rIns="0" bIns="0" rtlCol="0" anchor="ctr"/>
           <a:lstStyle/>
           <a:p>
-            <a:pPr indent="0" marL="0">
+            <a:pPr eaLnBrk="0" latinLnBrk="0" indent="0" marL="0">
               <a:buNone/>
             </a:pPr>
             <a:r>
@@ -15060,7 +15060,7 @@
           <a:bodyPr wrap="square" lIns="0" tIns="0" rIns="0" bIns="0" rtlCol="0" anchor="ctr"/>
           <a:lstStyle/>
           <a:p>
-            <a:pPr indent="0" marL="0">
+            <a:pPr eaLnBrk="0" latinLnBrk="0" indent="0" marL="0">
               <a:buNone/>
             </a:pPr>
             <a:r>
@@ -15121,7 +15121,7 @@
           <a:bodyPr wrap="square" lIns="0" tIns="0" rIns="0" bIns="0" rtlCol="0" anchor="ctr"/>
           <a:lstStyle/>
           <a:p>
-            <a:pPr algn="ctr" indent="0" marL="0">
+            <a:pPr eaLnBrk="0" latinLnBrk="0" algn="ctr" indent="0" marL="0">
               <a:buNone/>
             </a:pPr>
             <a:r>
@@ -15182,7 +15182,7 @@
           <a:bodyPr wrap="square" lIns="0" tIns="0" rIns="0" bIns="0" rtlCol="0" anchor="ctr"/>
           <a:lstStyle/>
           <a:p>
-            <a:pPr algn="ctr" indent="0" marL="0">
+            <a:pPr eaLnBrk="0" latinLnBrk="0" algn="ctr" indent="0" marL="0">
               <a:buNone/>
             </a:pPr>
             <a:r>
@@ -15243,7 +15243,7 @@
           <a:bodyPr wrap="square" lIns="0" tIns="0" rIns="0" bIns="0" rtlCol="0" anchor="ctr"/>
           <a:lstStyle/>
           <a:p>
-            <a:pPr algn="ctr" indent="0" marL="0">
+            <a:pPr eaLnBrk="0" latinLnBrk="0" algn="ctr" indent="0" marL="0">
               <a:buNone/>
             </a:pPr>
             <a:r>
@@ -15304,7 +15304,7 @@
           <a:bodyPr wrap="square" lIns="0" tIns="0" rIns="0" bIns="0" rtlCol="0" anchor="ctr"/>
           <a:lstStyle/>
           <a:p>
-            <a:pPr algn="ctr" indent="0" marL="0">
+            <a:pPr eaLnBrk="0" latinLnBrk="0" algn="ctr" indent="0" marL="0">
               <a:buNone/>
             </a:pPr>
             <a:r>
@@ -15343,7 +15343,7 @@
           <a:bodyPr wrap="square" lIns="0" tIns="0" rIns="0" bIns="0" rtlCol="0" anchor="ctr"/>
           <a:lstStyle/>
           <a:p>
-            <a:pPr indent="0" marL="0">
+            <a:pPr eaLnBrk="0" latinLnBrk="0" indent="0" marL="0">
               <a:buNone/>
             </a:pPr>
             <a:r>
@@ -15357,7 +15357,7 @@
               </a:rPr>
               <a:t>평가방법  </a:t>
             </a:r>
-            <a:pPr indent="0" marL="0">
+            <a:pPr eaLnBrk="0" latinLnBrk="0" indent="0" marL="0">
               <a:buNone/>
             </a:pPr>
             <a:r>
@@ -15396,7 +15396,7 @@
           <a:bodyPr wrap="square" lIns="0" tIns="0" rIns="0" bIns="0" rtlCol="0" anchor="ctr"/>
           <a:lstStyle/>
           <a:p>
-            <a:pPr indent="0" marL="0">
+            <a:pPr eaLnBrk="0" latinLnBrk="0" indent="0" marL="0">
               <a:buNone/>
             </a:pPr>
             <a:r>
@@ -15410,7 +15410,7 @@
               </a:rPr>
               <a:t>심사위원  </a:t>
             </a:r>
-            <a:pPr indent="0" marL="0">
+            <a:pPr eaLnBrk="0" latinLnBrk="0" indent="0" marL="0">
               <a:buNone/>
             </a:pPr>
             <a:r>
@@ -15461,7 +15461,7 @@
                     <a:bodyPr/>
                     <a:lstStyle/>
                     <a:p>
-                      <a:pPr algn="ctr" indent="0" marL="0">
+                      <a:pPr eaLnBrk="0" latinLnBrk="0" algn="ctr" indent="0" marL="0">
                         <a:buNone/>
                       </a:pPr>
                       <a:r>
@@ -15529,7 +15529,7 @@
                     <a:bodyPr/>
                     <a:lstStyle/>
                     <a:p>
-                      <a:pPr algn="ctr" indent="0" marL="0">
+                      <a:pPr eaLnBrk="0" latinLnBrk="0" algn="ctr" indent="0" marL="0">
                         <a:buNone/>
                       </a:pPr>
                       <a:r>
@@ -15597,7 +15597,7 @@
                     <a:bodyPr/>
                     <a:lstStyle/>
                     <a:p>
-                      <a:pPr algn="ctr" indent="0" marL="0">
+                      <a:pPr eaLnBrk="0" latinLnBrk="0" algn="ctr" indent="0" marL="0">
                         <a:buNone/>
                       </a:pPr>
                       <a:r>
@@ -15667,7 +15667,7 @@
                     <a:bodyPr/>
                     <a:lstStyle/>
                     <a:p>
-                      <a:pPr algn="l" indent="0" marL="0">
+                      <a:pPr eaLnBrk="0" latinLnBrk="0" algn="l" indent="0" marL="0">
                         <a:buNone/>
                       </a:pPr>
                       <a:r>
@@ -15732,7 +15732,7 @@
                     <a:bodyPr/>
                     <a:lstStyle/>
                     <a:p>
-                      <a:pPr algn="ctr" indent="0" marL="0">
+                      <a:pPr eaLnBrk="0" latinLnBrk="0" algn="ctr" indent="0" marL="0">
                         <a:buNone/>
                       </a:pPr>
                       <a:r>
@@ -15797,7 +15797,7 @@
                     <a:bodyPr/>
                     <a:lstStyle/>
                     <a:p>
-                      <a:pPr algn="ctr" indent="0" marL="0">
+                      <a:pPr eaLnBrk="0" latinLnBrk="0" algn="ctr" indent="0" marL="0">
                         <a:buNone/>
                       </a:pPr>
                       <a:r>
@@ -15818,7 +15818,7 @@
                       </a:endParaRPr>
                     </a:p>
                     <a:p>
-                      <a:pPr algn="ctr" indent="0" marL="0">
+                      <a:pPr eaLnBrk="0" latinLnBrk="0" algn="ctr" indent="0" marL="0">
                         <a:buNone/>
                       </a:pPr>
                       <a:r>
@@ -15888,7 +15888,7 @@
                     <a:bodyPr/>
                     <a:lstStyle/>
                     <a:p>
-                      <a:pPr algn="l" indent="0" marL="0">
+                      <a:pPr eaLnBrk="0" latinLnBrk="0" algn="l" indent="0" marL="0">
                         <a:buNone/>
                       </a:pPr>
                       <a:r>
@@ -15953,7 +15953,7 @@
                     <a:bodyPr/>
                     <a:lstStyle/>
                     <a:p>
-                      <a:pPr algn="ctr" indent="0" marL="0">
+                      <a:pPr eaLnBrk="0" latinLnBrk="0" algn="ctr" indent="0" marL="0">
                         <a:buNone/>
                       </a:pPr>
                       <a:r>
@@ -16023,7 +16023,7 @@
                     <a:bodyPr/>
                     <a:lstStyle/>
                     <a:p>
-                      <a:pPr algn="l" indent="0" marL="0">
+                      <a:pPr eaLnBrk="0" latinLnBrk="0" algn="l" indent="0" marL="0">
                         <a:buNone/>
                       </a:pPr>
                       <a:r>
@@ -16088,7 +16088,7 @@
                     <a:bodyPr/>
                     <a:lstStyle/>
                     <a:p>
-                      <a:pPr algn="ctr" indent="0" marL="0">
+                      <a:pPr eaLnBrk="0" latinLnBrk="0" algn="ctr" indent="0" marL="0">
                         <a:buNone/>
                       </a:pPr>
                       <a:r>
@@ -16158,7 +16158,7 @@
                     <a:bodyPr/>
                     <a:lstStyle/>
                     <a:p>
-                      <a:pPr algn="l" indent="0" marL="0">
+                      <a:pPr eaLnBrk="0" latinLnBrk="0" algn="l" indent="0" marL="0">
                         <a:buNone/>
                       </a:pPr>
                       <a:r>
@@ -16223,7 +16223,7 @@
                     <a:bodyPr/>
                     <a:lstStyle/>
                     <a:p>
-                      <a:pPr algn="ctr" indent="0" marL="0">
+                      <a:pPr eaLnBrk="0" latinLnBrk="0" algn="ctr" indent="0" marL="0">
                         <a:buNone/>
                       </a:pPr>
                       <a:r>
@@ -16293,7 +16293,7 @@
                     <a:bodyPr/>
                     <a:lstStyle/>
                     <a:p>
-                      <a:pPr algn="l" indent="0" marL="0">
+                      <a:pPr eaLnBrk="0" latinLnBrk="0" algn="l" indent="0" marL="0">
                         <a:buNone/>
                       </a:pPr>
                       <a:r>
@@ -16361,7 +16361,7 @@
                     <a:bodyPr/>
                     <a:lstStyle/>
                     <a:p>
-                      <a:pPr algn="ctr" indent="0" marL="0">
+                      <a:pPr eaLnBrk="0" latinLnBrk="0" algn="ctr" indent="0" marL="0">
                         <a:buNone/>
                       </a:pPr>
                       <a:r>
@@ -16487,7 +16487,7 @@
           <a:bodyPr wrap="square" lIns="0" tIns="0" rIns="0" bIns="0" rtlCol="0" anchor="ctr"/>
           <a:lstStyle/>
           <a:p>
-            <a:pPr indent="0" marL="0">
+            <a:pPr eaLnBrk="0" latinLnBrk="0" indent="0" marL="0">
               <a:buNone/>
             </a:pPr>
             <a:r>
@@ -16564,7 +16564,7 @@
           <a:bodyPr wrap="square" lIns="0" tIns="0" rIns="0" bIns="0" rtlCol="0" anchor="ctr"/>
           <a:lstStyle/>
           <a:p>
-            <a:pPr indent="0" marL="0">
+            <a:pPr eaLnBrk="0" latinLnBrk="0" indent="0" marL="0">
               <a:buNone/>
             </a:pPr>
             <a:r>
@@ -16603,7 +16603,7 @@
           <a:bodyPr wrap="square" lIns="0" tIns="0" rIns="0" bIns="0" rtlCol="0" anchor="ctr"/>
           <a:lstStyle/>
           <a:p>
-            <a:pPr algn="r" indent="0" marL="0">
+            <a:pPr eaLnBrk="0" latinLnBrk="0" algn="r" indent="0" marL="0">
               <a:buNone/>
             </a:pPr>
             <a:r>
@@ -16664,7 +16664,7 @@
           <a:bodyPr wrap="square" lIns="0" tIns="0" rIns="0" bIns="0" rtlCol="0" anchor="ctr"/>
           <a:lstStyle/>
           <a:p>
-            <a:pPr indent="0" marL="0">
+            <a:pPr eaLnBrk="0" latinLnBrk="0" indent="0" marL="0">
               <a:buNone/>
             </a:pPr>
             <a:r>
@@ -16703,7 +16703,7 @@
           <a:bodyPr wrap="square" lIns="0" tIns="0" rIns="0" bIns="0" rtlCol="0" anchor="ctr"/>
           <a:lstStyle/>
           <a:p>
-            <a:pPr algn="r" indent="0" marL="0">
+            <a:pPr eaLnBrk="0" latinLnBrk="0" algn="r" indent="0" marL="0">
               <a:buNone/>
             </a:pPr>
             <a:r>
@@ -16742,7 +16742,7 @@
           <a:bodyPr wrap="square" lIns="0" tIns="0" rIns="0" bIns="0" rtlCol="0" anchor="ctr"/>
           <a:lstStyle/>
           <a:p>
-            <a:pPr algn="ctr" indent="0" marL="0">
+            <a:pPr eaLnBrk="0" latinLnBrk="0" algn="ctr" indent="0" marL="0">
               <a:buNone/>
             </a:pPr>
             <a:r>
@@ -16781,7 +16781,7 @@
           <a:bodyPr wrap="square" lIns="0" tIns="0" rIns="0" bIns="0" rtlCol="0" anchor="ctr"/>
           <a:lstStyle/>
           <a:p>
-            <a:pPr algn="ctr" indent="0" marL="0">
+            <a:pPr eaLnBrk="0" latinLnBrk="0" algn="ctr" indent="0" marL="0">
               <a:buNone/>
             </a:pPr>
             <a:r>
@@ -16876,7 +16876,7 @@
           <a:bodyPr wrap="square" lIns="0" tIns="0" rIns="0" bIns="0" rtlCol="0" anchor="ctr"/>
           <a:lstStyle/>
           <a:p>
-            <a:pPr algn="ctr" indent="0" marL="0">
+            <a:pPr eaLnBrk="0" latinLnBrk="0" algn="ctr" indent="0" marL="0">
               <a:buNone/>
             </a:pPr>
             <a:r>
@@ -16915,7 +16915,7 @@
           <a:bodyPr wrap="square" lIns="0" tIns="0" rIns="0" bIns="0" rtlCol="0" anchor="ctr"/>
           <a:lstStyle/>
           <a:p>
-            <a:pPr indent="0" marL="0">
+            <a:pPr eaLnBrk="0" latinLnBrk="0" indent="0" marL="0">
               <a:buNone/>
             </a:pPr>
             <a:r>
@@ -16954,7 +16954,7 @@
           <a:bodyPr wrap="square" lIns="0" tIns="0" rIns="0" bIns="0" rtlCol="0" anchor="ctr"/>
           <a:lstStyle/>
           <a:p>
-            <a:pPr indent="0" marL="0">
+            <a:pPr eaLnBrk="0" latinLnBrk="0" indent="0" marL="0">
               <a:buNone/>
             </a:pPr>
             <a:r>
@@ -17015,7 +17015,7 @@
           <a:bodyPr wrap="square" lIns="0" tIns="0" rIns="0" bIns="0" rtlCol="0" anchor="ctr"/>
           <a:lstStyle/>
           <a:p>
-            <a:pPr algn="ctr" indent="0" marL="0">
+            <a:pPr eaLnBrk="0" latinLnBrk="0" algn="ctr" indent="0" marL="0">
               <a:buNone/>
             </a:pPr>
             <a:r>
@@ -17076,7 +17076,7 @@
           <a:bodyPr wrap="square" lIns="0" tIns="0" rIns="0" bIns="0" rtlCol="0" anchor="ctr"/>
           <a:lstStyle/>
           <a:p>
-            <a:pPr algn="ctr" indent="0" marL="0">
+            <a:pPr eaLnBrk="0" latinLnBrk="0" algn="ctr" indent="0" marL="0">
               <a:buNone/>
             </a:pPr>
             <a:r>
@@ -17137,7 +17137,7 @@
           <a:bodyPr wrap="square" lIns="0" tIns="0" rIns="0" bIns="0" rtlCol="0" anchor="ctr"/>
           <a:lstStyle/>
           <a:p>
-            <a:pPr algn="ctr" indent="0" marL="0">
+            <a:pPr eaLnBrk="0" latinLnBrk="0" algn="ctr" indent="0" marL="0">
               <a:buNone/>
             </a:pPr>
             <a:r>
@@ -17198,7 +17198,7 @@
           <a:bodyPr wrap="square" lIns="0" tIns="0" rIns="0" bIns="0" rtlCol="0" anchor="ctr"/>
           <a:lstStyle/>
           <a:p>
-            <a:pPr algn="ctr" indent="0" marL="0">
+            <a:pPr eaLnBrk="0" latinLnBrk="0" algn="ctr" indent="0" marL="0">
               <a:buNone/>
             </a:pPr>
             <a:r>
@@ -17237,7 +17237,7 @@
           <a:bodyPr wrap="square" lIns="0" tIns="0" rIns="0" bIns="0" rtlCol="0" anchor="ctr"/>
           <a:lstStyle/>
           <a:p>
-            <a:pPr indent="0" marL="0">
+            <a:pPr eaLnBrk="0" latinLnBrk="0" indent="0" marL="0">
               <a:buNone/>
             </a:pPr>
             <a:r>
@@ -17251,7 +17251,7 @@
               </a:rPr>
               <a:t>대 상 자  </a:t>
             </a:r>
-            <a:pPr indent="0" marL="0">
+            <a:pPr eaLnBrk="0" latinLnBrk="0" indent="0" marL="0">
               <a:buNone/>
             </a:pPr>
             <a:r>
@@ -17265,7 +17265,7 @@
               </a:rPr>
               <a:t>최종합격 예정자</a:t>
             </a:r>
-            <a:pPr indent="0" marL="0">
+            <a:pPr eaLnBrk="0" latinLnBrk="0" indent="0" marL="0">
               <a:buNone/>
             </a:pPr>
             <a:r>
@@ -17279,7 +17279,7 @@
               </a:rPr>
               <a:t>         검증내용  </a:t>
             </a:r>
-            <a:pPr indent="0" marL="0">
+            <a:pPr eaLnBrk="0" latinLnBrk="0" indent="0" marL="0">
               <a:buNone/>
             </a:pPr>
             <a:r>
@@ -17352,7 +17352,7 @@
           <a:bodyPr wrap="square" lIns="0" tIns="0" rIns="0" bIns="0" rtlCol="0" anchor="ctr"/>
           <a:lstStyle/>
           <a:p>
-            <a:pPr indent="0" marL="0">
+            <a:pPr eaLnBrk="0" latinLnBrk="0" indent="0" marL="0">
               <a:buNone/>
             </a:pPr>
             <a:r>
@@ -17391,7 +17391,7 @@
           <a:bodyPr wrap="square" lIns="0" tIns="0" rIns="0" bIns="0" rtlCol="0" anchor="ctr"/>
           <a:lstStyle/>
           <a:p>
-            <a:pPr indent="0" marL="0">
+            <a:pPr eaLnBrk="0" latinLnBrk="0" indent="0" marL="0">
               <a:buNone/>
             </a:pPr>
             <a:r>
@@ -17430,7 +17430,7 @@
           <a:bodyPr wrap="square" lIns="0" tIns="0" rIns="0" bIns="0" rtlCol="0" anchor="ctr"/>
           <a:lstStyle/>
           <a:p>
-            <a:pPr indent="0" marL="0">
+            <a:pPr eaLnBrk="0" latinLnBrk="0" indent="0" marL="0">
               <a:lnSpc>
                 <a:spcPts val="1800"/>
               </a:lnSpc>
@@ -17450,7 +17450,7 @@
             <a:endParaRPr lang="en-US" sz="1250" dirty="0"/>
           </a:p>
           <a:p>
-            <a:pPr indent="0" marL="0">
+            <a:pPr eaLnBrk="0" latinLnBrk="0" indent="0" marL="0">
               <a:lnSpc>
                 <a:spcPts val="1800"/>
               </a:lnSpc>
@@ -17492,7 +17492,7 @@
           <a:bodyPr wrap="square" lIns="0" tIns="0" rIns="0" bIns="0" rtlCol="0" anchor="ctr"/>
           <a:lstStyle/>
           <a:p>
-            <a:pPr indent="0" marL="0">
+            <a:pPr eaLnBrk="0" latinLnBrk="0" indent="0" marL="0">
               <a:buNone/>
             </a:pPr>
             <a:r>
@@ -17531,7 +17531,7 @@
           <a:bodyPr wrap="square" lIns="0" tIns="0" rIns="0" bIns="0" rtlCol="0" anchor="ctr"/>
           <a:lstStyle/>
           <a:p>
-            <a:pPr indent="0" marL="0">
+            <a:pPr eaLnBrk="0" latinLnBrk="0" indent="0" marL="0">
               <a:lnSpc>
                 <a:spcPts val="1800"/>
               </a:lnSpc>
@@ -17551,7 +17551,7 @@
             <a:endParaRPr lang="en-US" sz="1250" dirty="0"/>
           </a:p>
           <a:p>
-            <a:pPr indent="0" marL="0">
+            <a:pPr eaLnBrk="0" latinLnBrk="0" indent="0" marL="0">
               <a:lnSpc>
                 <a:spcPts val="1800"/>
               </a:lnSpc>
@@ -17593,7 +17593,7 @@
           <a:bodyPr wrap="square" lIns="0" tIns="0" rIns="0" bIns="0" rtlCol="0" anchor="ctr"/>
           <a:lstStyle/>
           <a:p>
-            <a:pPr indent="0" marL="0">
+            <a:pPr eaLnBrk="0" latinLnBrk="0" indent="0" marL="0">
               <a:buNone/>
             </a:pPr>
             <a:r>
@@ -17644,7 +17644,7 @@
                     <a:bodyPr/>
                     <a:lstStyle/>
                     <a:p>
-                      <a:pPr algn="ctr" indent="0" marL="0">
+                      <a:pPr eaLnBrk="0" latinLnBrk="0" algn="ctr" indent="0" marL="0">
                         <a:buNone/>
                       </a:pPr>
                       <a:r>
@@ -17712,7 +17712,7 @@
                     <a:bodyPr/>
                     <a:lstStyle/>
                     <a:p>
-                      <a:pPr algn="ctr" indent="0" marL="0">
+                      <a:pPr eaLnBrk="0" latinLnBrk="0" algn="ctr" indent="0" marL="0">
                         <a:buNone/>
                       </a:pPr>
                       <a:r>
@@ -17780,7 +17780,7 @@
                     <a:bodyPr/>
                     <a:lstStyle/>
                     <a:p>
-                      <a:pPr algn="ctr" indent="0" marL="0">
+                      <a:pPr eaLnBrk="0" latinLnBrk="0" algn="ctr" indent="0" marL="0">
                         <a:buNone/>
                       </a:pPr>
                       <a:r>
@@ -17850,7 +17850,7 @@
                     <a:bodyPr/>
                     <a:lstStyle/>
                     <a:p>
-                      <a:pPr algn="ctr" indent="0" marL="0">
+                      <a:pPr eaLnBrk="0" latinLnBrk="0" algn="ctr" indent="0" marL="0">
                         <a:buNone/>
                       </a:pPr>
                       <a:r>
@@ -17871,7 +17871,7 @@
                       </a:endParaRPr>
                     </a:p>
                     <a:p>
-                      <a:pPr algn="ctr" indent="0" marL="0">
+                      <a:pPr eaLnBrk="0" latinLnBrk="0" algn="ctr" indent="0" marL="0">
                         <a:buNone/>
                       </a:pPr>
                       <a:r>
@@ -17936,7 +17936,7 @@
                     <a:bodyPr/>
                     <a:lstStyle/>
                     <a:p>
-                      <a:pPr algn="l" indent="0" marL="0">
+                      <a:pPr eaLnBrk="0" latinLnBrk="0" algn="l" indent="0" marL="0">
                         <a:buNone/>
                       </a:pPr>
                       <a:r>
@@ -17957,7 +17957,7 @@
                       </a:endParaRPr>
                     </a:p>
                     <a:p>
-                      <a:pPr algn="l" indent="0" marL="0">
+                      <a:pPr eaLnBrk="0" latinLnBrk="0" algn="l" indent="0" marL="0">
                         <a:buNone/>
                       </a:pPr>
                       <a:r>
@@ -18022,7 +18022,7 @@
                     <a:bodyPr/>
                     <a:lstStyle/>
                     <a:p>
-                      <a:pPr algn="ctr" indent="0" marL="0">
+                      <a:pPr eaLnBrk="0" latinLnBrk="0" algn="ctr" indent="0" marL="0">
                         <a:buNone/>
                       </a:pPr>
                       <a:r>
@@ -18043,7 +18043,7 @@
                       </a:endParaRPr>
                     </a:p>
                     <a:p>
-                      <a:pPr algn="ctr" indent="0" marL="0">
+                      <a:pPr eaLnBrk="0" latinLnBrk="0" algn="ctr" indent="0" marL="0">
                         <a:buNone/>
                       </a:pPr>
                       <a:r>
@@ -18113,7 +18113,7 @@
                     <a:bodyPr/>
                     <a:lstStyle/>
                     <a:p>
-                      <a:pPr algn="ctr" indent="0" marL="0">
+                      <a:pPr eaLnBrk="0" latinLnBrk="0" algn="ctr" indent="0" marL="0">
                         <a:buNone/>
                       </a:pPr>
                       <a:r>
@@ -18134,7 +18134,7 @@
                       </a:endParaRPr>
                     </a:p>
                     <a:p>
-                      <a:pPr algn="ctr" indent="0" marL="0">
+                      <a:pPr eaLnBrk="0" latinLnBrk="0" algn="ctr" indent="0" marL="0">
                         <a:buNone/>
                       </a:pPr>
                       <a:r>
@@ -18199,7 +18199,7 @@
                     <a:bodyPr/>
                     <a:lstStyle/>
                     <a:p>
-                      <a:pPr algn="l" indent="0" marL="0">
+                      <a:pPr eaLnBrk="0" latinLnBrk="0" algn="l" indent="0" marL="0">
                         <a:buNone/>
                       </a:pPr>
                       <a:r>
@@ -18220,7 +18220,7 @@
                       </a:endParaRPr>
                     </a:p>
                     <a:p>
-                      <a:pPr algn="l" indent="0" marL="0">
+                      <a:pPr eaLnBrk="0" latinLnBrk="0" algn="l" indent="0" marL="0">
                         <a:buNone/>
                       </a:pPr>
                       <a:r>
@@ -18343,7 +18343,7 @@
           <a:bodyPr wrap="square" lIns="0" tIns="0" rIns="0" bIns="0" rtlCol="0" anchor="ctr"/>
           <a:lstStyle/>
           <a:p>
-            <a:pPr indent="0" marL="0">
+            <a:pPr eaLnBrk="0" latinLnBrk="0" indent="0" marL="0">
               <a:buNone/>
             </a:pPr>
             <a:r>
@@ -18404,7 +18404,7 @@
           <a:bodyPr wrap="square" lIns="0" tIns="0" rIns="0" bIns="0" rtlCol="0" anchor="ctr"/>
           <a:lstStyle/>
           <a:p>
-            <a:pPr algn="ctr" indent="0" marL="0">
+            <a:pPr eaLnBrk="0" latinLnBrk="0" algn="ctr" indent="0" marL="0">
               <a:buNone/>
             </a:pPr>
             <a:r>
@@ -18465,7 +18465,7 @@
           <a:bodyPr wrap="square" lIns="0" tIns="0" rIns="0" bIns="0" rtlCol="0" anchor="ctr"/>
           <a:lstStyle/>
           <a:p>
-            <a:pPr algn="ctr" indent="0" marL="0">
+            <a:pPr eaLnBrk="0" latinLnBrk="0" algn="ctr" indent="0" marL="0">
               <a:buNone/>
             </a:pPr>
             <a:r>
@@ -18526,7 +18526,7 @@
           <a:bodyPr wrap="square" lIns="0" tIns="0" rIns="0" bIns="0" rtlCol="0" anchor="ctr"/>
           <a:lstStyle/>
           <a:p>
-            <a:pPr algn="ctr" indent="0" marL="0">
+            <a:pPr eaLnBrk="0" latinLnBrk="0" algn="ctr" indent="0" marL="0">
               <a:buNone/>
             </a:pPr>
             <a:r>

</xml_diff>

<commit_message>
Group the two hiring routes under the vacancy count on page 2
The five equal summary cards hid the arithmetic: 공개채용 1명 and
기간제 2명 are how the 결원 3명 gets filled, not peers of it. The strip
now reads 정원 8명 - 현원 5명 = 결원 3명, then an arrow into a
"결원 3명 충원 방안" box holding the two routes as nested cards.

Co-Authored-By: Claude Opus 5 <noreply@anthropic.com>
Claude-Session: https://claude.ai/code/session_01GZfitk2JEKppZ4fGSDdghv
</commit_message>
<xml_diff>
--- a/docs/2027년_사무직원_채용계획안.pptx
+++ b/docs/2027년_사무직원_채용계획안.pptx
@@ -8421,12 +8421,12 @@
         </p:nvSpPr>
         <p:spPr>
           <a:xfrm>
-            <a:off x="658368" y="4901184"/>
-            <a:ext cx="2011680" cy="1042416"/>
+            <a:off x="658368" y="4645152"/>
+            <a:ext cx="1335024" cy="1335024"/>
           </a:xfrm>
           <a:prstGeom prst="roundRect">
             <a:avLst>
-              <a:gd name="adj" fmla="val 6140"/>
+              <a:gd name="adj" fmla="val 4795"/>
             </a:avLst>
           </a:prstGeom>
           <a:solidFill>
@@ -8455,8 +8455,8 @@
         </p:nvSpPr>
         <p:spPr>
           <a:xfrm>
-            <a:off x="658368" y="5047488"/>
-            <a:ext cx="2011680" cy="274320"/>
+            <a:off x="658368" y="4882896"/>
+            <a:ext cx="1335024" cy="274320"/>
           </a:xfrm>
           <a:prstGeom prst="rect">
             <a:avLst/>
@@ -8472,7 +8472,7 @@
               <a:buNone/>
             </a:pPr>
             <a:r>
-              <a:rPr lang="en-US" sz="1100" dirty="0">
+              <a:rPr lang="en-US" sz="1200" dirty="0">
                 <a:solidFill>
                   <a:srgbClr val="6B7186"/>
                 </a:solidFill>
@@ -8482,7 +8482,7 @@
               </a:rPr>
               <a:t>정원</a:t>
             </a:r>
-            <a:endParaRPr lang="en-US" sz="1100" dirty="0"/>
+            <a:endParaRPr lang="en-US" sz="1200" dirty="0"/>
           </a:p>
         </p:txBody>
       </p:sp>
@@ -8494,8 +8494,8 @@
         </p:nvSpPr>
         <p:spPr>
           <a:xfrm>
-            <a:off x="658368" y="5340096"/>
-            <a:ext cx="2011680" cy="457200"/>
+            <a:off x="658368" y="5212080"/>
+            <a:ext cx="1335024" cy="512064"/>
           </a:xfrm>
           <a:prstGeom prst="rect">
             <a:avLst/>
@@ -8511,7 +8511,7 @@
               <a:buNone/>
             </a:pPr>
             <a:r>
-              <a:rPr lang="en-US" sz="2100" b="1" dirty="0">
+              <a:rPr lang="en-US" sz="2400" b="1" dirty="0">
                 <a:solidFill>
                   <a:srgbClr val="1E2761"/>
                 </a:solidFill>
@@ -8521,24 +8521,63 @@
               </a:rPr>
               <a:t>8명</a:t>
             </a:r>
-            <a:endParaRPr lang="en-US" sz="2100" dirty="0"/>
-          </a:p>
-        </p:txBody>
-      </p:sp>
-      <p:sp>
-        <p:nvSpPr>
-          <p:cNvPr id="12" name="Shape 8"/>
+            <a:endParaRPr lang="en-US" sz="2400" dirty="0"/>
+          </a:p>
+        </p:txBody>
+      </p:sp>
+      <p:sp>
+        <p:nvSpPr>
+          <p:cNvPr id="12" name="Text 8"/>
+          <p:cNvSpPr txBox="1"/>
+          <p:nvPr/>
+        </p:nvSpPr>
+        <p:spPr>
+          <a:xfrm>
+            <a:off x="1993392" y="4645152"/>
+            <a:ext cx="365760" cy="1335024"/>
+          </a:xfrm>
+          <a:prstGeom prst="rect">
+            <a:avLst/>
+          </a:prstGeom>
+          <a:noFill/>
+          <a:ln/>
+        </p:spPr>
+        <p:txBody>
+          <a:bodyPr wrap="square" lIns="0" tIns="0" rIns="0" bIns="0" rtlCol="0" anchor="ctr"/>
+          <a:lstStyle/>
+          <a:p>
+            <a:pPr eaLnBrk="0" latinLnBrk="0" algn="ctr" indent="0" marL="0">
+              <a:buNone/>
+            </a:pPr>
+            <a:r>
+              <a:rPr lang="en-US" sz="2000" b="1" dirty="0">
+                <a:solidFill>
+                  <a:srgbClr val="6B7186"/>
+                </a:solidFill>
+                <a:latin typeface="맑은 고딕" pitchFamily="34" charset="0"/>
+                <a:ea typeface="맑은 고딕" pitchFamily="34" charset="-122"/>
+                <a:cs typeface="맑은 고딕" pitchFamily="34" charset="-120"/>
+              </a:rPr>
+              <a:t>-</a:t>
+            </a:r>
+            <a:endParaRPr lang="en-US" sz="2000" dirty="0"/>
+          </a:p>
+        </p:txBody>
+      </p:sp>
+      <p:sp>
+        <p:nvSpPr>
+          <p:cNvPr id="13" name="Shape 9"/>
           <p:cNvSpPr/>
           <p:nvPr/>
         </p:nvSpPr>
         <p:spPr>
           <a:xfrm>
-            <a:off x="2852928" y="4901184"/>
-            <a:ext cx="2011680" cy="1042416"/>
+            <a:off x="2359152" y="4645152"/>
+            <a:ext cx="1335024" cy="1335024"/>
           </a:xfrm>
           <a:prstGeom prst="roundRect">
             <a:avLst>
-              <a:gd name="adj" fmla="val 6140"/>
+              <a:gd name="adj" fmla="val 4795"/>
             </a:avLst>
           </a:prstGeom>
           <a:solidFill>
@@ -8561,14 +8600,14 @@
       </p:sp>
       <p:sp>
         <p:nvSpPr>
-          <p:cNvPr id="13" name="Text 9"/>
-          <p:cNvSpPr txBox="1"/>
-          <p:nvPr/>
-        </p:nvSpPr>
-        <p:spPr>
-          <a:xfrm>
-            <a:off x="2852928" y="5047488"/>
-            <a:ext cx="2011680" cy="274320"/>
+          <p:cNvPr id="14" name="Text 10"/>
+          <p:cNvSpPr txBox="1"/>
+          <p:nvPr/>
+        </p:nvSpPr>
+        <p:spPr>
+          <a:xfrm>
+            <a:off x="2359152" y="4882896"/>
+            <a:ext cx="1335024" cy="274320"/>
           </a:xfrm>
           <a:prstGeom prst="rect">
             <a:avLst/>
@@ -8584,7 +8623,7 @@
               <a:buNone/>
             </a:pPr>
             <a:r>
-              <a:rPr lang="en-US" sz="1100" dirty="0">
+              <a:rPr lang="en-US" sz="1200" dirty="0">
                 <a:solidFill>
                   <a:srgbClr val="6B7186"/>
                 </a:solidFill>
@@ -8594,20 +8633,20 @@
               </a:rPr>
               <a:t>현원</a:t>
             </a:r>
-            <a:endParaRPr lang="en-US" sz="1100" dirty="0"/>
-          </a:p>
-        </p:txBody>
-      </p:sp>
-      <p:sp>
-        <p:nvSpPr>
-          <p:cNvPr id="14" name="Text 10"/>
-          <p:cNvSpPr txBox="1"/>
-          <p:nvPr/>
-        </p:nvSpPr>
-        <p:spPr>
-          <a:xfrm>
-            <a:off x="2852928" y="5340096"/>
-            <a:ext cx="2011680" cy="457200"/>
+            <a:endParaRPr lang="en-US" sz="1200" dirty="0"/>
+          </a:p>
+        </p:txBody>
+      </p:sp>
+      <p:sp>
+        <p:nvSpPr>
+          <p:cNvPr id="15" name="Text 11"/>
+          <p:cNvSpPr txBox="1"/>
+          <p:nvPr/>
+        </p:nvSpPr>
+        <p:spPr>
+          <a:xfrm>
+            <a:off x="2359152" y="5212080"/>
+            <a:ext cx="1335024" cy="512064"/>
           </a:xfrm>
           <a:prstGeom prst="rect">
             <a:avLst/>
@@ -8623,7 +8662,7 @@
               <a:buNone/>
             </a:pPr>
             <a:r>
-              <a:rPr lang="en-US" sz="2100" b="1" dirty="0">
+              <a:rPr lang="en-US" sz="2400" b="1" dirty="0">
                 <a:solidFill>
                   <a:srgbClr val="1E2761"/>
                 </a:solidFill>
@@ -8633,24 +8672,195 @@
               </a:rPr>
               <a:t>5명</a:t>
             </a:r>
-            <a:endParaRPr lang="en-US" sz="2100" dirty="0"/>
-          </a:p>
-        </p:txBody>
-      </p:sp>
-      <p:sp>
-        <p:nvSpPr>
-          <p:cNvPr id="15" name="Shape 11"/>
+            <a:endParaRPr lang="en-US" sz="2400" dirty="0"/>
+          </a:p>
+        </p:txBody>
+      </p:sp>
+      <p:sp>
+        <p:nvSpPr>
+          <p:cNvPr id="16" name="Text 12"/>
+          <p:cNvSpPr txBox="1"/>
+          <p:nvPr/>
+        </p:nvSpPr>
+        <p:spPr>
+          <a:xfrm>
+            <a:off x="3694176" y="4645152"/>
+            <a:ext cx="365760" cy="1335024"/>
+          </a:xfrm>
+          <a:prstGeom prst="rect">
+            <a:avLst/>
+          </a:prstGeom>
+          <a:noFill/>
+          <a:ln/>
+        </p:spPr>
+        <p:txBody>
+          <a:bodyPr wrap="square" lIns="0" tIns="0" rIns="0" bIns="0" rtlCol="0" anchor="ctr"/>
+          <a:lstStyle/>
+          <a:p>
+            <a:pPr eaLnBrk="0" latinLnBrk="0" algn="ctr" indent="0" marL="0">
+              <a:buNone/>
+            </a:pPr>
+            <a:r>
+              <a:rPr lang="en-US" sz="2000" b="1" dirty="0">
+                <a:solidFill>
+                  <a:srgbClr val="6B7186"/>
+                </a:solidFill>
+                <a:latin typeface="맑은 고딕" pitchFamily="34" charset="0"/>
+                <a:ea typeface="맑은 고딕" pitchFamily="34" charset="-122"/>
+                <a:cs typeface="맑은 고딕" pitchFamily="34" charset="-120"/>
+              </a:rPr>
+              <a:t>=</a:t>
+            </a:r>
+            <a:endParaRPr lang="en-US" sz="2000" dirty="0"/>
+          </a:p>
+        </p:txBody>
+      </p:sp>
+      <p:sp>
+        <p:nvSpPr>
+          <p:cNvPr id="17" name="Shape 13"/>
           <p:cNvSpPr/>
           <p:nvPr/>
         </p:nvSpPr>
         <p:spPr>
           <a:xfrm>
-            <a:off x="5047488" y="4901184"/>
-            <a:ext cx="2011680" cy="1042416"/>
+            <a:off x="4059936" y="4645152"/>
+            <a:ext cx="1335024" cy="1335024"/>
           </a:xfrm>
           <a:prstGeom prst="roundRect">
             <a:avLst>
-              <a:gd name="adj" fmla="val 6140"/>
+              <a:gd name="adj" fmla="val 4795"/>
+            </a:avLst>
+          </a:prstGeom>
+          <a:solidFill>
+            <a:srgbClr val="FBEDEC"/>
+          </a:solidFill>
+          <a:ln w="12700">
+            <a:solidFill>
+              <a:srgbClr val="E3E8F4"/>
+            </a:solidFill>
+            <a:prstDash val="solid"/>
+          </a:ln>
+          <a:effectLst>
+            <a:outerShdw sx="100000" sy="100000" kx="0" ky="0" algn="bl" rotWithShape="0" blurRad="101600" dist="25400" dir="5400000">
+              <a:srgbClr val="1E2761">
+                <a:alpha val="10000"/>
+              </a:srgbClr>
+            </a:outerShdw>
+          </a:effectLst>
+        </p:spPr>
+      </p:sp>
+      <p:sp>
+        <p:nvSpPr>
+          <p:cNvPr id="18" name="Text 14"/>
+          <p:cNvSpPr txBox="1"/>
+          <p:nvPr/>
+        </p:nvSpPr>
+        <p:spPr>
+          <a:xfrm>
+            <a:off x="4059936" y="4882896"/>
+            <a:ext cx="1335024" cy="274320"/>
+          </a:xfrm>
+          <a:prstGeom prst="rect">
+            <a:avLst/>
+          </a:prstGeom>
+          <a:noFill/>
+          <a:ln/>
+        </p:spPr>
+        <p:txBody>
+          <a:bodyPr wrap="square" lIns="0" tIns="0" rIns="0" bIns="0" rtlCol="0" anchor="ctr"/>
+          <a:lstStyle/>
+          <a:p>
+            <a:pPr eaLnBrk="0" latinLnBrk="0" algn="ctr" indent="0" marL="0">
+              <a:buNone/>
+            </a:pPr>
+            <a:r>
+              <a:rPr lang="en-US" sz="1200" dirty="0">
+                <a:solidFill>
+                  <a:srgbClr val="6B7186"/>
+                </a:solidFill>
+                <a:latin typeface="맑은 고딕" pitchFamily="34" charset="0"/>
+                <a:ea typeface="맑은 고딕" pitchFamily="34" charset="-122"/>
+                <a:cs typeface="맑은 고딕" pitchFamily="34" charset="-120"/>
+              </a:rPr>
+              <a:t>결원</a:t>
+            </a:r>
+            <a:endParaRPr lang="en-US" sz="1200" dirty="0"/>
+          </a:p>
+        </p:txBody>
+      </p:sp>
+      <p:sp>
+        <p:nvSpPr>
+          <p:cNvPr id="19" name="Text 15"/>
+          <p:cNvSpPr txBox="1"/>
+          <p:nvPr/>
+        </p:nvSpPr>
+        <p:spPr>
+          <a:xfrm>
+            <a:off x="4059936" y="5212080"/>
+            <a:ext cx="1335024" cy="512064"/>
+          </a:xfrm>
+          <a:prstGeom prst="rect">
+            <a:avLst/>
+          </a:prstGeom>
+          <a:noFill/>
+          <a:ln/>
+        </p:spPr>
+        <p:txBody>
+          <a:bodyPr wrap="square" lIns="0" tIns="0" rIns="0" bIns="0" rtlCol="0" anchor="ctr"/>
+          <a:lstStyle/>
+          <a:p>
+            <a:pPr eaLnBrk="0" latinLnBrk="0" algn="ctr" indent="0" marL="0">
+              <a:buNone/>
+            </a:pPr>
+            <a:r>
+              <a:rPr lang="en-US" sz="2400" b="1" dirty="0">
+                <a:solidFill>
+                  <a:srgbClr val="B23A34"/>
+                </a:solidFill>
+                <a:latin typeface="맑은 고딕" pitchFamily="34" charset="0"/>
+                <a:ea typeface="맑은 고딕" pitchFamily="34" charset="-122"/>
+                <a:cs typeface="맑은 고딕" pitchFamily="34" charset="-120"/>
+              </a:rPr>
+              <a:t>3명</a:t>
+            </a:r>
+            <a:endParaRPr lang="en-US" sz="2400" dirty="0"/>
+          </a:p>
+        </p:txBody>
+      </p:sp>
+      <p:sp>
+        <p:nvSpPr>
+          <p:cNvPr id="20" name="Shape 16"/>
+          <p:cNvSpPr/>
+          <p:nvPr/>
+        </p:nvSpPr>
+        <p:spPr>
+          <a:xfrm rot="5400000">
+            <a:off x="5522976" y="5202936"/>
+            <a:ext cx="219456" cy="219456"/>
+          </a:xfrm>
+          <a:prstGeom prst="triangle">
+            <a:avLst/>
+          </a:prstGeom>
+          <a:solidFill>
+            <a:srgbClr val="1E2761"/>
+          </a:solidFill>
+          <a:ln/>
+        </p:spPr>
+      </p:sp>
+      <p:sp>
+        <p:nvSpPr>
+          <p:cNvPr id="21" name="Shape 17"/>
+          <p:cNvSpPr/>
+          <p:nvPr/>
+        </p:nvSpPr>
+        <p:spPr>
+          <a:xfrm>
+            <a:off x="5870448" y="4645152"/>
+            <a:ext cx="5815584" cy="1335024"/>
+          </a:xfrm>
+          <a:prstGeom prst="roundRect">
+            <a:avLst>
+              <a:gd name="adj" fmla="val 4795"/>
             </a:avLst>
           </a:prstGeom>
           <a:solidFill>
@@ -8673,14 +8883,14 @@
       </p:sp>
       <p:sp>
         <p:nvSpPr>
-          <p:cNvPr id="16" name="Text 12"/>
-          <p:cNvSpPr txBox="1"/>
-          <p:nvPr/>
-        </p:nvSpPr>
-        <p:spPr>
-          <a:xfrm>
-            <a:off x="5047488" y="5047488"/>
-            <a:ext cx="2011680" cy="274320"/>
+          <p:cNvPr id="22" name="Text 18"/>
+          <p:cNvSpPr txBox="1"/>
+          <p:nvPr/>
+        </p:nvSpPr>
+        <p:spPr>
+          <a:xfrm>
+            <a:off x="6126480" y="4791456"/>
+            <a:ext cx="5303520" cy="292608"/>
           </a:xfrm>
           <a:prstGeom prst="rect">
             <a:avLst/>
@@ -8692,50 +8902,11 @@
           <a:bodyPr wrap="square" lIns="0" tIns="0" rIns="0" bIns="0" rtlCol="0" anchor="ctr"/>
           <a:lstStyle/>
           <a:p>
-            <a:pPr eaLnBrk="0" latinLnBrk="0" algn="ctr" indent="0" marL="0">
-              <a:buNone/>
-            </a:pPr>
-            <a:r>
-              <a:rPr lang="en-US" sz="1100" dirty="0">
-                <a:solidFill>
-                  <a:srgbClr val="6B7186"/>
-                </a:solidFill>
-                <a:latin typeface="맑은 고딕" pitchFamily="34" charset="0"/>
-                <a:ea typeface="맑은 고딕" pitchFamily="34" charset="-122"/>
-                <a:cs typeface="맑은 고딕" pitchFamily="34" charset="-120"/>
-              </a:rPr>
-              <a:t>결원</a:t>
-            </a:r>
-            <a:endParaRPr lang="en-US" sz="1100" dirty="0"/>
-          </a:p>
-        </p:txBody>
-      </p:sp>
-      <p:sp>
-        <p:nvSpPr>
-          <p:cNvPr id="17" name="Text 13"/>
-          <p:cNvSpPr txBox="1"/>
-          <p:nvPr/>
-        </p:nvSpPr>
-        <p:spPr>
-          <a:xfrm>
-            <a:off x="5047488" y="5340096"/>
-            <a:ext cx="2011680" cy="457200"/>
-          </a:xfrm>
-          <a:prstGeom prst="rect">
-            <a:avLst/>
-          </a:prstGeom>
-          <a:noFill/>
-          <a:ln/>
-        </p:spPr>
-        <p:txBody>
-          <a:bodyPr wrap="square" lIns="0" tIns="0" rIns="0" bIns="0" rtlCol="0" anchor="ctr"/>
-          <a:lstStyle/>
-          <a:p>
-            <a:pPr eaLnBrk="0" latinLnBrk="0" algn="ctr" indent="0" marL="0">
-              <a:buNone/>
-            </a:pPr>
-            <a:r>
-              <a:rPr lang="en-US" sz="2100" b="1" dirty="0">
+            <a:pPr eaLnBrk="0" latinLnBrk="0" indent="0" marL="0">
+              <a:buNone/>
+            </a:pPr>
+            <a:r>
+              <a:rPr lang="en-US" sz="1400" b="1" dirty="0">
                 <a:solidFill>
                   <a:srgbClr val="1E2761"/>
                 </a:solidFill>
@@ -8743,56 +8914,44 @@
                 <a:ea typeface="맑은 고딕" pitchFamily="34" charset="-122"/>
                 <a:cs typeface="맑은 고딕" pitchFamily="34" charset="-120"/>
               </a:rPr>
-              <a:t>3명</a:t>
-            </a:r>
-            <a:endParaRPr lang="en-US" sz="2100" dirty="0"/>
-          </a:p>
-        </p:txBody>
-      </p:sp>
-      <p:sp>
-        <p:nvSpPr>
-          <p:cNvPr id="18" name="Shape 14"/>
+              <a:t>결원 3명 충원 방안</a:t>
+            </a:r>
+            <a:endParaRPr lang="en-US" sz="1400" dirty="0"/>
+          </a:p>
+        </p:txBody>
+      </p:sp>
+      <p:sp>
+        <p:nvSpPr>
+          <p:cNvPr id="23" name="Shape 19"/>
           <p:cNvSpPr/>
           <p:nvPr/>
         </p:nvSpPr>
         <p:spPr>
           <a:xfrm>
-            <a:off x="7242048" y="4901184"/>
-            <a:ext cx="2011680" cy="1042416"/>
+            <a:off x="6126480" y="5157216"/>
+            <a:ext cx="2569464" cy="658368"/>
           </a:xfrm>
           <a:prstGeom prst="roundRect">
             <a:avLst>
-              <a:gd name="adj" fmla="val 6140"/>
+              <a:gd name="adj" fmla="val 9722"/>
             </a:avLst>
           </a:prstGeom>
           <a:solidFill>
             <a:srgbClr val="1E2761"/>
           </a:solidFill>
-          <a:ln w="12700">
-            <a:solidFill>
-              <a:srgbClr val="E3E8F4"/>
-            </a:solidFill>
-            <a:prstDash val="solid"/>
-          </a:ln>
-          <a:effectLst>
-            <a:outerShdw sx="100000" sy="100000" kx="0" ky="0" algn="bl" rotWithShape="0" blurRad="101600" dist="25400" dir="5400000">
-              <a:srgbClr val="1E2761">
-                <a:alpha val="10000"/>
-              </a:srgbClr>
-            </a:outerShdw>
-          </a:effectLst>
-        </p:spPr>
-      </p:sp>
-      <p:sp>
-        <p:nvSpPr>
-          <p:cNvPr id="19" name="Text 15"/>
-          <p:cNvSpPr txBox="1"/>
-          <p:nvPr/>
-        </p:nvSpPr>
-        <p:spPr>
-          <a:xfrm>
-            <a:off x="7242048" y="5047488"/>
-            <a:ext cx="2011680" cy="274320"/>
+          <a:ln/>
+        </p:spPr>
+      </p:sp>
+      <p:sp>
+        <p:nvSpPr>
+          <p:cNvPr id="24" name="Text 20"/>
+          <p:cNvSpPr txBox="1"/>
+          <p:nvPr/>
+        </p:nvSpPr>
+        <p:spPr>
+          <a:xfrm>
+            <a:off x="6309360" y="5157216"/>
+            <a:ext cx="822960" cy="658368"/>
           </a:xfrm>
           <a:prstGeom prst="rect">
             <a:avLst/>
@@ -8804,11 +8963,50 @@
           <a:bodyPr wrap="square" lIns="0" tIns="0" rIns="0" bIns="0" rtlCol="0" anchor="ctr"/>
           <a:lstStyle/>
           <a:p>
-            <a:pPr eaLnBrk="0" latinLnBrk="0" algn="ctr" indent="0" marL="0">
-              <a:buNone/>
-            </a:pPr>
-            <a:r>
-              <a:rPr lang="en-US" sz="1100" dirty="0">
+            <a:pPr eaLnBrk="0" latinLnBrk="0" indent="0" marL="0">
+              <a:buNone/>
+            </a:pPr>
+            <a:r>
+              <a:rPr lang="en-US" sz="2200" b="1" dirty="0">
+                <a:solidFill>
+                  <a:srgbClr val="FFFFFF"/>
+                </a:solidFill>
+                <a:latin typeface="맑은 고딕" pitchFamily="34" charset="0"/>
+                <a:ea typeface="맑은 고딕" pitchFamily="34" charset="-122"/>
+                <a:cs typeface="맑은 고딕" pitchFamily="34" charset="-120"/>
+              </a:rPr>
+              <a:t>1명</a:t>
+            </a:r>
+            <a:endParaRPr lang="en-US" sz="2200" dirty="0"/>
+          </a:p>
+        </p:txBody>
+      </p:sp>
+      <p:sp>
+        <p:nvSpPr>
+          <p:cNvPr id="25" name="Text 21"/>
+          <p:cNvSpPr txBox="1"/>
+          <p:nvPr/>
+        </p:nvSpPr>
+        <p:spPr>
+          <a:xfrm>
+            <a:off x="7150608" y="5157216"/>
+            <a:ext cx="1399032" cy="658368"/>
+          </a:xfrm>
+          <a:prstGeom prst="rect">
+            <a:avLst/>
+          </a:prstGeom>
+          <a:noFill/>
+          <a:ln/>
+        </p:spPr>
+        <p:txBody>
+          <a:bodyPr wrap="square" lIns="0" tIns="0" rIns="0" bIns="0" rtlCol="0" anchor="ctr"/>
+          <a:lstStyle/>
+          <a:p>
+            <a:pPr eaLnBrk="0" latinLnBrk="0" indent="0" marL="0">
+              <a:buNone/>
+            </a:pPr>
+            <a:r>
+              <a:rPr lang="en-US" sz="1250" dirty="0">
                 <a:solidFill>
                   <a:srgbClr val="CADCFC"/>
                 </a:solidFill>
@@ -8818,93 +9016,42 @@
               </a:rPr>
               <a:t>공개채용</a:t>
             </a:r>
-            <a:endParaRPr lang="en-US" sz="1100" dirty="0"/>
-          </a:p>
-        </p:txBody>
-      </p:sp>
-      <p:sp>
-        <p:nvSpPr>
-          <p:cNvPr id="20" name="Text 16"/>
-          <p:cNvSpPr txBox="1"/>
-          <p:nvPr/>
-        </p:nvSpPr>
-        <p:spPr>
-          <a:xfrm>
-            <a:off x="7242048" y="5340096"/>
-            <a:ext cx="2011680" cy="457200"/>
-          </a:xfrm>
-          <a:prstGeom prst="rect">
-            <a:avLst/>
-          </a:prstGeom>
-          <a:noFill/>
-          <a:ln/>
-        </p:spPr>
-        <p:txBody>
-          <a:bodyPr wrap="square" lIns="0" tIns="0" rIns="0" bIns="0" rtlCol="0" anchor="ctr"/>
-          <a:lstStyle/>
-          <a:p>
-            <a:pPr eaLnBrk="0" latinLnBrk="0" algn="ctr" indent="0" marL="0">
-              <a:buNone/>
-            </a:pPr>
-            <a:r>
-              <a:rPr lang="en-US" sz="2100" b="1" dirty="0">
-                <a:solidFill>
-                  <a:srgbClr val="FFFFFF"/>
-                </a:solidFill>
-                <a:latin typeface="맑은 고딕" pitchFamily="34" charset="0"/>
-                <a:ea typeface="맑은 고딕" pitchFamily="34" charset="-122"/>
-                <a:cs typeface="맑은 고딕" pitchFamily="34" charset="-120"/>
-              </a:rPr>
-              <a:t>1명</a:t>
-            </a:r>
-            <a:endParaRPr lang="en-US" sz="2100" dirty="0"/>
-          </a:p>
-        </p:txBody>
-      </p:sp>
-      <p:sp>
-        <p:nvSpPr>
-          <p:cNvPr id="21" name="Shape 17"/>
+            <a:endParaRPr lang="en-US" sz="1250" dirty="0"/>
+          </a:p>
+        </p:txBody>
+      </p:sp>
+      <p:sp>
+        <p:nvSpPr>
+          <p:cNvPr id="26" name="Shape 22"/>
           <p:cNvSpPr/>
           <p:nvPr/>
         </p:nvSpPr>
         <p:spPr>
           <a:xfrm>
-            <a:off x="9436608" y="4901184"/>
-            <a:ext cx="2011680" cy="1042416"/>
+            <a:off x="8860536" y="5157216"/>
+            <a:ext cx="2569464" cy="658368"/>
           </a:xfrm>
           <a:prstGeom prst="roundRect">
             <a:avLst>
-              <a:gd name="adj" fmla="val 6140"/>
+              <a:gd name="adj" fmla="val 9722"/>
             </a:avLst>
           </a:prstGeom>
           <a:solidFill>
-            <a:srgbClr val="FFFFFF"/>
+            <a:srgbClr val="E8EFFC"/>
           </a:solidFill>
-          <a:ln w="12700">
-            <a:solidFill>
-              <a:srgbClr val="E3E8F4"/>
-            </a:solidFill>
-            <a:prstDash val="solid"/>
-          </a:ln>
-          <a:effectLst>
-            <a:outerShdw sx="100000" sy="100000" kx="0" ky="0" algn="bl" rotWithShape="0" blurRad="101600" dist="25400" dir="5400000">
-              <a:srgbClr val="1E2761">
-                <a:alpha val="10000"/>
-              </a:srgbClr>
-            </a:outerShdw>
-          </a:effectLst>
-        </p:spPr>
-      </p:sp>
-      <p:sp>
-        <p:nvSpPr>
-          <p:cNvPr id="22" name="Text 18"/>
-          <p:cNvSpPr txBox="1"/>
-          <p:nvPr/>
-        </p:nvSpPr>
-        <p:spPr>
-          <a:xfrm>
-            <a:off x="9436608" y="5047488"/>
-            <a:ext cx="2011680" cy="274320"/>
+          <a:ln/>
+        </p:spPr>
+      </p:sp>
+      <p:sp>
+        <p:nvSpPr>
+          <p:cNvPr id="27" name="Text 23"/>
+          <p:cNvSpPr txBox="1"/>
+          <p:nvPr/>
+        </p:nvSpPr>
+        <p:spPr>
+          <a:xfrm>
+            <a:off x="9043416" y="5157216"/>
+            <a:ext cx="822960" cy="658368"/>
           </a:xfrm>
           <a:prstGeom prst="rect">
             <a:avLst/>
@@ -8916,13 +9063,52 @@
           <a:bodyPr wrap="square" lIns="0" tIns="0" rIns="0" bIns="0" rtlCol="0" anchor="ctr"/>
           <a:lstStyle/>
           <a:p>
-            <a:pPr eaLnBrk="0" latinLnBrk="0" algn="ctr" indent="0" marL="0">
-              <a:buNone/>
-            </a:pPr>
-            <a:r>
-              <a:rPr lang="en-US" sz="1100" dirty="0">
-                <a:solidFill>
-                  <a:srgbClr val="6B7186"/>
+            <a:pPr eaLnBrk="0" latinLnBrk="0" indent="0" marL="0">
+              <a:buNone/>
+            </a:pPr>
+            <a:r>
+              <a:rPr lang="en-US" sz="2200" b="1" dirty="0">
+                <a:solidFill>
+                  <a:srgbClr val="1E2761"/>
+                </a:solidFill>
+                <a:latin typeface="맑은 고딕" pitchFamily="34" charset="0"/>
+                <a:ea typeface="맑은 고딕" pitchFamily="34" charset="-122"/>
+                <a:cs typeface="맑은 고딕" pitchFamily="34" charset="-120"/>
+              </a:rPr>
+              <a:t>2명</a:t>
+            </a:r>
+            <a:endParaRPr lang="en-US" sz="2200" dirty="0"/>
+          </a:p>
+        </p:txBody>
+      </p:sp>
+      <p:sp>
+        <p:nvSpPr>
+          <p:cNvPr id="28" name="Text 24"/>
+          <p:cNvSpPr txBox="1"/>
+          <p:nvPr/>
+        </p:nvSpPr>
+        <p:spPr>
+          <a:xfrm>
+            <a:off x="9884664" y="5157216"/>
+            <a:ext cx="1399032" cy="658368"/>
+          </a:xfrm>
+          <a:prstGeom prst="rect">
+            <a:avLst/>
+          </a:prstGeom>
+          <a:noFill/>
+          <a:ln/>
+        </p:spPr>
+        <p:txBody>
+          <a:bodyPr wrap="square" lIns="0" tIns="0" rIns="0" bIns="0" rtlCol="0" anchor="ctr"/>
+          <a:lstStyle/>
+          <a:p>
+            <a:pPr eaLnBrk="0" latinLnBrk="0" indent="0" marL="0">
+              <a:buNone/>
+            </a:pPr>
+            <a:r>
+              <a:rPr lang="en-US" sz="1250" dirty="0">
+                <a:solidFill>
+                  <a:srgbClr val="22263A"/>
                 </a:solidFill>
                 <a:latin typeface="맑은 고딕" pitchFamily="34" charset="0"/>
                 <a:ea typeface="맑은 고딕" pitchFamily="34" charset="-122"/>
@@ -8930,46 +9116,7 @@
               </a:rPr>
               <a:t>기간제 운영</a:t>
             </a:r>
-            <a:endParaRPr lang="en-US" sz="1100" dirty="0"/>
-          </a:p>
-        </p:txBody>
-      </p:sp>
-      <p:sp>
-        <p:nvSpPr>
-          <p:cNvPr id="23" name="Text 19"/>
-          <p:cNvSpPr txBox="1"/>
-          <p:nvPr/>
-        </p:nvSpPr>
-        <p:spPr>
-          <a:xfrm>
-            <a:off x="9436608" y="5340096"/>
-            <a:ext cx="2011680" cy="457200"/>
-          </a:xfrm>
-          <a:prstGeom prst="rect">
-            <a:avLst/>
-          </a:prstGeom>
-          <a:noFill/>
-          <a:ln/>
-        </p:spPr>
-        <p:txBody>
-          <a:bodyPr wrap="square" lIns="0" tIns="0" rIns="0" bIns="0" rtlCol="0" anchor="ctr"/>
-          <a:lstStyle/>
-          <a:p>
-            <a:pPr eaLnBrk="0" latinLnBrk="0" algn="ctr" indent="0" marL="0">
-              <a:buNone/>
-            </a:pPr>
-            <a:r>
-              <a:rPr lang="en-US" sz="2100" b="1" dirty="0">
-                <a:solidFill>
-                  <a:srgbClr val="1E2761"/>
-                </a:solidFill>
-                <a:latin typeface="맑은 고딕" pitchFamily="34" charset="0"/>
-                <a:ea typeface="맑은 고딕" pitchFamily="34" charset="-122"/>
-                <a:cs typeface="맑은 고딕" pitchFamily="34" charset="-120"/>
-              </a:rPr>
-              <a:t>2명</a:t>
-            </a:r>
-            <a:endParaRPr lang="en-US" sz="2100" dirty="0"/>
+            <a:endParaRPr lang="en-US" sz="1250" dirty="0"/>
           </a:p>
         </p:txBody>
       </p:sp>

</xml_diff>

<commit_message>
Wrap the 채용(안) header and unclip the verification bullets
- Page 2 staffing table: "채용(안)" now breaks after 채용 rather than
  filling the column edge to edge
- Page 4 결격사유 검증 card: the bullet list was clipping against the
  card. Its box now spans the card width less 0.16", the bullet indent
  drops to 10pt and the type to 9.5pt, so 채용신체검사 / 결격사유 조회 /
  성범죄 조회 each hold one line.

Co-Authored-By: Claude Opus 5 <noreply@anthropic.com>
Claude-Session: https://claude.ai/code/session_01GZfitk2JEKppZ4fGSDdghv
</commit_message>
<xml_diff>
--- a/docs/2027년_사무직원_채용계획안.pptx
+++ b/docs/2027년_사무직원_채용계획안.pptx
@@ -6274,7 +6274,28 @@
                           <a:ea typeface="맑은 고딕" pitchFamily="34" charset="-122"/>
                           <a:cs typeface="맑은 고딕" pitchFamily="34" charset="-120"/>
                         </a:rPr>
-                        <a:t>채용(안)</a:t>
+                        <a:t>채용</a:t>
+                      </a:r>
+                      <a:endParaRPr lang="en-US" sz="950" dirty="0">
+                        <a:latin typeface="맑은 고딕" charset="0"/>
+                        <a:ea typeface="맑은 고딕" charset="0"/>
+                        <a:cs typeface="맑은 고딕" charset="0"/>
+                      </a:endParaRPr>
+                    </a:p>
+                    <a:p>
+                      <a:pPr eaLnBrk="0" latinLnBrk="0" algn="ctr" indent="0" marL="0">
+                        <a:buNone/>
+                      </a:pPr>
+                      <a:r>
+                        <a:rPr lang="en-US" sz="950" b="1" dirty="0">
+                          <a:solidFill>
+                            <a:srgbClr val="FFFFFF"/>
+                          </a:solidFill>
+                          <a:latin typeface="맑은 고딕" pitchFamily="34" charset="0"/>
+                          <a:ea typeface="맑은 고딕" pitchFamily="34" charset="-122"/>
+                          <a:cs typeface="맑은 고딕" pitchFamily="34" charset="-120"/>
+                        </a:rPr>
+                        <a:t>(안)</a:t>
                       </a:r>
                       <a:endParaRPr lang="en-US" sz="950" dirty="0">
                         <a:latin typeface="맑은 고딕" charset="0"/>
@@ -11353,8 +11374,8 @@
         </p:nvSpPr>
         <p:spPr>
           <a:xfrm>
-            <a:off x="5769864" y="3383280"/>
-            <a:ext cx="1097280" cy="1005840"/>
+            <a:off x="5660136" y="3383280"/>
+            <a:ext cx="1243584" cy="1005840"/>
           </a:xfrm>
           <a:prstGeom prst="rect">
             <a:avLst/>
@@ -11366,7 +11387,7 @@
           <a:bodyPr wrap="square" lIns="0" tIns="0" rIns="0" bIns="0" rtlCol="0" anchor="t"/>
           <a:lstStyle/>
           <a:p>
-            <a:pPr eaLnBrk="0" latinLnBrk="0" marL="342900" indent="-342900">
+            <a:pPr eaLnBrk="0" latinLnBrk="0" marL="127000" indent="-127000">
               <a:spcAft>
                 <a:spcPts val="500"/>
               </a:spcAft>
@@ -11374,7 +11395,7 @@
               <a:buChar char="•"/>
             </a:pPr>
             <a:r>
-              <a:rPr lang="en-US" sz="1000" dirty="0">
+              <a:rPr lang="en-US" sz="950" dirty="0">
                 <a:solidFill>
                   <a:srgbClr val="22263A"/>
                 </a:solidFill>
@@ -11384,10 +11405,10 @@
               </a:rPr>
               <a:t>채용신체검사</a:t>
             </a:r>
-            <a:endParaRPr lang="en-US" sz="1000" dirty="0"/>
-          </a:p>
-          <a:p>
-            <a:pPr eaLnBrk="0" latinLnBrk="0" marL="342900" indent="-342900">
+            <a:endParaRPr lang="en-US" sz="950" dirty="0"/>
+          </a:p>
+          <a:p>
+            <a:pPr eaLnBrk="0" latinLnBrk="0" marL="127000" indent="-127000">
               <a:spcAft>
                 <a:spcPts val="500"/>
               </a:spcAft>
@@ -11395,7 +11416,7 @@
               <a:buChar char="•"/>
             </a:pPr>
             <a:r>
-              <a:rPr lang="en-US" sz="1000" dirty="0">
+              <a:rPr lang="en-US" sz="950" dirty="0">
                 <a:solidFill>
                   <a:srgbClr val="22263A"/>
                 </a:solidFill>
@@ -11405,10 +11426,10 @@
               </a:rPr>
               <a:t>결격사유 조회</a:t>
             </a:r>
-            <a:endParaRPr lang="en-US" sz="1000" dirty="0"/>
-          </a:p>
-          <a:p>
-            <a:pPr eaLnBrk="0" latinLnBrk="0" marL="342900" indent="-342900">
+            <a:endParaRPr lang="en-US" sz="950" dirty="0"/>
+          </a:p>
+          <a:p>
+            <a:pPr eaLnBrk="0" latinLnBrk="0" marL="127000" indent="-127000">
               <a:spcAft>
                 <a:spcPts val="500"/>
               </a:spcAft>
@@ -11416,7 +11437,7 @@
               <a:buChar char="•"/>
             </a:pPr>
             <a:r>
-              <a:rPr lang="en-US" sz="1000" dirty="0">
+              <a:rPr lang="en-US" sz="950" dirty="0">
                 <a:solidFill>
                   <a:srgbClr val="22263A"/>
                 </a:solidFill>
@@ -11426,7 +11447,7 @@
               </a:rPr>
               <a:t>성범죄 조회</a:t>
             </a:r>
-            <a:endParaRPr lang="en-US" sz="1000" dirty="0"/>
+            <a:endParaRPr lang="en-US" sz="950" dirty="0"/>
           </a:p>
         </p:txBody>
       </p:sp>

</xml_diff>

<commit_message>
Line up the left and right columns on pages 5-8
Each of these slides paired a table or card on the left with a block on
the right, and the two started and finished at different heights.

- p5 지원서 접수: both column headings sit outside their cards on one
  line (1.82"); both card stacks run 2.2"-5.5"
- p6 서류 전형: the 평가방법/심사위원 lines move above, so the score
  table and the 탈락 기준 card both span 2.5"-5.04"
- p7 업무적성 및 심층면접: same table geometry as p6; the chart card
  shares the 2.5" top but runs longer, since the doughnut needs it
- p8 결격사유 검증: 채용신체검사 becomes a heading outside its navy
  card, so card and table both span 2.68"-4.48"

Co-Authored-By: Claude Opus 5 <noreply@anthropic.com>
Claude-Session: https://claude.ai/code/session_01GZfitk2JEKppZ4fGSDdghv
</commit_message>
<xml_diff>
--- a/docs/2027년_사무직원_채용계획안.pptx
+++ b/docs/2027년_사무직원_채용계획안.pptx
@@ -12331,18 +12331,57 @@
       </p:sp>
       <p:sp>
         <p:nvSpPr>
-          <p:cNvPr id="14" name="Shape 11"/>
+          <p:cNvPr id="14" name="Text 11"/>
+          <p:cNvSpPr txBox="1"/>
+          <p:nvPr/>
+        </p:nvSpPr>
+        <p:spPr>
+          <a:xfrm>
+            <a:off x="457200" y="1664208"/>
+            <a:ext cx="3840480" cy="292608"/>
+          </a:xfrm>
+          <a:prstGeom prst="rect">
+            <a:avLst/>
+          </a:prstGeom>
+          <a:noFill/>
+          <a:ln/>
+        </p:spPr>
+        <p:txBody>
+          <a:bodyPr wrap="square" lIns="0" tIns="0" rIns="0" bIns="0" rtlCol="0" anchor="ctr"/>
+          <a:lstStyle/>
+          <a:p>
+            <a:pPr eaLnBrk="0" latinLnBrk="0" indent="0" marL="0">
+              <a:buNone/>
+            </a:pPr>
+            <a:r>
+              <a:rPr lang="en-US" sz="1500" b="1" dirty="0">
+                <a:solidFill>
+                  <a:srgbClr val="1E2761"/>
+                </a:solidFill>
+                <a:latin typeface="맑은 고딕" pitchFamily="34" charset="0"/>
+                <a:ea typeface="맑은 고딕" pitchFamily="34" charset="-122"/>
+                <a:cs typeface="맑은 고딕" pitchFamily="34" charset="-120"/>
+              </a:rPr>
+              <a:t>지원 자격</a:t>
+            </a:r>
+            <a:endParaRPr lang="en-US" sz="1500" dirty="0"/>
+          </a:p>
+        </p:txBody>
+      </p:sp>
+      <p:sp>
+        <p:nvSpPr>
+          <p:cNvPr id="15" name="Shape 12"/>
           <p:cNvSpPr/>
           <p:nvPr/>
         </p:nvSpPr>
         <p:spPr>
           <a:xfrm>
-            <a:off x="457200" y="1691640"/>
-            <a:ext cx="3840480" cy="2377440"/>
+            <a:off x="457200" y="2011680"/>
+            <a:ext cx="3840480" cy="1874520"/>
           </a:xfrm>
           <a:prstGeom prst="roundRect">
             <a:avLst>
-              <a:gd name="adj" fmla="val 2308"/>
+              <a:gd name="adj" fmla="val 2927"/>
             </a:avLst>
           </a:prstGeom>
           <a:solidFill>
@@ -12365,52 +12404,13 @@
       </p:sp>
       <p:sp>
         <p:nvSpPr>
-          <p:cNvPr id="15" name="Text 12"/>
-          <p:cNvSpPr txBox="1"/>
-          <p:nvPr/>
-        </p:nvSpPr>
-        <p:spPr>
-          <a:xfrm>
-            <a:off x="731520" y="1883664"/>
-            <a:ext cx="3291840" cy="292608"/>
-          </a:xfrm>
-          <a:prstGeom prst="rect">
-            <a:avLst/>
-          </a:prstGeom>
-          <a:noFill/>
-          <a:ln/>
-        </p:spPr>
-        <p:txBody>
-          <a:bodyPr wrap="square" lIns="0" tIns="0" rIns="0" bIns="0" rtlCol="0" anchor="ctr"/>
-          <a:lstStyle/>
-          <a:p>
-            <a:pPr eaLnBrk="0" latinLnBrk="0" indent="0" marL="0">
-              <a:buNone/>
-            </a:pPr>
-            <a:r>
-              <a:rPr lang="en-US" sz="1600" b="1" dirty="0">
-                <a:solidFill>
-                  <a:srgbClr val="1E2761"/>
-                </a:solidFill>
-                <a:latin typeface="맑은 고딕" pitchFamily="34" charset="0"/>
-                <a:ea typeface="맑은 고딕" pitchFamily="34" charset="-122"/>
-                <a:cs typeface="맑은 고딕" pitchFamily="34" charset="-120"/>
-              </a:rPr>
-              <a:t>지원 자격</a:t>
-            </a:r>
-            <a:endParaRPr lang="en-US" sz="1600" dirty="0"/>
-          </a:p>
-        </p:txBody>
-      </p:sp>
-      <p:sp>
-        <p:nvSpPr>
           <p:cNvPr id="16" name="Shape 13"/>
           <p:cNvSpPr/>
           <p:nvPr/>
         </p:nvSpPr>
         <p:spPr>
           <a:xfrm>
-            <a:off x="749808" y="2377440"/>
+            <a:off x="731520" y="2304288"/>
             <a:ext cx="82296" cy="82296"/>
           </a:xfrm>
           <a:prstGeom prst="ellipse">
@@ -12430,8 +12430,8 @@
         </p:nvSpPr>
         <p:spPr>
           <a:xfrm>
-            <a:off x="950976" y="2286000"/>
-            <a:ext cx="3054096" cy="731520"/>
+            <a:off x="932688" y="2212848"/>
+            <a:ext cx="3072384" cy="731520"/>
           </a:xfrm>
           <a:prstGeom prst="rect">
             <a:avLst/>
@@ -12472,7 +12472,7 @@
         </p:nvSpPr>
         <p:spPr>
           <a:xfrm>
-            <a:off x="749808" y="3163824"/>
+            <a:off x="731520" y="3090672"/>
             <a:ext cx="82296" cy="82296"/>
           </a:xfrm>
           <a:prstGeom prst="ellipse">
@@ -12492,8 +12492,8 @@
         </p:nvSpPr>
         <p:spPr>
           <a:xfrm>
-            <a:off x="950976" y="3072384"/>
-            <a:ext cx="3054096" cy="731520"/>
+            <a:off x="932688" y="2999232"/>
+            <a:ext cx="3072384" cy="731520"/>
           </a:xfrm>
           <a:prstGeom prst="rect">
             <a:avLst/>
@@ -12534,7 +12534,7 @@
         </p:nvSpPr>
         <p:spPr>
           <a:xfrm>
-            <a:off x="457200" y="4224528"/>
+            <a:off x="457200" y="4069080"/>
             <a:ext cx="3840480" cy="960120"/>
           </a:xfrm>
           <a:prstGeom prst="roundRect">
@@ -12568,7 +12568,7 @@
         </p:nvSpPr>
         <p:spPr>
           <a:xfrm>
-            <a:off x="731520" y="4370832"/>
+            <a:off x="731520" y="4206240"/>
             <a:ext cx="3291840" cy="274320"/>
           </a:xfrm>
           <a:prstGeom prst="rect">
@@ -12607,7 +12607,7 @@
         </p:nvSpPr>
         <p:spPr>
           <a:xfrm>
-            <a:off x="731520" y="4681728"/>
+            <a:off x="731520" y="4517136"/>
             <a:ext cx="3291840" cy="274320"/>
           </a:xfrm>
           <a:prstGeom prst="rect">
@@ -12646,8 +12646,8 @@
         </p:nvSpPr>
         <p:spPr>
           <a:xfrm>
-            <a:off x="4572000" y="1691640"/>
-            <a:ext cx="4114800" cy="310896"/>
+            <a:off x="4572000" y="1664208"/>
+            <a:ext cx="4114800" cy="292608"/>
           </a:xfrm>
           <a:prstGeom prst="rect">
             <a:avLst/>
@@ -12663,7 +12663,7 @@
               <a:buNone/>
             </a:pPr>
             <a:r>
-              <a:rPr lang="en-US" sz="1600" b="1" dirty="0">
+              <a:rPr lang="en-US" sz="1500" b="1" dirty="0">
                 <a:solidFill>
                   <a:srgbClr val="1E2761"/>
                 </a:solidFill>
@@ -12673,7 +12673,7 @@
               </a:rPr>
               <a:t>자기소개서 문항 (800자 이내)</a:t>
             </a:r>
-            <a:endParaRPr lang="en-US" sz="1600" dirty="0"/>
+            <a:endParaRPr lang="en-US" sz="1500" dirty="0"/>
           </a:p>
         </p:txBody>
       </p:sp>
@@ -12685,12 +12685,12 @@
         </p:nvSpPr>
         <p:spPr>
           <a:xfrm>
-            <a:off x="4572000" y="2121408"/>
-            <a:ext cx="4114800" cy="749808"/>
+            <a:off x="4572000" y="2011680"/>
+            <a:ext cx="4114800" cy="685800"/>
           </a:xfrm>
           <a:prstGeom prst="roundRect">
             <a:avLst>
-              <a:gd name="adj" fmla="val 7317"/>
+              <a:gd name="adj" fmla="val 8000"/>
             </a:avLst>
           </a:prstGeom>
           <a:solidFill>
@@ -12719,8 +12719,8 @@
         </p:nvSpPr>
         <p:spPr>
           <a:xfrm>
-            <a:off x="4754880" y="2313432"/>
-            <a:ext cx="365760" cy="365760"/>
+            <a:off x="4736592" y="2180844"/>
+            <a:ext cx="347472" cy="347472"/>
           </a:xfrm>
           <a:prstGeom prst="ellipse">
             <a:avLst/>
@@ -12739,8 +12739,8 @@
         </p:nvSpPr>
         <p:spPr>
           <a:xfrm>
-            <a:off x="4754880" y="2313432"/>
-            <a:ext cx="365760" cy="365760"/>
+            <a:off x="4736592" y="2180844"/>
+            <a:ext cx="347472" cy="347472"/>
           </a:xfrm>
           <a:prstGeom prst="rect">
             <a:avLst/>
@@ -12778,8 +12778,8 @@
         </p:nvSpPr>
         <p:spPr>
           <a:xfrm>
-            <a:off x="5230368" y="2157984"/>
-            <a:ext cx="3255264" cy="676656"/>
+            <a:off x="5175504" y="2039112"/>
+            <a:ext cx="3328416" cy="630936"/>
           </a:xfrm>
           <a:prstGeom prst="rect">
             <a:avLst/>
@@ -12793,12 +12793,12 @@
           <a:p>
             <a:pPr eaLnBrk="0" latinLnBrk="0" indent="0" marL="0">
               <a:lnSpc>
-                <a:spcPts val="1800"/>
+                <a:spcPts val="1700"/>
               </a:lnSpc>
               <a:buNone/>
             </a:pPr>
             <a:r>
-              <a:rPr lang="en-US" sz="1150" dirty="0">
+              <a:rPr lang="en-US" sz="1100" dirty="0">
                 <a:solidFill>
                   <a:srgbClr val="22263A"/>
                 </a:solidFill>
@@ -12808,7 +12808,7 @@
               </a:rPr>
               <a:t>성장배경, 본인 성격의 장·단점</a:t>
             </a:r>
-            <a:endParaRPr lang="en-US" sz="1150" dirty="0"/>
+            <a:endParaRPr lang="en-US" sz="1100" dirty="0"/>
           </a:p>
         </p:txBody>
       </p:sp>
@@ -12820,12 +12820,12 @@
         </p:nvSpPr>
         <p:spPr>
           <a:xfrm>
-            <a:off x="4572000" y="2980944"/>
-            <a:ext cx="4114800" cy="749808"/>
+            <a:off x="4572000" y="2788920"/>
+            <a:ext cx="4114800" cy="685800"/>
           </a:xfrm>
           <a:prstGeom prst="roundRect">
             <a:avLst>
-              <a:gd name="adj" fmla="val 7317"/>
+              <a:gd name="adj" fmla="val 8000"/>
             </a:avLst>
           </a:prstGeom>
           <a:solidFill>
@@ -12854,8 +12854,8 @@
         </p:nvSpPr>
         <p:spPr>
           <a:xfrm>
-            <a:off x="4754880" y="3172968"/>
-            <a:ext cx="365760" cy="365760"/>
+            <a:off x="4736592" y="2958084"/>
+            <a:ext cx="347472" cy="347472"/>
           </a:xfrm>
           <a:prstGeom prst="ellipse">
             <a:avLst/>
@@ -12874,8 +12874,8 @@
         </p:nvSpPr>
         <p:spPr>
           <a:xfrm>
-            <a:off x="4754880" y="3172968"/>
-            <a:ext cx="365760" cy="365760"/>
+            <a:off x="4736592" y="2958084"/>
+            <a:ext cx="347472" cy="347472"/>
           </a:xfrm>
           <a:prstGeom prst="rect">
             <a:avLst/>
@@ -12913,8 +12913,8 @@
         </p:nvSpPr>
         <p:spPr>
           <a:xfrm>
-            <a:off x="5230368" y="3017520"/>
-            <a:ext cx="3255264" cy="676656"/>
+            <a:off x="5175504" y="2816352"/>
+            <a:ext cx="3328416" cy="630936"/>
           </a:xfrm>
           <a:prstGeom prst="rect">
             <a:avLst/>
@@ -12928,12 +12928,12 @@
           <a:p>
             <a:pPr eaLnBrk="0" latinLnBrk="0" indent="0" marL="0">
               <a:lnSpc>
-                <a:spcPts val="1800"/>
+                <a:spcPts val="1700"/>
               </a:lnSpc>
               <a:buNone/>
             </a:pPr>
             <a:r>
-              <a:rPr lang="en-US" sz="1150" dirty="0">
+              <a:rPr lang="en-US" sz="1100" dirty="0">
                 <a:solidFill>
                   <a:srgbClr val="22263A"/>
                 </a:solidFill>
@@ -12943,7 +12943,7 @@
               </a:rPr>
               <a:t>지원동기 (본교에 지원하게 된 이유와 응시 직종에 본인이 적합하다고 판단되는 이유)</a:t>
             </a:r>
-            <a:endParaRPr lang="en-US" sz="1150" dirty="0"/>
+            <a:endParaRPr lang="en-US" sz="1100" dirty="0"/>
           </a:p>
         </p:txBody>
       </p:sp>
@@ -12955,12 +12955,12 @@
         </p:nvSpPr>
         <p:spPr>
           <a:xfrm>
-            <a:off x="4572000" y="3840480"/>
-            <a:ext cx="4114800" cy="749808"/>
+            <a:off x="4572000" y="3566160"/>
+            <a:ext cx="4114800" cy="685800"/>
           </a:xfrm>
           <a:prstGeom prst="roundRect">
             <a:avLst>
-              <a:gd name="adj" fmla="val 7317"/>
+              <a:gd name="adj" fmla="val 8000"/>
             </a:avLst>
           </a:prstGeom>
           <a:solidFill>
@@ -12989,8 +12989,8 @@
         </p:nvSpPr>
         <p:spPr>
           <a:xfrm>
-            <a:off x="4754880" y="4032504"/>
-            <a:ext cx="365760" cy="365760"/>
+            <a:off x="4736592" y="3735324"/>
+            <a:ext cx="347472" cy="347472"/>
           </a:xfrm>
           <a:prstGeom prst="ellipse">
             <a:avLst/>
@@ -13009,8 +13009,8 @@
         </p:nvSpPr>
         <p:spPr>
           <a:xfrm>
-            <a:off x="4754880" y="4032504"/>
-            <a:ext cx="365760" cy="365760"/>
+            <a:off x="4736592" y="3735324"/>
+            <a:ext cx="347472" cy="347472"/>
           </a:xfrm>
           <a:prstGeom prst="rect">
             <a:avLst/>
@@ -13048,8 +13048,8 @@
         </p:nvSpPr>
         <p:spPr>
           <a:xfrm>
-            <a:off x="5230368" y="3877056"/>
-            <a:ext cx="3255264" cy="676656"/>
+            <a:off x="5175504" y="3593592"/>
+            <a:ext cx="3328416" cy="630936"/>
           </a:xfrm>
           <a:prstGeom prst="rect">
             <a:avLst/>
@@ -13063,12 +13063,12 @@
           <a:p>
             <a:pPr eaLnBrk="0" latinLnBrk="0" indent="0" marL="0">
               <a:lnSpc>
-                <a:spcPts val="1800"/>
+                <a:spcPts val="1700"/>
               </a:lnSpc>
               <a:buNone/>
             </a:pPr>
             <a:r>
-              <a:rPr lang="en-US" sz="1150" dirty="0">
+              <a:rPr lang="en-US" sz="1100" dirty="0">
                 <a:solidFill>
                   <a:srgbClr val="22263A"/>
                 </a:solidFill>
@@ -13078,7 +13078,7 @@
               </a:rPr>
               <a:t>입사 후 포부 및 직무 수행 계획</a:t>
             </a:r>
-            <a:endParaRPr lang="en-US" sz="1150" dirty="0"/>
+            <a:endParaRPr lang="en-US" sz="1100" dirty="0"/>
           </a:p>
         </p:txBody>
       </p:sp>
@@ -13090,12 +13090,12 @@
         </p:nvSpPr>
         <p:spPr>
           <a:xfrm>
-            <a:off x="4572000" y="4700016"/>
-            <a:ext cx="4114800" cy="749808"/>
+            <a:off x="4572000" y="4343400"/>
+            <a:ext cx="4114800" cy="685800"/>
           </a:xfrm>
           <a:prstGeom prst="roundRect">
             <a:avLst>
-              <a:gd name="adj" fmla="val 7317"/>
+              <a:gd name="adj" fmla="val 8000"/>
             </a:avLst>
           </a:prstGeom>
           <a:solidFill>
@@ -13124,8 +13124,8 @@
         </p:nvSpPr>
         <p:spPr>
           <a:xfrm>
-            <a:off x="4754880" y="4892040"/>
-            <a:ext cx="365760" cy="365760"/>
+            <a:off x="4736592" y="4512564"/>
+            <a:ext cx="347472" cy="347472"/>
           </a:xfrm>
           <a:prstGeom prst="ellipse">
             <a:avLst/>
@@ -13144,8 +13144,8 @@
         </p:nvSpPr>
         <p:spPr>
           <a:xfrm>
-            <a:off x="4754880" y="4892040"/>
-            <a:ext cx="365760" cy="365760"/>
+            <a:off x="4736592" y="4512564"/>
+            <a:ext cx="347472" cy="347472"/>
           </a:xfrm>
           <a:prstGeom prst="rect">
             <a:avLst/>
@@ -13183,8 +13183,8 @@
         </p:nvSpPr>
         <p:spPr>
           <a:xfrm>
-            <a:off x="5230368" y="4736592"/>
-            <a:ext cx="3255264" cy="676656"/>
+            <a:off x="5175504" y="4370832"/>
+            <a:ext cx="3328416" cy="630936"/>
           </a:xfrm>
           <a:prstGeom prst="rect">
             <a:avLst/>
@@ -13198,12 +13198,12 @@
           <a:p>
             <a:pPr eaLnBrk="0" latinLnBrk="0" indent="0" marL="0">
               <a:lnSpc>
-                <a:spcPts val="1800"/>
+                <a:spcPts val="1700"/>
               </a:lnSpc>
               <a:buNone/>
             </a:pPr>
             <a:r>
-              <a:rPr lang="en-US" sz="1150" dirty="0">
+              <a:rPr lang="en-US" sz="1100" dirty="0">
                 <a:solidFill>
                   <a:srgbClr val="22263A"/>
                 </a:solidFill>
@@ -13213,7 +13213,7 @@
               </a:rPr>
               <a:t>조직 내 갈등 상황과 이를 해결하기 위한 노력 및 극복했던 경험</a:t>
             </a:r>
-            <a:endParaRPr lang="en-US" sz="1150" dirty="0"/>
+            <a:endParaRPr lang="en-US" sz="1100" dirty="0"/>
           </a:p>
         </p:txBody>
       </p:sp>
@@ -13642,7 +13642,7 @@
         </p:nvSpPr>
         <p:spPr>
           <a:xfrm>
-            <a:off x="457200" y="1700784"/>
+            <a:off x="457200" y="1664208"/>
             <a:ext cx="4937760" cy="256032"/>
           </a:xfrm>
           <a:prstGeom prst="rect">
@@ -13695,7 +13695,7 @@
         </p:nvSpPr>
         <p:spPr>
           <a:xfrm>
-            <a:off x="457200" y="1975104"/>
+            <a:off x="457200" y="1938528"/>
             <a:ext cx="4937760" cy="256032"/>
           </a:xfrm>
           <a:prstGeom prst="rect">
@@ -13755,7 +13755,7 @@
           </p:nvPr>
         </p:nvGraphicFramePr>
         <p:xfrm>
-          <a:off x="457200" y="2340864"/>
+          <a:off x="457200" y="2286000"/>
           <a:ext cx="4572000" cy="914400"/>
         </p:xfrm>
         <a:graphic>
@@ -13767,7 +13767,7 @@
                 <a:gridCol w="1143000"/>
                 <a:gridCol w="1143000"/>
               </a:tblGrid>
-              <a:tr h="329184">
+              <a:tr h="365760">
                 <a:tc>
                   <a:txBody>
                     <a:bodyPr/>
@@ -13973,7 +13973,7 @@
                   </a:tcPr>
                 </a:tc>
               </a:tr>
-              <a:tr h="347472">
+              <a:tr h="384048">
                 <a:tc>
                   <a:txBody>
                     <a:bodyPr/>
@@ -14194,7 +14194,7 @@
                   </a:tcPr>
                 </a:tc>
               </a:tr>
-              <a:tr h="347472">
+              <a:tr h="384048">
                 <a:tc>
                   <a:txBody>
                     <a:bodyPr/>
@@ -14329,7 +14329,7 @@
                   <a:tcPr/>
                 </a:tc>
               </a:tr>
-              <a:tr h="347472">
+              <a:tr h="384048">
                 <a:tc>
                   <a:txBody>
                     <a:bodyPr/>
@@ -14464,7 +14464,7 @@
                   <a:tcPr/>
                 </a:tc>
               </a:tr>
-              <a:tr h="347472">
+              <a:tr h="384048">
                 <a:tc>
                   <a:txBody>
                     <a:bodyPr/>
@@ -14599,7 +14599,7 @@
                   <a:tcPr/>
                 </a:tc>
               </a:tr>
-              <a:tr h="384048">
+              <a:tr h="420624">
                 <a:tc>
                   <a:txBody>
                     <a:bodyPr/>
@@ -14752,12 +14752,12 @@
         </p:nvSpPr>
         <p:spPr>
           <a:xfrm>
-            <a:off x="5303520" y="1700784"/>
-            <a:ext cx="3383280" cy="3017520"/>
+            <a:off x="5303520" y="2286000"/>
+            <a:ext cx="3383280" cy="2322576"/>
           </a:xfrm>
           <a:prstGeom prst="roundRect">
             <a:avLst>
-              <a:gd name="adj" fmla="val 1818"/>
+              <a:gd name="adj" fmla="val 2362"/>
             </a:avLst>
           </a:prstGeom>
           <a:solidFill>
@@ -14786,8 +14786,8 @@
         </p:nvSpPr>
         <p:spPr>
           <a:xfrm>
-            <a:off x="5541264" y="1920240"/>
-            <a:ext cx="2907792" cy="603504"/>
+            <a:off x="5541264" y="2432304"/>
+            <a:ext cx="2907792" cy="566928"/>
           </a:xfrm>
           <a:prstGeom prst="rect">
             <a:avLst/>
@@ -14801,12 +14801,12 @@
           <a:p>
             <a:pPr eaLnBrk="0" latinLnBrk="0" indent="0" marL="0">
               <a:lnSpc>
-                <a:spcPts val="2200"/>
+                <a:spcPts val="2100"/>
               </a:lnSpc>
               <a:buNone/>
             </a:pPr>
             <a:r>
-              <a:rPr lang="en-US" sz="1450" b="1" dirty="0">
+              <a:rPr lang="en-US" sz="1350" b="1" dirty="0">
                 <a:solidFill>
                   <a:srgbClr val="B23A34"/>
                 </a:solidFill>
@@ -14816,17 +14816,17 @@
               </a:rPr>
               <a:t>자기소개서 불성실 작성자</a:t>
             </a:r>
-            <a:endParaRPr lang="en-US" sz="1450" dirty="0"/>
+            <a:endParaRPr lang="en-US" sz="1350" dirty="0"/>
           </a:p>
           <a:p>
             <a:pPr eaLnBrk="0" latinLnBrk="0" indent="0" marL="0">
               <a:lnSpc>
-                <a:spcPts val="2200"/>
+                <a:spcPts val="2100"/>
               </a:lnSpc>
               <a:buNone/>
             </a:pPr>
             <a:r>
-              <a:rPr lang="en-US" sz="1450" b="1" dirty="0">
+              <a:rPr lang="en-US" sz="1350" b="1" dirty="0">
                 <a:solidFill>
                   <a:srgbClr val="B23A34"/>
                 </a:solidFill>
@@ -14836,7 +14836,7 @@
               </a:rPr>
               <a:t>탈락 기준</a:t>
             </a:r>
-            <a:endParaRPr lang="en-US" sz="1450" dirty="0"/>
+            <a:endParaRPr lang="en-US" sz="1350" dirty="0"/>
           </a:p>
         </p:txBody>
       </p:sp>
@@ -14848,8 +14848,8 @@
         </p:nvSpPr>
         <p:spPr>
           <a:xfrm>
-            <a:off x="5559552" y="2779776"/>
-            <a:ext cx="82296" cy="82296"/>
+            <a:off x="5541264" y="3209544"/>
+            <a:ext cx="73152" cy="73152"/>
           </a:xfrm>
           <a:prstGeom prst="ellipse">
             <a:avLst/>
@@ -14868,8 +14868,8 @@
         </p:nvSpPr>
         <p:spPr>
           <a:xfrm>
-            <a:off x="5760720" y="2688336"/>
-            <a:ext cx="2670048" cy="566928"/>
+            <a:off x="5724144" y="3127248"/>
+            <a:ext cx="2724912" cy="420624"/>
           </a:xfrm>
           <a:prstGeom prst="rect">
             <a:avLst/>
@@ -14883,12 +14883,12 @@
           <a:p>
             <a:pPr eaLnBrk="0" latinLnBrk="0" indent="0" marL="0">
               <a:lnSpc>
-                <a:spcPts val="1800"/>
+                <a:spcPts val="1600"/>
               </a:lnSpc>
               <a:buNone/>
             </a:pPr>
             <a:r>
-              <a:rPr lang="en-US" sz="1100" dirty="0">
+              <a:rPr lang="en-US" sz="1050" dirty="0">
                 <a:solidFill>
                   <a:srgbClr val="22263A"/>
                 </a:solidFill>
@@ -14898,7 +14898,7 @@
               </a:rPr>
               <a:t>문항과 전혀 무관한 내용을 작성</a:t>
             </a:r>
-            <a:endParaRPr lang="en-US" sz="1100" dirty="0"/>
+            <a:endParaRPr lang="en-US" sz="1050" dirty="0"/>
           </a:p>
         </p:txBody>
       </p:sp>
@@ -14910,8 +14910,8 @@
         </p:nvSpPr>
         <p:spPr>
           <a:xfrm>
-            <a:off x="5559552" y="3401568"/>
-            <a:ext cx="82296" cy="82296"/>
+            <a:off x="5541264" y="3666744"/>
+            <a:ext cx="73152" cy="73152"/>
           </a:xfrm>
           <a:prstGeom prst="ellipse">
             <a:avLst/>
@@ -14930,8 +14930,8 @@
         </p:nvSpPr>
         <p:spPr>
           <a:xfrm>
-            <a:off x="5760720" y="3310128"/>
-            <a:ext cx="2670048" cy="566928"/>
+            <a:off x="5724144" y="3584448"/>
+            <a:ext cx="2724912" cy="420624"/>
           </a:xfrm>
           <a:prstGeom prst="rect">
             <a:avLst/>
@@ -14945,12 +14945,12 @@
           <a:p>
             <a:pPr eaLnBrk="0" latinLnBrk="0" indent="0" marL="0">
               <a:lnSpc>
-                <a:spcPts val="1800"/>
+                <a:spcPts val="1600"/>
               </a:lnSpc>
               <a:buNone/>
             </a:pPr>
             <a:r>
-              <a:rPr lang="en-US" sz="1100" dirty="0">
+              <a:rPr lang="en-US" sz="1050" dirty="0">
                 <a:solidFill>
                   <a:srgbClr val="22263A"/>
                 </a:solidFill>
@@ -14960,7 +14960,7 @@
               </a:rPr>
               <a:t>동일 내용 반복 또는 문항별 50% 미만(약 400자) 작성한 경우</a:t>
             </a:r>
-            <a:endParaRPr lang="en-US" sz="1100" dirty="0"/>
+            <a:endParaRPr lang="en-US" sz="1050" dirty="0"/>
           </a:p>
         </p:txBody>
       </p:sp>
@@ -14972,8 +14972,8 @@
         </p:nvSpPr>
         <p:spPr>
           <a:xfrm>
-            <a:off x="5559552" y="4023360"/>
-            <a:ext cx="82296" cy="82296"/>
+            <a:off x="5541264" y="4123944"/>
+            <a:ext cx="73152" cy="73152"/>
           </a:xfrm>
           <a:prstGeom prst="ellipse">
             <a:avLst/>
@@ -14992,8 +14992,8 @@
         </p:nvSpPr>
         <p:spPr>
           <a:xfrm>
-            <a:off x="5760720" y="3931920"/>
-            <a:ext cx="2670048" cy="566928"/>
+            <a:off x="5724144" y="4041648"/>
+            <a:ext cx="2724912" cy="420624"/>
           </a:xfrm>
           <a:prstGeom prst="rect">
             <a:avLst/>
@@ -15007,12 +15007,12 @@
           <a:p>
             <a:pPr eaLnBrk="0" latinLnBrk="0" indent="0" marL="0">
               <a:lnSpc>
-                <a:spcPts val="1800"/>
+                <a:spcPts val="1600"/>
               </a:lnSpc>
               <a:buNone/>
             </a:pPr>
             <a:r>
-              <a:rPr lang="en-US" sz="1100" dirty="0">
+              <a:rPr lang="en-US" sz="1050" dirty="0">
                 <a:solidFill>
                   <a:srgbClr val="22263A"/>
                 </a:solidFill>
@@ -15022,7 +15022,7 @@
               </a:rPr>
               <a:t>채용 기관명을 오기재하여 제출한 경우 등</a:t>
             </a:r>
-            <a:endParaRPr lang="en-US" sz="1100" dirty="0"/>
+            <a:endParaRPr lang="en-US" sz="1050" dirty="0"/>
           </a:p>
         </p:txBody>
       </p:sp>
@@ -15524,7 +15524,7 @@
         </p:nvSpPr>
         <p:spPr>
           <a:xfrm>
-            <a:off x="457200" y="1700784"/>
+            <a:off x="457200" y="1664208"/>
             <a:ext cx="4937760" cy="256032"/>
           </a:xfrm>
           <a:prstGeom prst="rect">
@@ -15577,7 +15577,7 @@
         </p:nvSpPr>
         <p:spPr>
           <a:xfrm>
-            <a:off x="457200" y="1975104"/>
+            <a:off x="457200" y="1938528"/>
             <a:ext cx="4937760" cy="256032"/>
           </a:xfrm>
           <a:prstGeom prst="rect">
@@ -15637,7 +15637,7 @@
           </p:nvPr>
         </p:nvGraphicFramePr>
         <p:xfrm>
-          <a:off x="457200" y="2340864"/>
+          <a:off x="457200" y="2286000"/>
           <a:ext cx="4572000" cy="914400"/>
         </p:xfrm>
         <a:graphic>
@@ -15649,7 +15649,7 @@
                 <a:gridCol w="1143000"/>
                 <a:gridCol w="1143000"/>
               </a:tblGrid>
-              <a:tr h="329184">
+              <a:tr h="365760">
                 <a:tc>
                   <a:txBody>
                     <a:bodyPr/>
@@ -15855,7 +15855,7 @@
                   </a:tcPr>
                 </a:tc>
               </a:tr>
-              <a:tr h="347472">
+              <a:tr h="384048">
                 <a:tc>
                   <a:txBody>
                     <a:bodyPr/>
@@ -16076,7 +16076,7 @@
                   </a:tcPr>
                 </a:tc>
               </a:tr>
-              <a:tr h="347472">
+              <a:tr h="384048">
                 <a:tc>
                   <a:txBody>
                     <a:bodyPr/>
@@ -16211,7 +16211,7 @@
                   <a:tcPr/>
                 </a:tc>
               </a:tr>
-              <a:tr h="347472">
+              <a:tr h="384048">
                 <a:tc>
                   <a:txBody>
                     <a:bodyPr/>
@@ -16346,7 +16346,7 @@
                   <a:tcPr/>
                 </a:tc>
               </a:tr>
-              <a:tr h="347472">
+              <a:tr h="384048">
                 <a:tc>
                   <a:txBody>
                     <a:bodyPr/>
@@ -16481,7 +16481,7 @@
                   <a:tcPr/>
                 </a:tc>
               </a:tr>
-              <a:tr h="384048">
+              <a:tr h="420624">
                 <a:tc>
                   <a:txBody>
                     <a:bodyPr/>
@@ -16634,12 +16634,12 @@
         </p:nvSpPr>
         <p:spPr>
           <a:xfrm>
-            <a:off x="5303520" y="1700784"/>
-            <a:ext cx="3383280" cy="3877056"/>
+            <a:off x="5303520" y="2286000"/>
+            <a:ext cx="3383280" cy="3200400"/>
           </a:xfrm>
           <a:prstGeom prst="roundRect">
             <a:avLst>
-              <a:gd name="adj" fmla="val 1622"/>
+              <a:gd name="adj" fmla="val 1714"/>
             </a:avLst>
           </a:prstGeom>
           <a:solidFill>
@@ -16668,7 +16668,7 @@
         </p:nvSpPr>
         <p:spPr>
           <a:xfrm>
-            <a:off x="5541264" y="1901952"/>
+            <a:off x="5541264" y="2468880"/>
             <a:ext cx="2907792" cy="292608"/>
           </a:xfrm>
           <a:prstGeom prst="rect">
@@ -16706,8 +16706,8 @@
           <p:nvPr/>
         </p:nvGraphicFramePr>
         <p:xfrm>
-          <a:off x="5760720" y="2231136"/>
-          <a:ext cx="2468880" cy="1691640"/>
+          <a:off x="5760720" y="2761488"/>
+          <a:ext cx="2468880" cy="1371600"/>
         </p:xfrm>
         <a:graphic xmlns:a="http://schemas.openxmlformats.org/drawingml/2006/main">
           <a:graphicData uri="http://schemas.openxmlformats.org/drawingml/2006/chart">
@@ -16723,7 +16723,7 @@
         </p:nvSpPr>
         <p:spPr>
           <a:xfrm>
-            <a:off x="5669280" y="4114800"/>
+            <a:off x="5669280" y="4279392"/>
             <a:ext cx="164592" cy="164592"/>
           </a:xfrm>
           <a:prstGeom prst="roundRect">
@@ -16745,7 +16745,7 @@
         </p:nvSpPr>
         <p:spPr>
           <a:xfrm>
-            <a:off x="5943600" y="4041648"/>
+            <a:off x="5943600" y="4206240"/>
             <a:ext cx="1554480" cy="310896"/>
           </a:xfrm>
           <a:prstGeom prst="rect">
@@ -16784,7 +16784,7 @@
         </p:nvSpPr>
         <p:spPr>
           <a:xfrm>
-            <a:off x="7132320" y="4041648"/>
+            <a:off x="7132320" y="4206240"/>
             <a:ext cx="914400" cy="310896"/>
           </a:xfrm>
           <a:prstGeom prst="rect">
@@ -16823,7 +16823,7 @@
         </p:nvSpPr>
         <p:spPr>
           <a:xfrm>
-            <a:off x="5669280" y="4462272"/>
+            <a:off x="5669280" y="4590288"/>
             <a:ext cx="164592" cy="164592"/>
           </a:xfrm>
           <a:prstGeom prst="roundRect">
@@ -16845,7 +16845,7 @@
         </p:nvSpPr>
         <p:spPr>
           <a:xfrm>
-            <a:off x="5943600" y="4389120"/>
+            <a:off x="5943600" y="4517136"/>
             <a:ext cx="1554480" cy="310896"/>
           </a:xfrm>
           <a:prstGeom prst="rect">
@@ -16884,7 +16884,7 @@
         </p:nvSpPr>
         <p:spPr>
           <a:xfrm>
-            <a:off x="7132320" y="4389120"/>
+            <a:off x="7132320" y="4517136"/>
             <a:ext cx="914400" cy="310896"/>
           </a:xfrm>
           <a:prstGeom prst="rect">
@@ -16923,8 +16923,8 @@
         </p:nvSpPr>
         <p:spPr>
           <a:xfrm>
-            <a:off x="5541264" y="4828032"/>
-            <a:ext cx="2907792" cy="310896"/>
+            <a:off x="5541264" y="4846320"/>
+            <a:ext cx="2907792" cy="292608"/>
           </a:xfrm>
           <a:prstGeom prst="rect">
             <a:avLst/>
@@ -16940,7 +16940,7 @@
               <a:buNone/>
             </a:pPr>
             <a:r>
-              <a:rPr lang="en-US" sz="1300" b="1" dirty="0">
+              <a:rPr lang="en-US" sz="1250" b="1" dirty="0">
                 <a:solidFill>
                   <a:srgbClr val="1E2761"/>
                 </a:solidFill>
@@ -16950,7 +16950,7 @@
               </a:rPr>
               <a:t>1·2차 전형결과 합산 총 100점</a:t>
             </a:r>
-            <a:endParaRPr lang="en-US" sz="1300" dirty="0"/>
+            <a:endParaRPr lang="en-US" sz="1250" dirty="0"/>
           </a:p>
         </p:txBody>
       </p:sp>
@@ -16963,7 +16963,7 @@
         <p:spPr>
           <a:xfrm>
             <a:off x="5541264" y="5120640"/>
-            <a:ext cx="2907792" cy="402336"/>
+            <a:ext cx="2907792" cy="365760"/>
           </a:xfrm>
           <a:prstGeom prst="rect">
             <a:avLst/>
@@ -17516,18 +17516,57 @@
       </p:sp>
       <p:sp>
         <p:nvSpPr>
-          <p:cNvPr id="15" name="Shape 12"/>
+          <p:cNvPr id="15" name="Text 12"/>
+          <p:cNvSpPr txBox="1"/>
+          <p:nvPr/>
+        </p:nvSpPr>
+        <p:spPr>
+          <a:xfrm>
+            <a:off x="457200" y="2084832"/>
+            <a:ext cx="3108960" cy="292608"/>
+          </a:xfrm>
+          <a:prstGeom prst="rect">
+            <a:avLst/>
+          </a:prstGeom>
+          <a:noFill/>
+          <a:ln/>
+        </p:spPr>
+        <p:txBody>
+          <a:bodyPr wrap="square" lIns="0" tIns="0" rIns="0" bIns="0" rtlCol="0" anchor="ctr"/>
+          <a:lstStyle/>
+          <a:p>
+            <a:pPr eaLnBrk="0" latinLnBrk="0" indent="0" marL="0">
+              <a:buNone/>
+            </a:pPr>
+            <a:r>
+              <a:rPr lang="en-US" sz="1450" b="1" dirty="0">
+                <a:solidFill>
+                  <a:srgbClr val="1E2761"/>
+                </a:solidFill>
+                <a:latin typeface="맑은 고딕" pitchFamily="34" charset="0"/>
+                <a:ea typeface="맑은 고딕" pitchFamily="34" charset="-122"/>
+                <a:cs typeface="맑은 고딕" pitchFamily="34" charset="-120"/>
+              </a:rPr>
+              <a:t>채용신체검사</a:t>
+            </a:r>
+            <a:endParaRPr lang="en-US" sz="1450" dirty="0"/>
+          </a:p>
+        </p:txBody>
+      </p:sp>
+      <p:sp>
+        <p:nvSpPr>
+          <p:cNvPr id="16" name="Shape 13"/>
           <p:cNvSpPr/>
           <p:nvPr/>
         </p:nvSpPr>
         <p:spPr>
           <a:xfrm>
-            <a:off x="457200" y="2084832"/>
-            <a:ext cx="3108960" cy="2103120"/>
+            <a:off x="457200" y="2450592"/>
+            <a:ext cx="3108960" cy="1645920"/>
           </a:xfrm>
           <a:prstGeom prst="roundRect">
             <a:avLst>
-              <a:gd name="adj" fmla="val 2609"/>
+              <a:gd name="adj" fmla="val 3333"/>
             </a:avLst>
           </a:prstGeom>
           <a:solidFill>
@@ -17550,14 +17589,14 @@
       </p:sp>
       <p:sp>
         <p:nvSpPr>
-          <p:cNvPr id="16" name="Text 13"/>
-          <p:cNvSpPr txBox="1"/>
-          <p:nvPr/>
-        </p:nvSpPr>
-        <p:spPr>
-          <a:xfrm>
-            <a:off x="713232" y="2304288"/>
-            <a:ext cx="2596896" cy="329184"/>
+          <p:cNvPr id="17" name="Text 14"/>
+          <p:cNvSpPr txBox="1"/>
+          <p:nvPr/>
+        </p:nvSpPr>
+        <p:spPr>
+          <a:xfrm>
+            <a:off x="694944" y="2615184"/>
+            <a:ext cx="822960" cy="621792"/>
           </a:xfrm>
           <a:prstGeom prst="rect">
             <a:avLst/>
@@ -17573,45 +17612,6 @@
               <a:buNone/>
             </a:pPr>
             <a:r>
-              <a:rPr lang="en-US" sz="1600" b="1" dirty="0">
-                <a:solidFill>
-                  <a:srgbClr val="FFFFFF"/>
-                </a:solidFill>
-                <a:latin typeface="맑은 고딕" pitchFamily="34" charset="0"/>
-                <a:ea typeface="맑은 고딕" pitchFamily="34" charset="-122"/>
-                <a:cs typeface="맑은 고딕" pitchFamily="34" charset="-120"/>
-              </a:rPr>
-              <a:t>채용신체검사</a:t>
-            </a:r>
-            <a:endParaRPr lang="en-US" sz="1600" dirty="0"/>
-          </a:p>
-        </p:txBody>
-      </p:sp>
-      <p:sp>
-        <p:nvSpPr>
-          <p:cNvPr id="17" name="Text 14"/>
-          <p:cNvSpPr txBox="1"/>
-          <p:nvPr/>
-        </p:nvSpPr>
-        <p:spPr>
-          <a:xfrm>
-            <a:off x="713232" y="2798064"/>
-            <a:ext cx="822960" cy="585216"/>
-          </a:xfrm>
-          <a:prstGeom prst="rect">
-            <a:avLst/>
-          </a:prstGeom>
-          <a:noFill/>
-          <a:ln/>
-        </p:spPr>
-        <p:txBody>
-          <a:bodyPr wrap="square" lIns="0" tIns="0" rIns="0" bIns="0" rtlCol="0" anchor="ctr"/>
-          <a:lstStyle/>
-          <a:p>
-            <a:pPr eaLnBrk="0" latinLnBrk="0" indent="0" marL="0">
-              <a:buNone/>
-            </a:pPr>
-            <a:r>
               <a:rPr lang="en-US" sz="1050" b="1" dirty="0">
                 <a:solidFill>
                   <a:srgbClr val="CADCFC"/>
@@ -17634,8 +17634,8 @@
         </p:nvSpPr>
         <p:spPr>
           <a:xfrm>
-            <a:off x="1554480" y="2798064"/>
-            <a:ext cx="1755648" cy="585216"/>
+            <a:off x="1536192" y="2615184"/>
+            <a:ext cx="1792224" cy="621792"/>
           </a:xfrm>
           <a:prstGeom prst="rect">
             <a:avLst/>
@@ -17696,8 +17696,8 @@
         </p:nvSpPr>
         <p:spPr>
           <a:xfrm>
-            <a:off x="713232" y="3456432"/>
-            <a:ext cx="822960" cy="585216"/>
+            <a:off x="694944" y="3291840"/>
+            <a:ext cx="822960" cy="621792"/>
           </a:xfrm>
           <a:prstGeom prst="rect">
             <a:avLst/>
@@ -17735,8 +17735,8 @@
         </p:nvSpPr>
         <p:spPr>
           <a:xfrm>
-            <a:off x="1554480" y="3456432"/>
-            <a:ext cx="1755648" cy="585216"/>
+            <a:off x="1536192" y="3291840"/>
+            <a:ext cx="1792224" cy="621792"/>
           </a:xfrm>
           <a:prstGeom prst="rect">
             <a:avLst/>

</xml_diff>

<commit_message>
Match page 7's table to the chart card and dot its inner rules
- Row heights grow (data rows 0.42" -> 0.635", header 0.44", 합계 0.52")
  so the table spans 2.5"-6.0", exactly the chart card's extent
- The three rules between the four scoring rows are dashed, leaving the
  rule above 합계 solid so the total reads as separate. pptxgenjs 4.x
  cannot dash a table border, so those cell borders are set to none and
  redrawn as dashed line shapes over the table.

Co-Authored-By: Claude Opus 5 <noreply@anthropic.com>
Claude-Session: https://claude.ai/code/session_01GZfitk2JEKppZ4fGSDdghv
</commit_message>
<xml_diff>
--- a/docs/2027년_사무직원_채용계획안.pptx
+++ b/docs/2027년_사무직원_채용계획안.pptx
@@ -15649,7 +15649,7 @@
                 <a:gridCol w="1143000"/>
                 <a:gridCol w="1143000"/>
               </a:tblGrid>
-              <a:tr h="365760">
+              <a:tr h="402336">
                 <a:tc>
                   <a:txBody>
                     <a:bodyPr/>
@@ -15855,7 +15855,7 @@
                   </a:tcPr>
                 </a:tc>
               </a:tr>
-              <a:tr h="384048">
+              <a:tr h="580644">
                 <a:tc>
                   <a:txBody>
                     <a:bodyPr/>
@@ -15910,14 +15910,8 @@
                       <a:headEnd type="none" w="med" len="med"/>
                       <a:tailEnd type="none" w="med" len="med"/>
                     </a:lnT>
-                    <a:lnB w="12700" cap="flat" cmpd="sng" algn="ctr">
-                      <a:solidFill>
-                        <a:srgbClr val="C6CEE2"/>
-                      </a:solidFill>
-                      <a:prstDash val="solid"/>
-                      <a:round/>
-                      <a:headEnd type="none" w="med" len="med"/>
-                      <a:tailEnd type="none" w="med" len="med"/>
+                    <a:lnB w="0" cap="flat" cmpd="sng" algn="ctr">
+                      <a:noFill/>
                     </a:lnB>
                   </a:tcPr>
                 </a:tc>
@@ -15975,14 +15969,8 @@
                       <a:headEnd type="none" w="med" len="med"/>
                       <a:tailEnd type="none" w="med" len="med"/>
                     </a:lnT>
-                    <a:lnB w="12700" cap="flat" cmpd="sng" algn="ctr">
-                      <a:solidFill>
-                        <a:srgbClr val="C6CEE2"/>
-                      </a:solidFill>
-                      <a:prstDash val="solid"/>
-                      <a:round/>
-                      <a:headEnd type="none" w="med" len="med"/>
-                      <a:tailEnd type="none" w="med" len="med"/>
+                    <a:lnB w="0" cap="flat" cmpd="sng" algn="ctr">
+                      <a:noFill/>
                     </a:lnB>
                   </a:tcPr>
                 </a:tc>
@@ -16076,7 +16064,7 @@
                   </a:tcPr>
                 </a:tc>
               </a:tr>
-              <a:tr h="384048">
+              <a:tr h="580644">
                 <a:tc>
                   <a:txBody>
                     <a:bodyPr/>
@@ -16122,23 +16110,11 @@
                       <a:headEnd type="none" w="med" len="med"/>
                       <a:tailEnd type="none" w="med" len="med"/>
                     </a:lnR>
-                    <a:lnT w="12700" cap="flat" cmpd="sng" algn="ctr">
-                      <a:solidFill>
-                        <a:srgbClr val="C6CEE2"/>
-                      </a:solidFill>
-                      <a:prstDash val="solid"/>
-                      <a:round/>
-                      <a:headEnd type="none" w="med" len="med"/>
-                      <a:tailEnd type="none" w="med" len="med"/>
+                    <a:lnT w="0" cap="flat" cmpd="sng" algn="ctr">
+                      <a:noFill/>
                     </a:lnT>
-                    <a:lnB w="12700" cap="flat" cmpd="sng" algn="ctr">
-                      <a:solidFill>
-                        <a:srgbClr val="C6CEE2"/>
-                      </a:solidFill>
-                      <a:prstDash val="solid"/>
-                      <a:round/>
-                      <a:headEnd type="none" w="med" len="med"/>
-                      <a:tailEnd type="none" w="med" len="med"/>
+                    <a:lnB w="0" cap="flat" cmpd="sng" algn="ctr">
+                      <a:noFill/>
                     </a:lnB>
                   </a:tcPr>
                 </a:tc>
@@ -16187,23 +16163,11 @@
                       <a:headEnd type="none" w="med" len="med"/>
                       <a:tailEnd type="none" w="med" len="med"/>
                     </a:lnR>
-                    <a:lnT w="12700" cap="flat" cmpd="sng" algn="ctr">
-                      <a:solidFill>
-                        <a:srgbClr val="C6CEE2"/>
-                      </a:solidFill>
-                      <a:prstDash val="solid"/>
-                      <a:round/>
-                      <a:headEnd type="none" w="med" len="med"/>
-                      <a:tailEnd type="none" w="med" len="med"/>
+                    <a:lnT w="0" cap="flat" cmpd="sng" algn="ctr">
+                      <a:noFill/>
                     </a:lnT>
-                    <a:lnB w="12700" cap="flat" cmpd="sng" algn="ctr">
-                      <a:solidFill>
-                        <a:srgbClr val="C6CEE2"/>
-                      </a:solidFill>
-                      <a:prstDash val="solid"/>
-                      <a:round/>
-                      <a:headEnd type="none" w="med" len="med"/>
-                      <a:tailEnd type="none" w="med" len="med"/>
+                    <a:lnB w="0" cap="flat" cmpd="sng" algn="ctr">
+                      <a:noFill/>
                     </a:lnB>
                   </a:tcPr>
                 </a:tc>
@@ -16211,7 +16175,7 @@
                   <a:tcPr/>
                 </a:tc>
               </a:tr>
-              <a:tr h="384048">
+              <a:tr h="580644">
                 <a:tc>
                   <a:txBody>
                     <a:bodyPr/>
@@ -16257,23 +16221,11 @@
                       <a:headEnd type="none" w="med" len="med"/>
                       <a:tailEnd type="none" w="med" len="med"/>
                     </a:lnR>
-                    <a:lnT w="12700" cap="flat" cmpd="sng" algn="ctr">
-                      <a:solidFill>
-                        <a:srgbClr val="C6CEE2"/>
-                      </a:solidFill>
-                      <a:prstDash val="solid"/>
-                      <a:round/>
-                      <a:headEnd type="none" w="med" len="med"/>
-                      <a:tailEnd type="none" w="med" len="med"/>
+                    <a:lnT w="0" cap="flat" cmpd="sng" algn="ctr">
+                      <a:noFill/>
                     </a:lnT>
-                    <a:lnB w="12700" cap="flat" cmpd="sng" algn="ctr">
-                      <a:solidFill>
-                        <a:srgbClr val="C6CEE2"/>
-                      </a:solidFill>
-                      <a:prstDash val="solid"/>
-                      <a:round/>
-                      <a:headEnd type="none" w="med" len="med"/>
-                      <a:tailEnd type="none" w="med" len="med"/>
+                    <a:lnB w="0" cap="flat" cmpd="sng" algn="ctr">
+                      <a:noFill/>
                     </a:lnB>
                   </a:tcPr>
                 </a:tc>
@@ -16322,23 +16274,11 @@
                       <a:headEnd type="none" w="med" len="med"/>
                       <a:tailEnd type="none" w="med" len="med"/>
                     </a:lnR>
-                    <a:lnT w="12700" cap="flat" cmpd="sng" algn="ctr">
-                      <a:solidFill>
-                        <a:srgbClr val="C6CEE2"/>
-                      </a:solidFill>
-                      <a:prstDash val="solid"/>
-                      <a:round/>
-                      <a:headEnd type="none" w="med" len="med"/>
-                      <a:tailEnd type="none" w="med" len="med"/>
+                    <a:lnT w="0" cap="flat" cmpd="sng" algn="ctr">
+                      <a:noFill/>
                     </a:lnT>
-                    <a:lnB w="12700" cap="flat" cmpd="sng" algn="ctr">
-                      <a:solidFill>
-                        <a:srgbClr val="C6CEE2"/>
-                      </a:solidFill>
-                      <a:prstDash val="solid"/>
-                      <a:round/>
-                      <a:headEnd type="none" w="med" len="med"/>
-                      <a:tailEnd type="none" w="med" len="med"/>
+                    <a:lnB w="0" cap="flat" cmpd="sng" algn="ctr">
+                      <a:noFill/>
                     </a:lnB>
                   </a:tcPr>
                 </a:tc>
@@ -16346,7 +16286,7 @@
                   <a:tcPr/>
                 </a:tc>
               </a:tr>
-              <a:tr h="384048">
+              <a:tr h="580644">
                 <a:tc>
                   <a:txBody>
                     <a:bodyPr/>
@@ -16392,14 +16332,8 @@
                       <a:headEnd type="none" w="med" len="med"/>
                       <a:tailEnd type="none" w="med" len="med"/>
                     </a:lnR>
-                    <a:lnT w="12700" cap="flat" cmpd="sng" algn="ctr">
-                      <a:solidFill>
-                        <a:srgbClr val="C6CEE2"/>
-                      </a:solidFill>
-                      <a:prstDash val="solid"/>
-                      <a:round/>
-                      <a:headEnd type="none" w="med" len="med"/>
-                      <a:tailEnd type="none" w="med" len="med"/>
+                    <a:lnT w="0" cap="flat" cmpd="sng" algn="ctr">
+                      <a:noFill/>
                     </a:lnT>
                     <a:lnB w="12700" cap="flat" cmpd="sng" algn="ctr">
                       <a:solidFill>
@@ -16457,14 +16391,8 @@
                       <a:headEnd type="none" w="med" len="med"/>
                       <a:tailEnd type="none" w="med" len="med"/>
                     </a:lnR>
-                    <a:lnT w="12700" cap="flat" cmpd="sng" algn="ctr">
-                      <a:solidFill>
-                        <a:srgbClr val="C6CEE2"/>
-                      </a:solidFill>
-                      <a:prstDash val="solid"/>
-                      <a:round/>
-                      <a:headEnd type="none" w="med" len="med"/>
-                      <a:tailEnd type="none" w="med" len="med"/>
+                    <a:lnT w="0" cap="flat" cmpd="sng" algn="ctr">
+                      <a:noFill/>
                     </a:lnT>
                     <a:lnB w="12700" cap="flat" cmpd="sng" algn="ctr">
                       <a:solidFill>
@@ -16481,7 +16409,7 @@
                   <a:tcPr/>
                 </a:tc>
               </a:tr>
-              <a:tr h="420624">
+              <a:tr h="475488">
                 <a:tc>
                   <a:txBody>
                     <a:bodyPr/>
@@ -16634,6 +16562,75 @@
         </p:nvSpPr>
         <p:spPr>
           <a:xfrm>
+            <a:off x="457200" y="3268980"/>
+            <a:ext cx="3429000" cy="0"/>
+          </a:xfrm>
+          <a:prstGeom prst="line">
+            <a:avLst/>
+          </a:prstGeom>
+          <a:noFill/>
+          <a:ln w="12700">
+            <a:solidFill>
+              <a:srgbClr val="C6CEE2"/>
+            </a:solidFill>
+            <a:prstDash val="dash"/>
+          </a:ln>
+        </p:spPr>
+      </p:sp>
+      <p:sp>
+        <p:nvSpPr>
+          <p:cNvPr id="18" name="Shape 14"/>
+          <p:cNvSpPr/>
+          <p:nvPr/>
+        </p:nvSpPr>
+        <p:spPr>
+          <a:xfrm>
+            <a:off x="457200" y="3849624"/>
+            <a:ext cx="3429000" cy="0"/>
+          </a:xfrm>
+          <a:prstGeom prst="line">
+            <a:avLst/>
+          </a:prstGeom>
+          <a:noFill/>
+          <a:ln w="12700">
+            <a:solidFill>
+              <a:srgbClr val="C6CEE2"/>
+            </a:solidFill>
+            <a:prstDash val="dash"/>
+          </a:ln>
+        </p:spPr>
+      </p:sp>
+      <p:sp>
+        <p:nvSpPr>
+          <p:cNvPr id="19" name="Shape 15"/>
+          <p:cNvSpPr/>
+          <p:nvPr/>
+        </p:nvSpPr>
+        <p:spPr>
+          <a:xfrm>
+            <a:off x="457200" y="4430268"/>
+            <a:ext cx="3429000" cy="0"/>
+          </a:xfrm>
+          <a:prstGeom prst="line">
+            <a:avLst/>
+          </a:prstGeom>
+          <a:noFill/>
+          <a:ln w="12700">
+            <a:solidFill>
+              <a:srgbClr val="C6CEE2"/>
+            </a:solidFill>
+            <a:prstDash val="dash"/>
+          </a:ln>
+        </p:spPr>
+      </p:sp>
+      <p:sp>
+        <p:nvSpPr>
+          <p:cNvPr id="20" name="Shape 16"/>
+          <p:cNvSpPr/>
+          <p:nvPr/>
+        </p:nvSpPr>
+        <p:spPr>
+          <a:xfrm>
             <a:off x="5303520" y="2286000"/>
             <a:ext cx="3383280" cy="3200400"/>
           </a:xfrm>
@@ -16662,7 +16659,7 @@
       </p:sp>
       <p:sp>
         <p:nvSpPr>
-          <p:cNvPr id="18" name="Text 14"/>
+          <p:cNvPr id="21" name="Text 17"/>
           <p:cNvSpPr txBox="1"/>
           <p:nvPr/>
         </p:nvSpPr>
@@ -16701,7 +16698,7 @@
       </p:sp>
       <p:graphicFrame>
         <p:nvGraphicFramePr>
-          <p:cNvPr id="19" name="Chart 0" descr=""/>
+          <p:cNvPr id="22" name="Chart 0" descr=""/>
           <p:cNvGraphicFramePr/>
           <p:nvPr/>
         </p:nvGraphicFramePr>
@@ -16717,7 +16714,7 @@
       </p:graphicFrame>
       <p:sp>
         <p:nvSpPr>
-          <p:cNvPr id="20" name="Shape 15"/>
+          <p:cNvPr id="23" name="Shape 18"/>
           <p:cNvSpPr/>
           <p:nvPr/>
         </p:nvSpPr>
@@ -16739,7 +16736,7 @@
       </p:sp>
       <p:sp>
         <p:nvSpPr>
-          <p:cNvPr id="21" name="Text 16"/>
+          <p:cNvPr id="24" name="Text 19"/>
           <p:cNvSpPr txBox="1"/>
           <p:nvPr/>
         </p:nvSpPr>
@@ -16778,7 +16775,7 @@
       </p:sp>
       <p:sp>
         <p:nvSpPr>
-          <p:cNvPr id="22" name="Text 17"/>
+          <p:cNvPr id="25" name="Text 20"/>
           <p:cNvSpPr txBox="1"/>
           <p:nvPr/>
         </p:nvSpPr>
@@ -16817,7 +16814,7 @@
       </p:sp>
       <p:sp>
         <p:nvSpPr>
-          <p:cNvPr id="23" name="Shape 18"/>
+          <p:cNvPr id="26" name="Shape 21"/>
           <p:cNvSpPr/>
           <p:nvPr/>
         </p:nvSpPr>
@@ -16839,7 +16836,7 @@
       </p:sp>
       <p:sp>
         <p:nvSpPr>
-          <p:cNvPr id="24" name="Text 19"/>
+          <p:cNvPr id="27" name="Text 22"/>
           <p:cNvSpPr txBox="1"/>
           <p:nvPr/>
         </p:nvSpPr>
@@ -16878,7 +16875,7 @@
       </p:sp>
       <p:sp>
         <p:nvSpPr>
-          <p:cNvPr id="25" name="Text 20"/>
+          <p:cNvPr id="28" name="Text 23"/>
           <p:cNvSpPr txBox="1"/>
           <p:nvPr/>
         </p:nvSpPr>
@@ -16917,7 +16914,7 @@
       </p:sp>
       <p:sp>
         <p:nvSpPr>
-          <p:cNvPr id="26" name="Text 21"/>
+          <p:cNvPr id="29" name="Text 24"/>
           <p:cNvSpPr txBox="1"/>
           <p:nvPr/>
         </p:nvSpPr>
@@ -16956,7 +16953,7 @@
       </p:sp>
       <p:sp>
         <p:nvSpPr>
-          <p:cNvPr id="27" name="Text 22"/>
+          <p:cNvPr id="30" name="Text 25"/>
           <p:cNvSpPr txBox="1"/>
           <p:nvPr/>
         </p:nvSpPr>

</xml_diff>

<commit_message>
Dot the inner rules on page 6's score table too
Same treatment as page 7, so the two score tables read alike: the three
rules between the four scoring rows are dashed and the rule above 합계
stays solid. Row heights are unchanged here, since page 6's right-hand
card is short enough to already line up.

Co-Authored-By: Claude Opus 5 <noreply@anthropic.com>
Claude-Session: https://claude.ai/code/session_01GZfitk2JEKppZ4fGSDdghv
</commit_message>
<xml_diff>
--- a/docs/2027년_사무직원_채용계획안.pptx
+++ b/docs/2027년_사무직원_채용계획안.pptx
@@ -14028,14 +14028,8 @@
                       <a:headEnd type="none" w="med" len="med"/>
                       <a:tailEnd type="none" w="med" len="med"/>
                     </a:lnT>
-                    <a:lnB w="12700" cap="flat" cmpd="sng" algn="ctr">
-                      <a:solidFill>
-                        <a:srgbClr val="C6CEE2"/>
-                      </a:solidFill>
-                      <a:prstDash val="solid"/>
-                      <a:round/>
-                      <a:headEnd type="none" w="med" len="med"/>
-                      <a:tailEnd type="none" w="med" len="med"/>
+                    <a:lnB w="0" cap="flat" cmpd="sng" algn="ctr">
+                      <a:noFill/>
                     </a:lnB>
                   </a:tcPr>
                 </a:tc>
@@ -14093,14 +14087,8 @@
                       <a:headEnd type="none" w="med" len="med"/>
                       <a:tailEnd type="none" w="med" len="med"/>
                     </a:lnT>
-                    <a:lnB w="12700" cap="flat" cmpd="sng" algn="ctr">
-                      <a:solidFill>
-                        <a:srgbClr val="C6CEE2"/>
-                      </a:solidFill>
-                      <a:prstDash val="solid"/>
-                      <a:round/>
-                      <a:headEnd type="none" w="med" len="med"/>
-                      <a:tailEnd type="none" w="med" len="med"/>
+                    <a:lnB w="0" cap="flat" cmpd="sng" algn="ctr">
+                      <a:noFill/>
                     </a:lnB>
                   </a:tcPr>
                 </a:tc>
@@ -14240,23 +14228,11 @@
                       <a:headEnd type="none" w="med" len="med"/>
                       <a:tailEnd type="none" w="med" len="med"/>
                     </a:lnR>
-                    <a:lnT w="12700" cap="flat" cmpd="sng" algn="ctr">
-                      <a:solidFill>
-                        <a:srgbClr val="C6CEE2"/>
-                      </a:solidFill>
-                      <a:prstDash val="solid"/>
-                      <a:round/>
-                      <a:headEnd type="none" w="med" len="med"/>
-                      <a:tailEnd type="none" w="med" len="med"/>
+                    <a:lnT w="0" cap="flat" cmpd="sng" algn="ctr">
+                      <a:noFill/>
                     </a:lnT>
-                    <a:lnB w="12700" cap="flat" cmpd="sng" algn="ctr">
-                      <a:solidFill>
-                        <a:srgbClr val="C6CEE2"/>
-                      </a:solidFill>
-                      <a:prstDash val="solid"/>
-                      <a:round/>
-                      <a:headEnd type="none" w="med" len="med"/>
-                      <a:tailEnd type="none" w="med" len="med"/>
+                    <a:lnB w="0" cap="flat" cmpd="sng" algn="ctr">
+                      <a:noFill/>
                     </a:lnB>
                   </a:tcPr>
                 </a:tc>
@@ -14305,23 +14281,11 @@
                       <a:headEnd type="none" w="med" len="med"/>
                       <a:tailEnd type="none" w="med" len="med"/>
                     </a:lnR>
-                    <a:lnT w="12700" cap="flat" cmpd="sng" algn="ctr">
-                      <a:solidFill>
-                        <a:srgbClr val="C6CEE2"/>
-                      </a:solidFill>
-                      <a:prstDash val="solid"/>
-                      <a:round/>
-                      <a:headEnd type="none" w="med" len="med"/>
-                      <a:tailEnd type="none" w="med" len="med"/>
+                    <a:lnT w="0" cap="flat" cmpd="sng" algn="ctr">
+                      <a:noFill/>
                     </a:lnT>
-                    <a:lnB w="12700" cap="flat" cmpd="sng" algn="ctr">
-                      <a:solidFill>
-                        <a:srgbClr val="C6CEE2"/>
-                      </a:solidFill>
-                      <a:prstDash val="solid"/>
-                      <a:round/>
-                      <a:headEnd type="none" w="med" len="med"/>
-                      <a:tailEnd type="none" w="med" len="med"/>
+                    <a:lnB w="0" cap="flat" cmpd="sng" algn="ctr">
+                      <a:noFill/>
                     </a:lnB>
                   </a:tcPr>
                 </a:tc>
@@ -14375,23 +14339,11 @@
                       <a:headEnd type="none" w="med" len="med"/>
                       <a:tailEnd type="none" w="med" len="med"/>
                     </a:lnR>
-                    <a:lnT w="12700" cap="flat" cmpd="sng" algn="ctr">
-                      <a:solidFill>
-                        <a:srgbClr val="C6CEE2"/>
-                      </a:solidFill>
-                      <a:prstDash val="solid"/>
-                      <a:round/>
-                      <a:headEnd type="none" w="med" len="med"/>
-                      <a:tailEnd type="none" w="med" len="med"/>
+                    <a:lnT w="0" cap="flat" cmpd="sng" algn="ctr">
+                      <a:noFill/>
                     </a:lnT>
-                    <a:lnB w="12700" cap="flat" cmpd="sng" algn="ctr">
-                      <a:solidFill>
-                        <a:srgbClr val="C6CEE2"/>
-                      </a:solidFill>
-                      <a:prstDash val="solid"/>
-                      <a:round/>
-                      <a:headEnd type="none" w="med" len="med"/>
-                      <a:tailEnd type="none" w="med" len="med"/>
+                    <a:lnB w="0" cap="flat" cmpd="sng" algn="ctr">
+                      <a:noFill/>
                     </a:lnB>
                   </a:tcPr>
                 </a:tc>
@@ -14440,23 +14392,11 @@
                       <a:headEnd type="none" w="med" len="med"/>
                       <a:tailEnd type="none" w="med" len="med"/>
                     </a:lnR>
-                    <a:lnT w="12700" cap="flat" cmpd="sng" algn="ctr">
-                      <a:solidFill>
-                        <a:srgbClr val="C6CEE2"/>
-                      </a:solidFill>
-                      <a:prstDash val="solid"/>
-                      <a:round/>
-                      <a:headEnd type="none" w="med" len="med"/>
-                      <a:tailEnd type="none" w="med" len="med"/>
+                    <a:lnT w="0" cap="flat" cmpd="sng" algn="ctr">
+                      <a:noFill/>
                     </a:lnT>
-                    <a:lnB w="12700" cap="flat" cmpd="sng" algn="ctr">
-                      <a:solidFill>
-                        <a:srgbClr val="C6CEE2"/>
-                      </a:solidFill>
-                      <a:prstDash val="solid"/>
-                      <a:round/>
-                      <a:headEnd type="none" w="med" len="med"/>
-                      <a:tailEnd type="none" w="med" len="med"/>
+                    <a:lnB w="0" cap="flat" cmpd="sng" algn="ctr">
+                      <a:noFill/>
                     </a:lnB>
                   </a:tcPr>
                 </a:tc>
@@ -14510,14 +14450,8 @@
                       <a:headEnd type="none" w="med" len="med"/>
                       <a:tailEnd type="none" w="med" len="med"/>
                     </a:lnR>
-                    <a:lnT w="12700" cap="flat" cmpd="sng" algn="ctr">
-                      <a:solidFill>
-                        <a:srgbClr val="C6CEE2"/>
-                      </a:solidFill>
-                      <a:prstDash val="solid"/>
-                      <a:round/>
-                      <a:headEnd type="none" w="med" len="med"/>
-                      <a:tailEnd type="none" w="med" len="med"/>
+                    <a:lnT w="0" cap="flat" cmpd="sng" algn="ctr">
+                      <a:noFill/>
                     </a:lnT>
                     <a:lnB w="12700" cap="flat" cmpd="sng" algn="ctr">
                       <a:solidFill>
@@ -14575,14 +14509,8 @@
                       <a:headEnd type="none" w="med" len="med"/>
                       <a:tailEnd type="none" w="med" len="med"/>
                     </a:lnR>
-                    <a:lnT w="12700" cap="flat" cmpd="sng" algn="ctr">
-                      <a:solidFill>
-                        <a:srgbClr val="C6CEE2"/>
-                      </a:solidFill>
-                      <a:prstDash val="solid"/>
-                      <a:round/>
-                      <a:headEnd type="none" w="med" len="med"/>
-                      <a:tailEnd type="none" w="med" len="med"/>
+                    <a:lnT w="0" cap="flat" cmpd="sng" algn="ctr">
+                      <a:noFill/>
                     </a:lnT>
                     <a:lnB w="12700" cap="flat" cmpd="sng" algn="ctr">
                       <a:solidFill>
@@ -14752,6 +14680,75 @@
         </p:nvSpPr>
         <p:spPr>
           <a:xfrm>
+            <a:off x="457200" y="3035808"/>
+            <a:ext cx="3429000" cy="0"/>
+          </a:xfrm>
+          <a:prstGeom prst="line">
+            <a:avLst/>
+          </a:prstGeom>
+          <a:noFill/>
+          <a:ln w="12700">
+            <a:solidFill>
+              <a:srgbClr val="C6CEE2"/>
+            </a:solidFill>
+            <a:prstDash val="dash"/>
+          </a:ln>
+        </p:spPr>
+      </p:sp>
+      <p:sp>
+        <p:nvSpPr>
+          <p:cNvPr id="18" name="Shape 14"/>
+          <p:cNvSpPr/>
+          <p:nvPr/>
+        </p:nvSpPr>
+        <p:spPr>
+          <a:xfrm>
+            <a:off x="457200" y="3419856"/>
+            <a:ext cx="3429000" cy="0"/>
+          </a:xfrm>
+          <a:prstGeom prst="line">
+            <a:avLst/>
+          </a:prstGeom>
+          <a:noFill/>
+          <a:ln w="12700">
+            <a:solidFill>
+              <a:srgbClr val="C6CEE2"/>
+            </a:solidFill>
+            <a:prstDash val="dash"/>
+          </a:ln>
+        </p:spPr>
+      </p:sp>
+      <p:sp>
+        <p:nvSpPr>
+          <p:cNvPr id="19" name="Shape 15"/>
+          <p:cNvSpPr/>
+          <p:nvPr/>
+        </p:nvSpPr>
+        <p:spPr>
+          <a:xfrm>
+            <a:off x="457200" y="3803904"/>
+            <a:ext cx="3429000" cy="0"/>
+          </a:xfrm>
+          <a:prstGeom prst="line">
+            <a:avLst/>
+          </a:prstGeom>
+          <a:noFill/>
+          <a:ln w="12700">
+            <a:solidFill>
+              <a:srgbClr val="C6CEE2"/>
+            </a:solidFill>
+            <a:prstDash val="dash"/>
+          </a:ln>
+        </p:spPr>
+      </p:sp>
+      <p:sp>
+        <p:nvSpPr>
+          <p:cNvPr id="20" name="Shape 16"/>
+          <p:cNvSpPr/>
+          <p:nvPr/>
+        </p:nvSpPr>
+        <p:spPr>
+          <a:xfrm>
             <a:off x="5303520" y="2286000"/>
             <a:ext cx="3383280" cy="2322576"/>
           </a:xfrm>
@@ -14780,7 +14777,7 @@
       </p:sp>
       <p:sp>
         <p:nvSpPr>
-          <p:cNvPr id="18" name="Text 14"/>
+          <p:cNvPr id="21" name="Text 17"/>
           <p:cNvSpPr txBox="1"/>
           <p:nvPr/>
         </p:nvSpPr>
@@ -14842,7 +14839,7 @@
       </p:sp>
       <p:sp>
         <p:nvSpPr>
-          <p:cNvPr id="19" name="Shape 15"/>
+          <p:cNvPr id="22" name="Shape 18"/>
           <p:cNvSpPr/>
           <p:nvPr/>
         </p:nvSpPr>
@@ -14862,7 +14859,7 @@
       </p:sp>
       <p:sp>
         <p:nvSpPr>
-          <p:cNvPr id="20" name="Text 16"/>
+          <p:cNvPr id="23" name="Text 19"/>
           <p:cNvSpPr txBox="1"/>
           <p:nvPr/>
         </p:nvSpPr>
@@ -14904,7 +14901,7 @@
       </p:sp>
       <p:sp>
         <p:nvSpPr>
-          <p:cNvPr id="21" name="Shape 17"/>
+          <p:cNvPr id="24" name="Shape 20"/>
           <p:cNvSpPr/>
           <p:nvPr/>
         </p:nvSpPr>
@@ -14924,7 +14921,7 @@
       </p:sp>
       <p:sp>
         <p:nvSpPr>
-          <p:cNvPr id="22" name="Text 18"/>
+          <p:cNvPr id="25" name="Text 21"/>
           <p:cNvSpPr txBox="1"/>
           <p:nvPr/>
         </p:nvSpPr>
@@ -14966,7 +14963,7 @@
       </p:sp>
       <p:sp>
         <p:nvSpPr>
-          <p:cNvPr id="23" name="Shape 19"/>
+          <p:cNvPr id="26" name="Shape 22"/>
           <p:cNvSpPr/>
           <p:nvPr/>
         </p:nvSpPr>
@@ -14986,7 +14983,7 @@
       </p:sp>
       <p:sp>
         <p:nvSpPr>
-          <p:cNvPr id="24" name="Text 20"/>
+          <p:cNvPr id="27" name="Text 23"/>
           <p:cNvSpPr txBox="1"/>
           <p:nvPr/>
         </p:nvSpPr>
@@ -15028,7 +15025,7 @@
       </p:sp>
       <p:sp>
         <p:nvSpPr>
-          <p:cNvPr id="25" name="Shape 21"/>
+          <p:cNvPr id="28" name="Shape 24"/>
           <p:cNvSpPr/>
           <p:nvPr/>
         </p:nvSpPr>
@@ -15062,7 +15059,7 @@
       </p:sp>
       <p:sp>
         <p:nvSpPr>
-          <p:cNvPr id="26" name="Text 22"/>
+          <p:cNvPr id="29" name="Text 25"/>
           <p:cNvSpPr txBox="1"/>
           <p:nvPr/>
         </p:nvSpPr>

</xml_diff>

<commit_message>
Carry over the reference deck's title bands
The reference's sky-blue bands live on its slide master, so the first
pass missed them and left the titles as black text on white. Adds them
at the theme's accent3, 4FADD1:

- Content slides: a 0.78" band across the top with the title reversed
  to white, plus a 0.26" strip along the foot
- Cover: thin strips top and bottom, and the 2.11" band the title sits
  centred in, with the reference's soft text shadow

Co-Authored-By: Claude Opus 5 <noreply@anthropic.com>
Claude-Session: https://claude.ai/code/session_01GZfitk2JEKppZ4fGSDdghv
</commit_message>
<xml_diff>
--- a/docs/2027년_사무직원_채용계획안.pptx
+++ b/docs/2027년_사무직원_채용계획안.pptx
@@ -1767,20 +1767,102 @@
       </p:grpSpPr>
       <p:sp>
         <p:nvSpPr>
-          <p:cNvPr id="2" name="Text 0"/>
+          <p:cNvPr id="2" name="Shape 0"/>
+          <p:cNvSpPr/>
+          <p:nvPr/>
+        </p:nvSpPr>
+        <p:spPr>
+          <a:xfrm>
+            <a:off x="0" y="6620256"/>
+            <a:ext cx="9144000" cy="237744"/>
+          </a:xfrm>
+          <a:prstGeom prst="rect">
+            <a:avLst/>
+          </a:prstGeom>
+          <a:solidFill>
+            <a:srgbClr val="4FADD1"/>
+          </a:solidFill>
+          <a:ln w="6350">
+            <a:solidFill>
+              <a:srgbClr val="4FADD1"/>
+            </a:solidFill>
+            <a:prstDash val="solid"/>
+          </a:ln>
+        </p:spPr>
+      </p:sp>
+      <p:sp>
+        <p:nvSpPr>
+          <p:cNvPr id="3" name="Shape 1"/>
+          <p:cNvSpPr/>
+          <p:nvPr/>
+        </p:nvSpPr>
+        <p:spPr>
+          <a:xfrm>
+            <a:off x="0" y="0"/>
+            <a:ext cx="9144000" cy="237744"/>
+          </a:xfrm>
+          <a:prstGeom prst="rect">
+            <a:avLst/>
+          </a:prstGeom>
+          <a:solidFill>
+            <a:srgbClr val="4FADD1"/>
+          </a:solidFill>
+          <a:ln w="6350">
+            <a:solidFill>
+              <a:srgbClr val="4FADD1"/>
+            </a:solidFill>
+            <a:prstDash val="solid"/>
+          </a:ln>
+        </p:spPr>
+      </p:sp>
+      <p:sp>
+        <p:nvSpPr>
+          <p:cNvPr id="4" name="Shape 2"/>
+          <p:cNvSpPr/>
+          <p:nvPr/>
+        </p:nvSpPr>
+        <p:spPr>
+          <a:xfrm>
+            <a:off x="0" y="1929384"/>
+            <a:ext cx="9144000" cy="1929384"/>
+          </a:xfrm>
+          <a:prstGeom prst="rect">
+            <a:avLst/>
+          </a:prstGeom>
+          <a:solidFill>
+            <a:srgbClr val="4FADD1"/>
+          </a:solidFill>
+          <a:ln w="6350">
+            <a:solidFill>
+              <a:srgbClr val="4FADD1"/>
+            </a:solidFill>
+            <a:prstDash val="solid"/>
+          </a:ln>
+        </p:spPr>
+      </p:sp>
+      <p:sp>
+        <p:nvSpPr>
+          <p:cNvPr id="5" name="Text 3"/>
           <p:cNvSpPr txBox="1"/>
           <p:nvPr/>
         </p:nvSpPr>
         <p:spPr>
           <a:xfrm>
-            <a:off x="457200" y="2286000"/>
-            <a:ext cx="8229600" cy="731520"/>
+            <a:off x="457200" y="1929384"/>
+            <a:ext cx="8229600" cy="1929384"/>
           </a:xfrm>
           <a:prstGeom prst="rect">
             <a:avLst/>
           </a:prstGeom>
           <a:noFill/>
           <a:ln/>
+          <a:effectLst>
+            <a:outerShdw sx="100000" sy="100000" kx="0" ky="0" algn="bl" rotWithShape="0" blurRad="38100" dist="38100" dir="2700000">
+              <a:srgbClr val="000000">
+                <a:alpha val="43000"/>
+              </a:srgbClr>
+            </a:outerShdw>
+          </a:effectLst>
         </p:spPr>
         <p:txBody>
           <a:bodyPr wrap="square" lIns="0" tIns="0" rIns="0" bIns="0" rtlCol="0" anchor="ctr"/>
@@ -1806,13 +1888,13 @@
       </p:sp>
       <p:sp>
         <p:nvSpPr>
-          <p:cNvPr id="3" name="Text 1"/>
+          <p:cNvPr id="6" name="Text 4"/>
           <p:cNvSpPr txBox="1"/>
           <p:nvPr/>
         </p:nvSpPr>
         <p:spPr>
           <a:xfrm>
-            <a:off x="457200" y="3310128"/>
+            <a:off x="457200" y="4261104"/>
             <a:ext cx="8229600" cy="365760"/>
           </a:xfrm>
           <a:prstGeom prst="rect">
@@ -1845,7 +1927,7 @@
       </p:sp>
       <p:pic>
         <p:nvPicPr>
-          <p:cNvPr id="4" name="Image 0" descr="정석항공과학고등학교 엠블럼">    </p:cNvPr>
+          <p:cNvPr id="7" name="Image 0" descr="정석항공과학고등학교 엠블럼">    </p:cNvPr>
           <p:cNvPicPr>
             <a:picLocks noChangeAspect="1"/>
           </p:cNvPicPr>
@@ -1859,7 +1941,7 @@
         </p:blipFill>
         <p:spPr>
           <a:xfrm>
-            <a:off x="2999232" y="4736592"/>
+            <a:off x="2999232" y="5175504"/>
             <a:ext cx="658368" cy="658368"/>
           </a:xfrm>
           <a:prstGeom prst="rect">
@@ -1869,13 +1951,13 @@
       </p:pic>
       <p:sp>
         <p:nvSpPr>
-          <p:cNvPr id="5" name="Text 2"/>
+          <p:cNvPr id="8" name="Text 5"/>
           <p:cNvSpPr txBox="1"/>
           <p:nvPr/>
         </p:nvSpPr>
         <p:spPr>
           <a:xfrm>
-            <a:off x="3785616" y="4736592"/>
+            <a:off x="3785616" y="5175504"/>
             <a:ext cx="2377440" cy="658368"/>
           </a:xfrm>
           <a:prstGeom prst="rect">
@@ -1938,9 +2020,59 @@
           <a:chExt cx="0" cy="0"/>
         </a:xfrm>
       </p:grpSpPr>
+      <p:sp>
+        <p:nvSpPr>
+          <p:cNvPr id="2" name="Shape 0"/>
+          <p:cNvSpPr/>
+          <p:nvPr/>
+        </p:nvSpPr>
+        <p:spPr>
+          <a:xfrm>
+            <a:off x="0" y="6620256"/>
+            <a:ext cx="9144000" cy="237744"/>
+          </a:xfrm>
+          <a:prstGeom prst="rect">
+            <a:avLst/>
+          </a:prstGeom>
+          <a:solidFill>
+            <a:srgbClr val="4FADD1"/>
+          </a:solidFill>
+          <a:ln w="6350">
+            <a:solidFill>
+              <a:srgbClr val="4FADD1"/>
+            </a:solidFill>
+            <a:prstDash val="solid"/>
+          </a:ln>
+        </p:spPr>
+      </p:sp>
+      <p:sp>
+        <p:nvSpPr>
+          <p:cNvPr id="3" name="Shape 1"/>
+          <p:cNvSpPr/>
+          <p:nvPr/>
+        </p:nvSpPr>
+        <p:spPr>
+          <a:xfrm>
+            <a:off x="0" y="0"/>
+            <a:ext cx="9144000" cy="713232"/>
+          </a:xfrm>
+          <a:prstGeom prst="rect">
+            <a:avLst/>
+          </a:prstGeom>
+          <a:solidFill>
+            <a:srgbClr val="4FADD1"/>
+          </a:solidFill>
+          <a:ln w="6350">
+            <a:solidFill>
+              <a:srgbClr val="4FADD1"/>
+            </a:solidFill>
+            <a:prstDash val="solid"/>
+          </a:ln>
+        </p:spPr>
+      </p:sp>
       <p:pic>
         <p:nvPicPr>
-          <p:cNvPr id="2" name="Image 0" descr="정석항공과학고등학교 교표">    </p:cNvPr>
+          <p:cNvPr id="4" name="Image 0" descr="정석항공과학고등학교 교표">    </p:cNvPr>
           <p:cNvPicPr>
             <a:picLocks noChangeAspect="1"/>
           </p:cNvPicPr>
@@ -1954,7 +2086,7 @@
         </p:blipFill>
         <p:spPr>
           <a:xfrm>
-            <a:off x="7973568" y="256032"/>
+            <a:off x="7973568" y="201168"/>
             <a:ext cx="713232" cy="305410"/>
           </a:xfrm>
           <a:prstGeom prst="rect">
@@ -1964,13 +2096,13 @@
       </p:pic>
       <p:sp>
         <p:nvSpPr>
-          <p:cNvPr id="3" name="Text 0"/>
+          <p:cNvPr id="5" name="Text 2"/>
           <p:cNvSpPr txBox="1"/>
           <p:nvPr/>
         </p:nvSpPr>
         <p:spPr>
           <a:xfrm>
-            <a:off x="3657600" y="6345936"/>
+            <a:off x="3657600" y="6291072"/>
             <a:ext cx="1828800" cy="274320"/>
           </a:xfrm>
           <a:prstGeom prst="rect">
@@ -2003,13 +2135,13 @@
       </p:sp>
       <p:sp>
         <p:nvSpPr>
-          <p:cNvPr id="4" name="Text 1"/>
+          <p:cNvPr id="6" name="Text 3"/>
           <p:cNvSpPr txBox="1"/>
           <p:nvPr/>
         </p:nvSpPr>
         <p:spPr>
           <a:xfrm>
-            <a:off x="457200" y="237744"/>
+            <a:off x="457200" y="82296"/>
             <a:ext cx="7132320" cy="548640"/>
           </a:xfrm>
           <a:prstGeom prst="rect">
@@ -2026,9 +2158,9 @@
               <a:buNone/>
             </a:pPr>
             <a:r>
-              <a:rPr lang="en-US" sz="2800" dirty="0">
+              <a:rPr lang="en-US" sz="2600" dirty="0">
                 <a:solidFill>
-                  <a:srgbClr val="000000"/>
+                  <a:srgbClr val="FFFFFF"/>
                 </a:solidFill>
                 <a:latin typeface="HY헤드라인M" pitchFamily="34" charset="0"/>
                 <a:ea typeface="HY헤드라인M" pitchFamily="34" charset="-122"/>
@@ -2036,13 +2168,13 @@
               </a:rPr>
               <a:t>9. 기타 사항</a:t>
             </a:r>
-            <a:endParaRPr lang="en-US" sz="2800" dirty="0"/>
+            <a:endParaRPr lang="en-US" sz="2600" dirty="0"/>
           </a:p>
         </p:txBody>
       </p:sp>
       <p:sp>
         <p:nvSpPr>
-          <p:cNvPr id="5" name="Text 2"/>
+          <p:cNvPr id="7" name="Text 4"/>
           <p:cNvSpPr txBox="1"/>
           <p:nvPr/>
         </p:nvSpPr>
@@ -2081,7 +2213,7 @@
       </p:sp>
       <p:sp>
         <p:nvSpPr>
-          <p:cNvPr id="6" name="Text 3"/>
+          <p:cNvPr id="8" name="Text 5"/>
           <p:cNvSpPr txBox="1"/>
           <p:nvPr/>
         </p:nvSpPr>
@@ -2120,7 +2252,7 @@
       </p:sp>
       <p:sp>
         <p:nvSpPr>
-          <p:cNvPr id="7" name="Text 4"/>
+          <p:cNvPr id="9" name="Text 6"/>
           <p:cNvSpPr txBox="1"/>
           <p:nvPr/>
         </p:nvSpPr>
@@ -2162,7 +2294,7 @@
       </p:sp>
       <p:sp>
         <p:nvSpPr>
-          <p:cNvPr id="8" name="Text 5"/>
+          <p:cNvPr id="10" name="Text 7"/>
           <p:cNvSpPr txBox="1"/>
           <p:nvPr/>
         </p:nvSpPr>
@@ -2201,7 +2333,7 @@
       </p:sp>
       <p:sp>
         <p:nvSpPr>
-          <p:cNvPr id="9" name="Text 6"/>
+          <p:cNvPr id="11" name="Text 8"/>
           <p:cNvSpPr txBox="1"/>
           <p:nvPr/>
         </p:nvSpPr>
@@ -2243,7 +2375,7 @@
       </p:sp>
       <p:sp>
         <p:nvSpPr>
-          <p:cNvPr id="10" name="Text 7"/>
+          <p:cNvPr id="12" name="Text 9"/>
           <p:cNvSpPr txBox="1"/>
           <p:nvPr/>
         </p:nvSpPr>
@@ -2282,7 +2414,7 @@
       </p:sp>
       <p:sp>
         <p:nvSpPr>
-          <p:cNvPr id="11" name="Text 8"/>
+          <p:cNvPr id="13" name="Text 10"/>
           <p:cNvSpPr txBox="1"/>
           <p:nvPr/>
         </p:nvSpPr>
@@ -2321,7 +2453,7 @@
       </p:sp>
       <p:sp>
         <p:nvSpPr>
-          <p:cNvPr id="12" name="Text 9"/>
+          <p:cNvPr id="14" name="Text 11"/>
           <p:cNvSpPr txBox="1"/>
           <p:nvPr/>
         </p:nvSpPr>
@@ -2363,7 +2495,7 @@
       </p:sp>
       <p:sp>
         <p:nvSpPr>
-          <p:cNvPr id="13" name="Text 10"/>
+          <p:cNvPr id="15" name="Text 12"/>
           <p:cNvSpPr txBox="1"/>
           <p:nvPr/>
         </p:nvSpPr>
@@ -2402,7 +2534,7 @@
       </p:sp>
       <p:sp>
         <p:nvSpPr>
-          <p:cNvPr id="14" name="Text 11"/>
+          <p:cNvPr id="16" name="Text 13"/>
           <p:cNvSpPr txBox="1"/>
           <p:nvPr/>
         </p:nvSpPr>
@@ -2441,7 +2573,7 @@
       </p:sp>
       <p:sp>
         <p:nvSpPr>
-          <p:cNvPr id="15" name="Text 12"/>
+          <p:cNvPr id="17" name="Text 14"/>
           <p:cNvSpPr txBox="1"/>
           <p:nvPr/>
         </p:nvSpPr>
@@ -2483,7 +2615,7 @@
       </p:sp>
       <p:sp>
         <p:nvSpPr>
-          <p:cNvPr id="16" name="Text 13"/>
+          <p:cNvPr id="18" name="Text 15"/>
           <p:cNvSpPr txBox="1"/>
           <p:nvPr/>
         </p:nvSpPr>
@@ -2552,9 +2684,59 @@
           <a:chExt cx="0" cy="0"/>
         </a:xfrm>
       </p:grpSpPr>
+      <p:sp>
+        <p:nvSpPr>
+          <p:cNvPr id="2" name="Shape 0"/>
+          <p:cNvSpPr/>
+          <p:nvPr/>
+        </p:nvSpPr>
+        <p:spPr>
+          <a:xfrm>
+            <a:off x="0" y="6620256"/>
+            <a:ext cx="9144000" cy="237744"/>
+          </a:xfrm>
+          <a:prstGeom prst="rect">
+            <a:avLst/>
+          </a:prstGeom>
+          <a:solidFill>
+            <a:srgbClr val="4FADD1"/>
+          </a:solidFill>
+          <a:ln w="6350">
+            <a:solidFill>
+              <a:srgbClr val="4FADD1"/>
+            </a:solidFill>
+            <a:prstDash val="solid"/>
+          </a:ln>
+        </p:spPr>
+      </p:sp>
+      <p:sp>
+        <p:nvSpPr>
+          <p:cNvPr id="3" name="Shape 1"/>
+          <p:cNvSpPr/>
+          <p:nvPr/>
+        </p:nvSpPr>
+        <p:spPr>
+          <a:xfrm>
+            <a:off x="0" y="0"/>
+            <a:ext cx="9144000" cy="713232"/>
+          </a:xfrm>
+          <a:prstGeom prst="rect">
+            <a:avLst/>
+          </a:prstGeom>
+          <a:solidFill>
+            <a:srgbClr val="4FADD1"/>
+          </a:solidFill>
+          <a:ln w="6350">
+            <a:solidFill>
+              <a:srgbClr val="4FADD1"/>
+            </a:solidFill>
+            <a:prstDash val="solid"/>
+          </a:ln>
+        </p:spPr>
+      </p:sp>
       <p:pic>
         <p:nvPicPr>
-          <p:cNvPr id="2" name="Image 0" descr="정석항공과학고등학교 교표">    </p:cNvPr>
+          <p:cNvPr id="4" name="Image 0" descr="정석항공과학고등학교 교표">    </p:cNvPr>
           <p:cNvPicPr>
             <a:picLocks noChangeAspect="1"/>
           </p:cNvPicPr>
@@ -2568,7 +2750,7 @@
         </p:blipFill>
         <p:spPr>
           <a:xfrm>
-            <a:off x="7973568" y="256032"/>
+            <a:off x="7973568" y="201168"/>
             <a:ext cx="713232" cy="305410"/>
           </a:xfrm>
           <a:prstGeom prst="rect">
@@ -2578,13 +2760,13 @@
       </p:pic>
       <p:sp>
         <p:nvSpPr>
-          <p:cNvPr id="3" name="Text 0"/>
+          <p:cNvPr id="5" name="Text 2"/>
           <p:cNvSpPr txBox="1"/>
           <p:nvPr/>
         </p:nvSpPr>
         <p:spPr>
           <a:xfrm>
-            <a:off x="3657600" y="6345936"/>
+            <a:off x="3657600" y="6291072"/>
             <a:ext cx="1828800" cy="274320"/>
           </a:xfrm>
           <a:prstGeom prst="rect">
@@ -2617,13 +2799,13 @@
       </p:sp>
       <p:sp>
         <p:nvSpPr>
-          <p:cNvPr id="4" name="Text 1"/>
+          <p:cNvPr id="6" name="Text 3"/>
           <p:cNvSpPr txBox="1"/>
           <p:nvPr/>
         </p:nvSpPr>
         <p:spPr>
           <a:xfrm>
-            <a:off x="457200" y="237744"/>
+            <a:off x="457200" y="82296"/>
             <a:ext cx="7132320" cy="548640"/>
           </a:xfrm>
           <a:prstGeom prst="rect">
@@ -2640,9 +2822,9 @@
               <a:buNone/>
             </a:pPr>
             <a:r>
-              <a:rPr lang="en-US" sz="2800" dirty="0">
+              <a:rPr lang="en-US" sz="2600" dirty="0">
                 <a:solidFill>
-                  <a:srgbClr val="000000"/>
+                  <a:srgbClr val="FFFFFF"/>
                 </a:solidFill>
                 <a:latin typeface="HY헤드라인M" pitchFamily="34" charset="0"/>
                 <a:ea typeface="HY헤드라인M" pitchFamily="34" charset="-122"/>
@@ -2650,13 +2832,13 @@
               </a:rPr>
               <a:t>10. 채용 계획 요약</a:t>
             </a:r>
-            <a:endParaRPr lang="en-US" sz="2800" dirty="0"/>
+            <a:endParaRPr lang="en-US" sz="2600" dirty="0"/>
           </a:p>
         </p:txBody>
       </p:sp>
       <p:sp>
         <p:nvSpPr>
-          <p:cNvPr id="5" name="Text 2"/>
+          <p:cNvPr id="7" name="Text 4"/>
           <p:cNvSpPr txBox="1"/>
           <p:nvPr/>
         </p:nvSpPr>
@@ -3787,7 +3969,7 @@
       </p:graphicFrame>
       <p:sp>
         <p:nvSpPr>
-          <p:cNvPr id="7" name="Text 3"/>
+          <p:cNvPr id="9" name="Text 5"/>
           <p:cNvSpPr txBox="1"/>
           <p:nvPr/>
         </p:nvSpPr>
@@ -4487,9 +4669,59 @@
           <a:chExt cx="0" cy="0"/>
         </a:xfrm>
       </p:grpSpPr>
+      <p:sp>
+        <p:nvSpPr>
+          <p:cNvPr id="2" name="Shape 0"/>
+          <p:cNvSpPr/>
+          <p:nvPr/>
+        </p:nvSpPr>
+        <p:spPr>
+          <a:xfrm>
+            <a:off x="0" y="6620256"/>
+            <a:ext cx="9144000" cy="237744"/>
+          </a:xfrm>
+          <a:prstGeom prst="rect">
+            <a:avLst/>
+          </a:prstGeom>
+          <a:solidFill>
+            <a:srgbClr val="4FADD1"/>
+          </a:solidFill>
+          <a:ln w="6350">
+            <a:solidFill>
+              <a:srgbClr val="4FADD1"/>
+            </a:solidFill>
+            <a:prstDash val="solid"/>
+          </a:ln>
+        </p:spPr>
+      </p:sp>
+      <p:sp>
+        <p:nvSpPr>
+          <p:cNvPr id="3" name="Shape 1"/>
+          <p:cNvSpPr/>
+          <p:nvPr/>
+        </p:nvSpPr>
+        <p:spPr>
+          <a:xfrm>
+            <a:off x="0" y="0"/>
+            <a:ext cx="9144000" cy="713232"/>
+          </a:xfrm>
+          <a:prstGeom prst="rect">
+            <a:avLst/>
+          </a:prstGeom>
+          <a:solidFill>
+            <a:srgbClr val="4FADD1"/>
+          </a:solidFill>
+          <a:ln w="6350">
+            <a:solidFill>
+              <a:srgbClr val="4FADD1"/>
+            </a:solidFill>
+            <a:prstDash val="solid"/>
+          </a:ln>
+        </p:spPr>
+      </p:sp>
       <p:pic>
         <p:nvPicPr>
-          <p:cNvPr id="2" name="Image 0" descr="정석항공과학고등학교 교표">    </p:cNvPr>
+          <p:cNvPr id="4" name="Image 0" descr="정석항공과학고등학교 교표">    </p:cNvPr>
           <p:cNvPicPr>
             <a:picLocks noChangeAspect="1"/>
           </p:cNvPicPr>
@@ -4503,7 +4735,7 @@
         </p:blipFill>
         <p:spPr>
           <a:xfrm>
-            <a:off x="7973568" y="256032"/>
+            <a:off x="7973568" y="201168"/>
             <a:ext cx="713232" cy="305410"/>
           </a:xfrm>
           <a:prstGeom prst="rect">
@@ -4513,13 +4745,13 @@
       </p:pic>
       <p:sp>
         <p:nvSpPr>
-          <p:cNvPr id="3" name="Text 0"/>
+          <p:cNvPr id="5" name="Text 2"/>
           <p:cNvSpPr txBox="1"/>
           <p:nvPr/>
         </p:nvSpPr>
         <p:spPr>
           <a:xfrm>
-            <a:off x="3657600" y="6345936"/>
+            <a:off x="3657600" y="6291072"/>
             <a:ext cx="1828800" cy="274320"/>
           </a:xfrm>
           <a:prstGeom prst="rect">
@@ -4552,13 +4784,13 @@
       </p:sp>
       <p:sp>
         <p:nvSpPr>
-          <p:cNvPr id="4" name="Text 1"/>
+          <p:cNvPr id="6" name="Text 3"/>
           <p:cNvSpPr txBox="1"/>
           <p:nvPr/>
         </p:nvSpPr>
         <p:spPr>
           <a:xfrm>
-            <a:off x="457200" y="237744"/>
+            <a:off x="457200" y="82296"/>
             <a:ext cx="7132320" cy="548640"/>
           </a:xfrm>
           <a:prstGeom prst="rect">
@@ -4575,9 +4807,9 @@
               <a:buNone/>
             </a:pPr>
             <a:r>
-              <a:rPr lang="en-US" sz="2800" dirty="0">
+              <a:rPr lang="en-US" sz="2600" dirty="0">
                 <a:solidFill>
-                  <a:srgbClr val="000000"/>
+                  <a:srgbClr val="FFFFFF"/>
                 </a:solidFill>
                 <a:latin typeface="HY헤드라인M" pitchFamily="34" charset="0"/>
                 <a:ea typeface="HY헤드라인M" pitchFamily="34" charset="-122"/>
@@ -4585,13 +4817,13 @@
               </a:rPr>
               <a:t>1. 채용 인원 및 채용 사유</a:t>
             </a:r>
-            <a:endParaRPr lang="en-US" sz="2800" dirty="0"/>
+            <a:endParaRPr lang="en-US" sz="2600" dirty="0"/>
           </a:p>
         </p:txBody>
       </p:sp>
       <p:sp>
         <p:nvSpPr>
-          <p:cNvPr id="5" name="Text 2"/>
+          <p:cNvPr id="7" name="Text 4"/>
           <p:cNvSpPr txBox="1"/>
           <p:nvPr/>
         </p:nvSpPr>
@@ -4630,7 +4862,7 @@
       </p:sp>
       <p:sp>
         <p:nvSpPr>
-          <p:cNvPr id="6" name="Text 3"/>
+          <p:cNvPr id="8" name="Text 5"/>
           <p:cNvSpPr txBox="1"/>
           <p:nvPr/>
         </p:nvSpPr>
@@ -4669,7 +4901,7 @@
       </p:sp>
       <p:sp>
         <p:nvSpPr>
-          <p:cNvPr id="7" name="Text 4"/>
+          <p:cNvPr id="9" name="Text 6"/>
           <p:cNvSpPr txBox="1"/>
           <p:nvPr/>
         </p:nvSpPr>
@@ -4711,7 +4943,7 @@
       </p:sp>
       <p:sp>
         <p:nvSpPr>
-          <p:cNvPr id="8" name="Text 5"/>
+          <p:cNvPr id="10" name="Text 7"/>
           <p:cNvSpPr txBox="1"/>
           <p:nvPr/>
         </p:nvSpPr>
@@ -4750,7 +4982,7 @@
       </p:sp>
       <p:sp>
         <p:nvSpPr>
-          <p:cNvPr id="9" name="Text 6"/>
+          <p:cNvPr id="11" name="Text 8"/>
           <p:cNvSpPr txBox="1"/>
           <p:nvPr/>
         </p:nvSpPr>
@@ -4789,7 +5021,7 @@
       </p:sp>
       <p:sp>
         <p:nvSpPr>
-          <p:cNvPr id="10" name="Text 7"/>
+          <p:cNvPr id="12" name="Text 9"/>
           <p:cNvSpPr txBox="1"/>
           <p:nvPr/>
         </p:nvSpPr>
@@ -4831,7 +5063,7 @@
       </p:sp>
       <p:sp>
         <p:nvSpPr>
-          <p:cNvPr id="11" name="Text 8"/>
+          <p:cNvPr id="13" name="Text 10"/>
           <p:cNvSpPr txBox="1"/>
           <p:nvPr/>
         </p:nvSpPr>
@@ -4870,7 +5102,7 @@
       </p:sp>
       <p:sp>
         <p:nvSpPr>
-          <p:cNvPr id="12" name="Text 9"/>
+          <p:cNvPr id="14" name="Text 11"/>
           <p:cNvSpPr txBox="1"/>
           <p:nvPr/>
         </p:nvSpPr>
@@ -4912,7 +5144,7 @@
       </p:sp>
       <p:sp>
         <p:nvSpPr>
-          <p:cNvPr id="13" name="Text 10"/>
+          <p:cNvPr id="15" name="Text 12"/>
           <p:cNvSpPr txBox="1"/>
           <p:nvPr/>
         </p:nvSpPr>
@@ -5653,7 +5885,7 @@
       </p:graphicFrame>
       <p:sp>
         <p:nvSpPr>
-          <p:cNvPr id="15" name="Text 11"/>
+          <p:cNvPr id="17" name="Text 13"/>
           <p:cNvSpPr txBox="1"/>
           <p:nvPr/>
         </p:nvSpPr>
@@ -5722,9 +5954,59 @@
           <a:chExt cx="0" cy="0"/>
         </a:xfrm>
       </p:grpSpPr>
+      <p:sp>
+        <p:nvSpPr>
+          <p:cNvPr id="2" name="Shape 0"/>
+          <p:cNvSpPr/>
+          <p:nvPr/>
+        </p:nvSpPr>
+        <p:spPr>
+          <a:xfrm>
+            <a:off x="0" y="6620256"/>
+            <a:ext cx="9144000" cy="237744"/>
+          </a:xfrm>
+          <a:prstGeom prst="rect">
+            <a:avLst/>
+          </a:prstGeom>
+          <a:solidFill>
+            <a:srgbClr val="4FADD1"/>
+          </a:solidFill>
+          <a:ln w="6350">
+            <a:solidFill>
+              <a:srgbClr val="4FADD1"/>
+            </a:solidFill>
+            <a:prstDash val="solid"/>
+          </a:ln>
+        </p:spPr>
+      </p:sp>
+      <p:sp>
+        <p:nvSpPr>
+          <p:cNvPr id="3" name="Shape 1"/>
+          <p:cNvSpPr/>
+          <p:nvPr/>
+        </p:nvSpPr>
+        <p:spPr>
+          <a:xfrm>
+            <a:off x="0" y="0"/>
+            <a:ext cx="9144000" cy="713232"/>
+          </a:xfrm>
+          <a:prstGeom prst="rect">
+            <a:avLst/>
+          </a:prstGeom>
+          <a:solidFill>
+            <a:srgbClr val="4FADD1"/>
+          </a:solidFill>
+          <a:ln w="6350">
+            <a:solidFill>
+              <a:srgbClr val="4FADD1"/>
+            </a:solidFill>
+            <a:prstDash val="solid"/>
+          </a:ln>
+        </p:spPr>
+      </p:sp>
       <p:pic>
         <p:nvPicPr>
-          <p:cNvPr id="2" name="Image 0" descr="정석항공과학고등학교 교표">    </p:cNvPr>
+          <p:cNvPr id="4" name="Image 0" descr="정석항공과학고등학교 교표">    </p:cNvPr>
           <p:cNvPicPr>
             <a:picLocks noChangeAspect="1"/>
           </p:cNvPicPr>
@@ -5738,7 +6020,7 @@
         </p:blipFill>
         <p:spPr>
           <a:xfrm>
-            <a:off x="7973568" y="256032"/>
+            <a:off x="7973568" y="201168"/>
             <a:ext cx="713232" cy="305410"/>
           </a:xfrm>
           <a:prstGeom prst="rect">
@@ -5748,13 +6030,13 @@
       </p:pic>
       <p:sp>
         <p:nvSpPr>
-          <p:cNvPr id="3" name="Text 0"/>
+          <p:cNvPr id="5" name="Text 2"/>
           <p:cNvSpPr txBox="1"/>
           <p:nvPr/>
         </p:nvSpPr>
         <p:spPr>
           <a:xfrm>
-            <a:off x="3657600" y="6345936"/>
+            <a:off x="3657600" y="6291072"/>
             <a:ext cx="1828800" cy="274320"/>
           </a:xfrm>
           <a:prstGeom prst="rect">
@@ -5787,13 +6069,13 @@
       </p:sp>
       <p:sp>
         <p:nvSpPr>
-          <p:cNvPr id="4" name="Text 1"/>
+          <p:cNvPr id="6" name="Text 3"/>
           <p:cNvSpPr txBox="1"/>
           <p:nvPr/>
         </p:nvSpPr>
         <p:spPr>
           <a:xfrm>
-            <a:off x="457200" y="237744"/>
+            <a:off x="457200" y="82296"/>
             <a:ext cx="7132320" cy="548640"/>
           </a:xfrm>
           <a:prstGeom prst="rect">
@@ -5810,9 +6092,9 @@
               <a:buNone/>
             </a:pPr>
             <a:r>
-              <a:rPr lang="en-US" sz="2800" dirty="0">
+              <a:rPr lang="en-US" sz="2600" dirty="0">
                 <a:solidFill>
-                  <a:srgbClr val="000000"/>
+                  <a:srgbClr val="FFFFFF"/>
                 </a:solidFill>
                 <a:latin typeface="HY헤드라인M" pitchFamily="34" charset="0"/>
                 <a:ea typeface="HY헤드라인M" pitchFamily="34" charset="-122"/>
@@ -5820,13 +6102,13 @@
               </a:rPr>
               <a:t>2. 직원 현황</a:t>
             </a:r>
-            <a:endParaRPr lang="en-US" sz="2800" dirty="0"/>
+            <a:endParaRPr lang="en-US" sz="2600" dirty="0"/>
           </a:p>
         </p:txBody>
       </p:sp>
       <p:sp>
         <p:nvSpPr>
-          <p:cNvPr id="5" name="Text 2"/>
+          <p:cNvPr id="7" name="Text 4"/>
           <p:cNvSpPr txBox="1"/>
           <p:nvPr/>
         </p:nvSpPr>
@@ -5865,7 +6147,7 @@
       </p:sp>
       <p:sp>
         <p:nvSpPr>
-          <p:cNvPr id="6" name="Text 3"/>
+          <p:cNvPr id="8" name="Text 5"/>
           <p:cNvSpPr txBox="1"/>
           <p:nvPr/>
         </p:nvSpPr>
@@ -8518,7 +8800,7 @@
       </p:graphicFrame>
       <p:sp>
         <p:nvSpPr>
-          <p:cNvPr id="8" name="Text 4"/>
+          <p:cNvPr id="10" name="Text 6"/>
           <p:cNvSpPr txBox="1"/>
           <p:nvPr/>
         </p:nvSpPr>
@@ -8557,7 +8839,7 @@
       </p:sp>
       <p:sp>
         <p:nvSpPr>
-          <p:cNvPr id="9" name="Text 5"/>
+          <p:cNvPr id="11" name="Text 7"/>
           <p:cNvSpPr txBox="1"/>
           <p:nvPr/>
         </p:nvSpPr>
@@ -9517,7 +9799,7 @@
       </p:graphicFrame>
       <p:sp>
         <p:nvSpPr>
-          <p:cNvPr id="11" name="Text 6"/>
+          <p:cNvPr id="13" name="Text 8"/>
           <p:cNvSpPr txBox="1"/>
           <p:nvPr/>
         </p:nvSpPr>
@@ -9586,9 +9868,59 @@
           <a:chExt cx="0" cy="0"/>
         </a:xfrm>
       </p:grpSpPr>
+      <p:sp>
+        <p:nvSpPr>
+          <p:cNvPr id="2" name="Shape 0"/>
+          <p:cNvSpPr/>
+          <p:nvPr/>
+        </p:nvSpPr>
+        <p:spPr>
+          <a:xfrm>
+            <a:off x="0" y="6620256"/>
+            <a:ext cx="9144000" cy="237744"/>
+          </a:xfrm>
+          <a:prstGeom prst="rect">
+            <a:avLst/>
+          </a:prstGeom>
+          <a:solidFill>
+            <a:srgbClr val="4FADD1"/>
+          </a:solidFill>
+          <a:ln w="6350">
+            <a:solidFill>
+              <a:srgbClr val="4FADD1"/>
+            </a:solidFill>
+            <a:prstDash val="solid"/>
+          </a:ln>
+        </p:spPr>
+      </p:sp>
+      <p:sp>
+        <p:nvSpPr>
+          <p:cNvPr id="3" name="Shape 1"/>
+          <p:cNvSpPr/>
+          <p:nvPr/>
+        </p:nvSpPr>
+        <p:spPr>
+          <a:xfrm>
+            <a:off x="0" y="0"/>
+            <a:ext cx="9144000" cy="713232"/>
+          </a:xfrm>
+          <a:prstGeom prst="rect">
+            <a:avLst/>
+          </a:prstGeom>
+          <a:solidFill>
+            <a:srgbClr val="4FADD1"/>
+          </a:solidFill>
+          <a:ln w="6350">
+            <a:solidFill>
+              <a:srgbClr val="4FADD1"/>
+            </a:solidFill>
+            <a:prstDash val="solid"/>
+          </a:ln>
+        </p:spPr>
+      </p:sp>
       <p:pic>
         <p:nvPicPr>
-          <p:cNvPr id="2" name="Image 0" descr="정석항공과학고등학교 교표">    </p:cNvPr>
+          <p:cNvPr id="4" name="Image 0" descr="정석항공과학고등학교 교표">    </p:cNvPr>
           <p:cNvPicPr>
             <a:picLocks noChangeAspect="1"/>
           </p:cNvPicPr>
@@ -9602,7 +9934,7 @@
         </p:blipFill>
         <p:spPr>
           <a:xfrm>
-            <a:off x="7973568" y="256032"/>
+            <a:off x="7973568" y="201168"/>
             <a:ext cx="713232" cy="305410"/>
           </a:xfrm>
           <a:prstGeom prst="rect">
@@ -9612,13 +9944,13 @@
       </p:pic>
       <p:sp>
         <p:nvSpPr>
-          <p:cNvPr id="3" name="Text 0"/>
+          <p:cNvPr id="5" name="Text 2"/>
           <p:cNvSpPr txBox="1"/>
           <p:nvPr/>
         </p:nvSpPr>
         <p:spPr>
           <a:xfrm>
-            <a:off x="3657600" y="6345936"/>
+            <a:off x="3657600" y="6291072"/>
             <a:ext cx="1828800" cy="274320"/>
           </a:xfrm>
           <a:prstGeom prst="rect">
@@ -9651,13 +9983,13 @@
       </p:sp>
       <p:sp>
         <p:nvSpPr>
-          <p:cNvPr id="4" name="Text 1"/>
+          <p:cNvPr id="6" name="Text 3"/>
           <p:cNvSpPr txBox="1"/>
           <p:nvPr/>
         </p:nvSpPr>
         <p:spPr>
           <a:xfrm>
-            <a:off x="457200" y="237744"/>
+            <a:off x="457200" y="82296"/>
             <a:ext cx="7132320" cy="548640"/>
           </a:xfrm>
           <a:prstGeom prst="rect">
@@ -9674,9 +10006,9 @@
               <a:buNone/>
             </a:pPr>
             <a:r>
-              <a:rPr lang="en-US" sz="2800" dirty="0">
+              <a:rPr lang="en-US" sz="2600" dirty="0">
                 <a:solidFill>
-                  <a:srgbClr val="000000"/>
+                  <a:srgbClr val="FFFFFF"/>
                 </a:solidFill>
                 <a:latin typeface="HY헤드라인M" pitchFamily="34" charset="0"/>
                 <a:ea typeface="HY헤드라인M" pitchFamily="34" charset="-122"/>
@@ -9684,13 +10016,13 @@
               </a:rPr>
               <a:t>3. 채용 계획</a:t>
             </a:r>
-            <a:endParaRPr lang="en-US" sz="2800" dirty="0"/>
+            <a:endParaRPr lang="en-US" sz="2600" dirty="0"/>
           </a:p>
         </p:txBody>
       </p:sp>
       <p:sp>
         <p:nvSpPr>
-          <p:cNvPr id="5" name="Text 2"/>
+          <p:cNvPr id="7" name="Text 4"/>
           <p:cNvSpPr txBox="1"/>
           <p:nvPr/>
         </p:nvSpPr>
@@ -9729,7 +10061,7 @@
       </p:sp>
       <p:sp>
         <p:nvSpPr>
-          <p:cNvPr id="6" name="Shape 3"/>
+          <p:cNvPr id="8" name="Shape 5"/>
           <p:cNvSpPr/>
           <p:nvPr/>
         </p:nvSpPr>
@@ -9754,7 +10086,7 @@
       </p:sp>
       <p:sp>
         <p:nvSpPr>
-          <p:cNvPr id="7" name="Text 4"/>
+          <p:cNvPr id="9" name="Text 6"/>
           <p:cNvSpPr txBox="1"/>
           <p:nvPr/>
         </p:nvSpPr>
@@ -9816,7 +10148,7 @@
       </p:sp>
       <p:sp>
         <p:nvSpPr>
-          <p:cNvPr id="8" name="Shape 5"/>
+          <p:cNvPr id="10" name="Shape 7"/>
           <p:cNvSpPr/>
           <p:nvPr/>
         </p:nvSpPr>
@@ -9841,7 +10173,7 @@
       </p:sp>
       <p:sp>
         <p:nvSpPr>
-          <p:cNvPr id="9" name="Text 6"/>
+          <p:cNvPr id="11" name="Text 8"/>
           <p:cNvSpPr txBox="1"/>
           <p:nvPr/>
         </p:nvSpPr>
@@ -9883,7 +10215,7 @@
       </p:sp>
       <p:sp>
         <p:nvSpPr>
-          <p:cNvPr id="10" name="Shape 7"/>
+          <p:cNvPr id="12" name="Shape 9"/>
           <p:cNvSpPr/>
           <p:nvPr/>
         </p:nvSpPr>
@@ -9903,7 +10235,7 @@
       </p:sp>
       <p:sp>
         <p:nvSpPr>
-          <p:cNvPr id="11" name="Shape 8"/>
+          <p:cNvPr id="13" name="Shape 10"/>
           <p:cNvSpPr/>
           <p:nvPr/>
         </p:nvSpPr>
@@ -9928,7 +10260,7 @@
       </p:sp>
       <p:sp>
         <p:nvSpPr>
-          <p:cNvPr id="12" name="Text 9"/>
+          <p:cNvPr id="14" name="Text 11"/>
           <p:cNvSpPr txBox="1"/>
           <p:nvPr/>
         </p:nvSpPr>
@@ -9990,7 +10322,7 @@
       </p:sp>
       <p:sp>
         <p:nvSpPr>
-          <p:cNvPr id="13" name="Shape 10"/>
+          <p:cNvPr id="15" name="Shape 12"/>
           <p:cNvSpPr/>
           <p:nvPr/>
         </p:nvSpPr>
@@ -10015,7 +10347,7 @@
       </p:sp>
       <p:sp>
         <p:nvSpPr>
-          <p:cNvPr id="14" name="Text 11"/>
+          <p:cNvPr id="16" name="Text 13"/>
           <p:cNvSpPr txBox="1"/>
           <p:nvPr/>
         </p:nvSpPr>
@@ -10057,7 +10389,7 @@
       </p:sp>
       <p:sp>
         <p:nvSpPr>
-          <p:cNvPr id="15" name="Shape 12"/>
+          <p:cNvPr id="17" name="Shape 14"/>
           <p:cNvSpPr/>
           <p:nvPr/>
         </p:nvSpPr>
@@ -10077,7 +10409,7 @@
       </p:sp>
       <p:sp>
         <p:nvSpPr>
-          <p:cNvPr id="16" name="Shape 13"/>
+          <p:cNvPr id="18" name="Shape 15"/>
           <p:cNvSpPr/>
           <p:nvPr/>
         </p:nvSpPr>
@@ -10102,7 +10434,7 @@
       </p:sp>
       <p:sp>
         <p:nvSpPr>
-          <p:cNvPr id="17" name="Text 14"/>
+          <p:cNvPr id="19" name="Text 16"/>
           <p:cNvSpPr txBox="1"/>
           <p:nvPr/>
         </p:nvSpPr>
@@ -10184,7 +10516,7 @@
       </p:sp>
       <p:sp>
         <p:nvSpPr>
-          <p:cNvPr id="18" name="Shape 15"/>
+          <p:cNvPr id="20" name="Shape 17"/>
           <p:cNvSpPr/>
           <p:nvPr/>
         </p:nvSpPr>
@@ -10209,7 +10541,7 @@
       </p:sp>
       <p:sp>
         <p:nvSpPr>
-          <p:cNvPr id="19" name="Text 16"/>
+          <p:cNvPr id="21" name="Text 18"/>
           <p:cNvSpPr txBox="1"/>
           <p:nvPr/>
         </p:nvSpPr>
@@ -10251,7 +10583,7 @@
       </p:sp>
       <p:sp>
         <p:nvSpPr>
-          <p:cNvPr id="20" name="Shape 17"/>
+          <p:cNvPr id="22" name="Shape 19"/>
           <p:cNvSpPr/>
           <p:nvPr/>
         </p:nvSpPr>
@@ -10271,7 +10603,7 @@
       </p:sp>
       <p:sp>
         <p:nvSpPr>
-          <p:cNvPr id="21" name="Shape 18"/>
+          <p:cNvPr id="23" name="Shape 20"/>
           <p:cNvSpPr/>
           <p:nvPr/>
         </p:nvSpPr>
@@ -10296,7 +10628,7 @@
       </p:sp>
       <p:sp>
         <p:nvSpPr>
-          <p:cNvPr id="22" name="Text 19"/>
+          <p:cNvPr id="24" name="Text 21"/>
           <p:cNvSpPr txBox="1"/>
           <p:nvPr/>
         </p:nvSpPr>
@@ -10358,7 +10690,7 @@
       </p:sp>
       <p:sp>
         <p:nvSpPr>
-          <p:cNvPr id="23" name="Shape 20"/>
+          <p:cNvPr id="25" name="Shape 22"/>
           <p:cNvSpPr/>
           <p:nvPr/>
         </p:nvSpPr>
@@ -10383,7 +10715,7 @@
       </p:sp>
       <p:sp>
         <p:nvSpPr>
-          <p:cNvPr id="24" name="Text 21"/>
+          <p:cNvPr id="26" name="Text 23"/>
           <p:cNvSpPr txBox="1"/>
           <p:nvPr/>
         </p:nvSpPr>
@@ -10425,7 +10757,7 @@
       </p:sp>
       <p:sp>
         <p:nvSpPr>
-          <p:cNvPr id="25" name="Shape 22"/>
+          <p:cNvPr id="27" name="Shape 24"/>
           <p:cNvSpPr/>
           <p:nvPr/>
         </p:nvSpPr>
@@ -10445,7 +10777,7 @@
       </p:sp>
       <p:sp>
         <p:nvSpPr>
-          <p:cNvPr id="26" name="Shape 23"/>
+          <p:cNvPr id="28" name="Shape 25"/>
           <p:cNvSpPr/>
           <p:nvPr/>
         </p:nvSpPr>
@@ -10470,7 +10802,7 @@
       </p:sp>
       <p:sp>
         <p:nvSpPr>
-          <p:cNvPr id="27" name="Text 24"/>
+          <p:cNvPr id="29" name="Text 26"/>
           <p:cNvSpPr txBox="1"/>
           <p:nvPr/>
         </p:nvSpPr>
@@ -10512,7 +10844,7 @@
       </p:sp>
       <p:sp>
         <p:nvSpPr>
-          <p:cNvPr id="28" name="Shape 25"/>
+          <p:cNvPr id="30" name="Shape 27"/>
           <p:cNvSpPr/>
           <p:nvPr/>
         </p:nvSpPr>
@@ -10537,7 +10869,7 @@
       </p:sp>
       <p:sp>
         <p:nvSpPr>
-          <p:cNvPr id="29" name="Text 26"/>
+          <p:cNvPr id="31" name="Text 28"/>
           <p:cNvSpPr txBox="1"/>
           <p:nvPr/>
         </p:nvSpPr>
@@ -10579,7 +10911,7 @@
       </p:sp>
       <p:sp>
         <p:nvSpPr>
-          <p:cNvPr id="30" name="Text 27"/>
+          <p:cNvPr id="32" name="Text 29"/>
           <p:cNvSpPr txBox="1"/>
           <p:nvPr/>
         </p:nvSpPr>
@@ -10648,9 +10980,59 @@
           <a:chExt cx="0" cy="0"/>
         </a:xfrm>
       </p:grpSpPr>
+      <p:sp>
+        <p:nvSpPr>
+          <p:cNvPr id="2" name="Shape 0"/>
+          <p:cNvSpPr/>
+          <p:nvPr/>
+        </p:nvSpPr>
+        <p:spPr>
+          <a:xfrm>
+            <a:off x="0" y="6620256"/>
+            <a:ext cx="9144000" cy="237744"/>
+          </a:xfrm>
+          <a:prstGeom prst="rect">
+            <a:avLst/>
+          </a:prstGeom>
+          <a:solidFill>
+            <a:srgbClr val="4FADD1"/>
+          </a:solidFill>
+          <a:ln w="6350">
+            <a:solidFill>
+              <a:srgbClr val="4FADD1"/>
+            </a:solidFill>
+            <a:prstDash val="solid"/>
+          </a:ln>
+        </p:spPr>
+      </p:sp>
+      <p:sp>
+        <p:nvSpPr>
+          <p:cNvPr id="3" name="Shape 1"/>
+          <p:cNvSpPr/>
+          <p:nvPr/>
+        </p:nvSpPr>
+        <p:spPr>
+          <a:xfrm>
+            <a:off x="0" y="0"/>
+            <a:ext cx="9144000" cy="713232"/>
+          </a:xfrm>
+          <a:prstGeom prst="rect">
+            <a:avLst/>
+          </a:prstGeom>
+          <a:solidFill>
+            <a:srgbClr val="4FADD1"/>
+          </a:solidFill>
+          <a:ln w="6350">
+            <a:solidFill>
+              <a:srgbClr val="4FADD1"/>
+            </a:solidFill>
+            <a:prstDash val="solid"/>
+          </a:ln>
+        </p:spPr>
+      </p:sp>
       <p:pic>
         <p:nvPicPr>
-          <p:cNvPr id="2" name="Image 0" descr="정석항공과학고등학교 교표">    </p:cNvPr>
+          <p:cNvPr id="4" name="Image 0" descr="정석항공과학고등학교 교표">    </p:cNvPr>
           <p:cNvPicPr>
             <a:picLocks noChangeAspect="1"/>
           </p:cNvPicPr>
@@ -10664,7 +11046,7 @@
         </p:blipFill>
         <p:spPr>
           <a:xfrm>
-            <a:off x="7973568" y="256032"/>
+            <a:off x="7973568" y="201168"/>
             <a:ext cx="713232" cy="305410"/>
           </a:xfrm>
           <a:prstGeom prst="rect">
@@ -10674,13 +11056,13 @@
       </p:pic>
       <p:sp>
         <p:nvSpPr>
-          <p:cNvPr id="3" name="Text 0"/>
+          <p:cNvPr id="5" name="Text 2"/>
           <p:cNvSpPr txBox="1"/>
           <p:nvPr/>
         </p:nvSpPr>
         <p:spPr>
           <a:xfrm>
-            <a:off x="3657600" y="6345936"/>
+            <a:off x="3657600" y="6291072"/>
             <a:ext cx="1828800" cy="274320"/>
           </a:xfrm>
           <a:prstGeom prst="rect">
@@ -10713,13 +11095,13 @@
       </p:sp>
       <p:sp>
         <p:nvSpPr>
-          <p:cNvPr id="4" name="Text 1"/>
+          <p:cNvPr id="6" name="Text 3"/>
           <p:cNvSpPr txBox="1"/>
           <p:nvPr/>
         </p:nvSpPr>
         <p:spPr>
           <a:xfrm>
-            <a:off x="457200" y="237744"/>
+            <a:off x="457200" y="82296"/>
             <a:ext cx="7132320" cy="548640"/>
           </a:xfrm>
           <a:prstGeom prst="rect">
@@ -10736,9 +11118,9 @@
               <a:buNone/>
             </a:pPr>
             <a:r>
-              <a:rPr lang="en-US" sz="2800" dirty="0">
+              <a:rPr lang="en-US" sz="2600" dirty="0">
                 <a:solidFill>
-                  <a:srgbClr val="000000"/>
+                  <a:srgbClr val="FFFFFF"/>
                 </a:solidFill>
                 <a:latin typeface="HY헤드라인M" pitchFamily="34" charset="0"/>
                 <a:ea typeface="HY헤드라인M" pitchFamily="34" charset="-122"/>
@@ -10746,13 +11128,13 @@
               </a:rPr>
               <a:t>4. 전형 절차</a:t>
             </a:r>
-            <a:endParaRPr lang="en-US" sz="2800" dirty="0"/>
+            <a:endParaRPr lang="en-US" sz="2600" dirty="0"/>
           </a:p>
         </p:txBody>
       </p:sp>
       <p:sp>
         <p:nvSpPr>
-          <p:cNvPr id="5" name="Text 2"/>
+          <p:cNvPr id="7" name="Text 4"/>
           <p:cNvSpPr txBox="1"/>
           <p:nvPr/>
         </p:nvSpPr>
@@ -10791,7 +11173,7 @@
       </p:sp>
       <p:sp>
         <p:nvSpPr>
-          <p:cNvPr id="6" name="Shape 3"/>
+          <p:cNvPr id="8" name="Shape 5"/>
           <p:cNvSpPr/>
           <p:nvPr/>
         </p:nvSpPr>
@@ -10816,7 +11198,7 @@
       </p:sp>
       <p:sp>
         <p:nvSpPr>
-          <p:cNvPr id="7" name="Text 4"/>
+          <p:cNvPr id="9" name="Text 6"/>
           <p:cNvSpPr txBox="1"/>
           <p:nvPr/>
         </p:nvSpPr>
@@ -10858,7 +11240,7 @@
       </p:sp>
       <p:sp>
         <p:nvSpPr>
-          <p:cNvPr id="8" name="Shape 5"/>
+          <p:cNvPr id="10" name="Shape 7"/>
           <p:cNvSpPr/>
           <p:nvPr/>
         </p:nvSpPr>
@@ -10883,7 +11265,7 @@
       </p:sp>
       <p:sp>
         <p:nvSpPr>
-          <p:cNvPr id="9" name="Text 6"/>
+          <p:cNvPr id="11" name="Text 8"/>
           <p:cNvSpPr txBox="1"/>
           <p:nvPr/>
         </p:nvSpPr>
@@ -10925,7 +11307,7 @@
       </p:sp>
       <p:sp>
         <p:nvSpPr>
-          <p:cNvPr id="10" name="Shape 7"/>
+          <p:cNvPr id="12" name="Shape 9"/>
           <p:cNvSpPr/>
           <p:nvPr/>
         </p:nvSpPr>
@@ -10945,7 +11327,7 @@
       </p:sp>
       <p:sp>
         <p:nvSpPr>
-          <p:cNvPr id="11" name="Shape 8"/>
+          <p:cNvPr id="13" name="Shape 10"/>
           <p:cNvSpPr/>
           <p:nvPr/>
         </p:nvSpPr>
@@ -10970,7 +11352,7 @@
       </p:sp>
       <p:sp>
         <p:nvSpPr>
-          <p:cNvPr id="12" name="Text 9"/>
+          <p:cNvPr id="14" name="Text 11"/>
           <p:cNvSpPr txBox="1"/>
           <p:nvPr/>
         </p:nvSpPr>
@@ -11012,7 +11394,7 @@
       </p:sp>
       <p:sp>
         <p:nvSpPr>
-          <p:cNvPr id="13" name="Shape 10"/>
+          <p:cNvPr id="15" name="Shape 12"/>
           <p:cNvSpPr/>
           <p:nvPr/>
         </p:nvSpPr>
@@ -11037,7 +11419,7 @@
       </p:sp>
       <p:sp>
         <p:nvSpPr>
-          <p:cNvPr id="14" name="Text 11"/>
+          <p:cNvPr id="16" name="Text 13"/>
           <p:cNvSpPr txBox="1"/>
           <p:nvPr/>
         </p:nvSpPr>
@@ -11079,7 +11461,7 @@
       </p:sp>
       <p:sp>
         <p:nvSpPr>
-          <p:cNvPr id="15" name="Shape 12"/>
+          <p:cNvPr id="17" name="Shape 14"/>
           <p:cNvSpPr/>
           <p:nvPr/>
         </p:nvSpPr>
@@ -11099,7 +11481,7 @@
       </p:sp>
       <p:sp>
         <p:nvSpPr>
-          <p:cNvPr id="16" name="Shape 13"/>
+          <p:cNvPr id="18" name="Shape 15"/>
           <p:cNvSpPr/>
           <p:nvPr/>
         </p:nvSpPr>
@@ -11124,7 +11506,7 @@
       </p:sp>
       <p:sp>
         <p:nvSpPr>
-          <p:cNvPr id="17" name="Text 14"/>
+          <p:cNvPr id="19" name="Text 16"/>
           <p:cNvSpPr txBox="1"/>
           <p:nvPr/>
         </p:nvSpPr>
@@ -11186,7 +11568,7 @@
       </p:sp>
       <p:sp>
         <p:nvSpPr>
-          <p:cNvPr id="18" name="Shape 15"/>
+          <p:cNvPr id="20" name="Shape 17"/>
           <p:cNvSpPr/>
           <p:nvPr/>
         </p:nvSpPr>
@@ -11211,7 +11593,7 @@
       </p:sp>
       <p:sp>
         <p:nvSpPr>
-          <p:cNvPr id="19" name="Text 16"/>
+          <p:cNvPr id="21" name="Text 18"/>
           <p:cNvSpPr txBox="1"/>
           <p:nvPr/>
         </p:nvSpPr>
@@ -11273,7 +11655,7 @@
       </p:sp>
       <p:sp>
         <p:nvSpPr>
-          <p:cNvPr id="20" name="Shape 17"/>
+          <p:cNvPr id="22" name="Shape 19"/>
           <p:cNvSpPr/>
           <p:nvPr/>
         </p:nvSpPr>
@@ -11293,7 +11675,7 @@
       </p:sp>
       <p:sp>
         <p:nvSpPr>
-          <p:cNvPr id="21" name="Shape 18"/>
+          <p:cNvPr id="23" name="Shape 20"/>
           <p:cNvSpPr/>
           <p:nvPr/>
         </p:nvSpPr>
@@ -11318,7 +11700,7 @@
       </p:sp>
       <p:sp>
         <p:nvSpPr>
-          <p:cNvPr id="22" name="Text 19"/>
+          <p:cNvPr id="24" name="Text 21"/>
           <p:cNvSpPr txBox="1"/>
           <p:nvPr/>
         </p:nvSpPr>
@@ -11360,7 +11742,7 @@
       </p:sp>
       <p:sp>
         <p:nvSpPr>
-          <p:cNvPr id="23" name="Shape 20"/>
+          <p:cNvPr id="25" name="Shape 22"/>
           <p:cNvSpPr/>
           <p:nvPr/>
         </p:nvSpPr>
@@ -11385,7 +11767,7 @@
       </p:sp>
       <p:sp>
         <p:nvSpPr>
-          <p:cNvPr id="24" name="Text 21"/>
+          <p:cNvPr id="26" name="Text 23"/>
           <p:cNvSpPr txBox="1"/>
           <p:nvPr/>
         </p:nvSpPr>
@@ -11447,7 +11829,7 @@
       </p:sp>
       <p:sp>
         <p:nvSpPr>
-          <p:cNvPr id="25" name="Shape 22"/>
+          <p:cNvPr id="27" name="Shape 24"/>
           <p:cNvSpPr/>
           <p:nvPr/>
         </p:nvSpPr>
@@ -11467,7 +11849,7 @@
       </p:sp>
       <p:sp>
         <p:nvSpPr>
-          <p:cNvPr id="26" name="Shape 23"/>
+          <p:cNvPr id="28" name="Shape 25"/>
           <p:cNvSpPr/>
           <p:nvPr/>
         </p:nvSpPr>
@@ -11492,7 +11874,7 @@
       </p:sp>
       <p:sp>
         <p:nvSpPr>
-          <p:cNvPr id="27" name="Text 24"/>
+          <p:cNvPr id="29" name="Text 26"/>
           <p:cNvSpPr txBox="1"/>
           <p:nvPr/>
         </p:nvSpPr>
@@ -11534,7 +11916,7 @@
       </p:sp>
       <p:sp>
         <p:nvSpPr>
-          <p:cNvPr id="28" name="Shape 25"/>
+          <p:cNvPr id="30" name="Shape 27"/>
           <p:cNvSpPr/>
           <p:nvPr/>
         </p:nvSpPr>
@@ -11559,7 +11941,7 @@
       </p:sp>
       <p:sp>
         <p:nvSpPr>
-          <p:cNvPr id="29" name="Text 26"/>
+          <p:cNvPr id="31" name="Text 28"/>
           <p:cNvSpPr txBox="1"/>
           <p:nvPr/>
         </p:nvSpPr>
@@ -11601,7 +11983,7 @@
       </p:sp>
       <p:sp>
         <p:nvSpPr>
-          <p:cNvPr id="30" name="Text 27"/>
+          <p:cNvPr id="32" name="Text 29"/>
           <p:cNvSpPr txBox="1"/>
           <p:nvPr/>
         </p:nvSpPr>
@@ -12774,9 +13156,59 @@
           <a:chExt cx="0" cy="0"/>
         </a:xfrm>
       </p:grpSpPr>
+      <p:sp>
+        <p:nvSpPr>
+          <p:cNvPr id="2" name="Shape 0"/>
+          <p:cNvSpPr/>
+          <p:nvPr/>
+        </p:nvSpPr>
+        <p:spPr>
+          <a:xfrm>
+            <a:off x="0" y="6620256"/>
+            <a:ext cx="9144000" cy="237744"/>
+          </a:xfrm>
+          <a:prstGeom prst="rect">
+            <a:avLst/>
+          </a:prstGeom>
+          <a:solidFill>
+            <a:srgbClr val="4FADD1"/>
+          </a:solidFill>
+          <a:ln w="6350">
+            <a:solidFill>
+              <a:srgbClr val="4FADD1"/>
+            </a:solidFill>
+            <a:prstDash val="solid"/>
+          </a:ln>
+        </p:spPr>
+      </p:sp>
+      <p:sp>
+        <p:nvSpPr>
+          <p:cNvPr id="3" name="Shape 1"/>
+          <p:cNvSpPr/>
+          <p:nvPr/>
+        </p:nvSpPr>
+        <p:spPr>
+          <a:xfrm>
+            <a:off x="0" y="0"/>
+            <a:ext cx="9144000" cy="713232"/>
+          </a:xfrm>
+          <a:prstGeom prst="rect">
+            <a:avLst/>
+          </a:prstGeom>
+          <a:solidFill>
+            <a:srgbClr val="4FADD1"/>
+          </a:solidFill>
+          <a:ln w="6350">
+            <a:solidFill>
+              <a:srgbClr val="4FADD1"/>
+            </a:solidFill>
+            <a:prstDash val="solid"/>
+          </a:ln>
+        </p:spPr>
+      </p:sp>
       <p:pic>
         <p:nvPicPr>
-          <p:cNvPr id="2" name="Image 0" descr="정석항공과학고등학교 교표">    </p:cNvPr>
+          <p:cNvPr id="4" name="Image 0" descr="정석항공과학고등학교 교표">    </p:cNvPr>
           <p:cNvPicPr>
             <a:picLocks noChangeAspect="1"/>
           </p:cNvPicPr>
@@ -12790,7 +13222,7 @@
         </p:blipFill>
         <p:spPr>
           <a:xfrm>
-            <a:off x="7973568" y="256032"/>
+            <a:off x="7973568" y="201168"/>
             <a:ext cx="713232" cy="305410"/>
           </a:xfrm>
           <a:prstGeom prst="rect">
@@ -12800,13 +13232,13 @@
       </p:pic>
       <p:sp>
         <p:nvSpPr>
-          <p:cNvPr id="3" name="Text 0"/>
+          <p:cNvPr id="5" name="Text 2"/>
           <p:cNvSpPr txBox="1"/>
           <p:nvPr/>
         </p:nvSpPr>
         <p:spPr>
           <a:xfrm>
-            <a:off x="3657600" y="6345936"/>
+            <a:off x="3657600" y="6291072"/>
             <a:ext cx="1828800" cy="274320"/>
           </a:xfrm>
           <a:prstGeom prst="rect">
@@ -12839,13 +13271,13 @@
       </p:sp>
       <p:sp>
         <p:nvSpPr>
-          <p:cNvPr id="4" name="Text 1"/>
+          <p:cNvPr id="6" name="Text 3"/>
           <p:cNvSpPr txBox="1"/>
           <p:nvPr/>
         </p:nvSpPr>
         <p:spPr>
           <a:xfrm>
-            <a:off x="457200" y="237744"/>
+            <a:off x="457200" y="82296"/>
             <a:ext cx="7132320" cy="548640"/>
           </a:xfrm>
           <a:prstGeom prst="rect">
@@ -12862,9 +13294,9 @@
               <a:buNone/>
             </a:pPr>
             <a:r>
-              <a:rPr lang="en-US" sz="2800" dirty="0">
+              <a:rPr lang="en-US" sz="2600" dirty="0">
                 <a:solidFill>
-                  <a:srgbClr val="000000"/>
+                  <a:srgbClr val="FFFFFF"/>
                 </a:solidFill>
                 <a:latin typeface="HY헤드라인M" pitchFamily="34" charset="0"/>
                 <a:ea typeface="HY헤드라인M" pitchFamily="34" charset="-122"/>
@@ -12872,20 +13304,20 @@
               </a:rPr>
               <a:t>5. 지원서 접수</a:t>
             </a:r>
-            <a:endParaRPr lang="en-US" sz="2800" dirty="0"/>
+            <a:endParaRPr lang="en-US" sz="2600" dirty="0"/>
           </a:p>
         </p:txBody>
       </p:sp>
       <p:sp>
         <p:nvSpPr>
-          <p:cNvPr id="5" name="Text 2"/>
+          <p:cNvPr id="7" name="Text 4"/>
           <p:cNvSpPr txBox="1"/>
           <p:nvPr/>
         </p:nvSpPr>
         <p:spPr>
           <a:xfrm>
-            <a:off x="5029200" y="329184"/>
-            <a:ext cx="2788920" cy="310896"/>
+            <a:off x="4937760" y="201168"/>
+            <a:ext cx="2880360" cy="310896"/>
           </a:xfrm>
           <a:prstGeom prst="rect">
             <a:avLst/>
@@ -12901,9 +13333,9 @@
               <a:buNone/>
             </a:pPr>
             <a:r>
-              <a:rPr lang="en-US" sz="1200" b="1" dirty="0">
+              <a:rPr lang="en-US" sz="1150" b="1" dirty="0">
                 <a:solidFill>
-                  <a:srgbClr val="000000"/>
+                  <a:srgbClr val="FFFFFF"/>
                 </a:solidFill>
                 <a:latin typeface="맑은 고딕" pitchFamily="34" charset="0"/>
                 <a:ea typeface="맑은 고딕" pitchFamily="34" charset="-122"/>
@@ -12911,13 +13343,13 @@
               </a:rPr>
               <a:t>[ 전형 1단계 / 4단계 ]</a:t>
             </a:r>
-            <a:endParaRPr lang="en-US" sz="1200" dirty="0"/>
+            <a:endParaRPr lang="en-US" sz="1150" dirty="0"/>
           </a:p>
         </p:txBody>
       </p:sp>
       <p:sp>
         <p:nvSpPr>
-          <p:cNvPr id="6" name="Text 3"/>
+          <p:cNvPr id="8" name="Text 5"/>
           <p:cNvSpPr txBox="1"/>
           <p:nvPr/>
         </p:nvSpPr>
@@ -12956,7 +13388,7 @@
       </p:sp>
       <p:sp>
         <p:nvSpPr>
-          <p:cNvPr id="7" name="Text 4"/>
+          <p:cNvPr id="9" name="Text 6"/>
           <p:cNvSpPr txBox="1"/>
           <p:nvPr/>
         </p:nvSpPr>
@@ -12995,7 +13427,7 @@
       </p:sp>
       <p:sp>
         <p:nvSpPr>
-          <p:cNvPr id="8" name="Text 5"/>
+          <p:cNvPr id="10" name="Text 7"/>
           <p:cNvSpPr txBox="1"/>
           <p:nvPr/>
         </p:nvSpPr>
@@ -13037,7 +13469,7 @@
       </p:sp>
       <p:sp>
         <p:nvSpPr>
-          <p:cNvPr id="9" name="Text 6"/>
+          <p:cNvPr id="11" name="Text 8"/>
           <p:cNvSpPr txBox="1"/>
           <p:nvPr/>
         </p:nvSpPr>
@@ -13076,7 +13508,7 @@
       </p:sp>
       <p:sp>
         <p:nvSpPr>
-          <p:cNvPr id="10" name="Text 7"/>
+          <p:cNvPr id="12" name="Text 9"/>
           <p:cNvSpPr txBox="1"/>
           <p:nvPr/>
         </p:nvSpPr>
@@ -13118,7 +13550,7 @@
       </p:sp>
       <p:sp>
         <p:nvSpPr>
-          <p:cNvPr id="11" name="Text 8"/>
+          <p:cNvPr id="13" name="Text 10"/>
           <p:cNvSpPr txBox="1"/>
           <p:nvPr/>
         </p:nvSpPr>
@@ -13157,7 +13589,7 @@
       </p:sp>
       <p:sp>
         <p:nvSpPr>
-          <p:cNvPr id="12" name="Text 9"/>
+          <p:cNvPr id="14" name="Text 11"/>
           <p:cNvSpPr txBox="1"/>
           <p:nvPr/>
         </p:nvSpPr>
@@ -13196,7 +13628,7 @@
       </p:sp>
       <p:sp>
         <p:nvSpPr>
-          <p:cNvPr id="13" name="Text 10"/>
+          <p:cNvPr id="15" name="Text 12"/>
           <p:cNvSpPr txBox="1"/>
           <p:nvPr/>
         </p:nvSpPr>
@@ -13238,7 +13670,7 @@
       </p:sp>
       <p:sp>
         <p:nvSpPr>
-          <p:cNvPr id="14" name="Text 11"/>
+          <p:cNvPr id="16" name="Text 13"/>
           <p:cNvSpPr txBox="1"/>
           <p:nvPr/>
         </p:nvSpPr>
@@ -13277,7 +13709,7 @@
       </p:sp>
       <p:sp>
         <p:nvSpPr>
-          <p:cNvPr id="15" name="Text 12"/>
+          <p:cNvPr id="17" name="Text 14"/>
           <p:cNvSpPr txBox="1"/>
           <p:nvPr/>
         </p:nvSpPr>
@@ -14045,9 +14477,59 @@
           <a:chExt cx="0" cy="0"/>
         </a:xfrm>
       </p:grpSpPr>
+      <p:sp>
+        <p:nvSpPr>
+          <p:cNvPr id="2" name="Shape 0"/>
+          <p:cNvSpPr/>
+          <p:nvPr/>
+        </p:nvSpPr>
+        <p:spPr>
+          <a:xfrm>
+            <a:off x="0" y="6620256"/>
+            <a:ext cx="9144000" cy="237744"/>
+          </a:xfrm>
+          <a:prstGeom prst="rect">
+            <a:avLst/>
+          </a:prstGeom>
+          <a:solidFill>
+            <a:srgbClr val="4FADD1"/>
+          </a:solidFill>
+          <a:ln w="6350">
+            <a:solidFill>
+              <a:srgbClr val="4FADD1"/>
+            </a:solidFill>
+            <a:prstDash val="solid"/>
+          </a:ln>
+        </p:spPr>
+      </p:sp>
+      <p:sp>
+        <p:nvSpPr>
+          <p:cNvPr id="3" name="Shape 1"/>
+          <p:cNvSpPr/>
+          <p:nvPr/>
+        </p:nvSpPr>
+        <p:spPr>
+          <a:xfrm>
+            <a:off x="0" y="0"/>
+            <a:ext cx="9144000" cy="713232"/>
+          </a:xfrm>
+          <a:prstGeom prst="rect">
+            <a:avLst/>
+          </a:prstGeom>
+          <a:solidFill>
+            <a:srgbClr val="4FADD1"/>
+          </a:solidFill>
+          <a:ln w="6350">
+            <a:solidFill>
+              <a:srgbClr val="4FADD1"/>
+            </a:solidFill>
+            <a:prstDash val="solid"/>
+          </a:ln>
+        </p:spPr>
+      </p:sp>
       <p:pic>
         <p:nvPicPr>
-          <p:cNvPr id="2" name="Image 0" descr="정석항공과학고등학교 교표">    </p:cNvPr>
+          <p:cNvPr id="4" name="Image 0" descr="정석항공과학고등학교 교표">    </p:cNvPr>
           <p:cNvPicPr>
             <a:picLocks noChangeAspect="1"/>
           </p:cNvPicPr>
@@ -14061,7 +14543,7 @@
         </p:blipFill>
         <p:spPr>
           <a:xfrm>
-            <a:off x="7973568" y="256032"/>
+            <a:off x="7973568" y="201168"/>
             <a:ext cx="713232" cy="305410"/>
           </a:xfrm>
           <a:prstGeom prst="rect">
@@ -14071,13 +14553,13 @@
       </p:pic>
       <p:sp>
         <p:nvSpPr>
-          <p:cNvPr id="3" name="Text 0"/>
+          <p:cNvPr id="5" name="Text 2"/>
           <p:cNvSpPr txBox="1"/>
           <p:nvPr/>
         </p:nvSpPr>
         <p:spPr>
           <a:xfrm>
-            <a:off x="3657600" y="6345936"/>
+            <a:off x="3657600" y="6291072"/>
             <a:ext cx="1828800" cy="274320"/>
           </a:xfrm>
           <a:prstGeom prst="rect">
@@ -14110,13 +14592,13 @@
       </p:sp>
       <p:sp>
         <p:nvSpPr>
-          <p:cNvPr id="4" name="Text 1"/>
+          <p:cNvPr id="6" name="Text 3"/>
           <p:cNvSpPr txBox="1"/>
           <p:nvPr/>
         </p:nvSpPr>
         <p:spPr>
           <a:xfrm>
-            <a:off x="457200" y="237744"/>
+            <a:off x="457200" y="82296"/>
             <a:ext cx="7132320" cy="548640"/>
           </a:xfrm>
           <a:prstGeom prst="rect">
@@ -14133,9 +14615,9 @@
               <a:buNone/>
             </a:pPr>
             <a:r>
-              <a:rPr lang="en-US" sz="2800" dirty="0">
+              <a:rPr lang="en-US" sz="2600" dirty="0">
                 <a:solidFill>
-                  <a:srgbClr val="000000"/>
+                  <a:srgbClr val="FFFFFF"/>
                 </a:solidFill>
                 <a:latin typeface="HY헤드라인M" pitchFamily="34" charset="0"/>
                 <a:ea typeface="HY헤드라인M" pitchFamily="34" charset="-122"/>
@@ -14143,20 +14625,20 @@
               </a:rPr>
               <a:t>6. 서류 전형 (1차)</a:t>
             </a:r>
-            <a:endParaRPr lang="en-US" sz="2800" dirty="0"/>
+            <a:endParaRPr lang="en-US" sz="2600" dirty="0"/>
           </a:p>
         </p:txBody>
       </p:sp>
       <p:sp>
         <p:nvSpPr>
-          <p:cNvPr id="5" name="Text 2"/>
+          <p:cNvPr id="7" name="Text 4"/>
           <p:cNvSpPr txBox="1"/>
           <p:nvPr/>
         </p:nvSpPr>
         <p:spPr>
           <a:xfrm>
-            <a:off x="5029200" y="329184"/>
-            <a:ext cx="2788920" cy="310896"/>
+            <a:off x="4937760" y="201168"/>
+            <a:ext cx="2880360" cy="310896"/>
           </a:xfrm>
           <a:prstGeom prst="rect">
             <a:avLst/>
@@ -14172,9 +14654,9 @@
               <a:buNone/>
             </a:pPr>
             <a:r>
-              <a:rPr lang="en-US" sz="1200" b="1" dirty="0">
+              <a:rPr lang="en-US" sz="1150" b="1" dirty="0">
                 <a:solidFill>
-                  <a:srgbClr val="000000"/>
+                  <a:srgbClr val="FFFFFF"/>
                 </a:solidFill>
                 <a:latin typeface="맑은 고딕" pitchFamily="34" charset="0"/>
                 <a:ea typeface="맑은 고딕" pitchFamily="34" charset="-122"/>
@@ -14182,13 +14664,13 @@
               </a:rPr>
               <a:t>[ 전형 2단계 / 4단계 ]</a:t>
             </a:r>
-            <a:endParaRPr lang="en-US" sz="1200" dirty="0"/>
+            <a:endParaRPr lang="en-US" sz="1150" dirty="0"/>
           </a:p>
         </p:txBody>
       </p:sp>
       <p:sp>
         <p:nvSpPr>
-          <p:cNvPr id="6" name="Text 3"/>
+          <p:cNvPr id="8" name="Text 5"/>
           <p:cNvSpPr txBox="1"/>
           <p:nvPr/>
         </p:nvSpPr>
@@ -14227,7 +14709,7 @@
       </p:sp>
       <p:sp>
         <p:nvSpPr>
-          <p:cNvPr id="7" name="Text 4"/>
+          <p:cNvPr id="9" name="Text 6"/>
           <p:cNvSpPr txBox="1"/>
           <p:nvPr/>
         </p:nvSpPr>
@@ -14266,7 +14748,7 @@
       </p:sp>
       <p:sp>
         <p:nvSpPr>
-          <p:cNvPr id="8" name="Text 5"/>
+          <p:cNvPr id="10" name="Text 7"/>
           <p:cNvSpPr txBox="1"/>
           <p:nvPr/>
         </p:nvSpPr>
@@ -14308,7 +14790,7 @@
       </p:sp>
       <p:sp>
         <p:nvSpPr>
-          <p:cNvPr id="9" name="Text 6"/>
+          <p:cNvPr id="11" name="Text 8"/>
           <p:cNvSpPr txBox="1"/>
           <p:nvPr/>
         </p:nvSpPr>
@@ -14347,7 +14829,7 @@
       </p:sp>
       <p:sp>
         <p:nvSpPr>
-          <p:cNvPr id="10" name="Text 7"/>
+          <p:cNvPr id="12" name="Text 9"/>
           <p:cNvSpPr txBox="1"/>
           <p:nvPr/>
         </p:nvSpPr>
@@ -14389,7 +14871,7 @@
       </p:sp>
       <p:sp>
         <p:nvSpPr>
-          <p:cNvPr id="11" name="Text 8"/>
+          <p:cNvPr id="13" name="Text 10"/>
           <p:cNvSpPr txBox="1"/>
           <p:nvPr/>
         </p:nvSpPr>
@@ -15432,7 +15914,7 @@
       </p:graphicFrame>
       <p:sp>
         <p:nvSpPr>
-          <p:cNvPr id="13" name="Text 9"/>
+          <p:cNvPr id="15" name="Text 11"/>
           <p:cNvSpPr txBox="1"/>
           <p:nvPr/>
         </p:nvSpPr>
@@ -15471,7 +15953,7 @@
       </p:sp>
       <p:sp>
         <p:nvSpPr>
-          <p:cNvPr id="14" name="Text 10"/>
+          <p:cNvPr id="16" name="Text 12"/>
           <p:cNvSpPr txBox="1"/>
           <p:nvPr/>
         </p:nvSpPr>
@@ -15510,7 +15992,7 @@
       </p:sp>
       <p:sp>
         <p:nvSpPr>
-          <p:cNvPr id="15" name="Text 11"/>
+          <p:cNvPr id="17" name="Text 13"/>
           <p:cNvSpPr txBox="1"/>
           <p:nvPr/>
         </p:nvSpPr>
@@ -15552,7 +16034,7 @@
       </p:sp>
       <p:sp>
         <p:nvSpPr>
-          <p:cNvPr id="16" name="Text 12"/>
+          <p:cNvPr id="18" name="Text 14"/>
           <p:cNvSpPr txBox="1"/>
           <p:nvPr/>
         </p:nvSpPr>
@@ -15591,7 +16073,7 @@
       </p:sp>
       <p:sp>
         <p:nvSpPr>
-          <p:cNvPr id="17" name="Text 13"/>
+          <p:cNvPr id="19" name="Text 15"/>
           <p:cNvSpPr txBox="1"/>
           <p:nvPr/>
         </p:nvSpPr>
@@ -15633,7 +16115,7 @@
       </p:sp>
       <p:sp>
         <p:nvSpPr>
-          <p:cNvPr id="18" name="Text 14"/>
+          <p:cNvPr id="20" name="Text 16"/>
           <p:cNvSpPr txBox="1"/>
           <p:nvPr/>
         </p:nvSpPr>
@@ -15672,7 +16154,7 @@
       </p:sp>
       <p:sp>
         <p:nvSpPr>
-          <p:cNvPr id="19" name="Text 15"/>
+          <p:cNvPr id="21" name="Text 17"/>
           <p:cNvSpPr txBox="1"/>
           <p:nvPr/>
         </p:nvSpPr>
@@ -15744,9 +16226,59 @@
           <a:chExt cx="0" cy="0"/>
         </a:xfrm>
       </p:grpSpPr>
+      <p:sp>
+        <p:nvSpPr>
+          <p:cNvPr id="2" name="Shape 0"/>
+          <p:cNvSpPr/>
+          <p:nvPr/>
+        </p:nvSpPr>
+        <p:spPr>
+          <a:xfrm>
+            <a:off x="0" y="6620256"/>
+            <a:ext cx="9144000" cy="237744"/>
+          </a:xfrm>
+          <a:prstGeom prst="rect">
+            <a:avLst/>
+          </a:prstGeom>
+          <a:solidFill>
+            <a:srgbClr val="4FADD1"/>
+          </a:solidFill>
+          <a:ln w="6350">
+            <a:solidFill>
+              <a:srgbClr val="4FADD1"/>
+            </a:solidFill>
+            <a:prstDash val="solid"/>
+          </a:ln>
+        </p:spPr>
+      </p:sp>
+      <p:sp>
+        <p:nvSpPr>
+          <p:cNvPr id="3" name="Shape 1"/>
+          <p:cNvSpPr/>
+          <p:nvPr/>
+        </p:nvSpPr>
+        <p:spPr>
+          <a:xfrm>
+            <a:off x="0" y="0"/>
+            <a:ext cx="9144000" cy="713232"/>
+          </a:xfrm>
+          <a:prstGeom prst="rect">
+            <a:avLst/>
+          </a:prstGeom>
+          <a:solidFill>
+            <a:srgbClr val="4FADD1"/>
+          </a:solidFill>
+          <a:ln w="6350">
+            <a:solidFill>
+              <a:srgbClr val="4FADD1"/>
+            </a:solidFill>
+            <a:prstDash val="solid"/>
+          </a:ln>
+        </p:spPr>
+      </p:sp>
       <p:pic>
         <p:nvPicPr>
-          <p:cNvPr id="2" name="Image 0" descr="정석항공과학고등학교 교표">    </p:cNvPr>
+          <p:cNvPr id="4" name="Image 0" descr="정석항공과학고등학교 교표">    </p:cNvPr>
           <p:cNvPicPr>
             <a:picLocks noChangeAspect="1"/>
           </p:cNvPicPr>
@@ -15760,7 +16292,7 @@
         </p:blipFill>
         <p:spPr>
           <a:xfrm>
-            <a:off x="7973568" y="256032"/>
+            <a:off x="7973568" y="201168"/>
             <a:ext cx="713232" cy="305410"/>
           </a:xfrm>
           <a:prstGeom prst="rect">
@@ -15770,13 +16302,13 @@
       </p:pic>
       <p:sp>
         <p:nvSpPr>
-          <p:cNvPr id="3" name="Text 0"/>
+          <p:cNvPr id="5" name="Text 2"/>
           <p:cNvSpPr txBox="1"/>
           <p:nvPr/>
         </p:nvSpPr>
         <p:spPr>
           <a:xfrm>
-            <a:off x="3657600" y="6345936"/>
+            <a:off x="3657600" y="6291072"/>
             <a:ext cx="1828800" cy="274320"/>
           </a:xfrm>
           <a:prstGeom prst="rect">
@@ -15809,13 +16341,13 @@
       </p:sp>
       <p:sp>
         <p:nvSpPr>
-          <p:cNvPr id="4" name="Text 1"/>
+          <p:cNvPr id="6" name="Text 3"/>
           <p:cNvSpPr txBox="1"/>
           <p:nvPr/>
         </p:nvSpPr>
         <p:spPr>
           <a:xfrm>
-            <a:off x="457200" y="237744"/>
+            <a:off x="457200" y="82296"/>
             <a:ext cx="7132320" cy="548640"/>
           </a:xfrm>
           <a:prstGeom prst="rect">
@@ -15832,9 +16364,9 @@
               <a:buNone/>
             </a:pPr>
             <a:r>
-              <a:rPr lang="en-US" sz="2800" dirty="0">
+              <a:rPr lang="en-US" sz="2600" dirty="0">
                 <a:solidFill>
-                  <a:srgbClr val="000000"/>
+                  <a:srgbClr val="FFFFFF"/>
                 </a:solidFill>
                 <a:latin typeface="HY헤드라인M" pitchFamily="34" charset="0"/>
                 <a:ea typeface="HY헤드라인M" pitchFamily="34" charset="-122"/>
@@ -15842,20 +16374,20 @@
               </a:rPr>
               <a:t>7. 업무적성 및 심층면접 (2차)</a:t>
             </a:r>
-            <a:endParaRPr lang="en-US" sz="2800" dirty="0"/>
+            <a:endParaRPr lang="en-US" sz="2600" dirty="0"/>
           </a:p>
         </p:txBody>
       </p:sp>
       <p:sp>
         <p:nvSpPr>
-          <p:cNvPr id="5" name="Text 2"/>
+          <p:cNvPr id="7" name="Text 4"/>
           <p:cNvSpPr txBox="1"/>
           <p:nvPr/>
         </p:nvSpPr>
         <p:spPr>
           <a:xfrm>
-            <a:off x="5029200" y="329184"/>
-            <a:ext cx="2788920" cy="310896"/>
+            <a:off x="4937760" y="201168"/>
+            <a:ext cx="2880360" cy="310896"/>
           </a:xfrm>
           <a:prstGeom prst="rect">
             <a:avLst/>
@@ -15871,9 +16403,9 @@
               <a:buNone/>
             </a:pPr>
             <a:r>
-              <a:rPr lang="en-US" sz="1200" b="1" dirty="0">
+              <a:rPr lang="en-US" sz="1150" b="1" dirty="0">
                 <a:solidFill>
-                  <a:srgbClr val="000000"/>
+                  <a:srgbClr val="FFFFFF"/>
                 </a:solidFill>
                 <a:latin typeface="맑은 고딕" pitchFamily="34" charset="0"/>
                 <a:ea typeface="맑은 고딕" pitchFamily="34" charset="-122"/>
@@ -15881,13 +16413,13 @@
               </a:rPr>
               <a:t>[ 전형 3단계 / 4단계 ]</a:t>
             </a:r>
-            <a:endParaRPr lang="en-US" sz="1200" dirty="0"/>
+            <a:endParaRPr lang="en-US" sz="1150" dirty="0"/>
           </a:p>
         </p:txBody>
       </p:sp>
       <p:sp>
         <p:nvSpPr>
-          <p:cNvPr id="6" name="Text 3"/>
+          <p:cNvPr id="8" name="Text 5"/>
           <p:cNvSpPr txBox="1"/>
           <p:nvPr/>
         </p:nvSpPr>
@@ -15926,7 +16458,7 @@
       </p:sp>
       <p:sp>
         <p:nvSpPr>
-          <p:cNvPr id="7" name="Text 4"/>
+          <p:cNvPr id="9" name="Text 6"/>
           <p:cNvSpPr txBox="1"/>
           <p:nvPr/>
         </p:nvSpPr>
@@ -15965,7 +16497,7 @@
       </p:sp>
       <p:sp>
         <p:nvSpPr>
-          <p:cNvPr id="8" name="Text 5"/>
+          <p:cNvPr id="10" name="Text 7"/>
           <p:cNvSpPr txBox="1"/>
           <p:nvPr/>
         </p:nvSpPr>
@@ -16007,7 +16539,7 @@
       </p:sp>
       <p:sp>
         <p:nvSpPr>
-          <p:cNvPr id="9" name="Text 6"/>
+          <p:cNvPr id="11" name="Text 8"/>
           <p:cNvSpPr txBox="1"/>
           <p:nvPr/>
         </p:nvSpPr>
@@ -16046,7 +16578,7 @@
       </p:sp>
       <p:sp>
         <p:nvSpPr>
-          <p:cNvPr id="10" name="Text 7"/>
+          <p:cNvPr id="12" name="Text 9"/>
           <p:cNvSpPr txBox="1"/>
           <p:nvPr/>
         </p:nvSpPr>
@@ -16088,7 +16620,7 @@
       </p:sp>
       <p:sp>
         <p:nvSpPr>
-          <p:cNvPr id="11" name="Text 8"/>
+          <p:cNvPr id="13" name="Text 10"/>
           <p:cNvSpPr txBox="1"/>
           <p:nvPr/>
         </p:nvSpPr>
@@ -17131,7 +17663,7 @@
       </p:graphicFrame>
       <p:sp>
         <p:nvSpPr>
-          <p:cNvPr id="13" name="Text 9"/>
+          <p:cNvPr id="15" name="Text 11"/>
           <p:cNvSpPr txBox="1"/>
           <p:nvPr/>
         </p:nvSpPr>
@@ -17170,7 +17702,7 @@
       </p:sp>
       <p:sp>
         <p:nvSpPr>
-          <p:cNvPr id="14" name="Text 10"/>
+          <p:cNvPr id="16" name="Text 12"/>
           <p:cNvSpPr txBox="1"/>
           <p:nvPr/>
         </p:nvSpPr>
@@ -17209,7 +17741,7 @@
       </p:sp>
       <p:sp>
         <p:nvSpPr>
-          <p:cNvPr id="15" name="Text 11"/>
+          <p:cNvPr id="17" name="Text 13"/>
           <p:cNvSpPr txBox="1"/>
           <p:nvPr/>
         </p:nvSpPr>
@@ -17251,7 +17783,7 @@
       </p:sp>
       <p:sp>
         <p:nvSpPr>
-          <p:cNvPr id="16" name="Text 12"/>
+          <p:cNvPr id="18" name="Text 14"/>
           <p:cNvSpPr txBox="1"/>
           <p:nvPr/>
         </p:nvSpPr>
@@ -17290,7 +17822,7 @@
       </p:sp>
       <p:sp>
         <p:nvSpPr>
-          <p:cNvPr id="17" name="Text 13"/>
+          <p:cNvPr id="19" name="Text 15"/>
           <p:cNvSpPr txBox="1"/>
           <p:nvPr/>
         </p:nvSpPr>
@@ -17362,9 +17894,59 @@
           <a:chExt cx="0" cy="0"/>
         </a:xfrm>
       </p:grpSpPr>
+      <p:sp>
+        <p:nvSpPr>
+          <p:cNvPr id="2" name="Shape 0"/>
+          <p:cNvSpPr/>
+          <p:nvPr/>
+        </p:nvSpPr>
+        <p:spPr>
+          <a:xfrm>
+            <a:off x="0" y="6620256"/>
+            <a:ext cx="9144000" cy="237744"/>
+          </a:xfrm>
+          <a:prstGeom prst="rect">
+            <a:avLst/>
+          </a:prstGeom>
+          <a:solidFill>
+            <a:srgbClr val="4FADD1"/>
+          </a:solidFill>
+          <a:ln w="6350">
+            <a:solidFill>
+              <a:srgbClr val="4FADD1"/>
+            </a:solidFill>
+            <a:prstDash val="solid"/>
+          </a:ln>
+        </p:spPr>
+      </p:sp>
+      <p:sp>
+        <p:nvSpPr>
+          <p:cNvPr id="3" name="Shape 1"/>
+          <p:cNvSpPr/>
+          <p:nvPr/>
+        </p:nvSpPr>
+        <p:spPr>
+          <a:xfrm>
+            <a:off x="0" y="0"/>
+            <a:ext cx="9144000" cy="713232"/>
+          </a:xfrm>
+          <a:prstGeom prst="rect">
+            <a:avLst/>
+          </a:prstGeom>
+          <a:solidFill>
+            <a:srgbClr val="4FADD1"/>
+          </a:solidFill>
+          <a:ln w="6350">
+            <a:solidFill>
+              <a:srgbClr val="4FADD1"/>
+            </a:solidFill>
+            <a:prstDash val="solid"/>
+          </a:ln>
+        </p:spPr>
+      </p:sp>
       <p:pic>
         <p:nvPicPr>
-          <p:cNvPr id="2" name="Image 0" descr="정석항공과학고등학교 교표">    </p:cNvPr>
+          <p:cNvPr id="4" name="Image 0" descr="정석항공과학고등학교 교표">    </p:cNvPr>
           <p:cNvPicPr>
             <a:picLocks noChangeAspect="1"/>
           </p:cNvPicPr>
@@ -17378,7 +17960,7 @@
         </p:blipFill>
         <p:spPr>
           <a:xfrm>
-            <a:off x="7973568" y="256032"/>
+            <a:off x="7973568" y="201168"/>
             <a:ext cx="713232" cy="305410"/>
           </a:xfrm>
           <a:prstGeom prst="rect">
@@ -17388,13 +17970,13 @@
       </p:pic>
       <p:sp>
         <p:nvSpPr>
-          <p:cNvPr id="3" name="Text 0"/>
+          <p:cNvPr id="5" name="Text 2"/>
           <p:cNvSpPr txBox="1"/>
           <p:nvPr/>
         </p:nvSpPr>
         <p:spPr>
           <a:xfrm>
-            <a:off x="3657600" y="6345936"/>
+            <a:off x="3657600" y="6291072"/>
             <a:ext cx="1828800" cy="274320"/>
           </a:xfrm>
           <a:prstGeom prst="rect">
@@ -17427,13 +18009,13 @@
       </p:sp>
       <p:sp>
         <p:nvSpPr>
-          <p:cNvPr id="4" name="Text 1"/>
+          <p:cNvPr id="6" name="Text 3"/>
           <p:cNvSpPr txBox="1"/>
           <p:nvPr/>
         </p:nvSpPr>
         <p:spPr>
           <a:xfrm>
-            <a:off x="457200" y="237744"/>
+            <a:off x="457200" y="82296"/>
             <a:ext cx="7132320" cy="548640"/>
           </a:xfrm>
           <a:prstGeom prst="rect">
@@ -17450,9 +18032,9 @@
               <a:buNone/>
             </a:pPr>
             <a:r>
-              <a:rPr lang="en-US" sz="2800" dirty="0">
+              <a:rPr lang="en-US" sz="2600" dirty="0">
                 <a:solidFill>
-                  <a:srgbClr val="000000"/>
+                  <a:srgbClr val="FFFFFF"/>
                 </a:solidFill>
                 <a:latin typeface="HY헤드라인M" pitchFamily="34" charset="0"/>
                 <a:ea typeface="HY헤드라인M" pitchFamily="34" charset="-122"/>
@@ -17460,20 +18042,20 @@
               </a:rPr>
               <a:t>8. 결격사유 검증</a:t>
             </a:r>
-            <a:endParaRPr lang="en-US" sz="2800" dirty="0"/>
+            <a:endParaRPr lang="en-US" sz="2600" dirty="0"/>
           </a:p>
         </p:txBody>
       </p:sp>
       <p:sp>
         <p:nvSpPr>
-          <p:cNvPr id="5" name="Text 2"/>
+          <p:cNvPr id="7" name="Text 4"/>
           <p:cNvSpPr txBox="1"/>
           <p:nvPr/>
         </p:nvSpPr>
         <p:spPr>
           <a:xfrm>
-            <a:off x="5029200" y="329184"/>
-            <a:ext cx="2788920" cy="310896"/>
+            <a:off x="4937760" y="201168"/>
+            <a:ext cx="2880360" cy="310896"/>
           </a:xfrm>
           <a:prstGeom prst="rect">
             <a:avLst/>
@@ -17489,9 +18071,9 @@
               <a:buNone/>
             </a:pPr>
             <a:r>
-              <a:rPr lang="en-US" sz="1200" b="1" dirty="0">
+              <a:rPr lang="en-US" sz="1150" b="1" dirty="0">
                 <a:solidFill>
-                  <a:srgbClr val="000000"/>
+                  <a:srgbClr val="FFFFFF"/>
                 </a:solidFill>
                 <a:latin typeface="맑은 고딕" pitchFamily="34" charset="0"/>
                 <a:ea typeface="맑은 고딕" pitchFamily="34" charset="-122"/>
@@ -17499,13 +18081,13 @@
               </a:rPr>
               <a:t>[ 전형 4단계 / 4단계 ]</a:t>
             </a:r>
-            <a:endParaRPr lang="en-US" sz="1200" dirty="0"/>
+            <a:endParaRPr lang="en-US" sz="1150" dirty="0"/>
           </a:p>
         </p:txBody>
       </p:sp>
       <p:sp>
         <p:nvSpPr>
-          <p:cNvPr id="6" name="Text 3"/>
+          <p:cNvPr id="8" name="Text 5"/>
           <p:cNvSpPr txBox="1"/>
           <p:nvPr/>
         </p:nvSpPr>
@@ -17544,7 +18126,7 @@
       </p:sp>
       <p:sp>
         <p:nvSpPr>
-          <p:cNvPr id="7" name="Text 4"/>
+          <p:cNvPr id="9" name="Text 6"/>
           <p:cNvSpPr txBox="1"/>
           <p:nvPr/>
         </p:nvSpPr>
@@ -17583,7 +18165,7 @@
       </p:sp>
       <p:sp>
         <p:nvSpPr>
-          <p:cNvPr id="8" name="Text 5"/>
+          <p:cNvPr id="10" name="Text 7"/>
           <p:cNvSpPr txBox="1"/>
           <p:nvPr/>
         </p:nvSpPr>
@@ -17625,7 +18207,7 @@
       </p:sp>
       <p:sp>
         <p:nvSpPr>
-          <p:cNvPr id="9" name="Text 6"/>
+          <p:cNvPr id="11" name="Text 8"/>
           <p:cNvSpPr txBox="1"/>
           <p:nvPr/>
         </p:nvSpPr>
@@ -17664,7 +18246,7 @@
       </p:sp>
       <p:sp>
         <p:nvSpPr>
-          <p:cNvPr id="10" name="Text 7"/>
+          <p:cNvPr id="12" name="Text 9"/>
           <p:cNvSpPr txBox="1"/>
           <p:nvPr/>
         </p:nvSpPr>
@@ -17706,7 +18288,7 @@
       </p:sp>
       <p:sp>
         <p:nvSpPr>
-          <p:cNvPr id="11" name="Text 8"/>
+          <p:cNvPr id="13" name="Text 10"/>
           <p:cNvSpPr txBox="1"/>
           <p:nvPr/>
         </p:nvSpPr>
@@ -18177,7 +18759,7 @@
       </p:graphicFrame>
       <p:sp>
         <p:nvSpPr>
-          <p:cNvPr id="13" name="Text 9"/>
+          <p:cNvPr id="15" name="Text 11"/>
           <p:cNvSpPr txBox="1"/>
           <p:nvPr/>
         </p:nvSpPr>
@@ -18872,7 +19454,7 @@
       </p:graphicFrame>
       <p:sp>
         <p:nvSpPr>
-          <p:cNvPr id="15" name="Text 10"/>
+          <p:cNvPr id="17" name="Text 12"/>
           <p:cNvSpPr txBox="1"/>
           <p:nvPr/>
         </p:nvSpPr>

</xml_diff>

<commit_message>
Drop the badge from the top-right of content slides
The title band now runs clear to the right margin, so the title and the
[ 전형 N단계 ] label use the full width. The emblem stays on the cover.

Co-Authored-By: Claude Opus 5 <noreply@anthropic.com>
Claude-Session: https://claude.ai/code/session_01GZfitk2JEKppZ4fGSDdghv
</commit_message>
<xml_diff>
--- a/docs/2027년_사무직원_채용계획안.pptx
+++ b/docs/2027년_사무직원_채용계획안.pptx
@@ -2070,33 +2070,9 @@
           </a:ln>
         </p:spPr>
       </p:sp>
-      <p:pic>
-        <p:nvPicPr>
-          <p:cNvPr id="4" name="Image 0" descr="정석항공과학고등학교 교표">    </p:cNvPr>
-          <p:cNvPicPr>
-            <a:picLocks noChangeAspect="1"/>
-          </p:cNvPicPr>
-          <p:nvPr/>
-        </p:nvPicPr>
-        <p:blipFill>
-          <a:blip r:embed="rId1"/>
-          <a:stretch>
-            <a:fillRect/>
-          </a:stretch>
-        </p:blipFill>
-        <p:spPr>
-          <a:xfrm>
-            <a:off x="7973568" y="201168"/>
-            <a:ext cx="713232" cy="305410"/>
-          </a:xfrm>
-          <a:prstGeom prst="rect">
-            <a:avLst/>
-          </a:prstGeom>
-        </p:spPr>
-      </p:pic>
-      <p:sp>
-        <p:nvSpPr>
-          <p:cNvPr id="5" name="Text 2"/>
+      <p:sp>
+        <p:nvSpPr>
+          <p:cNvPr id="4" name="Text 2"/>
           <p:cNvSpPr txBox="1"/>
           <p:nvPr/>
         </p:nvSpPr>
@@ -2135,14 +2111,14 @@
       </p:sp>
       <p:sp>
         <p:nvSpPr>
-          <p:cNvPr id="6" name="Text 3"/>
+          <p:cNvPr id="5" name="Text 3"/>
           <p:cNvSpPr txBox="1"/>
           <p:nvPr/>
         </p:nvSpPr>
         <p:spPr>
           <a:xfrm>
             <a:off x="457200" y="82296"/>
-            <a:ext cx="7132320" cy="548640"/>
+            <a:ext cx="5120640" cy="548640"/>
           </a:xfrm>
           <a:prstGeom prst="rect">
             <a:avLst/>
@@ -2174,7 +2150,7 @@
       </p:sp>
       <p:sp>
         <p:nvSpPr>
-          <p:cNvPr id="7" name="Text 4"/>
+          <p:cNvPr id="6" name="Text 4"/>
           <p:cNvSpPr txBox="1"/>
           <p:nvPr/>
         </p:nvSpPr>
@@ -2213,7 +2189,7 @@
       </p:sp>
       <p:sp>
         <p:nvSpPr>
-          <p:cNvPr id="8" name="Text 5"/>
+          <p:cNvPr id="7" name="Text 5"/>
           <p:cNvSpPr txBox="1"/>
           <p:nvPr/>
         </p:nvSpPr>
@@ -2252,7 +2228,7 @@
       </p:sp>
       <p:sp>
         <p:nvSpPr>
-          <p:cNvPr id="9" name="Text 6"/>
+          <p:cNvPr id="8" name="Text 6"/>
           <p:cNvSpPr txBox="1"/>
           <p:nvPr/>
         </p:nvSpPr>
@@ -2294,7 +2270,7 @@
       </p:sp>
       <p:sp>
         <p:nvSpPr>
-          <p:cNvPr id="10" name="Text 7"/>
+          <p:cNvPr id="9" name="Text 7"/>
           <p:cNvSpPr txBox="1"/>
           <p:nvPr/>
         </p:nvSpPr>
@@ -2333,7 +2309,7 @@
       </p:sp>
       <p:sp>
         <p:nvSpPr>
-          <p:cNvPr id="11" name="Text 8"/>
+          <p:cNvPr id="10" name="Text 8"/>
           <p:cNvSpPr txBox="1"/>
           <p:nvPr/>
         </p:nvSpPr>
@@ -2375,7 +2351,7 @@
       </p:sp>
       <p:sp>
         <p:nvSpPr>
-          <p:cNvPr id="12" name="Text 9"/>
+          <p:cNvPr id="11" name="Text 9"/>
           <p:cNvSpPr txBox="1"/>
           <p:nvPr/>
         </p:nvSpPr>
@@ -2414,7 +2390,7 @@
       </p:sp>
       <p:sp>
         <p:nvSpPr>
-          <p:cNvPr id="13" name="Text 10"/>
+          <p:cNvPr id="12" name="Text 10"/>
           <p:cNvSpPr txBox="1"/>
           <p:nvPr/>
         </p:nvSpPr>
@@ -2453,7 +2429,7 @@
       </p:sp>
       <p:sp>
         <p:nvSpPr>
-          <p:cNvPr id="14" name="Text 11"/>
+          <p:cNvPr id="13" name="Text 11"/>
           <p:cNvSpPr txBox="1"/>
           <p:nvPr/>
         </p:nvSpPr>
@@ -2495,7 +2471,7 @@
       </p:sp>
       <p:sp>
         <p:nvSpPr>
-          <p:cNvPr id="15" name="Text 12"/>
+          <p:cNvPr id="14" name="Text 12"/>
           <p:cNvSpPr txBox="1"/>
           <p:nvPr/>
         </p:nvSpPr>
@@ -2534,7 +2510,7 @@
       </p:sp>
       <p:sp>
         <p:nvSpPr>
-          <p:cNvPr id="16" name="Text 13"/>
+          <p:cNvPr id="15" name="Text 13"/>
           <p:cNvSpPr txBox="1"/>
           <p:nvPr/>
         </p:nvSpPr>
@@ -2573,7 +2549,7 @@
       </p:sp>
       <p:sp>
         <p:nvSpPr>
-          <p:cNvPr id="17" name="Text 14"/>
+          <p:cNvPr id="16" name="Text 14"/>
           <p:cNvSpPr txBox="1"/>
           <p:nvPr/>
         </p:nvSpPr>
@@ -2615,7 +2591,7 @@
       </p:sp>
       <p:sp>
         <p:nvSpPr>
-          <p:cNvPr id="18" name="Text 15"/>
+          <p:cNvPr id="17" name="Text 15"/>
           <p:cNvSpPr txBox="1"/>
           <p:nvPr/>
         </p:nvSpPr>
@@ -2734,33 +2710,9 @@
           </a:ln>
         </p:spPr>
       </p:sp>
-      <p:pic>
-        <p:nvPicPr>
-          <p:cNvPr id="4" name="Image 0" descr="정석항공과학고등학교 교표">    </p:cNvPr>
-          <p:cNvPicPr>
-            <a:picLocks noChangeAspect="1"/>
-          </p:cNvPicPr>
-          <p:nvPr/>
-        </p:nvPicPr>
-        <p:blipFill>
-          <a:blip r:embed="rId1"/>
-          <a:stretch>
-            <a:fillRect/>
-          </a:stretch>
-        </p:blipFill>
-        <p:spPr>
-          <a:xfrm>
-            <a:off x="7973568" y="201168"/>
-            <a:ext cx="713232" cy="305410"/>
-          </a:xfrm>
-          <a:prstGeom prst="rect">
-            <a:avLst/>
-          </a:prstGeom>
-        </p:spPr>
-      </p:pic>
-      <p:sp>
-        <p:nvSpPr>
-          <p:cNvPr id="5" name="Text 2"/>
+      <p:sp>
+        <p:nvSpPr>
+          <p:cNvPr id="4" name="Text 2"/>
           <p:cNvSpPr txBox="1"/>
           <p:nvPr/>
         </p:nvSpPr>
@@ -2799,14 +2751,14 @@
       </p:sp>
       <p:sp>
         <p:nvSpPr>
-          <p:cNvPr id="6" name="Text 3"/>
+          <p:cNvPr id="5" name="Text 3"/>
           <p:cNvSpPr txBox="1"/>
           <p:nvPr/>
         </p:nvSpPr>
         <p:spPr>
           <a:xfrm>
             <a:off x="457200" y="82296"/>
-            <a:ext cx="7132320" cy="548640"/>
+            <a:ext cx="5120640" cy="548640"/>
           </a:xfrm>
           <a:prstGeom prst="rect">
             <a:avLst/>
@@ -2838,7 +2790,7 @@
       </p:sp>
       <p:sp>
         <p:nvSpPr>
-          <p:cNvPr id="7" name="Text 4"/>
+          <p:cNvPr id="6" name="Text 4"/>
           <p:cNvSpPr txBox="1"/>
           <p:nvPr/>
         </p:nvSpPr>
@@ -3969,7 +3921,7 @@
       </p:graphicFrame>
       <p:sp>
         <p:nvSpPr>
-          <p:cNvPr id="9" name="Text 5"/>
+          <p:cNvPr id="8" name="Text 5"/>
           <p:cNvSpPr txBox="1"/>
           <p:nvPr/>
         </p:nvSpPr>
@@ -4719,33 +4671,9 @@
           </a:ln>
         </p:spPr>
       </p:sp>
-      <p:pic>
-        <p:nvPicPr>
-          <p:cNvPr id="4" name="Image 0" descr="정석항공과학고등학교 교표">    </p:cNvPr>
-          <p:cNvPicPr>
-            <a:picLocks noChangeAspect="1"/>
-          </p:cNvPicPr>
-          <p:nvPr/>
-        </p:nvPicPr>
-        <p:blipFill>
-          <a:blip r:embed="rId1"/>
-          <a:stretch>
-            <a:fillRect/>
-          </a:stretch>
-        </p:blipFill>
-        <p:spPr>
-          <a:xfrm>
-            <a:off x="7973568" y="201168"/>
-            <a:ext cx="713232" cy="305410"/>
-          </a:xfrm>
-          <a:prstGeom prst="rect">
-            <a:avLst/>
-          </a:prstGeom>
-        </p:spPr>
-      </p:pic>
-      <p:sp>
-        <p:nvSpPr>
-          <p:cNvPr id="5" name="Text 2"/>
+      <p:sp>
+        <p:nvSpPr>
+          <p:cNvPr id="4" name="Text 2"/>
           <p:cNvSpPr txBox="1"/>
           <p:nvPr/>
         </p:nvSpPr>
@@ -4784,14 +4712,14 @@
       </p:sp>
       <p:sp>
         <p:nvSpPr>
-          <p:cNvPr id="6" name="Text 3"/>
+          <p:cNvPr id="5" name="Text 3"/>
           <p:cNvSpPr txBox="1"/>
           <p:nvPr/>
         </p:nvSpPr>
         <p:spPr>
           <a:xfrm>
             <a:off x="457200" y="82296"/>
-            <a:ext cx="7132320" cy="548640"/>
+            <a:ext cx="5120640" cy="548640"/>
           </a:xfrm>
           <a:prstGeom prst="rect">
             <a:avLst/>
@@ -4823,7 +4751,7 @@
       </p:sp>
       <p:sp>
         <p:nvSpPr>
-          <p:cNvPr id="7" name="Text 4"/>
+          <p:cNvPr id="6" name="Text 4"/>
           <p:cNvSpPr txBox="1"/>
           <p:nvPr/>
         </p:nvSpPr>
@@ -4862,7 +4790,7 @@
       </p:sp>
       <p:sp>
         <p:nvSpPr>
-          <p:cNvPr id="8" name="Text 5"/>
+          <p:cNvPr id="7" name="Text 5"/>
           <p:cNvSpPr txBox="1"/>
           <p:nvPr/>
         </p:nvSpPr>
@@ -4901,7 +4829,7 @@
       </p:sp>
       <p:sp>
         <p:nvSpPr>
-          <p:cNvPr id="9" name="Text 6"/>
+          <p:cNvPr id="8" name="Text 6"/>
           <p:cNvSpPr txBox="1"/>
           <p:nvPr/>
         </p:nvSpPr>
@@ -4943,7 +4871,7 @@
       </p:sp>
       <p:sp>
         <p:nvSpPr>
-          <p:cNvPr id="10" name="Text 7"/>
+          <p:cNvPr id="9" name="Text 7"/>
           <p:cNvSpPr txBox="1"/>
           <p:nvPr/>
         </p:nvSpPr>
@@ -4982,7 +4910,7 @@
       </p:sp>
       <p:sp>
         <p:nvSpPr>
-          <p:cNvPr id="11" name="Text 8"/>
+          <p:cNvPr id="10" name="Text 8"/>
           <p:cNvSpPr txBox="1"/>
           <p:nvPr/>
         </p:nvSpPr>
@@ -5021,7 +4949,7 @@
       </p:sp>
       <p:sp>
         <p:nvSpPr>
-          <p:cNvPr id="12" name="Text 9"/>
+          <p:cNvPr id="11" name="Text 9"/>
           <p:cNvSpPr txBox="1"/>
           <p:nvPr/>
         </p:nvSpPr>
@@ -5063,7 +4991,7 @@
       </p:sp>
       <p:sp>
         <p:nvSpPr>
-          <p:cNvPr id="13" name="Text 10"/>
+          <p:cNvPr id="12" name="Text 10"/>
           <p:cNvSpPr txBox="1"/>
           <p:nvPr/>
         </p:nvSpPr>
@@ -5102,7 +5030,7 @@
       </p:sp>
       <p:sp>
         <p:nvSpPr>
-          <p:cNvPr id="14" name="Text 11"/>
+          <p:cNvPr id="13" name="Text 11"/>
           <p:cNvSpPr txBox="1"/>
           <p:nvPr/>
         </p:nvSpPr>
@@ -5144,7 +5072,7 @@
       </p:sp>
       <p:sp>
         <p:nvSpPr>
-          <p:cNvPr id="15" name="Text 12"/>
+          <p:cNvPr id="14" name="Text 12"/>
           <p:cNvSpPr txBox="1"/>
           <p:nvPr/>
         </p:nvSpPr>
@@ -5885,7 +5813,7 @@
       </p:graphicFrame>
       <p:sp>
         <p:nvSpPr>
-          <p:cNvPr id="17" name="Text 13"/>
+          <p:cNvPr id="16" name="Text 13"/>
           <p:cNvSpPr txBox="1"/>
           <p:nvPr/>
         </p:nvSpPr>
@@ -6004,33 +5932,9 @@
           </a:ln>
         </p:spPr>
       </p:sp>
-      <p:pic>
-        <p:nvPicPr>
-          <p:cNvPr id="4" name="Image 0" descr="정석항공과학고등학교 교표">    </p:cNvPr>
-          <p:cNvPicPr>
-            <a:picLocks noChangeAspect="1"/>
-          </p:cNvPicPr>
-          <p:nvPr/>
-        </p:nvPicPr>
-        <p:blipFill>
-          <a:blip r:embed="rId1"/>
-          <a:stretch>
-            <a:fillRect/>
-          </a:stretch>
-        </p:blipFill>
-        <p:spPr>
-          <a:xfrm>
-            <a:off x="7973568" y="201168"/>
-            <a:ext cx="713232" cy="305410"/>
-          </a:xfrm>
-          <a:prstGeom prst="rect">
-            <a:avLst/>
-          </a:prstGeom>
-        </p:spPr>
-      </p:pic>
-      <p:sp>
-        <p:nvSpPr>
-          <p:cNvPr id="5" name="Text 2"/>
+      <p:sp>
+        <p:nvSpPr>
+          <p:cNvPr id="4" name="Text 2"/>
           <p:cNvSpPr txBox="1"/>
           <p:nvPr/>
         </p:nvSpPr>
@@ -6069,14 +5973,14 @@
       </p:sp>
       <p:sp>
         <p:nvSpPr>
-          <p:cNvPr id="6" name="Text 3"/>
+          <p:cNvPr id="5" name="Text 3"/>
           <p:cNvSpPr txBox="1"/>
           <p:nvPr/>
         </p:nvSpPr>
         <p:spPr>
           <a:xfrm>
             <a:off x="457200" y="82296"/>
-            <a:ext cx="7132320" cy="548640"/>
+            <a:ext cx="5120640" cy="548640"/>
           </a:xfrm>
           <a:prstGeom prst="rect">
             <a:avLst/>
@@ -6108,7 +6012,7 @@
       </p:sp>
       <p:sp>
         <p:nvSpPr>
-          <p:cNvPr id="7" name="Text 4"/>
+          <p:cNvPr id="6" name="Text 4"/>
           <p:cNvSpPr txBox="1"/>
           <p:nvPr/>
         </p:nvSpPr>
@@ -6147,7 +6051,7 @@
       </p:sp>
       <p:sp>
         <p:nvSpPr>
-          <p:cNvPr id="8" name="Text 5"/>
+          <p:cNvPr id="7" name="Text 5"/>
           <p:cNvSpPr txBox="1"/>
           <p:nvPr/>
         </p:nvSpPr>
@@ -8800,7 +8704,7 @@
       </p:graphicFrame>
       <p:sp>
         <p:nvSpPr>
-          <p:cNvPr id="10" name="Text 6"/>
+          <p:cNvPr id="9" name="Text 6"/>
           <p:cNvSpPr txBox="1"/>
           <p:nvPr/>
         </p:nvSpPr>
@@ -8839,7 +8743,7 @@
       </p:sp>
       <p:sp>
         <p:nvSpPr>
-          <p:cNvPr id="11" name="Text 7"/>
+          <p:cNvPr id="10" name="Text 7"/>
           <p:cNvSpPr txBox="1"/>
           <p:nvPr/>
         </p:nvSpPr>
@@ -9799,7 +9703,7 @@
       </p:graphicFrame>
       <p:sp>
         <p:nvSpPr>
-          <p:cNvPr id="13" name="Text 8"/>
+          <p:cNvPr id="12" name="Text 8"/>
           <p:cNvSpPr txBox="1"/>
           <p:nvPr/>
         </p:nvSpPr>
@@ -9918,33 +9822,9 @@
           </a:ln>
         </p:spPr>
       </p:sp>
-      <p:pic>
-        <p:nvPicPr>
-          <p:cNvPr id="4" name="Image 0" descr="정석항공과학고등학교 교표">    </p:cNvPr>
-          <p:cNvPicPr>
-            <a:picLocks noChangeAspect="1"/>
-          </p:cNvPicPr>
-          <p:nvPr/>
-        </p:nvPicPr>
-        <p:blipFill>
-          <a:blip r:embed="rId1"/>
-          <a:stretch>
-            <a:fillRect/>
-          </a:stretch>
-        </p:blipFill>
-        <p:spPr>
-          <a:xfrm>
-            <a:off x="7973568" y="201168"/>
-            <a:ext cx="713232" cy="305410"/>
-          </a:xfrm>
-          <a:prstGeom prst="rect">
-            <a:avLst/>
-          </a:prstGeom>
-        </p:spPr>
-      </p:pic>
-      <p:sp>
-        <p:nvSpPr>
-          <p:cNvPr id="5" name="Text 2"/>
+      <p:sp>
+        <p:nvSpPr>
+          <p:cNvPr id="4" name="Text 2"/>
           <p:cNvSpPr txBox="1"/>
           <p:nvPr/>
         </p:nvSpPr>
@@ -9983,14 +9863,14 @@
       </p:sp>
       <p:sp>
         <p:nvSpPr>
-          <p:cNvPr id="6" name="Text 3"/>
+          <p:cNvPr id="5" name="Text 3"/>
           <p:cNvSpPr txBox="1"/>
           <p:nvPr/>
         </p:nvSpPr>
         <p:spPr>
           <a:xfrm>
             <a:off x="457200" y="82296"/>
-            <a:ext cx="7132320" cy="548640"/>
+            <a:ext cx="5120640" cy="548640"/>
           </a:xfrm>
           <a:prstGeom prst="rect">
             <a:avLst/>
@@ -10022,7 +9902,7 @@
       </p:sp>
       <p:sp>
         <p:nvSpPr>
-          <p:cNvPr id="7" name="Text 4"/>
+          <p:cNvPr id="6" name="Text 4"/>
           <p:cNvSpPr txBox="1"/>
           <p:nvPr/>
         </p:nvSpPr>
@@ -10061,7 +9941,7 @@
       </p:sp>
       <p:sp>
         <p:nvSpPr>
-          <p:cNvPr id="8" name="Shape 5"/>
+          <p:cNvPr id="7" name="Shape 5"/>
           <p:cNvSpPr/>
           <p:nvPr/>
         </p:nvSpPr>
@@ -10086,7 +9966,7 @@
       </p:sp>
       <p:sp>
         <p:nvSpPr>
-          <p:cNvPr id="9" name="Text 6"/>
+          <p:cNvPr id="8" name="Text 6"/>
           <p:cNvSpPr txBox="1"/>
           <p:nvPr/>
         </p:nvSpPr>
@@ -10148,7 +10028,7 @@
       </p:sp>
       <p:sp>
         <p:nvSpPr>
-          <p:cNvPr id="10" name="Shape 7"/>
+          <p:cNvPr id="9" name="Shape 7"/>
           <p:cNvSpPr/>
           <p:nvPr/>
         </p:nvSpPr>
@@ -10173,7 +10053,7 @@
       </p:sp>
       <p:sp>
         <p:nvSpPr>
-          <p:cNvPr id="11" name="Text 8"/>
+          <p:cNvPr id="10" name="Text 8"/>
           <p:cNvSpPr txBox="1"/>
           <p:nvPr/>
         </p:nvSpPr>
@@ -10215,7 +10095,7 @@
       </p:sp>
       <p:sp>
         <p:nvSpPr>
-          <p:cNvPr id="12" name="Shape 9"/>
+          <p:cNvPr id="11" name="Shape 9"/>
           <p:cNvSpPr/>
           <p:nvPr/>
         </p:nvSpPr>
@@ -10235,7 +10115,7 @@
       </p:sp>
       <p:sp>
         <p:nvSpPr>
-          <p:cNvPr id="13" name="Shape 10"/>
+          <p:cNvPr id="12" name="Shape 10"/>
           <p:cNvSpPr/>
           <p:nvPr/>
         </p:nvSpPr>
@@ -10260,7 +10140,7 @@
       </p:sp>
       <p:sp>
         <p:nvSpPr>
-          <p:cNvPr id="14" name="Text 11"/>
+          <p:cNvPr id="13" name="Text 11"/>
           <p:cNvSpPr txBox="1"/>
           <p:nvPr/>
         </p:nvSpPr>
@@ -10322,7 +10202,7 @@
       </p:sp>
       <p:sp>
         <p:nvSpPr>
-          <p:cNvPr id="15" name="Shape 12"/>
+          <p:cNvPr id="14" name="Shape 12"/>
           <p:cNvSpPr/>
           <p:nvPr/>
         </p:nvSpPr>
@@ -10347,7 +10227,7 @@
       </p:sp>
       <p:sp>
         <p:nvSpPr>
-          <p:cNvPr id="16" name="Text 13"/>
+          <p:cNvPr id="15" name="Text 13"/>
           <p:cNvSpPr txBox="1"/>
           <p:nvPr/>
         </p:nvSpPr>
@@ -10389,7 +10269,7 @@
       </p:sp>
       <p:sp>
         <p:nvSpPr>
-          <p:cNvPr id="17" name="Shape 14"/>
+          <p:cNvPr id="16" name="Shape 14"/>
           <p:cNvSpPr/>
           <p:nvPr/>
         </p:nvSpPr>
@@ -10409,7 +10289,7 @@
       </p:sp>
       <p:sp>
         <p:nvSpPr>
-          <p:cNvPr id="18" name="Shape 15"/>
+          <p:cNvPr id="17" name="Shape 15"/>
           <p:cNvSpPr/>
           <p:nvPr/>
         </p:nvSpPr>
@@ -10434,7 +10314,7 @@
       </p:sp>
       <p:sp>
         <p:nvSpPr>
-          <p:cNvPr id="19" name="Text 16"/>
+          <p:cNvPr id="18" name="Text 16"/>
           <p:cNvSpPr txBox="1"/>
           <p:nvPr/>
         </p:nvSpPr>
@@ -10516,7 +10396,7 @@
       </p:sp>
       <p:sp>
         <p:nvSpPr>
-          <p:cNvPr id="20" name="Shape 17"/>
+          <p:cNvPr id="19" name="Shape 17"/>
           <p:cNvSpPr/>
           <p:nvPr/>
         </p:nvSpPr>
@@ -10541,7 +10421,7 @@
       </p:sp>
       <p:sp>
         <p:nvSpPr>
-          <p:cNvPr id="21" name="Text 18"/>
+          <p:cNvPr id="20" name="Text 18"/>
           <p:cNvSpPr txBox="1"/>
           <p:nvPr/>
         </p:nvSpPr>
@@ -10583,7 +10463,7 @@
       </p:sp>
       <p:sp>
         <p:nvSpPr>
-          <p:cNvPr id="22" name="Shape 19"/>
+          <p:cNvPr id="21" name="Shape 19"/>
           <p:cNvSpPr/>
           <p:nvPr/>
         </p:nvSpPr>
@@ -10603,7 +10483,7 @@
       </p:sp>
       <p:sp>
         <p:nvSpPr>
-          <p:cNvPr id="23" name="Shape 20"/>
+          <p:cNvPr id="22" name="Shape 20"/>
           <p:cNvSpPr/>
           <p:nvPr/>
         </p:nvSpPr>
@@ -10628,7 +10508,7 @@
       </p:sp>
       <p:sp>
         <p:nvSpPr>
-          <p:cNvPr id="24" name="Text 21"/>
+          <p:cNvPr id="23" name="Text 21"/>
           <p:cNvSpPr txBox="1"/>
           <p:nvPr/>
         </p:nvSpPr>
@@ -10690,7 +10570,7 @@
       </p:sp>
       <p:sp>
         <p:nvSpPr>
-          <p:cNvPr id="25" name="Shape 22"/>
+          <p:cNvPr id="24" name="Shape 22"/>
           <p:cNvSpPr/>
           <p:nvPr/>
         </p:nvSpPr>
@@ -10715,7 +10595,7 @@
       </p:sp>
       <p:sp>
         <p:nvSpPr>
-          <p:cNvPr id="26" name="Text 23"/>
+          <p:cNvPr id="25" name="Text 23"/>
           <p:cNvSpPr txBox="1"/>
           <p:nvPr/>
         </p:nvSpPr>
@@ -10757,7 +10637,7 @@
       </p:sp>
       <p:sp>
         <p:nvSpPr>
-          <p:cNvPr id="27" name="Shape 24"/>
+          <p:cNvPr id="26" name="Shape 24"/>
           <p:cNvSpPr/>
           <p:nvPr/>
         </p:nvSpPr>
@@ -10777,7 +10657,7 @@
       </p:sp>
       <p:sp>
         <p:nvSpPr>
-          <p:cNvPr id="28" name="Shape 25"/>
+          <p:cNvPr id="27" name="Shape 25"/>
           <p:cNvSpPr/>
           <p:nvPr/>
         </p:nvSpPr>
@@ -10802,7 +10682,7 @@
       </p:sp>
       <p:sp>
         <p:nvSpPr>
-          <p:cNvPr id="29" name="Text 26"/>
+          <p:cNvPr id="28" name="Text 26"/>
           <p:cNvSpPr txBox="1"/>
           <p:nvPr/>
         </p:nvSpPr>
@@ -10844,7 +10724,7 @@
       </p:sp>
       <p:sp>
         <p:nvSpPr>
-          <p:cNvPr id="30" name="Shape 27"/>
+          <p:cNvPr id="29" name="Shape 27"/>
           <p:cNvSpPr/>
           <p:nvPr/>
         </p:nvSpPr>
@@ -10869,7 +10749,7 @@
       </p:sp>
       <p:sp>
         <p:nvSpPr>
-          <p:cNvPr id="31" name="Text 28"/>
+          <p:cNvPr id="30" name="Text 28"/>
           <p:cNvSpPr txBox="1"/>
           <p:nvPr/>
         </p:nvSpPr>
@@ -10911,7 +10791,7 @@
       </p:sp>
       <p:sp>
         <p:nvSpPr>
-          <p:cNvPr id="32" name="Text 29"/>
+          <p:cNvPr id="31" name="Text 29"/>
           <p:cNvSpPr txBox="1"/>
           <p:nvPr/>
         </p:nvSpPr>
@@ -11030,33 +10910,9 @@
           </a:ln>
         </p:spPr>
       </p:sp>
-      <p:pic>
-        <p:nvPicPr>
-          <p:cNvPr id="4" name="Image 0" descr="정석항공과학고등학교 교표">    </p:cNvPr>
-          <p:cNvPicPr>
-            <a:picLocks noChangeAspect="1"/>
-          </p:cNvPicPr>
-          <p:nvPr/>
-        </p:nvPicPr>
-        <p:blipFill>
-          <a:blip r:embed="rId1"/>
-          <a:stretch>
-            <a:fillRect/>
-          </a:stretch>
-        </p:blipFill>
-        <p:spPr>
-          <a:xfrm>
-            <a:off x="7973568" y="201168"/>
-            <a:ext cx="713232" cy="305410"/>
-          </a:xfrm>
-          <a:prstGeom prst="rect">
-            <a:avLst/>
-          </a:prstGeom>
-        </p:spPr>
-      </p:pic>
-      <p:sp>
-        <p:nvSpPr>
-          <p:cNvPr id="5" name="Text 2"/>
+      <p:sp>
+        <p:nvSpPr>
+          <p:cNvPr id="4" name="Text 2"/>
           <p:cNvSpPr txBox="1"/>
           <p:nvPr/>
         </p:nvSpPr>
@@ -11095,14 +10951,14 @@
       </p:sp>
       <p:sp>
         <p:nvSpPr>
-          <p:cNvPr id="6" name="Text 3"/>
+          <p:cNvPr id="5" name="Text 3"/>
           <p:cNvSpPr txBox="1"/>
           <p:nvPr/>
         </p:nvSpPr>
         <p:spPr>
           <a:xfrm>
             <a:off x="457200" y="82296"/>
-            <a:ext cx="7132320" cy="548640"/>
+            <a:ext cx="5120640" cy="548640"/>
           </a:xfrm>
           <a:prstGeom prst="rect">
             <a:avLst/>
@@ -11134,7 +10990,7 @@
       </p:sp>
       <p:sp>
         <p:nvSpPr>
-          <p:cNvPr id="7" name="Text 4"/>
+          <p:cNvPr id="6" name="Text 4"/>
           <p:cNvSpPr txBox="1"/>
           <p:nvPr/>
         </p:nvSpPr>
@@ -11173,7 +11029,7 @@
       </p:sp>
       <p:sp>
         <p:nvSpPr>
-          <p:cNvPr id="8" name="Shape 5"/>
+          <p:cNvPr id="7" name="Shape 5"/>
           <p:cNvSpPr/>
           <p:nvPr/>
         </p:nvSpPr>
@@ -11198,7 +11054,7 @@
       </p:sp>
       <p:sp>
         <p:nvSpPr>
-          <p:cNvPr id="9" name="Text 6"/>
+          <p:cNvPr id="8" name="Text 6"/>
           <p:cNvSpPr txBox="1"/>
           <p:nvPr/>
         </p:nvSpPr>
@@ -11240,7 +11096,7 @@
       </p:sp>
       <p:sp>
         <p:nvSpPr>
-          <p:cNvPr id="10" name="Shape 7"/>
+          <p:cNvPr id="9" name="Shape 7"/>
           <p:cNvSpPr/>
           <p:nvPr/>
         </p:nvSpPr>
@@ -11265,7 +11121,7 @@
       </p:sp>
       <p:sp>
         <p:nvSpPr>
-          <p:cNvPr id="11" name="Text 8"/>
+          <p:cNvPr id="10" name="Text 8"/>
           <p:cNvSpPr txBox="1"/>
           <p:nvPr/>
         </p:nvSpPr>
@@ -11307,7 +11163,7 @@
       </p:sp>
       <p:sp>
         <p:nvSpPr>
-          <p:cNvPr id="12" name="Shape 9"/>
+          <p:cNvPr id="11" name="Shape 9"/>
           <p:cNvSpPr/>
           <p:nvPr/>
         </p:nvSpPr>
@@ -11327,7 +11183,7 @@
       </p:sp>
       <p:sp>
         <p:nvSpPr>
-          <p:cNvPr id="13" name="Shape 10"/>
+          <p:cNvPr id="12" name="Shape 10"/>
           <p:cNvSpPr/>
           <p:nvPr/>
         </p:nvSpPr>
@@ -11352,7 +11208,7 @@
       </p:sp>
       <p:sp>
         <p:nvSpPr>
-          <p:cNvPr id="14" name="Text 11"/>
+          <p:cNvPr id="13" name="Text 11"/>
           <p:cNvSpPr txBox="1"/>
           <p:nvPr/>
         </p:nvSpPr>
@@ -11394,7 +11250,7 @@
       </p:sp>
       <p:sp>
         <p:nvSpPr>
-          <p:cNvPr id="15" name="Shape 12"/>
+          <p:cNvPr id="14" name="Shape 12"/>
           <p:cNvSpPr/>
           <p:nvPr/>
         </p:nvSpPr>
@@ -11419,7 +11275,7 @@
       </p:sp>
       <p:sp>
         <p:nvSpPr>
-          <p:cNvPr id="16" name="Text 13"/>
+          <p:cNvPr id="15" name="Text 13"/>
           <p:cNvSpPr txBox="1"/>
           <p:nvPr/>
         </p:nvSpPr>
@@ -11461,7 +11317,7 @@
       </p:sp>
       <p:sp>
         <p:nvSpPr>
-          <p:cNvPr id="17" name="Shape 14"/>
+          <p:cNvPr id="16" name="Shape 14"/>
           <p:cNvSpPr/>
           <p:nvPr/>
         </p:nvSpPr>
@@ -11481,7 +11337,7 @@
       </p:sp>
       <p:sp>
         <p:nvSpPr>
-          <p:cNvPr id="18" name="Shape 15"/>
+          <p:cNvPr id="17" name="Shape 15"/>
           <p:cNvSpPr/>
           <p:nvPr/>
         </p:nvSpPr>
@@ -11506,7 +11362,7 @@
       </p:sp>
       <p:sp>
         <p:nvSpPr>
-          <p:cNvPr id="19" name="Text 16"/>
+          <p:cNvPr id="18" name="Text 16"/>
           <p:cNvSpPr txBox="1"/>
           <p:nvPr/>
         </p:nvSpPr>
@@ -11568,7 +11424,7 @@
       </p:sp>
       <p:sp>
         <p:nvSpPr>
-          <p:cNvPr id="20" name="Shape 17"/>
+          <p:cNvPr id="19" name="Shape 17"/>
           <p:cNvSpPr/>
           <p:nvPr/>
         </p:nvSpPr>
@@ -11593,7 +11449,7 @@
       </p:sp>
       <p:sp>
         <p:nvSpPr>
-          <p:cNvPr id="21" name="Text 18"/>
+          <p:cNvPr id="20" name="Text 18"/>
           <p:cNvSpPr txBox="1"/>
           <p:nvPr/>
         </p:nvSpPr>
@@ -11655,7 +11511,7 @@
       </p:sp>
       <p:sp>
         <p:nvSpPr>
-          <p:cNvPr id="22" name="Shape 19"/>
+          <p:cNvPr id="21" name="Shape 19"/>
           <p:cNvSpPr/>
           <p:nvPr/>
         </p:nvSpPr>
@@ -11675,7 +11531,7 @@
       </p:sp>
       <p:sp>
         <p:nvSpPr>
-          <p:cNvPr id="23" name="Shape 20"/>
+          <p:cNvPr id="22" name="Shape 20"/>
           <p:cNvSpPr/>
           <p:nvPr/>
         </p:nvSpPr>
@@ -11700,7 +11556,7 @@
       </p:sp>
       <p:sp>
         <p:nvSpPr>
-          <p:cNvPr id="24" name="Text 21"/>
+          <p:cNvPr id="23" name="Text 21"/>
           <p:cNvSpPr txBox="1"/>
           <p:nvPr/>
         </p:nvSpPr>
@@ -11742,7 +11598,7 @@
       </p:sp>
       <p:sp>
         <p:nvSpPr>
-          <p:cNvPr id="25" name="Shape 22"/>
+          <p:cNvPr id="24" name="Shape 22"/>
           <p:cNvSpPr/>
           <p:nvPr/>
         </p:nvSpPr>
@@ -11767,7 +11623,7 @@
       </p:sp>
       <p:sp>
         <p:nvSpPr>
-          <p:cNvPr id="26" name="Text 23"/>
+          <p:cNvPr id="25" name="Text 23"/>
           <p:cNvSpPr txBox="1"/>
           <p:nvPr/>
         </p:nvSpPr>
@@ -11829,7 +11685,7 @@
       </p:sp>
       <p:sp>
         <p:nvSpPr>
-          <p:cNvPr id="27" name="Shape 24"/>
+          <p:cNvPr id="26" name="Shape 24"/>
           <p:cNvSpPr/>
           <p:nvPr/>
         </p:nvSpPr>
@@ -11849,7 +11705,7 @@
       </p:sp>
       <p:sp>
         <p:nvSpPr>
-          <p:cNvPr id="28" name="Shape 25"/>
+          <p:cNvPr id="27" name="Shape 25"/>
           <p:cNvSpPr/>
           <p:nvPr/>
         </p:nvSpPr>
@@ -11874,7 +11730,7 @@
       </p:sp>
       <p:sp>
         <p:nvSpPr>
-          <p:cNvPr id="29" name="Text 26"/>
+          <p:cNvPr id="28" name="Text 26"/>
           <p:cNvSpPr txBox="1"/>
           <p:nvPr/>
         </p:nvSpPr>
@@ -11916,7 +11772,7 @@
       </p:sp>
       <p:sp>
         <p:nvSpPr>
-          <p:cNvPr id="30" name="Shape 27"/>
+          <p:cNvPr id="29" name="Shape 27"/>
           <p:cNvSpPr/>
           <p:nvPr/>
         </p:nvSpPr>
@@ -11941,7 +11797,7 @@
       </p:sp>
       <p:sp>
         <p:nvSpPr>
-          <p:cNvPr id="31" name="Text 28"/>
+          <p:cNvPr id="30" name="Text 28"/>
           <p:cNvSpPr txBox="1"/>
           <p:nvPr/>
         </p:nvSpPr>
@@ -11983,7 +11839,7 @@
       </p:sp>
       <p:sp>
         <p:nvSpPr>
-          <p:cNvPr id="32" name="Text 29"/>
+          <p:cNvPr id="31" name="Text 29"/>
           <p:cNvSpPr txBox="1"/>
           <p:nvPr/>
         </p:nvSpPr>
@@ -13206,33 +13062,9 @@
           </a:ln>
         </p:spPr>
       </p:sp>
-      <p:pic>
-        <p:nvPicPr>
-          <p:cNvPr id="4" name="Image 0" descr="정석항공과학고등학교 교표">    </p:cNvPr>
-          <p:cNvPicPr>
-            <a:picLocks noChangeAspect="1"/>
-          </p:cNvPicPr>
-          <p:nvPr/>
-        </p:nvPicPr>
-        <p:blipFill>
-          <a:blip r:embed="rId1"/>
-          <a:stretch>
-            <a:fillRect/>
-          </a:stretch>
-        </p:blipFill>
-        <p:spPr>
-          <a:xfrm>
-            <a:off x="7973568" y="201168"/>
-            <a:ext cx="713232" cy="305410"/>
-          </a:xfrm>
-          <a:prstGeom prst="rect">
-            <a:avLst/>
-          </a:prstGeom>
-        </p:spPr>
-      </p:pic>
-      <p:sp>
-        <p:nvSpPr>
-          <p:cNvPr id="5" name="Text 2"/>
+      <p:sp>
+        <p:nvSpPr>
+          <p:cNvPr id="4" name="Text 2"/>
           <p:cNvSpPr txBox="1"/>
           <p:nvPr/>
         </p:nvSpPr>
@@ -13271,14 +13103,14 @@
       </p:sp>
       <p:sp>
         <p:nvSpPr>
-          <p:cNvPr id="6" name="Text 3"/>
+          <p:cNvPr id="5" name="Text 3"/>
           <p:cNvSpPr txBox="1"/>
           <p:nvPr/>
         </p:nvSpPr>
         <p:spPr>
           <a:xfrm>
             <a:off x="457200" y="82296"/>
-            <a:ext cx="7132320" cy="548640"/>
+            <a:ext cx="5120640" cy="548640"/>
           </a:xfrm>
           <a:prstGeom prst="rect">
             <a:avLst/>
@@ -13310,14 +13142,14 @@
       </p:sp>
       <p:sp>
         <p:nvSpPr>
-          <p:cNvPr id="7" name="Text 4"/>
+          <p:cNvPr id="6" name="Text 4"/>
           <p:cNvSpPr txBox="1"/>
           <p:nvPr/>
         </p:nvSpPr>
         <p:spPr>
           <a:xfrm>
             <a:off x="4937760" y="201168"/>
-            <a:ext cx="2880360" cy="310896"/>
+            <a:ext cx="3749040" cy="310896"/>
           </a:xfrm>
           <a:prstGeom prst="rect">
             <a:avLst/>
@@ -13349,7 +13181,7 @@
       </p:sp>
       <p:sp>
         <p:nvSpPr>
-          <p:cNvPr id="8" name="Text 5"/>
+          <p:cNvPr id="7" name="Text 5"/>
           <p:cNvSpPr txBox="1"/>
           <p:nvPr/>
         </p:nvSpPr>
@@ -13388,7 +13220,7 @@
       </p:sp>
       <p:sp>
         <p:nvSpPr>
-          <p:cNvPr id="9" name="Text 6"/>
+          <p:cNvPr id="8" name="Text 6"/>
           <p:cNvSpPr txBox="1"/>
           <p:nvPr/>
         </p:nvSpPr>
@@ -13427,7 +13259,7 @@
       </p:sp>
       <p:sp>
         <p:nvSpPr>
-          <p:cNvPr id="10" name="Text 7"/>
+          <p:cNvPr id="9" name="Text 7"/>
           <p:cNvSpPr txBox="1"/>
           <p:nvPr/>
         </p:nvSpPr>
@@ -13469,7 +13301,7 @@
       </p:sp>
       <p:sp>
         <p:nvSpPr>
-          <p:cNvPr id="11" name="Text 8"/>
+          <p:cNvPr id="10" name="Text 8"/>
           <p:cNvSpPr txBox="1"/>
           <p:nvPr/>
         </p:nvSpPr>
@@ -13508,7 +13340,7 @@
       </p:sp>
       <p:sp>
         <p:nvSpPr>
-          <p:cNvPr id="12" name="Text 9"/>
+          <p:cNvPr id="11" name="Text 9"/>
           <p:cNvSpPr txBox="1"/>
           <p:nvPr/>
         </p:nvSpPr>
@@ -13550,7 +13382,7 @@
       </p:sp>
       <p:sp>
         <p:nvSpPr>
-          <p:cNvPr id="13" name="Text 10"/>
+          <p:cNvPr id="12" name="Text 10"/>
           <p:cNvSpPr txBox="1"/>
           <p:nvPr/>
         </p:nvSpPr>
@@ -13589,7 +13421,7 @@
       </p:sp>
       <p:sp>
         <p:nvSpPr>
-          <p:cNvPr id="14" name="Text 11"/>
+          <p:cNvPr id="13" name="Text 11"/>
           <p:cNvSpPr txBox="1"/>
           <p:nvPr/>
         </p:nvSpPr>
@@ -13628,7 +13460,7 @@
       </p:sp>
       <p:sp>
         <p:nvSpPr>
-          <p:cNvPr id="15" name="Text 12"/>
+          <p:cNvPr id="14" name="Text 12"/>
           <p:cNvSpPr txBox="1"/>
           <p:nvPr/>
         </p:nvSpPr>
@@ -13670,7 +13502,7 @@
       </p:sp>
       <p:sp>
         <p:nvSpPr>
-          <p:cNvPr id="16" name="Text 13"/>
+          <p:cNvPr id="15" name="Text 13"/>
           <p:cNvSpPr txBox="1"/>
           <p:nvPr/>
         </p:nvSpPr>
@@ -13709,7 +13541,7 @@
       </p:sp>
       <p:sp>
         <p:nvSpPr>
-          <p:cNvPr id="17" name="Text 14"/>
+          <p:cNvPr id="16" name="Text 14"/>
           <p:cNvSpPr txBox="1"/>
           <p:nvPr/>
         </p:nvSpPr>
@@ -14527,33 +14359,9 @@
           </a:ln>
         </p:spPr>
       </p:sp>
-      <p:pic>
-        <p:nvPicPr>
-          <p:cNvPr id="4" name="Image 0" descr="정석항공과학고등학교 교표">    </p:cNvPr>
-          <p:cNvPicPr>
-            <a:picLocks noChangeAspect="1"/>
-          </p:cNvPicPr>
-          <p:nvPr/>
-        </p:nvPicPr>
-        <p:blipFill>
-          <a:blip r:embed="rId1"/>
-          <a:stretch>
-            <a:fillRect/>
-          </a:stretch>
-        </p:blipFill>
-        <p:spPr>
-          <a:xfrm>
-            <a:off x="7973568" y="201168"/>
-            <a:ext cx="713232" cy="305410"/>
-          </a:xfrm>
-          <a:prstGeom prst="rect">
-            <a:avLst/>
-          </a:prstGeom>
-        </p:spPr>
-      </p:pic>
-      <p:sp>
-        <p:nvSpPr>
-          <p:cNvPr id="5" name="Text 2"/>
+      <p:sp>
+        <p:nvSpPr>
+          <p:cNvPr id="4" name="Text 2"/>
           <p:cNvSpPr txBox="1"/>
           <p:nvPr/>
         </p:nvSpPr>
@@ -14592,14 +14400,14 @@
       </p:sp>
       <p:sp>
         <p:nvSpPr>
-          <p:cNvPr id="6" name="Text 3"/>
+          <p:cNvPr id="5" name="Text 3"/>
           <p:cNvSpPr txBox="1"/>
           <p:nvPr/>
         </p:nvSpPr>
         <p:spPr>
           <a:xfrm>
             <a:off x="457200" y="82296"/>
-            <a:ext cx="7132320" cy="548640"/>
+            <a:ext cx="5120640" cy="548640"/>
           </a:xfrm>
           <a:prstGeom prst="rect">
             <a:avLst/>
@@ -14631,14 +14439,14 @@
       </p:sp>
       <p:sp>
         <p:nvSpPr>
-          <p:cNvPr id="7" name="Text 4"/>
+          <p:cNvPr id="6" name="Text 4"/>
           <p:cNvSpPr txBox="1"/>
           <p:nvPr/>
         </p:nvSpPr>
         <p:spPr>
           <a:xfrm>
             <a:off x="4937760" y="201168"/>
-            <a:ext cx="2880360" cy="310896"/>
+            <a:ext cx="3749040" cy="310896"/>
           </a:xfrm>
           <a:prstGeom prst="rect">
             <a:avLst/>
@@ -14670,7 +14478,7 @@
       </p:sp>
       <p:sp>
         <p:nvSpPr>
-          <p:cNvPr id="8" name="Text 5"/>
+          <p:cNvPr id="7" name="Text 5"/>
           <p:cNvSpPr txBox="1"/>
           <p:nvPr/>
         </p:nvSpPr>
@@ -14709,7 +14517,7 @@
       </p:sp>
       <p:sp>
         <p:nvSpPr>
-          <p:cNvPr id="9" name="Text 6"/>
+          <p:cNvPr id="8" name="Text 6"/>
           <p:cNvSpPr txBox="1"/>
           <p:nvPr/>
         </p:nvSpPr>
@@ -14748,7 +14556,7 @@
       </p:sp>
       <p:sp>
         <p:nvSpPr>
-          <p:cNvPr id="10" name="Text 7"/>
+          <p:cNvPr id="9" name="Text 7"/>
           <p:cNvSpPr txBox="1"/>
           <p:nvPr/>
         </p:nvSpPr>
@@ -14790,7 +14598,7 @@
       </p:sp>
       <p:sp>
         <p:nvSpPr>
-          <p:cNvPr id="11" name="Text 8"/>
+          <p:cNvPr id="10" name="Text 8"/>
           <p:cNvSpPr txBox="1"/>
           <p:nvPr/>
         </p:nvSpPr>
@@ -14829,7 +14637,7 @@
       </p:sp>
       <p:sp>
         <p:nvSpPr>
-          <p:cNvPr id="12" name="Text 9"/>
+          <p:cNvPr id="11" name="Text 9"/>
           <p:cNvSpPr txBox="1"/>
           <p:nvPr/>
         </p:nvSpPr>
@@ -14871,7 +14679,7 @@
       </p:sp>
       <p:sp>
         <p:nvSpPr>
-          <p:cNvPr id="13" name="Text 10"/>
+          <p:cNvPr id="12" name="Text 10"/>
           <p:cNvSpPr txBox="1"/>
           <p:nvPr/>
         </p:nvSpPr>
@@ -15914,7 +15722,7 @@
       </p:graphicFrame>
       <p:sp>
         <p:nvSpPr>
-          <p:cNvPr id="15" name="Text 11"/>
+          <p:cNvPr id="14" name="Text 11"/>
           <p:cNvSpPr txBox="1"/>
           <p:nvPr/>
         </p:nvSpPr>
@@ -15953,7 +15761,7 @@
       </p:sp>
       <p:sp>
         <p:nvSpPr>
-          <p:cNvPr id="16" name="Text 12"/>
+          <p:cNvPr id="15" name="Text 12"/>
           <p:cNvSpPr txBox="1"/>
           <p:nvPr/>
         </p:nvSpPr>
@@ -15992,7 +15800,7 @@
       </p:sp>
       <p:sp>
         <p:nvSpPr>
-          <p:cNvPr id="17" name="Text 13"/>
+          <p:cNvPr id="16" name="Text 13"/>
           <p:cNvSpPr txBox="1"/>
           <p:nvPr/>
         </p:nvSpPr>
@@ -16034,7 +15842,7 @@
       </p:sp>
       <p:sp>
         <p:nvSpPr>
-          <p:cNvPr id="18" name="Text 14"/>
+          <p:cNvPr id="17" name="Text 14"/>
           <p:cNvSpPr txBox="1"/>
           <p:nvPr/>
         </p:nvSpPr>
@@ -16073,7 +15881,7 @@
       </p:sp>
       <p:sp>
         <p:nvSpPr>
-          <p:cNvPr id="19" name="Text 15"/>
+          <p:cNvPr id="18" name="Text 15"/>
           <p:cNvSpPr txBox="1"/>
           <p:nvPr/>
         </p:nvSpPr>
@@ -16115,7 +15923,7 @@
       </p:sp>
       <p:sp>
         <p:nvSpPr>
-          <p:cNvPr id="20" name="Text 16"/>
+          <p:cNvPr id="19" name="Text 16"/>
           <p:cNvSpPr txBox="1"/>
           <p:nvPr/>
         </p:nvSpPr>
@@ -16154,7 +15962,7 @@
       </p:sp>
       <p:sp>
         <p:nvSpPr>
-          <p:cNvPr id="21" name="Text 17"/>
+          <p:cNvPr id="20" name="Text 17"/>
           <p:cNvSpPr txBox="1"/>
           <p:nvPr/>
         </p:nvSpPr>
@@ -16276,33 +16084,9 @@
           </a:ln>
         </p:spPr>
       </p:sp>
-      <p:pic>
-        <p:nvPicPr>
-          <p:cNvPr id="4" name="Image 0" descr="정석항공과학고등학교 교표">    </p:cNvPr>
-          <p:cNvPicPr>
-            <a:picLocks noChangeAspect="1"/>
-          </p:cNvPicPr>
-          <p:nvPr/>
-        </p:nvPicPr>
-        <p:blipFill>
-          <a:blip r:embed="rId1"/>
-          <a:stretch>
-            <a:fillRect/>
-          </a:stretch>
-        </p:blipFill>
-        <p:spPr>
-          <a:xfrm>
-            <a:off x="7973568" y="201168"/>
-            <a:ext cx="713232" cy="305410"/>
-          </a:xfrm>
-          <a:prstGeom prst="rect">
-            <a:avLst/>
-          </a:prstGeom>
-        </p:spPr>
-      </p:pic>
-      <p:sp>
-        <p:nvSpPr>
-          <p:cNvPr id="5" name="Text 2"/>
+      <p:sp>
+        <p:nvSpPr>
+          <p:cNvPr id="4" name="Text 2"/>
           <p:cNvSpPr txBox="1"/>
           <p:nvPr/>
         </p:nvSpPr>
@@ -16341,14 +16125,14 @@
       </p:sp>
       <p:sp>
         <p:nvSpPr>
-          <p:cNvPr id="6" name="Text 3"/>
+          <p:cNvPr id="5" name="Text 3"/>
           <p:cNvSpPr txBox="1"/>
           <p:nvPr/>
         </p:nvSpPr>
         <p:spPr>
           <a:xfrm>
             <a:off x="457200" y="82296"/>
-            <a:ext cx="7132320" cy="548640"/>
+            <a:ext cx="5120640" cy="548640"/>
           </a:xfrm>
           <a:prstGeom prst="rect">
             <a:avLst/>
@@ -16380,14 +16164,14 @@
       </p:sp>
       <p:sp>
         <p:nvSpPr>
-          <p:cNvPr id="7" name="Text 4"/>
+          <p:cNvPr id="6" name="Text 4"/>
           <p:cNvSpPr txBox="1"/>
           <p:nvPr/>
         </p:nvSpPr>
         <p:spPr>
           <a:xfrm>
             <a:off x="4937760" y="201168"/>
-            <a:ext cx="2880360" cy="310896"/>
+            <a:ext cx="3749040" cy="310896"/>
           </a:xfrm>
           <a:prstGeom prst="rect">
             <a:avLst/>
@@ -16419,7 +16203,7 @@
       </p:sp>
       <p:sp>
         <p:nvSpPr>
-          <p:cNvPr id="8" name="Text 5"/>
+          <p:cNvPr id="7" name="Text 5"/>
           <p:cNvSpPr txBox="1"/>
           <p:nvPr/>
         </p:nvSpPr>
@@ -16458,7 +16242,7 @@
       </p:sp>
       <p:sp>
         <p:nvSpPr>
-          <p:cNvPr id="9" name="Text 6"/>
+          <p:cNvPr id="8" name="Text 6"/>
           <p:cNvSpPr txBox="1"/>
           <p:nvPr/>
         </p:nvSpPr>
@@ -16497,7 +16281,7 @@
       </p:sp>
       <p:sp>
         <p:nvSpPr>
-          <p:cNvPr id="10" name="Text 7"/>
+          <p:cNvPr id="9" name="Text 7"/>
           <p:cNvSpPr txBox="1"/>
           <p:nvPr/>
         </p:nvSpPr>
@@ -16539,7 +16323,7 @@
       </p:sp>
       <p:sp>
         <p:nvSpPr>
-          <p:cNvPr id="11" name="Text 8"/>
+          <p:cNvPr id="10" name="Text 8"/>
           <p:cNvSpPr txBox="1"/>
           <p:nvPr/>
         </p:nvSpPr>
@@ -16578,7 +16362,7 @@
       </p:sp>
       <p:sp>
         <p:nvSpPr>
-          <p:cNvPr id="12" name="Text 9"/>
+          <p:cNvPr id="11" name="Text 9"/>
           <p:cNvSpPr txBox="1"/>
           <p:nvPr/>
         </p:nvSpPr>
@@ -16620,7 +16404,7 @@
       </p:sp>
       <p:sp>
         <p:nvSpPr>
-          <p:cNvPr id="13" name="Text 10"/>
+          <p:cNvPr id="12" name="Text 10"/>
           <p:cNvSpPr txBox="1"/>
           <p:nvPr/>
         </p:nvSpPr>
@@ -17663,7 +17447,7 @@
       </p:graphicFrame>
       <p:sp>
         <p:nvSpPr>
-          <p:cNvPr id="15" name="Text 11"/>
+          <p:cNvPr id="14" name="Text 11"/>
           <p:cNvSpPr txBox="1"/>
           <p:nvPr/>
         </p:nvSpPr>
@@ -17702,7 +17486,7 @@
       </p:sp>
       <p:sp>
         <p:nvSpPr>
-          <p:cNvPr id="16" name="Text 12"/>
+          <p:cNvPr id="15" name="Text 12"/>
           <p:cNvSpPr txBox="1"/>
           <p:nvPr/>
         </p:nvSpPr>
@@ -17741,7 +17525,7 @@
       </p:sp>
       <p:sp>
         <p:nvSpPr>
-          <p:cNvPr id="17" name="Text 13"/>
+          <p:cNvPr id="16" name="Text 13"/>
           <p:cNvSpPr txBox="1"/>
           <p:nvPr/>
         </p:nvSpPr>
@@ -17783,7 +17567,7 @@
       </p:sp>
       <p:sp>
         <p:nvSpPr>
-          <p:cNvPr id="18" name="Text 14"/>
+          <p:cNvPr id="17" name="Text 14"/>
           <p:cNvSpPr txBox="1"/>
           <p:nvPr/>
         </p:nvSpPr>
@@ -17822,7 +17606,7 @@
       </p:sp>
       <p:sp>
         <p:nvSpPr>
-          <p:cNvPr id="19" name="Text 15"/>
+          <p:cNvPr id="18" name="Text 15"/>
           <p:cNvSpPr txBox="1"/>
           <p:nvPr/>
         </p:nvSpPr>
@@ -17944,33 +17728,9 @@
           </a:ln>
         </p:spPr>
       </p:sp>
-      <p:pic>
-        <p:nvPicPr>
-          <p:cNvPr id="4" name="Image 0" descr="정석항공과학고등학교 교표">    </p:cNvPr>
-          <p:cNvPicPr>
-            <a:picLocks noChangeAspect="1"/>
-          </p:cNvPicPr>
-          <p:nvPr/>
-        </p:nvPicPr>
-        <p:blipFill>
-          <a:blip r:embed="rId1"/>
-          <a:stretch>
-            <a:fillRect/>
-          </a:stretch>
-        </p:blipFill>
-        <p:spPr>
-          <a:xfrm>
-            <a:off x="7973568" y="201168"/>
-            <a:ext cx="713232" cy="305410"/>
-          </a:xfrm>
-          <a:prstGeom prst="rect">
-            <a:avLst/>
-          </a:prstGeom>
-        </p:spPr>
-      </p:pic>
-      <p:sp>
-        <p:nvSpPr>
-          <p:cNvPr id="5" name="Text 2"/>
+      <p:sp>
+        <p:nvSpPr>
+          <p:cNvPr id="4" name="Text 2"/>
           <p:cNvSpPr txBox="1"/>
           <p:nvPr/>
         </p:nvSpPr>
@@ -18009,14 +17769,14 @@
       </p:sp>
       <p:sp>
         <p:nvSpPr>
-          <p:cNvPr id="6" name="Text 3"/>
+          <p:cNvPr id="5" name="Text 3"/>
           <p:cNvSpPr txBox="1"/>
           <p:nvPr/>
         </p:nvSpPr>
         <p:spPr>
           <a:xfrm>
             <a:off x="457200" y="82296"/>
-            <a:ext cx="7132320" cy="548640"/>
+            <a:ext cx="5120640" cy="548640"/>
           </a:xfrm>
           <a:prstGeom prst="rect">
             <a:avLst/>
@@ -18048,14 +17808,14 @@
       </p:sp>
       <p:sp>
         <p:nvSpPr>
-          <p:cNvPr id="7" name="Text 4"/>
+          <p:cNvPr id="6" name="Text 4"/>
           <p:cNvSpPr txBox="1"/>
           <p:nvPr/>
         </p:nvSpPr>
         <p:spPr>
           <a:xfrm>
             <a:off x="4937760" y="201168"/>
-            <a:ext cx="2880360" cy="310896"/>
+            <a:ext cx="3749040" cy="310896"/>
           </a:xfrm>
           <a:prstGeom prst="rect">
             <a:avLst/>
@@ -18087,7 +17847,7 @@
       </p:sp>
       <p:sp>
         <p:nvSpPr>
-          <p:cNvPr id="8" name="Text 5"/>
+          <p:cNvPr id="7" name="Text 5"/>
           <p:cNvSpPr txBox="1"/>
           <p:nvPr/>
         </p:nvSpPr>
@@ -18126,7 +17886,7 @@
       </p:sp>
       <p:sp>
         <p:nvSpPr>
-          <p:cNvPr id="9" name="Text 6"/>
+          <p:cNvPr id="8" name="Text 6"/>
           <p:cNvSpPr txBox="1"/>
           <p:nvPr/>
         </p:nvSpPr>
@@ -18165,7 +17925,7 @@
       </p:sp>
       <p:sp>
         <p:nvSpPr>
-          <p:cNvPr id="10" name="Text 7"/>
+          <p:cNvPr id="9" name="Text 7"/>
           <p:cNvSpPr txBox="1"/>
           <p:nvPr/>
         </p:nvSpPr>
@@ -18207,7 +17967,7 @@
       </p:sp>
       <p:sp>
         <p:nvSpPr>
-          <p:cNvPr id="11" name="Text 8"/>
+          <p:cNvPr id="10" name="Text 8"/>
           <p:cNvSpPr txBox="1"/>
           <p:nvPr/>
         </p:nvSpPr>
@@ -18246,7 +18006,7 @@
       </p:sp>
       <p:sp>
         <p:nvSpPr>
-          <p:cNvPr id="12" name="Text 9"/>
+          <p:cNvPr id="11" name="Text 9"/>
           <p:cNvSpPr txBox="1"/>
           <p:nvPr/>
         </p:nvSpPr>
@@ -18288,7 +18048,7 @@
       </p:sp>
       <p:sp>
         <p:nvSpPr>
-          <p:cNvPr id="13" name="Text 10"/>
+          <p:cNvPr id="12" name="Text 10"/>
           <p:cNvSpPr txBox="1"/>
           <p:nvPr/>
         </p:nvSpPr>
@@ -18759,7 +18519,7 @@
       </p:graphicFrame>
       <p:sp>
         <p:nvSpPr>
-          <p:cNvPr id="15" name="Text 11"/>
+          <p:cNvPr id="14" name="Text 11"/>
           <p:cNvSpPr txBox="1"/>
           <p:nvPr/>
         </p:nvSpPr>
@@ -19454,7 +19214,7 @@
       </p:graphicFrame>
       <p:sp>
         <p:nvSpPr>
-          <p:cNvPr id="17" name="Text 12"/>
+          <p:cNvPr id="16" name="Text 12"/>
           <p:cNvSpPr txBox="1"/>
           <p:nvPr/>
         </p:nvSpPr>

</xml_diff>

<commit_message>
Reverse the cover title to white and add the report date
presentation.xml's defaultTextStyle sets bg1 (white) and bold
HY헤드라인M, so the reference's cover title is white on its band, not
black as the first pass had it. The subtitle moves up into the band
alongside it, and a blue 2026. 9. date now sits below the band where
the reference carries its own report date.

Co-Authored-By: Claude Opus 5 <noreply@anthropic.com>
Claude-Session: https://claude.ai/code/session_01GZfitk2JEKppZ4fGSDdghv
</commit_message>
<xml_diff>
--- a/docs/2027년_사무직원_채용계획안.pptx
+++ b/docs/2027년_사무직원_채용계획안.pptx
@@ -1848,8 +1848,8 @@
         </p:nvSpPr>
         <p:spPr>
           <a:xfrm>
-            <a:off x="457200" y="1929384"/>
-            <a:ext cx="8229600" cy="1929384"/>
+            <a:off x="457200" y="2212848"/>
+            <a:ext cx="8229600" cy="841248"/>
           </a:xfrm>
           <a:prstGeom prst="rect">
             <a:avLst/>
@@ -1872,9 +1872,9 @@
               <a:buNone/>
             </a:pPr>
             <a:r>
-              <a:rPr lang="en-US" sz="3200" dirty="0">
+              <a:rPr lang="en-US" sz="3200" b="1" dirty="0">
                 <a:solidFill>
-                  <a:srgbClr val="000000"/>
+                  <a:srgbClr val="FFFFFF"/>
                 </a:solidFill>
                 <a:latin typeface="HY헤드라인M" pitchFamily="34" charset="0"/>
                 <a:ea typeface="HY헤드라인M" pitchFamily="34" charset="-122"/>
@@ -1894,7 +1894,7 @@
         </p:nvSpPr>
         <p:spPr>
           <a:xfrm>
-            <a:off x="457200" y="4261104"/>
+            <a:off x="457200" y="3127248"/>
             <a:ext cx="8229600" cy="365760"/>
           </a:xfrm>
           <a:prstGeom prst="rect">
@@ -1911,7 +1911,46 @@
               <a:buNone/>
             </a:pPr>
             <a:r>
-              <a:rPr lang="en-US" sz="1600" dirty="0">
+              <a:rPr lang="en-US" sz="1500" dirty="0">
+                <a:solidFill>
+                  <a:srgbClr val="FFFFFF"/>
+                </a:solidFill>
+                <a:latin typeface="맑은 고딕" pitchFamily="34" charset="0"/>
+                <a:ea typeface="맑은 고딕" pitchFamily="34" charset="-122"/>
+                <a:cs typeface="맑은 고딕" pitchFamily="34" charset="-120"/>
+              </a:rPr>
+              <a:t>기술·관리운영직(9급) 1명 공개채용</a:t>
+            </a:r>
+            <a:endParaRPr lang="en-US" sz="1500" dirty="0"/>
+          </a:p>
+        </p:txBody>
+      </p:sp>
+      <p:sp>
+        <p:nvSpPr>
+          <p:cNvPr id="7" name="Text 5"/>
+          <p:cNvSpPr txBox="1"/>
+          <p:nvPr/>
+        </p:nvSpPr>
+        <p:spPr>
+          <a:xfrm>
+            <a:off x="457200" y="4297680"/>
+            <a:ext cx="8229600" cy="402336"/>
+          </a:xfrm>
+          <a:prstGeom prst="rect">
+            <a:avLst/>
+          </a:prstGeom>
+          <a:noFill/>
+          <a:ln/>
+        </p:spPr>
+        <p:txBody>
+          <a:bodyPr wrap="square" lIns="0" tIns="0" rIns="0" bIns="0" rtlCol="0" anchor="ctr"/>
+          <a:lstStyle/>
+          <a:p>
+            <a:pPr eaLnBrk="0" latinLnBrk="0" algn="ctr" indent="0" marL="0">
+              <a:buNone/>
+            </a:pPr>
+            <a:r>
+              <a:rPr lang="en-US" sz="1700" dirty="0">
                 <a:solidFill>
                   <a:srgbClr val="263FFA"/>
                 </a:solidFill>
@@ -1919,15 +1958,15 @@
                 <a:ea typeface="맑은 고딕" pitchFamily="34" charset="-122"/>
                 <a:cs typeface="맑은 고딕" pitchFamily="34" charset="-120"/>
               </a:rPr>
-              <a:t>기술·관리운영직(9급) 1명 공개채용</a:t>
+              <a:t>2026.  9.</a:t>
             </a:r>
-            <a:endParaRPr lang="en-US" sz="1600" dirty="0"/>
+            <a:endParaRPr lang="en-US" sz="1700" dirty="0"/>
           </a:p>
         </p:txBody>
       </p:sp>
       <p:pic>
         <p:nvPicPr>
-          <p:cNvPr id="7" name="Image 0" descr="정석항공과학고등학교 엠블럼">    </p:cNvPr>
+          <p:cNvPr id="8" name="Image 0" descr="정석항공과학고등학교 엠블럼">    </p:cNvPr>
           <p:cNvPicPr>
             <a:picLocks noChangeAspect="1"/>
           </p:cNvPicPr>
@@ -1951,7 +1990,7 @@
       </p:pic>
       <p:sp>
         <p:nvSpPr>
-          <p:cNvPr id="8" name="Text 5"/>
+          <p:cNvPr id="9" name="Text 6"/>
           <p:cNvSpPr txBox="1"/>
           <p:nvPr/>
         </p:nvSpPr>

</xml_diff>

<commit_message>
Number body pages as N / total and leave the 목차 unnumbered
The 목차 now follows the cover in carrying no number, and the ten body
pages read 1 / 10 through 10 / 10. The total is counted from the slides
actually numbered and stamped just before the file is written, so it
stays right if pages are added or removed.

Co-Authored-By: Claude Opus 5 <noreply@anthropic.com>
Claude-Session: https://claude.ai/code/session_01GZfitk2JEKppZ4fGSDdghv
</commit_message>
<xml_diff>
--- a/docs/2027년_사무직원_채용계획안.pptx
+++ b/docs/2027년_사무직원_채용계획안.pptx
@@ -2206,45 +2206,6 @@
         </p:nvSpPr>
         <p:spPr>
           <a:xfrm>
-            <a:off x="3657600" y="6291072"/>
-            <a:ext cx="1828800" cy="274320"/>
-          </a:xfrm>
-          <a:prstGeom prst="rect">
-            <a:avLst/>
-          </a:prstGeom>
-          <a:noFill/>
-          <a:ln/>
-        </p:spPr>
-        <p:txBody>
-          <a:bodyPr wrap="square" lIns="0" tIns="0" rIns="0" bIns="0" rtlCol="0" anchor="ctr"/>
-          <a:lstStyle/>
-          <a:p>
-            <a:pPr eaLnBrk="0" latinLnBrk="0" algn="ctr" indent="0" marL="0">
-              <a:buNone/>
-            </a:pPr>
-            <a:r>
-              <a:rPr lang="en-US" sz="1100" dirty="0">
-                <a:solidFill>
-                  <a:srgbClr val="000000"/>
-                </a:solidFill>
-                <a:latin typeface="맑은 고딕" pitchFamily="34" charset="0"/>
-                <a:ea typeface="맑은 고딕" pitchFamily="34" charset="-122"/>
-                <a:cs typeface="맑은 고딕" pitchFamily="34" charset="-120"/>
-              </a:rPr>
-              <a:t>- 9 -</a:t>
-            </a:r>
-            <a:endParaRPr lang="en-US" sz="1100" dirty="0"/>
-          </a:p>
-        </p:txBody>
-      </p:sp>
-      <p:sp>
-        <p:nvSpPr>
-          <p:cNvPr id="5" name="Text 3"/>
-          <p:cNvSpPr txBox="1"/>
-          <p:nvPr/>
-        </p:nvSpPr>
-        <p:spPr>
-          <a:xfrm>
             <a:off x="457200" y="82296"/>
             <a:ext cx="5120640" cy="548640"/>
           </a:xfrm>
@@ -2278,7 +2239,7 @@
       </p:sp>
       <p:sp>
         <p:nvSpPr>
-          <p:cNvPr id="6" name="Text 4"/>
+          <p:cNvPr id="5" name="Text 3"/>
           <p:cNvSpPr txBox="1"/>
           <p:nvPr/>
         </p:nvSpPr>
@@ -2317,7 +2278,7 @@
       </p:sp>
       <p:sp>
         <p:nvSpPr>
-          <p:cNvPr id="7" name="Text 5"/>
+          <p:cNvPr id="6" name="Text 4"/>
           <p:cNvSpPr txBox="1"/>
           <p:nvPr/>
         </p:nvSpPr>
@@ -2356,7 +2317,7 @@
       </p:sp>
       <p:sp>
         <p:nvSpPr>
-          <p:cNvPr id="8" name="Text 6"/>
+          <p:cNvPr id="7" name="Text 5"/>
           <p:cNvSpPr txBox="1"/>
           <p:nvPr/>
         </p:nvSpPr>
@@ -2395,7 +2356,7 @@
       </p:sp>
       <p:sp>
         <p:nvSpPr>
-          <p:cNvPr id="9" name="Text 7"/>
+          <p:cNvPr id="8" name="Text 6"/>
           <p:cNvSpPr txBox="1"/>
           <p:nvPr/>
         </p:nvSpPr>
@@ -2437,7 +2398,7 @@
       </p:sp>
       <p:sp>
         <p:nvSpPr>
-          <p:cNvPr id="10" name="Text 8"/>
+          <p:cNvPr id="9" name="Text 7"/>
           <p:cNvSpPr txBox="1"/>
           <p:nvPr/>
         </p:nvSpPr>
@@ -2476,7 +2437,7 @@
       </p:sp>
       <p:sp>
         <p:nvSpPr>
-          <p:cNvPr id="11" name="Text 9"/>
+          <p:cNvPr id="10" name="Text 8"/>
           <p:cNvSpPr txBox="1"/>
           <p:nvPr/>
         </p:nvSpPr>
@@ -2518,7 +2479,7 @@
       </p:sp>
       <p:sp>
         <p:nvSpPr>
-          <p:cNvPr id="12" name="Text 10"/>
+          <p:cNvPr id="11" name="Text 9"/>
           <p:cNvSpPr txBox="1"/>
           <p:nvPr/>
         </p:nvSpPr>
@@ -2989,7 +2950,7 @@
       </p:graphicFrame>
       <p:sp>
         <p:nvSpPr>
-          <p:cNvPr id="14" name="Text 11"/>
+          <p:cNvPr id="13" name="Text 10"/>
           <p:cNvSpPr txBox="1"/>
           <p:nvPr/>
         </p:nvSpPr>
@@ -3684,7 +3645,7 @@
       </p:graphicFrame>
       <p:sp>
         <p:nvSpPr>
-          <p:cNvPr id="16" name="Text 12"/>
+          <p:cNvPr id="15" name="Text 11"/>
           <p:cNvSpPr txBox="1"/>
           <p:nvPr/>
         </p:nvSpPr>
@@ -3721,6 +3682,45 @@
           </a:p>
         </p:txBody>
       </p:sp>
+      <p:sp>
+        <p:nvSpPr>
+          <p:cNvPr id="17" name="Text 12"/>
+          <p:cNvSpPr txBox="1"/>
+          <p:nvPr/>
+        </p:nvSpPr>
+        <p:spPr>
+          <a:xfrm>
+            <a:off x="3657600" y="6291072"/>
+            <a:ext cx="1828800" cy="274320"/>
+          </a:xfrm>
+          <a:prstGeom prst="rect">
+            <a:avLst/>
+          </a:prstGeom>
+          <a:noFill/>
+          <a:ln/>
+        </p:spPr>
+        <p:txBody>
+          <a:bodyPr wrap="square" lIns="0" tIns="0" rIns="0" bIns="0" rtlCol="0" anchor="ctr"/>
+          <a:lstStyle/>
+          <a:p>
+            <a:pPr eaLnBrk="0" latinLnBrk="0" algn="ctr" indent="0" marL="0">
+              <a:buNone/>
+            </a:pPr>
+            <a:r>
+              <a:rPr lang="en-US" sz="1100" dirty="0">
+                <a:solidFill>
+                  <a:srgbClr val="000000"/>
+                </a:solidFill>
+                <a:latin typeface="맑은 고딕" pitchFamily="34" charset="0"/>
+                <a:ea typeface="맑은 고딕" pitchFamily="34" charset="-122"/>
+                <a:cs typeface="맑은 고딕" pitchFamily="34" charset="-120"/>
+              </a:rPr>
+              <a:t>8 / 10</a:t>
+            </a:r>
+            <a:endParaRPr lang="en-US" sz="1100" dirty="0"/>
+          </a:p>
+        </p:txBody>
+      </p:sp>
     </p:spTree>
   </p:cSld>
   <p:clrMapOvr>
@@ -3811,45 +3811,6 @@
         </p:nvSpPr>
         <p:spPr>
           <a:xfrm>
-            <a:off x="3657600" y="6291072"/>
-            <a:ext cx="1828800" cy="274320"/>
-          </a:xfrm>
-          <a:prstGeom prst="rect">
-            <a:avLst/>
-          </a:prstGeom>
-          <a:noFill/>
-          <a:ln/>
-        </p:spPr>
-        <p:txBody>
-          <a:bodyPr wrap="square" lIns="0" tIns="0" rIns="0" bIns="0" rtlCol="0" anchor="ctr"/>
-          <a:lstStyle/>
-          <a:p>
-            <a:pPr eaLnBrk="0" latinLnBrk="0" algn="ctr" indent="0" marL="0">
-              <a:buNone/>
-            </a:pPr>
-            <a:r>
-              <a:rPr lang="en-US" sz="1100" dirty="0">
-                <a:solidFill>
-                  <a:srgbClr val="000000"/>
-                </a:solidFill>
-                <a:latin typeface="맑은 고딕" pitchFamily="34" charset="0"/>
-                <a:ea typeface="맑은 고딕" pitchFamily="34" charset="-122"/>
-                <a:cs typeface="맑은 고딕" pitchFamily="34" charset="-120"/>
-              </a:rPr>
-              <a:t>- 10 -</a:t>
-            </a:r>
-            <a:endParaRPr lang="en-US" sz="1100" dirty="0"/>
-          </a:p>
-        </p:txBody>
-      </p:sp>
-      <p:sp>
-        <p:nvSpPr>
-          <p:cNvPr id="5" name="Text 3"/>
-          <p:cNvSpPr txBox="1"/>
-          <p:nvPr/>
-        </p:nvSpPr>
-        <p:spPr>
-          <a:xfrm>
             <a:off x="457200" y="82296"/>
             <a:ext cx="5120640" cy="548640"/>
           </a:xfrm>
@@ -3883,7 +3844,7 @@
       </p:sp>
       <p:sp>
         <p:nvSpPr>
-          <p:cNvPr id="6" name="Text 4"/>
+          <p:cNvPr id="5" name="Text 3"/>
           <p:cNvSpPr txBox="1"/>
           <p:nvPr/>
         </p:nvSpPr>
@@ -3922,7 +3883,7 @@
       </p:sp>
       <p:sp>
         <p:nvSpPr>
-          <p:cNvPr id="7" name="Text 5"/>
+          <p:cNvPr id="6" name="Text 4"/>
           <p:cNvSpPr txBox="1"/>
           <p:nvPr/>
         </p:nvSpPr>
@@ -3961,7 +3922,7 @@
       </p:sp>
       <p:sp>
         <p:nvSpPr>
-          <p:cNvPr id="8" name="Text 6"/>
+          <p:cNvPr id="7" name="Text 5"/>
           <p:cNvSpPr txBox="1"/>
           <p:nvPr/>
         </p:nvSpPr>
@@ -4003,7 +3964,7 @@
       </p:sp>
       <p:sp>
         <p:nvSpPr>
-          <p:cNvPr id="9" name="Text 7"/>
+          <p:cNvPr id="8" name="Text 6"/>
           <p:cNvSpPr txBox="1"/>
           <p:nvPr/>
         </p:nvSpPr>
@@ -4042,7 +4003,7 @@
       </p:sp>
       <p:sp>
         <p:nvSpPr>
-          <p:cNvPr id="10" name="Text 8"/>
+          <p:cNvPr id="9" name="Text 7"/>
           <p:cNvSpPr txBox="1"/>
           <p:nvPr/>
         </p:nvSpPr>
@@ -4084,7 +4045,7 @@
       </p:sp>
       <p:sp>
         <p:nvSpPr>
-          <p:cNvPr id="11" name="Text 9"/>
+          <p:cNvPr id="10" name="Text 8"/>
           <p:cNvSpPr txBox="1"/>
           <p:nvPr/>
         </p:nvSpPr>
@@ -4123,7 +4084,7 @@
       </p:sp>
       <p:sp>
         <p:nvSpPr>
-          <p:cNvPr id="12" name="Text 10"/>
+          <p:cNvPr id="11" name="Text 9"/>
           <p:cNvSpPr txBox="1"/>
           <p:nvPr/>
         </p:nvSpPr>
@@ -4162,7 +4123,7 @@
       </p:sp>
       <p:sp>
         <p:nvSpPr>
-          <p:cNvPr id="13" name="Text 11"/>
+          <p:cNvPr id="12" name="Text 10"/>
           <p:cNvSpPr txBox="1"/>
           <p:nvPr/>
         </p:nvSpPr>
@@ -4204,7 +4165,7 @@
       </p:sp>
       <p:sp>
         <p:nvSpPr>
-          <p:cNvPr id="14" name="Text 12"/>
+          <p:cNvPr id="13" name="Text 11"/>
           <p:cNvSpPr txBox="1"/>
           <p:nvPr/>
         </p:nvSpPr>
@@ -4243,7 +4204,7 @@
       </p:sp>
       <p:sp>
         <p:nvSpPr>
-          <p:cNvPr id="15" name="Text 13"/>
+          <p:cNvPr id="14" name="Text 12"/>
           <p:cNvSpPr txBox="1"/>
           <p:nvPr/>
         </p:nvSpPr>
@@ -4282,7 +4243,7 @@
       </p:sp>
       <p:sp>
         <p:nvSpPr>
-          <p:cNvPr id="16" name="Text 14"/>
+          <p:cNvPr id="15" name="Text 13"/>
           <p:cNvSpPr txBox="1"/>
           <p:nvPr/>
         </p:nvSpPr>
@@ -4324,7 +4285,7 @@
       </p:sp>
       <p:sp>
         <p:nvSpPr>
-          <p:cNvPr id="17" name="Text 15"/>
+          <p:cNvPr id="16" name="Text 14"/>
           <p:cNvSpPr txBox="1"/>
           <p:nvPr/>
         </p:nvSpPr>
@@ -4361,6 +4322,45 @@
           </a:p>
         </p:txBody>
       </p:sp>
+      <p:sp>
+        <p:nvSpPr>
+          <p:cNvPr id="18" name="Text 15"/>
+          <p:cNvSpPr txBox="1"/>
+          <p:nvPr/>
+        </p:nvSpPr>
+        <p:spPr>
+          <a:xfrm>
+            <a:off x="3657600" y="6291072"/>
+            <a:ext cx="1828800" cy="274320"/>
+          </a:xfrm>
+          <a:prstGeom prst="rect">
+            <a:avLst/>
+          </a:prstGeom>
+          <a:noFill/>
+          <a:ln/>
+        </p:spPr>
+        <p:txBody>
+          <a:bodyPr wrap="square" lIns="0" tIns="0" rIns="0" bIns="0" rtlCol="0" anchor="ctr"/>
+          <a:lstStyle/>
+          <a:p>
+            <a:pPr eaLnBrk="0" latinLnBrk="0" algn="ctr" indent="0" marL="0">
+              <a:buNone/>
+            </a:pPr>
+            <a:r>
+              <a:rPr lang="en-US" sz="1100" dirty="0">
+                <a:solidFill>
+                  <a:srgbClr val="000000"/>
+                </a:solidFill>
+                <a:latin typeface="맑은 고딕" pitchFamily="34" charset="0"/>
+                <a:ea typeface="맑은 고딕" pitchFamily="34" charset="-122"/>
+                <a:cs typeface="맑은 고딕" pitchFamily="34" charset="-120"/>
+              </a:rPr>
+              <a:t>9 / 10</a:t>
+            </a:r>
+            <a:endParaRPr lang="en-US" sz="1100" dirty="0"/>
+          </a:p>
+        </p:txBody>
+      </p:sp>
     </p:spTree>
   </p:cSld>
   <p:clrMapOvr>
@@ -4451,45 +4451,6 @@
         </p:nvSpPr>
         <p:spPr>
           <a:xfrm>
-            <a:off x="3657600" y="6291072"/>
-            <a:ext cx="1828800" cy="274320"/>
-          </a:xfrm>
-          <a:prstGeom prst="rect">
-            <a:avLst/>
-          </a:prstGeom>
-          <a:noFill/>
-          <a:ln/>
-        </p:spPr>
-        <p:txBody>
-          <a:bodyPr wrap="square" lIns="0" tIns="0" rIns="0" bIns="0" rtlCol="0" anchor="ctr"/>
-          <a:lstStyle/>
-          <a:p>
-            <a:pPr eaLnBrk="0" latinLnBrk="0" algn="ctr" indent="0" marL="0">
-              <a:buNone/>
-            </a:pPr>
-            <a:r>
-              <a:rPr lang="en-US" sz="1100" dirty="0">
-                <a:solidFill>
-                  <a:srgbClr val="000000"/>
-                </a:solidFill>
-                <a:latin typeface="맑은 고딕" pitchFamily="34" charset="0"/>
-                <a:ea typeface="맑은 고딕" pitchFamily="34" charset="-122"/>
-                <a:cs typeface="맑은 고딕" pitchFamily="34" charset="-120"/>
-              </a:rPr>
-              <a:t>- 11 -</a:t>
-            </a:r>
-            <a:endParaRPr lang="en-US" sz="1100" dirty="0"/>
-          </a:p>
-        </p:txBody>
-      </p:sp>
-      <p:sp>
-        <p:nvSpPr>
-          <p:cNvPr id="5" name="Text 3"/>
-          <p:cNvSpPr txBox="1"/>
-          <p:nvPr/>
-        </p:nvSpPr>
-        <p:spPr>
-          <a:xfrm>
             <a:off x="457200" y="82296"/>
             <a:ext cx="5120640" cy="548640"/>
           </a:xfrm>
@@ -4523,7 +4484,7 @@
       </p:sp>
       <p:sp>
         <p:nvSpPr>
-          <p:cNvPr id="6" name="Text 4"/>
+          <p:cNvPr id="5" name="Text 3"/>
           <p:cNvSpPr txBox="1"/>
           <p:nvPr/>
         </p:nvSpPr>
@@ -5654,7 +5615,7 @@
       </p:graphicFrame>
       <p:sp>
         <p:nvSpPr>
-          <p:cNvPr id="8" name="Text 5"/>
+          <p:cNvPr id="7" name="Text 4"/>
           <p:cNvSpPr txBox="1"/>
           <p:nvPr/>
         </p:nvSpPr>
@@ -6322,6 +6283,45 @@
           </a:graphicData>
         </a:graphic>
       </p:graphicFrame>
+      <p:sp>
+        <p:nvSpPr>
+          <p:cNvPr id="10" name="Text 5"/>
+          <p:cNvSpPr txBox="1"/>
+          <p:nvPr/>
+        </p:nvSpPr>
+        <p:spPr>
+          <a:xfrm>
+            <a:off x="3657600" y="6291072"/>
+            <a:ext cx="1828800" cy="274320"/>
+          </a:xfrm>
+          <a:prstGeom prst="rect">
+            <a:avLst/>
+          </a:prstGeom>
+          <a:noFill/>
+          <a:ln/>
+        </p:spPr>
+        <p:txBody>
+          <a:bodyPr wrap="square" lIns="0" tIns="0" rIns="0" bIns="0" rtlCol="0" anchor="ctr"/>
+          <a:lstStyle/>
+          <a:p>
+            <a:pPr eaLnBrk="0" latinLnBrk="0" algn="ctr" indent="0" marL="0">
+              <a:buNone/>
+            </a:pPr>
+            <a:r>
+              <a:rPr lang="en-US" sz="1100" dirty="0">
+                <a:solidFill>
+                  <a:srgbClr val="000000"/>
+                </a:solidFill>
+                <a:latin typeface="맑은 고딕" pitchFamily="34" charset="0"/>
+                <a:ea typeface="맑은 고딕" pitchFamily="34" charset="-122"/>
+                <a:cs typeface="맑은 고딕" pitchFamily="34" charset="-120"/>
+              </a:rPr>
+              <a:t>10 / 10</a:t>
+            </a:r>
+            <a:endParaRPr lang="en-US" sz="1100" dirty="0"/>
+          </a:p>
+        </p:txBody>
+      </p:sp>
     </p:spTree>
   </p:cSld>
   <p:clrMapOvr>
@@ -6412,45 +6412,6 @@
         </p:nvSpPr>
         <p:spPr>
           <a:xfrm>
-            <a:off x="3657600" y="6291072"/>
-            <a:ext cx="1828800" cy="274320"/>
-          </a:xfrm>
-          <a:prstGeom prst="rect">
-            <a:avLst/>
-          </a:prstGeom>
-          <a:noFill/>
-          <a:ln/>
-        </p:spPr>
-        <p:txBody>
-          <a:bodyPr wrap="square" lIns="0" tIns="0" rIns="0" bIns="0" rtlCol="0" anchor="ctr"/>
-          <a:lstStyle/>
-          <a:p>
-            <a:pPr eaLnBrk="0" latinLnBrk="0" algn="ctr" indent="0" marL="0">
-              <a:buNone/>
-            </a:pPr>
-            <a:r>
-              <a:rPr lang="en-US" sz="1100" dirty="0">
-                <a:solidFill>
-                  <a:srgbClr val="000000"/>
-                </a:solidFill>
-                <a:latin typeface="맑은 고딕" pitchFamily="34" charset="0"/>
-                <a:ea typeface="맑은 고딕" pitchFamily="34" charset="-122"/>
-                <a:cs typeface="맑은 고딕" pitchFamily="34" charset="-120"/>
-              </a:rPr>
-              <a:t>- 1 -</a:t>
-            </a:r>
-            <a:endParaRPr lang="en-US" sz="1100" dirty="0"/>
-          </a:p>
-        </p:txBody>
-      </p:sp>
-      <p:sp>
-        <p:nvSpPr>
-          <p:cNvPr id="5" name="Text 3"/>
-          <p:cNvSpPr txBox="1"/>
-          <p:nvPr/>
-        </p:nvSpPr>
-        <p:spPr>
-          <a:xfrm>
             <a:off x="457200" y="82296"/>
             <a:ext cx="8229600" cy="548640"/>
           </a:xfrm>
@@ -6484,7 +6445,7 @@
       </p:sp>
       <p:sp>
         <p:nvSpPr>
-          <p:cNvPr id="6" name="Text 4"/>
+          <p:cNvPr id="5" name="Text 3"/>
           <p:cNvSpPr txBox="1"/>
           <p:nvPr/>
         </p:nvSpPr>
@@ -6523,7 +6484,7 @@
       </p:sp>
       <p:sp>
         <p:nvSpPr>
-          <p:cNvPr id="7" name="Text 5"/>
+          <p:cNvPr id="6" name="Text 4"/>
           <p:cNvSpPr txBox="1"/>
           <p:nvPr/>
         </p:nvSpPr>
@@ -6562,7 +6523,7 @@
       </p:sp>
       <p:sp>
         <p:nvSpPr>
-          <p:cNvPr id="8" name="Text 6"/>
+          <p:cNvPr id="7" name="Text 5"/>
           <p:cNvSpPr txBox="1"/>
           <p:nvPr/>
         </p:nvSpPr>
@@ -6601,7 +6562,7 @@
       </p:sp>
       <p:sp>
         <p:nvSpPr>
-          <p:cNvPr id="9" name="Text 7"/>
+          <p:cNvPr id="8" name="Text 6"/>
           <p:cNvSpPr txBox="1"/>
           <p:nvPr/>
         </p:nvSpPr>
@@ -6640,7 +6601,7 @@
       </p:sp>
       <p:sp>
         <p:nvSpPr>
-          <p:cNvPr id="10" name="Text 8"/>
+          <p:cNvPr id="9" name="Text 7"/>
           <p:cNvSpPr txBox="1"/>
           <p:nvPr/>
         </p:nvSpPr>
@@ -6679,7 +6640,7 @@
       </p:sp>
       <p:sp>
         <p:nvSpPr>
-          <p:cNvPr id="11" name="Text 9"/>
+          <p:cNvPr id="10" name="Text 8"/>
           <p:cNvSpPr txBox="1"/>
           <p:nvPr/>
         </p:nvSpPr>
@@ -6718,7 +6679,7 @@
       </p:sp>
       <p:sp>
         <p:nvSpPr>
-          <p:cNvPr id="12" name="Text 10"/>
+          <p:cNvPr id="11" name="Text 9"/>
           <p:cNvSpPr txBox="1"/>
           <p:nvPr/>
         </p:nvSpPr>
@@ -6757,7 +6718,7 @@
       </p:sp>
       <p:sp>
         <p:nvSpPr>
-          <p:cNvPr id="13" name="Text 11"/>
+          <p:cNvPr id="12" name="Text 10"/>
           <p:cNvSpPr txBox="1"/>
           <p:nvPr/>
         </p:nvSpPr>
@@ -6796,7 +6757,7 @@
       </p:sp>
       <p:sp>
         <p:nvSpPr>
-          <p:cNvPr id="14" name="Text 12"/>
+          <p:cNvPr id="13" name="Text 11"/>
           <p:cNvSpPr txBox="1"/>
           <p:nvPr/>
         </p:nvSpPr>
@@ -6835,7 +6796,7 @@
       </p:sp>
       <p:sp>
         <p:nvSpPr>
-          <p:cNvPr id="15" name="Text 13"/>
+          <p:cNvPr id="14" name="Text 12"/>
           <p:cNvSpPr txBox="1"/>
           <p:nvPr/>
         </p:nvSpPr>
@@ -6874,7 +6835,7 @@
       </p:sp>
       <p:sp>
         <p:nvSpPr>
-          <p:cNvPr id="16" name="Text 14"/>
+          <p:cNvPr id="15" name="Text 13"/>
           <p:cNvSpPr txBox="1"/>
           <p:nvPr/>
         </p:nvSpPr>
@@ -6913,7 +6874,7 @@
       </p:sp>
       <p:sp>
         <p:nvSpPr>
-          <p:cNvPr id="17" name="Text 15"/>
+          <p:cNvPr id="16" name="Text 14"/>
           <p:cNvSpPr txBox="1"/>
           <p:nvPr/>
         </p:nvSpPr>
@@ -6952,7 +6913,7 @@
       </p:sp>
       <p:sp>
         <p:nvSpPr>
-          <p:cNvPr id="18" name="Text 16"/>
+          <p:cNvPr id="17" name="Text 15"/>
           <p:cNvSpPr txBox="1"/>
           <p:nvPr/>
         </p:nvSpPr>
@@ -6991,7 +6952,7 @@
       </p:sp>
       <p:sp>
         <p:nvSpPr>
-          <p:cNvPr id="19" name="Text 17"/>
+          <p:cNvPr id="18" name="Text 16"/>
           <p:cNvSpPr txBox="1"/>
           <p:nvPr/>
         </p:nvSpPr>
@@ -7118,45 +7079,6 @@
         </p:nvSpPr>
         <p:spPr>
           <a:xfrm>
-            <a:off x="3657600" y="6291072"/>
-            <a:ext cx="1828800" cy="274320"/>
-          </a:xfrm>
-          <a:prstGeom prst="rect">
-            <a:avLst/>
-          </a:prstGeom>
-          <a:noFill/>
-          <a:ln/>
-        </p:spPr>
-        <p:txBody>
-          <a:bodyPr wrap="square" lIns="0" tIns="0" rIns="0" bIns="0" rtlCol="0" anchor="ctr"/>
-          <a:lstStyle/>
-          <a:p>
-            <a:pPr eaLnBrk="0" latinLnBrk="0" algn="ctr" indent="0" marL="0">
-              <a:buNone/>
-            </a:pPr>
-            <a:r>
-              <a:rPr lang="en-US" sz="1100" dirty="0">
-                <a:solidFill>
-                  <a:srgbClr val="000000"/>
-                </a:solidFill>
-                <a:latin typeface="맑은 고딕" pitchFamily="34" charset="0"/>
-                <a:ea typeface="맑은 고딕" pitchFamily="34" charset="-122"/>
-                <a:cs typeface="맑은 고딕" pitchFamily="34" charset="-120"/>
-              </a:rPr>
-              <a:t>- 2 -</a:t>
-            </a:r>
-            <a:endParaRPr lang="en-US" sz="1100" dirty="0"/>
-          </a:p>
-        </p:txBody>
-      </p:sp>
-      <p:sp>
-        <p:nvSpPr>
-          <p:cNvPr id="5" name="Text 3"/>
-          <p:cNvSpPr txBox="1"/>
-          <p:nvPr/>
-        </p:nvSpPr>
-        <p:spPr>
-          <a:xfrm>
             <a:off x="457200" y="82296"/>
             <a:ext cx="5120640" cy="548640"/>
           </a:xfrm>
@@ -7190,7 +7112,7 @@
       </p:sp>
       <p:sp>
         <p:nvSpPr>
-          <p:cNvPr id="6" name="Text 4"/>
+          <p:cNvPr id="5" name="Text 3"/>
           <p:cNvSpPr txBox="1"/>
           <p:nvPr/>
         </p:nvSpPr>
@@ -7229,7 +7151,7 @@
       </p:sp>
       <p:sp>
         <p:nvSpPr>
-          <p:cNvPr id="7" name="Text 5"/>
+          <p:cNvPr id="6" name="Text 4"/>
           <p:cNvSpPr txBox="1"/>
           <p:nvPr/>
         </p:nvSpPr>
@@ -7268,7 +7190,7 @@
       </p:sp>
       <p:sp>
         <p:nvSpPr>
-          <p:cNvPr id="8" name="Text 6"/>
+          <p:cNvPr id="7" name="Text 5"/>
           <p:cNvSpPr txBox="1"/>
           <p:nvPr/>
         </p:nvSpPr>
@@ -7310,7 +7232,7 @@
       </p:sp>
       <p:sp>
         <p:nvSpPr>
-          <p:cNvPr id="9" name="Text 7"/>
+          <p:cNvPr id="8" name="Text 6"/>
           <p:cNvSpPr txBox="1"/>
           <p:nvPr/>
         </p:nvSpPr>
@@ -7349,7 +7271,7 @@
       </p:sp>
       <p:sp>
         <p:nvSpPr>
-          <p:cNvPr id="10" name="Text 8"/>
+          <p:cNvPr id="9" name="Text 7"/>
           <p:cNvSpPr txBox="1"/>
           <p:nvPr/>
         </p:nvSpPr>
@@ -7388,7 +7310,7 @@
       </p:sp>
       <p:sp>
         <p:nvSpPr>
-          <p:cNvPr id="11" name="Text 9"/>
+          <p:cNvPr id="10" name="Text 8"/>
           <p:cNvSpPr txBox="1"/>
           <p:nvPr/>
         </p:nvSpPr>
@@ -7430,7 +7352,7 @@
       </p:sp>
       <p:sp>
         <p:nvSpPr>
-          <p:cNvPr id="12" name="Text 10"/>
+          <p:cNvPr id="11" name="Text 9"/>
           <p:cNvSpPr txBox="1"/>
           <p:nvPr/>
         </p:nvSpPr>
@@ -7469,7 +7391,7 @@
       </p:sp>
       <p:sp>
         <p:nvSpPr>
-          <p:cNvPr id="13" name="Text 11"/>
+          <p:cNvPr id="12" name="Text 10"/>
           <p:cNvSpPr txBox="1"/>
           <p:nvPr/>
         </p:nvSpPr>
@@ -7511,7 +7433,7 @@
       </p:sp>
       <p:sp>
         <p:nvSpPr>
-          <p:cNvPr id="14" name="Text 12"/>
+          <p:cNvPr id="13" name="Text 11"/>
           <p:cNvSpPr txBox="1"/>
           <p:nvPr/>
         </p:nvSpPr>
@@ -8252,7 +8174,7 @@
       </p:graphicFrame>
       <p:sp>
         <p:nvSpPr>
-          <p:cNvPr id="16" name="Text 13"/>
+          <p:cNvPr id="15" name="Text 12"/>
           <p:cNvSpPr txBox="1"/>
           <p:nvPr/>
         </p:nvSpPr>
@@ -8289,6 +8211,45 @@
           </a:p>
         </p:txBody>
       </p:sp>
+      <p:sp>
+        <p:nvSpPr>
+          <p:cNvPr id="17" name="Text 13"/>
+          <p:cNvSpPr txBox="1"/>
+          <p:nvPr/>
+        </p:nvSpPr>
+        <p:spPr>
+          <a:xfrm>
+            <a:off x="3657600" y="6291072"/>
+            <a:ext cx="1828800" cy="274320"/>
+          </a:xfrm>
+          <a:prstGeom prst="rect">
+            <a:avLst/>
+          </a:prstGeom>
+          <a:noFill/>
+          <a:ln/>
+        </p:spPr>
+        <p:txBody>
+          <a:bodyPr wrap="square" lIns="0" tIns="0" rIns="0" bIns="0" rtlCol="0" anchor="ctr"/>
+          <a:lstStyle/>
+          <a:p>
+            <a:pPr eaLnBrk="0" latinLnBrk="0" algn="ctr" indent="0" marL="0">
+              <a:buNone/>
+            </a:pPr>
+            <a:r>
+              <a:rPr lang="en-US" sz="1100" dirty="0">
+                <a:solidFill>
+                  <a:srgbClr val="000000"/>
+                </a:solidFill>
+                <a:latin typeface="맑은 고딕" pitchFamily="34" charset="0"/>
+                <a:ea typeface="맑은 고딕" pitchFamily="34" charset="-122"/>
+                <a:cs typeface="맑은 고딕" pitchFamily="34" charset="-120"/>
+              </a:rPr>
+              <a:t>1 / 10</a:t>
+            </a:r>
+            <a:endParaRPr lang="en-US" sz="1100" dirty="0"/>
+          </a:p>
+        </p:txBody>
+      </p:sp>
     </p:spTree>
   </p:cSld>
   <p:clrMapOvr>
@@ -8379,45 +8340,6 @@
         </p:nvSpPr>
         <p:spPr>
           <a:xfrm>
-            <a:off x="3657600" y="6291072"/>
-            <a:ext cx="1828800" cy="274320"/>
-          </a:xfrm>
-          <a:prstGeom prst="rect">
-            <a:avLst/>
-          </a:prstGeom>
-          <a:noFill/>
-          <a:ln/>
-        </p:spPr>
-        <p:txBody>
-          <a:bodyPr wrap="square" lIns="0" tIns="0" rIns="0" bIns="0" rtlCol="0" anchor="ctr"/>
-          <a:lstStyle/>
-          <a:p>
-            <a:pPr eaLnBrk="0" latinLnBrk="0" algn="ctr" indent="0" marL="0">
-              <a:buNone/>
-            </a:pPr>
-            <a:r>
-              <a:rPr lang="en-US" sz="1100" dirty="0">
-                <a:solidFill>
-                  <a:srgbClr val="000000"/>
-                </a:solidFill>
-                <a:latin typeface="맑은 고딕" pitchFamily="34" charset="0"/>
-                <a:ea typeface="맑은 고딕" pitchFamily="34" charset="-122"/>
-                <a:cs typeface="맑은 고딕" pitchFamily="34" charset="-120"/>
-              </a:rPr>
-              <a:t>- 3 -</a:t>
-            </a:r>
-            <a:endParaRPr lang="en-US" sz="1100" dirty="0"/>
-          </a:p>
-        </p:txBody>
-      </p:sp>
-      <p:sp>
-        <p:nvSpPr>
-          <p:cNvPr id="5" name="Text 3"/>
-          <p:cNvSpPr txBox="1"/>
-          <p:nvPr/>
-        </p:nvSpPr>
-        <p:spPr>
-          <a:xfrm>
             <a:off x="457200" y="82296"/>
             <a:ext cx="5120640" cy="548640"/>
           </a:xfrm>
@@ -8451,7 +8373,7 @@
       </p:sp>
       <p:sp>
         <p:nvSpPr>
-          <p:cNvPr id="6" name="Text 4"/>
+          <p:cNvPr id="5" name="Text 3"/>
           <p:cNvSpPr txBox="1"/>
           <p:nvPr/>
         </p:nvSpPr>
@@ -8490,7 +8412,7 @@
       </p:sp>
       <p:sp>
         <p:nvSpPr>
-          <p:cNvPr id="7" name="Text 5"/>
+          <p:cNvPr id="6" name="Text 4"/>
           <p:cNvSpPr txBox="1"/>
           <p:nvPr/>
         </p:nvSpPr>
@@ -11143,7 +11065,7 @@
       </p:graphicFrame>
       <p:sp>
         <p:nvSpPr>
-          <p:cNvPr id="9" name="Text 6"/>
+          <p:cNvPr id="8" name="Text 5"/>
           <p:cNvSpPr txBox="1"/>
           <p:nvPr/>
         </p:nvSpPr>
@@ -11182,7 +11104,7 @@
       </p:sp>
       <p:sp>
         <p:nvSpPr>
-          <p:cNvPr id="10" name="Text 7"/>
+          <p:cNvPr id="9" name="Text 6"/>
           <p:cNvSpPr txBox="1"/>
           <p:nvPr/>
         </p:nvSpPr>
@@ -12142,7 +12064,7 @@
       </p:graphicFrame>
       <p:sp>
         <p:nvSpPr>
-          <p:cNvPr id="12" name="Text 8"/>
+          <p:cNvPr id="11" name="Text 7"/>
           <p:cNvSpPr txBox="1"/>
           <p:nvPr/>
         </p:nvSpPr>
@@ -12179,6 +12101,45 @@
           </a:p>
         </p:txBody>
       </p:sp>
+      <p:sp>
+        <p:nvSpPr>
+          <p:cNvPr id="13" name="Text 8"/>
+          <p:cNvSpPr txBox="1"/>
+          <p:nvPr/>
+        </p:nvSpPr>
+        <p:spPr>
+          <a:xfrm>
+            <a:off x="3657600" y="6291072"/>
+            <a:ext cx="1828800" cy="274320"/>
+          </a:xfrm>
+          <a:prstGeom prst="rect">
+            <a:avLst/>
+          </a:prstGeom>
+          <a:noFill/>
+          <a:ln/>
+        </p:spPr>
+        <p:txBody>
+          <a:bodyPr wrap="square" lIns="0" tIns="0" rIns="0" bIns="0" rtlCol="0" anchor="ctr"/>
+          <a:lstStyle/>
+          <a:p>
+            <a:pPr eaLnBrk="0" latinLnBrk="0" algn="ctr" indent="0" marL="0">
+              <a:buNone/>
+            </a:pPr>
+            <a:r>
+              <a:rPr lang="en-US" sz="1100" dirty="0">
+                <a:solidFill>
+                  <a:srgbClr val="000000"/>
+                </a:solidFill>
+                <a:latin typeface="맑은 고딕" pitchFamily="34" charset="0"/>
+                <a:ea typeface="맑은 고딕" pitchFamily="34" charset="-122"/>
+                <a:cs typeface="맑은 고딕" pitchFamily="34" charset="-120"/>
+              </a:rPr>
+              <a:t>2 / 10</a:t>
+            </a:r>
+            <a:endParaRPr lang="en-US" sz="1100" dirty="0"/>
+          </a:p>
+        </p:txBody>
+      </p:sp>
     </p:spTree>
   </p:cSld>
   <p:clrMapOvr>
@@ -12269,45 +12230,6 @@
         </p:nvSpPr>
         <p:spPr>
           <a:xfrm>
-            <a:off x="3657600" y="6291072"/>
-            <a:ext cx="1828800" cy="274320"/>
-          </a:xfrm>
-          <a:prstGeom prst="rect">
-            <a:avLst/>
-          </a:prstGeom>
-          <a:noFill/>
-          <a:ln/>
-        </p:spPr>
-        <p:txBody>
-          <a:bodyPr wrap="square" lIns="0" tIns="0" rIns="0" bIns="0" rtlCol="0" anchor="ctr"/>
-          <a:lstStyle/>
-          <a:p>
-            <a:pPr eaLnBrk="0" latinLnBrk="0" algn="ctr" indent="0" marL="0">
-              <a:buNone/>
-            </a:pPr>
-            <a:r>
-              <a:rPr lang="en-US" sz="1100" dirty="0">
-                <a:solidFill>
-                  <a:srgbClr val="000000"/>
-                </a:solidFill>
-                <a:latin typeface="맑은 고딕" pitchFamily="34" charset="0"/>
-                <a:ea typeface="맑은 고딕" pitchFamily="34" charset="-122"/>
-                <a:cs typeface="맑은 고딕" pitchFamily="34" charset="-120"/>
-              </a:rPr>
-              <a:t>- 4 -</a:t>
-            </a:r>
-            <a:endParaRPr lang="en-US" sz="1100" dirty="0"/>
-          </a:p>
-        </p:txBody>
-      </p:sp>
-      <p:sp>
-        <p:nvSpPr>
-          <p:cNvPr id="5" name="Text 3"/>
-          <p:cNvSpPr txBox="1"/>
-          <p:nvPr/>
-        </p:nvSpPr>
-        <p:spPr>
-          <a:xfrm>
             <a:off x="457200" y="82296"/>
             <a:ext cx="5120640" cy="548640"/>
           </a:xfrm>
@@ -12341,7 +12263,7 @@
       </p:sp>
       <p:sp>
         <p:nvSpPr>
-          <p:cNvPr id="6" name="Text 4"/>
+          <p:cNvPr id="5" name="Text 3"/>
           <p:cNvSpPr txBox="1"/>
           <p:nvPr/>
         </p:nvSpPr>
@@ -12380,7 +12302,7 @@
       </p:sp>
       <p:sp>
         <p:nvSpPr>
-          <p:cNvPr id="7" name="Shape 5"/>
+          <p:cNvPr id="6" name="Shape 4"/>
           <p:cNvSpPr/>
           <p:nvPr/>
         </p:nvSpPr>
@@ -12405,7 +12327,7 @@
       </p:sp>
       <p:sp>
         <p:nvSpPr>
-          <p:cNvPr id="8" name="Text 6"/>
+          <p:cNvPr id="7" name="Text 5"/>
           <p:cNvSpPr txBox="1"/>
           <p:nvPr/>
         </p:nvSpPr>
@@ -12467,7 +12389,7 @@
       </p:sp>
       <p:sp>
         <p:nvSpPr>
-          <p:cNvPr id="9" name="Shape 7"/>
+          <p:cNvPr id="8" name="Shape 6"/>
           <p:cNvSpPr/>
           <p:nvPr/>
         </p:nvSpPr>
@@ -12492,7 +12414,7 @@
       </p:sp>
       <p:sp>
         <p:nvSpPr>
-          <p:cNvPr id="10" name="Text 8"/>
+          <p:cNvPr id="9" name="Text 7"/>
           <p:cNvSpPr txBox="1"/>
           <p:nvPr/>
         </p:nvSpPr>
@@ -12534,7 +12456,7 @@
       </p:sp>
       <p:sp>
         <p:nvSpPr>
-          <p:cNvPr id="11" name="Shape 9"/>
+          <p:cNvPr id="10" name="Shape 8"/>
           <p:cNvSpPr/>
           <p:nvPr/>
         </p:nvSpPr>
@@ -12554,7 +12476,7 @@
       </p:sp>
       <p:sp>
         <p:nvSpPr>
-          <p:cNvPr id="12" name="Shape 10"/>
+          <p:cNvPr id="11" name="Shape 9"/>
           <p:cNvSpPr/>
           <p:nvPr/>
         </p:nvSpPr>
@@ -12579,7 +12501,7 @@
       </p:sp>
       <p:sp>
         <p:nvSpPr>
-          <p:cNvPr id="13" name="Text 11"/>
+          <p:cNvPr id="12" name="Text 10"/>
           <p:cNvSpPr txBox="1"/>
           <p:nvPr/>
         </p:nvSpPr>
@@ -12641,7 +12563,7 @@
       </p:sp>
       <p:sp>
         <p:nvSpPr>
-          <p:cNvPr id="14" name="Shape 12"/>
+          <p:cNvPr id="13" name="Shape 11"/>
           <p:cNvSpPr/>
           <p:nvPr/>
         </p:nvSpPr>
@@ -12666,7 +12588,7 @@
       </p:sp>
       <p:sp>
         <p:nvSpPr>
-          <p:cNvPr id="15" name="Text 13"/>
+          <p:cNvPr id="14" name="Text 12"/>
           <p:cNvSpPr txBox="1"/>
           <p:nvPr/>
         </p:nvSpPr>
@@ -12708,7 +12630,7 @@
       </p:sp>
       <p:sp>
         <p:nvSpPr>
-          <p:cNvPr id="16" name="Shape 14"/>
+          <p:cNvPr id="15" name="Shape 13"/>
           <p:cNvSpPr/>
           <p:nvPr/>
         </p:nvSpPr>
@@ -12728,7 +12650,7 @@
       </p:sp>
       <p:sp>
         <p:nvSpPr>
-          <p:cNvPr id="17" name="Shape 15"/>
+          <p:cNvPr id="16" name="Shape 14"/>
           <p:cNvSpPr/>
           <p:nvPr/>
         </p:nvSpPr>
@@ -12753,7 +12675,7 @@
       </p:sp>
       <p:sp>
         <p:nvSpPr>
-          <p:cNvPr id="18" name="Text 16"/>
+          <p:cNvPr id="17" name="Text 15"/>
           <p:cNvSpPr txBox="1"/>
           <p:nvPr/>
         </p:nvSpPr>
@@ -12835,7 +12757,7 @@
       </p:sp>
       <p:sp>
         <p:nvSpPr>
-          <p:cNvPr id="19" name="Shape 17"/>
+          <p:cNvPr id="18" name="Shape 16"/>
           <p:cNvSpPr/>
           <p:nvPr/>
         </p:nvSpPr>
@@ -12860,7 +12782,7 @@
       </p:sp>
       <p:sp>
         <p:nvSpPr>
-          <p:cNvPr id="20" name="Text 18"/>
+          <p:cNvPr id="19" name="Text 17"/>
           <p:cNvSpPr txBox="1"/>
           <p:nvPr/>
         </p:nvSpPr>
@@ -12902,7 +12824,7 @@
       </p:sp>
       <p:sp>
         <p:nvSpPr>
-          <p:cNvPr id="21" name="Shape 19"/>
+          <p:cNvPr id="20" name="Shape 18"/>
           <p:cNvSpPr/>
           <p:nvPr/>
         </p:nvSpPr>
@@ -12922,7 +12844,7 @@
       </p:sp>
       <p:sp>
         <p:nvSpPr>
-          <p:cNvPr id="22" name="Shape 20"/>
+          <p:cNvPr id="21" name="Shape 19"/>
           <p:cNvSpPr/>
           <p:nvPr/>
         </p:nvSpPr>
@@ -12947,7 +12869,7 @@
       </p:sp>
       <p:sp>
         <p:nvSpPr>
-          <p:cNvPr id="23" name="Text 21"/>
+          <p:cNvPr id="22" name="Text 20"/>
           <p:cNvSpPr txBox="1"/>
           <p:nvPr/>
         </p:nvSpPr>
@@ -13009,7 +12931,7 @@
       </p:sp>
       <p:sp>
         <p:nvSpPr>
-          <p:cNvPr id="24" name="Shape 22"/>
+          <p:cNvPr id="23" name="Shape 21"/>
           <p:cNvSpPr/>
           <p:nvPr/>
         </p:nvSpPr>
@@ -13034,7 +12956,7 @@
       </p:sp>
       <p:sp>
         <p:nvSpPr>
-          <p:cNvPr id="25" name="Text 23"/>
+          <p:cNvPr id="24" name="Text 22"/>
           <p:cNvSpPr txBox="1"/>
           <p:nvPr/>
         </p:nvSpPr>
@@ -13076,7 +12998,7 @@
       </p:sp>
       <p:sp>
         <p:nvSpPr>
-          <p:cNvPr id="26" name="Shape 24"/>
+          <p:cNvPr id="25" name="Shape 23"/>
           <p:cNvSpPr/>
           <p:nvPr/>
         </p:nvSpPr>
@@ -13096,7 +13018,7 @@
       </p:sp>
       <p:sp>
         <p:nvSpPr>
-          <p:cNvPr id="27" name="Shape 25"/>
+          <p:cNvPr id="26" name="Shape 24"/>
           <p:cNvSpPr/>
           <p:nvPr/>
         </p:nvSpPr>
@@ -13121,7 +13043,7 @@
       </p:sp>
       <p:sp>
         <p:nvSpPr>
-          <p:cNvPr id="28" name="Text 26"/>
+          <p:cNvPr id="27" name="Text 25"/>
           <p:cNvSpPr txBox="1"/>
           <p:nvPr/>
         </p:nvSpPr>
@@ -13163,7 +13085,7 @@
       </p:sp>
       <p:sp>
         <p:nvSpPr>
-          <p:cNvPr id="29" name="Shape 27"/>
+          <p:cNvPr id="28" name="Shape 26"/>
           <p:cNvSpPr/>
           <p:nvPr/>
         </p:nvSpPr>
@@ -13188,7 +13110,7 @@
       </p:sp>
       <p:sp>
         <p:nvSpPr>
-          <p:cNvPr id="30" name="Text 28"/>
+          <p:cNvPr id="29" name="Text 27"/>
           <p:cNvSpPr txBox="1"/>
           <p:nvPr/>
         </p:nvSpPr>
@@ -13230,7 +13152,7 @@
       </p:sp>
       <p:sp>
         <p:nvSpPr>
-          <p:cNvPr id="31" name="Text 29"/>
+          <p:cNvPr id="30" name="Text 28"/>
           <p:cNvSpPr txBox="1"/>
           <p:nvPr/>
         </p:nvSpPr>
@@ -13267,6 +13189,45 @@
           </a:p>
         </p:txBody>
       </p:sp>
+      <p:sp>
+        <p:nvSpPr>
+          <p:cNvPr id="32" name="Text 29"/>
+          <p:cNvSpPr txBox="1"/>
+          <p:nvPr/>
+        </p:nvSpPr>
+        <p:spPr>
+          <a:xfrm>
+            <a:off x="3657600" y="6291072"/>
+            <a:ext cx="1828800" cy="274320"/>
+          </a:xfrm>
+          <a:prstGeom prst="rect">
+            <a:avLst/>
+          </a:prstGeom>
+          <a:noFill/>
+          <a:ln/>
+        </p:spPr>
+        <p:txBody>
+          <a:bodyPr wrap="square" lIns="0" tIns="0" rIns="0" bIns="0" rtlCol="0" anchor="ctr"/>
+          <a:lstStyle/>
+          <a:p>
+            <a:pPr eaLnBrk="0" latinLnBrk="0" algn="ctr" indent="0" marL="0">
+              <a:buNone/>
+            </a:pPr>
+            <a:r>
+              <a:rPr lang="en-US" sz="1100" dirty="0">
+                <a:solidFill>
+                  <a:srgbClr val="000000"/>
+                </a:solidFill>
+                <a:latin typeface="맑은 고딕" pitchFamily="34" charset="0"/>
+                <a:ea typeface="맑은 고딕" pitchFamily="34" charset="-122"/>
+                <a:cs typeface="맑은 고딕" pitchFamily="34" charset="-120"/>
+              </a:rPr>
+              <a:t>3 / 10</a:t>
+            </a:r>
+            <a:endParaRPr lang="en-US" sz="1100" dirty="0"/>
+          </a:p>
+        </p:txBody>
+      </p:sp>
     </p:spTree>
   </p:cSld>
   <p:clrMapOvr>
@@ -13357,45 +13318,6 @@
         </p:nvSpPr>
         <p:spPr>
           <a:xfrm>
-            <a:off x="3657600" y="6291072"/>
-            <a:ext cx="1828800" cy="274320"/>
-          </a:xfrm>
-          <a:prstGeom prst="rect">
-            <a:avLst/>
-          </a:prstGeom>
-          <a:noFill/>
-          <a:ln/>
-        </p:spPr>
-        <p:txBody>
-          <a:bodyPr wrap="square" lIns="0" tIns="0" rIns="0" bIns="0" rtlCol="0" anchor="ctr"/>
-          <a:lstStyle/>
-          <a:p>
-            <a:pPr eaLnBrk="0" latinLnBrk="0" algn="ctr" indent="0" marL="0">
-              <a:buNone/>
-            </a:pPr>
-            <a:r>
-              <a:rPr lang="en-US" sz="1100" dirty="0">
-                <a:solidFill>
-                  <a:srgbClr val="000000"/>
-                </a:solidFill>
-                <a:latin typeface="맑은 고딕" pitchFamily="34" charset="0"/>
-                <a:ea typeface="맑은 고딕" pitchFamily="34" charset="-122"/>
-                <a:cs typeface="맑은 고딕" pitchFamily="34" charset="-120"/>
-              </a:rPr>
-              <a:t>- 5 -</a:t>
-            </a:r>
-            <a:endParaRPr lang="en-US" sz="1100" dirty="0"/>
-          </a:p>
-        </p:txBody>
-      </p:sp>
-      <p:sp>
-        <p:nvSpPr>
-          <p:cNvPr id="5" name="Text 3"/>
-          <p:cNvSpPr txBox="1"/>
-          <p:nvPr/>
-        </p:nvSpPr>
-        <p:spPr>
-          <a:xfrm>
             <a:off x="457200" y="82296"/>
             <a:ext cx="5120640" cy="548640"/>
           </a:xfrm>
@@ -13429,7 +13351,7 @@
       </p:sp>
       <p:sp>
         <p:nvSpPr>
-          <p:cNvPr id="6" name="Text 4"/>
+          <p:cNvPr id="5" name="Text 3"/>
           <p:cNvSpPr txBox="1"/>
           <p:nvPr/>
         </p:nvSpPr>
@@ -13468,7 +13390,7 @@
       </p:sp>
       <p:sp>
         <p:nvSpPr>
-          <p:cNvPr id="7" name="Shape 5"/>
+          <p:cNvPr id="6" name="Shape 4"/>
           <p:cNvSpPr/>
           <p:nvPr/>
         </p:nvSpPr>
@@ -13493,7 +13415,7 @@
       </p:sp>
       <p:sp>
         <p:nvSpPr>
-          <p:cNvPr id="8" name="Text 6"/>
+          <p:cNvPr id="7" name="Text 5"/>
           <p:cNvSpPr txBox="1"/>
           <p:nvPr/>
         </p:nvSpPr>
@@ -13535,7 +13457,7 @@
       </p:sp>
       <p:sp>
         <p:nvSpPr>
-          <p:cNvPr id="9" name="Shape 7"/>
+          <p:cNvPr id="8" name="Shape 6"/>
           <p:cNvSpPr/>
           <p:nvPr/>
         </p:nvSpPr>
@@ -13560,7 +13482,7 @@
       </p:sp>
       <p:sp>
         <p:nvSpPr>
-          <p:cNvPr id="10" name="Text 8"/>
+          <p:cNvPr id="9" name="Text 7"/>
           <p:cNvSpPr txBox="1"/>
           <p:nvPr/>
         </p:nvSpPr>
@@ -13602,7 +13524,7 @@
       </p:sp>
       <p:sp>
         <p:nvSpPr>
-          <p:cNvPr id="11" name="Shape 9"/>
+          <p:cNvPr id="10" name="Shape 8"/>
           <p:cNvSpPr/>
           <p:nvPr/>
         </p:nvSpPr>
@@ -13622,7 +13544,7 @@
       </p:sp>
       <p:sp>
         <p:nvSpPr>
-          <p:cNvPr id="12" name="Shape 10"/>
+          <p:cNvPr id="11" name="Shape 9"/>
           <p:cNvSpPr/>
           <p:nvPr/>
         </p:nvSpPr>
@@ -13647,7 +13569,7 @@
       </p:sp>
       <p:sp>
         <p:nvSpPr>
-          <p:cNvPr id="13" name="Text 11"/>
+          <p:cNvPr id="12" name="Text 10"/>
           <p:cNvSpPr txBox="1"/>
           <p:nvPr/>
         </p:nvSpPr>
@@ -13689,7 +13611,7 @@
       </p:sp>
       <p:sp>
         <p:nvSpPr>
-          <p:cNvPr id="14" name="Shape 12"/>
+          <p:cNvPr id="13" name="Shape 11"/>
           <p:cNvSpPr/>
           <p:nvPr/>
         </p:nvSpPr>
@@ -13714,7 +13636,7 @@
       </p:sp>
       <p:sp>
         <p:nvSpPr>
-          <p:cNvPr id="15" name="Text 13"/>
+          <p:cNvPr id="14" name="Text 12"/>
           <p:cNvSpPr txBox="1"/>
           <p:nvPr/>
         </p:nvSpPr>
@@ -13756,7 +13678,7 @@
       </p:sp>
       <p:sp>
         <p:nvSpPr>
-          <p:cNvPr id="16" name="Shape 14"/>
+          <p:cNvPr id="15" name="Shape 13"/>
           <p:cNvSpPr/>
           <p:nvPr/>
         </p:nvSpPr>
@@ -13776,7 +13698,7 @@
       </p:sp>
       <p:sp>
         <p:nvSpPr>
-          <p:cNvPr id="17" name="Shape 15"/>
+          <p:cNvPr id="16" name="Shape 14"/>
           <p:cNvSpPr/>
           <p:nvPr/>
         </p:nvSpPr>
@@ -13801,7 +13723,7 @@
       </p:sp>
       <p:sp>
         <p:nvSpPr>
-          <p:cNvPr id="18" name="Text 16"/>
+          <p:cNvPr id="17" name="Text 15"/>
           <p:cNvSpPr txBox="1"/>
           <p:nvPr/>
         </p:nvSpPr>
@@ -13863,7 +13785,7 @@
       </p:sp>
       <p:sp>
         <p:nvSpPr>
-          <p:cNvPr id="19" name="Shape 17"/>
+          <p:cNvPr id="18" name="Shape 16"/>
           <p:cNvSpPr/>
           <p:nvPr/>
         </p:nvSpPr>
@@ -13888,7 +13810,7 @@
       </p:sp>
       <p:sp>
         <p:nvSpPr>
-          <p:cNvPr id="20" name="Text 18"/>
+          <p:cNvPr id="19" name="Text 17"/>
           <p:cNvSpPr txBox="1"/>
           <p:nvPr/>
         </p:nvSpPr>
@@ -13950,7 +13872,7 @@
       </p:sp>
       <p:sp>
         <p:nvSpPr>
-          <p:cNvPr id="21" name="Shape 19"/>
+          <p:cNvPr id="20" name="Shape 18"/>
           <p:cNvSpPr/>
           <p:nvPr/>
         </p:nvSpPr>
@@ -13970,7 +13892,7 @@
       </p:sp>
       <p:sp>
         <p:nvSpPr>
-          <p:cNvPr id="22" name="Shape 20"/>
+          <p:cNvPr id="21" name="Shape 19"/>
           <p:cNvSpPr/>
           <p:nvPr/>
         </p:nvSpPr>
@@ -13995,7 +13917,7 @@
       </p:sp>
       <p:sp>
         <p:nvSpPr>
-          <p:cNvPr id="23" name="Text 21"/>
+          <p:cNvPr id="22" name="Text 20"/>
           <p:cNvSpPr txBox="1"/>
           <p:nvPr/>
         </p:nvSpPr>
@@ -14037,7 +13959,7 @@
       </p:sp>
       <p:sp>
         <p:nvSpPr>
-          <p:cNvPr id="24" name="Shape 22"/>
+          <p:cNvPr id="23" name="Shape 21"/>
           <p:cNvSpPr/>
           <p:nvPr/>
         </p:nvSpPr>
@@ -14062,7 +13984,7 @@
       </p:sp>
       <p:sp>
         <p:nvSpPr>
-          <p:cNvPr id="25" name="Text 23"/>
+          <p:cNvPr id="24" name="Text 22"/>
           <p:cNvSpPr txBox="1"/>
           <p:nvPr/>
         </p:nvSpPr>
@@ -14124,7 +14046,7 @@
       </p:sp>
       <p:sp>
         <p:nvSpPr>
-          <p:cNvPr id="26" name="Shape 24"/>
+          <p:cNvPr id="25" name="Shape 23"/>
           <p:cNvSpPr/>
           <p:nvPr/>
         </p:nvSpPr>
@@ -14144,7 +14066,7 @@
       </p:sp>
       <p:sp>
         <p:nvSpPr>
-          <p:cNvPr id="27" name="Shape 25"/>
+          <p:cNvPr id="26" name="Shape 24"/>
           <p:cNvSpPr/>
           <p:nvPr/>
         </p:nvSpPr>
@@ -14169,7 +14091,7 @@
       </p:sp>
       <p:sp>
         <p:nvSpPr>
-          <p:cNvPr id="28" name="Text 26"/>
+          <p:cNvPr id="27" name="Text 25"/>
           <p:cNvSpPr txBox="1"/>
           <p:nvPr/>
         </p:nvSpPr>
@@ -14211,7 +14133,7 @@
       </p:sp>
       <p:sp>
         <p:nvSpPr>
-          <p:cNvPr id="29" name="Shape 27"/>
+          <p:cNvPr id="28" name="Shape 26"/>
           <p:cNvSpPr/>
           <p:nvPr/>
         </p:nvSpPr>
@@ -14236,7 +14158,7 @@
       </p:sp>
       <p:sp>
         <p:nvSpPr>
-          <p:cNvPr id="30" name="Text 28"/>
+          <p:cNvPr id="29" name="Text 27"/>
           <p:cNvSpPr txBox="1"/>
           <p:nvPr/>
         </p:nvSpPr>
@@ -14278,7 +14200,7 @@
       </p:sp>
       <p:sp>
         <p:nvSpPr>
-          <p:cNvPr id="31" name="Text 29"/>
+          <p:cNvPr id="30" name="Text 28"/>
           <p:cNvSpPr txBox="1"/>
           <p:nvPr/>
         </p:nvSpPr>
@@ -15419,6 +15341,45 @@
           </a:graphicData>
         </a:graphic>
       </p:graphicFrame>
+      <p:sp>
+        <p:nvSpPr>
+          <p:cNvPr id="33" name="Text 29"/>
+          <p:cNvSpPr txBox="1"/>
+          <p:nvPr/>
+        </p:nvSpPr>
+        <p:spPr>
+          <a:xfrm>
+            <a:off x="3657600" y="6291072"/>
+            <a:ext cx="1828800" cy="274320"/>
+          </a:xfrm>
+          <a:prstGeom prst="rect">
+            <a:avLst/>
+          </a:prstGeom>
+          <a:noFill/>
+          <a:ln/>
+        </p:spPr>
+        <p:txBody>
+          <a:bodyPr wrap="square" lIns="0" tIns="0" rIns="0" bIns="0" rtlCol="0" anchor="ctr"/>
+          <a:lstStyle/>
+          <a:p>
+            <a:pPr eaLnBrk="0" latinLnBrk="0" algn="ctr" indent="0" marL="0">
+              <a:buNone/>
+            </a:pPr>
+            <a:r>
+              <a:rPr lang="en-US" sz="1100" dirty="0">
+                <a:solidFill>
+                  <a:srgbClr val="000000"/>
+                </a:solidFill>
+                <a:latin typeface="맑은 고딕" pitchFamily="34" charset="0"/>
+                <a:ea typeface="맑은 고딕" pitchFamily="34" charset="-122"/>
+                <a:cs typeface="맑은 고딕" pitchFamily="34" charset="-120"/>
+              </a:rPr>
+              <a:t>4 / 10</a:t>
+            </a:r>
+            <a:endParaRPr lang="en-US" sz="1100" dirty="0"/>
+          </a:p>
+        </p:txBody>
+      </p:sp>
     </p:spTree>
   </p:cSld>
   <p:clrMapOvr>
@@ -15509,45 +15470,6 @@
         </p:nvSpPr>
         <p:spPr>
           <a:xfrm>
-            <a:off x="3657600" y="6291072"/>
-            <a:ext cx="1828800" cy="274320"/>
-          </a:xfrm>
-          <a:prstGeom prst="rect">
-            <a:avLst/>
-          </a:prstGeom>
-          <a:noFill/>
-          <a:ln/>
-        </p:spPr>
-        <p:txBody>
-          <a:bodyPr wrap="square" lIns="0" tIns="0" rIns="0" bIns="0" rtlCol="0" anchor="ctr"/>
-          <a:lstStyle/>
-          <a:p>
-            <a:pPr eaLnBrk="0" latinLnBrk="0" algn="ctr" indent="0" marL="0">
-              <a:buNone/>
-            </a:pPr>
-            <a:r>
-              <a:rPr lang="en-US" sz="1100" dirty="0">
-                <a:solidFill>
-                  <a:srgbClr val="000000"/>
-                </a:solidFill>
-                <a:latin typeface="맑은 고딕" pitchFamily="34" charset="0"/>
-                <a:ea typeface="맑은 고딕" pitchFamily="34" charset="-122"/>
-                <a:cs typeface="맑은 고딕" pitchFamily="34" charset="-120"/>
-              </a:rPr>
-              <a:t>- 6 -</a:t>
-            </a:r>
-            <a:endParaRPr lang="en-US" sz="1100" dirty="0"/>
-          </a:p>
-        </p:txBody>
-      </p:sp>
-      <p:sp>
-        <p:nvSpPr>
-          <p:cNvPr id="5" name="Text 3"/>
-          <p:cNvSpPr txBox="1"/>
-          <p:nvPr/>
-        </p:nvSpPr>
-        <p:spPr>
-          <a:xfrm>
             <a:off x="457200" y="82296"/>
             <a:ext cx="5120640" cy="548640"/>
           </a:xfrm>
@@ -15581,7 +15503,7 @@
       </p:sp>
       <p:sp>
         <p:nvSpPr>
-          <p:cNvPr id="6" name="Text 4"/>
+          <p:cNvPr id="5" name="Text 3"/>
           <p:cNvSpPr txBox="1"/>
           <p:nvPr/>
         </p:nvSpPr>
@@ -15620,7 +15542,7 @@
       </p:sp>
       <p:sp>
         <p:nvSpPr>
-          <p:cNvPr id="7" name="Text 5"/>
+          <p:cNvPr id="6" name="Text 4"/>
           <p:cNvSpPr txBox="1"/>
           <p:nvPr/>
         </p:nvSpPr>
@@ -15659,7 +15581,7 @@
       </p:sp>
       <p:sp>
         <p:nvSpPr>
-          <p:cNvPr id="8" name="Text 6"/>
+          <p:cNvPr id="7" name="Text 5"/>
           <p:cNvSpPr txBox="1"/>
           <p:nvPr/>
         </p:nvSpPr>
@@ -15698,7 +15620,7 @@
       </p:sp>
       <p:sp>
         <p:nvSpPr>
-          <p:cNvPr id="9" name="Text 7"/>
+          <p:cNvPr id="8" name="Text 6"/>
           <p:cNvSpPr txBox="1"/>
           <p:nvPr/>
         </p:nvSpPr>
@@ -15740,7 +15662,7 @@
       </p:sp>
       <p:sp>
         <p:nvSpPr>
-          <p:cNvPr id="10" name="Text 8"/>
+          <p:cNvPr id="9" name="Text 7"/>
           <p:cNvSpPr txBox="1"/>
           <p:nvPr/>
         </p:nvSpPr>
@@ -15779,7 +15701,7 @@
       </p:sp>
       <p:sp>
         <p:nvSpPr>
-          <p:cNvPr id="11" name="Text 9"/>
+          <p:cNvPr id="10" name="Text 8"/>
           <p:cNvSpPr txBox="1"/>
           <p:nvPr/>
         </p:nvSpPr>
@@ -15821,7 +15743,7 @@
       </p:sp>
       <p:sp>
         <p:nvSpPr>
-          <p:cNvPr id="12" name="Text 10"/>
+          <p:cNvPr id="11" name="Text 9"/>
           <p:cNvSpPr txBox="1"/>
           <p:nvPr/>
         </p:nvSpPr>
@@ -15860,7 +15782,7 @@
       </p:sp>
       <p:sp>
         <p:nvSpPr>
-          <p:cNvPr id="13" name="Text 11"/>
+          <p:cNvPr id="12" name="Text 10"/>
           <p:cNvSpPr txBox="1"/>
           <p:nvPr/>
         </p:nvSpPr>
@@ -15899,7 +15821,7 @@
       </p:sp>
       <p:sp>
         <p:nvSpPr>
-          <p:cNvPr id="14" name="Text 12"/>
+          <p:cNvPr id="13" name="Text 11"/>
           <p:cNvSpPr txBox="1"/>
           <p:nvPr/>
         </p:nvSpPr>
@@ -15941,7 +15863,7 @@
       </p:sp>
       <p:sp>
         <p:nvSpPr>
-          <p:cNvPr id="15" name="Text 13"/>
+          <p:cNvPr id="14" name="Text 12"/>
           <p:cNvSpPr txBox="1"/>
           <p:nvPr/>
         </p:nvSpPr>
@@ -15980,7 +15902,7 @@
       </p:sp>
       <p:sp>
         <p:nvSpPr>
-          <p:cNvPr id="16" name="Text 14"/>
+          <p:cNvPr id="15" name="Text 13"/>
           <p:cNvSpPr txBox="1"/>
           <p:nvPr/>
         </p:nvSpPr>
@@ -16716,6 +16638,45 @@
           </a:graphicData>
         </a:graphic>
       </p:graphicFrame>
+      <p:sp>
+        <p:nvSpPr>
+          <p:cNvPr id="18" name="Text 14"/>
+          <p:cNvSpPr txBox="1"/>
+          <p:nvPr/>
+        </p:nvSpPr>
+        <p:spPr>
+          <a:xfrm>
+            <a:off x="3657600" y="6291072"/>
+            <a:ext cx="1828800" cy="274320"/>
+          </a:xfrm>
+          <a:prstGeom prst="rect">
+            <a:avLst/>
+          </a:prstGeom>
+          <a:noFill/>
+          <a:ln/>
+        </p:spPr>
+        <p:txBody>
+          <a:bodyPr wrap="square" lIns="0" tIns="0" rIns="0" bIns="0" rtlCol="0" anchor="ctr"/>
+          <a:lstStyle/>
+          <a:p>
+            <a:pPr eaLnBrk="0" latinLnBrk="0" algn="ctr" indent="0" marL="0">
+              <a:buNone/>
+            </a:pPr>
+            <a:r>
+              <a:rPr lang="en-US" sz="1100" dirty="0">
+                <a:solidFill>
+                  <a:srgbClr val="000000"/>
+                </a:solidFill>
+                <a:latin typeface="맑은 고딕" pitchFamily="34" charset="0"/>
+                <a:ea typeface="맑은 고딕" pitchFamily="34" charset="-122"/>
+                <a:cs typeface="맑은 고딕" pitchFamily="34" charset="-120"/>
+              </a:rPr>
+              <a:t>5 / 10</a:t>
+            </a:r>
+            <a:endParaRPr lang="en-US" sz="1100" dirty="0"/>
+          </a:p>
+        </p:txBody>
+      </p:sp>
     </p:spTree>
   </p:cSld>
   <p:clrMapOvr>
@@ -16806,45 +16767,6 @@
         </p:nvSpPr>
         <p:spPr>
           <a:xfrm>
-            <a:off x="3657600" y="6291072"/>
-            <a:ext cx="1828800" cy="274320"/>
-          </a:xfrm>
-          <a:prstGeom prst="rect">
-            <a:avLst/>
-          </a:prstGeom>
-          <a:noFill/>
-          <a:ln/>
-        </p:spPr>
-        <p:txBody>
-          <a:bodyPr wrap="square" lIns="0" tIns="0" rIns="0" bIns="0" rtlCol="0" anchor="ctr"/>
-          <a:lstStyle/>
-          <a:p>
-            <a:pPr eaLnBrk="0" latinLnBrk="0" algn="ctr" indent="0" marL="0">
-              <a:buNone/>
-            </a:pPr>
-            <a:r>
-              <a:rPr lang="en-US" sz="1100" dirty="0">
-                <a:solidFill>
-                  <a:srgbClr val="000000"/>
-                </a:solidFill>
-                <a:latin typeface="맑은 고딕" pitchFamily="34" charset="0"/>
-                <a:ea typeface="맑은 고딕" pitchFamily="34" charset="-122"/>
-                <a:cs typeface="맑은 고딕" pitchFamily="34" charset="-120"/>
-              </a:rPr>
-              <a:t>- 7 -</a:t>
-            </a:r>
-            <a:endParaRPr lang="en-US" sz="1100" dirty="0"/>
-          </a:p>
-        </p:txBody>
-      </p:sp>
-      <p:sp>
-        <p:nvSpPr>
-          <p:cNvPr id="5" name="Text 3"/>
-          <p:cNvSpPr txBox="1"/>
-          <p:nvPr/>
-        </p:nvSpPr>
-        <p:spPr>
-          <a:xfrm>
             <a:off x="457200" y="82296"/>
             <a:ext cx="5120640" cy="548640"/>
           </a:xfrm>
@@ -16878,7 +16800,7 @@
       </p:sp>
       <p:sp>
         <p:nvSpPr>
-          <p:cNvPr id="6" name="Text 4"/>
+          <p:cNvPr id="5" name="Text 3"/>
           <p:cNvSpPr txBox="1"/>
           <p:nvPr/>
         </p:nvSpPr>
@@ -16917,7 +16839,7 @@
       </p:sp>
       <p:sp>
         <p:nvSpPr>
-          <p:cNvPr id="7" name="Text 5"/>
+          <p:cNvPr id="6" name="Text 4"/>
           <p:cNvSpPr txBox="1"/>
           <p:nvPr/>
         </p:nvSpPr>
@@ -16956,7 +16878,7 @@
       </p:sp>
       <p:sp>
         <p:nvSpPr>
-          <p:cNvPr id="8" name="Text 6"/>
+          <p:cNvPr id="7" name="Text 5"/>
           <p:cNvSpPr txBox="1"/>
           <p:nvPr/>
         </p:nvSpPr>
@@ -16995,7 +16917,7 @@
       </p:sp>
       <p:sp>
         <p:nvSpPr>
-          <p:cNvPr id="9" name="Text 7"/>
+          <p:cNvPr id="8" name="Text 6"/>
           <p:cNvSpPr txBox="1"/>
           <p:nvPr/>
         </p:nvSpPr>
@@ -17037,7 +16959,7 @@
       </p:sp>
       <p:sp>
         <p:nvSpPr>
-          <p:cNvPr id="10" name="Text 8"/>
+          <p:cNvPr id="9" name="Text 7"/>
           <p:cNvSpPr txBox="1"/>
           <p:nvPr/>
         </p:nvSpPr>
@@ -17076,7 +16998,7 @@
       </p:sp>
       <p:sp>
         <p:nvSpPr>
-          <p:cNvPr id="11" name="Text 9"/>
+          <p:cNvPr id="10" name="Text 8"/>
           <p:cNvSpPr txBox="1"/>
           <p:nvPr/>
         </p:nvSpPr>
@@ -17118,7 +17040,7 @@
       </p:sp>
       <p:sp>
         <p:nvSpPr>
-          <p:cNvPr id="12" name="Text 10"/>
+          <p:cNvPr id="11" name="Text 9"/>
           <p:cNvSpPr txBox="1"/>
           <p:nvPr/>
         </p:nvSpPr>
@@ -18161,7 +18083,7 @@
       </p:graphicFrame>
       <p:sp>
         <p:nvSpPr>
-          <p:cNvPr id="14" name="Text 11"/>
+          <p:cNvPr id="13" name="Text 10"/>
           <p:cNvSpPr txBox="1"/>
           <p:nvPr/>
         </p:nvSpPr>
@@ -18200,7 +18122,7 @@
       </p:sp>
       <p:sp>
         <p:nvSpPr>
-          <p:cNvPr id="15" name="Text 12"/>
+          <p:cNvPr id="14" name="Text 11"/>
           <p:cNvSpPr txBox="1"/>
           <p:nvPr/>
         </p:nvSpPr>
@@ -18239,7 +18161,7 @@
       </p:sp>
       <p:sp>
         <p:nvSpPr>
-          <p:cNvPr id="16" name="Text 13"/>
+          <p:cNvPr id="15" name="Text 12"/>
           <p:cNvSpPr txBox="1"/>
           <p:nvPr/>
         </p:nvSpPr>
@@ -18281,7 +18203,7 @@
       </p:sp>
       <p:sp>
         <p:nvSpPr>
-          <p:cNvPr id="17" name="Text 14"/>
+          <p:cNvPr id="16" name="Text 13"/>
           <p:cNvSpPr txBox="1"/>
           <p:nvPr/>
         </p:nvSpPr>
@@ -18320,7 +18242,7 @@
       </p:sp>
       <p:sp>
         <p:nvSpPr>
-          <p:cNvPr id="18" name="Text 15"/>
+          <p:cNvPr id="17" name="Text 14"/>
           <p:cNvSpPr txBox="1"/>
           <p:nvPr/>
         </p:nvSpPr>
@@ -18362,7 +18284,7 @@
       </p:sp>
       <p:sp>
         <p:nvSpPr>
-          <p:cNvPr id="19" name="Text 16"/>
+          <p:cNvPr id="18" name="Text 15"/>
           <p:cNvSpPr txBox="1"/>
           <p:nvPr/>
         </p:nvSpPr>
@@ -18401,7 +18323,7 @@
       </p:sp>
       <p:sp>
         <p:nvSpPr>
-          <p:cNvPr id="20" name="Text 17"/>
+          <p:cNvPr id="19" name="Text 16"/>
           <p:cNvSpPr txBox="1"/>
           <p:nvPr/>
         </p:nvSpPr>
@@ -18441,6 +18363,45 @@
           </a:p>
         </p:txBody>
       </p:sp>
+      <p:sp>
+        <p:nvSpPr>
+          <p:cNvPr id="21" name="Text 17"/>
+          <p:cNvSpPr txBox="1"/>
+          <p:nvPr/>
+        </p:nvSpPr>
+        <p:spPr>
+          <a:xfrm>
+            <a:off x="3657600" y="6291072"/>
+            <a:ext cx="1828800" cy="274320"/>
+          </a:xfrm>
+          <a:prstGeom prst="rect">
+            <a:avLst/>
+          </a:prstGeom>
+          <a:noFill/>
+          <a:ln/>
+        </p:spPr>
+        <p:txBody>
+          <a:bodyPr wrap="square" lIns="0" tIns="0" rIns="0" bIns="0" rtlCol="0" anchor="ctr"/>
+          <a:lstStyle/>
+          <a:p>
+            <a:pPr eaLnBrk="0" latinLnBrk="0" algn="ctr" indent="0" marL="0">
+              <a:buNone/>
+            </a:pPr>
+            <a:r>
+              <a:rPr lang="en-US" sz="1100" dirty="0">
+                <a:solidFill>
+                  <a:srgbClr val="000000"/>
+                </a:solidFill>
+                <a:latin typeface="맑은 고딕" pitchFamily="34" charset="0"/>
+                <a:ea typeface="맑은 고딕" pitchFamily="34" charset="-122"/>
+                <a:cs typeface="맑은 고딕" pitchFamily="34" charset="-120"/>
+              </a:rPr>
+              <a:t>6 / 10</a:t>
+            </a:r>
+            <a:endParaRPr lang="en-US" sz="1100" dirty="0"/>
+          </a:p>
+        </p:txBody>
+      </p:sp>
     </p:spTree>
   </p:cSld>
   <p:clrMapOvr>
@@ -18531,45 +18492,6 @@
         </p:nvSpPr>
         <p:spPr>
           <a:xfrm>
-            <a:off x="3657600" y="6291072"/>
-            <a:ext cx="1828800" cy="274320"/>
-          </a:xfrm>
-          <a:prstGeom prst="rect">
-            <a:avLst/>
-          </a:prstGeom>
-          <a:noFill/>
-          <a:ln/>
-        </p:spPr>
-        <p:txBody>
-          <a:bodyPr wrap="square" lIns="0" tIns="0" rIns="0" bIns="0" rtlCol="0" anchor="ctr"/>
-          <a:lstStyle/>
-          <a:p>
-            <a:pPr eaLnBrk="0" latinLnBrk="0" algn="ctr" indent="0" marL="0">
-              <a:buNone/>
-            </a:pPr>
-            <a:r>
-              <a:rPr lang="en-US" sz="1100" dirty="0">
-                <a:solidFill>
-                  <a:srgbClr val="000000"/>
-                </a:solidFill>
-                <a:latin typeface="맑은 고딕" pitchFamily="34" charset="0"/>
-                <a:ea typeface="맑은 고딕" pitchFamily="34" charset="-122"/>
-                <a:cs typeface="맑은 고딕" pitchFamily="34" charset="-120"/>
-              </a:rPr>
-              <a:t>- 8 -</a:t>
-            </a:r>
-            <a:endParaRPr lang="en-US" sz="1100" dirty="0"/>
-          </a:p>
-        </p:txBody>
-      </p:sp>
-      <p:sp>
-        <p:nvSpPr>
-          <p:cNvPr id="5" name="Text 3"/>
-          <p:cNvSpPr txBox="1"/>
-          <p:nvPr/>
-        </p:nvSpPr>
-        <p:spPr>
-          <a:xfrm>
             <a:off x="457200" y="82296"/>
             <a:ext cx="5120640" cy="548640"/>
           </a:xfrm>
@@ -18603,7 +18525,7 @@
       </p:sp>
       <p:sp>
         <p:nvSpPr>
-          <p:cNvPr id="6" name="Text 4"/>
+          <p:cNvPr id="5" name="Text 3"/>
           <p:cNvSpPr txBox="1"/>
           <p:nvPr/>
         </p:nvSpPr>
@@ -18642,7 +18564,7 @@
       </p:sp>
       <p:sp>
         <p:nvSpPr>
-          <p:cNvPr id="7" name="Text 5"/>
+          <p:cNvPr id="6" name="Text 4"/>
           <p:cNvSpPr txBox="1"/>
           <p:nvPr/>
         </p:nvSpPr>
@@ -18681,7 +18603,7 @@
       </p:sp>
       <p:sp>
         <p:nvSpPr>
-          <p:cNvPr id="8" name="Text 6"/>
+          <p:cNvPr id="7" name="Text 5"/>
           <p:cNvSpPr txBox="1"/>
           <p:nvPr/>
         </p:nvSpPr>
@@ -18720,7 +18642,7 @@
       </p:sp>
       <p:sp>
         <p:nvSpPr>
-          <p:cNvPr id="9" name="Text 7"/>
+          <p:cNvPr id="8" name="Text 6"/>
           <p:cNvSpPr txBox="1"/>
           <p:nvPr/>
         </p:nvSpPr>
@@ -18762,7 +18684,7 @@
       </p:sp>
       <p:sp>
         <p:nvSpPr>
-          <p:cNvPr id="10" name="Text 8"/>
+          <p:cNvPr id="9" name="Text 7"/>
           <p:cNvSpPr txBox="1"/>
           <p:nvPr/>
         </p:nvSpPr>
@@ -18801,7 +18723,7 @@
       </p:sp>
       <p:sp>
         <p:nvSpPr>
-          <p:cNvPr id="11" name="Text 9"/>
+          <p:cNvPr id="10" name="Text 8"/>
           <p:cNvSpPr txBox="1"/>
           <p:nvPr/>
         </p:nvSpPr>
@@ -18843,7 +18765,7 @@
       </p:sp>
       <p:sp>
         <p:nvSpPr>
-          <p:cNvPr id="12" name="Text 10"/>
+          <p:cNvPr id="11" name="Text 9"/>
           <p:cNvSpPr txBox="1"/>
           <p:nvPr/>
         </p:nvSpPr>
@@ -19886,7 +19808,7 @@
       </p:graphicFrame>
       <p:sp>
         <p:nvSpPr>
-          <p:cNvPr id="14" name="Text 11"/>
+          <p:cNvPr id="13" name="Text 10"/>
           <p:cNvSpPr txBox="1"/>
           <p:nvPr/>
         </p:nvSpPr>
@@ -19925,7 +19847,7 @@
       </p:sp>
       <p:sp>
         <p:nvSpPr>
-          <p:cNvPr id="15" name="Text 12"/>
+          <p:cNvPr id="14" name="Text 11"/>
           <p:cNvSpPr txBox="1"/>
           <p:nvPr/>
         </p:nvSpPr>
@@ -19964,7 +19886,7 @@
       </p:sp>
       <p:sp>
         <p:nvSpPr>
-          <p:cNvPr id="16" name="Text 13"/>
+          <p:cNvPr id="15" name="Text 12"/>
           <p:cNvSpPr txBox="1"/>
           <p:nvPr/>
         </p:nvSpPr>
@@ -20006,7 +19928,7 @@
       </p:sp>
       <p:sp>
         <p:nvSpPr>
-          <p:cNvPr id="17" name="Text 14"/>
+          <p:cNvPr id="16" name="Text 13"/>
           <p:cNvSpPr txBox="1"/>
           <p:nvPr/>
         </p:nvSpPr>
@@ -20045,7 +19967,7 @@
       </p:sp>
       <p:sp>
         <p:nvSpPr>
-          <p:cNvPr id="18" name="Text 15"/>
+          <p:cNvPr id="17" name="Text 14"/>
           <p:cNvSpPr txBox="1"/>
           <p:nvPr/>
         </p:nvSpPr>
@@ -20080,6 +20002,45 @@
                 <a:cs typeface="맑은 고딕" pitchFamily="34" charset="-120"/>
               </a:rPr>
               <a:t>최종합격 예정자에 대하여 법인에 임용 제청을 요청함.</a:t>
+            </a:r>
+            <a:endParaRPr lang="en-US" sz="1100" dirty="0"/>
+          </a:p>
+        </p:txBody>
+      </p:sp>
+      <p:sp>
+        <p:nvSpPr>
+          <p:cNvPr id="19" name="Text 15"/>
+          <p:cNvSpPr txBox="1"/>
+          <p:nvPr/>
+        </p:nvSpPr>
+        <p:spPr>
+          <a:xfrm>
+            <a:off x="3657600" y="6291072"/>
+            <a:ext cx="1828800" cy="274320"/>
+          </a:xfrm>
+          <a:prstGeom prst="rect">
+            <a:avLst/>
+          </a:prstGeom>
+          <a:noFill/>
+          <a:ln/>
+        </p:spPr>
+        <p:txBody>
+          <a:bodyPr wrap="square" lIns="0" tIns="0" rIns="0" bIns="0" rtlCol="0" anchor="ctr"/>
+          <a:lstStyle/>
+          <a:p>
+            <a:pPr eaLnBrk="0" latinLnBrk="0" algn="ctr" indent="0" marL="0">
+              <a:buNone/>
+            </a:pPr>
+            <a:r>
+              <a:rPr lang="en-US" sz="1100" dirty="0">
+                <a:solidFill>
+                  <a:srgbClr val="000000"/>
+                </a:solidFill>
+                <a:latin typeface="맑은 고딕" pitchFamily="34" charset="0"/>
+                <a:ea typeface="맑은 고딕" pitchFamily="34" charset="-122"/>
+                <a:cs typeface="맑은 고딕" pitchFamily="34" charset="-120"/>
+              </a:rPr>
+              <a:t>7 / 10</a:t>
             </a:r>
             <a:endParaRPr lang="en-US" sz="1100" dirty="0"/>
           </a:p>

</xml_diff>

<commit_message>
Set the 목차 as a shaded table rather than a bare list
Each section becomes a row in a bordered 구분 / 항목 / 비고 table: the
number column carries the pale D9F6FF tint, and rows 5-8 are washed in
a lighter EFF9FC so the four 전형 단계 read as one group, with the stage
named in 비고.

Co-Authored-By: Claude Opus 5 <noreply@anthropic.com>
Claude-Session: https://claude.ai/code/session_01GZfitk2JEKppZ4fGSDdghv
</commit_message>
<xml_diff>
--- a/docs/2027년_사무직원_채용계획안.pptx
+++ b/docs/2027년_사무직원_채용계획안.pptx
@@ -6443,16 +6443,2211 @@
           </a:p>
         </p:txBody>
       </p:sp>
+      <p:graphicFrame>
+        <p:nvGraphicFramePr>
+          <p:cNvPr id="3" name="Table 0"/>
+          <p:cNvGraphicFramePr>
+            <a:graphicFrameLocks noGrp="1"/>
+          </p:cNvGraphicFramePr>
+          <p:nvPr>
+            <p:extLst>
+              <p:ext uri="{D42A27DB-BD31-4B8C-83A1-F6EECF244321}">
+                <p14:modId xmlns:p14="http://schemas.microsoft.com/office/powerpoint/2010/main" val="1579011935"/>
+              </p:ext>
+            </p:extLst>
+          </p:nvPr>
+        </p:nvGraphicFramePr>
+        <p:xfrm>
+          <a:off x="1005840" y="1188720"/>
+          <a:ext cx="7132320" cy="914400"/>
+        </p:xfrm>
+        <a:graphic>
+          <a:graphicData uri="http://schemas.openxmlformats.org/drawingml/2006/table">
+            <a:tbl>
+              <a:tblPr/>
+              <a:tblGrid>
+                <a:gridCol w="822960"/>
+                <a:gridCol w="4206240"/>
+                <a:gridCol w="2103120"/>
+              </a:tblGrid>
+              <a:tr h="329184">
+                <a:tc>
+                  <a:txBody>
+                    <a:bodyPr/>
+                    <a:lstStyle/>
+                    <a:p>
+                      <a:pPr eaLnBrk="0" latinLnBrk="0" algn="ctr" indent="0" marL="0">
+                        <a:buNone/>
+                      </a:pPr>
+                      <a:r>
+                        <a:rPr lang="en-US" sz="1050" b="1" dirty="0">
+                          <a:solidFill>
+                            <a:srgbClr val="000000"/>
+                          </a:solidFill>
+                          <a:latin typeface="맑은 고딕" pitchFamily="34" charset="0"/>
+                          <a:ea typeface="맑은 고딕" pitchFamily="34" charset="-122"/>
+                          <a:cs typeface="맑은 고딕" pitchFamily="34" charset="-120"/>
+                        </a:rPr>
+                        <a:t>구분</a:t>
+                      </a:r>
+                      <a:endParaRPr lang="en-US" sz="1050" dirty="0">
+                        <a:latin typeface="맑은 고딕" charset="0"/>
+                        <a:ea typeface="맑은 고딕" charset="0"/>
+                        <a:cs typeface="맑은 고딕" charset="0"/>
+                      </a:endParaRPr>
+                    </a:p>
+                  </a:txBody>
+                  <a:tcPr marL="38100" marR="38100" marT="38100" marB="38100" anchor="ctr">
+                    <a:lnL w="12700" cap="flat" cmpd="sng" algn="ctr">
+                      <a:solidFill>
+                        <a:srgbClr val="000000"/>
+                      </a:solidFill>
+                      <a:prstDash val="solid"/>
+                      <a:round/>
+                      <a:headEnd type="none" w="med" len="med"/>
+                      <a:tailEnd type="none" w="med" len="med"/>
+                    </a:lnL>
+                    <a:lnR w="12700" cap="flat" cmpd="sng" algn="ctr">
+                      <a:solidFill>
+                        <a:srgbClr val="000000"/>
+                      </a:solidFill>
+                      <a:prstDash val="solid"/>
+                      <a:round/>
+                      <a:headEnd type="none" w="med" len="med"/>
+                      <a:tailEnd type="none" w="med" len="med"/>
+                    </a:lnR>
+                    <a:lnT w="12700" cap="flat" cmpd="sng" algn="ctr">
+                      <a:solidFill>
+                        <a:srgbClr val="000000"/>
+                      </a:solidFill>
+                      <a:prstDash val="solid"/>
+                      <a:round/>
+                      <a:headEnd type="none" w="med" len="med"/>
+                      <a:tailEnd type="none" w="med" len="med"/>
+                    </a:lnT>
+                    <a:lnB w="12700" cap="flat" cmpd="sng" algn="ctr">
+                      <a:solidFill>
+                        <a:srgbClr val="000000"/>
+                      </a:solidFill>
+                      <a:prstDash val="solid"/>
+                      <a:round/>
+                      <a:headEnd type="none" w="med" len="med"/>
+                      <a:tailEnd type="none" w="med" len="med"/>
+                    </a:lnB>
+                    <a:solidFill>
+                      <a:srgbClr val="CCFFFF"/>
+                    </a:solidFill>
+                  </a:tcPr>
+                </a:tc>
+                <a:tc>
+                  <a:txBody>
+                    <a:bodyPr/>
+                    <a:lstStyle/>
+                    <a:p>
+                      <a:pPr eaLnBrk="0" latinLnBrk="0" algn="ctr" indent="0" marL="0">
+                        <a:buNone/>
+                      </a:pPr>
+                      <a:r>
+                        <a:rPr lang="en-US" sz="1050" b="1" dirty="0">
+                          <a:solidFill>
+                            <a:srgbClr val="000000"/>
+                          </a:solidFill>
+                          <a:latin typeface="맑은 고딕" pitchFamily="34" charset="0"/>
+                          <a:ea typeface="맑은 고딕" pitchFamily="34" charset="-122"/>
+                          <a:cs typeface="맑은 고딕" pitchFamily="34" charset="-120"/>
+                        </a:rPr>
+                        <a:t>항  목</a:t>
+                      </a:r>
+                      <a:endParaRPr lang="en-US" sz="1050" dirty="0">
+                        <a:latin typeface="맑은 고딕" charset="0"/>
+                        <a:ea typeface="맑은 고딕" charset="0"/>
+                        <a:cs typeface="맑은 고딕" charset="0"/>
+                      </a:endParaRPr>
+                    </a:p>
+                  </a:txBody>
+                  <a:tcPr marL="38100" marR="38100" marT="38100" marB="38100" anchor="ctr">
+                    <a:lnL w="12700" cap="flat" cmpd="sng" algn="ctr">
+                      <a:solidFill>
+                        <a:srgbClr val="000000"/>
+                      </a:solidFill>
+                      <a:prstDash val="solid"/>
+                      <a:round/>
+                      <a:headEnd type="none" w="med" len="med"/>
+                      <a:tailEnd type="none" w="med" len="med"/>
+                    </a:lnL>
+                    <a:lnR w="12700" cap="flat" cmpd="sng" algn="ctr">
+                      <a:solidFill>
+                        <a:srgbClr val="000000"/>
+                      </a:solidFill>
+                      <a:prstDash val="solid"/>
+                      <a:round/>
+                      <a:headEnd type="none" w="med" len="med"/>
+                      <a:tailEnd type="none" w="med" len="med"/>
+                    </a:lnR>
+                    <a:lnT w="12700" cap="flat" cmpd="sng" algn="ctr">
+                      <a:solidFill>
+                        <a:srgbClr val="000000"/>
+                      </a:solidFill>
+                      <a:prstDash val="solid"/>
+                      <a:round/>
+                      <a:headEnd type="none" w="med" len="med"/>
+                      <a:tailEnd type="none" w="med" len="med"/>
+                    </a:lnT>
+                    <a:lnB w="12700" cap="flat" cmpd="sng" algn="ctr">
+                      <a:solidFill>
+                        <a:srgbClr val="000000"/>
+                      </a:solidFill>
+                      <a:prstDash val="solid"/>
+                      <a:round/>
+                      <a:headEnd type="none" w="med" len="med"/>
+                      <a:tailEnd type="none" w="med" len="med"/>
+                    </a:lnB>
+                    <a:solidFill>
+                      <a:srgbClr val="CCFFFF"/>
+                    </a:solidFill>
+                  </a:tcPr>
+                </a:tc>
+                <a:tc>
+                  <a:txBody>
+                    <a:bodyPr/>
+                    <a:lstStyle/>
+                    <a:p>
+                      <a:pPr eaLnBrk="0" latinLnBrk="0" algn="ctr" indent="0" marL="0">
+                        <a:buNone/>
+                      </a:pPr>
+                      <a:r>
+                        <a:rPr lang="en-US" sz="1050" b="1" dirty="0">
+                          <a:solidFill>
+                            <a:srgbClr val="000000"/>
+                          </a:solidFill>
+                          <a:latin typeface="맑은 고딕" pitchFamily="34" charset="0"/>
+                          <a:ea typeface="맑은 고딕" pitchFamily="34" charset="-122"/>
+                          <a:cs typeface="맑은 고딕" pitchFamily="34" charset="-120"/>
+                        </a:rPr>
+                        <a:t>비고</a:t>
+                      </a:r>
+                      <a:endParaRPr lang="en-US" sz="1050" dirty="0">
+                        <a:latin typeface="맑은 고딕" charset="0"/>
+                        <a:ea typeface="맑은 고딕" charset="0"/>
+                        <a:cs typeface="맑은 고딕" charset="0"/>
+                      </a:endParaRPr>
+                    </a:p>
+                  </a:txBody>
+                  <a:tcPr marL="38100" marR="38100" marT="38100" marB="38100" anchor="ctr">
+                    <a:lnL w="12700" cap="flat" cmpd="sng" algn="ctr">
+                      <a:solidFill>
+                        <a:srgbClr val="000000"/>
+                      </a:solidFill>
+                      <a:prstDash val="solid"/>
+                      <a:round/>
+                      <a:headEnd type="none" w="med" len="med"/>
+                      <a:tailEnd type="none" w="med" len="med"/>
+                    </a:lnL>
+                    <a:lnR w="12700" cap="flat" cmpd="sng" algn="ctr">
+                      <a:solidFill>
+                        <a:srgbClr val="000000"/>
+                      </a:solidFill>
+                      <a:prstDash val="solid"/>
+                      <a:round/>
+                      <a:headEnd type="none" w="med" len="med"/>
+                      <a:tailEnd type="none" w="med" len="med"/>
+                    </a:lnR>
+                    <a:lnT w="12700" cap="flat" cmpd="sng" algn="ctr">
+                      <a:solidFill>
+                        <a:srgbClr val="000000"/>
+                      </a:solidFill>
+                      <a:prstDash val="solid"/>
+                      <a:round/>
+                      <a:headEnd type="none" w="med" len="med"/>
+                      <a:tailEnd type="none" w="med" len="med"/>
+                    </a:lnT>
+                    <a:lnB w="12700" cap="flat" cmpd="sng" algn="ctr">
+                      <a:solidFill>
+                        <a:srgbClr val="000000"/>
+                      </a:solidFill>
+                      <a:prstDash val="solid"/>
+                      <a:round/>
+                      <a:headEnd type="none" w="med" len="med"/>
+                      <a:tailEnd type="none" w="med" len="med"/>
+                    </a:lnB>
+                    <a:solidFill>
+                      <a:srgbClr val="CCFFFF"/>
+                    </a:solidFill>
+                  </a:tcPr>
+                </a:tc>
+              </a:tr>
+              <a:tr h="402336">
+                <a:tc>
+                  <a:txBody>
+                    <a:bodyPr/>
+                    <a:lstStyle/>
+                    <a:p>
+                      <a:pPr eaLnBrk="0" latinLnBrk="0" algn="ctr" indent="0" marL="0">
+                        <a:buNone/>
+                      </a:pPr>
+                      <a:r>
+                        <a:rPr lang="en-US" sz="1200" b="1" dirty="0">
+                          <a:solidFill>
+                            <a:srgbClr val="000000"/>
+                          </a:solidFill>
+                          <a:latin typeface="맑은 고딕" pitchFamily="34" charset="0"/>
+                          <a:ea typeface="맑은 고딕" pitchFamily="34" charset="-122"/>
+                          <a:cs typeface="맑은 고딕" pitchFamily="34" charset="-120"/>
+                        </a:rPr>
+                        <a:t>1</a:t>
+                      </a:r>
+                      <a:endParaRPr lang="en-US" sz="1200" dirty="0">
+                        <a:latin typeface="맑은 고딕" charset="0"/>
+                        <a:ea typeface="맑은 고딕" charset="0"/>
+                        <a:cs typeface="맑은 고딕" charset="0"/>
+                      </a:endParaRPr>
+                    </a:p>
+                  </a:txBody>
+                  <a:tcPr marL="38100" marR="38100" marT="38100" marB="38100" anchor="ctr">
+                    <a:lnL w="12700" cap="flat" cmpd="sng" algn="ctr">
+                      <a:solidFill>
+                        <a:srgbClr val="000000"/>
+                      </a:solidFill>
+                      <a:prstDash val="solid"/>
+                      <a:round/>
+                      <a:headEnd type="none" w="med" len="med"/>
+                      <a:tailEnd type="none" w="med" len="med"/>
+                    </a:lnL>
+                    <a:lnR w="12700" cap="flat" cmpd="sng" algn="ctr">
+                      <a:solidFill>
+                        <a:srgbClr val="000000"/>
+                      </a:solidFill>
+                      <a:prstDash val="solid"/>
+                      <a:round/>
+                      <a:headEnd type="none" w="med" len="med"/>
+                      <a:tailEnd type="none" w="med" len="med"/>
+                    </a:lnR>
+                    <a:lnT w="12700" cap="flat" cmpd="sng" algn="ctr">
+                      <a:solidFill>
+                        <a:srgbClr val="000000"/>
+                      </a:solidFill>
+                      <a:prstDash val="solid"/>
+                      <a:round/>
+                      <a:headEnd type="none" w="med" len="med"/>
+                      <a:tailEnd type="none" w="med" len="med"/>
+                    </a:lnT>
+                    <a:lnB w="12700" cap="flat" cmpd="sng" algn="ctr">
+                      <a:solidFill>
+                        <a:srgbClr val="000000"/>
+                      </a:solidFill>
+                      <a:prstDash val="solid"/>
+                      <a:round/>
+                      <a:headEnd type="none" w="med" len="med"/>
+                      <a:tailEnd type="none" w="med" len="med"/>
+                    </a:lnB>
+                    <a:solidFill>
+                      <a:srgbClr val="D9F6FF"/>
+                    </a:solidFill>
+                  </a:tcPr>
+                </a:tc>
+                <a:tc>
+                  <a:txBody>
+                    <a:bodyPr/>
+                    <a:lstStyle/>
+                    <a:p>
+                      <a:pPr eaLnBrk="0" latinLnBrk="0" algn="l" indent="0" marL="0">
+                        <a:buNone/>
+                      </a:pPr>
+                      <a:r>
+                        <a:rPr lang="en-US" sz="1300" dirty="0">
+                          <a:solidFill>
+                            <a:srgbClr val="000000"/>
+                          </a:solidFill>
+                          <a:latin typeface="맑은 고딕" pitchFamily="34" charset="0"/>
+                          <a:ea typeface="맑은 고딕" pitchFamily="34" charset="-122"/>
+                          <a:cs typeface="맑은 고딕" pitchFamily="34" charset="-120"/>
+                        </a:rPr>
+                        <a:t>채용 인원 및 채용 사유</a:t>
+                      </a:r>
+                      <a:endParaRPr lang="en-US" sz="1300" dirty="0">
+                        <a:latin typeface="맑은 고딕" charset="0"/>
+                        <a:ea typeface="맑은 고딕" charset="0"/>
+                        <a:cs typeface="맑은 고딕" charset="0"/>
+                      </a:endParaRPr>
+                    </a:p>
+                  </a:txBody>
+                  <a:tcPr marL="38100" marR="38100" marT="38100" marB="38100" anchor="ctr">
+                    <a:lnL w="12700" cap="flat" cmpd="sng" algn="ctr">
+                      <a:solidFill>
+                        <a:srgbClr val="000000"/>
+                      </a:solidFill>
+                      <a:prstDash val="solid"/>
+                      <a:round/>
+                      <a:headEnd type="none" w="med" len="med"/>
+                      <a:tailEnd type="none" w="med" len="med"/>
+                    </a:lnL>
+                    <a:lnR w="12700" cap="flat" cmpd="sng" algn="ctr">
+                      <a:solidFill>
+                        <a:srgbClr val="000000"/>
+                      </a:solidFill>
+                      <a:prstDash val="solid"/>
+                      <a:round/>
+                      <a:headEnd type="none" w="med" len="med"/>
+                      <a:tailEnd type="none" w="med" len="med"/>
+                    </a:lnR>
+                    <a:lnT w="12700" cap="flat" cmpd="sng" algn="ctr">
+                      <a:solidFill>
+                        <a:srgbClr val="000000"/>
+                      </a:solidFill>
+                      <a:prstDash val="solid"/>
+                      <a:round/>
+                      <a:headEnd type="none" w="med" len="med"/>
+                      <a:tailEnd type="none" w="med" len="med"/>
+                    </a:lnT>
+                    <a:lnB w="12700" cap="flat" cmpd="sng" algn="ctr">
+                      <a:solidFill>
+                        <a:srgbClr val="000000"/>
+                      </a:solidFill>
+                      <a:prstDash val="solid"/>
+                      <a:round/>
+                      <a:headEnd type="none" w="med" len="med"/>
+                      <a:tailEnd type="none" w="med" len="med"/>
+                    </a:lnB>
+                  </a:tcPr>
+                </a:tc>
+                <a:tc>
+                  <a:txBody>
+                    <a:bodyPr/>
+                    <a:lstStyle/>
+                    <a:p>
+                      <a:pPr eaLnBrk="0" latinLnBrk="0" algn="ctr" indent="0" marL="0">
+                        <a:buNone/>
+                      </a:pPr>
+                      <a:endParaRPr lang="en-US" sz="1050" dirty="0">
+                        <a:latin typeface="맑은 고딕" charset="0"/>
+                        <a:ea typeface="맑은 고딕" charset="0"/>
+                        <a:cs typeface="맑은 고딕" charset="0"/>
+                      </a:endParaRPr>
+                    </a:p>
+                  </a:txBody>
+                  <a:tcPr marL="38100" marR="38100" marT="38100" marB="38100" anchor="ctr">
+                    <a:lnL w="12700" cap="flat" cmpd="sng" algn="ctr">
+                      <a:solidFill>
+                        <a:srgbClr val="000000"/>
+                      </a:solidFill>
+                      <a:prstDash val="solid"/>
+                      <a:round/>
+                      <a:headEnd type="none" w="med" len="med"/>
+                      <a:tailEnd type="none" w="med" len="med"/>
+                    </a:lnL>
+                    <a:lnR w="12700" cap="flat" cmpd="sng" algn="ctr">
+                      <a:solidFill>
+                        <a:srgbClr val="000000"/>
+                      </a:solidFill>
+                      <a:prstDash val="solid"/>
+                      <a:round/>
+                      <a:headEnd type="none" w="med" len="med"/>
+                      <a:tailEnd type="none" w="med" len="med"/>
+                    </a:lnR>
+                    <a:lnT w="12700" cap="flat" cmpd="sng" algn="ctr">
+                      <a:solidFill>
+                        <a:srgbClr val="000000"/>
+                      </a:solidFill>
+                      <a:prstDash val="solid"/>
+                      <a:round/>
+                      <a:headEnd type="none" w="med" len="med"/>
+                      <a:tailEnd type="none" w="med" len="med"/>
+                    </a:lnT>
+                    <a:lnB w="12700" cap="flat" cmpd="sng" algn="ctr">
+                      <a:solidFill>
+                        <a:srgbClr val="000000"/>
+                      </a:solidFill>
+                      <a:prstDash val="solid"/>
+                      <a:round/>
+                      <a:headEnd type="none" w="med" len="med"/>
+                      <a:tailEnd type="none" w="med" len="med"/>
+                    </a:lnB>
+                  </a:tcPr>
+                </a:tc>
+              </a:tr>
+              <a:tr h="402336">
+                <a:tc>
+                  <a:txBody>
+                    <a:bodyPr/>
+                    <a:lstStyle/>
+                    <a:p>
+                      <a:pPr eaLnBrk="0" latinLnBrk="0" algn="ctr" indent="0" marL="0">
+                        <a:buNone/>
+                      </a:pPr>
+                      <a:r>
+                        <a:rPr lang="en-US" sz="1200" b="1" dirty="0">
+                          <a:solidFill>
+                            <a:srgbClr val="000000"/>
+                          </a:solidFill>
+                          <a:latin typeface="맑은 고딕" pitchFamily="34" charset="0"/>
+                          <a:ea typeface="맑은 고딕" pitchFamily="34" charset="-122"/>
+                          <a:cs typeface="맑은 고딕" pitchFamily="34" charset="-120"/>
+                        </a:rPr>
+                        <a:t>2</a:t>
+                      </a:r>
+                      <a:endParaRPr lang="en-US" sz="1200" dirty="0">
+                        <a:latin typeface="맑은 고딕" charset="0"/>
+                        <a:ea typeface="맑은 고딕" charset="0"/>
+                        <a:cs typeface="맑은 고딕" charset="0"/>
+                      </a:endParaRPr>
+                    </a:p>
+                  </a:txBody>
+                  <a:tcPr marL="38100" marR="38100" marT="38100" marB="38100" anchor="ctr">
+                    <a:lnL w="12700" cap="flat" cmpd="sng" algn="ctr">
+                      <a:solidFill>
+                        <a:srgbClr val="000000"/>
+                      </a:solidFill>
+                      <a:prstDash val="solid"/>
+                      <a:round/>
+                      <a:headEnd type="none" w="med" len="med"/>
+                      <a:tailEnd type="none" w="med" len="med"/>
+                    </a:lnL>
+                    <a:lnR w="12700" cap="flat" cmpd="sng" algn="ctr">
+                      <a:solidFill>
+                        <a:srgbClr val="000000"/>
+                      </a:solidFill>
+                      <a:prstDash val="solid"/>
+                      <a:round/>
+                      <a:headEnd type="none" w="med" len="med"/>
+                      <a:tailEnd type="none" w="med" len="med"/>
+                    </a:lnR>
+                    <a:lnT w="12700" cap="flat" cmpd="sng" algn="ctr">
+                      <a:solidFill>
+                        <a:srgbClr val="000000"/>
+                      </a:solidFill>
+                      <a:prstDash val="solid"/>
+                      <a:round/>
+                      <a:headEnd type="none" w="med" len="med"/>
+                      <a:tailEnd type="none" w="med" len="med"/>
+                    </a:lnT>
+                    <a:lnB w="12700" cap="flat" cmpd="sng" algn="ctr">
+                      <a:solidFill>
+                        <a:srgbClr val="000000"/>
+                      </a:solidFill>
+                      <a:prstDash val="solid"/>
+                      <a:round/>
+                      <a:headEnd type="none" w="med" len="med"/>
+                      <a:tailEnd type="none" w="med" len="med"/>
+                    </a:lnB>
+                    <a:solidFill>
+                      <a:srgbClr val="D9F6FF"/>
+                    </a:solidFill>
+                  </a:tcPr>
+                </a:tc>
+                <a:tc>
+                  <a:txBody>
+                    <a:bodyPr/>
+                    <a:lstStyle/>
+                    <a:p>
+                      <a:pPr eaLnBrk="0" latinLnBrk="0" algn="l" indent="0" marL="0">
+                        <a:buNone/>
+                      </a:pPr>
+                      <a:r>
+                        <a:rPr lang="en-US" sz="1300" dirty="0">
+                          <a:solidFill>
+                            <a:srgbClr val="000000"/>
+                          </a:solidFill>
+                          <a:latin typeface="맑은 고딕" pitchFamily="34" charset="0"/>
+                          <a:ea typeface="맑은 고딕" pitchFamily="34" charset="-122"/>
+                          <a:cs typeface="맑은 고딕" pitchFamily="34" charset="-120"/>
+                        </a:rPr>
+                        <a:t>직원 현황</a:t>
+                      </a:r>
+                      <a:endParaRPr lang="en-US" sz="1300" dirty="0">
+                        <a:latin typeface="맑은 고딕" charset="0"/>
+                        <a:ea typeface="맑은 고딕" charset="0"/>
+                        <a:cs typeface="맑은 고딕" charset="0"/>
+                      </a:endParaRPr>
+                    </a:p>
+                  </a:txBody>
+                  <a:tcPr marL="38100" marR="38100" marT="38100" marB="38100" anchor="ctr">
+                    <a:lnL w="12700" cap="flat" cmpd="sng" algn="ctr">
+                      <a:solidFill>
+                        <a:srgbClr val="000000"/>
+                      </a:solidFill>
+                      <a:prstDash val="solid"/>
+                      <a:round/>
+                      <a:headEnd type="none" w="med" len="med"/>
+                      <a:tailEnd type="none" w="med" len="med"/>
+                    </a:lnL>
+                    <a:lnR w="12700" cap="flat" cmpd="sng" algn="ctr">
+                      <a:solidFill>
+                        <a:srgbClr val="000000"/>
+                      </a:solidFill>
+                      <a:prstDash val="solid"/>
+                      <a:round/>
+                      <a:headEnd type="none" w="med" len="med"/>
+                      <a:tailEnd type="none" w="med" len="med"/>
+                    </a:lnR>
+                    <a:lnT w="12700" cap="flat" cmpd="sng" algn="ctr">
+                      <a:solidFill>
+                        <a:srgbClr val="000000"/>
+                      </a:solidFill>
+                      <a:prstDash val="solid"/>
+                      <a:round/>
+                      <a:headEnd type="none" w="med" len="med"/>
+                      <a:tailEnd type="none" w="med" len="med"/>
+                    </a:lnT>
+                    <a:lnB w="12700" cap="flat" cmpd="sng" algn="ctr">
+                      <a:solidFill>
+                        <a:srgbClr val="000000"/>
+                      </a:solidFill>
+                      <a:prstDash val="solid"/>
+                      <a:round/>
+                      <a:headEnd type="none" w="med" len="med"/>
+                      <a:tailEnd type="none" w="med" len="med"/>
+                    </a:lnB>
+                  </a:tcPr>
+                </a:tc>
+                <a:tc>
+                  <a:txBody>
+                    <a:bodyPr/>
+                    <a:lstStyle/>
+                    <a:p>
+                      <a:pPr eaLnBrk="0" latinLnBrk="0" algn="ctr" indent="0" marL="0">
+                        <a:buNone/>
+                      </a:pPr>
+                      <a:endParaRPr lang="en-US" sz="1050" dirty="0">
+                        <a:latin typeface="맑은 고딕" charset="0"/>
+                        <a:ea typeface="맑은 고딕" charset="0"/>
+                        <a:cs typeface="맑은 고딕" charset="0"/>
+                      </a:endParaRPr>
+                    </a:p>
+                  </a:txBody>
+                  <a:tcPr marL="38100" marR="38100" marT="38100" marB="38100" anchor="ctr">
+                    <a:lnL w="12700" cap="flat" cmpd="sng" algn="ctr">
+                      <a:solidFill>
+                        <a:srgbClr val="000000"/>
+                      </a:solidFill>
+                      <a:prstDash val="solid"/>
+                      <a:round/>
+                      <a:headEnd type="none" w="med" len="med"/>
+                      <a:tailEnd type="none" w="med" len="med"/>
+                    </a:lnL>
+                    <a:lnR w="12700" cap="flat" cmpd="sng" algn="ctr">
+                      <a:solidFill>
+                        <a:srgbClr val="000000"/>
+                      </a:solidFill>
+                      <a:prstDash val="solid"/>
+                      <a:round/>
+                      <a:headEnd type="none" w="med" len="med"/>
+                      <a:tailEnd type="none" w="med" len="med"/>
+                    </a:lnR>
+                    <a:lnT w="12700" cap="flat" cmpd="sng" algn="ctr">
+                      <a:solidFill>
+                        <a:srgbClr val="000000"/>
+                      </a:solidFill>
+                      <a:prstDash val="solid"/>
+                      <a:round/>
+                      <a:headEnd type="none" w="med" len="med"/>
+                      <a:tailEnd type="none" w="med" len="med"/>
+                    </a:lnT>
+                    <a:lnB w="12700" cap="flat" cmpd="sng" algn="ctr">
+                      <a:solidFill>
+                        <a:srgbClr val="000000"/>
+                      </a:solidFill>
+                      <a:prstDash val="solid"/>
+                      <a:round/>
+                      <a:headEnd type="none" w="med" len="med"/>
+                      <a:tailEnd type="none" w="med" len="med"/>
+                    </a:lnB>
+                  </a:tcPr>
+                </a:tc>
+              </a:tr>
+              <a:tr h="402336">
+                <a:tc>
+                  <a:txBody>
+                    <a:bodyPr/>
+                    <a:lstStyle/>
+                    <a:p>
+                      <a:pPr eaLnBrk="0" latinLnBrk="0" algn="ctr" indent="0" marL="0">
+                        <a:buNone/>
+                      </a:pPr>
+                      <a:r>
+                        <a:rPr lang="en-US" sz="1200" b="1" dirty="0">
+                          <a:solidFill>
+                            <a:srgbClr val="000000"/>
+                          </a:solidFill>
+                          <a:latin typeface="맑은 고딕" pitchFamily="34" charset="0"/>
+                          <a:ea typeface="맑은 고딕" pitchFamily="34" charset="-122"/>
+                          <a:cs typeface="맑은 고딕" pitchFamily="34" charset="-120"/>
+                        </a:rPr>
+                        <a:t>3</a:t>
+                      </a:r>
+                      <a:endParaRPr lang="en-US" sz="1200" dirty="0">
+                        <a:latin typeface="맑은 고딕" charset="0"/>
+                        <a:ea typeface="맑은 고딕" charset="0"/>
+                        <a:cs typeface="맑은 고딕" charset="0"/>
+                      </a:endParaRPr>
+                    </a:p>
+                  </a:txBody>
+                  <a:tcPr marL="38100" marR="38100" marT="38100" marB="38100" anchor="ctr">
+                    <a:lnL w="12700" cap="flat" cmpd="sng" algn="ctr">
+                      <a:solidFill>
+                        <a:srgbClr val="000000"/>
+                      </a:solidFill>
+                      <a:prstDash val="solid"/>
+                      <a:round/>
+                      <a:headEnd type="none" w="med" len="med"/>
+                      <a:tailEnd type="none" w="med" len="med"/>
+                    </a:lnL>
+                    <a:lnR w="12700" cap="flat" cmpd="sng" algn="ctr">
+                      <a:solidFill>
+                        <a:srgbClr val="000000"/>
+                      </a:solidFill>
+                      <a:prstDash val="solid"/>
+                      <a:round/>
+                      <a:headEnd type="none" w="med" len="med"/>
+                      <a:tailEnd type="none" w="med" len="med"/>
+                    </a:lnR>
+                    <a:lnT w="12700" cap="flat" cmpd="sng" algn="ctr">
+                      <a:solidFill>
+                        <a:srgbClr val="000000"/>
+                      </a:solidFill>
+                      <a:prstDash val="solid"/>
+                      <a:round/>
+                      <a:headEnd type="none" w="med" len="med"/>
+                      <a:tailEnd type="none" w="med" len="med"/>
+                    </a:lnT>
+                    <a:lnB w="12700" cap="flat" cmpd="sng" algn="ctr">
+                      <a:solidFill>
+                        <a:srgbClr val="000000"/>
+                      </a:solidFill>
+                      <a:prstDash val="solid"/>
+                      <a:round/>
+                      <a:headEnd type="none" w="med" len="med"/>
+                      <a:tailEnd type="none" w="med" len="med"/>
+                    </a:lnB>
+                    <a:solidFill>
+                      <a:srgbClr val="D9F6FF"/>
+                    </a:solidFill>
+                  </a:tcPr>
+                </a:tc>
+                <a:tc>
+                  <a:txBody>
+                    <a:bodyPr/>
+                    <a:lstStyle/>
+                    <a:p>
+                      <a:pPr eaLnBrk="0" latinLnBrk="0" algn="l" indent="0" marL="0">
+                        <a:buNone/>
+                      </a:pPr>
+                      <a:r>
+                        <a:rPr lang="en-US" sz="1300" dirty="0">
+                          <a:solidFill>
+                            <a:srgbClr val="000000"/>
+                          </a:solidFill>
+                          <a:latin typeface="맑은 고딕" pitchFamily="34" charset="0"/>
+                          <a:ea typeface="맑은 고딕" pitchFamily="34" charset="-122"/>
+                          <a:cs typeface="맑은 고딕" pitchFamily="34" charset="-120"/>
+                        </a:rPr>
+                        <a:t>채용 계획</a:t>
+                      </a:r>
+                      <a:endParaRPr lang="en-US" sz="1300" dirty="0">
+                        <a:latin typeface="맑은 고딕" charset="0"/>
+                        <a:ea typeface="맑은 고딕" charset="0"/>
+                        <a:cs typeface="맑은 고딕" charset="0"/>
+                      </a:endParaRPr>
+                    </a:p>
+                  </a:txBody>
+                  <a:tcPr marL="38100" marR="38100" marT="38100" marB="38100" anchor="ctr">
+                    <a:lnL w="12700" cap="flat" cmpd="sng" algn="ctr">
+                      <a:solidFill>
+                        <a:srgbClr val="000000"/>
+                      </a:solidFill>
+                      <a:prstDash val="solid"/>
+                      <a:round/>
+                      <a:headEnd type="none" w="med" len="med"/>
+                      <a:tailEnd type="none" w="med" len="med"/>
+                    </a:lnL>
+                    <a:lnR w="12700" cap="flat" cmpd="sng" algn="ctr">
+                      <a:solidFill>
+                        <a:srgbClr val="000000"/>
+                      </a:solidFill>
+                      <a:prstDash val="solid"/>
+                      <a:round/>
+                      <a:headEnd type="none" w="med" len="med"/>
+                      <a:tailEnd type="none" w="med" len="med"/>
+                    </a:lnR>
+                    <a:lnT w="12700" cap="flat" cmpd="sng" algn="ctr">
+                      <a:solidFill>
+                        <a:srgbClr val="000000"/>
+                      </a:solidFill>
+                      <a:prstDash val="solid"/>
+                      <a:round/>
+                      <a:headEnd type="none" w="med" len="med"/>
+                      <a:tailEnd type="none" w="med" len="med"/>
+                    </a:lnT>
+                    <a:lnB w="12700" cap="flat" cmpd="sng" algn="ctr">
+                      <a:solidFill>
+                        <a:srgbClr val="000000"/>
+                      </a:solidFill>
+                      <a:prstDash val="solid"/>
+                      <a:round/>
+                      <a:headEnd type="none" w="med" len="med"/>
+                      <a:tailEnd type="none" w="med" len="med"/>
+                    </a:lnB>
+                  </a:tcPr>
+                </a:tc>
+                <a:tc>
+                  <a:txBody>
+                    <a:bodyPr/>
+                    <a:lstStyle/>
+                    <a:p>
+                      <a:pPr eaLnBrk="0" latinLnBrk="0" algn="ctr" indent="0" marL="0">
+                        <a:buNone/>
+                      </a:pPr>
+                      <a:endParaRPr lang="en-US" sz="1050" dirty="0">
+                        <a:latin typeface="맑은 고딕" charset="0"/>
+                        <a:ea typeface="맑은 고딕" charset="0"/>
+                        <a:cs typeface="맑은 고딕" charset="0"/>
+                      </a:endParaRPr>
+                    </a:p>
+                  </a:txBody>
+                  <a:tcPr marL="38100" marR="38100" marT="38100" marB="38100" anchor="ctr">
+                    <a:lnL w="12700" cap="flat" cmpd="sng" algn="ctr">
+                      <a:solidFill>
+                        <a:srgbClr val="000000"/>
+                      </a:solidFill>
+                      <a:prstDash val="solid"/>
+                      <a:round/>
+                      <a:headEnd type="none" w="med" len="med"/>
+                      <a:tailEnd type="none" w="med" len="med"/>
+                    </a:lnL>
+                    <a:lnR w="12700" cap="flat" cmpd="sng" algn="ctr">
+                      <a:solidFill>
+                        <a:srgbClr val="000000"/>
+                      </a:solidFill>
+                      <a:prstDash val="solid"/>
+                      <a:round/>
+                      <a:headEnd type="none" w="med" len="med"/>
+                      <a:tailEnd type="none" w="med" len="med"/>
+                    </a:lnR>
+                    <a:lnT w="12700" cap="flat" cmpd="sng" algn="ctr">
+                      <a:solidFill>
+                        <a:srgbClr val="000000"/>
+                      </a:solidFill>
+                      <a:prstDash val="solid"/>
+                      <a:round/>
+                      <a:headEnd type="none" w="med" len="med"/>
+                      <a:tailEnd type="none" w="med" len="med"/>
+                    </a:lnT>
+                    <a:lnB w="12700" cap="flat" cmpd="sng" algn="ctr">
+                      <a:solidFill>
+                        <a:srgbClr val="000000"/>
+                      </a:solidFill>
+                      <a:prstDash val="solid"/>
+                      <a:round/>
+                      <a:headEnd type="none" w="med" len="med"/>
+                      <a:tailEnd type="none" w="med" len="med"/>
+                    </a:lnB>
+                  </a:tcPr>
+                </a:tc>
+              </a:tr>
+              <a:tr h="402336">
+                <a:tc>
+                  <a:txBody>
+                    <a:bodyPr/>
+                    <a:lstStyle/>
+                    <a:p>
+                      <a:pPr eaLnBrk="0" latinLnBrk="0" algn="ctr" indent="0" marL="0">
+                        <a:buNone/>
+                      </a:pPr>
+                      <a:r>
+                        <a:rPr lang="en-US" sz="1200" b="1" dirty="0">
+                          <a:solidFill>
+                            <a:srgbClr val="000000"/>
+                          </a:solidFill>
+                          <a:latin typeface="맑은 고딕" pitchFamily="34" charset="0"/>
+                          <a:ea typeface="맑은 고딕" pitchFamily="34" charset="-122"/>
+                          <a:cs typeface="맑은 고딕" pitchFamily="34" charset="-120"/>
+                        </a:rPr>
+                        <a:t>4</a:t>
+                      </a:r>
+                      <a:endParaRPr lang="en-US" sz="1200" dirty="0">
+                        <a:latin typeface="맑은 고딕" charset="0"/>
+                        <a:ea typeface="맑은 고딕" charset="0"/>
+                        <a:cs typeface="맑은 고딕" charset="0"/>
+                      </a:endParaRPr>
+                    </a:p>
+                  </a:txBody>
+                  <a:tcPr marL="38100" marR="38100" marT="38100" marB="38100" anchor="ctr">
+                    <a:lnL w="12700" cap="flat" cmpd="sng" algn="ctr">
+                      <a:solidFill>
+                        <a:srgbClr val="000000"/>
+                      </a:solidFill>
+                      <a:prstDash val="solid"/>
+                      <a:round/>
+                      <a:headEnd type="none" w="med" len="med"/>
+                      <a:tailEnd type="none" w="med" len="med"/>
+                    </a:lnL>
+                    <a:lnR w="12700" cap="flat" cmpd="sng" algn="ctr">
+                      <a:solidFill>
+                        <a:srgbClr val="000000"/>
+                      </a:solidFill>
+                      <a:prstDash val="solid"/>
+                      <a:round/>
+                      <a:headEnd type="none" w="med" len="med"/>
+                      <a:tailEnd type="none" w="med" len="med"/>
+                    </a:lnR>
+                    <a:lnT w="12700" cap="flat" cmpd="sng" algn="ctr">
+                      <a:solidFill>
+                        <a:srgbClr val="000000"/>
+                      </a:solidFill>
+                      <a:prstDash val="solid"/>
+                      <a:round/>
+                      <a:headEnd type="none" w="med" len="med"/>
+                      <a:tailEnd type="none" w="med" len="med"/>
+                    </a:lnT>
+                    <a:lnB w="12700" cap="flat" cmpd="sng" algn="ctr">
+                      <a:solidFill>
+                        <a:srgbClr val="000000"/>
+                      </a:solidFill>
+                      <a:prstDash val="solid"/>
+                      <a:round/>
+                      <a:headEnd type="none" w="med" len="med"/>
+                      <a:tailEnd type="none" w="med" len="med"/>
+                    </a:lnB>
+                    <a:solidFill>
+                      <a:srgbClr val="D9F6FF"/>
+                    </a:solidFill>
+                  </a:tcPr>
+                </a:tc>
+                <a:tc>
+                  <a:txBody>
+                    <a:bodyPr/>
+                    <a:lstStyle/>
+                    <a:p>
+                      <a:pPr eaLnBrk="0" latinLnBrk="0" algn="l" indent="0" marL="0">
+                        <a:buNone/>
+                      </a:pPr>
+                      <a:r>
+                        <a:rPr lang="en-US" sz="1300" dirty="0">
+                          <a:solidFill>
+                            <a:srgbClr val="000000"/>
+                          </a:solidFill>
+                          <a:latin typeface="맑은 고딕" pitchFamily="34" charset="0"/>
+                          <a:ea typeface="맑은 고딕" pitchFamily="34" charset="-122"/>
+                          <a:cs typeface="맑은 고딕" pitchFamily="34" charset="-120"/>
+                        </a:rPr>
+                        <a:t>전형 절차</a:t>
+                      </a:r>
+                      <a:endParaRPr lang="en-US" sz="1300" dirty="0">
+                        <a:latin typeface="맑은 고딕" charset="0"/>
+                        <a:ea typeface="맑은 고딕" charset="0"/>
+                        <a:cs typeface="맑은 고딕" charset="0"/>
+                      </a:endParaRPr>
+                    </a:p>
+                  </a:txBody>
+                  <a:tcPr marL="38100" marR="38100" marT="38100" marB="38100" anchor="ctr">
+                    <a:lnL w="12700" cap="flat" cmpd="sng" algn="ctr">
+                      <a:solidFill>
+                        <a:srgbClr val="000000"/>
+                      </a:solidFill>
+                      <a:prstDash val="solid"/>
+                      <a:round/>
+                      <a:headEnd type="none" w="med" len="med"/>
+                      <a:tailEnd type="none" w="med" len="med"/>
+                    </a:lnL>
+                    <a:lnR w="12700" cap="flat" cmpd="sng" algn="ctr">
+                      <a:solidFill>
+                        <a:srgbClr val="000000"/>
+                      </a:solidFill>
+                      <a:prstDash val="solid"/>
+                      <a:round/>
+                      <a:headEnd type="none" w="med" len="med"/>
+                      <a:tailEnd type="none" w="med" len="med"/>
+                    </a:lnR>
+                    <a:lnT w="12700" cap="flat" cmpd="sng" algn="ctr">
+                      <a:solidFill>
+                        <a:srgbClr val="000000"/>
+                      </a:solidFill>
+                      <a:prstDash val="solid"/>
+                      <a:round/>
+                      <a:headEnd type="none" w="med" len="med"/>
+                      <a:tailEnd type="none" w="med" len="med"/>
+                    </a:lnT>
+                    <a:lnB w="12700" cap="flat" cmpd="sng" algn="ctr">
+                      <a:solidFill>
+                        <a:srgbClr val="000000"/>
+                      </a:solidFill>
+                      <a:prstDash val="solid"/>
+                      <a:round/>
+                      <a:headEnd type="none" w="med" len="med"/>
+                      <a:tailEnd type="none" w="med" len="med"/>
+                    </a:lnB>
+                  </a:tcPr>
+                </a:tc>
+                <a:tc>
+                  <a:txBody>
+                    <a:bodyPr/>
+                    <a:lstStyle/>
+                    <a:p>
+                      <a:pPr eaLnBrk="0" latinLnBrk="0" algn="ctr" indent="0" marL="0">
+                        <a:buNone/>
+                      </a:pPr>
+                      <a:endParaRPr lang="en-US" sz="1050" dirty="0">
+                        <a:latin typeface="맑은 고딕" charset="0"/>
+                        <a:ea typeface="맑은 고딕" charset="0"/>
+                        <a:cs typeface="맑은 고딕" charset="0"/>
+                      </a:endParaRPr>
+                    </a:p>
+                  </a:txBody>
+                  <a:tcPr marL="38100" marR="38100" marT="38100" marB="38100" anchor="ctr">
+                    <a:lnL w="12700" cap="flat" cmpd="sng" algn="ctr">
+                      <a:solidFill>
+                        <a:srgbClr val="000000"/>
+                      </a:solidFill>
+                      <a:prstDash val="solid"/>
+                      <a:round/>
+                      <a:headEnd type="none" w="med" len="med"/>
+                      <a:tailEnd type="none" w="med" len="med"/>
+                    </a:lnL>
+                    <a:lnR w="12700" cap="flat" cmpd="sng" algn="ctr">
+                      <a:solidFill>
+                        <a:srgbClr val="000000"/>
+                      </a:solidFill>
+                      <a:prstDash val="solid"/>
+                      <a:round/>
+                      <a:headEnd type="none" w="med" len="med"/>
+                      <a:tailEnd type="none" w="med" len="med"/>
+                    </a:lnR>
+                    <a:lnT w="12700" cap="flat" cmpd="sng" algn="ctr">
+                      <a:solidFill>
+                        <a:srgbClr val="000000"/>
+                      </a:solidFill>
+                      <a:prstDash val="solid"/>
+                      <a:round/>
+                      <a:headEnd type="none" w="med" len="med"/>
+                      <a:tailEnd type="none" w="med" len="med"/>
+                    </a:lnT>
+                    <a:lnB w="12700" cap="flat" cmpd="sng" algn="ctr">
+                      <a:solidFill>
+                        <a:srgbClr val="000000"/>
+                      </a:solidFill>
+                      <a:prstDash val="solid"/>
+                      <a:round/>
+                      <a:headEnd type="none" w="med" len="med"/>
+                      <a:tailEnd type="none" w="med" len="med"/>
+                    </a:lnB>
+                  </a:tcPr>
+                </a:tc>
+              </a:tr>
+              <a:tr h="402336">
+                <a:tc>
+                  <a:txBody>
+                    <a:bodyPr/>
+                    <a:lstStyle/>
+                    <a:p>
+                      <a:pPr eaLnBrk="0" latinLnBrk="0" algn="ctr" indent="0" marL="0">
+                        <a:buNone/>
+                      </a:pPr>
+                      <a:r>
+                        <a:rPr lang="en-US" sz="1200" b="1" dirty="0">
+                          <a:solidFill>
+                            <a:srgbClr val="000000"/>
+                          </a:solidFill>
+                          <a:latin typeface="맑은 고딕" pitchFamily="34" charset="0"/>
+                          <a:ea typeface="맑은 고딕" pitchFamily="34" charset="-122"/>
+                          <a:cs typeface="맑은 고딕" pitchFamily="34" charset="-120"/>
+                        </a:rPr>
+                        <a:t>5</a:t>
+                      </a:r>
+                      <a:endParaRPr lang="en-US" sz="1200" dirty="0">
+                        <a:latin typeface="맑은 고딕" charset="0"/>
+                        <a:ea typeface="맑은 고딕" charset="0"/>
+                        <a:cs typeface="맑은 고딕" charset="0"/>
+                      </a:endParaRPr>
+                    </a:p>
+                  </a:txBody>
+                  <a:tcPr marL="38100" marR="38100" marT="38100" marB="38100" anchor="ctr">
+                    <a:lnL w="12700" cap="flat" cmpd="sng" algn="ctr">
+                      <a:solidFill>
+                        <a:srgbClr val="000000"/>
+                      </a:solidFill>
+                      <a:prstDash val="solid"/>
+                      <a:round/>
+                      <a:headEnd type="none" w="med" len="med"/>
+                      <a:tailEnd type="none" w="med" len="med"/>
+                    </a:lnL>
+                    <a:lnR w="12700" cap="flat" cmpd="sng" algn="ctr">
+                      <a:solidFill>
+                        <a:srgbClr val="000000"/>
+                      </a:solidFill>
+                      <a:prstDash val="solid"/>
+                      <a:round/>
+                      <a:headEnd type="none" w="med" len="med"/>
+                      <a:tailEnd type="none" w="med" len="med"/>
+                    </a:lnR>
+                    <a:lnT w="12700" cap="flat" cmpd="sng" algn="ctr">
+                      <a:solidFill>
+                        <a:srgbClr val="000000"/>
+                      </a:solidFill>
+                      <a:prstDash val="solid"/>
+                      <a:round/>
+                      <a:headEnd type="none" w="med" len="med"/>
+                      <a:tailEnd type="none" w="med" len="med"/>
+                    </a:lnT>
+                    <a:lnB w="12700" cap="flat" cmpd="sng" algn="ctr">
+                      <a:solidFill>
+                        <a:srgbClr val="000000"/>
+                      </a:solidFill>
+                      <a:prstDash val="solid"/>
+                      <a:round/>
+                      <a:headEnd type="none" w="med" len="med"/>
+                      <a:tailEnd type="none" w="med" len="med"/>
+                    </a:lnB>
+                    <a:solidFill>
+                      <a:srgbClr val="D9F6FF"/>
+                    </a:solidFill>
+                  </a:tcPr>
+                </a:tc>
+                <a:tc>
+                  <a:txBody>
+                    <a:bodyPr/>
+                    <a:lstStyle/>
+                    <a:p>
+                      <a:pPr eaLnBrk="0" latinLnBrk="0" algn="l" indent="0" marL="0">
+                        <a:buNone/>
+                      </a:pPr>
+                      <a:r>
+                        <a:rPr lang="en-US" sz="1300" dirty="0">
+                          <a:solidFill>
+                            <a:srgbClr val="000000"/>
+                          </a:solidFill>
+                          <a:latin typeface="맑은 고딕" pitchFamily="34" charset="0"/>
+                          <a:ea typeface="맑은 고딕" pitchFamily="34" charset="-122"/>
+                          <a:cs typeface="맑은 고딕" pitchFamily="34" charset="-120"/>
+                        </a:rPr>
+                        <a:t>지원서 접수</a:t>
+                      </a:r>
+                      <a:endParaRPr lang="en-US" sz="1300" dirty="0">
+                        <a:latin typeface="맑은 고딕" charset="0"/>
+                        <a:ea typeface="맑은 고딕" charset="0"/>
+                        <a:cs typeface="맑은 고딕" charset="0"/>
+                      </a:endParaRPr>
+                    </a:p>
+                  </a:txBody>
+                  <a:tcPr marL="38100" marR="38100" marT="38100" marB="38100" anchor="ctr">
+                    <a:lnL w="12700" cap="flat" cmpd="sng" algn="ctr">
+                      <a:solidFill>
+                        <a:srgbClr val="000000"/>
+                      </a:solidFill>
+                      <a:prstDash val="solid"/>
+                      <a:round/>
+                      <a:headEnd type="none" w="med" len="med"/>
+                      <a:tailEnd type="none" w="med" len="med"/>
+                    </a:lnL>
+                    <a:lnR w="12700" cap="flat" cmpd="sng" algn="ctr">
+                      <a:solidFill>
+                        <a:srgbClr val="000000"/>
+                      </a:solidFill>
+                      <a:prstDash val="solid"/>
+                      <a:round/>
+                      <a:headEnd type="none" w="med" len="med"/>
+                      <a:tailEnd type="none" w="med" len="med"/>
+                    </a:lnR>
+                    <a:lnT w="12700" cap="flat" cmpd="sng" algn="ctr">
+                      <a:solidFill>
+                        <a:srgbClr val="000000"/>
+                      </a:solidFill>
+                      <a:prstDash val="solid"/>
+                      <a:round/>
+                      <a:headEnd type="none" w="med" len="med"/>
+                      <a:tailEnd type="none" w="med" len="med"/>
+                    </a:lnT>
+                    <a:lnB w="12700" cap="flat" cmpd="sng" algn="ctr">
+                      <a:solidFill>
+                        <a:srgbClr val="000000"/>
+                      </a:solidFill>
+                      <a:prstDash val="solid"/>
+                      <a:round/>
+                      <a:headEnd type="none" w="med" len="med"/>
+                      <a:tailEnd type="none" w="med" len="med"/>
+                    </a:lnB>
+                    <a:solidFill>
+                      <a:srgbClr val="EFF9FC"/>
+                    </a:solidFill>
+                  </a:tcPr>
+                </a:tc>
+                <a:tc>
+                  <a:txBody>
+                    <a:bodyPr/>
+                    <a:lstStyle/>
+                    <a:p>
+                      <a:pPr eaLnBrk="0" latinLnBrk="0" algn="ctr" indent="0" marL="0">
+                        <a:buNone/>
+                      </a:pPr>
+                      <a:r>
+                        <a:rPr lang="en-US" sz="1050" dirty="0">
+                          <a:solidFill>
+                            <a:srgbClr val="404040"/>
+                          </a:solidFill>
+                          <a:latin typeface="맑은 고딕" pitchFamily="34" charset="0"/>
+                          <a:ea typeface="맑은 고딕" pitchFamily="34" charset="-122"/>
+                          <a:cs typeface="맑은 고딕" pitchFamily="34" charset="-120"/>
+                        </a:rPr>
+                        <a:t>전형 1단계</a:t>
+                      </a:r>
+                      <a:endParaRPr lang="en-US" sz="1050" dirty="0">
+                        <a:latin typeface="맑은 고딕" charset="0"/>
+                        <a:ea typeface="맑은 고딕" charset="0"/>
+                        <a:cs typeface="맑은 고딕" charset="0"/>
+                      </a:endParaRPr>
+                    </a:p>
+                  </a:txBody>
+                  <a:tcPr marL="38100" marR="38100" marT="38100" marB="38100" anchor="ctr">
+                    <a:lnL w="12700" cap="flat" cmpd="sng" algn="ctr">
+                      <a:solidFill>
+                        <a:srgbClr val="000000"/>
+                      </a:solidFill>
+                      <a:prstDash val="solid"/>
+                      <a:round/>
+                      <a:headEnd type="none" w="med" len="med"/>
+                      <a:tailEnd type="none" w="med" len="med"/>
+                    </a:lnL>
+                    <a:lnR w="12700" cap="flat" cmpd="sng" algn="ctr">
+                      <a:solidFill>
+                        <a:srgbClr val="000000"/>
+                      </a:solidFill>
+                      <a:prstDash val="solid"/>
+                      <a:round/>
+                      <a:headEnd type="none" w="med" len="med"/>
+                      <a:tailEnd type="none" w="med" len="med"/>
+                    </a:lnR>
+                    <a:lnT w="12700" cap="flat" cmpd="sng" algn="ctr">
+                      <a:solidFill>
+                        <a:srgbClr val="000000"/>
+                      </a:solidFill>
+                      <a:prstDash val="solid"/>
+                      <a:round/>
+                      <a:headEnd type="none" w="med" len="med"/>
+                      <a:tailEnd type="none" w="med" len="med"/>
+                    </a:lnT>
+                    <a:lnB w="12700" cap="flat" cmpd="sng" algn="ctr">
+                      <a:solidFill>
+                        <a:srgbClr val="000000"/>
+                      </a:solidFill>
+                      <a:prstDash val="solid"/>
+                      <a:round/>
+                      <a:headEnd type="none" w="med" len="med"/>
+                      <a:tailEnd type="none" w="med" len="med"/>
+                    </a:lnB>
+                    <a:solidFill>
+                      <a:srgbClr val="EFF9FC"/>
+                    </a:solidFill>
+                  </a:tcPr>
+                </a:tc>
+              </a:tr>
+              <a:tr h="402336">
+                <a:tc>
+                  <a:txBody>
+                    <a:bodyPr/>
+                    <a:lstStyle/>
+                    <a:p>
+                      <a:pPr eaLnBrk="0" latinLnBrk="0" algn="ctr" indent="0" marL="0">
+                        <a:buNone/>
+                      </a:pPr>
+                      <a:r>
+                        <a:rPr lang="en-US" sz="1200" b="1" dirty="0">
+                          <a:solidFill>
+                            <a:srgbClr val="000000"/>
+                          </a:solidFill>
+                          <a:latin typeface="맑은 고딕" pitchFamily="34" charset="0"/>
+                          <a:ea typeface="맑은 고딕" pitchFamily="34" charset="-122"/>
+                          <a:cs typeface="맑은 고딕" pitchFamily="34" charset="-120"/>
+                        </a:rPr>
+                        <a:t>6</a:t>
+                      </a:r>
+                      <a:endParaRPr lang="en-US" sz="1200" dirty="0">
+                        <a:latin typeface="맑은 고딕" charset="0"/>
+                        <a:ea typeface="맑은 고딕" charset="0"/>
+                        <a:cs typeface="맑은 고딕" charset="0"/>
+                      </a:endParaRPr>
+                    </a:p>
+                  </a:txBody>
+                  <a:tcPr marL="38100" marR="38100" marT="38100" marB="38100" anchor="ctr">
+                    <a:lnL w="12700" cap="flat" cmpd="sng" algn="ctr">
+                      <a:solidFill>
+                        <a:srgbClr val="000000"/>
+                      </a:solidFill>
+                      <a:prstDash val="solid"/>
+                      <a:round/>
+                      <a:headEnd type="none" w="med" len="med"/>
+                      <a:tailEnd type="none" w="med" len="med"/>
+                    </a:lnL>
+                    <a:lnR w="12700" cap="flat" cmpd="sng" algn="ctr">
+                      <a:solidFill>
+                        <a:srgbClr val="000000"/>
+                      </a:solidFill>
+                      <a:prstDash val="solid"/>
+                      <a:round/>
+                      <a:headEnd type="none" w="med" len="med"/>
+                      <a:tailEnd type="none" w="med" len="med"/>
+                    </a:lnR>
+                    <a:lnT w="12700" cap="flat" cmpd="sng" algn="ctr">
+                      <a:solidFill>
+                        <a:srgbClr val="000000"/>
+                      </a:solidFill>
+                      <a:prstDash val="solid"/>
+                      <a:round/>
+                      <a:headEnd type="none" w="med" len="med"/>
+                      <a:tailEnd type="none" w="med" len="med"/>
+                    </a:lnT>
+                    <a:lnB w="12700" cap="flat" cmpd="sng" algn="ctr">
+                      <a:solidFill>
+                        <a:srgbClr val="000000"/>
+                      </a:solidFill>
+                      <a:prstDash val="solid"/>
+                      <a:round/>
+                      <a:headEnd type="none" w="med" len="med"/>
+                      <a:tailEnd type="none" w="med" len="med"/>
+                    </a:lnB>
+                    <a:solidFill>
+                      <a:srgbClr val="D9F6FF"/>
+                    </a:solidFill>
+                  </a:tcPr>
+                </a:tc>
+                <a:tc>
+                  <a:txBody>
+                    <a:bodyPr/>
+                    <a:lstStyle/>
+                    <a:p>
+                      <a:pPr eaLnBrk="0" latinLnBrk="0" algn="l" indent="0" marL="0">
+                        <a:buNone/>
+                      </a:pPr>
+                      <a:r>
+                        <a:rPr lang="en-US" sz="1300" dirty="0">
+                          <a:solidFill>
+                            <a:srgbClr val="000000"/>
+                          </a:solidFill>
+                          <a:latin typeface="맑은 고딕" pitchFamily="34" charset="0"/>
+                          <a:ea typeface="맑은 고딕" pitchFamily="34" charset="-122"/>
+                          <a:cs typeface="맑은 고딕" pitchFamily="34" charset="-120"/>
+                        </a:rPr>
+                        <a:t>서류 전형 (1차)</a:t>
+                      </a:r>
+                      <a:endParaRPr lang="en-US" sz="1300" dirty="0">
+                        <a:latin typeface="맑은 고딕" charset="0"/>
+                        <a:ea typeface="맑은 고딕" charset="0"/>
+                        <a:cs typeface="맑은 고딕" charset="0"/>
+                      </a:endParaRPr>
+                    </a:p>
+                  </a:txBody>
+                  <a:tcPr marL="38100" marR="38100" marT="38100" marB="38100" anchor="ctr">
+                    <a:lnL w="12700" cap="flat" cmpd="sng" algn="ctr">
+                      <a:solidFill>
+                        <a:srgbClr val="000000"/>
+                      </a:solidFill>
+                      <a:prstDash val="solid"/>
+                      <a:round/>
+                      <a:headEnd type="none" w="med" len="med"/>
+                      <a:tailEnd type="none" w="med" len="med"/>
+                    </a:lnL>
+                    <a:lnR w="12700" cap="flat" cmpd="sng" algn="ctr">
+                      <a:solidFill>
+                        <a:srgbClr val="000000"/>
+                      </a:solidFill>
+                      <a:prstDash val="solid"/>
+                      <a:round/>
+                      <a:headEnd type="none" w="med" len="med"/>
+                      <a:tailEnd type="none" w="med" len="med"/>
+                    </a:lnR>
+                    <a:lnT w="12700" cap="flat" cmpd="sng" algn="ctr">
+                      <a:solidFill>
+                        <a:srgbClr val="000000"/>
+                      </a:solidFill>
+                      <a:prstDash val="solid"/>
+                      <a:round/>
+                      <a:headEnd type="none" w="med" len="med"/>
+                      <a:tailEnd type="none" w="med" len="med"/>
+                    </a:lnT>
+                    <a:lnB w="12700" cap="flat" cmpd="sng" algn="ctr">
+                      <a:solidFill>
+                        <a:srgbClr val="000000"/>
+                      </a:solidFill>
+                      <a:prstDash val="solid"/>
+                      <a:round/>
+                      <a:headEnd type="none" w="med" len="med"/>
+                      <a:tailEnd type="none" w="med" len="med"/>
+                    </a:lnB>
+                    <a:solidFill>
+                      <a:srgbClr val="EFF9FC"/>
+                    </a:solidFill>
+                  </a:tcPr>
+                </a:tc>
+                <a:tc>
+                  <a:txBody>
+                    <a:bodyPr/>
+                    <a:lstStyle/>
+                    <a:p>
+                      <a:pPr eaLnBrk="0" latinLnBrk="0" algn="ctr" indent="0" marL="0">
+                        <a:buNone/>
+                      </a:pPr>
+                      <a:r>
+                        <a:rPr lang="en-US" sz="1050" dirty="0">
+                          <a:solidFill>
+                            <a:srgbClr val="404040"/>
+                          </a:solidFill>
+                          <a:latin typeface="맑은 고딕" pitchFamily="34" charset="0"/>
+                          <a:ea typeface="맑은 고딕" pitchFamily="34" charset="-122"/>
+                          <a:cs typeface="맑은 고딕" pitchFamily="34" charset="-120"/>
+                        </a:rPr>
+                        <a:t>전형 2단계</a:t>
+                      </a:r>
+                      <a:endParaRPr lang="en-US" sz="1050" dirty="0">
+                        <a:latin typeface="맑은 고딕" charset="0"/>
+                        <a:ea typeface="맑은 고딕" charset="0"/>
+                        <a:cs typeface="맑은 고딕" charset="0"/>
+                      </a:endParaRPr>
+                    </a:p>
+                  </a:txBody>
+                  <a:tcPr marL="38100" marR="38100" marT="38100" marB="38100" anchor="ctr">
+                    <a:lnL w="12700" cap="flat" cmpd="sng" algn="ctr">
+                      <a:solidFill>
+                        <a:srgbClr val="000000"/>
+                      </a:solidFill>
+                      <a:prstDash val="solid"/>
+                      <a:round/>
+                      <a:headEnd type="none" w="med" len="med"/>
+                      <a:tailEnd type="none" w="med" len="med"/>
+                    </a:lnL>
+                    <a:lnR w="12700" cap="flat" cmpd="sng" algn="ctr">
+                      <a:solidFill>
+                        <a:srgbClr val="000000"/>
+                      </a:solidFill>
+                      <a:prstDash val="solid"/>
+                      <a:round/>
+                      <a:headEnd type="none" w="med" len="med"/>
+                      <a:tailEnd type="none" w="med" len="med"/>
+                    </a:lnR>
+                    <a:lnT w="12700" cap="flat" cmpd="sng" algn="ctr">
+                      <a:solidFill>
+                        <a:srgbClr val="000000"/>
+                      </a:solidFill>
+                      <a:prstDash val="solid"/>
+                      <a:round/>
+                      <a:headEnd type="none" w="med" len="med"/>
+                      <a:tailEnd type="none" w="med" len="med"/>
+                    </a:lnT>
+                    <a:lnB w="12700" cap="flat" cmpd="sng" algn="ctr">
+                      <a:solidFill>
+                        <a:srgbClr val="000000"/>
+                      </a:solidFill>
+                      <a:prstDash val="solid"/>
+                      <a:round/>
+                      <a:headEnd type="none" w="med" len="med"/>
+                      <a:tailEnd type="none" w="med" len="med"/>
+                    </a:lnB>
+                    <a:solidFill>
+                      <a:srgbClr val="EFF9FC"/>
+                    </a:solidFill>
+                  </a:tcPr>
+                </a:tc>
+              </a:tr>
+              <a:tr h="402336">
+                <a:tc>
+                  <a:txBody>
+                    <a:bodyPr/>
+                    <a:lstStyle/>
+                    <a:p>
+                      <a:pPr eaLnBrk="0" latinLnBrk="0" algn="ctr" indent="0" marL="0">
+                        <a:buNone/>
+                      </a:pPr>
+                      <a:r>
+                        <a:rPr lang="en-US" sz="1200" b="1" dirty="0">
+                          <a:solidFill>
+                            <a:srgbClr val="000000"/>
+                          </a:solidFill>
+                          <a:latin typeface="맑은 고딕" pitchFamily="34" charset="0"/>
+                          <a:ea typeface="맑은 고딕" pitchFamily="34" charset="-122"/>
+                          <a:cs typeface="맑은 고딕" pitchFamily="34" charset="-120"/>
+                        </a:rPr>
+                        <a:t>7</a:t>
+                      </a:r>
+                      <a:endParaRPr lang="en-US" sz="1200" dirty="0">
+                        <a:latin typeface="맑은 고딕" charset="0"/>
+                        <a:ea typeface="맑은 고딕" charset="0"/>
+                        <a:cs typeface="맑은 고딕" charset="0"/>
+                      </a:endParaRPr>
+                    </a:p>
+                  </a:txBody>
+                  <a:tcPr marL="38100" marR="38100" marT="38100" marB="38100" anchor="ctr">
+                    <a:lnL w="12700" cap="flat" cmpd="sng" algn="ctr">
+                      <a:solidFill>
+                        <a:srgbClr val="000000"/>
+                      </a:solidFill>
+                      <a:prstDash val="solid"/>
+                      <a:round/>
+                      <a:headEnd type="none" w="med" len="med"/>
+                      <a:tailEnd type="none" w="med" len="med"/>
+                    </a:lnL>
+                    <a:lnR w="12700" cap="flat" cmpd="sng" algn="ctr">
+                      <a:solidFill>
+                        <a:srgbClr val="000000"/>
+                      </a:solidFill>
+                      <a:prstDash val="solid"/>
+                      <a:round/>
+                      <a:headEnd type="none" w="med" len="med"/>
+                      <a:tailEnd type="none" w="med" len="med"/>
+                    </a:lnR>
+                    <a:lnT w="12700" cap="flat" cmpd="sng" algn="ctr">
+                      <a:solidFill>
+                        <a:srgbClr val="000000"/>
+                      </a:solidFill>
+                      <a:prstDash val="solid"/>
+                      <a:round/>
+                      <a:headEnd type="none" w="med" len="med"/>
+                      <a:tailEnd type="none" w="med" len="med"/>
+                    </a:lnT>
+                    <a:lnB w="12700" cap="flat" cmpd="sng" algn="ctr">
+                      <a:solidFill>
+                        <a:srgbClr val="000000"/>
+                      </a:solidFill>
+                      <a:prstDash val="solid"/>
+                      <a:round/>
+                      <a:headEnd type="none" w="med" len="med"/>
+                      <a:tailEnd type="none" w="med" len="med"/>
+                    </a:lnB>
+                    <a:solidFill>
+                      <a:srgbClr val="D9F6FF"/>
+                    </a:solidFill>
+                  </a:tcPr>
+                </a:tc>
+                <a:tc>
+                  <a:txBody>
+                    <a:bodyPr/>
+                    <a:lstStyle/>
+                    <a:p>
+                      <a:pPr eaLnBrk="0" latinLnBrk="0" algn="l" indent="0" marL="0">
+                        <a:buNone/>
+                      </a:pPr>
+                      <a:r>
+                        <a:rPr lang="en-US" sz="1300" dirty="0">
+                          <a:solidFill>
+                            <a:srgbClr val="000000"/>
+                          </a:solidFill>
+                          <a:latin typeface="맑은 고딕" pitchFamily="34" charset="0"/>
+                          <a:ea typeface="맑은 고딕" pitchFamily="34" charset="-122"/>
+                          <a:cs typeface="맑은 고딕" pitchFamily="34" charset="-120"/>
+                        </a:rPr>
+                        <a:t>업무적성 및 심층면접 (2차)</a:t>
+                      </a:r>
+                      <a:endParaRPr lang="en-US" sz="1300" dirty="0">
+                        <a:latin typeface="맑은 고딕" charset="0"/>
+                        <a:ea typeface="맑은 고딕" charset="0"/>
+                        <a:cs typeface="맑은 고딕" charset="0"/>
+                      </a:endParaRPr>
+                    </a:p>
+                  </a:txBody>
+                  <a:tcPr marL="38100" marR="38100" marT="38100" marB="38100" anchor="ctr">
+                    <a:lnL w="12700" cap="flat" cmpd="sng" algn="ctr">
+                      <a:solidFill>
+                        <a:srgbClr val="000000"/>
+                      </a:solidFill>
+                      <a:prstDash val="solid"/>
+                      <a:round/>
+                      <a:headEnd type="none" w="med" len="med"/>
+                      <a:tailEnd type="none" w="med" len="med"/>
+                    </a:lnL>
+                    <a:lnR w="12700" cap="flat" cmpd="sng" algn="ctr">
+                      <a:solidFill>
+                        <a:srgbClr val="000000"/>
+                      </a:solidFill>
+                      <a:prstDash val="solid"/>
+                      <a:round/>
+                      <a:headEnd type="none" w="med" len="med"/>
+                      <a:tailEnd type="none" w="med" len="med"/>
+                    </a:lnR>
+                    <a:lnT w="12700" cap="flat" cmpd="sng" algn="ctr">
+                      <a:solidFill>
+                        <a:srgbClr val="000000"/>
+                      </a:solidFill>
+                      <a:prstDash val="solid"/>
+                      <a:round/>
+                      <a:headEnd type="none" w="med" len="med"/>
+                      <a:tailEnd type="none" w="med" len="med"/>
+                    </a:lnT>
+                    <a:lnB w="12700" cap="flat" cmpd="sng" algn="ctr">
+                      <a:solidFill>
+                        <a:srgbClr val="000000"/>
+                      </a:solidFill>
+                      <a:prstDash val="solid"/>
+                      <a:round/>
+                      <a:headEnd type="none" w="med" len="med"/>
+                      <a:tailEnd type="none" w="med" len="med"/>
+                    </a:lnB>
+                    <a:solidFill>
+                      <a:srgbClr val="EFF9FC"/>
+                    </a:solidFill>
+                  </a:tcPr>
+                </a:tc>
+                <a:tc>
+                  <a:txBody>
+                    <a:bodyPr/>
+                    <a:lstStyle/>
+                    <a:p>
+                      <a:pPr eaLnBrk="0" latinLnBrk="0" algn="ctr" indent="0" marL="0">
+                        <a:buNone/>
+                      </a:pPr>
+                      <a:r>
+                        <a:rPr lang="en-US" sz="1050" dirty="0">
+                          <a:solidFill>
+                            <a:srgbClr val="404040"/>
+                          </a:solidFill>
+                          <a:latin typeface="맑은 고딕" pitchFamily="34" charset="0"/>
+                          <a:ea typeface="맑은 고딕" pitchFamily="34" charset="-122"/>
+                          <a:cs typeface="맑은 고딕" pitchFamily="34" charset="-120"/>
+                        </a:rPr>
+                        <a:t>전형 3단계</a:t>
+                      </a:r>
+                      <a:endParaRPr lang="en-US" sz="1050" dirty="0">
+                        <a:latin typeface="맑은 고딕" charset="0"/>
+                        <a:ea typeface="맑은 고딕" charset="0"/>
+                        <a:cs typeface="맑은 고딕" charset="0"/>
+                      </a:endParaRPr>
+                    </a:p>
+                  </a:txBody>
+                  <a:tcPr marL="38100" marR="38100" marT="38100" marB="38100" anchor="ctr">
+                    <a:lnL w="12700" cap="flat" cmpd="sng" algn="ctr">
+                      <a:solidFill>
+                        <a:srgbClr val="000000"/>
+                      </a:solidFill>
+                      <a:prstDash val="solid"/>
+                      <a:round/>
+                      <a:headEnd type="none" w="med" len="med"/>
+                      <a:tailEnd type="none" w="med" len="med"/>
+                    </a:lnL>
+                    <a:lnR w="12700" cap="flat" cmpd="sng" algn="ctr">
+                      <a:solidFill>
+                        <a:srgbClr val="000000"/>
+                      </a:solidFill>
+                      <a:prstDash val="solid"/>
+                      <a:round/>
+                      <a:headEnd type="none" w="med" len="med"/>
+                      <a:tailEnd type="none" w="med" len="med"/>
+                    </a:lnR>
+                    <a:lnT w="12700" cap="flat" cmpd="sng" algn="ctr">
+                      <a:solidFill>
+                        <a:srgbClr val="000000"/>
+                      </a:solidFill>
+                      <a:prstDash val="solid"/>
+                      <a:round/>
+                      <a:headEnd type="none" w="med" len="med"/>
+                      <a:tailEnd type="none" w="med" len="med"/>
+                    </a:lnT>
+                    <a:lnB w="12700" cap="flat" cmpd="sng" algn="ctr">
+                      <a:solidFill>
+                        <a:srgbClr val="000000"/>
+                      </a:solidFill>
+                      <a:prstDash val="solid"/>
+                      <a:round/>
+                      <a:headEnd type="none" w="med" len="med"/>
+                      <a:tailEnd type="none" w="med" len="med"/>
+                    </a:lnB>
+                    <a:solidFill>
+                      <a:srgbClr val="EFF9FC"/>
+                    </a:solidFill>
+                  </a:tcPr>
+                </a:tc>
+              </a:tr>
+              <a:tr h="402336">
+                <a:tc>
+                  <a:txBody>
+                    <a:bodyPr/>
+                    <a:lstStyle/>
+                    <a:p>
+                      <a:pPr eaLnBrk="0" latinLnBrk="0" algn="ctr" indent="0" marL="0">
+                        <a:buNone/>
+                      </a:pPr>
+                      <a:r>
+                        <a:rPr lang="en-US" sz="1200" b="1" dirty="0">
+                          <a:solidFill>
+                            <a:srgbClr val="000000"/>
+                          </a:solidFill>
+                          <a:latin typeface="맑은 고딕" pitchFamily="34" charset="0"/>
+                          <a:ea typeface="맑은 고딕" pitchFamily="34" charset="-122"/>
+                          <a:cs typeface="맑은 고딕" pitchFamily="34" charset="-120"/>
+                        </a:rPr>
+                        <a:t>8</a:t>
+                      </a:r>
+                      <a:endParaRPr lang="en-US" sz="1200" dirty="0">
+                        <a:latin typeface="맑은 고딕" charset="0"/>
+                        <a:ea typeface="맑은 고딕" charset="0"/>
+                        <a:cs typeface="맑은 고딕" charset="0"/>
+                      </a:endParaRPr>
+                    </a:p>
+                  </a:txBody>
+                  <a:tcPr marL="38100" marR="38100" marT="38100" marB="38100" anchor="ctr">
+                    <a:lnL w="12700" cap="flat" cmpd="sng" algn="ctr">
+                      <a:solidFill>
+                        <a:srgbClr val="000000"/>
+                      </a:solidFill>
+                      <a:prstDash val="solid"/>
+                      <a:round/>
+                      <a:headEnd type="none" w="med" len="med"/>
+                      <a:tailEnd type="none" w="med" len="med"/>
+                    </a:lnL>
+                    <a:lnR w="12700" cap="flat" cmpd="sng" algn="ctr">
+                      <a:solidFill>
+                        <a:srgbClr val="000000"/>
+                      </a:solidFill>
+                      <a:prstDash val="solid"/>
+                      <a:round/>
+                      <a:headEnd type="none" w="med" len="med"/>
+                      <a:tailEnd type="none" w="med" len="med"/>
+                    </a:lnR>
+                    <a:lnT w="12700" cap="flat" cmpd="sng" algn="ctr">
+                      <a:solidFill>
+                        <a:srgbClr val="000000"/>
+                      </a:solidFill>
+                      <a:prstDash val="solid"/>
+                      <a:round/>
+                      <a:headEnd type="none" w="med" len="med"/>
+                      <a:tailEnd type="none" w="med" len="med"/>
+                    </a:lnT>
+                    <a:lnB w="12700" cap="flat" cmpd="sng" algn="ctr">
+                      <a:solidFill>
+                        <a:srgbClr val="000000"/>
+                      </a:solidFill>
+                      <a:prstDash val="solid"/>
+                      <a:round/>
+                      <a:headEnd type="none" w="med" len="med"/>
+                      <a:tailEnd type="none" w="med" len="med"/>
+                    </a:lnB>
+                    <a:solidFill>
+                      <a:srgbClr val="D9F6FF"/>
+                    </a:solidFill>
+                  </a:tcPr>
+                </a:tc>
+                <a:tc>
+                  <a:txBody>
+                    <a:bodyPr/>
+                    <a:lstStyle/>
+                    <a:p>
+                      <a:pPr eaLnBrk="0" latinLnBrk="0" algn="l" indent="0" marL="0">
+                        <a:buNone/>
+                      </a:pPr>
+                      <a:r>
+                        <a:rPr lang="en-US" sz="1300" dirty="0">
+                          <a:solidFill>
+                            <a:srgbClr val="000000"/>
+                          </a:solidFill>
+                          <a:latin typeface="맑은 고딕" pitchFamily="34" charset="0"/>
+                          <a:ea typeface="맑은 고딕" pitchFamily="34" charset="-122"/>
+                          <a:cs typeface="맑은 고딕" pitchFamily="34" charset="-120"/>
+                        </a:rPr>
+                        <a:t>결격사유 검증</a:t>
+                      </a:r>
+                      <a:endParaRPr lang="en-US" sz="1300" dirty="0">
+                        <a:latin typeface="맑은 고딕" charset="0"/>
+                        <a:ea typeface="맑은 고딕" charset="0"/>
+                        <a:cs typeface="맑은 고딕" charset="0"/>
+                      </a:endParaRPr>
+                    </a:p>
+                  </a:txBody>
+                  <a:tcPr marL="38100" marR="38100" marT="38100" marB="38100" anchor="ctr">
+                    <a:lnL w="12700" cap="flat" cmpd="sng" algn="ctr">
+                      <a:solidFill>
+                        <a:srgbClr val="000000"/>
+                      </a:solidFill>
+                      <a:prstDash val="solid"/>
+                      <a:round/>
+                      <a:headEnd type="none" w="med" len="med"/>
+                      <a:tailEnd type="none" w="med" len="med"/>
+                    </a:lnL>
+                    <a:lnR w="12700" cap="flat" cmpd="sng" algn="ctr">
+                      <a:solidFill>
+                        <a:srgbClr val="000000"/>
+                      </a:solidFill>
+                      <a:prstDash val="solid"/>
+                      <a:round/>
+                      <a:headEnd type="none" w="med" len="med"/>
+                      <a:tailEnd type="none" w="med" len="med"/>
+                    </a:lnR>
+                    <a:lnT w="12700" cap="flat" cmpd="sng" algn="ctr">
+                      <a:solidFill>
+                        <a:srgbClr val="000000"/>
+                      </a:solidFill>
+                      <a:prstDash val="solid"/>
+                      <a:round/>
+                      <a:headEnd type="none" w="med" len="med"/>
+                      <a:tailEnd type="none" w="med" len="med"/>
+                    </a:lnT>
+                    <a:lnB w="12700" cap="flat" cmpd="sng" algn="ctr">
+                      <a:solidFill>
+                        <a:srgbClr val="000000"/>
+                      </a:solidFill>
+                      <a:prstDash val="solid"/>
+                      <a:round/>
+                      <a:headEnd type="none" w="med" len="med"/>
+                      <a:tailEnd type="none" w="med" len="med"/>
+                    </a:lnB>
+                    <a:solidFill>
+                      <a:srgbClr val="EFF9FC"/>
+                    </a:solidFill>
+                  </a:tcPr>
+                </a:tc>
+                <a:tc>
+                  <a:txBody>
+                    <a:bodyPr/>
+                    <a:lstStyle/>
+                    <a:p>
+                      <a:pPr eaLnBrk="0" latinLnBrk="0" algn="ctr" indent="0" marL="0">
+                        <a:buNone/>
+                      </a:pPr>
+                      <a:r>
+                        <a:rPr lang="en-US" sz="1050" dirty="0">
+                          <a:solidFill>
+                            <a:srgbClr val="404040"/>
+                          </a:solidFill>
+                          <a:latin typeface="맑은 고딕" pitchFamily="34" charset="0"/>
+                          <a:ea typeface="맑은 고딕" pitchFamily="34" charset="-122"/>
+                          <a:cs typeface="맑은 고딕" pitchFamily="34" charset="-120"/>
+                        </a:rPr>
+                        <a:t>전형 4단계</a:t>
+                      </a:r>
+                      <a:endParaRPr lang="en-US" sz="1050" dirty="0">
+                        <a:latin typeface="맑은 고딕" charset="0"/>
+                        <a:ea typeface="맑은 고딕" charset="0"/>
+                        <a:cs typeface="맑은 고딕" charset="0"/>
+                      </a:endParaRPr>
+                    </a:p>
+                  </a:txBody>
+                  <a:tcPr marL="38100" marR="38100" marT="38100" marB="38100" anchor="ctr">
+                    <a:lnL w="12700" cap="flat" cmpd="sng" algn="ctr">
+                      <a:solidFill>
+                        <a:srgbClr val="000000"/>
+                      </a:solidFill>
+                      <a:prstDash val="solid"/>
+                      <a:round/>
+                      <a:headEnd type="none" w="med" len="med"/>
+                      <a:tailEnd type="none" w="med" len="med"/>
+                    </a:lnL>
+                    <a:lnR w="12700" cap="flat" cmpd="sng" algn="ctr">
+                      <a:solidFill>
+                        <a:srgbClr val="000000"/>
+                      </a:solidFill>
+                      <a:prstDash val="solid"/>
+                      <a:round/>
+                      <a:headEnd type="none" w="med" len="med"/>
+                      <a:tailEnd type="none" w="med" len="med"/>
+                    </a:lnR>
+                    <a:lnT w="12700" cap="flat" cmpd="sng" algn="ctr">
+                      <a:solidFill>
+                        <a:srgbClr val="000000"/>
+                      </a:solidFill>
+                      <a:prstDash val="solid"/>
+                      <a:round/>
+                      <a:headEnd type="none" w="med" len="med"/>
+                      <a:tailEnd type="none" w="med" len="med"/>
+                    </a:lnT>
+                    <a:lnB w="12700" cap="flat" cmpd="sng" algn="ctr">
+                      <a:solidFill>
+                        <a:srgbClr val="000000"/>
+                      </a:solidFill>
+                      <a:prstDash val="solid"/>
+                      <a:round/>
+                      <a:headEnd type="none" w="med" len="med"/>
+                      <a:tailEnd type="none" w="med" len="med"/>
+                    </a:lnB>
+                    <a:solidFill>
+                      <a:srgbClr val="EFF9FC"/>
+                    </a:solidFill>
+                  </a:tcPr>
+                </a:tc>
+              </a:tr>
+              <a:tr h="402336">
+                <a:tc>
+                  <a:txBody>
+                    <a:bodyPr/>
+                    <a:lstStyle/>
+                    <a:p>
+                      <a:pPr eaLnBrk="0" latinLnBrk="0" algn="ctr" indent="0" marL="0">
+                        <a:buNone/>
+                      </a:pPr>
+                      <a:r>
+                        <a:rPr lang="en-US" sz="1200" b="1" dirty="0">
+                          <a:solidFill>
+                            <a:srgbClr val="000000"/>
+                          </a:solidFill>
+                          <a:latin typeface="맑은 고딕" pitchFamily="34" charset="0"/>
+                          <a:ea typeface="맑은 고딕" pitchFamily="34" charset="-122"/>
+                          <a:cs typeface="맑은 고딕" pitchFamily="34" charset="-120"/>
+                        </a:rPr>
+                        <a:t>9</a:t>
+                      </a:r>
+                      <a:endParaRPr lang="en-US" sz="1200" dirty="0">
+                        <a:latin typeface="맑은 고딕" charset="0"/>
+                        <a:ea typeface="맑은 고딕" charset="0"/>
+                        <a:cs typeface="맑은 고딕" charset="0"/>
+                      </a:endParaRPr>
+                    </a:p>
+                  </a:txBody>
+                  <a:tcPr marL="38100" marR="38100" marT="38100" marB="38100" anchor="ctr">
+                    <a:lnL w="12700" cap="flat" cmpd="sng" algn="ctr">
+                      <a:solidFill>
+                        <a:srgbClr val="000000"/>
+                      </a:solidFill>
+                      <a:prstDash val="solid"/>
+                      <a:round/>
+                      <a:headEnd type="none" w="med" len="med"/>
+                      <a:tailEnd type="none" w="med" len="med"/>
+                    </a:lnL>
+                    <a:lnR w="12700" cap="flat" cmpd="sng" algn="ctr">
+                      <a:solidFill>
+                        <a:srgbClr val="000000"/>
+                      </a:solidFill>
+                      <a:prstDash val="solid"/>
+                      <a:round/>
+                      <a:headEnd type="none" w="med" len="med"/>
+                      <a:tailEnd type="none" w="med" len="med"/>
+                    </a:lnR>
+                    <a:lnT w="12700" cap="flat" cmpd="sng" algn="ctr">
+                      <a:solidFill>
+                        <a:srgbClr val="000000"/>
+                      </a:solidFill>
+                      <a:prstDash val="solid"/>
+                      <a:round/>
+                      <a:headEnd type="none" w="med" len="med"/>
+                      <a:tailEnd type="none" w="med" len="med"/>
+                    </a:lnT>
+                    <a:lnB w="12700" cap="flat" cmpd="sng" algn="ctr">
+                      <a:solidFill>
+                        <a:srgbClr val="000000"/>
+                      </a:solidFill>
+                      <a:prstDash val="solid"/>
+                      <a:round/>
+                      <a:headEnd type="none" w="med" len="med"/>
+                      <a:tailEnd type="none" w="med" len="med"/>
+                    </a:lnB>
+                    <a:solidFill>
+                      <a:srgbClr val="D9F6FF"/>
+                    </a:solidFill>
+                  </a:tcPr>
+                </a:tc>
+                <a:tc>
+                  <a:txBody>
+                    <a:bodyPr/>
+                    <a:lstStyle/>
+                    <a:p>
+                      <a:pPr eaLnBrk="0" latinLnBrk="0" algn="l" indent="0" marL="0">
+                        <a:buNone/>
+                      </a:pPr>
+                      <a:r>
+                        <a:rPr lang="en-US" sz="1300" dirty="0">
+                          <a:solidFill>
+                            <a:srgbClr val="000000"/>
+                          </a:solidFill>
+                          <a:latin typeface="맑은 고딕" pitchFamily="34" charset="0"/>
+                          <a:ea typeface="맑은 고딕" pitchFamily="34" charset="-122"/>
+                          <a:cs typeface="맑은 고딕" pitchFamily="34" charset="-120"/>
+                        </a:rPr>
+                        <a:t>기타 사항</a:t>
+                      </a:r>
+                      <a:endParaRPr lang="en-US" sz="1300" dirty="0">
+                        <a:latin typeface="맑은 고딕" charset="0"/>
+                        <a:ea typeface="맑은 고딕" charset="0"/>
+                        <a:cs typeface="맑은 고딕" charset="0"/>
+                      </a:endParaRPr>
+                    </a:p>
+                  </a:txBody>
+                  <a:tcPr marL="38100" marR="38100" marT="38100" marB="38100" anchor="ctr">
+                    <a:lnL w="12700" cap="flat" cmpd="sng" algn="ctr">
+                      <a:solidFill>
+                        <a:srgbClr val="000000"/>
+                      </a:solidFill>
+                      <a:prstDash val="solid"/>
+                      <a:round/>
+                      <a:headEnd type="none" w="med" len="med"/>
+                      <a:tailEnd type="none" w="med" len="med"/>
+                    </a:lnL>
+                    <a:lnR w="12700" cap="flat" cmpd="sng" algn="ctr">
+                      <a:solidFill>
+                        <a:srgbClr val="000000"/>
+                      </a:solidFill>
+                      <a:prstDash val="solid"/>
+                      <a:round/>
+                      <a:headEnd type="none" w="med" len="med"/>
+                      <a:tailEnd type="none" w="med" len="med"/>
+                    </a:lnR>
+                    <a:lnT w="12700" cap="flat" cmpd="sng" algn="ctr">
+                      <a:solidFill>
+                        <a:srgbClr val="000000"/>
+                      </a:solidFill>
+                      <a:prstDash val="solid"/>
+                      <a:round/>
+                      <a:headEnd type="none" w="med" len="med"/>
+                      <a:tailEnd type="none" w="med" len="med"/>
+                    </a:lnT>
+                    <a:lnB w="12700" cap="flat" cmpd="sng" algn="ctr">
+                      <a:solidFill>
+                        <a:srgbClr val="000000"/>
+                      </a:solidFill>
+                      <a:prstDash val="solid"/>
+                      <a:round/>
+                      <a:headEnd type="none" w="med" len="med"/>
+                      <a:tailEnd type="none" w="med" len="med"/>
+                    </a:lnB>
+                  </a:tcPr>
+                </a:tc>
+                <a:tc>
+                  <a:txBody>
+                    <a:bodyPr/>
+                    <a:lstStyle/>
+                    <a:p>
+                      <a:pPr eaLnBrk="0" latinLnBrk="0" algn="ctr" indent="0" marL="0">
+                        <a:buNone/>
+                      </a:pPr>
+                      <a:endParaRPr lang="en-US" sz="1050" dirty="0">
+                        <a:latin typeface="맑은 고딕" charset="0"/>
+                        <a:ea typeface="맑은 고딕" charset="0"/>
+                        <a:cs typeface="맑은 고딕" charset="0"/>
+                      </a:endParaRPr>
+                    </a:p>
+                  </a:txBody>
+                  <a:tcPr marL="38100" marR="38100" marT="38100" marB="38100" anchor="ctr">
+                    <a:lnL w="12700" cap="flat" cmpd="sng" algn="ctr">
+                      <a:solidFill>
+                        <a:srgbClr val="000000"/>
+                      </a:solidFill>
+                      <a:prstDash val="solid"/>
+                      <a:round/>
+                      <a:headEnd type="none" w="med" len="med"/>
+                      <a:tailEnd type="none" w="med" len="med"/>
+                    </a:lnL>
+                    <a:lnR w="12700" cap="flat" cmpd="sng" algn="ctr">
+                      <a:solidFill>
+                        <a:srgbClr val="000000"/>
+                      </a:solidFill>
+                      <a:prstDash val="solid"/>
+                      <a:round/>
+                      <a:headEnd type="none" w="med" len="med"/>
+                      <a:tailEnd type="none" w="med" len="med"/>
+                    </a:lnR>
+                    <a:lnT w="12700" cap="flat" cmpd="sng" algn="ctr">
+                      <a:solidFill>
+                        <a:srgbClr val="000000"/>
+                      </a:solidFill>
+                      <a:prstDash val="solid"/>
+                      <a:round/>
+                      <a:headEnd type="none" w="med" len="med"/>
+                      <a:tailEnd type="none" w="med" len="med"/>
+                    </a:lnT>
+                    <a:lnB w="12700" cap="flat" cmpd="sng" algn="ctr">
+                      <a:solidFill>
+                        <a:srgbClr val="000000"/>
+                      </a:solidFill>
+                      <a:prstDash val="solid"/>
+                      <a:round/>
+                      <a:headEnd type="none" w="med" len="med"/>
+                      <a:tailEnd type="none" w="med" len="med"/>
+                    </a:lnB>
+                  </a:tcPr>
+                </a:tc>
+              </a:tr>
+              <a:tr h="402336">
+                <a:tc>
+                  <a:txBody>
+                    <a:bodyPr/>
+                    <a:lstStyle/>
+                    <a:p>
+                      <a:pPr eaLnBrk="0" latinLnBrk="0" algn="ctr" indent="0" marL="0">
+                        <a:buNone/>
+                      </a:pPr>
+                      <a:r>
+                        <a:rPr lang="en-US" sz="1200" b="1" dirty="0">
+                          <a:solidFill>
+                            <a:srgbClr val="000000"/>
+                          </a:solidFill>
+                          <a:latin typeface="맑은 고딕" pitchFamily="34" charset="0"/>
+                          <a:ea typeface="맑은 고딕" pitchFamily="34" charset="-122"/>
+                          <a:cs typeface="맑은 고딕" pitchFamily="34" charset="-120"/>
+                        </a:rPr>
+                        <a:t>10</a:t>
+                      </a:r>
+                      <a:endParaRPr lang="en-US" sz="1200" dirty="0">
+                        <a:latin typeface="맑은 고딕" charset="0"/>
+                        <a:ea typeface="맑은 고딕" charset="0"/>
+                        <a:cs typeface="맑은 고딕" charset="0"/>
+                      </a:endParaRPr>
+                    </a:p>
+                  </a:txBody>
+                  <a:tcPr marL="38100" marR="38100" marT="38100" marB="38100" anchor="ctr">
+                    <a:lnL w="12700" cap="flat" cmpd="sng" algn="ctr">
+                      <a:solidFill>
+                        <a:srgbClr val="000000"/>
+                      </a:solidFill>
+                      <a:prstDash val="solid"/>
+                      <a:round/>
+                      <a:headEnd type="none" w="med" len="med"/>
+                      <a:tailEnd type="none" w="med" len="med"/>
+                    </a:lnL>
+                    <a:lnR w="12700" cap="flat" cmpd="sng" algn="ctr">
+                      <a:solidFill>
+                        <a:srgbClr val="000000"/>
+                      </a:solidFill>
+                      <a:prstDash val="solid"/>
+                      <a:round/>
+                      <a:headEnd type="none" w="med" len="med"/>
+                      <a:tailEnd type="none" w="med" len="med"/>
+                    </a:lnR>
+                    <a:lnT w="12700" cap="flat" cmpd="sng" algn="ctr">
+                      <a:solidFill>
+                        <a:srgbClr val="000000"/>
+                      </a:solidFill>
+                      <a:prstDash val="solid"/>
+                      <a:round/>
+                      <a:headEnd type="none" w="med" len="med"/>
+                      <a:tailEnd type="none" w="med" len="med"/>
+                    </a:lnT>
+                    <a:lnB w="12700" cap="flat" cmpd="sng" algn="ctr">
+                      <a:solidFill>
+                        <a:srgbClr val="000000"/>
+                      </a:solidFill>
+                      <a:prstDash val="solid"/>
+                      <a:round/>
+                      <a:headEnd type="none" w="med" len="med"/>
+                      <a:tailEnd type="none" w="med" len="med"/>
+                    </a:lnB>
+                    <a:solidFill>
+                      <a:srgbClr val="D9F6FF"/>
+                    </a:solidFill>
+                  </a:tcPr>
+                </a:tc>
+                <a:tc>
+                  <a:txBody>
+                    <a:bodyPr/>
+                    <a:lstStyle/>
+                    <a:p>
+                      <a:pPr eaLnBrk="0" latinLnBrk="0" algn="l" indent="0" marL="0">
+                        <a:buNone/>
+                      </a:pPr>
+                      <a:r>
+                        <a:rPr lang="en-US" sz="1300" dirty="0">
+                          <a:solidFill>
+                            <a:srgbClr val="000000"/>
+                          </a:solidFill>
+                          <a:latin typeface="맑은 고딕" pitchFamily="34" charset="0"/>
+                          <a:ea typeface="맑은 고딕" pitchFamily="34" charset="-122"/>
+                          <a:cs typeface="맑은 고딕" pitchFamily="34" charset="-120"/>
+                        </a:rPr>
+                        <a:t>채용 계획 요약</a:t>
+                      </a:r>
+                      <a:endParaRPr lang="en-US" sz="1300" dirty="0">
+                        <a:latin typeface="맑은 고딕" charset="0"/>
+                        <a:ea typeface="맑은 고딕" charset="0"/>
+                        <a:cs typeface="맑은 고딕" charset="0"/>
+                      </a:endParaRPr>
+                    </a:p>
+                  </a:txBody>
+                  <a:tcPr marL="38100" marR="38100" marT="38100" marB="38100" anchor="ctr">
+                    <a:lnL w="12700" cap="flat" cmpd="sng" algn="ctr">
+                      <a:solidFill>
+                        <a:srgbClr val="000000"/>
+                      </a:solidFill>
+                      <a:prstDash val="solid"/>
+                      <a:round/>
+                      <a:headEnd type="none" w="med" len="med"/>
+                      <a:tailEnd type="none" w="med" len="med"/>
+                    </a:lnL>
+                    <a:lnR w="12700" cap="flat" cmpd="sng" algn="ctr">
+                      <a:solidFill>
+                        <a:srgbClr val="000000"/>
+                      </a:solidFill>
+                      <a:prstDash val="solid"/>
+                      <a:round/>
+                      <a:headEnd type="none" w="med" len="med"/>
+                      <a:tailEnd type="none" w="med" len="med"/>
+                    </a:lnR>
+                    <a:lnT w="12700" cap="flat" cmpd="sng" algn="ctr">
+                      <a:solidFill>
+                        <a:srgbClr val="000000"/>
+                      </a:solidFill>
+                      <a:prstDash val="solid"/>
+                      <a:round/>
+                      <a:headEnd type="none" w="med" len="med"/>
+                      <a:tailEnd type="none" w="med" len="med"/>
+                    </a:lnT>
+                    <a:lnB w="12700" cap="flat" cmpd="sng" algn="ctr">
+                      <a:solidFill>
+                        <a:srgbClr val="000000"/>
+                      </a:solidFill>
+                      <a:prstDash val="solid"/>
+                      <a:round/>
+                      <a:headEnd type="none" w="med" len="med"/>
+                      <a:tailEnd type="none" w="med" len="med"/>
+                    </a:lnB>
+                  </a:tcPr>
+                </a:tc>
+                <a:tc>
+                  <a:txBody>
+                    <a:bodyPr/>
+                    <a:lstStyle/>
+                    <a:p>
+                      <a:pPr eaLnBrk="0" latinLnBrk="0" algn="ctr" indent="0" marL="0">
+                        <a:buNone/>
+                      </a:pPr>
+                      <a:endParaRPr lang="en-US" sz="1050" dirty="0">
+                        <a:latin typeface="맑은 고딕" charset="0"/>
+                        <a:ea typeface="맑은 고딕" charset="0"/>
+                        <a:cs typeface="맑은 고딕" charset="0"/>
+                      </a:endParaRPr>
+                    </a:p>
+                  </a:txBody>
+                  <a:tcPr marL="38100" marR="38100" marT="38100" marB="38100" anchor="ctr">
+                    <a:lnL w="12700" cap="flat" cmpd="sng" algn="ctr">
+                      <a:solidFill>
+                        <a:srgbClr val="000000"/>
+                      </a:solidFill>
+                      <a:prstDash val="solid"/>
+                      <a:round/>
+                      <a:headEnd type="none" w="med" len="med"/>
+                      <a:tailEnd type="none" w="med" len="med"/>
+                    </a:lnL>
+                    <a:lnR w="12700" cap="flat" cmpd="sng" algn="ctr">
+                      <a:solidFill>
+                        <a:srgbClr val="000000"/>
+                      </a:solidFill>
+                      <a:prstDash val="solid"/>
+                      <a:round/>
+                      <a:headEnd type="none" w="med" len="med"/>
+                      <a:tailEnd type="none" w="med" len="med"/>
+                    </a:lnR>
+                    <a:lnT w="12700" cap="flat" cmpd="sng" algn="ctr">
+                      <a:solidFill>
+                        <a:srgbClr val="000000"/>
+                      </a:solidFill>
+                      <a:prstDash val="solid"/>
+                      <a:round/>
+                      <a:headEnd type="none" w="med" len="med"/>
+                      <a:tailEnd type="none" w="med" len="med"/>
+                    </a:lnT>
+                    <a:lnB w="12700" cap="flat" cmpd="sng" algn="ctr">
+                      <a:solidFill>
+                        <a:srgbClr val="000000"/>
+                      </a:solidFill>
+                      <a:prstDash val="solid"/>
+                      <a:round/>
+                      <a:headEnd type="none" w="med" len="med"/>
+                      <a:tailEnd type="none" w="med" len="med"/>
+                    </a:lnB>
+                  </a:tcPr>
+                </a:tc>
+              </a:tr>
+            </a:tbl>
+          </a:graphicData>
+        </a:graphic>
+      </p:graphicFrame>
       <p:sp>
         <p:nvSpPr>
-          <p:cNvPr id="5" name="Text 3"/>
+          <p:cNvPr id="6" name="Text 3"/>
           <p:cNvSpPr txBox="1"/>
           <p:nvPr/>
         </p:nvSpPr>
         <p:spPr>
           <a:xfrm>
-            <a:off x="1645920" y="1298448"/>
-            <a:ext cx="4206240" cy="384048"/>
+            <a:off x="1005840" y="5669280"/>
+            <a:ext cx="7132320" cy="256032"/>
           </a:xfrm>
           <a:prstGeom prst="rect">
             <a:avLst/>
@@ -6468,202 +8663,7 @@
               <a:buNone/>
             </a:pPr>
             <a:r>
-              <a:rPr lang="en-US" sz="1800" dirty="0">
-                <a:solidFill>
-                  <a:srgbClr val="000000"/>
-                </a:solidFill>
-                <a:latin typeface="맑은 고딕" pitchFamily="34" charset="0"/>
-                <a:ea typeface="맑은 고딕" pitchFamily="34" charset="-122"/>
-                <a:cs typeface="맑은 고딕" pitchFamily="34" charset="-120"/>
-              </a:rPr>
-              <a:t>1.  채용 인원 및 채용 사유</a:t>
-            </a:r>
-            <a:endParaRPr lang="en-US" sz="1800" dirty="0"/>
-          </a:p>
-        </p:txBody>
-      </p:sp>
-      <p:sp>
-        <p:nvSpPr>
-          <p:cNvPr id="6" name="Text 4"/>
-          <p:cNvSpPr txBox="1"/>
-          <p:nvPr/>
-        </p:nvSpPr>
-        <p:spPr>
-          <a:xfrm>
-            <a:off x="1645920" y="1737360"/>
-            <a:ext cx="4206240" cy="384048"/>
-          </a:xfrm>
-          <a:prstGeom prst="rect">
-            <a:avLst/>
-          </a:prstGeom>
-          <a:noFill/>
-          <a:ln/>
-        </p:spPr>
-        <p:txBody>
-          <a:bodyPr wrap="square" lIns="0" tIns="0" rIns="0" bIns="0" rtlCol="0" anchor="ctr"/>
-          <a:lstStyle/>
-          <a:p>
-            <a:pPr eaLnBrk="0" latinLnBrk="0" indent="0" marL="0">
-              <a:buNone/>
-            </a:pPr>
-            <a:r>
-              <a:rPr lang="en-US" sz="1800" dirty="0">
-                <a:solidFill>
-                  <a:srgbClr val="000000"/>
-                </a:solidFill>
-                <a:latin typeface="맑은 고딕" pitchFamily="34" charset="0"/>
-                <a:ea typeface="맑은 고딕" pitchFamily="34" charset="-122"/>
-                <a:cs typeface="맑은 고딕" pitchFamily="34" charset="-120"/>
-              </a:rPr>
-              <a:t>2.  직원 현황</a:t>
-            </a:r>
-            <a:endParaRPr lang="en-US" sz="1800" dirty="0"/>
-          </a:p>
-        </p:txBody>
-      </p:sp>
-      <p:sp>
-        <p:nvSpPr>
-          <p:cNvPr id="7" name="Text 5"/>
-          <p:cNvSpPr txBox="1"/>
-          <p:nvPr/>
-        </p:nvSpPr>
-        <p:spPr>
-          <a:xfrm>
-            <a:off x="1645920" y="2176272"/>
-            <a:ext cx="4206240" cy="384048"/>
-          </a:xfrm>
-          <a:prstGeom prst="rect">
-            <a:avLst/>
-          </a:prstGeom>
-          <a:noFill/>
-          <a:ln/>
-        </p:spPr>
-        <p:txBody>
-          <a:bodyPr wrap="square" lIns="0" tIns="0" rIns="0" bIns="0" rtlCol="0" anchor="ctr"/>
-          <a:lstStyle/>
-          <a:p>
-            <a:pPr eaLnBrk="0" latinLnBrk="0" indent="0" marL="0">
-              <a:buNone/>
-            </a:pPr>
-            <a:r>
-              <a:rPr lang="en-US" sz="1800" dirty="0">
-                <a:solidFill>
-                  <a:srgbClr val="000000"/>
-                </a:solidFill>
-                <a:latin typeface="맑은 고딕" pitchFamily="34" charset="0"/>
-                <a:ea typeface="맑은 고딕" pitchFamily="34" charset="-122"/>
-                <a:cs typeface="맑은 고딕" pitchFamily="34" charset="-120"/>
-              </a:rPr>
-              <a:t>3.  채용 계획</a:t>
-            </a:r>
-            <a:endParaRPr lang="en-US" sz="1800" dirty="0"/>
-          </a:p>
-        </p:txBody>
-      </p:sp>
-      <p:sp>
-        <p:nvSpPr>
-          <p:cNvPr id="8" name="Text 6"/>
-          <p:cNvSpPr txBox="1"/>
-          <p:nvPr/>
-        </p:nvSpPr>
-        <p:spPr>
-          <a:xfrm>
-            <a:off x="1645920" y="2615184"/>
-            <a:ext cx="4206240" cy="384048"/>
-          </a:xfrm>
-          <a:prstGeom prst="rect">
-            <a:avLst/>
-          </a:prstGeom>
-          <a:noFill/>
-          <a:ln/>
-        </p:spPr>
-        <p:txBody>
-          <a:bodyPr wrap="square" lIns="0" tIns="0" rIns="0" bIns="0" rtlCol="0" anchor="ctr"/>
-          <a:lstStyle/>
-          <a:p>
-            <a:pPr eaLnBrk="0" latinLnBrk="0" indent="0" marL="0">
-              <a:buNone/>
-            </a:pPr>
-            <a:r>
-              <a:rPr lang="en-US" sz="1800" dirty="0">
-                <a:solidFill>
-                  <a:srgbClr val="000000"/>
-                </a:solidFill>
-                <a:latin typeface="맑은 고딕" pitchFamily="34" charset="0"/>
-                <a:ea typeface="맑은 고딕" pitchFamily="34" charset="-122"/>
-                <a:cs typeface="맑은 고딕" pitchFamily="34" charset="-120"/>
-              </a:rPr>
-              <a:t>4.  전형 절차</a:t>
-            </a:r>
-            <a:endParaRPr lang="en-US" sz="1800" dirty="0"/>
-          </a:p>
-        </p:txBody>
-      </p:sp>
-      <p:sp>
-        <p:nvSpPr>
-          <p:cNvPr id="9" name="Text 7"/>
-          <p:cNvSpPr txBox="1"/>
-          <p:nvPr/>
-        </p:nvSpPr>
-        <p:spPr>
-          <a:xfrm>
-            <a:off x="1645920" y="3054096"/>
-            <a:ext cx="4206240" cy="384048"/>
-          </a:xfrm>
-          <a:prstGeom prst="rect">
-            <a:avLst/>
-          </a:prstGeom>
-          <a:noFill/>
-          <a:ln/>
-        </p:spPr>
-        <p:txBody>
-          <a:bodyPr wrap="square" lIns="0" tIns="0" rIns="0" bIns="0" rtlCol="0" anchor="ctr"/>
-          <a:lstStyle/>
-          <a:p>
-            <a:pPr eaLnBrk="0" latinLnBrk="0" indent="0" marL="0">
-              <a:buNone/>
-            </a:pPr>
-            <a:r>
-              <a:rPr lang="en-US" sz="1800" dirty="0">
-                <a:solidFill>
-                  <a:srgbClr val="000000"/>
-                </a:solidFill>
-                <a:latin typeface="맑은 고딕" pitchFamily="34" charset="0"/>
-                <a:ea typeface="맑은 고딕" pitchFamily="34" charset="-122"/>
-                <a:cs typeface="맑은 고딕" pitchFamily="34" charset="-120"/>
-              </a:rPr>
-              <a:t>5.  지원서 접수</a:t>
-            </a:r>
-            <a:endParaRPr lang="en-US" sz="1800" dirty="0"/>
-          </a:p>
-        </p:txBody>
-      </p:sp>
-      <p:sp>
-        <p:nvSpPr>
-          <p:cNvPr id="10" name="Text 8"/>
-          <p:cNvSpPr txBox="1"/>
-          <p:nvPr/>
-        </p:nvSpPr>
-        <p:spPr>
-          <a:xfrm>
-            <a:off x="5852160" y="3054096"/>
-            <a:ext cx="1645920" cy="384048"/>
-          </a:xfrm>
-          <a:prstGeom prst="rect">
-            <a:avLst/>
-          </a:prstGeom>
-          <a:noFill/>
-          <a:ln/>
-        </p:spPr>
-        <p:txBody>
-          <a:bodyPr wrap="square" lIns="0" tIns="0" rIns="0" bIns="0" rtlCol="0" anchor="ctr"/>
-          <a:lstStyle/>
-          <a:p>
-            <a:pPr eaLnBrk="0" latinLnBrk="0" indent="0" marL="0">
-              <a:buNone/>
-            </a:pPr>
-            <a:r>
-              <a:rPr lang="en-US" sz="1200" dirty="0">
+              <a:rPr lang="en-US" sz="1050" dirty="0">
                 <a:solidFill>
                   <a:srgbClr val="404040"/>
                 </a:solidFill>
@@ -6671,321 +8671,9 @@
                 <a:ea typeface="맑은 고딕" pitchFamily="34" charset="-122"/>
                 <a:cs typeface="맑은 고딕" pitchFamily="34" charset="-120"/>
               </a:rPr>
-              <a:t>[ 전형 1단계 ]</a:t>
+              <a:t>※ 5 ~ 8은 전형 4단계에 해당함</a:t>
             </a:r>
-            <a:endParaRPr lang="en-US" sz="1200" dirty="0"/>
-          </a:p>
-        </p:txBody>
-      </p:sp>
-      <p:sp>
-        <p:nvSpPr>
-          <p:cNvPr id="11" name="Text 9"/>
-          <p:cNvSpPr txBox="1"/>
-          <p:nvPr/>
-        </p:nvSpPr>
-        <p:spPr>
-          <a:xfrm>
-            <a:off x="1645920" y="3493008"/>
-            <a:ext cx="4206240" cy="384048"/>
-          </a:xfrm>
-          <a:prstGeom prst="rect">
-            <a:avLst/>
-          </a:prstGeom>
-          <a:noFill/>
-          <a:ln/>
-        </p:spPr>
-        <p:txBody>
-          <a:bodyPr wrap="square" lIns="0" tIns="0" rIns="0" bIns="0" rtlCol="0" anchor="ctr"/>
-          <a:lstStyle/>
-          <a:p>
-            <a:pPr eaLnBrk="0" latinLnBrk="0" indent="0" marL="0">
-              <a:buNone/>
-            </a:pPr>
-            <a:r>
-              <a:rPr lang="en-US" sz="1800" dirty="0">
-                <a:solidFill>
-                  <a:srgbClr val="000000"/>
-                </a:solidFill>
-                <a:latin typeface="맑은 고딕" pitchFamily="34" charset="0"/>
-                <a:ea typeface="맑은 고딕" pitchFamily="34" charset="-122"/>
-                <a:cs typeface="맑은 고딕" pitchFamily="34" charset="-120"/>
-              </a:rPr>
-              <a:t>6.  서류 전형 (1차)</a:t>
-            </a:r>
-            <a:endParaRPr lang="en-US" sz="1800" dirty="0"/>
-          </a:p>
-        </p:txBody>
-      </p:sp>
-      <p:sp>
-        <p:nvSpPr>
-          <p:cNvPr id="12" name="Text 10"/>
-          <p:cNvSpPr txBox="1"/>
-          <p:nvPr/>
-        </p:nvSpPr>
-        <p:spPr>
-          <a:xfrm>
-            <a:off x="5852160" y="3493008"/>
-            <a:ext cx="1645920" cy="384048"/>
-          </a:xfrm>
-          <a:prstGeom prst="rect">
-            <a:avLst/>
-          </a:prstGeom>
-          <a:noFill/>
-          <a:ln/>
-        </p:spPr>
-        <p:txBody>
-          <a:bodyPr wrap="square" lIns="0" tIns="0" rIns="0" bIns="0" rtlCol="0" anchor="ctr"/>
-          <a:lstStyle/>
-          <a:p>
-            <a:pPr eaLnBrk="0" latinLnBrk="0" indent="0" marL="0">
-              <a:buNone/>
-            </a:pPr>
-            <a:r>
-              <a:rPr lang="en-US" sz="1200" dirty="0">
-                <a:solidFill>
-                  <a:srgbClr val="404040"/>
-                </a:solidFill>
-                <a:latin typeface="맑은 고딕" pitchFamily="34" charset="0"/>
-                <a:ea typeface="맑은 고딕" pitchFamily="34" charset="-122"/>
-                <a:cs typeface="맑은 고딕" pitchFamily="34" charset="-120"/>
-              </a:rPr>
-              <a:t>[ 전형 2단계 ]</a:t>
-            </a:r>
-            <a:endParaRPr lang="en-US" sz="1200" dirty="0"/>
-          </a:p>
-        </p:txBody>
-      </p:sp>
-      <p:sp>
-        <p:nvSpPr>
-          <p:cNvPr id="13" name="Text 11"/>
-          <p:cNvSpPr txBox="1"/>
-          <p:nvPr/>
-        </p:nvSpPr>
-        <p:spPr>
-          <a:xfrm>
-            <a:off x="1645920" y="3931920"/>
-            <a:ext cx="4206240" cy="384048"/>
-          </a:xfrm>
-          <a:prstGeom prst="rect">
-            <a:avLst/>
-          </a:prstGeom>
-          <a:noFill/>
-          <a:ln/>
-        </p:spPr>
-        <p:txBody>
-          <a:bodyPr wrap="square" lIns="0" tIns="0" rIns="0" bIns="0" rtlCol="0" anchor="ctr"/>
-          <a:lstStyle/>
-          <a:p>
-            <a:pPr eaLnBrk="0" latinLnBrk="0" indent="0" marL="0">
-              <a:buNone/>
-            </a:pPr>
-            <a:r>
-              <a:rPr lang="en-US" sz="1800" dirty="0">
-                <a:solidFill>
-                  <a:srgbClr val="000000"/>
-                </a:solidFill>
-                <a:latin typeface="맑은 고딕" pitchFamily="34" charset="0"/>
-                <a:ea typeface="맑은 고딕" pitchFamily="34" charset="-122"/>
-                <a:cs typeface="맑은 고딕" pitchFamily="34" charset="-120"/>
-              </a:rPr>
-              <a:t>7.  업무적성 및 심층면접 (2차)</a:t>
-            </a:r>
-            <a:endParaRPr lang="en-US" sz="1800" dirty="0"/>
-          </a:p>
-        </p:txBody>
-      </p:sp>
-      <p:sp>
-        <p:nvSpPr>
-          <p:cNvPr id="14" name="Text 12"/>
-          <p:cNvSpPr txBox="1"/>
-          <p:nvPr/>
-        </p:nvSpPr>
-        <p:spPr>
-          <a:xfrm>
-            <a:off x="5852160" y="3931920"/>
-            <a:ext cx="1645920" cy="384048"/>
-          </a:xfrm>
-          <a:prstGeom prst="rect">
-            <a:avLst/>
-          </a:prstGeom>
-          <a:noFill/>
-          <a:ln/>
-        </p:spPr>
-        <p:txBody>
-          <a:bodyPr wrap="square" lIns="0" tIns="0" rIns="0" bIns="0" rtlCol="0" anchor="ctr"/>
-          <a:lstStyle/>
-          <a:p>
-            <a:pPr eaLnBrk="0" latinLnBrk="0" indent="0" marL="0">
-              <a:buNone/>
-            </a:pPr>
-            <a:r>
-              <a:rPr lang="en-US" sz="1200" dirty="0">
-                <a:solidFill>
-                  <a:srgbClr val="404040"/>
-                </a:solidFill>
-                <a:latin typeface="맑은 고딕" pitchFamily="34" charset="0"/>
-                <a:ea typeface="맑은 고딕" pitchFamily="34" charset="-122"/>
-                <a:cs typeface="맑은 고딕" pitchFamily="34" charset="-120"/>
-              </a:rPr>
-              <a:t>[ 전형 3단계 ]</a:t>
-            </a:r>
-            <a:endParaRPr lang="en-US" sz="1200" dirty="0"/>
-          </a:p>
-        </p:txBody>
-      </p:sp>
-      <p:sp>
-        <p:nvSpPr>
-          <p:cNvPr id="15" name="Text 13"/>
-          <p:cNvSpPr txBox="1"/>
-          <p:nvPr/>
-        </p:nvSpPr>
-        <p:spPr>
-          <a:xfrm>
-            <a:off x="1645920" y="4370832"/>
-            <a:ext cx="4206240" cy="384048"/>
-          </a:xfrm>
-          <a:prstGeom prst="rect">
-            <a:avLst/>
-          </a:prstGeom>
-          <a:noFill/>
-          <a:ln/>
-        </p:spPr>
-        <p:txBody>
-          <a:bodyPr wrap="square" lIns="0" tIns="0" rIns="0" bIns="0" rtlCol="0" anchor="ctr"/>
-          <a:lstStyle/>
-          <a:p>
-            <a:pPr eaLnBrk="0" latinLnBrk="0" indent="0" marL="0">
-              <a:buNone/>
-            </a:pPr>
-            <a:r>
-              <a:rPr lang="en-US" sz="1800" dirty="0">
-                <a:solidFill>
-                  <a:srgbClr val="000000"/>
-                </a:solidFill>
-                <a:latin typeface="맑은 고딕" pitchFamily="34" charset="0"/>
-                <a:ea typeface="맑은 고딕" pitchFamily="34" charset="-122"/>
-                <a:cs typeface="맑은 고딕" pitchFamily="34" charset="-120"/>
-              </a:rPr>
-              <a:t>8.  결격사유 검증</a:t>
-            </a:r>
-            <a:endParaRPr lang="en-US" sz="1800" dirty="0"/>
-          </a:p>
-        </p:txBody>
-      </p:sp>
-      <p:sp>
-        <p:nvSpPr>
-          <p:cNvPr id="16" name="Text 14"/>
-          <p:cNvSpPr txBox="1"/>
-          <p:nvPr/>
-        </p:nvSpPr>
-        <p:spPr>
-          <a:xfrm>
-            <a:off x="5852160" y="4370832"/>
-            <a:ext cx="1645920" cy="384048"/>
-          </a:xfrm>
-          <a:prstGeom prst="rect">
-            <a:avLst/>
-          </a:prstGeom>
-          <a:noFill/>
-          <a:ln/>
-        </p:spPr>
-        <p:txBody>
-          <a:bodyPr wrap="square" lIns="0" tIns="0" rIns="0" bIns="0" rtlCol="0" anchor="ctr"/>
-          <a:lstStyle/>
-          <a:p>
-            <a:pPr eaLnBrk="0" latinLnBrk="0" indent="0" marL="0">
-              <a:buNone/>
-            </a:pPr>
-            <a:r>
-              <a:rPr lang="en-US" sz="1200" dirty="0">
-                <a:solidFill>
-                  <a:srgbClr val="404040"/>
-                </a:solidFill>
-                <a:latin typeface="맑은 고딕" pitchFamily="34" charset="0"/>
-                <a:ea typeface="맑은 고딕" pitchFamily="34" charset="-122"/>
-                <a:cs typeface="맑은 고딕" pitchFamily="34" charset="-120"/>
-              </a:rPr>
-              <a:t>[ 전형 4단계 ]</a:t>
-            </a:r>
-            <a:endParaRPr lang="en-US" sz="1200" dirty="0"/>
-          </a:p>
-        </p:txBody>
-      </p:sp>
-      <p:sp>
-        <p:nvSpPr>
-          <p:cNvPr id="17" name="Text 15"/>
-          <p:cNvSpPr txBox="1"/>
-          <p:nvPr/>
-        </p:nvSpPr>
-        <p:spPr>
-          <a:xfrm>
-            <a:off x="1645920" y="4809744"/>
-            <a:ext cx="4206240" cy="384048"/>
-          </a:xfrm>
-          <a:prstGeom prst="rect">
-            <a:avLst/>
-          </a:prstGeom>
-          <a:noFill/>
-          <a:ln/>
-        </p:spPr>
-        <p:txBody>
-          <a:bodyPr wrap="square" lIns="0" tIns="0" rIns="0" bIns="0" rtlCol="0" anchor="ctr"/>
-          <a:lstStyle/>
-          <a:p>
-            <a:pPr eaLnBrk="0" latinLnBrk="0" indent="0" marL="0">
-              <a:buNone/>
-            </a:pPr>
-            <a:r>
-              <a:rPr lang="en-US" sz="1800" dirty="0">
-                <a:solidFill>
-                  <a:srgbClr val="000000"/>
-                </a:solidFill>
-                <a:latin typeface="맑은 고딕" pitchFamily="34" charset="0"/>
-                <a:ea typeface="맑은 고딕" pitchFamily="34" charset="-122"/>
-                <a:cs typeface="맑은 고딕" pitchFamily="34" charset="-120"/>
-              </a:rPr>
-              <a:t>9.  기타 사항</a:t>
-            </a:r>
-            <a:endParaRPr lang="en-US" sz="1800" dirty="0"/>
-          </a:p>
-        </p:txBody>
-      </p:sp>
-      <p:sp>
-        <p:nvSpPr>
-          <p:cNvPr id="18" name="Text 16"/>
-          <p:cNvSpPr txBox="1"/>
-          <p:nvPr/>
-        </p:nvSpPr>
-        <p:spPr>
-          <a:xfrm>
-            <a:off x="1645920" y="5248656"/>
-            <a:ext cx="4206240" cy="384048"/>
-          </a:xfrm>
-          <a:prstGeom prst="rect">
-            <a:avLst/>
-          </a:prstGeom>
-          <a:noFill/>
-          <a:ln/>
-        </p:spPr>
-        <p:txBody>
-          <a:bodyPr wrap="square" lIns="0" tIns="0" rIns="0" bIns="0" rtlCol="0" anchor="ctr"/>
-          <a:lstStyle/>
-          <a:p>
-            <a:pPr eaLnBrk="0" latinLnBrk="0" indent="0" marL="0">
-              <a:buNone/>
-            </a:pPr>
-            <a:r>
-              <a:rPr lang="en-US" sz="1800" dirty="0">
-                <a:solidFill>
-                  <a:srgbClr val="000000"/>
-                </a:solidFill>
-                <a:latin typeface="맑은 고딕" pitchFamily="34" charset="0"/>
-                <a:ea typeface="맑은 고딕" pitchFamily="34" charset="-122"/>
-                <a:cs typeface="맑은 고딕" pitchFamily="34" charset="-120"/>
-              </a:rPr>
-              <a:t>10.  채용 계획 요약</a:t>
-            </a:r>
-            <a:endParaRPr lang="en-US" sz="1800" dirty="0"/>
+            <a:endParaRPr lang="en-US" sz="1050" dirty="0"/>
           </a:p>
         </p:txBody>
       </p:sp>

</xml_diff>

<commit_message>
Frame the 목차 as one box with no inner rules
The grid read as clutter, so the contents page now follows the
reference: a single black-bordered box around the list, no lines
between entries, and only a pale EFF9FC wash behind 5-8 to hold the
four 전형 단계 together. Entries go up to 16pt with the stage marker
set beside them in grey.

Co-Authored-By: Claude Opus 5 <noreply@anthropic.com>
Claude-Session: https://claude.ai/code/session_01GZfitk2JEKppZ4fGSDdghv
</commit_message>
<xml_diff>
--- a/docs/2027년_사무직원_채용계획안.pptx
+++ b/docs/2027년_사무직원_채용계획안.pptx
@@ -6443,2211 +6443,1002 @@
           </a:p>
         </p:txBody>
       </p:sp>
-      <p:graphicFrame>
-        <p:nvGraphicFramePr>
-          <p:cNvPr id="3" name="Table 0"/>
-          <p:cNvGraphicFramePr>
-            <a:graphicFrameLocks noGrp="1"/>
-          </p:cNvGraphicFramePr>
-          <p:nvPr>
-            <p:extLst>
-              <p:ext uri="{D42A27DB-BD31-4B8C-83A1-F6EECF244321}">
-                <p14:modId xmlns:p14="http://schemas.microsoft.com/office/powerpoint/2010/main" val="1579011935"/>
-              </p:ext>
-            </p:extLst>
-          </p:nvPr>
-        </p:nvGraphicFramePr>
-        <p:xfrm>
-          <a:off x="1005840" y="1188720"/>
-          <a:ext cx="7132320" cy="914400"/>
-        </p:xfrm>
-        <a:graphic>
-          <a:graphicData uri="http://schemas.openxmlformats.org/drawingml/2006/table">
-            <a:tbl>
-              <a:tblPr/>
-              <a:tblGrid>
-                <a:gridCol w="822960"/>
-                <a:gridCol w="4206240"/>
-                <a:gridCol w="2103120"/>
-              </a:tblGrid>
-              <a:tr h="329184">
-                <a:tc>
-                  <a:txBody>
-                    <a:bodyPr/>
-                    <a:lstStyle/>
-                    <a:p>
-                      <a:pPr eaLnBrk="0" latinLnBrk="0" algn="ctr" indent="0" marL="0">
-                        <a:buNone/>
-                      </a:pPr>
-                      <a:r>
-                        <a:rPr lang="en-US" sz="1050" b="1" dirty="0">
-                          <a:solidFill>
-                            <a:srgbClr val="000000"/>
-                          </a:solidFill>
-                          <a:latin typeface="맑은 고딕" pitchFamily="34" charset="0"/>
-                          <a:ea typeface="맑은 고딕" pitchFamily="34" charset="-122"/>
-                          <a:cs typeface="맑은 고딕" pitchFamily="34" charset="-120"/>
-                        </a:rPr>
-                        <a:t>구분</a:t>
-                      </a:r>
-                      <a:endParaRPr lang="en-US" sz="1050" dirty="0">
-                        <a:latin typeface="맑은 고딕" charset="0"/>
-                        <a:ea typeface="맑은 고딕" charset="0"/>
-                        <a:cs typeface="맑은 고딕" charset="0"/>
-                      </a:endParaRPr>
-                    </a:p>
-                  </a:txBody>
-                  <a:tcPr marL="38100" marR="38100" marT="38100" marB="38100" anchor="ctr">
-                    <a:lnL w="12700" cap="flat" cmpd="sng" algn="ctr">
-                      <a:solidFill>
-                        <a:srgbClr val="000000"/>
-                      </a:solidFill>
-                      <a:prstDash val="solid"/>
-                      <a:round/>
-                      <a:headEnd type="none" w="med" len="med"/>
-                      <a:tailEnd type="none" w="med" len="med"/>
-                    </a:lnL>
-                    <a:lnR w="12700" cap="flat" cmpd="sng" algn="ctr">
-                      <a:solidFill>
-                        <a:srgbClr val="000000"/>
-                      </a:solidFill>
-                      <a:prstDash val="solid"/>
-                      <a:round/>
-                      <a:headEnd type="none" w="med" len="med"/>
-                      <a:tailEnd type="none" w="med" len="med"/>
-                    </a:lnR>
-                    <a:lnT w="12700" cap="flat" cmpd="sng" algn="ctr">
-                      <a:solidFill>
-                        <a:srgbClr val="000000"/>
-                      </a:solidFill>
-                      <a:prstDash val="solid"/>
-                      <a:round/>
-                      <a:headEnd type="none" w="med" len="med"/>
-                      <a:tailEnd type="none" w="med" len="med"/>
-                    </a:lnT>
-                    <a:lnB w="12700" cap="flat" cmpd="sng" algn="ctr">
-                      <a:solidFill>
-                        <a:srgbClr val="000000"/>
-                      </a:solidFill>
-                      <a:prstDash val="solid"/>
-                      <a:round/>
-                      <a:headEnd type="none" w="med" len="med"/>
-                      <a:tailEnd type="none" w="med" len="med"/>
-                    </a:lnB>
-                    <a:solidFill>
-                      <a:srgbClr val="CCFFFF"/>
-                    </a:solidFill>
-                  </a:tcPr>
-                </a:tc>
-                <a:tc>
-                  <a:txBody>
-                    <a:bodyPr/>
-                    <a:lstStyle/>
-                    <a:p>
-                      <a:pPr eaLnBrk="0" latinLnBrk="0" algn="ctr" indent="0" marL="0">
-                        <a:buNone/>
-                      </a:pPr>
-                      <a:r>
-                        <a:rPr lang="en-US" sz="1050" b="1" dirty="0">
-                          <a:solidFill>
-                            <a:srgbClr val="000000"/>
-                          </a:solidFill>
-                          <a:latin typeface="맑은 고딕" pitchFamily="34" charset="0"/>
-                          <a:ea typeface="맑은 고딕" pitchFamily="34" charset="-122"/>
-                          <a:cs typeface="맑은 고딕" pitchFamily="34" charset="-120"/>
-                        </a:rPr>
-                        <a:t>항  목</a:t>
-                      </a:r>
-                      <a:endParaRPr lang="en-US" sz="1050" dirty="0">
-                        <a:latin typeface="맑은 고딕" charset="0"/>
-                        <a:ea typeface="맑은 고딕" charset="0"/>
-                        <a:cs typeface="맑은 고딕" charset="0"/>
-                      </a:endParaRPr>
-                    </a:p>
-                  </a:txBody>
-                  <a:tcPr marL="38100" marR="38100" marT="38100" marB="38100" anchor="ctr">
-                    <a:lnL w="12700" cap="flat" cmpd="sng" algn="ctr">
-                      <a:solidFill>
-                        <a:srgbClr val="000000"/>
-                      </a:solidFill>
-                      <a:prstDash val="solid"/>
-                      <a:round/>
-                      <a:headEnd type="none" w="med" len="med"/>
-                      <a:tailEnd type="none" w="med" len="med"/>
-                    </a:lnL>
-                    <a:lnR w="12700" cap="flat" cmpd="sng" algn="ctr">
-                      <a:solidFill>
-                        <a:srgbClr val="000000"/>
-                      </a:solidFill>
-                      <a:prstDash val="solid"/>
-                      <a:round/>
-                      <a:headEnd type="none" w="med" len="med"/>
-                      <a:tailEnd type="none" w="med" len="med"/>
-                    </a:lnR>
-                    <a:lnT w="12700" cap="flat" cmpd="sng" algn="ctr">
-                      <a:solidFill>
-                        <a:srgbClr val="000000"/>
-                      </a:solidFill>
-                      <a:prstDash val="solid"/>
-                      <a:round/>
-                      <a:headEnd type="none" w="med" len="med"/>
-                      <a:tailEnd type="none" w="med" len="med"/>
-                    </a:lnT>
-                    <a:lnB w="12700" cap="flat" cmpd="sng" algn="ctr">
-                      <a:solidFill>
-                        <a:srgbClr val="000000"/>
-                      </a:solidFill>
-                      <a:prstDash val="solid"/>
-                      <a:round/>
-                      <a:headEnd type="none" w="med" len="med"/>
-                      <a:tailEnd type="none" w="med" len="med"/>
-                    </a:lnB>
-                    <a:solidFill>
-                      <a:srgbClr val="CCFFFF"/>
-                    </a:solidFill>
-                  </a:tcPr>
-                </a:tc>
-                <a:tc>
-                  <a:txBody>
-                    <a:bodyPr/>
-                    <a:lstStyle/>
-                    <a:p>
-                      <a:pPr eaLnBrk="0" latinLnBrk="0" algn="ctr" indent="0" marL="0">
-                        <a:buNone/>
-                      </a:pPr>
-                      <a:r>
-                        <a:rPr lang="en-US" sz="1050" b="1" dirty="0">
-                          <a:solidFill>
-                            <a:srgbClr val="000000"/>
-                          </a:solidFill>
-                          <a:latin typeface="맑은 고딕" pitchFamily="34" charset="0"/>
-                          <a:ea typeface="맑은 고딕" pitchFamily="34" charset="-122"/>
-                          <a:cs typeface="맑은 고딕" pitchFamily="34" charset="-120"/>
-                        </a:rPr>
-                        <a:t>비고</a:t>
-                      </a:r>
-                      <a:endParaRPr lang="en-US" sz="1050" dirty="0">
-                        <a:latin typeface="맑은 고딕" charset="0"/>
-                        <a:ea typeface="맑은 고딕" charset="0"/>
-                        <a:cs typeface="맑은 고딕" charset="0"/>
-                      </a:endParaRPr>
-                    </a:p>
-                  </a:txBody>
-                  <a:tcPr marL="38100" marR="38100" marT="38100" marB="38100" anchor="ctr">
-                    <a:lnL w="12700" cap="flat" cmpd="sng" algn="ctr">
-                      <a:solidFill>
-                        <a:srgbClr val="000000"/>
-                      </a:solidFill>
-                      <a:prstDash val="solid"/>
-                      <a:round/>
-                      <a:headEnd type="none" w="med" len="med"/>
-                      <a:tailEnd type="none" w="med" len="med"/>
-                    </a:lnL>
-                    <a:lnR w="12700" cap="flat" cmpd="sng" algn="ctr">
-                      <a:solidFill>
-                        <a:srgbClr val="000000"/>
-                      </a:solidFill>
-                      <a:prstDash val="solid"/>
-                      <a:round/>
-                      <a:headEnd type="none" w="med" len="med"/>
-                      <a:tailEnd type="none" w="med" len="med"/>
-                    </a:lnR>
-                    <a:lnT w="12700" cap="flat" cmpd="sng" algn="ctr">
-                      <a:solidFill>
-                        <a:srgbClr val="000000"/>
-                      </a:solidFill>
-                      <a:prstDash val="solid"/>
-                      <a:round/>
-                      <a:headEnd type="none" w="med" len="med"/>
-                      <a:tailEnd type="none" w="med" len="med"/>
-                    </a:lnT>
-                    <a:lnB w="12700" cap="flat" cmpd="sng" algn="ctr">
-                      <a:solidFill>
-                        <a:srgbClr val="000000"/>
-                      </a:solidFill>
-                      <a:prstDash val="solid"/>
-                      <a:round/>
-                      <a:headEnd type="none" w="med" len="med"/>
-                      <a:tailEnd type="none" w="med" len="med"/>
-                    </a:lnB>
-                    <a:solidFill>
-                      <a:srgbClr val="CCFFFF"/>
-                    </a:solidFill>
-                  </a:tcPr>
-                </a:tc>
-              </a:tr>
-              <a:tr h="402336">
-                <a:tc>
-                  <a:txBody>
-                    <a:bodyPr/>
-                    <a:lstStyle/>
-                    <a:p>
-                      <a:pPr eaLnBrk="0" latinLnBrk="0" algn="ctr" indent="0" marL="0">
-                        <a:buNone/>
-                      </a:pPr>
-                      <a:r>
-                        <a:rPr lang="en-US" sz="1200" b="1" dirty="0">
-                          <a:solidFill>
-                            <a:srgbClr val="000000"/>
-                          </a:solidFill>
-                          <a:latin typeface="맑은 고딕" pitchFamily="34" charset="0"/>
-                          <a:ea typeface="맑은 고딕" pitchFamily="34" charset="-122"/>
-                          <a:cs typeface="맑은 고딕" pitchFamily="34" charset="-120"/>
-                        </a:rPr>
-                        <a:t>1</a:t>
-                      </a:r>
-                      <a:endParaRPr lang="en-US" sz="1200" dirty="0">
-                        <a:latin typeface="맑은 고딕" charset="0"/>
-                        <a:ea typeface="맑은 고딕" charset="0"/>
-                        <a:cs typeface="맑은 고딕" charset="0"/>
-                      </a:endParaRPr>
-                    </a:p>
-                  </a:txBody>
-                  <a:tcPr marL="38100" marR="38100" marT="38100" marB="38100" anchor="ctr">
-                    <a:lnL w="12700" cap="flat" cmpd="sng" algn="ctr">
-                      <a:solidFill>
-                        <a:srgbClr val="000000"/>
-                      </a:solidFill>
-                      <a:prstDash val="solid"/>
-                      <a:round/>
-                      <a:headEnd type="none" w="med" len="med"/>
-                      <a:tailEnd type="none" w="med" len="med"/>
-                    </a:lnL>
-                    <a:lnR w="12700" cap="flat" cmpd="sng" algn="ctr">
-                      <a:solidFill>
-                        <a:srgbClr val="000000"/>
-                      </a:solidFill>
-                      <a:prstDash val="solid"/>
-                      <a:round/>
-                      <a:headEnd type="none" w="med" len="med"/>
-                      <a:tailEnd type="none" w="med" len="med"/>
-                    </a:lnR>
-                    <a:lnT w="12700" cap="flat" cmpd="sng" algn="ctr">
-                      <a:solidFill>
-                        <a:srgbClr val="000000"/>
-                      </a:solidFill>
-                      <a:prstDash val="solid"/>
-                      <a:round/>
-                      <a:headEnd type="none" w="med" len="med"/>
-                      <a:tailEnd type="none" w="med" len="med"/>
-                    </a:lnT>
-                    <a:lnB w="12700" cap="flat" cmpd="sng" algn="ctr">
-                      <a:solidFill>
-                        <a:srgbClr val="000000"/>
-                      </a:solidFill>
-                      <a:prstDash val="solid"/>
-                      <a:round/>
-                      <a:headEnd type="none" w="med" len="med"/>
-                      <a:tailEnd type="none" w="med" len="med"/>
-                    </a:lnB>
-                    <a:solidFill>
-                      <a:srgbClr val="D9F6FF"/>
-                    </a:solidFill>
-                  </a:tcPr>
-                </a:tc>
-                <a:tc>
-                  <a:txBody>
-                    <a:bodyPr/>
-                    <a:lstStyle/>
-                    <a:p>
-                      <a:pPr eaLnBrk="0" latinLnBrk="0" algn="l" indent="0" marL="0">
-                        <a:buNone/>
-                      </a:pPr>
-                      <a:r>
-                        <a:rPr lang="en-US" sz="1300" dirty="0">
-                          <a:solidFill>
-                            <a:srgbClr val="000000"/>
-                          </a:solidFill>
-                          <a:latin typeface="맑은 고딕" pitchFamily="34" charset="0"/>
-                          <a:ea typeface="맑은 고딕" pitchFamily="34" charset="-122"/>
-                          <a:cs typeface="맑은 고딕" pitchFamily="34" charset="-120"/>
-                        </a:rPr>
-                        <a:t>채용 인원 및 채용 사유</a:t>
-                      </a:r>
-                      <a:endParaRPr lang="en-US" sz="1300" dirty="0">
-                        <a:latin typeface="맑은 고딕" charset="0"/>
-                        <a:ea typeface="맑은 고딕" charset="0"/>
-                        <a:cs typeface="맑은 고딕" charset="0"/>
-                      </a:endParaRPr>
-                    </a:p>
-                  </a:txBody>
-                  <a:tcPr marL="38100" marR="38100" marT="38100" marB="38100" anchor="ctr">
-                    <a:lnL w="12700" cap="flat" cmpd="sng" algn="ctr">
-                      <a:solidFill>
-                        <a:srgbClr val="000000"/>
-                      </a:solidFill>
-                      <a:prstDash val="solid"/>
-                      <a:round/>
-                      <a:headEnd type="none" w="med" len="med"/>
-                      <a:tailEnd type="none" w="med" len="med"/>
-                    </a:lnL>
-                    <a:lnR w="12700" cap="flat" cmpd="sng" algn="ctr">
-                      <a:solidFill>
-                        <a:srgbClr val="000000"/>
-                      </a:solidFill>
-                      <a:prstDash val="solid"/>
-                      <a:round/>
-                      <a:headEnd type="none" w="med" len="med"/>
-                      <a:tailEnd type="none" w="med" len="med"/>
-                    </a:lnR>
-                    <a:lnT w="12700" cap="flat" cmpd="sng" algn="ctr">
-                      <a:solidFill>
-                        <a:srgbClr val="000000"/>
-                      </a:solidFill>
-                      <a:prstDash val="solid"/>
-                      <a:round/>
-                      <a:headEnd type="none" w="med" len="med"/>
-                      <a:tailEnd type="none" w="med" len="med"/>
-                    </a:lnT>
-                    <a:lnB w="12700" cap="flat" cmpd="sng" algn="ctr">
-                      <a:solidFill>
-                        <a:srgbClr val="000000"/>
-                      </a:solidFill>
-                      <a:prstDash val="solid"/>
-                      <a:round/>
-                      <a:headEnd type="none" w="med" len="med"/>
-                      <a:tailEnd type="none" w="med" len="med"/>
-                    </a:lnB>
-                  </a:tcPr>
-                </a:tc>
-                <a:tc>
-                  <a:txBody>
-                    <a:bodyPr/>
-                    <a:lstStyle/>
-                    <a:p>
-                      <a:pPr eaLnBrk="0" latinLnBrk="0" algn="ctr" indent="0" marL="0">
-                        <a:buNone/>
-                      </a:pPr>
-                      <a:endParaRPr lang="en-US" sz="1050" dirty="0">
-                        <a:latin typeface="맑은 고딕" charset="0"/>
-                        <a:ea typeface="맑은 고딕" charset="0"/>
-                        <a:cs typeface="맑은 고딕" charset="0"/>
-                      </a:endParaRPr>
-                    </a:p>
-                  </a:txBody>
-                  <a:tcPr marL="38100" marR="38100" marT="38100" marB="38100" anchor="ctr">
-                    <a:lnL w="12700" cap="flat" cmpd="sng" algn="ctr">
-                      <a:solidFill>
-                        <a:srgbClr val="000000"/>
-                      </a:solidFill>
-                      <a:prstDash val="solid"/>
-                      <a:round/>
-                      <a:headEnd type="none" w="med" len="med"/>
-                      <a:tailEnd type="none" w="med" len="med"/>
-                    </a:lnL>
-                    <a:lnR w="12700" cap="flat" cmpd="sng" algn="ctr">
-                      <a:solidFill>
-                        <a:srgbClr val="000000"/>
-                      </a:solidFill>
-                      <a:prstDash val="solid"/>
-                      <a:round/>
-                      <a:headEnd type="none" w="med" len="med"/>
-                      <a:tailEnd type="none" w="med" len="med"/>
-                    </a:lnR>
-                    <a:lnT w="12700" cap="flat" cmpd="sng" algn="ctr">
-                      <a:solidFill>
-                        <a:srgbClr val="000000"/>
-                      </a:solidFill>
-                      <a:prstDash val="solid"/>
-                      <a:round/>
-                      <a:headEnd type="none" w="med" len="med"/>
-                      <a:tailEnd type="none" w="med" len="med"/>
-                    </a:lnT>
-                    <a:lnB w="12700" cap="flat" cmpd="sng" algn="ctr">
-                      <a:solidFill>
-                        <a:srgbClr val="000000"/>
-                      </a:solidFill>
-                      <a:prstDash val="solid"/>
-                      <a:round/>
-                      <a:headEnd type="none" w="med" len="med"/>
-                      <a:tailEnd type="none" w="med" len="med"/>
-                    </a:lnB>
-                  </a:tcPr>
-                </a:tc>
-              </a:tr>
-              <a:tr h="402336">
-                <a:tc>
-                  <a:txBody>
-                    <a:bodyPr/>
-                    <a:lstStyle/>
-                    <a:p>
-                      <a:pPr eaLnBrk="0" latinLnBrk="0" algn="ctr" indent="0" marL="0">
-                        <a:buNone/>
-                      </a:pPr>
-                      <a:r>
-                        <a:rPr lang="en-US" sz="1200" b="1" dirty="0">
-                          <a:solidFill>
-                            <a:srgbClr val="000000"/>
-                          </a:solidFill>
-                          <a:latin typeface="맑은 고딕" pitchFamily="34" charset="0"/>
-                          <a:ea typeface="맑은 고딕" pitchFamily="34" charset="-122"/>
-                          <a:cs typeface="맑은 고딕" pitchFamily="34" charset="-120"/>
-                        </a:rPr>
-                        <a:t>2</a:t>
-                      </a:r>
-                      <a:endParaRPr lang="en-US" sz="1200" dirty="0">
-                        <a:latin typeface="맑은 고딕" charset="0"/>
-                        <a:ea typeface="맑은 고딕" charset="0"/>
-                        <a:cs typeface="맑은 고딕" charset="0"/>
-                      </a:endParaRPr>
-                    </a:p>
-                  </a:txBody>
-                  <a:tcPr marL="38100" marR="38100" marT="38100" marB="38100" anchor="ctr">
-                    <a:lnL w="12700" cap="flat" cmpd="sng" algn="ctr">
-                      <a:solidFill>
-                        <a:srgbClr val="000000"/>
-                      </a:solidFill>
-                      <a:prstDash val="solid"/>
-                      <a:round/>
-                      <a:headEnd type="none" w="med" len="med"/>
-                      <a:tailEnd type="none" w="med" len="med"/>
-                    </a:lnL>
-                    <a:lnR w="12700" cap="flat" cmpd="sng" algn="ctr">
-                      <a:solidFill>
-                        <a:srgbClr val="000000"/>
-                      </a:solidFill>
-                      <a:prstDash val="solid"/>
-                      <a:round/>
-                      <a:headEnd type="none" w="med" len="med"/>
-                      <a:tailEnd type="none" w="med" len="med"/>
-                    </a:lnR>
-                    <a:lnT w="12700" cap="flat" cmpd="sng" algn="ctr">
-                      <a:solidFill>
-                        <a:srgbClr val="000000"/>
-                      </a:solidFill>
-                      <a:prstDash val="solid"/>
-                      <a:round/>
-                      <a:headEnd type="none" w="med" len="med"/>
-                      <a:tailEnd type="none" w="med" len="med"/>
-                    </a:lnT>
-                    <a:lnB w="12700" cap="flat" cmpd="sng" algn="ctr">
-                      <a:solidFill>
-                        <a:srgbClr val="000000"/>
-                      </a:solidFill>
-                      <a:prstDash val="solid"/>
-                      <a:round/>
-                      <a:headEnd type="none" w="med" len="med"/>
-                      <a:tailEnd type="none" w="med" len="med"/>
-                    </a:lnB>
-                    <a:solidFill>
-                      <a:srgbClr val="D9F6FF"/>
-                    </a:solidFill>
-                  </a:tcPr>
-                </a:tc>
-                <a:tc>
-                  <a:txBody>
-                    <a:bodyPr/>
-                    <a:lstStyle/>
-                    <a:p>
-                      <a:pPr eaLnBrk="0" latinLnBrk="0" algn="l" indent="0" marL="0">
-                        <a:buNone/>
-                      </a:pPr>
-                      <a:r>
-                        <a:rPr lang="en-US" sz="1300" dirty="0">
-                          <a:solidFill>
-                            <a:srgbClr val="000000"/>
-                          </a:solidFill>
-                          <a:latin typeface="맑은 고딕" pitchFamily="34" charset="0"/>
-                          <a:ea typeface="맑은 고딕" pitchFamily="34" charset="-122"/>
-                          <a:cs typeface="맑은 고딕" pitchFamily="34" charset="-120"/>
-                        </a:rPr>
-                        <a:t>직원 현황</a:t>
-                      </a:r>
-                      <a:endParaRPr lang="en-US" sz="1300" dirty="0">
-                        <a:latin typeface="맑은 고딕" charset="0"/>
-                        <a:ea typeface="맑은 고딕" charset="0"/>
-                        <a:cs typeface="맑은 고딕" charset="0"/>
-                      </a:endParaRPr>
-                    </a:p>
-                  </a:txBody>
-                  <a:tcPr marL="38100" marR="38100" marT="38100" marB="38100" anchor="ctr">
-                    <a:lnL w="12700" cap="flat" cmpd="sng" algn="ctr">
-                      <a:solidFill>
-                        <a:srgbClr val="000000"/>
-                      </a:solidFill>
-                      <a:prstDash val="solid"/>
-                      <a:round/>
-                      <a:headEnd type="none" w="med" len="med"/>
-                      <a:tailEnd type="none" w="med" len="med"/>
-                    </a:lnL>
-                    <a:lnR w="12700" cap="flat" cmpd="sng" algn="ctr">
-                      <a:solidFill>
-                        <a:srgbClr val="000000"/>
-                      </a:solidFill>
-                      <a:prstDash val="solid"/>
-                      <a:round/>
-                      <a:headEnd type="none" w="med" len="med"/>
-                      <a:tailEnd type="none" w="med" len="med"/>
-                    </a:lnR>
-                    <a:lnT w="12700" cap="flat" cmpd="sng" algn="ctr">
-                      <a:solidFill>
-                        <a:srgbClr val="000000"/>
-                      </a:solidFill>
-                      <a:prstDash val="solid"/>
-                      <a:round/>
-                      <a:headEnd type="none" w="med" len="med"/>
-                      <a:tailEnd type="none" w="med" len="med"/>
-                    </a:lnT>
-                    <a:lnB w="12700" cap="flat" cmpd="sng" algn="ctr">
-                      <a:solidFill>
-                        <a:srgbClr val="000000"/>
-                      </a:solidFill>
-                      <a:prstDash val="solid"/>
-                      <a:round/>
-                      <a:headEnd type="none" w="med" len="med"/>
-                      <a:tailEnd type="none" w="med" len="med"/>
-                    </a:lnB>
-                  </a:tcPr>
-                </a:tc>
-                <a:tc>
-                  <a:txBody>
-                    <a:bodyPr/>
-                    <a:lstStyle/>
-                    <a:p>
-                      <a:pPr eaLnBrk="0" latinLnBrk="0" algn="ctr" indent="0" marL="0">
-                        <a:buNone/>
-                      </a:pPr>
-                      <a:endParaRPr lang="en-US" sz="1050" dirty="0">
-                        <a:latin typeface="맑은 고딕" charset="0"/>
-                        <a:ea typeface="맑은 고딕" charset="0"/>
-                        <a:cs typeface="맑은 고딕" charset="0"/>
-                      </a:endParaRPr>
-                    </a:p>
-                  </a:txBody>
-                  <a:tcPr marL="38100" marR="38100" marT="38100" marB="38100" anchor="ctr">
-                    <a:lnL w="12700" cap="flat" cmpd="sng" algn="ctr">
-                      <a:solidFill>
-                        <a:srgbClr val="000000"/>
-                      </a:solidFill>
-                      <a:prstDash val="solid"/>
-                      <a:round/>
-                      <a:headEnd type="none" w="med" len="med"/>
-                      <a:tailEnd type="none" w="med" len="med"/>
-                    </a:lnL>
-                    <a:lnR w="12700" cap="flat" cmpd="sng" algn="ctr">
-                      <a:solidFill>
-                        <a:srgbClr val="000000"/>
-                      </a:solidFill>
-                      <a:prstDash val="solid"/>
-                      <a:round/>
-                      <a:headEnd type="none" w="med" len="med"/>
-                      <a:tailEnd type="none" w="med" len="med"/>
-                    </a:lnR>
-                    <a:lnT w="12700" cap="flat" cmpd="sng" algn="ctr">
-                      <a:solidFill>
-                        <a:srgbClr val="000000"/>
-                      </a:solidFill>
-                      <a:prstDash val="solid"/>
-                      <a:round/>
-                      <a:headEnd type="none" w="med" len="med"/>
-                      <a:tailEnd type="none" w="med" len="med"/>
-                    </a:lnT>
-                    <a:lnB w="12700" cap="flat" cmpd="sng" algn="ctr">
-                      <a:solidFill>
-                        <a:srgbClr val="000000"/>
-                      </a:solidFill>
-                      <a:prstDash val="solid"/>
-                      <a:round/>
-                      <a:headEnd type="none" w="med" len="med"/>
-                      <a:tailEnd type="none" w="med" len="med"/>
-                    </a:lnB>
-                  </a:tcPr>
-                </a:tc>
-              </a:tr>
-              <a:tr h="402336">
-                <a:tc>
-                  <a:txBody>
-                    <a:bodyPr/>
-                    <a:lstStyle/>
-                    <a:p>
-                      <a:pPr eaLnBrk="0" latinLnBrk="0" algn="ctr" indent="0" marL="0">
-                        <a:buNone/>
-                      </a:pPr>
-                      <a:r>
-                        <a:rPr lang="en-US" sz="1200" b="1" dirty="0">
-                          <a:solidFill>
-                            <a:srgbClr val="000000"/>
-                          </a:solidFill>
-                          <a:latin typeface="맑은 고딕" pitchFamily="34" charset="0"/>
-                          <a:ea typeface="맑은 고딕" pitchFamily="34" charset="-122"/>
-                          <a:cs typeface="맑은 고딕" pitchFamily="34" charset="-120"/>
-                        </a:rPr>
-                        <a:t>3</a:t>
-                      </a:r>
-                      <a:endParaRPr lang="en-US" sz="1200" dirty="0">
-                        <a:latin typeface="맑은 고딕" charset="0"/>
-                        <a:ea typeface="맑은 고딕" charset="0"/>
-                        <a:cs typeface="맑은 고딕" charset="0"/>
-                      </a:endParaRPr>
-                    </a:p>
-                  </a:txBody>
-                  <a:tcPr marL="38100" marR="38100" marT="38100" marB="38100" anchor="ctr">
-                    <a:lnL w="12700" cap="flat" cmpd="sng" algn="ctr">
-                      <a:solidFill>
-                        <a:srgbClr val="000000"/>
-                      </a:solidFill>
-                      <a:prstDash val="solid"/>
-                      <a:round/>
-                      <a:headEnd type="none" w="med" len="med"/>
-                      <a:tailEnd type="none" w="med" len="med"/>
-                    </a:lnL>
-                    <a:lnR w="12700" cap="flat" cmpd="sng" algn="ctr">
-                      <a:solidFill>
-                        <a:srgbClr val="000000"/>
-                      </a:solidFill>
-                      <a:prstDash val="solid"/>
-                      <a:round/>
-                      <a:headEnd type="none" w="med" len="med"/>
-                      <a:tailEnd type="none" w="med" len="med"/>
-                    </a:lnR>
-                    <a:lnT w="12700" cap="flat" cmpd="sng" algn="ctr">
-                      <a:solidFill>
-                        <a:srgbClr val="000000"/>
-                      </a:solidFill>
-                      <a:prstDash val="solid"/>
-                      <a:round/>
-                      <a:headEnd type="none" w="med" len="med"/>
-                      <a:tailEnd type="none" w="med" len="med"/>
-                    </a:lnT>
-                    <a:lnB w="12700" cap="flat" cmpd="sng" algn="ctr">
-                      <a:solidFill>
-                        <a:srgbClr val="000000"/>
-                      </a:solidFill>
-                      <a:prstDash val="solid"/>
-                      <a:round/>
-                      <a:headEnd type="none" w="med" len="med"/>
-                      <a:tailEnd type="none" w="med" len="med"/>
-                    </a:lnB>
-                    <a:solidFill>
-                      <a:srgbClr val="D9F6FF"/>
-                    </a:solidFill>
-                  </a:tcPr>
-                </a:tc>
-                <a:tc>
-                  <a:txBody>
-                    <a:bodyPr/>
-                    <a:lstStyle/>
-                    <a:p>
-                      <a:pPr eaLnBrk="0" latinLnBrk="0" algn="l" indent="0" marL="0">
-                        <a:buNone/>
-                      </a:pPr>
-                      <a:r>
-                        <a:rPr lang="en-US" sz="1300" dirty="0">
-                          <a:solidFill>
-                            <a:srgbClr val="000000"/>
-                          </a:solidFill>
-                          <a:latin typeface="맑은 고딕" pitchFamily="34" charset="0"/>
-                          <a:ea typeface="맑은 고딕" pitchFamily="34" charset="-122"/>
-                          <a:cs typeface="맑은 고딕" pitchFamily="34" charset="-120"/>
-                        </a:rPr>
-                        <a:t>채용 계획</a:t>
-                      </a:r>
-                      <a:endParaRPr lang="en-US" sz="1300" dirty="0">
-                        <a:latin typeface="맑은 고딕" charset="0"/>
-                        <a:ea typeface="맑은 고딕" charset="0"/>
-                        <a:cs typeface="맑은 고딕" charset="0"/>
-                      </a:endParaRPr>
-                    </a:p>
-                  </a:txBody>
-                  <a:tcPr marL="38100" marR="38100" marT="38100" marB="38100" anchor="ctr">
-                    <a:lnL w="12700" cap="flat" cmpd="sng" algn="ctr">
-                      <a:solidFill>
-                        <a:srgbClr val="000000"/>
-                      </a:solidFill>
-                      <a:prstDash val="solid"/>
-                      <a:round/>
-                      <a:headEnd type="none" w="med" len="med"/>
-                      <a:tailEnd type="none" w="med" len="med"/>
-                    </a:lnL>
-                    <a:lnR w="12700" cap="flat" cmpd="sng" algn="ctr">
-                      <a:solidFill>
-                        <a:srgbClr val="000000"/>
-                      </a:solidFill>
-                      <a:prstDash val="solid"/>
-                      <a:round/>
-                      <a:headEnd type="none" w="med" len="med"/>
-                      <a:tailEnd type="none" w="med" len="med"/>
-                    </a:lnR>
-                    <a:lnT w="12700" cap="flat" cmpd="sng" algn="ctr">
-                      <a:solidFill>
-                        <a:srgbClr val="000000"/>
-                      </a:solidFill>
-                      <a:prstDash val="solid"/>
-                      <a:round/>
-                      <a:headEnd type="none" w="med" len="med"/>
-                      <a:tailEnd type="none" w="med" len="med"/>
-                    </a:lnT>
-                    <a:lnB w="12700" cap="flat" cmpd="sng" algn="ctr">
-                      <a:solidFill>
-                        <a:srgbClr val="000000"/>
-                      </a:solidFill>
-                      <a:prstDash val="solid"/>
-                      <a:round/>
-                      <a:headEnd type="none" w="med" len="med"/>
-                      <a:tailEnd type="none" w="med" len="med"/>
-                    </a:lnB>
-                  </a:tcPr>
-                </a:tc>
-                <a:tc>
-                  <a:txBody>
-                    <a:bodyPr/>
-                    <a:lstStyle/>
-                    <a:p>
-                      <a:pPr eaLnBrk="0" latinLnBrk="0" algn="ctr" indent="0" marL="0">
-                        <a:buNone/>
-                      </a:pPr>
-                      <a:endParaRPr lang="en-US" sz="1050" dirty="0">
-                        <a:latin typeface="맑은 고딕" charset="0"/>
-                        <a:ea typeface="맑은 고딕" charset="0"/>
-                        <a:cs typeface="맑은 고딕" charset="0"/>
-                      </a:endParaRPr>
-                    </a:p>
-                  </a:txBody>
-                  <a:tcPr marL="38100" marR="38100" marT="38100" marB="38100" anchor="ctr">
-                    <a:lnL w="12700" cap="flat" cmpd="sng" algn="ctr">
-                      <a:solidFill>
-                        <a:srgbClr val="000000"/>
-                      </a:solidFill>
-                      <a:prstDash val="solid"/>
-                      <a:round/>
-                      <a:headEnd type="none" w="med" len="med"/>
-                      <a:tailEnd type="none" w="med" len="med"/>
-                    </a:lnL>
-                    <a:lnR w="12700" cap="flat" cmpd="sng" algn="ctr">
-                      <a:solidFill>
-                        <a:srgbClr val="000000"/>
-                      </a:solidFill>
-                      <a:prstDash val="solid"/>
-                      <a:round/>
-                      <a:headEnd type="none" w="med" len="med"/>
-                      <a:tailEnd type="none" w="med" len="med"/>
-                    </a:lnR>
-                    <a:lnT w="12700" cap="flat" cmpd="sng" algn="ctr">
-                      <a:solidFill>
-                        <a:srgbClr val="000000"/>
-                      </a:solidFill>
-                      <a:prstDash val="solid"/>
-                      <a:round/>
-                      <a:headEnd type="none" w="med" len="med"/>
-                      <a:tailEnd type="none" w="med" len="med"/>
-                    </a:lnT>
-                    <a:lnB w="12700" cap="flat" cmpd="sng" algn="ctr">
-                      <a:solidFill>
-                        <a:srgbClr val="000000"/>
-                      </a:solidFill>
-                      <a:prstDash val="solid"/>
-                      <a:round/>
-                      <a:headEnd type="none" w="med" len="med"/>
-                      <a:tailEnd type="none" w="med" len="med"/>
-                    </a:lnB>
-                  </a:tcPr>
-                </a:tc>
-              </a:tr>
-              <a:tr h="402336">
-                <a:tc>
-                  <a:txBody>
-                    <a:bodyPr/>
-                    <a:lstStyle/>
-                    <a:p>
-                      <a:pPr eaLnBrk="0" latinLnBrk="0" algn="ctr" indent="0" marL="0">
-                        <a:buNone/>
-                      </a:pPr>
-                      <a:r>
-                        <a:rPr lang="en-US" sz="1200" b="1" dirty="0">
-                          <a:solidFill>
-                            <a:srgbClr val="000000"/>
-                          </a:solidFill>
-                          <a:latin typeface="맑은 고딕" pitchFamily="34" charset="0"/>
-                          <a:ea typeface="맑은 고딕" pitchFamily="34" charset="-122"/>
-                          <a:cs typeface="맑은 고딕" pitchFamily="34" charset="-120"/>
-                        </a:rPr>
-                        <a:t>4</a:t>
-                      </a:r>
-                      <a:endParaRPr lang="en-US" sz="1200" dirty="0">
-                        <a:latin typeface="맑은 고딕" charset="0"/>
-                        <a:ea typeface="맑은 고딕" charset="0"/>
-                        <a:cs typeface="맑은 고딕" charset="0"/>
-                      </a:endParaRPr>
-                    </a:p>
-                  </a:txBody>
-                  <a:tcPr marL="38100" marR="38100" marT="38100" marB="38100" anchor="ctr">
-                    <a:lnL w="12700" cap="flat" cmpd="sng" algn="ctr">
-                      <a:solidFill>
-                        <a:srgbClr val="000000"/>
-                      </a:solidFill>
-                      <a:prstDash val="solid"/>
-                      <a:round/>
-                      <a:headEnd type="none" w="med" len="med"/>
-                      <a:tailEnd type="none" w="med" len="med"/>
-                    </a:lnL>
-                    <a:lnR w="12700" cap="flat" cmpd="sng" algn="ctr">
-                      <a:solidFill>
-                        <a:srgbClr val="000000"/>
-                      </a:solidFill>
-                      <a:prstDash val="solid"/>
-                      <a:round/>
-                      <a:headEnd type="none" w="med" len="med"/>
-                      <a:tailEnd type="none" w="med" len="med"/>
-                    </a:lnR>
-                    <a:lnT w="12700" cap="flat" cmpd="sng" algn="ctr">
-                      <a:solidFill>
-                        <a:srgbClr val="000000"/>
-                      </a:solidFill>
-                      <a:prstDash val="solid"/>
-                      <a:round/>
-                      <a:headEnd type="none" w="med" len="med"/>
-                      <a:tailEnd type="none" w="med" len="med"/>
-                    </a:lnT>
-                    <a:lnB w="12700" cap="flat" cmpd="sng" algn="ctr">
-                      <a:solidFill>
-                        <a:srgbClr val="000000"/>
-                      </a:solidFill>
-                      <a:prstDash val="solid"/>
-                      <a:round/>
-                      <a:headEnd type="none" w="med" len="med"/>
-                      <a:tailEnd type="none" w="med" len="med"/>
-                    </a:lnB>
-                    <a:solidFill>
-                      <a:srgbClr val="D9F6FF"/>
-                    </a:solidFill>
-                  </a:tcPr>
-                </a:tc>
-                <a:tc>
-                  <a:txBody>
-                    <a:bodyPr/>
-                    <a:lstStyle/>
-                    <a:p>
-                      <a:pPr eaLnBrk="0" latinLnBrk="0" algn="l" indent="0" marL="0">
-                        <a:buNone/>
-                      </a:pPr>
-                      <a:r>
-                        <a:rPr lang="en-US" sz="1300" dirty="0">
-                          <a:solidFill>
-                            <a:srgbClr val="000000"/>
-                          </a:solidFill>
-                          <a:latin typeface="맑은 고딕" pitchFamily="34" charset="0"/>
-                          <a:ea typeface="맑은 고딕" pitchFamily="34" charset="-122"/>
-                          <a:cs typeface="맑은 고딕" pitchFamily="34" charset="-120"/>
-                        </a:rPr>
-                        <a:t>전형 절차</a:t>
-                      </a:r>
-                      <a:endParaRPr lang="en-US" sz="1300" dirty="0">
-                        <a:latin typeface="맑은 고딕" charset="0"/>
-                        <a:ea typeface="맑은 고딕" charset="0"/>
-                        <a:cs typeface="맑은 고딕" charset="0"/>
-                      </a:endParaRPr>
-                    </a:p>
-                  </a:txBody>
-                  <a:tcPr marL="38100" marR="38100" marT="38100" marB="38100" anchor="ctr">
-                    <a:lnL w="12700" cap="flat" cmpd="sng" algn="ctr">
-                      <a:solidFill>
-                        <a:srgbClr val="000000"/>
-                      </a:solidFill>
-                      <a:prstDash val="solid"/>
-                      <a:round/>
-                      <a:headEnd type="none" w="med" len="med"/>
-                      <a:tailEnd type="none" w="med" len="med"/>
-                    </a:lnL>
-                    <a:lnR w="12700" cap="flat" cmpd="sng" algn="ctr">
-                      <a:solidFill>
-                        <a:srgbClr val="000000"/>
-                      </a:solidFill>
-                      <a:prstDash val="solid"/>
-                      <a:round/>
-                      <a:headEnd type="none" w="med" len="med"/>
-                      <a:tailEnd type="none" w="med" len="med"/>
-                    </a:lnR>
-                    <a:lnT w="12700" cap="flat" cmpd="sng" algn="ctr">
-                      <a:solidFill>
-                        <a:srgbClr val="000000"/>
-                      </a:solidFill>
-                      <a:prstDash val="solid"/>
-                      <a:round/>
-                      <a:headEnd type="none" w="med" len="med"/>
-                      <a:tailEnd type="none" w="med" len="med"/>
-                    </a:lnT>
-                    <a:lnB w="12700" cap="flat" cmpd="sng" algn="ctr">
-                      <a:solidFill>
-                        <a:srgbClr val="000000"/>
-                      </a:solidFill>
-                      <a:prstDash val="solid"/>
-                      <a:round/>
-                      <a:headEnd type="none" w="med" len="med"/>
-                      <a:tailEnd type="none" w="med" len="med"/>
-                    </a:lnB>
-                  </a:tcPr>
-                </a:tc>
-                <a:tc>
-                  <a:txBody>
-                    <a:bodyPr/>
-                    <a:lstStyle/>
-                    <a:p>
-                      <a:pPr eaLnBrk="0" latinLnBrk="0" algn="ctr" indent="0" marL="0">
-                        <a:buNone/>
-                      </a:pPr>
-                      <a:endParaRPr lang="en-US" sz="1050" dirty="0">
-                        <a:latin typeface="맑은 고딕" charset="0"/>
-                        <a:ea typeface="맑은 고딕" charset="0"/>
-                        <a:cs typeface="맑은 고딕" charset="0"/>
-                      </a:endParaRPr>
-                    </a:p>
-                  </a:txBody>
-                  <a:tcPr marL="38100" marR="38100" marT="38100" marB="38100" anchor="ctr">
-                    <a:lnL w="12700" cap="flat" cmpd="sng" algn="ctr">
-                      <a:solidFill>
-                        <a:srgbClr val="000000"/>
-                      </a:solidFill>
-                      <a:prstDash val="solid"/>
-                      <a:round/>
-                      <a:headEnd type="none" w="med" len="med"/>
-                      <a:tailEnd type="none" w="med" len="med"/>
-                    </a:lnL>
-                    <a:lnR w="12700" cap="flat" cmpd="sng" algn="ctr">
-                      <a:solidFill>
-                        <a:srgbClr val="000000"/>
-                      </a:solidFill>
-                      <a:prstDash val="solid"/>
-                      <a:round/>
-                      <a:headEnd type="none" w="med" len="med"/>
-                      <a:tailEnd type="none" w="med" len="med"/>
-                    </a:lnR>
-                    <a:lnT w="12700" cap="flat" cmpd="sng" algn="ctr">
-                      <a:solidFill>
-                        <a:srgbClr val="000000"/>
-                      </a:solidFill>
-                      <a:prstDash val="solid"/>
-                      <a:round/>
-                      <a:headEnd type="none" w="med" len="med"/>
-                      <a:tailEnd type="none" w="med" len="med"/>
-                    </a:lnT>
-                    <a:lnB w="12700" cap="flat" cmpd="sng" algn="ctr">
-                      <a:solidFill>
-                        <a:srgbClr val="000000"/>
-                      </a:solidFill>
-                      <a:prstDash val="solid"/>
-                      <a:round/>
-                      <a:headEnd type="none" w="med" len="med"/>
-                      <a:tailEnd type="none" w="med" len="med"/>
-                    </a:lnB>
-                  </a:tcPr>
-                </a:tc>
-              </a:tr>
-              <a:tr h="402336">
-                <a:tc>
-                  <a:txBody>
-                    <a:bodyPr/>
-                    <a:lstStyle/>
-                    <a:p>
-                      <a:pPr eaLnBrk="0" latinLnBrk="0" algn="ctr" indent="0" marL="0">
-                        <a:buNone/>
-                      </a:pPr>
-                      <a:r>
-                        <a:rPr lang="en-US" sz="1200" b="1" dirty="0">
-                          <a:solidFill>
-                            <a:srgbClr val="000000"/>
-                          </a:solidFill>
-                          <a:latin typeface="맑은 고딕" pitchFamily="34" charset="0"/>
-                          <a:ea typeface="맑은 고딕" pitchFamily="34" charset="-122"/>
-                          <a:cs typeface="맑은 고딕" pitchFamily="34" charset="-120"/>
-                        </a:rPr>
-                        <a:t>5</a:t>
-                      </a:r>
-                      <a:endParaRPr lang="en-US" sz="1200" dirty="0">
-                        <a:latin typeface="맑은 고딕" charset="0"/>
-                        <a:ea typeface="맑은 고딕" charset="0"/>
-                        <a:cs typeface="맑은 고딕" charset="0"/>
-                      </a:endParaRPr>
-                    </a:p>
-                  </a:txBody>
-                  <a:tcPr marL="38100" marR="38100" marT="38100" marB="38100" anchor="ctr">
-                    <a:lnL w="12700" cap="flat" cmpd="sng" algn="ctr">
-                      <a:solidFill>
-                        <a:srgbClr val="000000"/>
-                      </a:solidFill>
-                      <a:prstDash val="solid"/>
-                      <a:round/>
-                      <a:headEnd type="none" w="med" len="med"/>
-                      <a:tailEnd type="none" w="med" len="med"/>
-                    </a:lnL>
-                    <a:lnR w="12700" cap="flat" cmpd="sng" algn="ctr">
-                      <a:solidFill>
-                        <a:srgbClr val="000000"/>
-                      </a:solidFill>
-                      <a:prstDash val="solid"/>
-                      <a:round/>
-                      <a:headEnd type="none" w="med" len="med"/>
-                      <a:tailEnd type="none" w="med" len="med"/>
-                    </a:lnR>
-                    <a:lnT w="12700" cap="flat" cmpd="sng" algn="ctr">
-                      <a:solidFill>
-                        <a:srgbClr val="000000"/>
-                      </a:solidFill>
-                      <a:prstDash val="solid"/>
-                      <a:round/>
-                      <a:headEnd type="none" w="med" len="med"/>
-                      <a:tailEnd type="none" w="med" len="med"/>
-                    </a:lnT>
-                    <a:lnB w="12700" cap="flat" cmpd="sng" algn="ctr">
-                      <a:solidFill>
-                        <a:srgbClr val="000000"/>
-                      </a:solidFill>
-                      <a:prstDash val="solid"/>
-                      <a:round/>
-                      <a:headEnd type="none" w="med" len="med"/>
-                      <a:tailEnd type="none" w="med" len="med"/>
-                    </a:lnB>
-                    <a:solidFill>
-                      <a:srgbClr val="D9F6FF"/>
-                    </a:solidFill>
-                  </a:tcPr>
-                </a:tc>
-                <a:tc>
-                  <a:txBody>
-                    <a:bodyPr/>
-                    <a:lstStyle/>
-                    <a:p>
-                      <a:pPr eaLnBrk="0" latinLnBrk="0" algn="l" indent="0" marL="0">
-                        <a:buNone/>
-                      </a:pPr>
-                      <a:r>
-                        <a:rPr lang="en-US" sz="1300" dirty="0">
-                          <a:solidFill>
-                            <a:srgbClr val="000000"/>
-                          </a:solidFill>
-                          <a:latin typeface="맑은 고딕" pitchFamily="34" charset="0"/>
-                          <a:ea typeface="맑은 고딕" pitchFamily="34" charset="-122"/>
-                          <a:cs typeface="맑은 고딕" pitchFamily="34" charset="-120"/>
-                        </a:rPr>
-                        <a:t>지원서 접수</a:t>
-                      </a:r>
-                      <a:endParaRPr lang="en-US" sz="1300" dirty="0">
-                        <a:latin typeface="맑은 고딕" charset="0"/>
-                        <a:ea typeface="맑은 고딕" charset="0"/>
-                        <a:cs typeface="맑은 고딕" charset="0"/>
-                      </a:endParaRPr>
-                    </a:p>
-                  </a:txBody>
-                  <a:tcPr marL="38100" marR="38100" marT="38100" marB="38100" anchor="ctr">
-                    <a:lnL w="12700" cap="flat" cmpd="sng" algn="ctr">
-                      <a:solidFill>
-                        <a:srgbClr val="000000"/>
-                      </a:solidFill>
-                      <a:prstDash val="solid"/>
-                      <a:round/>
-                      <a:headEnd type="none" w="med" len="med"/>
-                      <a:tailEnd type="none" w="med" len="med"/>
-                    </a:lnL>
-                    <a:lnR w="12700" cap="flat" cmpd="sng" algn="ctr">
-                      <a:solidFill>
-                        <a:srgbClr val="000000"/>
-                      </a:solidFill>
-                      <a:prstDash val="solid"/>
-                      <a:round/>
-                      <a:headEnd type="none" w="med" len="med"/>
-                      <a:tailEnd type="none" w="med" len="med"/>
-                    </a:lnR>
-                    <a:lnT w="12700" cap="flat" cmpd="sng" algn="ctr">
-                      <a:solidFill>
-                        <a:srgbClr val="000000"/>
-                      </a:solidFill>
-                      <a:prstDash val="solid"/>
-                      <a:round/>
-                      <a:headEnd type="none" w="med" len="med"/>
-                      <a:tailEnd type="none" w="med" len="med"/>
-                    </a:lnT>
-                    <a:lnB w="12700" cap="flat" cmpd="sng" algn="ctr">
-                      <a:solidFill>
-                        <a:srgbClr val="000000"/>
-                      </a:solidFill>
-                      <a:prstDash val="solid"/>
-                      <a:round/>
-                      <a:headEnd type="none" w="med" len="med"/>
-                      <a:tailEnd type="none" w="med" len="med"/>
-                    </a:lnB>
-                    <a:solidFill>
-                      <a:srgbClr val="EFF9FC"/>
-                    </a:solidFill>
-                  </a:tcPr>
-                </a:tc>
-                <a:tc>
-                  <a:txBody>
-                    <a:bodyPr/>
-                    <a:lstStyle/>
-                    <a:p>
-                      <a:pPr eaLnBrk="0" latinLnBrk="0" algn="ctr" indent="0" marL="0">
-                        <a:buNone/>
-                      </a:pPr>
-                      <a:r>
-                        <a:rPr lang="en-US" sz="1050" dirty="0">
-                          <a:solidFill>
-                            <a:srgbClr val="404040"/>
-                          </a:solidFill>
-                          <a:latin typeface="맑은 고딕" pitchFamily="34" charset="0"/>
-                          <a:ea typeface="맑은 고딕" pitchFamily="34" charset="-122"/>
-                          <a:cs typeface="맑은 고딕" pitchFamily="34" charset="-120"/>
-                        </a:rPr>
-                        <a:t>전형 1단계</a:t>
-                      </a:r>
-                      <a:endParaRPr lang="en-US" sz="1050" dirty="0">
-                        <a:latin typeface="맑은 고딕" charset="0"/>
-                        <a:ea typeface="맑은 고딕" charset="0"/>
-                        <a:cs typeface="맑은 고딕" charset="0"/>
-                      </a:endParaRPr>
-                    </a:p>
-                  </a:txBody>
-                  <a:tcPr marL="38100" marR="38100" marT="38100" marB="38100" anchor="ctr">
-                    <a:lnL w="12700" cap="flat" cmpd="sng" algn="ctr">
-                      <a:solidFill>
-                        <a:srgbClr val="000000"/>
-                      </a:solidFill>
-                      <a:prstDash val="solid"/>
-                      <a:round/>
-                      <a:headEnd type="none" w="med" len="med"/>
-                      <a:tailEnd type="none" w="med" len="med"/>
-                    </a:lnL>
-                    <a:lnR w="12700" cap="flat" cmpd="sng" algn="ctr">
-                      <a:solidFill>
-                        <a:srgbClr val="000000"/>
-                      </a:solidFill>
-                      <a:prstDash val="solid"/>
-                      <a:round/>
-                      <a:headEnd type="none" w="med" len="med"/>
-                      <a:tailEnd type="none" w="med" len="med"/>
-                    </a:lnR>
-                    <a:lnT w="12700" cap="flat" cmpd="sng" algn="ctr">
-                      <a:solidFill>
-                        <a:srgbClr val="000000"/>
-                      </a:solidFill>
-                      <a:prstDash val="solid"/>
-                      <a:round/>
-                      <a:headEnd type="none" w="med" len="med"/>
-                      <a:tailEnd type="none" w="med" len="med"/>
-                    </a:lnT>
-                    <a:lnB w="12700" cap="flat" cmpd="sng" algn="ctr">
-                      <a:solidFill>
-                        <a:srgbClr val="000000"/>
-                      </a:solidFill>
-                      <a:prstDash val="solid"/>
-                      <a:round/>
-                      <a:headEnd type="none" w="med" len="med"/>
-                      <a:tailEnd type="none" w="med" len="med"/>
-                    </a:lnB>
-                    <a:solidFill>
-                      <a:srgbClr val="EFF9FC"/>
-                    </a:solidFill>
-                  </a:tcPr>
-                </a:tc>
-              </a:tr>
-              <a:tr h="402336">
-                <a:tc>
-                  <a:txBody>
-                    <a:bodyPr/>
-                    <a:lstStyle/>
-                    <a:p>
-                      <a:pPr eaLnBrk="0" latinLnBrk="0" algn="ctr" indent="0" marL="0">
-                        <a:buNone/>
-                      </a:pPr>
-                      <a:r>
-                        <a:rPr lang="en-US" sz="1200" b="1" dirty="0">
-                          <a:solidFill>
-                            <a:srgbClr val="000000"/>
-                          </a:solidFill>
-                          <a:latin typeface="맑은 고딕" pitchFamily="34" charset="0"/>
-                          <a:ea typeface="맑은 고딕" pitchFamily="34" charset="-122"/>
-                          <a:cs typeface="맑은 고딕" pitchFamily="34" charset="-120"/>
-                        </a:rPr>
-                        <a:t>6</a:t>
-                      </a:r>
-                      <a:endParaRPr lang="en-US" sz="1200" dirty="0">
-                        <a:latin typeface="맑은 고딕" charset="0"/>
-                        <a:ea typeface="맑은 고딕" charset="0"/>
-                        <a:cs typeface="맑은 고딕" charset="0"/>
-                      </a:endParaRPr>
-                    </a:p>
-                  </a:txBody>
-                  <a:tcPr marL="38100" marR="38100" marT="38100" marB="38100" anchor="ctr">
-                    <a:lnL w="12700" cap="flat" cmpd="sng" algn="ctr">
-                      <a:solidFill>
-                        <a:srgbClr val="000000"/>
-                      </a:solidFill>
-                      <a:prstDash val="solid"/>
-                      <a:round/>
-                      <a:headEnd type="none" w="med" len="med"/>
-                      <a:tailEnd type="none" w="med" len="med"/>
-                    </a:lnL>
-                    <a:lnR w="12700" cap="flat" cmpd="sng" algn="ctr">
-                      <a:solidFill>
-                        <a:srgbClr val="000000"/>
-                      </a:solidFill>
-                      <a:prstDash val="solid"/>
-                      <a:round/>
-                      <a:headEnd type="none" w="med" len="med"/>
-                      <a:tailEnd type="none" w="med" len="med"/>
-                    </a:lnR>
-                    <a:lnT w="12700" cap="flat" cmpd="sng" algn="ctr">
-                      <a:solidFill>
-                        <a:srgbClr val="000000"/>
-                      </a:solidFill>
-                      <a:prstDash val="solid"/>
-                      <a:round/>
-                      <a:headEnd type="none" w="med" len="med"/>
-                      <a:tailEnd type="none" w="med" len="med"/>
-                    </a:lnT>
-                    <a:lnB w="12700" cap="flat" cmpd="sng" algn="ctr">
-                      <a:solidFill>
-                        <a:srgbClr val="000000"/>
-                      </a:solidFill>
-                      <a:prstDash val="solid"/>
-                      <a:round/>
-                      <a:headEnd type="none" w="med" len="med"/>
-                      <a:tailEnd type="none" w="med" len="med"/>
-                    </a:lnB>
-                    <a:solidFill>
-                      <a:srgbClr val="D9F6FF"/>
-                    </a:solidFill>
-                  </a:tcPr>
-                </a:tc>
-                <a:tc>
-                  <a:txBody>
-                    <a:bodyPr/>
-                    <a:lstStyle/>
-                    <a:p>
-                      <a:pPr eaLnBrk="0" latinLnBrk="0" algn="l" indent="0" marL="0">
-                        <a:buNone/>
-                      </a:pPr>
-                      <a:r>
-                        <a:rPr lang="en-US" sz="1300" dirty="0">
-                          <a:solidFill>
-                            <a:srgbClr val="000000"/>
-                          </a:solidFill>
-                          <a:latin typeface="맑은 고딕" pitchFamily="34" charset="0"/>
-                          <a:ea typeface="맑은 고딕" pitchFamily="34" charset="-122"/>
-                          <a:cs typeface="맑은 고딕" pitchFamily="34" charset="-120"/>
-                        </a:rPr>
-                        <a:t>서류 전형 (1차)</a:t>
-                      </a:r>
-                      <a:endParaRPr lang="en-US" sz="1300" dirty="0">
-                        <a:latin typeface="맑은 고딕" charset="0"/>
-                        <a:ea typeface="맑은 고딕" charset="0"/>
-                        <a:cs typeface="맑은 고딕" charset="0"/>
-                      </a:endParaRPr>
-                    </a:p>
-                  </a:txBody>
-                  <a:tcPr marL="38100" marR="38100" marT="38100" marB="38100" anchor="ctr">
-                    <a:lnL w="12700" cap="flat" cmpd="sng" algn="ctr">
-                      <a:solidFill>
-                        <a:srgbClr val="000000"/>
-                      </a:solidFill>
-                      <a:prstDash val="solid"/>
-                      <a:round/>
-                      <a:headEnd type="none" w="med" len="med"/>
-                      <a:tailEnd type="none" w="med" len="med"/>
-                    </a:lnL>
-                    <a:lnR w="12700" cap="flat" cmpd="sng" algn="ctr">
-                      <a:solidFill>
-                        <a:srgbClr val="000000"/>
-                      </a:solidFill>
-                      <a:prstDash val="solid"/>
-                      <a:round/>
-                      <a:headEnd type="none" w="med" len="med"/>
-                      <a:tailEnd type="none" w="med" len="med"/>
-                    </a:lnR>
-                    <a:lnT w="12700" cap="flat" cmpd="sng" algn="ctr">
-                      <a:solidFill>
-                        <a:srgbClr val="000000"/>
-                      </a:solidFill>
-                      <a:prstDash val="solid"/>
-                      <a:round/>
-                      <a:headEnd type="none" w="med" len="med"/>
-                      <a:tailEnd type="none" w="med" len="med"/>
-                    </a:lnT>
-                    <a:lnB w="12700" cap="flat" cmpd="sng" algn="ctr">
-                      <a:solidFill>
-                        <a:srgbClr val="000000"/>
-                      </a:solidFill>
-                      <a:prstDash val="solid"/>
-                      <a:round/>
-                      <a:headEnd type="none" w="med" len="med"/>
-                      <a:tailEnd type="none" w="med" len="med"/>
-                    </a:lnB>
-                    <a:solidFill>
-                      <a:srgbClr val="EFF9FC"/>
-                    </a:solidFill>
-                  </a:tcPr>
-                </a:tc>
-                <a:tc>
-                  <a:txBody>
-                    <a:bodyPr/>
-                    <a:lstStyle/>
-                    <a:p>
-                      <a:pPr eaLnBrk="0" latinLnBrk="0" algn="ctr" indent="0" marL="0">
-                        <a:buNone/>
-                      </a:pPr>
-                      <a:r>
-                        <a:rPr lang="en-US" sz="1050" dirty="0">
-                          <a:solidFill>
-                            <a:srgbClr val="404040"/>
-                          </a:solidFill>
-                          <a:latin typeface="맑은 고딕" pitchFamily="34" charset="0"/>
-                          <a:ea typeface="맑은 고딕" pitchFamily="34" charset="-122"/>
-                          <a:cs typeface="맑은 고딕" pitchFamily="34" charset="-120"/>
-                        </a:rPr>
-                        <a:t>전형 2단계</a:t>
-                      </a:r>
-                      <a:endParaRPr lang="en-US" sz="1050" dirty="0">
-                        <a:latin typeface="맑은 고딕" charset="0"/>
-                        <a:ea typeface="맑은 고딕" charset="0"/>
-                        <a:cs typeface="맑은 고딕" charset="0"/>
-                      </a:endParaRPr>
-                    </a:p>
-                  </a:txBody>
-                  <a:tcPr marL="38100" marR="38100" marT="38100" marB="38100" anchor="ctr">
-                    <a:lnL w="12700" cap="flat" cmpd="sng" algn="ctr">
-                      <a:solidFill>
-                        <a:srgbClr val="000000"/>
-                      </a:solidFill>
-                      <a:prstDash val="solid"/>
-                      <a:round/>
-                      <a:headEnd type="none" w="med" len="med"/>
-                      <a:tailEnd type="none" w="med" len="med"/>
-                    </a:lnL>
-                    <a:lnR w="12700" cap="flat" cmpd="sng" algn="ctr">
-                      <a:solidFill>
-                        <a:srgbClr val="000000"/>
-                      </a:solidFill>
-                      <a:prstDash val="solid"/>
-                      <a:round/>
-                      <a:headEnd type="none" w="med" len="med"/>
-                      <a:tailEnd type="none" w="med" len="med"/>
-                    </a:lnR>
-                    <a:lnT w="12700" cap="flat" cmpd="sng" algn="ctr">
-                      <a:solidFill>
-                        <a:srgbClr val="000000"/>
-                      </a:solidFill>
-                      <a:prstDash val="solid"/>
-                      <a:round/>
-                      <a:headEnd type="none" w="med" len="med"/>
-                      <a:tailEnd type="none" w="med" len="med"/>
-                    </a:lnT>
-                    <a:lnB w="12700" cap="flat" cmpd="sng" algn="ctr">
-                      <a:solidFill>
-                        <a:srgbClr val="000000"/>
-                      </a:solidFill>
-                      <a:prstDash val="solid"/>
-                      <a:round/>
-                      <a:headEnd type="none" w="med" len="med"/>
-                      <a:tailEnd type="none" w="med" len="med"/>
-                    </a:lnB>
-                    <a:solidFill>
-                      <a:srgbClr val="EFF9FC"/>
-                    </a:solidFill>
-                  </a:tcPr>
-                </a:tc>
-              </a:tr>
-              <a:tr h="402336">
-                <a:tc>
-                  <a:txBody>
-                    <a:bodyPr/>
-                    <a:lstStyle/>
-                    <a:p>
-                      <a:pPr eaLnBrk="0" latinLnBrk="0" algn="ctr" indent="0" marL="0">
-                        <a:buNone/>
-                      </a:pPr>
-                      <a:r>
-                        <a:rPr lang="en-US" sz="1200" b="1" dirty="0">
-                          <a:solidFill>
-                            <a:srgbClr val="000000"/>
-                          </a:solidFill>
-                          <a:latin typeface="맑은 고딕" pitchFamily="34" charset="0"/>
-                          <a:ea typeface="맑은 고딕" pitchFamily="34" charset="-122"/>
-                          <a:cs typeface="맑은 고딕" pitchFamily="34" charset="-120"/>
-                        </a:rPr>
-                        <a:t>7</a:t>
-                      </a:r>
-                      <a:endParaRPr lang="en-US" sz="1200" dirty="0">
-                        <a:latin typeface="맑은 고딕" charset="0"/>
-                        <a:ea typeface="맑은 고딕" charset="0"/>
-                        <a:cs typeface="맑은 고딕" charset="0"/>
-                      </a:endParaRPr>
-                    </a:p>
-                  </a:txBody>
-                  <a:tcPr marL="38100" marR="38100" marT="38100" marB="38100" anchor="ctr">
-                    <a:lnL w="12700" cap="flat" cmpd="sng" algn="ctr">
-                      <a:solidFill>
-                        <a:srgbClr val="000000"/>
-                      </a:solidFill>
-                      <a:prstDash val="solid"/>
-                      <a:round/>
-                      <a:headEnd type="none" w="med" len="med"/>
-                      <a:tailEnd type="none" w="med" len="med"/>
-                    </a:lnL>
-                    <a:lnR w="12700" cap="flat" cmpd="sng" algn="ctr">
-                      <a:solidFill>
-                        <a:srgbClr val="000000"/>
-                      </a:solidFill>
-                      <a:prstDash val="solid"/>
-                      <a:round/>
-                      <a:headEnd type="none" w="med" len="med"/>
-                      <a:tailEnd type="none" w="med" len="med"/>
-                    </a:lnR>
-                    <a:lnT w="12700" cap="flat" cmpd="sng" algn="ctr">
-                      <a:solidFill>
-                        <a:srgbClr val="000000"/>
-                      </a:solidFill>
-                      <a:prstDash val="solid"/>
-                      <a:round/>
-                      <a:headEnd type="none" w="med" len="med"/>
-                      <a:tailEnd type="none" w="med" len="med"/>
-                    </a:lnT>
-                    <a:lnB w="12700" cap="flat" cmpd="sng" algn="ctr">
-                      <a:solidFill>
-                        <a:srgbClr val="000000"/>
-                      </a:solidFill>
-                      <a:prstDash val="solid"/>
-                      <a:round/>
-                      <a:headEnd type="none" w="med" len="med"/>
-                      <a:tailEnd type="none" w="med" len="med"/>
-                    </a:lnB>
-                    <a:solidFill>
-                      <a:srgbClr val="D9F6FF"/>
-                    </a:solidFill>
-                  </a:tcPr>
-                </a:tc>
-                <a:tc>
-                  <a:txBody>
-                    <a:bodyPr/>
-                    <a:lstStyle/>
-                    <a:p>
-                      <a:pPr eaLnBrk="0" latinLnBrk="0" algn="l" indent="0" marL="0">
-                        <a:buNone/>
-                      </a:pPr>
-                      <a:r>
-                        <a:rPr lang="en-US" sz="1300" dirty="0">
-                          <a:solidFill>
-                            <a:srgbClr val="000000"/>
-                          </a:solidFill>
-                          <a:latin typeface="맑은 고딕" pitchFamily="34" charset="0"/>
-                          <a:ea typeface="맑은 고딕" pitchFamily="34" charset="-122"/>
-                          <a:cs typeface="맑은 고딕" pitchFamily="34" charset="-120"/>
-                        </a:rPr>
-                        <a:t>업무적성 및 심층면접 (2차)</a:t>
-                      </a:r>
-                      <a:endParaRPr lang="en-US" sz="1300" dirty="0">
-                        <a:latin typeface="맑은 고딕" charset="0"/>
-                        <a:ea typeface="맑은 고딕" charset="0"/>
-                        <a:cs typeface="맑은 고딕" charset="0"/>
-                      </a:endParaRPr>
-                    </a:p>
-                  </a:txBody>
-                  <a:tcPr marL="38100" marR="38100" marT="38100" marB="38100" anchor="ctr">
-                    <a:lnL w="12700" cap="flat" cmpd="sng" algn="ctr">
-                      <a:solidFill>
-                        <a:srgbClr val="000000"/>
-                      </a:solidFill>
-                      <a:prstDash val="solid"/>
-                      <a:round/>
-                      <a:headEnd type="none" w="med" len="med"/>
-                      <a:tailEnd type="none" w="med" len="med"/>
-                    </a:lnL>
-                    <a:lnR w="12700" cap="flat" cmpd="sng" algn="ctr">
-                      <a:solidFill>
-                        <a:srgbClr val="000000"/>
-                      </a:solidFill>
-                      <a:prstDash val="solid"/>
-                      <a:round/>
-                      <a:headEnd type="none" w="med" len="med"/>
-                      <a:tailEnd type="none" w="med" len="med"/>
-                    </a:lnR>
-                    <a:lnT w="12700" cap="flat" cmpd="sng" algn="ctr">
-                      <a:solidFill>
-                        <a:srgbClr val="000000"/>
-                      </a:solidFill>
-                      <a:prstDash val="solid"/>
-                      <a:round/>
-                      <a:headEnd type="none" w="med" len="med"/>
-                      <a:tailEnd type="none" w="med" len="med"/>
-                    </a:lnT>
-                    <a:lnB w="12700" cap="flat" cmpd="sng" algn="ctr">
-                      <a:solidFill>
-                        <a:srgbClr val="000000"/>
-                      </a:solidFill>
-                      <a:prstDash val="solid"/>
-                      <a:round/>
-                      <a:headEnd type="none" w="med" len="med"/>
-                      <a:tailEnd type="none" w="med" len="med"/>
-                    </a:lnB>
-                    <a:solidFill>
-                      <a:srgbClr val="EFF9FC"/>
-                    </a:solidFill>
-                  </a:tcPr>
-                </a:tc>
-                <a:tc>
-                  <a:txBody>
-                    <a:bodyPr/>
-                    <a:lstStyle/>
-                    <a:p>
-                      <a:pPr eaLnBrk="0" latinLnBrk="0" algn="ctr" indent="0" marL="0">
-                        <a:buNone/>
-                      </a:pPr>
-                      <a:r>
-                        <a:rPr lang="en-US" sz="1050" dirty="0">
-                          <a:solidFill>
-                            <a:srgbClr val="404040"/>
-                          </a:solidFill>
-                          <a:latin typeface="맑은 고딕" pitchFamily="34" charset="0"/>
-                          <a:ea typeface="맑은 고딕" pitchFamily="34" charset="-122"/>
-                          <a:cs typeface="맑은 고딕" pitchFamily="34" charset="-120"/>
-                        </a:rPr>
-                        <a:t>전형 3단계</a:t>
-                      </a:r>
-                      <a:endParaRPr lang="en-US" sz="1050" dirty="0">
-                        <a:latin typeface="맑은 고딕" charset="0"/>
-                        <a:ea typeface="맑은 고딕" charset="0"/>
-                        <a:cs typeface="맑은 고딕" charset="0"/>
-                      </a:endParaRPr>
-                    </a:p>
-                  </a:txBody>
-                  <a:tcPr marL="38100" marR="38100" marT="38100" marB="38100" anchor="ctr">
-                    <a:lnL w="12700" cap="flat" cmpd="sng" algn="ctr">
-                      <a:solidFill>
-                        <a:srgbClr val="000000"/>
-                      </a:solidFill>
-                      <a:prstDash val="solid"/>
-                      <a:round/>
-                      <a:headEnd type="none" w="med" len="med"/>
-                      <a:tailEnd type="none" w="med" len="med"/>
-                    </a:lnL>
-                    <a:lnR w="12700" cap="flat" cmpd="sng" algn="ctr">
-                      <a:solidFill>
-                        <a:srgbClr val="000000"/>
-                      </a:solidFill>
-                      <a:prstDash val="solid"/>
-                      <a:round/>
-                      <a:headEnd type="none" w="med" len="med"/>
-                      <a:tailEnd type="none" w="med" len="med"/>
-                    </a:lnR>
-                    <a:lnT w="12700" cap="flat" cmpd="sng" algn="ctr">
-                      <a:solidFill>
-                        <a:srgbClr val="000000"/>
-                      </a:solidFill>
-                      <a:prstDash val="solid"/>
-                      <a:round/>
-                      <a:headEnd type="none" w="med" len="med"/>
-                      <a:tailEnd type="none" w="med" len="med"/>
-                    </a:lnT>
-                    <a:lnB w="12700" cap="flat" cmpd="sng" algn="ctr">
-                      <a:solidFill>
-                        <a:srgbClr val="000000"/>
-                      </a:solidFill>
-                      <a:prstDash val="solid"/>
-                      <a:round/>
-                      <a:headEnd type="none" w="med" len="med"/>
-                      <a:tailEnd type="none" w="med" len="med"/>
-                    </a:lnB>
-                    <a:solidFill>
-                      <a:srgbClr val="EFF9FC"/>
-                    </a:solidFill>
-                  </a:tcPr>
-                </a:tc>
-              </a:tr>
-              <a:tr h="402336">
-                <a:tc>
-                  <a:txBody>
-                    <a:bodyPr/>
-                    <a:lstStyle/>
-                    <a:p>
-                      <a:pPr eaLnBrk="0" latinLnBrk="0" algn="ctr" indent="0" marL="0">
-                        <a:buNone/>
-                      </a:pPr>
-                      <a:r>
-                        <a:rPr lang="en-US" sz="1200" b="1" dirty="0">
-                          <a:solidFill>
-                            <a:srgbClr val="000000"/>
-                          </a:solidFill>
-                          <a:latin typeface="맑은 고딕" pitchFamily="34" charset="0"/>
-                          <a:ea typeface="맑은 고딕" pitchFamily="34" charset="-122"/>
-                          <a:cs typeface="맑은 고딕" pitchFamily="34" charset="-120"/>
-                        </a:rPr>
-                        <a:t>8</a:t>
-                      </a:r>
-                      <a:endParaRPr lang="en-US" sz="1200" dirty="0">
-                        <a:latin typeface="맑은 고딕" charset="0"/>
-                        <a:ea typeface="맑은 고딕" charset="0"/>
-                        <a:cs typeface="맑은 고딕" charset="0"/>
-                      </a:endParaRPr>
-                    </a:p>
-                  </a:txBody>
-                  <a:tcPr marL="38100" marR="38100" marT="38100" marB="38100" anchor="ctr">
-                    <a:lnL w="12700" cap="flat" cmpd="sng" algn="ctr">
-                      <a:solidFill>
-                        <a:srgbClr val="000000"/>
-                      </a:solidFill>
-                      <a:prstDash val="solid"/>
-                      <a:round/>
-                      <a:headEnd type="none" w="med" len="med"/>
-                      <a:tailEnd type="none" w="med" len="med"/>
-                    </a:lnL>
-                    <a:lnR w="12700" cap="flat" cmpd="sng" algn="ctr">
-                      <a:solidFill>
-                        <a:srgbClr val="000000"/>
-                      </a:solidFill>
-                      <a:prstDash val="solid"/>
-                      <a:round/>
-                      <a:headEnd type="none" w="med" len="med"/>
-                      <a:tailEnd type="none" w="med" len="med"/>
-                    </a:lnR>
-                    <a:lnT w="12700" cap="flat" cmpd="sng" algn="ctr">
-                      <a:solidFill>
-                        <a:srgbClr val="000000"/>
-                      </a:solidFill>
-                      <a:prstDash val="solid"/>
-                      <a:round/>
-                      <a:headEnd type="none" w="med" len="med"/>
-                      <a:tailEnd type="none" w="med" len="med"/>
-                    </a:lnT>
-                    <a:lnB w="12700" cap="flat" cmpd="sng" algn="ctr">
-                      <a:solidFill>
-                        <a:srgbClr val="000000"/>
-                      </a:solidFill>
-                      <a:prstDash val="solid"/>
-                      <a:round/>
-                      <a:headEnd type="none" w="med" len="med"/>
-                      <a:tailEnd type="none" w="med" len="med"/>
-                    </a:lnB>
-                    <a:solidFill>
-                      <a:srgbClr val="D9F6FF"/>
-                    </a:solidFill>
-                  </a:tcPr>
-                </a:tc>
-                <a:tc>
-                  <a:txBody>
-                    <a:bodyPr/>
-                    <a:lstStyle/>
-                    <a:p>
-                      <a:pPr eaLnBrk="0" latinLnBrk="0" algn="l" indent="0" marL="0">
-                        <a:buNone/>
-                      </a:pPr>
-                      <a:r>
-                        <a:rPr lang="en-US" sz="1300" dirty="0">
-                          <a:solidFill>
-                            <a:srgbClr val="000000"/>
-                          </a:solidFill>
-                          <a:latin typeface="맑은 고딕" pitchFamily="34" charset="0"/>
-                          <a:ea typeface="맑은 고딕" pitchFamily="34" charset="-122"/>
-                          <a:cs typeface="맑은 고딕" pitchFamily="34" charset="-120"/>
-                        </a:rPr>
-                        <a:t>결격사유 검증</a:t>
-                      </a:r>
-                      <a:endParaRPr lang="en-US" sz="1300" dirty="0">
-                        <a:latin typeface="맑은 고딕" charset="0"/>
-                        <a:ea typeface="맑은 고딕" charset="0"/>
-                        <a:cs typeface="맑은 고딕" charset="0"/>
-                      </a:endParaRPr>
-                    </a:p>
-                  </a:txBody>
-                  <a:tcPr marL="38100" marR="38100" marT="38100" marB="38100" anchor="ctr">
-                    <a:lnL w="12700" cap="flat" cmpd="sng" algn="ctr">
-                      <a:solidFill>
-                        <a:srgbClr val="000000"/>
-                      </a:solidFill>
-                      <a:prstDash val="solid"/>
-                      <a:round/>
-                      <a:headEnd type="none" w="med" len="med"/>
-                      <a:tailEnd type="none" w="med" len="med"/>
-                    </a:lnL>
-                    <a:lnR w="12700" cap="flat" cmpd="sng" algn="ctr">
-                      <a:solidFill>
-                        <a:srgbClr val="000000"/>
-                      </a:solidFill>
-                      <a:prstDash val="solid"/>
-                      <a:round/>
-                      <a:headEnd type="none" w="med" len="med"/>
-                      <a:tailEnd type="none" w="med" len="med"/>
-                    </a:lnR>
-                    <a:lnT w="12700" cap="flat" cmpd="sng" algn="ctr">
-                      <a:solidFill>
-                        <a:srgbClr val="000000"/>
-                      </a:solidFill>
-                      <a:prstDash val="solid"/>
-                      <a:round/>
-                      <a:headEnd type="none" w="med" len="med"/>
-                      <a:tailEnd type="none" w="med" len="med"/>
-                    </a:lnT>
-                    <a:lnB w="12700" cap="flat" cmpd="sng" algn="ctr">
-                      <a:solidFill>
-                        <a:srgbClr val="000000"/>
-                      </a:solidFill>
-                      <a:prstDash val="solid"/>
-                      <a:round/>
-                      <a:headEnd type="none" w="med" len="med"/>
-                      <a:tailEnd type="none" w="med" len="med"/>
-                    </a:lnB>
-                    <a:solidFill>
-                      <a:srgbClr val="EFF9FC"/>
-                    </a:solidFill>
-                  </a:tcPr>
-                </a:tc>
-                <a:tc>
-                  <a:txBody>
-                    <a:bodyPr/>
-                    <a:lstStyle/>
-                    <a:p>
-                      <a:pPr eaLnBrk="0" latinLnBrk="0" algn="ctr" indent="0" marL="0">
-                        <a:buNone/>
-                      </a:pPr>
-                      <a:r>
-                        <a:rPr lang="en-US" sz="1050" dirty="0">
-                          <a:solidFill>
-                            <a:srgbClr val="404040"/>
-                          </a:solidFill>
-                          <a:latin typeface="맑은 고딕" pitchFamily="34" charset="0"/>
-                          <a:ea typeface="맑은 고딕" pitchFamily="34" charset="-122"/>
-                          <a:cs typeface="맑은 고딕" pitchFamily="34" charset="-120"/>
-                        </a:rPr>
-                        <a:t>전형 4단계</a:t>
-                      </a:r>
-                      <a:endParaRPr lang="en-US" sz="1050" dirty="0">
-                        <a:latin typeface="맑은 고딕" charset="0"/>
-                        <a:ea typeface="맑은 고딕" charset="0"/>
-                        <a:cs typeface="맑은 고딕" charset="0"/>
-                      </a:endParaRPr>
-                    </a:p>
-                  </a:txBody>
-                  <a:tcPr marL="38100" marR="38100" marT="38100" marB="38100" anchor="ctr">
-                    <a:lnL w="12700" cap="flat" cmpd="sng" algn="ctr">
-                      <a:solidFill>
-                        <a:srgbClr val="000000"/>
-                      </a:solidFill>
-                      <a:prstDash val="solid"/>
-                      <a:round/>
-                      <a:headEnd type="none" w="med" len="med"/>
-                      <a:tailEnd type="none" w="med" len="med"/>
-                    </a:lnL>
-                    <a:lnR w="12700" cap="flat" cmpd="sng" algn="ctr">
-                      <a:solidFill>
-                        <a:srgbClr val="000000"/>
-                      </a:solidFill>
-                      <a:prstDash val="solid"/>
-                      <a:round/>
-                      <a:headEnd type="none" w="med" len="med"/>
-                      <a:tailEnd type="none" w="med" len="med"/>
-                    </a:lnR>
-                    <a:lnT w="12700" cap="flat" cmpd="sng" algn="ctr">
-                      <a:solidFill>
-                        <a:srgbClr val="000000"/>
-                      </a:solidFill>
-                      <a:prstDash val="solid"/>
-                      <a:round/>
-                      <a:headEnd type="none" w="med" len="med"/>
-                      <a:tailEnd type="none" w="med" len="med"/>
-                    </a:lnT>
-                    <a:lnB w="12700" cap="flat" cmpd="sng" algn="ctr">
-                      <a:solidFill>
-                        <a:srgbClr val="000000"/>
-                      </a:solidFill>
-                      <a:prstDash val="solid"/>
-                      <a:round/>
-                      <a:headEnd type="none" w="med" len="med"/>
-                      <a:tailEnd type="none" w="med" len="med"/>
-                    </a:lnB>
-                    <a:solidFill>
-                      <a:srgbClr val="EFF9FC"/>
-                    </a:solidFill>
-                  </a:tcPr>
-                </a:tc>
-              </a:tr>
-              <a:tr h="402336">
-                <a:tc>
-                  <a:txBody>
-                    <a:bodyPr/>
-                    <a:lstStyle/>
-                    <a:p>
-                      <a:pPr eaLnBrk="0" latinLnBrk="0" algn="ctr" indent="0" marL="0">
-                        <a:buNone/>
-                      </a:pPr>
-                      <a:r>
-                        <a:rPr lang="en-US" sz="1200" b="1" dirty="0">
-                          <a:solidFill>
-                            <a:srgbClr val="000000"/>
-                          </a:solidFill>
-                          <a:latin typeface="맑은 고딕" pitchFamily="34" charset="0"/>
-                          <a:ea typeface="맑은 고딕" pitchFamily="34" charset="-122"/>
-                          <a:cs typeface="맑은 고딕" pitchFamily="34" charset="-120"/>
-                        </a:rPr>
-                        <a:t>9</a:t>
-                      </a:r>
-                      <a:endParaRPr lang="en-US" sz="1200" dirty="0">
-                        <a:latin typeface="맑은 고딕" charset="0"/>
-                        <a:ea typeface="맑은 고딕" charset="0"/>
-                        <a:cs typeface="맑은 고딕" charset="0"/>
-                      </a:endParaRPr>
-                    </a:p>
-                  </a:txBody>
-                  <a:tcPr marL="38100" marR="38100" marT="38100" marB="38100" anchor="ctr">
-                    <a:lnL w="12700" cap="flat" cmpd="sng" algn="ctr">
-                      <a:solidFill>
-                        <a:srgbClr val="000000"/>
-                      </a:solidFill>
-                      <a:prstDash val="solid"/>
-                      <a:round/>
-                      <a:headEnd type="none" w="med" len="med"/>
-                      <a:tailEnd type="none" w="med" len="med"/>
-                    </a:lnL>
-                    <a:lnR w="12700" cap="flat" cmpd="sng" algn="ctr">
-                      <a:solidFill>
-                        <a:srgbClr val="000000"/>
-                      </a:solidFill>
-                      <a:prstDash val="solid"/>
-                      <a:round/>
-                      <a:headEnd type="none" w="med" len="med"/>
-                      <a:tailEnd type="none" w="med" len="med"/>
-                    </a:lnR>
-                    <a:lnT w="12700" cap="flat" cmpd="sng" algn="ctr">
-                      <a:solidFill>
-                        <a:srgbClr val="000000"/>
-                      </a:solidFill>
-                      <a:prstDash val="solid"/>
-                      <a:round/>
-                      <a:headEnd type="none" w="med" len="med"/>
-                      <a:tailEnd type="none" w="med" len="med"/>
-                    </a:lnT>
-                    <a:lnB w="12700" cap="flat" cmpd="sng" algn="ctr">
-                      <a:solidFill>
-                        <a:srgbClr val="000000"/>
-                      </a:solidFill>
-                      <a:prstDash val="solid"/>
-                      <a:round/>
-                      <a:headEnd type="none" w="med" len="med"/>
-                      <a:tailEnd type="none" w="med" len="med"/>
-                    </a:lnB>
-                    <a:solidFill>
-                      <a:srgbClr val="D9F6FF"/>
-                    </a:solidFill>
-                  </a:tcPr>
-                </a:tc>
-                <a:tc>
-                  <a:txBody>
-                    <a:bodyPr/>
-                    <a:lstStyle/>
-                    <a:p>
-                      <a:pPr eaLnBrk="0" latinLnBrk="0" algn="l" indent="0" marL="0">
-                        <a:buNone/>
-                      </a:pPr>
-                      <a:r>
-                        <a:rPr lang="en-US" sz="1300" dirty="0">
-                          <a:solidFill>
-                            <a:srgbClr val="000000"/>
-                          </a:solidFill>
-                          <a:latin typeface="맑은 고딕" pitchFamily="34" charset="0"/>
-                          <a:ea typeface="맑은 고딕" pitchFamily="34" charset="-122"/>
-                          <a:cs typeface="맑은 고딕" pitchFamily="34" charset="-120"/>
-                        </a:rPr>
-                        <a:t>기타 사항</a:t>
-                      </a:r>
-                      <a:endParaRPr lang="en-US" sz="1300" dirty="0">
-                        <a:latin typeface="맑은 고딕" charset="0"/>
-                        <a:ea typeface="맑은 고딕" charset="0"/>
-                        <a:cs typeface="맑은 고딕" charset="0"/>
-                      </a:endParaRPr>
-                    </a:p>
-                  </a:txBody>
-                  <a:tcPr marL="38100" marR="38100" marT="38100" marB="38100" anchor="ctr">
-                    <a:lnL w="12700" cap="flat" cmpd="sng" algn="ctr">
-                      <a:solidFill>
-                        <a:srgbClr val="000000"/>
-                      </a:solidFill>
-                      <a:prstDash val="solid"/>
-                      <a:round/>
-                      <a:headEnd type="none" w="med" len="med"/>
-                      <a:tailEnd type="none" w="med" len="med"/>
-                    </a:lnL>
-                    <a:lnR w="12700" cap="flat" cmpd="sng" algn="ctr">
-                      <a:solidFill>
-                        <a:srgbClr val="000000"/>
-                      </a:solidFill>
-                      <a:prstDash val="solid"/>
-                      <a:round/>
-                      <a:headEnd type="none" w="med" len="med"/>
-                      <a:tailEnd type="none" w="med" len="med"/>
-                    </a:lnR>
-                    <a:lnT w="12700" cap="flat" cmpd="sng" algn="ctr">
-                      <a:solidFill>
-                        <a:srgbClr val="000000"/>
-                      </a:solidFill>
-                      <a:prstDash val="solid"/>
-                      <a:round/>
-                      <a:headEnd type="none" w="med" len="med"/>
-                      <a:tailEnd type="none" w="med" len="med"/>
-                    </a:lnT>
-                    <a:lnB w="12700" cap="flat" cmpd="sng" algn="ctr">
-                      <a:solidFill>
-                        <a:srgbClr val="000000"/>
-                      </a:solidFill>
-                      <a:prstDash val="solid"/>
-                      <a:round/>
-                      <a:headEnd type="none" w="med" len="med"/>
-                      <a:tailEnd type="none" w="med" len="med"/>
-                    </a:lnB>
-                  </a:tcPr>
-                </a:tc>
-                <a:tc>
-                  <a:txBody>
-                    <a:bodyPr/>
-                    <a:lstStyle/>
-                    <a:p>
-                      <a:pPr eaLnBrk="0" latinLnBrk="0" algn="ctr" indent="0" marL="0">
-                        <a:buNone/>
-                      </a:pPr>
-                      <a:endParaRPr lang="en-US" sz="1050" dirty="0">
-                        <a:latin typeface="맑은 고딕" charset="0"/>
-                        <a:ea typeface="맑은 고딕" charset="0"/>
-                        <a:cs typeface="맑은 고딕" charset="0"/>
-                      </a:endParaRPr>
-                    </a:p>
-                  </a:txBody>
-                  <a:tcPr marL="38100" marR="38100" marT="38100" marB="38100" anchor="ctr">
-                    <a:lnL w="12700" cap="flat" cmpd="sng" algn="ctr">
-                      <a:solidFill>
-                        <a:srgbClr val="000000"/>
-                      </a:solidFill>
-                      <a:prstDash val="solid"/>
-                      <a:round/>
-                      <a:headEnd type="none" w="med" len="med"/>
-                      <a:tailEnd type="none" w="med" len="med"/>
-                    </a:lnL>
-                    <a:lnR w="12700" cap="flat" cmpd="sng" algn="ctr">
-                      <a:solidFill>
-                        <a:srgbClr val="000000"/>
-                      </a:solidFill>
-                      <a:prstDash val="solid"/>
-                      <a:round/>
-                      <a:headEnd type="none" w="med" len="med"/>
-                      <a:tailEnd type="none" w="med" len="med"/>
-                    </a:lnR>
-                    <a:lnT w="12700" cap="flat" cmpd="sng" algn="ctr">
-                      <a:solidFill>
-                        <a:srgbClr val="000000"/>
-                      </a:solidFill>
-                      <a:prstDash val="solid"/>
-                      <a:round/>
-                      <a:headEnd type="none" w="med" len="med"/>
-                      <a:tailEnd type="none" w="med" len="med"/>
-                    </a:lnT>
-                    <a:lnB w="12700" cap="flat" cmpd="sng" algn="ctr">
-                      <a:solidFill>
-                        <a:srgbClr val="000000"/>
-                      </a:solidFill>
-                      <a:prstDash val="solid"/>
-                      <a:round/>
-                      <a:headEnd type="none" w="med" len="med"/>
-                      <a:tailEnd type="none" w="med" len="med"/>
-                    </a:lnB>
-                  </a:tcPr>
-                </a:tc>
-              </a:tr>
-              <a:tr h="402336">
-                <a:tc>
-                  <a:txBody>
-                    <a:bodyPr/>
-                    <a:lstStyle/>
-                    <a:p>
-                      <a:pPr eaLnBrk="0" latinLnBrk="0" algn="ctr" indent="0" marL="0">
-                        <a:buNone/>
-                      </a:pPr>
-                      <a:r>
-                        <a:rPr lang="en-US" sz="1200" b="1" dirty="0">
-                          <a:solidFill>
-                            <a:srgbClr val="000000"/>
-                          </a:solidFill>
-                          <a:latin typeface="맑은 고딕" pitchFamily="34" charset="0"/>
-                          <a:ea typeface="맑은 고딕" pitchFamily="34" charset="-122"/>
-                          <a:cs typeface="맑은 고딕" pitchFamily="34" charset="-120"/>
-                        </a:rPr>
-                        <a:t>10</a:t>
-                      </a:r>
-                      <a:endParaRPr lang="en-US" sz="1200" dirty="0">
-                        <a:latin typeface="맑은 고딕" charset="0"/>
-                        <a:ea typeface="맑은 고딕" charset="0"/>
-                        <a:cs typeface="맑은 고딕" charset="0"/>
-                      </a:endParaRPr>
-                    </a:p>
-                  </a:txBody>
-                  <a:tcPr marL="38100" marR="38100" marT="38100" marB="38100" anchor="ctr">
-                    <a:lnL w="12700" cap="flat" cmpd="sng" algn="ctr">
-                      <a:solidFill>
-                        <a:srgbClr val="000000"/>
-                      </a:solidFill>
-                      <a:prstDash val="solid"/>
-                      <a:round/>
-                      <a:headEnd type="none" w="med" len="med"/>
-                      <a:tailEnd type="none" w="med" len="med"/>
-                    </a:lnL>
-                    <a:lnR w="12700" cap="flat" cmpd="sng" algn="ctr">
-                      <a:solidFill>
-                        <a:srgbClr val="000000"/>
-                      </a:solidFill>
-                      <a:prstDash val="solid"/>
-                      <a:round/>
-                      <a:headEnd type="none" w="med" len="med"/>
-                      <a:tailEnd type="none" w="med" len="med"/>
-                    </a:lnR>
-                    <a:lnT w="12700" cap="flat" cmpd="sng" algn="ctr">
-                      <a:solidFill>
-                        <a:srgbClr val="000000"/>
-                      </a:solidFill>
-                      <a:prstDash val="solid"/>
-                      <a:round/>
-                      <a:headEnd type="none" w="med" len="med"/>
-                      <a:tailEnd type="none" w="med" len="med"/>
-                    </a:lnT>
-                    <a:lnB w="12700" cap="flat" cmpd="sng" algn="ctr">
-                      <a:solidFill>
-                        <a:srgbClr val="000000"/>
-                      </a:solidFill>
-                      <a:prstDash val="solid"/>
-                      <a:round/>
-                      <a:headEnd type="none" w="med" len="med"/>
-                      <a:tailEnd type="none" w="med" len="med"/>
-                    </a:lnB>
-                    <a:solidFill>
-                      <a:srgbClr val="D9F6FF"/>
-                    </a:solidFill>
-                  </a:tcPr>
-                </a:tc>
-                <a:tc>
-                  <a:txBody>
-                    <a:bodyPr/>
-                    <a:lstStyle/>
-                    <a:p>
-                      <a:pPr eaLnBrk="0" latinLnBrk="0" algn="l" indent="0" marL="0">
-                        <a:buNone/>
-                      </a:pPr>
-                      <a:r>
-                        <a:rPr lang="en-US" sz="1300" dirty="0">
-                          <a:solidFill>
-                            <a:srgbClr val="000000"/>
-                          </a:solidFill>
-                          <a:latin typeface="맑은 고딕" pitchFamily="34" charset="0"/>
-                          <a:ea typeface="맑은 고딕" pitchFamily="34" charset="-122"/>
-                          <a:cs typeface="맑은 고딕" pitchFamily="34" charset="-120"/>
-                        </a:rPr>
-                        <a:t>채용 계획 요약</a:t>
-                      </a:r>
-                      <a:endParaRPr lang="en-US" sz="1300" dirty="0">
-                        <a:latin typeface="맑은 고딕" charset="0"/>
-                        <a:ea typeface="맑은 고딕" charset="0"/>
-                        <a:cs typeface="맑은 고딕" charset="0"/>
-                      </a:endParaRPr>
-                    </a:p>
-                  </a:txBody>
-                  <a:tcPr marL="38100" marR="38100" marT="38100" marB="38100" anchor="ctr">
-                    <a:lnL w="12700" cap="flat" cmpd="sng" algn="ctr">
-                      <a:solidFill>
-                        <a:srgbClr val="000000"/>
-                      </a:solidFill>
-                      <a:prstDash val="solid"/>
-                      <a:round/>
-                      <a:headEnd type="none" w="med" len="med"/>
-                      <a:tailEnd type="none" w="med" len="med"/>
-                    </a:lnL>
-                    <a:lnR w="12700" cap="flat" cmpd="sng" algn="ctr">
-                      <a:solidFill>
-                        <a:srgbClr val="000000"/>
-                      </a:solidFill>
-                      <a:prstDash val="solid"/>
-                      <a:round/>
-                      <a:headEnd type="none" w="med" len="med"/>
-                      <a:tailEnd type="none" w="med" len="med"/>
-                    </a:lnR>
-                    <a:lnT w="12700" cap="flat" cmpd="sng" algn="ctr">
-                      <a:solidFill>
-                        <a:srgbClr val="000000"/>
-                      </a:solidFill>
-                      <a:prstDash val="solid"/>
-                      <a:round/>
-                      <a:headEnd type="none" w="med" len="med"/>
-                      <a:tailEnd type="none" w="med" len="med"/>
-                    </a:lnT>
-                    <a:lnB w="12700" cap="flat" cmpd="sng" algn="ctr">
-                      <a:solidFill>
-                        <a:srgbClr val="000000"/>
-                      </a:solidFill>
-                      <a:prstDash val="solid"/>
-                      <a:round/>
-                      <a:headEnd type="none" w="med" len="med"/>
-                      <a:tailEnd type="none" w="med" len="med"/>
-                    </a:lnB>
-                  </a:tcPr>
-                </a:tc>
-                <a:tc>
-                  <a:txBody>
-                    <a:bodyPr/>
-                    <a:lstStyle/>
-                    <a:p>
-                      <a:pPr eaLnBrk="0" latinLnBrk="0" algn="ctr" indent="0" marL="0">
-                        <a:buNone/>
-                      </a:pPr>
-                      <a:endParaRPr lang="en-US" sz="1050" dirty="0">
-                        <a:latin typeface="맑은 고딕" charset="0"/>
-                        <a:ea typeface="맑은 고딕" charset="0"/>
-                        <a:cs typeface="맑은 고딕" charset="0"/>
-                      </a:endParaRPr>
-                    </a:p>
-                  </a:txBody>
-                  <a:tcPr marL="38100" marR="38100" marT="38100" marB="38100" anchor="ctr">
-                    <a:lnL w="12700" cap="flat" cmpd="sng" algn="ctr">
-                      <a:solidFill>
-                        <a:srgbClr val="000000"/>
-                      </a:solidFill>
-                      <a:prstDash val="solid"/>
-                      <a:round/>
-                      <a:headEnd type="none" w="med" len="med"/>
-                      <a:tailEnd type="none" w="med" len="med"/>
-                    </a:lnL>
-                    <a:lnR w="12700" cap="flat" cmpd="sng" algn="ctr">
-                      <a:solidFill>
-                        <a:srgbClr val="000000"/>
-                      </a:solidFill>
-                      <a:prstDash val="solid"/>
-                      <a:round/>
-                      <a:headEnd type="none" w="med" len="med"/>
-                      <a:tailEnd type="none" w="med" len="med"/>
-                    </a:lnR>
-                    <a:lnT w="12700" cap="flat" cmpd="sng" algn="ctr">
-                      <a:solidFill>
-                        <a:srgbClr val="000000"/>
-                      </a:solidFill>
-                      <a:prstDash val="solid"/>
-                      <a:round/>
-                      <a:headEnd type="none" w="med" len="med"/>
-                      <a:tailEnd type="none" w="med" len="med"/>
-                    </a:lnT>
-                    <a:lnB w="12700" cap="flat" cmpd="sng" algn="ctr">
-                      <a:solidFill>
-                        <a:srgbClr val="000000"/>
-                      </a:solidFill>
-                      <a:prstDash val="solid"/>
-                      <a:round/>
-                      <a:headEnd type="none" w="med" len="med"/>
-                      <a:tailEnd type="none" w="med" len="med"/>
-                    </a:lnB>
-                  </a:tcPr>
-                </a:tc>
-              </a:tr>
-            </a:tbl>
-          </a:graphicData>
-        </a:graphic>
-      </p:graphicFrame>
-      <p:sp>
-        <p:nvSpPr>
-          <p:cNvPr id="6" name="Text 3"/>
+      <p:sp>
+        <p:nvSpPr>
+          <p:cNvPr id="5" name="Shape 3"/>
+          <p:cNvSpPr/>
+          <p:nvPr/>
+        </p:nvSpPr>
+        <p:spPr>
+          <a:xfrm>
+            <a:off x="1051560" y="1188720"/>
+            <a:ext cx="7040880" cy="4443984"/>
+          </a:xfrm>
+          <a:prstGeom prst="rect">
+            <a:avLst/>
+          </a:prstGeom>
+          <a:solidFill>
+            <a:srgbClr val="FFFFFF"/>
+          </a:solidFill>
+          <a:ln w="12700">
+            <a:solidFill>
+              <a:srgbClr val="000000"/>
+            </a:solidFill>
+            <a:prstDash val="solid"/>
+          </a:ln>
+        </p:spPr>
+      </p:sp>
+      <p:sp>
+        <p:nvSpPr>
+          <p:cNvPr id="6" name="Shape 4"/>
+          <p:cNvSpPr/>
+          <p:nvPr/>
+        </p:nvSpPr>
+        <p:spPr>
+          <a:xfrm>
+            <a:off x="1069848" y="2944368"/>
+            <a:ext cx="7004304" cy="1609344"/>
+          </a:xfrm>
+          <a:prstGeom prst="rect">
+            <a:avLst/>
+          </a:prstGeom>
+          <a:solidFill>
+            <a:srgbClr val="EFF9FC"/>
+          </a:solidFill>
+          <a:ln w="6350">
+            <a:solidFill>
+              <a:srgbClr val="EFF9FC"/>
+            </a:solidFill>
+            <a:prstDash val="solid"/>
+          </a:ln>
+        </p:spPr>
+      </p:sp>
+      <p:sp>
+        <p:nvSpPr>
+          <p:cNvPr id="7" name="Text 5"/>
           <p:cNvSpPr txBox="1"/>
           <p:nvPr/>
         </p:nvSpPr>
         <p:spPr>
           <a:xfrm>
-            <a:off x="1005840" y="5669280"/>
-            <a:ext cx="7132320" cy="256032"/>
+            <a:off x="1325880" y="1389888"/>
+            <a:ext cx="502920" cy="365760"/>
+          </a:xfrm>
+          <a:prstGeom prst="rect">
+            <a:avLst/>
+          </a:prstGeom>
+          <a:noFill/>
+          <a:ln/>
+        </p:spPr>
+        <p:txBody>
+          <a:bodyPr wrap="square" lIns="0" tIns="0" rIns="0" bIns="0" rtlCol="0" anchor="ctr"/>
+          <a:lstStyle/>
+          <a:p>
+            <a:pPr eaLnBrk="0" latinLnBrk="0" algn="r" indent="0" marL="0">
+              <a:buNone/>
+            </a:pPr>
+            <a:r>
+              <a:rPr lang="en-US" sz="1600" dirty="0">
+                <a:solidFill>
+                  <a:srgbClr val="000000"/>
+                </a:solidFill>
+                <a:latin typeface="맑은 고딕" pitchFamily="34" charset="0"/>
+                <a:ea typeface="맑은 고딕" pitchFamily="34" charset="-122"/>
+                <a:cs typeface="맑은 고딕" pitchFamily="34" charset="-120"/>
+              </a:rPr>
+              <a:t>1.</a:t>
+            </a:r>
+            <a:endParaRPr lang="en-US" sz="1600" dirty="0"/>
+          </a:p>
+        </p:txBody>
+      </p:sp>
+      <p:sp>
+        <p:nvSpPr>
+          <p:cNvPr id="8" name="Text 6"/>
+          <p:cNvSpPr txBox="1"/>
+          <p:nvPr/>
+        </p:nvSpPr>
+        <p:spPr>
+          <a:xfrm>
+            <a:off x="1965960" y="1389888"/>
+            <a:ext cx="4023360" cy="365760"/>
+          </a:xfrm>
+          <a:prstGeom prst="rect">
+            <a:avLst/>
+          </a:prstGeom>
+          <a:noFill/>
+          <a:ln/>
+        </p:spPr>
+        <p:txBody>
+          <a:bodyPr wrap="square" lIns="0" tIns="0" rIns="0" bIns="0" rtlCol="0" anchor="ctr"/>
+          <a:lstStyle/>
+          <a:p>
+            <a:pPr eaLnBrk="0" latinLnBrk="0" indent="0" marL="0">
+              <a:buNone/>
+            </a:pPr>
+            <a:r>
+              <a:rPr lang="en-US" sz="1600" dirty="0">
+                <a:solidFill>
+                  <a:srgbClr val="000000"/>
+                </a:solidFill>
+                <a:latin typeface="맑은 고딕" pitchFamily="34" charset="0"/>
+                <a:ea typeface="맑은 고딕" pitchFamily="34" charset="-122"/>
+                <a:cs typeface="맑은 고딕" pitchFamily="34" charset="-120"/>
+              </a:rPr>
+              <a:t>채용 인원 및 채용 사유</a:t>
+            </a:r>
+            <a:endParaRPr lang="en-US" sz="1600" dirty="0"/>
+          </a:p>
+        </p:txBody>
+      </p:sp>
+      <p:sp>
+        <p:nvSpPr>
+          <p:cNvPr id="9" name="Text 7"/>
+          <p:cNvSpPr txBox="1"/>
+          <p:nvPr/>
+        </p:nvSpPr>
+        <p:spPr>
+          <a:xfrm>
+            <a:off x="1325880" y="1792224"/>
+            <a:ext cx="502920" cy="365760"/>
+          </a:xfrm>
+          <a:prstGeom prst="rect">
+            <a:avLst/>
+          </a:prstGeom>
+          <a:noFill/>
+          <a:ln/>
+        </p:spPr>
+        <p:txBody>
+          <a:bodyPr wrap="square" lIns="0" tIns="0" rIns="0" bIns="0" rtlCol="0" anchor="ctr"/>
+          <a:lstStyle/>
+          <a:p>
+            <a:pPr eaLnBrk="0" latinLnBrk="0" algn="r" indent="0" marL="0">
+              <a:buNone/>
+            </a:pPr>
+            <a:r>
+              <a:rPr lang="en-US" sz="1600" dirty="0">
+                <a:solidFill>
+                  <a:srgbClr val="000000"/>
+                </a:solidFill>
+                <a:latin typeface="맑은 고딕" pitchFamily="34" charset="0"/>
+                <a:ea typeface="맑은 고딕" pitchFamily="34" charset="-122"/>
+                <a:cs typeface="맑은 고딕" pitchFamily="34" charset="-120"/>
+              </a:rPr>
+              <a:t>2.</a:t>
+            </a:r>
+            <a:endParaRPr lang="en-US" sz="1600" dirty="0"/>
+          </a:p>
+        </p:txBody>
+      </p:sp>
+      <p:sp>
+        <p:nvSpPr>
+          <p:cNvPr id="10" name="Text 8"/>
+          <p:cNvSpPr txBox="1"/>
+          <p:nvPr/>
+        </p:nvSpPr>
+        <p:spPr>
+          <a:xfrm>
+            <a:off x="1965960" y="1792224"/>
+            <a:ext cx="4023360" cy="365760"/>
+          </a:xfrm>
+          <a:prstGeom prst="rect">
+            <a:avLst/>
+          </a:prstGeom>
+          <a:noFill/>
+          <a:ln/>
+        </p:spPr>
+        <p:txBody>
+          <a:bodyPr wrap="square" lIns="0" tIns="0" rIns="0" bIns="0" rtlCol="0" anchor="ctr"/>
+          <a:lstStyle/>
+          <a:p>
+            <a:pPr eaLnBrk="0" latinLnBrk="0" indent="0" marL="0">
+              <a:buNone/>
+            </a:pPr>
+            <a:r>
+              <a:rPr lang="en-US" sz="1600" dirty="0">
+                <a:solidFill>
+                  <a:srgbClr val="000000"/>
+                </a:solidFill>
+                <a:latin typeface="맑은 고딕" pitchFamily="34" charset="0"/>
+                <a:ea typeface="맑은 고딕" pitchFamily="34" charset="-122"/>
+                <a:cs typeface="맑은 고딕" pitchFamily="34" charset="-120"/>
+              </a:rPr>
+              <a:t>직원 현황</a:t>
+            </a:r>
+            <a:endParaRPr lang="en-US" sz="1600" dirty="0"/>
+          </a:p>
+        </p:txBody>
+      </p:sp>
+      <p:sp>
+        <p:nvSpPr>
+          <p:cNvPr id="11" name="Text 9"/>
+          <p:cNvSpPr txBox="1"/>
+          <p:nvPr/>
+        </p:nvSpPr>
+        <p:spPr>
+          <a:xfrm>
+            <a:off x="1325880" y="2194560"/>
+            <a:ext cx="502920" cy="365760"/>
+          </a:xfrm>
+          <a:prstGeom prst="rect">
+            <a:avLst/>
+          </a:prstGeom>
+          <a:noFill/>
+          <a:ln/>
+        </p:spPr>
+        <p:txBody>
+          <a:bodyPr wrap="square" lIns="0" tIns="0" rIns="0" bIns="0" rtlCol="0" anchor="ctr"/>
+          <a:lstStyle/>
+          <a:p>
+            <a:pPr eaLnBrk="0" latinLnBrk="0" algn="r" indent="0" marL="0">
+              <a:buNone/>
+            </a:pPr>
+            <a:r>
+              <a:rPr lang="en-US" sz="1600" dirty="0">
+                <a:solidFill>
+                  <a:srgbClr val="000000"/>
+                </a:solidFill>
+                <a:latin typeface="맑은 고딕" pitchFamily="34" charset="0"/>
+                <a:ea typeface="맑은 고딕" pitchFamily="34" charset="-122"/>
+                <a:cs typeface="맑은 고딕" pitchFamily="34" charset="-120"/>
+              </a:rPr>
+              <a:t>3.</a:t>
+            </a:r>
+            <a:endParaRPr lang="en-US" sz="1600" dirty="0"/>
+          </a:p>
+        </p:txBody>
+      </p:sp>
+      <p:sp>
+        <p:nvSpPr>
+          <p:cNvPr id="12" name="Text 10"/>
+          <p:cNvSpPr txBox="1"/>
+          <p:nvPr/>
+        </p:nvSpPr>
+        <p:spPr>
+          <a:xfrm>
+            <a:off x="1965960" y="2194560"/>
+            <a:ext cx="4023360" cy="365760"/>
+          </a:xfrm>
+          <a:prstGeom prst="rect">
+            <a:avLst/>
+          </a:prstGeom>
+          <a:noFill/>
+          <a:ln/>
+        </p:spPr>
+        <p:txBody>
+          <a:bodyPr wrap="square" lIns="0" tIns="0" rIns="0" bIns="0" rtlCol="0" anchor="ctr"/>
+          <a:lstStyle/>
+          <a:p>
+            <a:pPr eaLnBrk="0" latinLnBrk="0" indent="0" marL="0">
+              <a:buNone/>
+            </a:pPr>
+            <a:r>
+              <a:rPr lang="en-US" sz="1600" dirty="0">
+                <a:solidFill>
+                  <a:srgbClr val="000000"/>
+                </a:solidFill>
+                <a:latin typeface="맑은 고딕" pitchFamily="34" charset="0"/>
+                <a:ea typeface="맑은 고딕" pitchFamily="34" charset="-122"/>
+                <a:cs typeface="맑은 고딕" pitchFamily="34" charset="-120"/>
+              </a:rPr>
+              <a:t>채용 계획</a:t>
+            </a:r>
+            <a:endParaRPr lang="en-US" sz="1600" dirty="0"/>
+          </a:p>
+        </p:txBody>
+      </p:sp>
+      <p:sp>
+        <p:nvSpPr>
+          <p:cNvPr id="13" name="Text 11"/>
+          <p:cNvSpPr txBox="1"/>
+          <p:nvPr/>
+        </p:nvSpPr>
+        <p:spPr>
+          <a:xfrm>
+            <a:off x="1325880" y="2596896"/>
+            <a:ext cx="502920" cy="365760"/>
+          </a:xfrm>
+          <a:prstGeom prst="rect">
+            <a:avLst/>
+          </a:prstGeom>
+          <a:noFill/>
+          <a:ln/>
+        </p:spPr>
+        <p:txBody>
+          <a:bodyPr wrap="square" lIns="0" tIns="0" rIns="0" bIns="0" rtlCol="0" anchor="ctr"/>
+          <a:lstStyle/>
+          <a:p>
+            <a:pPr eaLnBrk="0" latinLnBrk="0" algn="r" indent="0" marL="0">
+              <a:buNone/>
+            </a:pPr>
+            <a:r>
+              <a:rPr lang="en-US" sz="1600" dirty="0">
+                <a:solidFill>
+                  <a:srgbClr val="000000"/>
+                </a:solidFill>
+                <a:latin typeface="맑은 고딕" pitchFamily="34" charset="0"/>
+                <a:ea typeface="맑은 고딕" pitchFamily="34" charset="-122"/>
+                <a:cs typeface="맑은 고딕" pitchFamily="34" charset="-120"/>
+              </a:rPr>
+              <a:t>4.</a:t>
+            </a:r>
+            <a:endParaRPr lang="en-US" sz="1600" dirty="0"/>
+          </a:p>
+        </p:txBody>
+      </p:sp>
+      <p:sp>
+        <p:nvSpPr>
+          <p:cNvPr id="14" name="Text 12"/>
+          <p:cNvSpPr txBox="1"/>
+          <p:nvPr/>
+        </p:nvSpPr>
+        <p:spPr>
+          <a:xfrm>
+            <a:off x="1965960" y="2596896"/>
+            <a:ext cx="4023360" cy="365760"/>
+          </a:xfrm>
+          <a:prstGeom prst="rect">
+            <a:avLst/>
+          </a:prstGeom>
+          <a:noFill/>
+          <a:ln/>
+        </p:spPr>
+        <p:txBody>
+          <a:bodyPr wrap="square" lIns="0" tIns="0" rIns="0" bIns="0" rtlCol="0" anchor="ctr"/>
+          <a:lstStyle/>
+          <a:p>
+            <a:pPr eaLnBrk="0" latinLnBrk="0" indent="0" marL="0">
+              <a:buNone/>
+            </a:pPr>
+            <a:r>
+              <a:rPr lang="en-US" sz="1600" dirty="0">
+                <a:solidFill>
+                  <a:srgbClr val="000000"/>
+                </a:solidFill>
+                <a:latin typeface="맑은 고딕" pitchFamily="34" charset="0"/>
+                <a:ea typeface="맑은 고딕" pitchFamily="34" charset="-122"/>
+                <a:cs typeface="맑은 고딕" pitchFamily="34" charset="-120"/>
+              </a:rPr>
+              <a:t>전형 절차</a:t>
+            </a:r>
+            <a:endParaRPr lang="en-US" sz="1600" dirty="0"/>
+          </a:p>
+        </p:txBody>
+      </p:sp>
+      <p:sp>
+        <p:nvSpPr>
+          <p:cNvPr id="15" name="Text 13"/>
+          <p:cNvSpPr txBox="1"/>
+          <p:nvPr/>
+        </p:nvSpPr>
+        <p:spPr>
+          <a:xfrm>
+            <a:off x="1325880" y="2999232"/>
+            <a:ext cx="502920" cy="365760"/>
+          </a:xfrm>
+          <a:prstGeom prst="rect">
+            <a:avLst/>
+          </a:prstGeom>
+          <a:noFill/>
+          <a:ln/>
+        </p:spPr>
+        <p:txBody>
+          <a:bodyPr wrap="square" lIns="0" tIns="0" rIns="0" bIns="0" rtlCol="0" anchor="ctr"/>
+          <a:lstStyle/>
+          <a:p>
+            <a:pPr eaLnBrk="0" latinLnBrk="0" algn="r" indent="0" marL="0">
+              <a:buNone/>
+            </a:pPr>
+            <a:r>
+              <a:rPr lang="en-US" sz="1600" dirty="0">
+                <a:solidFill>
+                  <a:srgbClr val="000000"/>
+                </a:solidFill>
+                <a:latin typeface="맑은 고딕" pitchFamily="34" charset="0"/>
+                <a:ea typeface="맑은 고딕" pitchFamily="34" charset="-122"/>
+                <a:cs typeface="맑은 고딕" pitchFamily="34" charset="-120"/>
+              </a:rPr>
+              <a:t>5.</a:t>
+            </a:r>
+            <a:endParaRPr lang="en-US" sz="1600" dirty="0"/>
+          </a:p>
+        </p:txBody>
+      </p:sp>
+      <p:sp>
+        <p:nvSpPr>
+          <p:cNvPr id="16" name="Text 14"/>
+          <p:cNvSpPr txBox="1"/>
+          <p:nvPr/>
+        </p:nvSpPr>
+        <p:spPr>
+          <a:xfrm>
+            <a:off x="1965960" y="2999232"/>
+            <a:ext cx="4023360" cy="365760"/>
+          </a:xfrm>
+          <a:prstGeom prst="rect">
+            <a:avLst/>
+          </a:prstGeom>
+          <a:noFill/>
+          <a:ln/>
+        </p:spPr>
+        <p:txBody>
+          <a:bodyPr wrap="square" lIns="0" tIns="0" rIns="0" bIns="0" rtlCol="0" anchor="ctr"/>
+          <a:lstStyle/>
+          <a:p>
+            <a:pPr eaLnBrk="0" latinLnBrk="0" indent="0" marL="0">
+              <a:buNone/>
+            </a:pPr>
+            <a:r>
+              <a:rPr lang="en-US" sz="1600" dirty="0">
+                <a:solidFill>
+                  <a:srgbClr val="000000"/>
+                </a:solidFill>
+                <a:latin typeface="맑은 고딕" pitchFamily="34" charset="0"/>
+                <a:ea typeface="맑은 고딕" pitchFamily="34" charset="-122"/>
+                <a:cs typeface="맑은 고딕" pitchFamily="34" charset="-120"/>
+              </a:rPr>
+              <a:t>지원서 접수</a:t>
+            </a:r>
+            <a:endParaRPr lang="en-US" sz="1600" dirty="0"/>
+          </a:p>
+        </p:txBody>
+      </p:sp>
+      <p:sp>
+        <p:nvSpPr>
+          <p:cNvPr id="17" name="Text 15"/>
+          <p:cNvSpPr txBox="1"/>
+          <p:nvPr/>
+        </p:nvSpPr>
+        <p:spPr>
+          <a:xfrm>
+            <a:off x="6035040" y="2999232"/>
+            <a:ext cx="1828800" cy="365760"/>
+          </a:xfrm>
+          <a:prstGeom prst="rect">
+            <a:avLst/>
+          </a:prstGeom>
+          <a:noFill/>
+          <a:ln/>
+        </p:spPr>
+        <p:txBody>
+          <a:bodyPr wrap="square" lIns="0" tIns="0" rIns="0" bIns="0" rtlCol="0" anchor="ctr"/>
+          <a:lstStyle/>
+          <a:p>
+            <a:pPr eaLnBrk="0" latinLnBrk="0" indent="0" marL="0">
+              <a:buNone/>
+            </a:pPr>
+            <a:r>
+              <a:rPr lang="en-US" sz="1150" dirty="0">
+                <a:solidFill>
+                  <a:srgbClr val="404040"/>
+                </a:solidFill>
+                <a:latin typeface="맑은 고딕" pitchFamily="34" charset="0"/>
+                <a:ea typeface="맑은 고딕" pitchFamily="34" charset="-122"/>
+                <a:cs typeface="맑은 고딕" pitchFamily="34" charset="-120"/>
+              </a:rPr>
+              <a:t>[ 전형 1단계 ]</a:t>
+            </a:r>
+            <a:endParaRPr lang="en-US" sz="1150" dirty="0"/>
+          </a:p>
+        </p:txBody>
+      </p:sp>
+      <p:sp>
+        <p:nvSpPr>
+          <p:cNvPr id="18" name="Text 16"/>
+          <p:cNvSpPr txBox="1"/>
+          <p:nvPr/>
+        </p:nvSpPr>
+        <p:spPr>
+          <a:xfrm>
+            <a:off x="1325880" y="3401568"/>
+            <a:ext cx="502920" cy="365760"/>
+          </a:xfrm>
+          <a:prstGeom prst="rect">
+            <a:avLst/>
+          </a:prstGeom>
+          <a:noFill/>
+          <a:ln/>
+        </p:spPr>
+        <p:txBody>
+          <a:bodyPr wrap="square" lIns="0" tIns="0" rIns="0" bIns="0" rtlCol="0" anchor="ctr"/>
+          <a:lstStyle/>
+          <a:p>
+            <a:pPr eaLnBrk="0" latinLnBrk="0" algn="r" indent="0" marL="0">
+              <a:buNone/>
+            </a:pPr>
+            <a:r>
+              <a:rPr lang="en-US" sz="1600" dirty="0">
+                <a:solidFill>
+                  <a:srgbClr val="000000"/>
+                </a:solidFill>
+                <a:latin typeface="맑은 고딕" pitchFamily="34" charset="0"/>
+                <a:ea typeface="맑은 고딕" pitchFamily="34" charset="-122"/>
+                <a:cs typeface="맑은 고딕" pitchFamily="34" charset="-120"/>
+              </a:rPr>
+              <a:t>6.</a:t>
+            </a:r>
+            <a:endParaRPr lang="en-US" sz="1600" dirty="0"/>
+          </a:p>
+        </p:txBody>
+      </p:sp>
+      <p:sp>
+        <p:nvSpPr>
+          <p:cNvPr id="19" name="Text 17"/>
+          <p:cNvSpPr txBox="1"/>
+          <p:nvPr/>
+        </p:nvSpPr>
+        <p:spPr>
+          <a:xfrm>
+            <a:off x="1965960" y="3401568"/>
+            <a:ext cx="4023360" cy="365760"/>
+          </a:xfrm>
+          <a:prstGeom prst="rect">
+            <a:avLst/>
+          </a:prstGeom>
+          <a:noFill/>
+          <a:ln/>
+        </p:spPr>
+        <p:txBody>
+          <a:bodyPr wrap="square" lIns="0" tIns="0" rIns="0" bIns="0" rtlCol="0" anchor="ctr"/>
+          <a:lstStyle/>
+          <a:p>
+            <a:pPr eaLnBrk="0" latinLnBrk="0" indent="0" marL="0">
+              <a:buNone/>
+            </a:pPr>
+            <a:r>
+              <a:rPr lang="en-US" sz="1600" dirty="0">
+                <a:solidFill>
+                  <a:srgbClr val="000000"/>
+                </a:solidFill>
+                <a:latin typeface="맑은 고딕" pitchFamily="34" charset="0"/>
+                <a:ea typeface="맑은 고딕" pitchFamily="34" charset="-122"/>
+                <a:cs typeface="맑은 고딕" pitchFamily="34" charset="-120"/>
+              </a:rPr>
+              <a:t>서류 전형 (1차)</a:t>
+            </a:r>
+            <a:endParaRPr lang="en-US" sz="1600" dirty="0"/>
+          </a:p>
+        </p:txBody>
+      </p:sp>
+      <p:sp>
+        <p:nvSpPr>
+          <p:cNvPr id="20" name="Text 18"/>
+          <p:cNvSpPr txBox="1"/>
+          <p:nvPr/>
+        </p:nvSpPr>
+        <p:spPr>
+          <a:xfrm>
+            <a:off x="6035040" y="3401568"/>
+            <a:ext cx="1828800" cy="365760"/>
+          </a:xfrm>
+          <a:prstGeom prst="rect">
+            <a:avLst/>
+          </a:prstGeom>
+          <a:noFill/>
+          <a:ln/>
+        </p:spPr>
+        <p:txBody>
+          <a:bodyPr wrap="square" lIns="0" tIns="0" rIns="0" bIns="0" rtlCol="0" anchor="ctr"/>
+          <a:lstStyle/>
+          <a:p>
+            <a:pPr eaLnBrk="0" latinLnBrk="0" indent="0" marL="0">
+              <a:buNone/>
+            </a:pPr>
+            <a:r>
+              <a:rPr lang="en-US" sz="1150" dirty="0">
+                <a:solidFill>
+                  <a:srgbClr val="404040"/>
+                </a:solidFill>
+                <a:latin typeface="맑은 고딕" pitchFamily="34" charset="0"/>
+                <a:ea typeface="맑은 고딕" pitchFamily="34" charset="-122"/>
+                <a:cs typeface="맑은 고딕" pitchFamily="34" charset="-120"/>
+              </a:rPr>
+              <a:t>[ 전형 2단계 ]</a:t>
+            </a:r>
+            <a:endParaRPr lang="en-US" sz="1150" dirty="0"/>
+          </a:p>
+        </p:txBody>
+      </p:sp>
+      <p:sp>
+        <p:nvSpPr>
+          <p:cNvPr id="21" name="Text 19"/>
+          <p:cNvSpPr txBox="1"/>
+          <p:nvPr/>
+        </p:nvSpPr>
+        <p:spPr>
+          <a:xfrm>
+            <a:off x="1325880" y="3803904"/>
+            <a:ext cx="502920" cy="365760"/>
+          </a:xfrm>
+          <a:prstGeom prst="rect">
+            <a:avLst/>
+          </a:prstGeom>
+          <a:noFill/>
+          <a:ln/>
+        </p:spPr>
+        <p:txBody>
+          <a:bodyPr wrap="square" lIns="0" tIns="0" rIns="0" bIns="0" rtlCol="0" anchor="ctr"/>
+          <a:lstStyle/>
+          <a:p>
+            <a:pPr eaLnBrk="0" latinLnBrk="0" algn="r" indent="0" marL="0">
+              <a:buNone/>
+            </a:pPr>
+            <a:r>
+              <a:rPr lang="en-US" sz="1600" dirty="0">
+                <a:solidFill>
+                  <a:srgbClr val="000000"/>
+                </a:solidFill>
+                <a:latin typeface="맑은 고딕" pitchFamily="34" charset="0"/>
+                <a:ea typeface="맑은 고딕" pitchFamily="34" charset="-122"/>
+                <a:cs typeface="맑은 고딕" pitchFamily="34" charset="-120"/>
+              </a:rPr>
+              <a:t>7.</a:t>
+            </a:r>
+            <a:endParaRPr lang="en-US" sz="1600" dirty="0"/>
+          </a:p>
+        </p:txBody>
+      </p:sp>
+      <p:sp>
+        <p:nvSpPr>
+          <p:cNvPr id="22" name="Text 20"/>
+          <p:cNvSpPr txBox="1"/>
+          <p:nvPr/>
+        </p:nvSpPr>
+        <p:spPr>
+          <a:xfrm>
+            <a:off x="1965960" y="3803904"/>
+            <a:ext cx="4023360" cy="365760"/>
+          </a:xfrm>
+          <a:prstGeom prst="rect">
+            <a:avLst/>
+          </a:prstGeom>
+          <a:noFill/>
+          <a:ln/>
+        </p:spPr>
+        <p:txBody>
+          <a:bodyPr wrap="square" lIns="0" tIns="0" rIns="0" bIns="0" rtlCol="0" anchor="ctr"/>
+          <a:lstStyle/>
+          <a:p>
+            <a:pPr eaLnBrk="0" latinLnBrk="0" indent="0" marL="0">
+              <a:buNone/>
+            </a:pPr>
+            <a:r>
+              <a:rPr lang="en-US" sz="1600" dirty="0">
+                <a:solidFill>
+                  <a:srgbClr val="000000"/>
+                </a:solidFill>
+                <a:latin typeface="맑은 고딕" pitchFamily="34" charset="0"/>
+                <a:ea typeface="맑은 고딕" pitchFamily="34" charset="-122"/>
+                <a:cs typeface="맑은 고딕" pitchFamily="34" charset="-120"/>
+              </a:rPr>
+              <a:t>업무적성 및 심층면접 (2차)</a:t>
+            </a:r>
+            <a:endParaRPr lang="en-US" sz="1600" dirty="0"/>
+          </a:p>
+        </p:txBody>
+      </p:sp>
+      <p:sp>
+        <p:nvSpPr>
+          <p:cNvPr id="23" name="Text 21"/>
+          <p:cNvSpPr txBox="1"/>
+          <p:nvPr/>
+        </p:nvSpPr>
+        <p:spPr>
+          <a:xfrm>
+            <a:off x="6035040" y="3803904"/>
+            <a:ext cx="1828800" cy="365760"/>
+          </a:xfrm>
+          <a:prstGeom prst="rect">
+            <a:avLst/>
+          </a:prstGeom>
+          <a:noFill/>
+          <a:ln/>
+        </p:spPr>
+        <p:txBody>
+          <a:bodyPr wrap="square" lIns="0" tIns="0" rIns="0" bIns="0" rtlCol="0" anchor="ctr"/>
+          <a:lstStyle/>
+          <a:p>
+            <a:pPr eaLnBrk="0" latinLnBrk="0" indent="0" marL="0">
+              <a:buNone/>
+            </a:pPr>
+            <a:r>
+              <a:rPr lang="en-US" sz="1150" dirty="0">
+                <a:solidFill>
+                  <a:srgbClr val="404040"/>
+                </a:solidFill>
+                <a:latin typeface="맑은 고딕" pitchFamily="34" charset="0"/>
+                <a:ea typeface="맑은 고딕" pitchFamily="34" charset="-122"/>
+                <a:cs typeface="맑은 고딕" pitchFamily="34" charset="-120"/>
+              </a:rPr>
+              <a:t>[ 전형 3단계 ]</a:t>
+            </a:r>
+            <a:endParaRPr lang="en-US" sz="1150" dirty="0"/>
+          </a:p>
+        </p:txBody>
+      </p:sp>
+      <p:sp>
+        <p:nvSpPr>
+          <p:cNvPr id="24" name="Text 22"/>
+          <p:cNvSpPr txBox="1"/>
+          <p:nvPr/>
+        </p:nvSpPr>
+        <p:spPr>
+          <a:xfrm>
+            <a:off x="1325880" y="4206240"/>
+            <a:ext cx="502920" cy="365760"/>
+          </a:xfrm>
+          <a:prstGeom prst="rect">
+            <a:avLst/>
+          </a:prstGeom>
+          <a:noFill/>
+          <a:ln/>
+        </p:spPr>
+        <p:txBody>
+          <a:bodyPr wrap="square" lIns="0" tIns="0" rIns="0" bIns="0" rtlCol="0" anchor="ctr"/>
+          <a:lstStyle/>
+          <a:p>
+            <a:pPr eaLnBrk="0" latinLnBrk="0" algn="r" indent="0" marL="0">
+              <a:buNone/>
+            </a:pPr>
+            <a:r>
+              <a:rPr lang="en-US" sz="1600" dirty="0">
+                <a:solidFill>
+                  <a:srgbClr val="000000"/>
+                </a:solidFill>
+                <a:latin typeface="맑은 고딕" pitchFamily="34" charset="0"/>
+                <a:ea typeface="맑은 고딕" pitchFamily="34" charset="-122"/>
+                <a:cs typeface="맑은 고딕" pitchFamily="34" charset="-120"/>
+              </a:rPr>
+              <a:t>8.</a:t>
+            </a:r>
+            <a:endParaRPr lang="en-US" sz="1600" dirty="0"/>
+          </a:p>
+        </p:txBody>
+      </p:sp>
+      <p:sp>
+        <p:nvSpPr>
+          <p:cNvPr id="25" name="Text 23"/>
+          <p:cNvSpPr txBox="1"/>
+          <p:nvPr/>
+        </p:nvSpPr>
+        <p:spPr>
+          <a:xfrm>
+            <a:off x="1965960" y="4206240"/>
+            <a:ext cx="4023360" cy="365760"/>
+          </a:xfrm>
+          <a:prstGeom prst="rect">
+            <a:avLst/>
+          </a:prstGeom>
+          <a:noFill/>
+          <a:ln/>
+        </p:spPr>
+        <p:txBody>
+          <a:bodyPr wrap="square" lIns="0" tIns="0" rIns="0" bIns="0" rtlCol="0" anchor="ctr"/>
+          <a:lstStyle/>
+          <a:p>
+            <a:pPr eaLnBrk="0" latinLnBrk="0" indent="0" marL="0">
+              <a:buNone/>
+            </a:pPr>
+            <a:r>
+              <a:rPr lang="en-US" sz="1600" dirty="0">
+                <a:solidFill>
+                  <a:srgbClr val="000000"/>
+                </a:solidFill>
+                <a:latin typeface="맑은 고딕" pitchFamily="34" charset="0"/>
+                <a:ea typeface="맑은 고딕" pitchFamily="34" charset="-122"/>
+                <a:cs typeface="맑은 고딕" pitchFamily="34" charset="-120"/>
+              </a:rPr>
+              <a:t>결격사유 검증</a:t>
+            </a:r>
+            <a:endParaRPr lang="en-US" sz="1600" dirty="0"/>
+          </a:p>
+        </p:txBody>
+      </p:sp>
+      <p:sp>
+        <p:nvSpPr>
+          <p:cNvPr id="26" name="Text 24"/>
+          <p:cNvSpPr txBox="1"/>
+          <p:nvPr/>
+        </p:nvSpPr>
+        <p:spPr>
+          <a:xfrm>
+            <a:off x="6035040" y="4206240"/>
+            <a:ext cx="1828800" cy="365760"/>
+          </a:xfrm>
+          <a:prstGeom prst="rect">
+            <a:avLst/>
+          </a:prstGeom>
+          <a:noFill/>
+          <a:ln/>
+        </p:spPr>
+        <p:txBody>
+          <a:bodyPr wrap="square" lIns="0" tIns="0" rIns="0" bIns="0" rtlCol="0" anchor="ctr"/>
+          <a:lstStyle/>
+          <a:p>
+            <a:pPr eaLnBrk="0" latinLnBrk="0" indent="0" marL="0">
+              <a:buNone/>
+            </a:pPr>
+            <a:r>
+              <a:rPr lang="en-US" sz="1150" dirty="0">
+                <a:solidFill>
+                  <a:srgbClr val="404040"/>
+                </a:solidFill>
+                <a:latin typeface="맑은 고딕" pitchFamily="34" charset="0"/>
+                <a:ea typeface="맑은 고딕" pitchFamily="34" charset="-122"/>
+                <a:cs typeface="맑은 고딕" pitchFamily="34" charset="-120"/>
+              </a:rPr>
+              <a:t>[ 전형 4단계 ]</a:t>
+            </a:r>
+            <a:endParaRPr lang="en-US" sz="1150" dirty="0"/>
+          </a:p>
+        </p:txBody>
+      </p:sp>
+      <p:sp>
+        <p:nvSpPr>
+          <p:cNvPr id="27" name="Text 25"/>
+          <p:cNvSpPr txBox="1"/>
+          <p:nvPr/>
+        </p:nvSpPr>
+        <p:spPr>
+          <a:xfrm>
+            <a:off x="1325880" y="4608576"/>
+            <a:ext cx="502920" cy="365760"/>
+          </a:xfrm>
+          <a:prstGeom prst="rect">
+            <a:avLst/>
+          </a:prstGeom>
+          <a:noFill/>
+          <a:ln/>
+        </p:spPr>
+        <p:txBody>
+          <a:bodyPr wrap="square" lIns="0" tIns="0" rIns="0" bIns="0" rtlCol="0" anchor="ctr"/>
+          <a:lstStyle/>
+          <a:p>
+            <a:pPr eaLnBrk="0" latinLnBrk="0" algn="r" indent="0" marL="0">
+              <a:buNone/>
+            </a:pPr>
+            <a:r>
+              <a:rPr lang="en-US" sz="1600" dirty="0">
+                <a:solidFill>
+                  <a:srgbClr val="000000"/>
+                </a:solidFill>
+                <a:latin typeface="맑은 고딕" pitchFamily="34" charset="0"/>
+                <a:ea typeface="맑은 고딕" pitchFamily="34" charset="-122"/>
+                <a:cs typeface="맑은 고딕" pitchFamily="34" charset="-120"/>
+              </a:rPr>
+              <a:t>9.</a:t>
+            </a:r>
+            <a:endParaRPr lang="en-US" sz="1600" dirty="0"/>
+          </a:p>
+        </p:txBody>
+      </p:sp>
+      <p:sp>
+        <p:nvSpPr>
+          <p:cNvPr id="28" name="Text 26"/>
+          <p:cNvSpPr txBox="1"/>
+          <p:nvPr/>
+        </p:nvSpPr>
+        <p:spPr>
+          <a:xfrm>
+            <a:off x="1965960" y="4608576"/>
+            <a:ext cx="4023360" cy="365760"/>
+          </a:xfrm>
+          <a:prstGeom prst="rect">
+            <a:avLst/>
+          </a:prstGeom>
+          <a:noFill/>
+          <a:ln/>
+        </p:spPr>
+        <p:txBody>
+          <a:bodyPr wrap="square" lIns="0" tIns="0" rIns="0" bIns="0" rtlCol="0" anchor="ctr"/>
+          <a:lstStyle/>
+          <a:p>
+            <a:pPr eaLnBrk="0" latinLnBrk="0" indent="0" marL="0">
+              <a:buNone/>
+            </a:pPr>
+            <a:r>
+              <a:rPr lang="en-US" sz="1600" dirty="0">
+                <a:solidFill>
+                  <a:srgbClr val="000000"/>
+                </a:solidFill>
+                <a:latin typeface="맑은 고딕" pitchFamily="34" charset="0"/>
+                <a:ea typeface="맑은 고딕" pitchFamily="34" charset="-122"/>
+                <a:cs typeface="맑은 고딕" pitchFamily="34" charset="-120"/>
+              </a:rPr>
+              <a:t>기타 사항</a:t>
+            </a:r>
+            <a:endParaRPr lang="en-US" sz="1600" dirty="0"/>
+          </a:p>
+        </p:txBody>
+      </p:sp>
+      <p:sp>
+        <p:nvSpPr>
+          <p:cNvPr id="29" name="Text 27"/>
+          <p:cNvSpPr txBox="1"/>
+          <p:nvPr/>
+        </p:nvSpPr>
+        <p:spPr>
+          <a:xfrm>
+            <a:off x="1325880" y="5010912"/>
+            <a:ext cx="502920" cy="365760"/>
+          </a:xfrm>
+          <a:prstGeom prst="rect">
+            <a:avLst/>
+          </a:prstGeom>
+          <a:noFill/>
+          <a:ln/>
+        </p:spPr>
+        <p:txBody>
+          <a:bodyPr wrap="square" lIns="0" tIns="0" rIns="0" bIns="0" rtlCol="0" anchor="ctr"/>
+          <a:lstStyle/>
+          <a:p>
+            <a:pPr eaLnBrk="0" latinLnBrk="0" algn="r" indent="0" marL="0">
+              <a:buNone/>
+            </a:pPr>
+            <a:r>
+              <a:rPr lang="en-US" sz="1600" dirty="0">
+                <a:solidFill>
+                  <a:srgbClr val="000000"/>
+                </a:solidFill>
+                <a:latin typeface="맑은 고딕" pitchFamily="34" charset="0"/>
+                <a:ea typeface="맑은 고딕" pitchFamily="34" charset="-122"/>
+                <a:cs typeface="맑은 고딕" pitchFamily="34" charset="-120"/>
+              </a:rPr>
+              <a:t>10.</a:t>
+            </a:r>
+            <a:endParaRPr lang="en-US" sz="1600" dirty="0"/>
+          </a:p>
+        </p:txBody>
+      </p:sp>
+      <p:sp>
+        <p:nvSpPr>
+          <p:cNvPr id="30" name="Text 28"/>
+          <p:cNvSpPr txBox="1"/>
+          <p:nvPr/>
+        </p:nvSpPr>
+        <p:spPr>
+          <a:xfrm>
+            <a:off x="1965960" y="5010912"/>
+            <a:ext cx="4023360" cy="365760"/>
+          </a:xfrm>
+          <a:prstGeom prst="rect">
+            <a:avLst/>
+          </a:prstGeom>
+          <a:noFill/>
+          <a:ln/>
+        </p:spPr>
+        <p:txBody>
+          <a:bodyPr wrap="square" lIns="0" tIns="0" rIns="0" bIns="0" rtlCol="0" anchor="ctr"/>
+          <a:lstStyle/>
+          <a:p>
+            <a:pPr eaLnBrk="0" latinLnBrk="0" indent="0" marL="0">
+              <a:buNone/>
+            </a:pPr>
+            <a:r>
+              <a:rPr lang="en-US" sz="1600" dirty="0">
+                <a:solidFill>
+                  <a:srgbClr val="000000"/>
+                </a:solidFill>
+                <a:latin typeface="맑은 고딕" pitchFamily="34" charset="0"/>
+                <a:ea typeface="맑은 고딕" pitchFamily="34" charset="-122"/>
+                <a:cs typeface="맑은 고딕" pitchFamily="34" charset="-120"/>
+              </a:rPr>
+              <a:t>채용 계획 요약</a:t>
+            </a:r>
+            <a:endParaRPr lang="en-US" sz="1600" dirty="0"/>
+          </a:p>
+        </p:txBody>
+      </p:sp>
+      <p:sp>
+        <p:nvSpPr>
+          <p:cNvPr id="31" name="Text 29"/>
+          <p:cNvSpPr txBox="1"/>
+          <p:nvPr/>
+        </p:nvSpPr>
+        <p:spPr>
+          <a:xfrm>
+            <a:off x="1051560" y="5760720"/>
+            <a:ext cx="7040880" cy="256032"/>
           </a:xfrm>
           <a:prstGeom prst="rect">
             <a:avLst/>

</xml_diff>

<commit_message>
Dot the inner horizontal rules across the remaining tables
Adds a dashRules() helper beside the existing border override, since
pptxgenjs 4.x still cannot dash a table border: the cell edges are set
to none and a dashed line shape is laid over the same coordinates.

- p2 staffing: between 정원 and 현원, stopping short of the 결원 /
  채용(안) / 비고 columns, which are merged down both rows
- p4 배점표: between 1차 and 2차, leaving 계 solid
- p5 자기소개서 문항: between the four items
- p6, p7 배점표: between the four 평가항목 rows, across the two
  unmerged columns only
- p8: inside both the 채용신체검사 and 결격사유조회 tables
- p10 요약: between all seven rows

Header rules and the rules above totals stay solid.

Co-Authored-By: Claude Opus 5 <noreply@anthropic.com>
Claude-Session: https://claude.ai/code/session_01GZfitk2JEKppZ4fGSDdghv
</commit_message>
<xml_diff>
--- a/docs/2027년_사무직원_채용계획안.pptx
+++ b/docs/2027년_사무직원_채용계획안.pptx
@@ -2735,14 +2735,8 @@
                       <a:headEnd type="none" w="med" len="med"/>
                       <a:tailEnd type="none" w="med" len="med"/>
                     </a:lnT>
-                    <a:lnB w="12700" cap="flat" cmpd="sng" algn="ctr">
-                      <a:solidFill>
-                        <a:srgbClr val="000000"/>
-                      </a:solidFill>
-                      <a:prstDash val="solid"/>
-                      <a:round/>
-                      <a:headEnd type="none" w="med" len="med"/>
-                      <a:tailEnd type="none" w="med" len="med"/>
+                    <a:lnB w="0" cap="flat" cmpd="sng" algn="ctr">
+                      <a:noFill/>
                     </a:lnB>
                   </a:tcPr>
                 </a:tc>
@@ -2800,14 +2794,8 @@
                       <a:headEnd type="none" w="med" len="med"/>
                       <a:tailEnd type="none" w="med" len="med"/>
                     </a:lnT>
-                    <a:lnB w="12700" cap="flat" cmpd="sng" algn="ctr">
-                      <a:solidFill>
-                        <a:srgbClr val="000000"/>
-                      </a:solidFill>
-                      <a:prstDash val="solid"/>
-                      <a:round/>
-                      <a:headEnd type="none" w="med" len="med"/>
-                      <a:tailEnd type="none" w="med" len="med"/>
+                    <a:lnB w="0" cap="flat" cmpd="sng" algn="ctr">
+                      <a:noFill/>
                     </a:lnB>
                   </a:tcPr>
                 </a:tc>
@@ -2858,14 +2846,8 @@
                       <a:headEnd type="none" w="med" len="med"/>
                       <a:tailEnd type="none" w="med" len="med"/>
                     </a:lnR>
-                    <a:lnT w="12700" cap="flat" cmpd="sng" algn="ctr">
-                      <a:solidFill>
-                        <a:srgbClr val="000000"/>
-                      </a:solidFill>
-                      <a:prstDash val="solid"/>
-                      <a:round/>
-                      <a:headEnd type="none" w="med" len="med"/>
-                      <a:tailEnd type="none" w="med" len="med"/>
+                    <a:lnT w="0" cap="flat" cmpd="sng" algn="ctr">
+                      <a:noFill/>
                     </a:lnT>
                     <a:lnB w="12700" cap="flat" cmpd="sng" algn="ctr">
                       <a:solidFill>
@@ -2923,14 +2905,8 @@
                       <a:headEnd type="none" w="med" len="med"/>
                       <a:tailEnd type="none" w="med" len="med"/>
                     </a:lnR>
-                    <a:lnT w="12700" cap="flat" cmpd="sng" algn="ctr">
-                      <a:solidFill>
-                        <a:srgbClr val="000000"/>
-                      </a:solidFill>
-                      <a:prstDash val="solid"/>
-                      <a:round/>
-                      <a:headEnd type="none" w="med" len="med"/>
-                      <a:tailEnd type="none" w="med" len="med"/>
+                    <a:lnT w="0" cap="flat" cmpd="sng" algn="ctr">
+                      <a:noFill/>
                     </a:lnT>
                     <a:lnB w="12700" cap="flat" cmpd="sng" algn="ctr">
                       <a:solidFill>
@@ -2950,7 +2926,30 @@
       </p:graphicFrame>
       <p:sp>
         <p:nvSpPr>
-          <p:cNvPr id="13" name="Text 10"/>
+          <p:cNvPr id="13" name="Shape 10"/>
+          <p:cNvSpPr/>
+          <p:nvPr/>
+        </p:nvSpPr>
+        <p:spPr>
+          <a:xfrm>
+            <a:off x="914400" y="3182112"/>
+            <a:ext cx="7772400" cy="0"/>
+          </a:xfrm>
+          <a:prstGeom prst="line">
+            <a:avLst/>
+          </a:prstGeom>
+          <a:noFill/>
+          <a:ln w="12700">
+            <a:solidFill>
+              <a:srgbClr val="000000"/>
+            </a:solidFill>
+            <a:prstDash val="dash"/>
+          </a:ln>
+        </p:spPr>
+      </p:sp>
+      <p:sp>
+        <p:nvSpPr>
+          <p:cNvPr id="14" name="Text 11"/>
           <p:cNvSpPr txBox="1"/>
           <p:nvPr/>
         </p:nvSpPr>
@@ -3296,14 +3295,8 @@
                       <a:headEnd type="none" w="med" len="med"/>
                       <a:tailEnd type="none" w="med" len="med"/>
                     </a:lnT>
-                    <a:lnB w="12700" cap="flat" cmpd="sng" algn="ctr">
-                      <a:solidFill>
-                        <a:srgbClr val="000000"/>
-                      </a:solidFill>
-                      <a:prstDash val="solid"/>
-                      <a:round/>
-                      <a:headEnd type="none" w="med" len="med"/>
-                      <a:tailEnd type="none" w="med" len="med"/>
+                    <a:lnB w="0" cap="flat" cmpd="sng" algn="ctr">
+                      <a:noFill/>
                     </a:lnB>
                   </a:tcPr>
                 </a:tc>
@@ -3382,14 +3375,8 @@
                       <a:headEnd type="none" w="med" len="med"/>
                       <a:tailEnd type="none" w="med" len="med"/>
                     </a:lnT>
-                    <a:lnB w="12700" cap="flat" cmpd="sng" algn="ctr">
-                      <a:solidFill>
-                        <a:srgbClr val="000000"/>
-                      </a:solidFill>
-                      <a:prstDash val="solid"/>
-                      <a:round/>
-                      <a:headEnd type="none" w="med" len="med"/>
-                      <a:tailEnd type="none" w="med" len="med"/>
+                    <a:lnB w="0" cap="flat" cmpd="sng" algn="ctr">
+                      <a:noFill/>
                     </a:lnB>
                   </a:tcPr>
                 </a:tc>
@@ -3550,14 +3537,8 @@
                       <a:headEnd type="none" w="med" len="med"/>
                       <a:tailEnd type="none" w="med" len="med"/>
                     </a:lnR>
-                    <a:lnT w="12700" cap="flat" cmpd="sng" algn="ctr">
-                      <a:solidFill>
-                        <a:srgbClr val="000000"/>
-                      </a:solidFill>
-                      <a:prstDash val="solid"/>
-                      <a:round/>
-                      <a:headEnd type="none" w="med" len="med"/>
-                      <a:tailEnd type="none" w="med" len="med"/>
+                    <a:lnT w="0" cap="flat" cmpd="sng" algn="ctr">
+                      <a:noFill/>
                     </a:lnT>
                     <a:lnB w="12700" cap="flat" cmpd="sng" algn="ctr">
                       <a:solidFill>
@@ -3615,14 +3596,8 @@
                       <a:headEnd type="none" w="med" len="med"/>
                       <a:tailEnd type="none" w="med" len="med"/>
                     </a:lnR>
-                    <a:lnT w="12700" cap="flat" cmpd="sng" algn="ctr">
-                      <a:solidFill>
-                        <a:srgbClr val="000000"/>
-                      </a:solidFill>
-                      <a:prstDash val="solid"/>
-                      <a:round/>
-                      <a:headEnd type="none" w="med" len="med"/>
-                      <a:tailEnd type="none" w="med" len="med"/>
+                    <a:lnT w="0" cap="flat" cmpd="sng" algn="ctr">
+                      <a:noFill/>
                     </a:lnT>
                     <a:lnB w="12700" cap="flat" cmpd="sng" algn="ctr">
                       <a:solidFill>
@@ -3645,7 +3620,30 @@
       </p:graphicFrame>
       <p:sp>
         <p:nvSpPr>
-          <p:cNvPr id="15" name="Text 11"/>
+          <p:cNvPr id="16" name="Shape 12"/>
+          <p:cNvSpPr/>
+          <p:nvPr/>
+        </p:nvSpPr>
+        <p:spPr>
+          <a:xfrm>
+            <a:off x="914400" y="4956048"/>
+            <a:ext cx="5486400" cy="0"/>
+          </a:xfrm>
+          <a:prstGeom prst="line">
+            <a:avLst/>
+          </a:prstGeom>
+          <a:noFill/>
+          <a:ln w="12700">
+            <a:solidFill>
+              <a:srgbClr val="000000"/>
+            </a:solidFill>
+            <a:prstDash val="dash"/>
+          </a:ln>
+        </p:spPr>
+      </p:sp>
+      <p:sp>
+        <p:nvSpPr>
+          <p:cNvPr id="17" name="Text 13"/>
           <p:cNvSpPr txBox="1"/>
           <p:nvPr/>
         </p:nvSpPr>
@@ -3684,7 +3682,7 @@
       </p:sp>
       <p:sp>
         <p:nvSpPr>
-          <p:cNvPr id="17" name="Text 12"/>
+          <p:cNvPr id="19" name="Text 14"/>
           <p:cNvSpPr txBox="1"/>
           <p:nvPr/>
         </p:nvSpPr>
@@ -4740,14 +4738,8 @@
                       <a:headEnd type="none" w="med" len="med"/>
                       <a:tailEnd type="none" w="med" len="med"/>
                     </a:lnT>
-                    <a:lnB w="12700" cap="flat" cmpd="sng" algn="ctr">
-                      <a:solidFill>
-                        <a:srgbClr val="000000"/>
-                      </a:solidFill>
-                      <a:prstDash val="solid"/>
-                      <a:round/>
-                      <a:headEnd type="none" w="med" len="med"/>
-                      <a:tailEnd type="none" w="med" len="med"/>
+                    <a:lnB w="0" cap="flat" cmpd="sng" algn="ctr">
+                      <a:noFill/>
                     </a:lnB>
                   </a:tcPr>
                 </a:tc>
@@ -4805,14 +4797,8 @@
                       <a:headEnd type="none" w="med" len="med"/>
                       <a:tailEnd type="none" w="med" len="med"/>
                     </a:lnT>
-                    <a:lnB w="12700" cap="flat" cmpd="sng" algn="ctr">
-                      <a:solidFill>
-                        <a:srgbClr val="000000"/>
-                      </a:solidFill>
-                      <a:prstDash val="solid"/>
-                      <a:round/>
-                      <a:headEnd type="none" w="med" len="med"/>
-                      <a:tailEnd type="none" w="med" len="med"/>
+                    <a:lnB w="0" cap="flat" cmpd="sng" algn="ctr">
+                      <a:noFill/>
                     </a:lnB>
                   </a:tcPr>
                 </a:tc>
@@ -4863,23 +4849,11 @@
                       <a:headEnd type="none" w="med" len="med"/>
                       <a:tailEnd type="none" w="med" len="med"/>
                     </a:lnR>
-                    <a:lnT w="12700" cap="flat" cmpd="sng" algn="ctr">
-                      <a:solidFill>
-                        <a:srgbClr val="000000"/>
-                      </a:solidFill>
-                      <a:prstDash val="solid"/>
-                      <a:round/>
-                      <a:headEnd type="none" w="med" len="med"/>
-                      <a:tailEnd type="none" w="med" len="med"/>
+                    <a:lnT w="0" cap="flat" cmpd="sng" algn="ctr">
+                      <a:noFill/>
                     </a:lnT>
-                    <a:lnB w="12700" cap="flat" cmpd="sng" algn="ctr">
-                      <a:solidFill>
-                        <a:srgbClr val="000000"/>
-                      </a:solidFill>
-                      <a:prstDash val="solid"/>
-                      <a:round/>
-                      <a:headEnd type="none" w="med" len="med"/>
-                      <a:tailEnd type="none" w="med" len="med"/>
+                    <a:lnB w="0" cap="flat" cmpd="sng" algn="ctr">
+                      <a:noFill/>
                     </a:lnB>
                   </a:tcPr>
                 </a:tc>
@@ -4928,23 +4902,11 @@
                       <a:headEnd type="none" w="med" len="med"/>
                       <a:tailEnd type="none" w="med" len="med"/>
                     </a:lnR>
-                    <a:lnT w="12700" cap="flat" cmpd="sng" algn="ctr">
-                      <a:solidFill>
-                        <a:srgbClr val="000000"/>
-                      </a:solidFill>
-                      <a:prstDash val="solid"/>
-                      <a:round/>
-                      <a:headEnd type="none" w="med" len="med"/>
-                      <a:tailEnd type="none" w="med" len="med"/>
+                    <a:lnT w="0" cap="flat" cmpd="sng" algn="ctr">
+                      <a:noFill/>
                     </a:lnT>
-                    <a:lnB w="12700" cap="flat" cmpd="sng" algn="ctr">
-                      <a:solidFill>
-                        <a:srgbClr val="000000"/>
-                      </a:solidFill>
-                      <a:prstDash val="solid"/>
-                      <a:round/>
-                      <a:headEnd type="none" w="med" len="med"/>
-                      <a:tailEnd type="none" w="med" len="med"/>
+                    <a:lnB w="0" cap="flat" cmpd="sng" algn="ctr">
+                      <a:noFill/>
                     </a:lnB>
                   </a:tcPr>
                 </a:tc>
@@ -4995,23 +4957,11 @@
                       <a:headEnd type="none" w="med" len="med"/>
                       <a:tailEnd type="none" w="med" len="med"/>
                     </a:lnR>
-                    <a:lnT w="12700" cap="flat" cmpd="sng" algn="ctr">
-                      <a:solidFill>
-                        <a:srgbClr val="000000"/>
-                      </a:solidFill>
-                      <a:prstDash val="solid"/>
-                      <a:round/>
-                      <a:headEnd type="none" w="med" len="med"/>
-                      <a:tailEnd type="none" w="med" len="med"/>
+                    <a:lnT w="0" cap="flat" cmpd="sng" algn="ctr">
+                      <a:noFill/>
                     </a:lnT>
-                    <a:lnB w="12700" cap="flat" cmpd="sng" algn="ctr">
-                      <a:solidFill>
-                        <a:srgbClr val="000000"/>
-                      </a:solidFill>
-                      <a:prstDash val="solid"/>
-                      <a:round/>
-                      <a:headEnd type="none" w="med" len="med"/>
-                      <a:tailEnd type="none" w="med" len="med"/>
+                    <a:lnB w="0" cap="flat" cmpd="sng" algn="ctr">
+                      <a:noFill/>
                     </a:lnB>
                   </a:tcPr>
                 </a:tc>
@@ -5060,23 +5010,11 @@
                       <a:headEnd type="none" w="med" len="med"/>
                       <a:tailEnd type="none" w="med" len="med"/>
                     </a:lnR>
-                    <a:lnT w="12700" cap="flat" cmpd="sng" algn="ctr">
-                      <a:solidFill>
-                        <a:srgbClr val="000000"/>
-                      </a:solidFill>
-                      <a:prstDash val="solid"/>
-                      <a:round/>
-                      <a:headEnd type="none" w="med" len="med"/>
-                      <a:tailEnd type="none" w="med" len="med"/>
+                    <a:lnT w="0" cap="flat" cmpd="sng" algn="ctr">
+                      <a:noFill/>
                     </a:lnT>
-                    <a:lnB w="12700" cap="flat" cmpd="sng" algn="ctr">
-                      <a:solidFill>
-                        <a:srgbClr val="000000"/>
-                      </a:solidFill>
-                      <a:prstDash val="solid"/>
-                      <a:round/>
-                      <a:headEnd type="none" w="med" len="med"/>
-                      <a:tailEnd type="none" w="med" len="med"/>
+                    <a:lnB w="0" cap="flat" cmpd="sng" algn="ctr">
+                      <a:noFill/>
                     </a:lnB>
                   </a:tcPr>
                 </a:tc>
@@ -5127,23 +5065,11 @@
                       <a:headEnd type="none" w="med" len="med"/>
                       <a:tailEnd type="none" w="med" len="med"/>
                     </a:lnR>
-                    <a:lnT w="12700" cap="flat" cmpd="sng" algn="ctr">
-                      <a:solidFill>
-                        <a:srgbClr val="000000"/>
-                      </a:solidFill>
-                      <a:prstDash val="solid"/>
-                      <a:round/>
-                      <a:headEnd type="none" w="med" len="med"/>
-                      <a:tailEnd type="none" w="med" len="med"/>
+                    <a:lnT w="0" cap="flat" cmpd="sng" algn="ctr">
+                      <a:noFill/>
                     </a:lnT>
-                    <a:lnB w="12700" cap="flat" cmpd="sng" algn="ctr">
-                      <a:solidFill>
-                        <a:srgbClr val="000000"/>
-                      </a:solidFill>
-                      <a:prstDash val="solid"/>
-                      <a:round/>
-                      <a:headEnd type="none" w="med" len="med"/>
-                      <a:tailEnd type="none" w="med" len="med"/>
+                    <a:lnB w="0" cap="flat" cmpd="sng" algn="ctr">
+                      <a:noFill/>
                     </a:lnB>
                   </a:tcPr>
                 </a:tc>
@@ -5192,23 +5118,11 @@
                       <a:headEnd type="none" w="med" len="med"/>
                       <a:tailEnd type="none" w="med" len="med"/>
                     </a:lnR>
-                    <a:lnT w="12700" cap="flat" cmpd="sng" algn="ctr">
-                      <a:solidFill>
-                        <a:srgbClr val="000000"/>
-                      </a:solidFill>
-                      <a:prstDash val="solid"/>
-                      <a:round/>
-                      <a:headEnd type="none" w="med" len="med"/>
-                      <a:tailEnd type="none" w="med" len="med"/>
+                    <a:lnT w="0" cap="flat" cmpd="sng" algn="ctr">
+                      <a:noFill/>
                     </a:lnT>
-                    <a:lnB w="12700" cap="flat" cmpd="sng" algn="ctr">
-                      <a:solidFill>
-                        <a:srgbClr val="000000"/>
-                      </a:solidFill>
-                      <a:prstDash val="solid"/>
-                      <a:round/>
-                      <a:headEnd type="none" w="med" len="med"/>
-                      <a:tailEnd type="none" w="med" len="med"/>
+                    <a:lnB w="0" cap="flat" cmpd="sng" algn="ctr">
+                      <a:noFill/>
                     </a:lnB>
                   </a:tcPr>
                 </a:tc>
@@ -5259,23 +5173,11 @@
                       <a:headEnd type="none" w="med" len="med"/>
                       <a:tailEnd type="none" w="med" len="med"/>
                     </a:lnR>
-                    <a:lnT w="12700" cap="flat" cmpd="sng" algn="ctr">
-                      <a:solidFill>
-                        <a:srgbClr val="000000"/>
-                      </a:solidFill>
-                      <a:prstDash val="solid"/>
-                      <a:round/>
-                      <a:headEnd type="none" w="med" len="med"/>
-                      <a:tailEnd type="none" w="med" len="med"/>
+                    <a:lnT w="0" cap="flat" cmpd="sng" algn="ctr">
+                      <a:noFill/>
                     </a:lnT>
-                    <a:lnB w="12700" cap="flat" cmpd="sng" algn="ctr">
-                      <a:solidFill>
-                        <a:srgbClr val="000000"/>
-                      </a:solidFill>
-                      <a:prstDash val="solid"/>
-                      <a:round/>
-                      <a:headEnd type="none" w="med" len="med"/>
-                      <a:tailEnd type="none" w="med" len="med"/>
+                    <a:lnB w="0" cap="flat" cmpd="sng" algn="ctr">
+                      <a:noFill/>
                     </a:lnB>
                   </a:tcPr>
                 </a:tc>
@@ -5324,23 +5226,11 @@
                       <a:headEnd type="none" w="med" len="med"/>
                       <a:tailEnd type="none" w="med" len="med"/>
                     </a:lnR>
-                    <a:lnT w="12700" cap="flat" cmpd="sng" algn="ctr">
-                      <a:solidFill>
-                        <a:srgbClr val="000000"/>
-                      </a:solidFill>
-                      <a:prstDash val="solid"/>
-                      <a:round/>
-                      <a:headEnd type="none" w="med" len="med"/>
-                      <a:tailEnd type="none" w="med" len="med"/>
+                    <a:lnT w="0" cap="flat" cmpd="sng" algn="ctr">
+                      <a:noFill/>
                     </a:lnT>
-                    <a:lnB w="12700" cap="flat" cmpd="sng" algn="ctr">
-                      <a:solidFill>
-                        <a:srgbClr val="000000"/>
-                      </a:solidFill>
-                      <a:prstDash val="solid"/>
-                      <a:round/>
-                      <a:headEnd type="none" w="med" len="med"/>
-                      <a:tailEnd type="none" w="med" len="med"/>
+                    <a:lnB w="0" cap="flat" cmpd="sng" algn="ctr">
+                      <a:noFill/>
                     </a:lnB>
                   </a:tcPr>
                 </a:tc>
@@ -5391,23 +5281,11 @@
                       <a:headEnd type="none" w="med" len="med"/>
                       <a:tailEnd type="none" w="med" len="med"/>
                     </a:lnR>
-                    <a:lnT w="12700" cap="flat" cmpd="sng" algn="ctr">
-                      <a:solidFill>
-                        <a:srgbClr val="000000"/>
-                      </a:solidFill>
-                      <a:prstDash val="solid"/>
-                      <a:round/>
-                      <a:headEnd type="none" w="med" len="med"/>
-                      <a:tailEnd type="none" w="med" len="med"/>
+                    <a:lnT w="0" cap="flat" cmpd="sng" algn="ctr">
+                      <a:noFill/>
                     </a:lnT>
-                    <a:lnB w="12700" cap="flat" cmpd="sng" algn="ctr">
-                      <a:solidFill>
-                        <a:srgbClr val="000000"/>
-                      </a:solidFill>
-                      <a:prstDash val="solid"/>
-                      <a:round/>
-                      <a:headEnd type="none" w="med" len="med"/>
-                      <a:tailEnd type="none" w="med" len="med"/>
+                    <a:lnB w="0" cap="flat" cmpd="sng" algn="ctr">
+                      <a:noFill/>
                     </a:lnB>
                   </a:tcPr>
                 </a:tc>
@@ -5456,23 +5334,11 @@
                       <a:headEnd type="none" w="med" len="med"/>
                       <a:tailEnd type="none" w="med" len="med"/>
                     </a:lnR>
-                    <a:lnT w="12700" cap="flat" cmpd="sng" algn="ctr">
-                      <a:solidFill>
-                        <a:srgbClr val="000000"/>
-                      </a:solidFill>
-                      <a:prstDash val="solid"/>
-                      <a:round/>
-                      <a:headEnd type="none" w="med" len="med"/>
-                      <a:tailEnd type="none" w="med" len="med"/>
+                    <a:lnT w="0" cap="flat" cmpd="sng" algn="ctr">
+                      <a:noFill/>
                     </a:lnT>
-                    <a:lnB w="12700" cap="flat" cmpd="sng" algn="ctr">
-                      <a:solidFill>
-                        <a:srgbClr val="000000"/>
-                      </a:solidFill>
-                      <a:prstDash val="solid"/>
-                      <a:round/>
-                      <a:headEnd type="none" w="med" len="med"/>
-                      <a:tailEnd type="none" w="med" len="med"/>
+                    <a:lnB w="0" cap="flat" cmpd="sng" algn="ctr">
+                      <a:noFill/>
                     </a:lnB>
                   </a:tcPr>
                 </a:tc>
@@ -5523,14 +5389,8 @@
                       <a:headEnd type="none" w="med" len="med"/>
                       <a:tailEnd type="none" w="med" len="med"/>
                     </a:lnR>
-                    <a:lnT w="12700" cap="flat" cmpd="sng" algn="ctr">
-                      <a:solidFill>
-                        <a:srgbClr val="000000"/>
-                      </a:solidFill>
-                      <a:prstDash val="solid"/>
-                      <a:round/>
-                      <a:headEnd type="none" w="med" len="med"/>
-                      <a:tailEnd type="none" w="med" len="med"/>
+                    <a:lnT w="0" cap="flat" cmpd="sng" algn="ctr">
+                      <a:noFill/>
                     </a:lnT>
                     <a:lnB w="12700" cap="flat" cmpd="sng" algn="ctr">
                       <a:solidFill>
@@ -5588,14 +5448,8 @@
                       <a:headEnd type="none" w="med" len="med"/>
                       <a:tailEnd type="none" w="med" len="med"/>
                     </a:lnR>
-                    <a:lnT w="12700" cap="flat" cmpd="sng" algn="ctr">
-                      <a:solidFill>
-                        <a:srgbClr val="000000"/>
-                      </a:solidFill>
-                      <a:prstDash val="solid"/>
-                      <a:round/>
-                      <a:headEnd type="none" w="med" len="med"/>
-                      <a:tailEnd type="none" w="med" len="med"/>
+                    <a:lnT w="0" cap="flat" cmpd="sng" algn="ctr">
+                      <a:noFill/>
                     </a:lnT>
                     <a:lnB w="12700" cap="flat" cmpd="sng" algn="ctr">
                       <a:solidFill>
@@ -5615,7 +5469,145 @@
       </p:graphicFrame>
       <p:sp>
         <p:nvSpPr>
-          <p:cNvPr id="7" name="Text 4"/>
+          <p:cNvPr id="7" name="Shape 4"/>
+          <p:cNvSpPr/>
+          <p:nvPr/>
+        </p:nvSpPr>
+        <p:spPr>
+          <a:xfrm>
+            <a:off x="457200" y="2103120"/>
+            <a:ext cx="8229600" cy="0"/>
+          </a:xfrm>
+          <a:prstGeom prst="line">
+            <a:avLst/>
+          </a:prstGeom>
+          <a:noFill/>
+          <a:ln w="12700">
+            <a:solidFill>
+              <a:srgbClr val="000000"/>
+            </a:solidFill>
+            <a:prstDash val="dash"/>
+          </a:ln>
+        </p:spPr>
+      </p:sp>
+      <p:sp>
+        <p:nvSpPr>
+          <p:cNvPr id="8" name="Shape 5"/>
+          <p:cNvSpPr/>
+          <p:nvPr/>
+        </p:nvSpPr>
+        <p:spPr>
+          <a:xfrm>
+            <a:off x="457200" y="2487168"/>
+            <a:ext cx="8229600" cy="0"/>
+          </a:xfrm>
+          <a:prstGeom prst="line">
+            <a:avLst/>
+          </a:prstGeom>
+          <a:noFill/>
+          <a:ln w="12700">
+            <a:solidFill>
+              <a:srgbClr val="000000"/>
+            </a:solidFill>
+            <a:prstDash val="dash"/>
+          </a:ln>
+        </p:spPr>
+      </p:sp>
+      <p:sp>
+        <p:nvSpPr>
+          <p:cNvPr id="9" name="Shape 6"/>
+          <p:cNvSpPr/>
+          <p:nvPr/>
+        </p:nvSpPr>
+        <p:spPr>
+          <a:xfrm>
+            <a:off x="457200" y="2871216"/>
+            <a:ext cx="8229600" cy="0"/>
+          </a:xfrm>
+          <a:prstGeom prst="line">
+            <a:avLst/>
+          </a:prstGeom>
+          <a:noFill/>
+          <a:ln w="12700">
+            <a:solidFill>
+              <a:srgbClr val="000000"/>
+            </a:solidFill>
+            <a:prstDash val="dash"/>
+          </a:ln>
+        </p:spPr>
+      </p:sp>
+      <p:sp>
+        <p:nvSpPr>
+          <p:cNvPr id="10" name="Shape 7"/>
+          <p:cNvSpPr/>
+          <p:nvPr/>
+        </p:nvSpPr>
+        <p:spPr>
+          <a:xfrm>
+            <a:off x="457200" y="3255264"/>
+            <a:ext cx="8229600" cy="0"/>
+          </a:xfrm>
+          <a:prstGeom prst="line">
+            <a:avLst/>
+          </a:prstGeom>
+          <a:noFill/>
+          <a:ln w="12700">
+            <a:solidFill>
+              <a:srgbClr val="000000"/>
+            </a:solidFill>
+            <a:prstDash val="dash"/>
+          </a:ln>
+        </p:spPr>
+      </p:sp>
+      <p:sp>
+        <p:nvSpPr>
+          <p:cNvPr id="11" name="Shape 8"/>
+          <p:cNvSpPr/>
+          <p:nvPr/>
+        </p:nvSpPr>
+        <p:spPr>
+          <a:xfrm>
+            <a:off x="457200" y="3639312"/>
+            <a:ext cx="8229600" cy="0"/>
+          </a:xfrm>
+          <a:prstGeom prst="line">
+            <a:avLst/>
+          </a:prstGeom>
+          <a:noFill/>
+          <a:ln w="12700">
+            <a:solidFill>
+              <a:srgbClr val="000000"/>
+            </a:solidFill>
+            <a:prstDash val="dash"/>
+          </a:ln>
+        </p:spPr>
+      </p:sp>
+      <p:sp>
+        <p:nvSpPr>
+          <p:cNvPr id="12" name="Shape 9"/>
+          <p:cNvSpPr/>
+          <p:nvPr/>
+        </p:nvSpPr>
+        <p:spPr>
+          <a:xfrm>
+            <a:off x="457200" y="4023360"/>
+            <a:ext cx="8229600" cy="0"/>
+          </a:xfrm>
+          <a:prstGeom prst="line">
+            <a:avLst/>
+          </a:prstGeom>
+          <a:noFill/>
+          <a:ln w="12700">
+            <a:solidFill>
+              <a:srgbClr val="000000"/>
+            </a:solidFill>
+            <a:prstDash val="dash"/>
+          </a:ln>
+        </p:spPr>
+      </p:sp>
+      <p:sp>
+        <p:nvSpPr>
+          <p:cNvPr id="13" name="Text 10"/>
           <p:cNvSpPr txBox="1"/>
           <p:nvPr/>
         </p:nvSpPr>
@@ -6285,7 +6277,7 @@
       </p:graphicFrame>
       <p:sp>
         <p:nvSpPr>
-          <p:cNvPr id="10" name="Text 5"/>
+          <p:cNvPr id="16" name="Text 11"/>
           <p:cNvSpPr txBox="1"/>
           <p:nvPr/>
         </p:nvSpPr>
@@ -10202,14 +10194,8 @@
                       <a:headEnd type="none" w="med" len="med"/>
                       <a:tailEnd type="none" w="med" len="med"/>
                     </a:lnT>
-                    <a:lnB w="12700" cap="flat" cmpd="sng" algn="ctr">
-                      <a:solidFill>
-                        <a:srgbClr val="000000"/>
-                      </a:solidFill>
-                      <a:prstDash val="solid"/>
-                      <a:round/>
-                      <a:headEnd type="none" w="med" len="med"/>
-                      <a:tailEnd type="none" w="med" len="med"/>
+                    <a:lnB w="0" cap="flat" cmpd="sng" algn="ctr">
+                      <a:noFill/>
                     </a:lnB>
                   </a:tcPr>
                 </a:tc>
@@ -10267,14 +10253,8 @@
                       <a:headEnd type="none" w="med" len="med"/>
                       <a:tailEnd type="none" w="med" len="med"/>
                     </a:lnT>
-                    <a:lnB w="12700" cap="flat" cmpd="sng" algn="ctr">
-                      <a:solidFill>
-                        <a:srgbClr val="000000"/>
-                      </a:solidFill>
-                      <a:prstDash val="solid"/>
-                      <a:round/>
-                      <a:headEnd type="none" w="med" len="med"/>
-                      <a:tailEnd type="none" w="med" len="med"/>
+                    <a:lnB w="0" cap="flat" cmpd="sng" algn="ctr">
+                      <a:noFill/>
                     </a:lnB>
                   </a:tcPr>
                 </a:tc>
@@ -10332,14 +10312,8 @@
                       <a:headEnd type="none" w="med" len="med"/>
                       <a:tailEnd type="none" w="med" len="med"/>
                     </a:lnT>
-                    <a:lnB w="12700" cap="flat" cmpd="sng" algn="ctr">
-                      <a:solidFill>
-                        <a:srgbClr val="000000"/>
-                      </a:solidFill>
-                      <a:prstDash val="solid"/>
-                      <a:round/>
-                      <a:headEnd type="none" w="med" len="med"/>
-                      <a:tailEnd type="none" w="med" len="med"/>
+                    <a:lnB w="0" cap="flat" cmpd="sng" algn="ctr">
+                      <a:noFill/>
                     </a:lnB>
                   </a:tcPr>
                 </a:tc>
@@ -10397,14 +10371,8 @@
                       <a:headEnd type="none" w="med" len="med"/>
                       <a:tailEnd type="none" w="med" len="med"/>
                     </a:lnT>
-                    <a:lnB w="12700" cap="flat" cmpd="sng" algn="ctr">
-                      <a:solidFill>
-                        <a:srgbClr val="000000"/>
-                      </a:solidFill>
-                      <a:prstDash val="solid"/>
-                      <a:round/>
-                      <a:headEnd type="none" w="med" len="med"/>
-                      <a:tailEnd type="none" w="med" len="med"/>
+                    <a:lnB w="0" cap="flat" cmpd="sng" algn="ctr">
+                      <a:noFill/>
                     </a:lnB>
                   </a:tcPr>
                 </a:tc>
@@ -10462,14 +10430,8 @@
                       <a:headEnd type="none" w="med" len="med"/>
                       <a:tailEnd type="none" w="med" len="med"/>
                     </a:lnT>
-                    <a:lnB w="12700" cap="flat" cmpd="sng" algn="ctr">
-                      <a:solidFill>
-                        <a:srgbClr val="000000"/>
-                      </a:solidFill>
-                      <a:prstDash val="solid"/>
-                      <a:round/>
-                      <a:headEnd type="none" w="med" len="med"/>
-                      <a:tailEnd type="none" w="med" len="med"/>
+                    <a:lnB w="0" cap="flat" cmpd="sng" algn="ctr">
+                      <a:noFill/>
                     </a:lnB>
                   </a:tcPr>
                 </a:tc>
@@ -10527,14 +10489,8 @@
                       <a:headEnd type="none" w="med" len="med"/>
                       <a:tailEnd type="none" w="med" len="med"/>
                     </a:lnT>
-                    <a:lnB w="12700" cap="flat" cmpd="sng" algn="ctr">
-                      <a:solidFill>
-                        <a:srgbClr val="000000"/>
-                      </a:solidFill>
-                      <a:prstDash val="solid"/>
-                      <a:round/>
-                      <a:headEnd type="none" w="med" len="med"/>
-                      <a:tailEnd type="none" w="med" len="med"/>
+                    <a:lnB w="0" cap="flat" cmpd="sng" algn="ctr">
+                      <a:noFill/>
                     </a:lnB>
                   </a:tcPr>
                 </a:tc>
@@ -10592,14 +10548,8 @@
                       <a:headEnd type="none" w="med" len="med"/>
                       <a:tailEnd type="none" w="med" len="med"/>
                     </a:lnT>
-                    <a:lnB w="12700" cap="flat" cmpd="sng" algn="ctr">
-                      <a:solidFill>
-                        <a:srgbClr val="000000"/>
-                      </a:solidFill>
-                      <a:prstDash val="solid"/>
-                      <a:round/>
-                      <a:headEnd type="none" w="med" len="med"/>
-                      <a:tailEnd type="none" w="med" len="med"/>
+                    <a:lnB w="0" cap="flat" cmpd="sng" algn="ctr">
+                      <a:noFill/>
                     </a:lnB>
                   </a:tcPr>
                 </a:tc>
@@ -10657,14 +10607,8 @@
                       <a:headEnd type="none" w="med" len="med"/>
                       <a:tailEnd type="none" w="med" len="med"/>
                     </a:lnT>
-                    <a:lnB w="12700" cap="flat" cmpd="sng" algn="ctr">
-                      <a:solidFill>
-                        <a:srgbClr val="000000"/>
-                      </a:solidFill>
-                      <a:prstDash val="solid"/>
-                      <a:round/>
-                      <a:headEnd type="none" w="med" len="med"/>
-                      <a:tailEnd type="none" w="med" len="med"/>
+                    <a:lnB w="0" cap="flat" cmpd="sng" algn="ctr">
+                      <a:noFill/>
                     </a:lnB>
                   </a:tcPr>
                 </a:tc>
@@ -10722,14 +10666,8 @@
                       <a:headEnd type="none" w="med" len="med"/>
                       <a:tailEnd type="none" w="med" len="med"/>
                     </a:lnT>
-                    <a:lnB w="12700" cap="flat" cmpd="sng" algn="ctr">
-                      <a:solidFill>
-                        <a:srgbClr val="000000"/>
-                      </a:solidFill>
-                      <a:prstDash val="solid"/>
-                      <a:round/>
-                      <a:headEnd type="none" w="med" len="med"/>
-                      <a:tailEnd type="none" w="med" len="med"/>
+                    <a:lnB w="0" cap="flat" cmpd="sng" algn="ctr">
+                      <a:noFill/>
                     </a:lnB>
                   </a:tcPr>
                 </a:tc>
@@ -10999,14 +10937,8 @@
                       <a:headEnd type="none" w="med" len="med"/>
                       <a:tailEnd type="none" w="med" len="med"/>
                     </a:lnR>
-                    <a:lnT w="12700" cap="flat" cmpd="sng" algn="ctr">
-                      <a:solidFill>
-                        <a:srgbClr val="000000"/>
-                      </a:solidFill>
-                      <a:prstDash val="solid"/>
-                      <a:round/>
-                      <a:headEnd type="none" w="med" len="med"/>
-                      <a:tailEnd type="none" w="med" len="med"/>
+                    <a:lnT w="0" cap="flat" cmpd="sng" algn="ctr">
+                      <a:noFill/>
                     </a:lnT>
                     <a:lnB w="12700" cap="flat" cmpd="sng" algn="ctr">
                       <a:solidFill>
@@ -11053,14 +10985,8 @@
                       <a:headEnd type="none" w="med" len="med"/>
                       <a:tailEnd type="none" w="med" len="med"/>
                     </a:lnR>
-                    <a:lnT w="12700" cap="flat" cmpd="sng" algn="ctr">
-                      <a:solidFill>
-                        <a:srgbClr val="000000"/>
-                      </a:solidFill>
-                      <a:prstDash val="solid"/>
-                      <a:round/>
-                      <a:headEnd type="none" w="med" len="med"/>
-                      <a:tailEnd type="none" w="med" len="med"/>
+                    <a:lnT w="0" cap="flat" cmpd="sng" algn="ctr">
+                      <a:noFill/>
                     </a:lnT>
                     <a:lnB w="12700" cap="flat" cmpd="sng" algn="ctr">
                       <a:solidFill>
@@ -11118,14 +11044,8 @@
                       <a:headEnd type="none" w="med" len="med"/>
                       <a:tailEnd type="none" w="med" len="med"/>
                     </a:lnR>
-                    <a:lnT w="12700" cap="flat" cmpd="sng" algn="ctr">
-                      <a:solidFill>
-                        <a:srgbClr val="000000"/>
-                      </a:solidFill>
-                      <a:prstDash val="solid"/>
-                      <a:round/>
-                      <a:headEnd type="none" w="med" len="med"/>
-                      <a:tailEnd type="none" w="med" len="med"/>
+                    <a:lnT w="0" cap="flat" cmpd="sng" algn="ctr">
+                      <a:noFill/>
                     </a:lnT>
                     <a:lnB w="12700" cap="flat" cmpd="sng" algn="ctr">
                       <a:solidFill>
@@ -11183,14 +11103,8 @@
                       <a:headEnd type="none" w="med" len="med"/>
                       <a:tailEnd type="none" w="med" len="med"/>
                     </a:lnR>
-                    <a:lnT w="12700" cap="flat" cmpd="sng" algn="ctr">
-                      <a:solidFill>
-                        <a:srgbClr val="000000"/>
-                      </a:solidFill>
-                      <a:prstDash val="solid"/>
-                      <a:round/>
-                      <a:headEnd type="none" w="med" len="med"/>
-                      <a:tailEnd type="none" w="med" len="med"/>
+                    <a:lnT w="0" cap="flat" cmpd="sng" algn="ctr">
+                      <a:noFill/>
                     </a:lnT>
                     <a:lnB w="12700" cap="flat" cmpd="sng" algn="ctr">
                       <a:solidFill>
@@ -11248,14 +11162,8 @@
                       <a:headEnd type="none" w="med" len="med"/>
                       <a:tailEnd type="none" w="med" len="med"/>
                     </a:lnR>
-                    <a:lnT w="12700" cap="flat" cmpd="sng" algn="ctr">
-                      <a:solidFill>
-                        <a:srgbClr val="000000"/>
-                      </a:solidFill>
-                      <a:prstDash val="solid"/>
-                      <a:round/>
-                      <a:headEnd type="none" w="med" len="med"/>
-                      <a:tailEnd type="none" w="med" len="med"/>
+                    <a:lnT w="0" cap="flat" cmpd="sng" algn="ctr">
+                      <a:noFill/>
                     </a:lnT>
                     <a:lnB w="12700" cap="flat" cmpd="sng" algn="ctr">
                       <a:solidFill>
@@ -11313,14 +11221,8 @@
                       <a:headEnd type="none" w="med" len="med"/>
                       <a:tailEnd type="none" w="med" len="med"/>
                     </a:lnR>
-                    <a:lnT w="12700" cap="flat" cmpd="sng" algn="ctr">
-                      <a:solidFill>
-                        <a:srgbClr val="000000"/>
-                      </a:solidFill>
-                      <a:prstDash val="solid"/>
-                      <a:round/>
-                      <a:headEnd type="none" w="med" len="med"/>
-                      <a:tailEnd type="none" w="med" len="med"/>
+                    <a:lnT w="0" cap="flat" cmpd="sng" algn="ctr">
+                      <a:noFill/>
                     </a:lnT>
                     <a:lnB w="12700" cap="flat" cmpd="sng" algn="ctr">
                       <a:solidFill>
@@ -11378,14 +11280,8 @@
                       <a:headEnd type="none" w="med" len="med"/>
                       <a:tailEnd type="none" w="med" len="med"/>
                     </a:lnR>
-                    <a:lnT w="12700" cap="flat" cmpd="sng" algn="ctr">
-                      <a:solidFill>
-                        <a:srgbClr val="000000"/>
-                      </a:solidFill>
-                      <a:prstDash val="solid"/>
-                      <a:round/>
-                      <a:headEnd type="none" w="med" len="med"/>
-                      <a:tailEnd type="none" w="med" len="med"/>
+                    <a:lnT w="0" cap="flat" cmpd="sng" algn="ctr">
+                      <a:noFill/>
                     </a:lnT>
                     <a:lnB w="12700" cap="flat" cmpd="sng" algn="ctr">
                       <a:solidFill>
@@ -11443,14 +11339,8 @@
                       <a:headEnd type="none" w="med" len="med"/>
                       <a:tailEnd type="none" w="med" len="med"/>
                     </a:lnR>
-                    <a:lnT w="12700" cap="flat" cmpd="sng" algn="ctr">
-                      <a:solidFill>
-                        <a:srgbClr val="000000"/>
-                      </a:solidFill>
-                      <a:prstDash val="solid"/>
-                      <a:round/>
-                      <a:headEnd type="none" w="med" len="med"/>
-                      <a:tailEnd type="none" w="med" len="med"/>
+                    <a:lnT w="0" cap="flat" cmpd="sng" algn="ctr">
+                      <a:noFill/>
                     </a:lnT>
                     <a:lnB w="12700" cap="flat" cmpd="sng" algn="ctr">
                       <a:solidFill>
@@ -11508,14 +11398,8 @@
                       <a:headEnd type="none" w="med" len="med"/>
                       <a:tailEnd type="none" w="med" len="med"/>
                     </a:lnR>
-                    <a:lnT w="12700" cap="flat" cmpd="sng" algn="ctr">
-                      <a:solidFill>
-                        <a:srgbClr val="000000"/>
-                      </a:solidFill>
-                      <a:prstDash val="solid"/>
-                      <a:round/>
-                      <a:headEnd type="none" w="med" len="med"/>
-                      <a:tailEnd type="none" w="med" len="med"/>
+                    <a:lnT w="0" cap="flat" cmpd="sng" algn="ctr">
+                      <a:noFill/>
                     </a:lnT>
                     <a:lnB w="12700" cap="flat" cmpd="sng" algn="ctr">
                       <a:solidFill>
@@ -11544,7 +11428,30 @@
       </p:graphicFrame>
       <p:sp>
         <p:nvSpPr>
-          <p:cNvPr id="8" name="Text 5"/>
+          <p:cNvPr id="8" name="Shape 5"/>
+          <p:cNvSpPr/>
+          <p:nvPr/>
+        </p:nvSpPr>
+        <p:spPr>
+          <a:xfrm>
+            <a:off x="1371600" y="2761488"/>
+            <a:ext cx="4912431" cy="0"/>
+          </a:xfrm>
+          <a:prstGeom prst="line">
+            <a:avLst/>
+          </a:prstGeom>
+          <a:noFill/>
+          <a:ln w="12700">
+            <a:solidFill>
+              <a:srgbClr val="000000"/>
+            </a:solidFill>
+            <a:prstDash val="dash"/>
+          </a:ln>
+        </p:spPr>
+      </p:sp>
+      <p:sp>
+        <p:nvSpPr>
+          <p:cNvPr id="9" name="Text 6"/>
           <p:cNvSpPr txBox="1"/>
           <p:nvPr/>
         </p:nvSpPr>
@@ -11583,7 +11490,7 @@
       </p:sp>
       <p:sp>
         <p:nvSpPr>
-          <p:cNvPr id="9" name="Text 6"/>
+          <p:cNvPr id="10" name="Text 7"/>
           <p:cNvSpPr txBox="1"/>
           <p:nvPr/>
         </p:nvSpPr>
@@ -12543,7 +12450,7 @@
       </p:graphicFrame>
       <p:sp>
         <p:nvSpPr>
-          <p:cNvPr id="11" name="Text 7"/>
+          <p:cNvPr id="12" name="Text 8"/>
           <p:cNvSpPr txBox="1"/>
           <p:nvPr/>
         </p:nvSpPr>
@@ -12582,7 +12489,7 @@
       </p:sp>
       <p:sp>
         <p:nvSpPr>
-          <p:cNvPr id="13" name="Text 8"/>
+          <p:cNvPr id="14" name="Text 9"/>
           <p:cNvSpPr txBox="1"/>
           <p:nvPr/>
         </p:nvSpPr>
@@ -15073,14 +14980,8 @@
                       <a:headEnd type="none" w="med" len="med"/>
                       <a:tailEnd type="none" w="med" len="med"/>
                     </a:lnT>
-                    <a:lnB w="12700" cap="flat" cmpd="sng" algn="ctr">
-                      <a:solidFill>
-                        <a:srgbClr val="000000"/>
-                      </a:solidFill>
-                      <a:prstDash val="solid"/>
-                      <a:round/>
-                      <a:headEnd type="none" w="med" len="med"/>
-                      <a:tailEnd type="none" w="med" len="med"/>
+                    <a:lnB w="0" cap="flat" cmpd="sng" algn="ctr">
+                      <a:noFill/>
                     </a:lnB>
                   </a:tcPr>
                 </a:tc>
@@ -15138,14 +15039,8 @@
                       <a:headEnd type="none" w="med" len="med"/>
                       <a:tailEnd type="none" w="med" len="med"/>
                     </a:lnT>
-                    <a:lnB w="12700" cap="flat" cmpd="sng" algn="ctr">
-                      <a:solidFill>
-                        <a:srgbClr val="000000"/>
-                      </a:solidFill>
-                      <a:prstDash val="solid"/>
-                      <a:round/>
-                      <a:headEnd type="none" w="med" len="med"/>
-                      <a:tailEnd type="none" w="med" len="med"/>
+                    <a:lnB w="0" cap="flat" cmpd="sng" algn="ctr">
+                      <a:noFill/>
                     </a:lnB>
                   </a:tcPr>
                 </a:tc>
@@ -15203,14 +15098,8 @@
                       <a:headEnd type="none" w="med" len="med"/>
                       <a:tailEnd type="none" w="med" len="med"/>
                     </a:lnT>
-                    <a:lnB w="12700" cap="flat" cmpd="sng" algn="ctr">
-                      <a:solidFill>
-                        <a:srgbClr val="000000"/>
-                      </a:solidFill>
-                      <a:prstDash val="solid"/>
-                      <a:round/>
-                      <a:headEnd type="none" w="med" len="med"/>
-                      <a:tailEnd type="none" w="med" len="med"/>
+                    <a:lnB w="0" cap="flat" cmpd="sng" algn="ctr">
+                      <a:noFill/>
                     </a:lnB>
                   </a:tcPr>
                 </a:tc>
@@ -15268,14 +15157,8 @@
                       <a:headEnd type="none" w="med" len="med"/>
                       <a:tailEnd type="none" w="med" len="med"/>
                     </a:lnT>
-                    <a:lnB w="12700" cap="flat" cmpd="sng" algn="ctr">
-                      <a:solidFill>
-                        <a:srgbClr val="000000"/>
-                      </a:solidFill>
-                      <a:prstDash val="solid"/>
-                      <a:round/>
-                      <a:headEnd type="none" w="med" len="med"/>
-                      <a:tailEnd type="none" w="med" len="med"/>
+                    <a:lnB w="0" cap="flat" cmpd="sng" algn="ctr">
+                      <a:noFill/>
                     </a:lnB>
                   </a:tcPr>
                 </a:tc>
@@ -15326,14 +15209,8 @@
                       <a:headEnd type="none" w="med" len="med"/>
                       <a:tailEnd type="none" w="med" len="med"/>
                     </a:lnR>
-                    <a:lnT w="12700" cap="flat" cmpd="sng" algn="ctr">
-                      <a:solidFill>
-                        <a:srgbClr val="000000"/>
-                      </a:solidFill>
-                      <a:prstDash val="solid"/>
-                      <a:round/>
-                      <a:headEnd type="none" w="med" len="med"/>
-                      <a:tailEnd type="none" w="med" len="med"/>
+                    <a:lnT w="0" cap="flat" cmpd="sng" algn="ctr">
+                      <a:noFill/>
                     </a:lnT>
                     <a:lnB w="12700" cap="flat" cmpd="sng" algn="ctr">
                       <a:solidFill>
@@ -15391,14 +15268,8 @@
                       <a:headEnd type="none" w="med" len="med"/>
                       <a:tailEnd type="none" w="med" len="med"/>
                     </a:lnR>
-                    <a:lnT w="12700" cap="flat" cmpd="sng" algn="ctr">
-                      <a:solidFill>
-                        <a:srgbClr val="000000"/>
-                      </a:solidFill>
-                      <a:prstDash val="solid"/>
-                      <a:round/>
-                      <a:headEnd type="none" w="med" len="med"/>
-                      <a:tailEnd type="none" w="med" len="med"/>
+                    <a:lnT w="0" cap="flat" cmpd="sng" algn="ctr">
+                      <a:noFill/>
                     </a:lnT>
                     <a:lnB w="12700" cap="flat" cmpd="sng" algn="ctr">
                       <a:solidFill>
@@ -15456,14 +15327,8 @@
                       <a:headEnd type="none" w="med" len="med"/>
                       <a:tailEnd type="none" w="med" len="med"/>
                     </a:lnR>
-                    <a:lnT w="12700" cap="flat" cmpd="sng" algn="ctr">
-                      <a:solidFill>
-                        <a:srgbClr val="000000"/>
-                      </a:solidFill>
-                      <a:prstDash val="solid"/>
-                      <a:round/>
-                      <a:headEnd type="none" w="med" len="med"/>
-                      <a:tailEnd type="none" w="med" len="med"/>
+                    <a:lnT w="0" cap="flat" cmpd="sng" algn="ctr">
+                      <a:noFill/>
                     </a:lnT>
                     <a:lnB w="12700" cap="flat" cmpd="sng" algn="ctr">
                       <a:solidFill>
@@ -15521,14 +15386,8 @@
                       <a:headEnd type="none" w="med" len="med"/>
                       <a:tailEnd type="none" w="med" len="med"/>
                     </a:lnR>
-                    <a:lnT w="12700" cap="flat" cmpd="sng" algn="ctr">
-                      <a:solidFill>
-                        <a:srgbClr val="000000"/>
-                      </a:solidFill>
-                      <a:prstDash val="solid"/>
-                      <a:round/>
-                      <a:headEnd type="none" w="med" len="med"/>
-                      <a:tailEnd type="none" w="med" len="med"/>
+                    <a:lnT w="0" cap="flat" cmpd="sng" algn="ctr">
+                      <a:noFill/>
                     </a:lnT>
                     <a:lnB w="12700" cap="flat" cmpd="sng" algn="ctr">
                       <a:solidFill>
@@ -15822,7 +15681,30 @@
       </p:graphicFrame>
       <p:sp>
         <p:nvSpPr>
-          <p:cNvPr id="33" name="Text 29"/>
+          <p:cNvPr id="32" name="Shape 29"/>
+          <p:cNvSpPr/>
+          <p:nvPr/>
+        </p:nvSpPr>
+        <p:spPr>
+          <a:xfrm>
+            <a:off x="457200" y="4937760"/>
+            <a:ext cx="8229600" cy="0"/>
+          </a:xfrm>
+          <a:prstGeom prst="line">
+            <a:avLst/>
+          </a:prstGeom>
+          <a:noFill/>
+          <a:ln w="12700">
+            <a:solidFill>
+              <a:srgbClr val="000000"/>
+            </a:solidFill>
+            <a:prstDash val="dash"/>
+          </a:ln>
+        </p:spPr>
+      </p:sp>
+      <p:sp>
+        <p:nvSpPr>
+          <p:cNvPr id="34" name="Text 30"/>
           <p:cNvSpPr txBox="1"/>
           <p:nvPr/>
         </p:nvSpPr>
@@ -16640,14 +16522,8 @@
                       <a:headEnd type="none" w="med" len="med"/>
                       <a:tailEnd type="none" w="med" len="med"/>
                     </a:lnT>
-                    <a:lnB w="12700" cap="flat" cmpd="sng" algn="ctr">
-                      <a:solidFill>
-                        <a:srgbClr val="000000"/>
-                      </a:solidFill>
-                      <a:prstDash val="solid"/>
-                      <a:round/>
-                      <a:headEnd type="none" w="med" len="med"/>
-                      <a:tailEnd type="none" w="med" len="med"/>
+                    <a:lnB w="0" cap="flat" cmpd="sng" algn="ctr">
+                      <a:noFill/>
                     </a:lnB>
                   </a:tcPr>
                 </a:tc>
@@ -16705,14 +16581,8 @@
                       <a:headEnd type="none" w="med" len="med"/>
                       <a:tailEnd type="none" w="med" len="med"/>
                     </a:lnT>
-                    <a:lnB w="12700" cap="flat" cmpd="sng" algn="ctr">
-                      <a:solidFill>
-                        <a:srgbClr val="000000"/>
-                      </a:solidFill>
-                      <a:prstDash val="solid"/>
-                      <a:round/>
-                      <a:headEnd type="none" w="med" len="med"/>
-                      <a:tailEnd type="none" w="med" len="med"/>
+                    <a:lnB w="0" cap="flat" cmpd="sng" algn="ctr">
+                      <a:noFill/>
                     </a:lnB>
                   </a:tcPr>
                 </a:tc>
@@ -16763,23 +16633,11 @@
                       <a:headEnd type="none" w="med" len="med"/>
                       <a:tailEnd type="none" w="med" len="med"/>
                     </a:lnR>
-                    <a:lnT w="12700" cap="flat" cmpd="sng" algn="ctr">
-                      <a:solidFill>
-                        <a:srgbClr val="000000"/>
-                      </a:solidFill>
-                      <a:prstDash val="solid"/>
-                      <a:round/>
-                      <a:headEnd type="none" w="med" len="med"/>
-                      <a:tailEnd type="none" w="med" len="med"/>
+                    <a:lnT w="0" cap="flat" cmpd="sng" algn="ctr">
+                      <a:noFill/>
                     </a:lnT>
-                    <a:lnB w="12700" cap="flat" cmpd="sng" algn="ctr">
-                      <a:solidFill>
-                        <a:srgbClr val="000000"/>
-                      </a:solidFill>
-                      <a:prstDash val="solid"/>
-                      <a:round/>
-                      <a:headEnd type="none" w="med" len="med"/>
-                      <a:tailEnd type="none" w="med" len="med"/>
+                    <a:lnB w="0" cap="flat" cmpd="sng" algn="ctr">
+                      <a:noFill/>
                     </a:lnB>
                   </a:tcPr>
                 </a:tc>
@@ -16828,23 +16686,11 @@
                       <a:headEnd type="none" w="med" len="med"/>
                       <a:tailEnd type="none" w="med" len="med"/>
                     </a:lnR>
-                    <a:lnT w="12700" cap="flat" cmpd="sng" algn="ctr">
-                      <a:solidFill>
-                        <a:srgbClr val="000000"/>
-                      </a:solidFill>
-                      <a:prstDash val="solid"/>
-                      <a:round/>
-                      <a:headEnd type="none" w="med" len="med"/>
-                      <a:tailEnd type="none" w="med" len="med"/>
+                    <a:lnT w="0" cap="flat" cmpd="sng" algn="ctr">
+                      <a:noFill/>
                     </a:lnT>
-                    <a:lnB w="12700" cap="flat" cmpd="sng" algn="ctr">
-                      <a:solidFill>
-                        <a:srgbClr val="000000"/>
-                      </a:solidFill>
-                      <a:prstDash val="solid"/>
-                      <a:round/>
-                      <a:headEnd type="none" w="med" len="med"/>
-                      <a:tailEnd type="none" w="med" len="med"/>
+                    <a:lnB w="0" cap="flat" cmpd="sng" algn="ctr">
+                      <a:noFill/>
                     </a:lnB>
                   </a:tcPr>
                 </a:tc>
@@ -16895,23 +16741,11 @@
                       <a:headEnd type="none" w="med" len="med"/>
                       <a:tailEnd type="none" w="med" len="med"/>
                     </a:lnR>
-                    <a:lnT w="12700" cap="flat" cmpd="sng" algn="ctr">
-                      <a:solidFill>
-                        <a:srgbClr val="000000"/>
-                      </a:solidFill>
-                      <a:prstDash val="solid"/>
-                      <a:round/>
-                      <a:headEnd type="none" w="med" len="med"/>
-                      <a:tailEnd type="none" w="med" len="med"/>
+                    <a:lnT w="0" cap="flat" cmpd="sng" algn="ctr">
+                      <a:noFill/>
                     </a:lnT>
-                    <a:lnB w="12700" cap="flat" cmpd="sng" algn="ctr">
-                      <a:solidFill>
-                        <a:srgbClr val="000000"/>
-                      </a:solidFill>
-                      <a:prstDash val="solid"/>
-                      <a:round/>
-                      <a:headEnd type="none" w="med" len="med"/>
-                      <a:tailEnd type="none" w="med" len="med"/>
+                    <a:lnB w="0" cap="flat" cmpd="sng" algn="ctr">
+                      <a:noFill/>
                     </a:lnB>
                   </a:tcPr>
                 </a:tc>
@@ -16960,23 +16794,11 @@
                       <a:headEnd type="none" w="med" len="med"/>
                       <a:tailEnd type="none" w="med" len="med"/>
                     </a:lnR>
-                    <a:lnT w="12700" cap="flat" cmpd="sng" algn="ctr">
-                      <a:solidFill>
-                        <a:srgbClr val="000000"/>
-                      </a:solidFill>
-                      <a:prstDash val="solid"/>
-                      <a:round/>
-                      <a:headEnd type="none" w="med" len="med"/>
-                      <a:tailEnd type="none" w="med" len="med"/>
+                    <a:lnT w="0" cap="flat" cmpd="sng" algn="ctr">
+                      <a:noFill/>
                     </a:lnT>
-                    <a:lnB w="12700" cap="flat" cmpd="sng" algn="ctr">
-                      <a:solidFill>
-                        <a:srgbClr val="000000"/>
-                      </a:solidFill>
-                      <a:prstDash val="solid"/>
-                      <a:round/>
-                      <a:headEnd type="none" w="med" len="med"/>
-                      <a:tailEnd type="none" w="med" len="med"/>
+                    <a:lnB w="0" cap="flat" cmpd="sng" algn="ctr">
+                      <a:noFill/>
                     </a:lnB>
                   </a:tcPr>
                 </a:tc>
@@ -17027,14 +16849,8 @@
                       <a:headEnd type="none" w="med" len="med"/>
                       <a:tailEnd type="none" w="med" len="med"/>
                     </a:lnR>
-                    <a:lnT w="12700" cap="flat" cmpd="sng" algn="ctr">
-                      <a:solidFill>
-                        <a:srgbClr val="000000"/>
-                      </a:solidFill>
-                      <a:prstDash val="solid"/>
-                      <a:round/>
-                      <a:headEnd type="none" w="med" len="med"/>
-                      <a:tailEnd type="none" w="med" len="med"/>
+                    <a:lnT w="0" cap="flat" cmpd="sng" algn="ctr">
+                      <a:noFill/>
                     </a:lnT>
                     <a:lnB w="12700" cap="flat" cmpd="sng" algn="ctr">
                       <a:solidFill>
@@ -17092,14 +16908,8 @@
                       <a:headEnd type="none" w="med" len="med"/>
                       <a:tailEnd type="none" w="med" len="med"/>
                     </a:lnR>
-                    <a:lnT w="12700" cap="flat" cmpd="sng" algn="ctr">
-                      <a:solidFill>
-                        <a:srgbClr val="000000"/>
-                      </a:solidFill>
-                      <a:prstDash val="solid"/>
-                      <a:round/>
-                      <a:headEnd type="none" w="med" len="med"/>
-                      <a:tailEnd type="none" w="med" len="med"/>
+                    <a:lnT w="0" cap="flat" cmpd="sng" algn="ctr">
+                      <a:noFill/>
                     </a:lnT>
                     <a:lnB w="12700" cap="flat" cmpd="sng" algn="ctr">
                       <a:solidFill>
@@ -17119,7 +16929,76 @@
       </p:graphicFrame>
       <p:sp>
         <p:nvSpPr>
-          <p:cNvPr id="18" name="Text 14"/>
+          <p:cNvPr id="17" name="Shape 14"/>
+          <p:cNvSpPr/>
+          <p:nvPr/>
+        </p:nvSpPr>
+        <p:spPr>
+          <a:xfrm>
+            <a:off x="914400" y="4096512"/>
+            <a:ext cx="7772400" cy="0"/>
+          </a:xfrm>
+          <a:prstGeom prst="line">
+            <a:avLst/>
+          </a:prstGeom>
+          <a:noFill/>
+          <a:ln w="12700">
+            <a:solidFill>
+              <a:srgbClr val="000000"/>
+            </a:solidFill>
+            <a:prstDash val="dash"/>
+          </a:ln>
+        </p:spPr>
+      </p:sp>
+      <p:sp>
+        <p:nvSpPr>
+          <p:cNvPr id="18" name="Shape 15"/>
+          <p:cNvSpPr/>
+          <p:nvPr/>
+        </p:nvSpPr>
+        <p:spPr>
+          <a:xfrm>
+            <a:off x="914400" y="4498848"/>
+            <a:ext cx="7772400" cy="0"/>
+          </a:xfrm>
+          <a:prstGeom prst="line">
+            <a:avLst/>
+          </a:prstGeom>
+          <a:noFill/>
+          <a:ln w="12700">
+            <a:solidFill>
+              <a:srgbClr val="000000"/>
+            </a:solidFill>
+            <a:prstDash val="dash"/>
+          </a:ln>
+        </p:spPr>
+      </p:sp>
+      <p:sp>
+        <p:nvSpPr>
+          <p:cNvPr id="19" name="Shape 16"/>
+          <p:cNvSpPr/>
+          <p:nvPr/>
+        </p:nvSpPr>
+        <p:spPr>
+          <a:xfrm>
+            <a:off x="914400" y="4864608"/>
+            <a:ext cx="7772400" cy="0"/>
+          </a:xfrm>
+          <a:prstGeom prst="line">
+            <a:avLst/>
+          </a:prstGeom>
+          <a:noFill/>
+          <a:ln w="12700">
+            <a:solidFill>
+              <a:srgbClr val="000000"/>
+            </a:solidFill>
+            <a:prstDash val="dash"/>
+          </a:ln>
+        </p:spPr>
+      </p:sp>
+      <p:sp>
+        <p:nvSpPr>
+          <p:cNvPr id="21" name="Text 17"/>
           <p:cNvSpPr txBox="1"/>
           <p:nvPr/>
         </p:nvSpPr>
@@ -17844,14 +17723,8 @@
                       <a:headEnd type="none" w="med" len="med"/>
                       <a:tailEnd type="none" w="med" len="med"/>
                     </a:lnT>
-                    <a:lnB w="12700" cap="flat" cmpd="sng" algn="ctr">
-                      <a:solidFill>
-                        <a:srgbClr val="000000"/>
-                      </a:solidFill>
-                      <a:prstDash val="solid"/>
-                      <a:round/>
-                      <a:headEnd type="none" w="med" len="med"/>
-                      <a:tailEnd type="none" w="med" len="med"/>
+                    <a:lnB w="0" cap="flat" cmpd="sng" algn="ctr">
+                      <a:noFill/>
                     </a:lnB>
                   </a:tcPr>
                 </a:tc>
@@ -17909,14 +17782,8 @@
                       <a:headEnd type="none" w="med" len="med"/>
                       <a:tailEnd type="none" w="med" len="med"/>
                     </a:lnT>
-                    <a:lnB w="12700" cap="flat" cmpd="sng" algn="ctr">
-                      <a:solidFill>
-                        <a:srgbClr val="000000"/>
-                      </a:solidFill>
-                      <a:prstDash val="solid"/>
-                      <a:round/>
-                      <a:headEnd type="none" w="med" len="med"/>
-                      <a:tailEnd type="none" w="med" len="med"/>
+                    <a:lnB w="0" cap="flat" cmpd="sng" algn="ctr">
+                      <a:noFill/>
                     </a:lnB>
                   </a:tcPr>
                 </a:tc>
@@ -18056,23 +17923,11 @@
                       <a:headEnd type="none" w="med" len="med"/>
                       <a:tailEnd type="none" w="med" len="med"/>
                     </a:lnR>
-                    <a:lnT w="12700" cap="flat" cmpd="sng" algn="ctr">
-                      <a:solidFill>
-                        <a:srgbClr val="000000"/>
-                      </a:solidFill>
-                      <a:prstDash val="solid"/>
-                      <a:round/>
-                      <a:headEnd type="none" w="med" len="med"/>
-                      <a:tailEnd type="none" w="med" len="med"/>
+                    <a:lnT w="0" cap="flat" cmpd="sng" algn="ctr">
+                      <a:noFill/>
                     </a:lnT>
-                    <a:lnB w="12700" cap="flat" cmpd="sng" algn="ctr">
-                      <a:solidFill>
-                        <a:srgbClr val="000000"/>
-                      </a:solidFill>
-                      <a:prstDash val="solid"/>
-                      <a:round/>
-                      <a:headEnd type="none" w="med" len="med"/>
-                      <a:tailEnd type="none" w="med" len="med"/>
+                    <a:lnB w="0" cap="flat" cmpd="sng" algn="ctr">
+                      <a:noFill/>
                     </a:lnB>
                   </a:tcPr>
                 </a:tc>
@@ -18121,23 +17976,11 @@
                       <a:headEnd type="none" w="med" len="med"/>
                       <a:tailEnd type="none" w="med" len="med"/>
                     </a:lnR>
-                    <a:lnT w="12700" cap="flat" cmpd="sng" algn="ctr">
-                      <a:solidFill>
-                        <a:srgbClr val="000000"/>
-                      </a:solidFill>
-                      <a:prstDash val="solid"/>
-                      <a:round/>
-                      <a:headEnd type="none" w="med" len="med"/>
-                      <a:tailEnd type="none" w="med" len="med"/>
+                    <a:lnT w="0" cap="flat" cmpd="sng" algn="ctr">
+                      <a:noFill/>
                     </a:lnT>
-                    <a:lnB w="12700" cap="flat" cmpd="sng" algn="ctr">
-                      <a:solidFill>
-                        <a:srgbClr val="000000"/>
-                      </a:solidFill>
-                      <a:prstDash val="solid"/>
-                      <a:round/>
-                      <a:headEnd type="none" w="med" len="med"/>
-                      <a:tailEnd type="none" w="med" len="med"/>
+                    <a:lnB w="0" cap="flat" cmpd="sng" algn="ctr">
+                      <a:noFill/>
                     </a:lnB>
                   </a:tcPr>
                 </a:tc>
@@ -18191,23 +18034,11 @@
                       <a:headEnd type="none" w="med" len="med"/>
                       <a:tailEnd type="none" w="med" len="med"/>
                     </a:lnR>
-                    <a:lnT w="12700" cap="flat" cmpd="sng" algn="ctr">
-                      <a:solidFill>
-                        <a:srgbClr val="000000"/>
-                      </a:solidFill>
-                      <a:prstDash val="solid"/>
-                      <a:round/>
-                      <a:headEnd type="none" w="med" len="med"/>
-                      <a:tailEnd type="none" w="med" len="med"/>
+                    <a:lnT w="0" cap="flat" cmpd="sng" algn="ctr">
+                      <a:noFill/>
                     </a:lnT>
-                    <a:lnB w="12700" cap="flat" cmpd="sng" algn="ctr">
-                      <a:solidFill>
-                        <a:srgbClr val="000000"/>
-                      </a:solidFill>
-                      <a:prstDash val="solid"/>
-                      <a:round/>
-                      <a:headEnd type="none" w="med" len="med"/>
-                      <a:tailEnd type="none" w="med" len="med"/>
+                    <a:lnB w="0" cap="flat" cmpd="sng" algn="ctr">
+                      <a:noFill/>
                     </a:lnB>
                   </a:tcPr>
                 </a:tc>
@@ -18256,23 +18087,11 @@
                       <a:headEnd type="none" w="med" len="med"/>
                       <a:tailEnd type="none" w="med" len="med"/>
                     </a:lnR>
-                    <a:lnT w="12700" cap="flat" cmpd="sng" algn="ctr">
-                      <a:solidFill>
-                        <a:srgbClr val="000000"/>
-                      </a:solidFill>
-                      <a:prstDash val="solid"/>
-                      <a:round/>
-                      <a:headEnd type="none" w="med" len="med"/>
-                      <a:tailEnd type="none" w="med" len="med"/>
+                    <a:lnT w="0" cap="flat" cmpd="sng" algn="ctr">
+                      <a:noFill/>
                     </a:lnT>
-                    <a:lnB w="12700" cap="flat" cmpd="sng" algn="ctr">
-                      <a:solidFill>
-                        <a:srgbClr val="000000"/>
-                      </a:solidFill>
-                      <a:prstDash val="solid"/>
-                      <a:round/>
-                      <a:headEnd type="none" w="med" len="med"/>
-                      <a:tailEnd type="none" w="med" len="med"/>
+                    <a:lnB w="0" cap="flat" cmpd="sng" algn="ctr">
+                      <a:noFill/>
                     </a:lnB>
                   </a:tcPr>
                 </a:tc>
@@ -18326,14 +18145,8 @@
                       <a:headEnd type="none" w="med" len="med"/>
                       <a:tailEnd type="none" w="med" len="med"/>
                     </a:lnR>
-                    <a:lnT w="12700" cap="flat" cmpd="sng" algn="ctr">
-                      <a:solidFill>
-                        <a:srgbClr val="000000"/>
-                      </a:solidFill>
-                      <a:prstDash val="solid"/>
-                      <a:round/>
-                      <a:headEnd type="none" w="med" len="med"/>
-                      <a:tailEnd type="none" w="med" len="med"/>
+                    <a:lnT w="0" cap="flat" cmpd="sng" algn="ctr">
+                      <a:noFill/>
                     </a:lnT>
                     <a:lnB w="12700" cap="flat" cmpd="sng" algn="ctr">
                       <a:solidFill>
@@ -18391,14 +18204,8 @@
                       <a:headEnd type="none" w="med" len="med"/>
                       <a:tailEnd type="none" w="med" len="med"/>
                     </a:lnR>
-                    <a:lnT w="12700" cap="flat" cmpd="sng" algn="ctr">
-                      <a:solidFill>
-                        <a:srgbClr val="000000"/>
-                      </a:solidFill>
-                      <a:prstDash val="solid"/>
-                      <a:round/>
-                      <a:headEnd type="none" w="med" len="med"/>
-                      <a:tailEnd type="none" w="med" len="med"/>
+                    <a:lnT w="0" cap="flat" cmpd="sng" algn="ctr">
+                      <a:noFill/>
                     </a:lnT>
                     <a:lnB w="12700" cap="flat" cmpd="sng" algn="ctr">
                       <a:solidFill>
@@ -18562,7 +18369,76 @@
       </p:graphicFrame>
       <p:sp>
         <p:nvSpPr>
-          <p:cNvPr id="13" name="Text 10"/>
+          <p:cNvPr id="13" name="Shape 10"/>
+          <p:cNvSpPr/>
+          <p:nvPr/>
+        </p:nvSpPr>
+        <p:spPr>
+          <a:xfrm>
+            <a:off x="914400" y="3163824"/>
+            <a:ext cx="4572000" cy="0"/>
+          </a:xfrm>
+          <a:prstGeom prst="line">
+            <a:avLst/>
+          </a:prstGeom>
+          <a:noFill/>
+          <a:ln w="12700">
+            <a:solidFill>
+              <a:srgbClr val="000000"/>
+            </a:solidFill>
+            <a:prstDash val="dash"/>
+          </a:ln>
+        </p:spPr>
+      </p:sp>
+      <p:sp>
+        <p:nvSpPr>
+          <p:cNvPr id="14" name="Shape 11"/>
+          <p:cNvSpPr/>
+          <p:nvPr/>
+        </p:nvSpPr>
+        <p:spPr>
+          <a:xfrm>
+            <a:off x="914400" y="3493008"/>
+            <a:ext cx="4572000" cy="0"/>
+          </a:xfrm>
+          <a:prstGeom prst="line">
+            <a:avLst/>
+          </a:prstGeom>
+          <a:noFill/>
+          <a:ln w="12700">
+            <a:solidFill>
+              <a:srgbClr val="000000"/>
+            </a:solidFill>
+            <a:prstDash val="dash"/>
+          </a:ln>
+        </p:spPr>
+      </p:sp>
+      <p:sp>
+        <p:nvSpPr>
+          <p:cNvPr id="15" name="Shape 12"/>
+          <p:cNvSpPr/>
+          <p:nvPr/>
+        </p:nvSpPr>
+        <p:spPr>
+          <a:xfrm>
+            <a:off x="914400" y="3822192"/>
+            <a:ext cx="4572000" cy="0"/>
+          </a:xfrm>
+          <a:prstGeom prst="line">
+            <a:avLst/>
+          </a:prstGeom>
+          <a:noFill/>
+          <a:ln w="12700">
+            <a:solidFill>
+              <a:srgbClr val="000000"/>
+            </a:solidFill>
+            <a:prstDash val="dash"/>
+          </a:ln>
+        </p:spPr>
+      </p:sp>
+      <p:sp>
+        <p:nvSpPr>
+          <p:cNvPr id="16" name="Text 13"/>
           <p:cNvSpPr txBox="1"/>
           <p:nvPr/>
         </p:nvSpPr>
@@ -18601,7 +18477,7 @@
       </p:sp>
       <p:sp>
         <p:nvSpPr>
-          <p:cNvPr id="14" name="Text 11"/>
+          <p:cNvPr id="17" name="Text 14"/>
           <p:cNvSpPr txBox="1"/>
           <p:nvPr/>
         </p:nvSpPr>
@@ -18640,7 +18516,7 @@
       </p:sp>
       <p:sp>
         <p:nvSpPr>
-          <p:cNvPr id="15" name="Text 12"/>
+          <p:cNvPr id="18" name="Text 15"/>
           <p:cNvSpPr txBox="1"/>
           <p:nvPr/>
         </p:nvSpPr>
@@ -18682,7 +18558,7 @@
       </p:sp>
       <p:sp>
         <p:nvSpPr>
-          <p:cNvPr id="16" name="Text 13"/>
+          <p:cNvPr id="19" name="Text 16"/>
           <p:cNvSpPr txBox="1"/>
           <p:nvPr/>
         </p:nvSpPr>
@@ -18721,7 +18597,7 @@
       </p:sp>
       <p:sp>
         <p:nvSpPr>
-          <p:cNvPr id="17" name="Text 14"/>
+          <p:cNvPr id="20" name="Text 17"/>
           <p:cNvSpPr txBox="1"/>
           <p:nvPr/>
         </p:nvSpPr>
@@ -18763,7 +18639,7 @@
       </p:sp>
       <p:sp>
         <p:nvSpPr>
-          <p:cNvPr id="18" name="Text 15"/>
+          <p:cNvPr id="21" name="Text 18"/>
           <p:cNvSpPr txBox="1"/>
           <p:nvPr/>
         </p:nvSpPr>
@@ -18802,7 +18678,7 @@
       </p:sp>
       <p:sp>
         <p:nvSpPr>
-          <p:cNvPr id="19" name="Text 16"/>
+          <p:cNvPr id="22" name="Text 19"/>
           <p:cNvSpPr txBox="1"/>
           <p:nvPr/>
         </p:nvSpPr>
@@ -18844,7 +18720,7 @@
       </p:sp>
       <p:sp>
         <p:nvSpPr>
-          <p:cNvPr id="21" name="Text 17"/>
+          <p:cNvPr id="24" name="Text 20"/>
           <p:cNvSpPr txBox="1"/>
           <p:nvPr/>
         </p:nvSpPr>
@@ -19569,14 +19445,8 @@
                       <a:headEnd type="none" w="med" len="med"/>
                       <a:tailEnd type="none" w="med" len="med"/>
                     </a:lnT>
-                    <a:lnB w="12700" cap="flat" cmpd="sng" algn="ctr">
-                      <a:solidFill>
-                        <a:srgbClr val="000000"/>
-                      </a:solidFill>
-                      <a:prstDash val="solid"/>
-                      <a:round/>
-                      <a:headEnd type="none" w="med" len="med"/>
-                      <a:tailEnd type="none" w="med" len="med"/>
+                    <a:lnB w="0" cap="flat" cmpd="sng" algn="ctr">
+                      <a:noFill/>
                     </a:lnB>
                   </a:tcPr>
                 </a:tc>
@@ -19634,14 +19504,8 @@
                       <a:headEnd type="none" w="med" len="med"/>
                       <a:tailEnd type="none" w="med" len="med"/>
                     </a:lnT>
-                    <a:lnB w="12700" cap="flat" cmpd="sng" algn="ctr">
-                      <a:solidFill>
-                        <a:srgbClr val="000000"/>
-                      </a:solidFill>
-                      <a:prstDash val="solid"/>
-                      <a:round/>
-                      <a:headEnd type="none" w="med" len="med"/>
-                      <a:tailEnd type="none" w="med" len="med"/>
+                    <a:lnB w="0" cap="flat" cmpd="sng" algn="ctr">
+                      <a:noFill/>
                     </a:lnB>
                   </a:tcPr>
                 </a:tc>
@@ -19781,23 +19645,11 @@
                       <a:headEnd type="none" w="med" len="med"/>
                       <a:tailEnd type="none" w="med" len="med"/>
                     </a:lnR>
-                    <a:lnT w="12700" cap="flat" cmpd="sng" algn="ctr">
-                      <a:solidFill>
-                        <a:srgbClr val="000000"/>
-                      </a:solidFill>
-                      <a:prstDash val="solid"/>
-                      <a:round/>
-                      <a:headEnd type="none" w="med" len="med"/>
-                      <a:tailEnd type="none" w="med" len="med"/>
+                    <a:lnT w="0" cap="flat" cmpd="sng" algn="ctr">
+                      <a:noFill/>
                     </a:lnT>
-                    <a:lnB w="12700" cap="flat" cmpd="sng" algn="ctr">
-                      <a:solidFill>
-                        <a:srgbClr val="000000"/>
-                      </a:solidFill>
-                      <a:prstDash val="solid"/>
-                      <a:round/>
-                      <a:headEnd type="none" w="med" len="med"/>
-                      <a:tailEnd type="none" w="med" len="med"/>
+                    <a:lnB w="0" cap="flat" cmpd="sng" algn="ctr">
+                      <a:noFill/>
                     </a:lnB>
                   </a:tcPr>
                 </a:tc>
@@ -19846,23 +19698,11 @@
                       <a:headEnd type="none" w="med" len="med"/>
                       <a:tailEnd type="none" w="med" len="med"/>
                     </a:lnR>
-                    <a:lnT w="12700" cap="flat" cmpd="sng" algn="ctr">
-                      <a:solidFill>
-                        <a:srgbClr val="000000"/>
-                      </a:solidFill>
-                      <a:prstDash val="solid"/>
-                      <a:round/>
-                      <a:headEnd type="none" w="med" len="med"/>
-                      <a:tailEnd type="none" w="med" len="med"/>
+                    <a:lnT w="0" cap="flat" cmpd="sng" algn="ctr">
+                      <a:noFill/>
                     </a:lnT>
-                    <a:lnB w="12700" cap="flat" cmpd="sng" algn="ctr">
-                      <a:solidFill>
-                        <a:srgbClr val="000000"/>
-                      </a:solidFill>
-                      <a:prstDash val="solid"/>
-                      <a:round/>
-                      <a:headEnd type="none" w="med" len="med"/>
-                      <a:tailEnd type="none" w="med" len="med"/>
+                    <a:lnB w="0" cap="flat" cmpd="sng" algn="ctr">
+                      <a:noFill/>
                     </a:lnB>
                   </a:tcPr>
                 </a:tc>
@@ -19916,23 +19756,11 @@
                       <a:headEnd type="none" w="med" len="med"/>
                       <a:tailEnd type="none" w="med" len="med"/>
                     </a:lnR>
-                    <a:lnT w="12700" cap="flat" cmpd="sng" algn="ctr">
-                      <a:solidFill>
-                        <a:srgbClr val="000000"/>
-                      </a:solidFill>
-                      <a:prstDash val="solid"/>
-                      <a:round/>
-                      <a:headEnd type="none" w="med" len="med"/>
-                      <a:tailEnd type="none" w="med" len="med"/>
+                    <a:lnT w="0" cap="flat" cmpd="sng" algn="ctr">
+                      <a:noFill/>
                     </a:lnT>
-                    <a:lnB w="12700" cap="flat" cmpd="sng" algn="ctr">
-                      <a:solidFill>
-                        <a:srgbClr val="000000"/>
-                      </a:solidFill>
-                      <a:prstDash val="solid"/>
-                      <a:round/>
-                      <a:headEnd type="none" w="med" len="med"/>
-                      <a:tailEnd type="none" w="med" len="med"/>
+                    <a:lnB w="0" cap="flat" cmpd="sng" algn="ctr">
+                      <a:noFill/>
                     </a:lnB>
                   </a:tcPr>
                 </a:tc>
@@ -19981,23 +19809,11 @@
                       <a:headEnd type="none" w="med" len="med"/>
                       <a:tailEnd type="none" w="med" len="med"/>
                     </a:lnR>
-                    <a:lnT w="12700" cap="flat" cmpd="sng" algn="ctr">
-                      <a:solidFill>
-                        <a:srgbClr val="000000"/>
-                      </a:solidFill>
-                      <a:prstDash val="solid"/>
-                      <a:round/>
-                      <a:headEnd type="none" w="med" len="med"/>
-                      <a:tailEnd type="none" w="med" len="med"/>
+                    <a:lnT w="0" cap="flat" cmpd="sng" algn="ctr">
+                      <a:noFill/>
                     </a:lnT>
-                    <a:lnB w="12700" cap="flat" cmpd="sng" algn="ctr">
-                      <a:solidFill>
-                        <a:srgbClr val="000000"/>
-                      </a:solidFill>
-                      <a:prstDash val="solid"/>
-                      <a:round/>
-                      <a:headEnd type="none" w="med" len="med"/>
-                      <a:tailEnd type="none" w="med" len="med"/>
+                    <a:lnB w="0" cap="flat" cmpd="sng" algn="ctr">
+                      <a:noFill/>
                     </a:lnB>
                   </a:tcPr>
                 </a:tc>
@@ -20051,14 +19867,8 @@
                       <a:headEnd type="none" w="med" len="med"/>
                       <a:tailEnd type="none" w="med" len="med"/>
                     </a:lnR>
-                    <a:lnT w="12700" cap="flat" cmpd="sng" algn="ctr">
-                      <a:solidFill>
-                        <a:srgbClr val="000000"/>
-                      </a:solidFill>
-                      <a:prstDash val="solid"/>
-                      <a:round/>
-                      <a:headEnd type="none" w="med" len="med"/>
-                      <a:tailEnd type="none" w="med" len="med"/>
+                    <a:lnT w="0" cap="flat" cmpd="sng" algn="ctr">
+                      <a:noFill/>
                     </a:lnT>
                     <a:lnB w="12700" cap="flat" cmpd="sng" algn="ctr">
                       <a:solidFill>
@@ -20116,14 +19926,8 @@
                       <a:headEnd type="none" w="med" len="med"/>
                       <a:tailEnd type="none" w="med" len="med"/>
                     </a:lnR>
-                    <a:lnT w="12700" cap="flat" cmpd="sng" algn="ctr">
-                      <a:solidFill>
-                        <a:srgbClr val="000000"/>
-                      </a:solidFill>
-                      <a:prstDash val="solid"/>
-                      <a:round/>
-                      <a:headEnd type="none" w="med" len="med"/>
-                      <a:tailEnd type="none" w="med" len="med"/>
+                    <a:lnT w="0" cap="flat" cmpd="sng" algn="ctr">
+                      <a:noFill/>
                     </a:lnT>
                     <a:lnB w="12700" cap="flat" cmpd="sng" algn="ctr">
                       <a:solidFill>
@@ -20287,7 +20091,76 @@
       </p:graphicFrame>
       <p:sp>
         <p:nvSpPr>
-          <p:cNvPr id="13" name="Text 10"/>
+          <p:cNvPr id="13" name="Shape 10"/>
+          <p:cNvSpPr/>
+          <p:nvPr/>
+        </p:nvSpPr>
+        <p:spPr>
+          <a:xfrm>
+            <a:off x="914400" y="3163824"/>
+            <a:ext cx="4572000" cy="0"/>
+          </a:xfrm>
+          <a:prstGeom prst="line">
+            <a:avLst/>
+          </a:prstGeom>
+          <a:noFill/>
+          <a:ln w="12700">
+            <a:solidFill>
+              <a:srgbClr val="000000"/>
+            </a:solidFill>
+            <a:prstDash val="dash"/>
+          </a:ln>
+        </p:spPr>
+      </p:sp>
+      <p:sp>
+        <p:nvSpPr>
+          <p:cNvPr id="14" name="Shape 11"/>
+          <p:cNvSpPr/>
+          <p:nvPr/>
+        </p:nvSpPr>
+        <p:spPr>
+          <a:xfrm>
+            <a:off x="914400" y="3493008"/>
+            <a:ext cx="4572000" cy="0"/>
+          </a:xfrm>
+          <a:prstGeom prst="line">
+            <a:avLst/>
+          </a:prstGeom>
+          <a:noFill/>
+          <a:ln w="12700">
+            <a:solidFill>
+              <a:srgbClr val="000000"/>
+            </a:solidFill>
+            <a:prstDash val="dash"/>
+          </a:ln>
+        </p:spPr>
+      </p:sp>
+      <p:sp>
+        <p:nvSpPr>
+          <p:cNvPr id="15" name="Shape 12"/>
+          <p:cNvSpPr/>
+          <p:nvPr/>
+        </p:nvSpPr>
+        <p:spPr>
+          <a:xfrm>
+            <a:off x="914400" y="3822192"/>
+            <a:ext cx="4572000" cy="0"/>
+          </a:xfrm>
+          <a:prstGeom prst="line">
+            <a:avLst/>
+          </a:prstGeom>
+          <a:noFill/>
+          <a:ln w="12700">
+            <a:solidFill>
+              <a:srgbClr val="000000"/>
+            </a:solidFill>
+            <a:prstDash val="dash"/>
+          </a:ln>
+        </p:spPr>
+      </p:sp>
+      <p:sp>
+        <p:nvSpPr>
+          <p:cNvPr id="16" name="Text 13"/>
           <p:cNvSpPr txBox="1"/>
           <p:nvPr/>
         </p:nvSpPr>
@@ -20326,7 +20199,7 @@
       </p:sp>
       <p:sp>
         <p:nvSpPr>
-          <p:cNvPr id="14" name="Text 11"/>
+          <p:cNvPr id="17" name="Text 14"/>
           <p:cNvSpPr txBox="1"/>
           <p:nvPr/>
         </p:nvSpPr>
@@ -20365,7 +20238,7 @@
       </p:sp>
       <p:sp>
         <p:nvSpPr>
-          <p:cNvPr id="15" name="Text 12"/>
+          <p:cNvPr id="18" name="Text 15"/>
           <p:cNvSpPr txBox="1"/>
           <p:nvPr/>
         </p:nvSpPr>
@@ -20407,7 +20280,7 @@
       </p:sp>
       <p:sp>
         <p:nvSpPr>
-          <p:cNvPr id="16" name="Text 13"/>
+          <p:cNvPr id="19" name="Text 16"/>
           <p:cNvSpPr txBox="1"/>
           <p:nvPr/>
         </p:nvSpPr>
@@ -20446,7 +20319,7 @@
       </p:sp>
       <p:sp>
         <p:nvSpPr>
-          <p:cNvPr id="17" name="Text 14"/>
+          <p:cNvPr id="20" name="Text 17"/>
           <p:cNvSpPr txBox="1"/>
           <p:nvPr/>
         </p:nvSpPr>
@@ -20488,7 +20361,7 @@
       </p:sp>
       <p:sp>
         <p:nvSpPr>
-          <p:cNvPr id="19" name="Text 15"/>
+          <p:cNvPr id="22" name="Text 18"/>
           <p:cNvSpPr txBox="1"/>
           <p:nvPr/>
         </p:nvSpPr>

</xml_diff>